<commit_message>
Polish Stage 2 professor-facing report
</commit_message>
<xml_diff>
--- a/slides/mop_stage2_final/output/output.pptx
+++ b/slides/mop_stage2_final/output/output.pptx
@@ -2,20 +2,20 @@
 <file path=ppt/presentation.xml><?xml version="1.0" encoding="utf-8"?>
 <p:presentation xmlns:p="http://schemas.openxmlformats.org/presentationml/2006/main">
   <p:sldMasterIdLst>
-    <p:sldMasterId xmlns:r="http://schemas.openxmlformats.org/officeDocument/2006/relationships" id="2147483648" r:id="R0d170f4e879a4431"/>
+    <p:sldMasterId xmlns:r="http://schemas.openxmlformats.org/officeDocument/2006/relationships" id="2147483648" r:id="R9d056e3f6eaa43e6"/>
   </p:sldMasterIdLst>
   <p:notesMasterIdLst>
-    <p:notesMasterId xmlns:r="http://schemas.openxmlformats.org/officeDocument/2006/relationships" r:id="R8ba617c061674374"/>
+    <p:notesMasterId xmlns:r="http://schemas.openxmlformats.org/officeDocument/2006/relationships" r:id="R4d1f1986ef284f10"/>
   </p:notesMasterIdLst>
   <p:sldIdLst>
-    <p:sldId xmlns:r="http://schemas.openxmlformats.org/officeDocument/2006/relationships" id="256" r:id="Rac9557befb54452a"/>
-    <p:sldId xmlns:r="http://schemas.openxmlformats.org/officeDocument/2006/relationships" id="257" r:id="R59a12d5cb18546c4"/>
-    <p:sldId xmlns:r="http://schemas.openxmlformats.org/officeDocument/2006/relationships" id="258" r:id="R50b452e567ca43dc"/>
-    <p:sldId xmlns:r="http://schemas.openxmlformats.org/officeDocument/2006/relationships" id="259" r:id="Rf841a50505c64095"/>
-    <p:sldId xmlns:r="http://schemas.openxmlformats.org/officeDocument/2006/relationships" id="260" r:id="R312515d041964809"/>
-    <p:sldId xmlns:r="http://schemas.openxmlformats.org/officeDocument/2006/relationships" id="261" r:id="R57cade09845a49b5"/>
-    <p:sldId xmlns:r="http://schemas.openxmlformats.org/officeDocument/2006/relationships" id="262" r:id="Rb8a2c73d4fd04b3e"/>
-    <p:sldId xmlns:r="http://schemas.openxmlformats.org/officeDocument/2006/relationships" id="263" r:id="R13c346cc22054c79"/>
+    <p:sldId xmlns:r="http://schemas.openxmlformats.org/officeDocument/2006/relationships" id="256" r:id="Rc9fba26c2bfd4d9c"/>
+    <p:sldId xmlns:r="http://schemas.openxmlformats.org/officeDocument/2006/relationships" id="257" r:id="Rfc6dc8397d874df0"/>
+    <p:sldId xmlns:r="http://schemas.openxmlformats.org/officeDocument/2006/relationships" id="258" r:id="R70ec9d0814274419"/>
+    <p:sldId xmlns:r="http://schemas.openxmlformats.org/officeDocument/2006/relationships" id="259" r:id="R5379ecf69a634d2f"/>
+    <p:sldId xmlns:r="http://schemas.openxmlformats.org/officeDocument/2006/relationships" id="260" r:id="Rdec4330402864d8a"/>
+    <p:sldId xmlns:r="http://schemas.openxmlformats.org/officeDocument/2006/relationships" id="261" r:id="Rec3ea2e7925b49d8"/>
+    <p:sldId xmlns:r="http://schemas.openxmlformats.org/officeDocument/2006/relationships" id="262" r:id="Rcc9228c613ac4b38"/>
+    <p:sldId xmlns:r="http://schemas.openxmlformats.org/officeDocument/2006/relationships" id="263" r:id="Rb00e074e2a4f4ef7"/>
   </p:sldIdLst>
   <p:sldSz cx="18288000" cy="10287000"/>
   <p:notesSz cx="6858000" cy="9144000"/>
@@ -1024,7 +1024,7 @@
   </p:cSld>
   <p:clrMap bg1="lt1" tx1="dk1" bg2="lt2" tx2="dk2" accent1="accent1" accent2="accent2" accent3="accent3" accent4="accent4" accent5="accent5" accent6="accent6" hlink="hlink" folHlink="folHlink"/>
   <p:sldLayoutIdLst>
-    <p:sldLayoutId xmlns:r="http://schemas.openxmlformats.org/officeDocument/2006/relationships" id="2147483649" r:id="R819801fc8fbf4577"/>
+    <p:sldLayoutId xmlns:r="http://schemas.openxmlformats.org/officeDocument/2006/relationships" id="2147483649" r:id="R368124988b454d44"/>
   </p:sldLayoutIdLst>
   <p:txStyles>
     <p:titleStyle>
@@ -1323,7 +1323,7 @@
           <p:cNvPr id="1" name="cover-title">
             <a:extLst xmlns:a="http://schemas.openxmlformats.org/drawingml/2006/main">
               <a:ext uri="{FF2B5EF4-FFF2-40B4-BE49-F238E27FC236}">
-                <a16:creationId xmlns:a16="http://schemas.microsoft.com/office/drawing/2014/main" id="{F0EA62E4-7750-434C-98FC-D29E33FA12B3}"/>
+                <a16:creationId xmlns:a16="http://schemas.microsoft.com/office/drawing/2014/main" id="{5AA06128-D2C3-49C7-9799-2139AF6C81C9}"/>
               </a:ext>
             </a:extLst>
           </p:cNvPr>
@@ -1368,7 +1368,7 @@
           <p:cNvPr id="2" name="cover-rule">
             <a:extLst xmlns:a="http://schemas.openxmlformats.org/drawingml/2006/main">
               <a:ext uri="{FF2B5EF4-FFF2-40B4-BE49-F238E27FC236}">
-                <a16:creationId xmlns:a16="http://schemas.microsoft.com/office/drawing/2014/main" id="{886D8F07-FE6F-446D-AF11-1B5496B47503}"/>
+                <a16:creationId xmlns:a16="http://schemas.microsoft.com/office/drawing/2014/main" id="{FCCCE44D-FD62-4161-950B-2D654A09B08D}"/>
               </a:ext>
             </a:extLst>
           </p:cNvPr>
@@ -1401,7 +1401,7 @@
           <p:cNvPr id="3" name="cover-thesis">
             <a:extLst xmlns:a="http://schemas.openxmlformats.org/drawingml/2006/main">
               <a:ext uri="{FF2B5EF4-FFF2-40B4-BE49-F238E27FC236}">
-                <a16:creationId xmlns:a16="http://schemas.microsoft.com/office/drawing/2014/main" id="{11A22A2E-A8E2-4B85-A244-AD6C31987F27}"/>
+                <a16:creationId xmlns:a16="http://schemas.microsoft.com/office/drawing/2014/main" id="{665B6407-59C4-4F13-AFE2-5FADA6D092D3}"/>
               </a:ext>
             </a:extLst>
           </p:cNvPr>
@@ -1436,7 +1436,7 @@
                   <a:srgbClr val="000000"/>
                 </a:solidFill>
               </a:rPr>
-              <a:t>A small L2C router that closes the train-window gap and clears no-prefetch on heldout</a:t>
+              <a:t>A small L2C router that closes the train-window pair-best gap and clears no-prefetch on heldout</a:t>
             </a:r>
           </a:p>
         </p:txBody>
@@ -1446,7 +1446,7 @@
           <p:cNvPr id="4" name="cover-metric-1">
             <a:extLst xmlns:a="http://schemas.openxmlformats.org/drawingml/2006/main">
               <a:ext uri="{FF2B5EF4-FFF2-40B4-BE49-F238E27FC236}">
-                <a16:creationId xmlns:a16="http://schemas.microsoft.com/office/drawing/2014/main" id="{13B79BF9-37AE-4BC1-A872-12DFA627696E}"/>
+                <a16:creationId xmlns:a16="http://schemas.microsoft.com/office/drawing/2014/main" id="{9D731DA8-0CC3-4E15-B60C-689346423C1A}"/>
               </a:ext>
             </a:extLst>
           </p:cNvPr>
@@ -1491,7 +1491,7 @@
           <p:cNvPr id="5" name="cover-label-1">
             <a:extLst xmlns:a="http://schemas.openxmlformats.org/drawingml/2006/main">
               <a:ext uri="{FF2B5EF4-FFF2-40B4-BE49-F238E27FC236}">
-                <a16:creationId xmlns:a16="http://schemas.microsoft.com/office/drawing/2014/main" id="{9BA32388-34CE-4EC9-874F-6F8A27B6D9E8}"/>
+                <a16:creationId xmlns:a16="http://schemas.microsoft.com/office/drawing/2014/main" id="{C9DC9791-195F-43D5-BD4B-D7FFB21E3C3F}"/>
               </a:ext>
             </a:extLst>
           </p:cNvPr>
@@ -1536,7 +1536,7 @@
           <p:cNvPr id="6" name="cover-metric-2">
             <a:extLst xmlns:a="http://schemas.openxmlformats.org/drawingml/2006/main">
               <a:ext uri="{FF2B5EF4-FFF2-40B4-BE49-F238E27FC236}">
-                <a16:creationId xmlns:a16="http://schemas.microsoft.com/office/drawing/2014/main" id="{4CD5EF8E-787B-4703-9728-3C113759DE1D}"/>
+                <a16:creationId xmlns:a16="http://schemas.microsoft.com/office/drawing/2014/main" id="{F5EFE05B-DF10-4F08-811C-C7E20B9DE350}"/>
               </a:ext>
             </a:extLst>
           </p:cNvPr>
@@ -1581,7 +1581,7 @@
           <p:cNvPr id="7" name="cover-label-2">
             <a:extLst xmlns:a="http://schemas.openxmlformats.org/drawingml/2006/main">
               <a:ext uri="{FF2B5EF4-FFF2-40B4-BE49-F238E27FC236}">
-                <a16:creationId xmlns:a16="http://schemas.microsoft.com/office/drawing/2014/main" id="{B1AB6730-B1AA-433F-9FE5-A8D9B660D2B0}"/>
+                <a16:creationId xmlns:a16="http://schemas.microsoft.com/office/drawing/2014/main" id="{E8035DC6-83C4-4C66-8665-AEBA0DE6748C}"/>
               </a:ext>
             </a:extLst>
           </p:cNvPr>
@@ -1626,7 +1626,7 @@
           <p:cNvPr id="8" name="cover-footer">
             <a:extLst xmlns:a="http://schemas.openxmlformats.org/drawingml/2006/main">
               <a:ext uri="{FF2B5EF4-FFF2-40B4-BE49-F238E27FC236}">
-                <a16:creationId xmlns:a16="http://schemas.microsoft.com/office/drawing/2014/main" id="{C2E575A8-3BB8-4141-9931-2FC56350611A}"/>
+                <a16:creationId xmlns:a16="http://schemas.microsoft.com/office/drawing/2014/main" id="{B2A557B4-39B7-49C3-B8CE-DC3EB7AE01F6}"/>
               </a:ext>
             </a:extLst>
           </p:cNvPr>
@@ -1669,7 +1669,7 @@
     </p:spTree>
     <p:extLst>
       <p:ext uri="{BB962C8B-B14F-4D97-AF65-F5344CB8AC3E}">
-        <p14:creationId xmlns:p14="http://schemas.microsoft.com/office/powerpoint/2010/main" val="818021643"/>
+        <p14:creationId xmlns:p14="http://schemas.microsoft.com/office/powerpoint/2010/main" val="275022592"/>
       </p:ext>
     </p:extLst>
   </p:cSld>
@@ -1693,7 +1693,7 @@
           <p:cNvPr id="1" name="slide-title">
             <a:extLst xmlns:a="http://schemas.openxmlformats.org/drawingml/2006/main">
               <a:ext uri="{FF2B5EF4-FFF2-40B4-BE49-F238E27FC236}">
-                <a16:creationId xmlns:a16="http://schemas.microsoft.com/office/drawing/2014/main" id="{2078550E-6D47-47AF-81B1-ADD41B13F1E2}"/>
+                <a16:creationId xmlns:a16="http://schemas.microsoft.com/office/drawing/2014/main" id="{8A8C3815-8D57-431A-A058-7F48B585F763}"/>
               </a:ext>
             </a:extLst>
           </p:cNvPr>
@@ -1738,7 +1738,7 @@
           <p:cNvPr id="2" name="slide-subtitle">
             <a:extLst xmlns:a="http://schemas.openxmlformats.org/drawingml/2006/main">
               <a:ext uri="{FF2B5EF4-FFF2-40B4-BE49-F238E27FC236}">
-                <a16:creationId xmlns:a16="http://schemas.microsoft.com/office/drawing/2014/main" id="{2394E504-E6B8-456B-A18B-C00F826E378F}"/>
+                <a16:creationId xmlns:a16="http://schemas.microsoft.com/office/drawing/2014/main" id="{D12D3449-1FB1-4135-B3AE-50D879CB0281}"/>
               </a:ext>
             </a:extLst>
           </p:cNvPr>
@@ -1773,7 +1773,7 @@
                   <a:srgbClr val="000000"/>
                 </a:solidFill>
               </a:rPr>
-              <a:t>Athena stays the simulator and prefetcher substrate; MoP is the coordination layer and evaluation harness.</a:t>
+              <a:t>Athena is the simulator substrate. Our work is the router, sandboxed search, ledgers, and report pipeline.</a:t>
             </a:r>
           </a:p>
         </p:txBody>
@@ -1783,7 +1783,7 @@
           <p:cNvPr id="3" name="bullet-0">
             <a:extLst xmlns:a="http://schemas.openxmlformats.org/drawingml/2006/main">
               <a:ext uri="{FF2B5EF4-FFF2-40B4-BE49-F238E27FC236}">
-                <a16:creationId xmlns:a16="http://schemas.microsoft.com/office/drawing/2014/main" id="{F288A7E3-75D4-4D52-8F5F-37A34B22DE3F}"/>
+                <a16:creationId xmlns:a16="http://schemas.microsoft.com/office/drawing/2014/main" id="{D259D593-04AE-4D22-B8CD-97982D9F48DE}"/>
               </a:ext>
             </a:extLst>
           </p:cNvPr>
@@ -1818,7 +1818,7 @@
                   <a:srgbClr val="000000"/>
                 </a:solidFill>
               </a:rPr>
-              <a:t>Athena</a:t>
+              <a:t>Athena substrate</a:t>
             </a:r>
           </a:p>
         </p:txBody>
@@ -1828,7 +1828,7 @@
           <p:cNvPr id="4" name="bullet-1">
             <a:extLst xmlns:a="http://schemas.openxmlformats.org/drawingml/2006/main">
               <a:ext uri="{FF2B5EF4-FFF2-40B4-BE49-F238E27FC236}">
-                <a16:creationId xmlns:a16="http://schemas.microsoft.com/office/drawing/2014/main" id="{230F9A4A-5953-442A-82AC-BBB11262FA77}"/>
+                <a16:creationId xmlns:a16="http://schemas.microsoft.com/office/drawing/2014/main" id="{6722DAC3-8B70-44E9-91CB-63E38EC0A422}"/>
               </a:ext>
             </a:extLst>
           </p:cNvPr>
@@ -1873,7 +1873,7 @@
           <p:cNvPr id="5" name="bullet-2">
             <a:extLst xmlns:a="http://schemas.openxmlformats.org/drawingml/2006/main">
               <a:ext uri="{FF2B5EF4-FFF2-40B4-BE49-F238E27FC236}">
-                <a16:creationId xmlns:a16="http://schemas.microsoft.com/office/drawing/2014/main" id="{9711FD4D-451B-4D59-B6A0-4201C0E108FF}"/>
+                <a16:creationId xmlns:a16="http://schemas.microsoft.com/office/drawing/2014/main" id="{18FCBE21-8C28-42ED-9323-D9FB22B7B753}"/>
               </a:ext>
             </a:extLst>
           </p:cNvPr>
@@ -1918,7 +1918,7 @@
           <p:cNvPr id="6" name="bullet-3">
             <a:extLst xmlns:a="http://schemas.openxmlformats.org/drawingml/2006/main">
               <a:ext uri="{FF2B5EF4-FFF2-40B4-BE49-F238E27FC236}">
-                <a16:creationId xmlns:a16="http://schemas.microsoft.com/office/drawing/2014/main" id="{51E1D279-EE49-43FD-BEAB-DDFF00F5114D}"/>
+                <a16:creationId xmlns:a16="http://schemas.microsoft.com/office/drawing/2014/main" id="{57D3A22C-54BA-430B-94D8-C49685877DC6}"/>
               </a:ext>
             </a:extLst>
           </p:cNvPr>
@@ -1963,7 +1963,7 @@
           <p:cNvPr id="7" name="bullet-0">
             <a:extLst xmlns:a="http://schemas.openxmlformats.org/drawingml/2006/main">
               <a:ext uri="{FF2B5EF4-FFF2-40B4-BE49-F238E27FC236}">
-                <a16:creationId xmlns:a16="http://schemas.microsoft.com/office/drawing/2014/main" id="{68A7AB09-C2F5-4E13-9C70-4466BEEF9556}"/>
+                <a16:creationId xmlns:a16="http://schemas.microsoft.com/office/drawing/2014/main" id="{7D21B9FF-1173-400C-87E7-F09AD9C38FA4}"/>
               </a:ext>
             </a:extLst>
           </p:cNvPr>
@@ -1998,7 +1998,7 @@
                   <a:srgbClr val="000000"/>
                 </a:solidFill>
               </a:rPr>
-              <a:t>MoP layer</a:t>
+              <a:t>Our MoP layer</a:t>
             </a:r>
           </a:p>
         </p:txBody>
@@ -2008,7 +2008,7 @@
           <p:cNvPr id="8" name="bullet-1">
             <a:extLst xmlns:a="http://schemas.openxmlformats.org/drawingml/2006/main">
               <a:ext uri="{FF2B5EF4-FFF2-40B4-BE49-F238E27FC236}">
-                <a16:creationId xmlns:a16="http://schemas.microsoft.com/office/drawing/2014/main" id="{2724E56D-A153-4A06-92C7-8B378D99F7E6}"/>
+                <a16:creationId xmlns:a16="http://schemas.microsoft.com/office/drawing/2014/main" id="{F3E2172A-8E2A-4659-B352-A45BC8779387}"/>
               </a:ext>
             </a:extLst>
           </p:cNvPr>
@@ -2053,7 +2053,7 @@
           <p:cNvPr id="9" name="bullet-2">
             <a:extLst xmlns:a="http://schemas.openxmlformats.org/drawingml/2006/main">
               <a:ext uri="{FF2B5EF4-FFF2-40B4-BE49-F238E27FC236}">
-                <a16:creationId xmlns:a16="http://schemas.microsoft.com/office/drawing/2014/main" id="{B29404B5-10BE-4663-B7AD-39CAD03E072A}"/>
+                <a16:creationId xmlns:a16="http://schemas.microsoft.com/office/drawing/2014/main" id="{FC209193-F756-4B4E-BFD4-AE0C359D2E3A}"/>
               </a:ext>
             </a:extLst>
           </p:cNvPr>
@@ -2098,7 +2098,7 @@
           <p:cNvPr id="10" name="bullet-3">
             <a:extLst xmlns:a="http://schemas.openxmlformats.org/drawingml/2006/main">
               <a:ext uri="{FF2B5EF4-FFF2-40B4-BE49-F238E27FC236}">
-                <a16:creationId xmlns:a16="http://schemas.microsoft.com/office/drawing/2014/main" id="{2825CDB2-730D-4E62-9CEE-CD3807ADDCEE}"/>
+                <a16:creationId xmlns:a16="http://schemas.microsoft.com/office/drawing/2014/main" id="{55A1FCBB-3D2D-4741-BAA6-310DFDF7935A}"/>
               </a:ext>
             </a:extLst>
           </p:cNvPr>
@@ -2143,7 +2143,7 @@
           <p:cNvPr id="11" name="bullet-0">
             <a:extLst xmlns:a="http://schemas.openxmlformats.org/drawingml/2006/main">
               <a:ext uri="{FF2B5EF4-FFF2-40B4-BE49-F238E27FC236}">
-                <a16:creationId xmlns:a16="http://schemas.microsoft.com/office/drawing/2014/main" id="{F9C1B792-A3E5-4B5C-B8B9-05022490C39E}"/>
+                <a16:creationId xmlns:a16="http://schemas.microsoft.com/office/drawing/2014/main" id="{858C6237-3079-4EA8-AEE9-A853006B711E}"/>
               </a:ext>
             </a:extLst>
           </p:cNvPr>
@@ -2178,7 +2178,7 @@
                   <a:srgbClr val="000000"/>
                 </a:solidFill>
               </a:rPr>
-              <a:t>Evaluation</a:t>
+              <a:t>Our evidence layer</a:t>
             </a:r>
           </a:p>
         </p:txBody>
@@ -2188,7 +2188,7 @@
           <p:cNvPr id="12" name="bullet-1">
             <a:extLst xmlns:a="http://schemas.openxmlformats.org/drawingml/2006/main">
               <a:ext uri="{FF2B5EF4-FFF2-40B4-BE49-F238E27FC236}">
-                <a16:creationId xmlns:a16="http://schemas.microsoft.com/office/drawing/2014/main" id="{5A2D2B2F-0D5E-4E62-B8B9-AD45A9AF0061}"/>
+                <a16:creationId xmlns:a16="http://schemas.microsoft.com/office/drawing/2014/main" id="{8EBCC444-1FD5-4764-82D2-F8151F84FFD9}"/>
               </a:ext>
             </a:extLst>
           </p:cNvPr>
@@ -2223,7 +2223,7 @@
                   <a:srgbClr val="000000"/>
                 </a:solidFill>
               </a:rPr>
-              <a:t>Official train/heldout split</a:t>
+              <a:t>Frozen train/heldout split</a:t>
             </a:r>
           </a:p>
         </p:txBody>
@@ -2233,7 +2233,7 @@
           <p:cNvPr id="13" name="bullet-2">
             <a:extLst xmlns:a="http://schemas.openxmlformats.org/drawingml/2006/main">
               <a:ext uri="{FF2B5EF4-FFF2-40B4-BE49-F238E27FC236}">
-                <a16:creationId xmlns:a16="http://schemas.microsoft.com/office/drawing/2014/main" id="{6ACE32F8-BEA3-4298-94A5-CE343DFD282A}"/>
+                <a16:creationId xmlns:a16="http://schemas.microsoft.com/office/drawing/2014/main" id="{7DB1B36A-0B4E-4A13-8111-107380124CF9}"/>
               </a:ext>
             </a:extLst>
           </p:cNvPr>
@@ -2268,7 +2268,7 @@
                   <a:srgbClr val="000000"/>
                 </a:solidFill>
               </a:rPr>
-              <a:t>Candidate ledger</a:t>
+              <a:t>OpenEvolve candidate ledger</a:t>
             </a:r>
           </a:p>
         </p:txBody>
@@ -2278,7 +2278,7 @@
           <p:cNvPr id="14" name="bullet-3">
             <a:extLst xmlns:a="http://schemas.openxmlformats.org/drawingml/2006/main">
               <a:ext uri="{FF2B5EF4-FFF2-40B4-BE49-F238E27FC236}">
-                <a16:creationId xmlns:a16="http://schemas.microsoft.com/office/drawing/2014/main" id="{7A71F389-5817-452E-988A-E20C658A55EE}"/>
+                <a16:creationId xmlns:a16="http://schemas.microsoft.com/office/drawing/2014/main" id="{E93617EC-B7BF-4845-A917-3A77B47436A0}"/>
               </a:ext>
             </a:extLst>
           </p:cNvPr>
@@ -2321,7 +2321,7 @@
     </p:spTree>
     <p:extLst>
       <p:ext uri="{BB962C8B-B14F-4D97-AF65-F5344CB8AC3E}">
-        <p14:creationId xmlns:p14="http://schemas.microsoft.com/office/powerpoint/2010/main" val="391455651"/>
+        <p14:creationId xmlns:p14="http://schemas.microsoft.com/office/powerpoint/2010/main" val="1325640862"/>
       </p:ext>
     </p:extLst>
   </p:cSld>
@@ -2345,7 +2345,7 @@
           <p:cNvPr id="1" name="slide-title">
             <a:extLst xmlns:a="http://schemas.openxmlformats.org/drawingml/2006/main">
               <a:ext uri="{FF2B5EF4-FFF2-40B4-BE49-F238E27FC236}">
-                <a16:creationId xmlns:a16="http://schemas.microsoft.com/office/drawing/2014/main" id="{C45BB1E6-4945-45C4-B122-247B318EA418}"/>
+                <a16:creationId xmlns:a16="http://schemas.microsoft.com/office/drawing/2014/main" id="{9FD0ED3C-3839-4B60-8498-37FE7D3D35B6}"/>
               </a:ext>
             </a:extLst>
           </p:cNvPr>
@@ -2390,7 +2390,7 @@
           <p:cNvPr id="2" name="title-rule">
             <a:extLst xmlns:a="http://schemas.openxmlformats.org/drawingml/2006/main">
               <a:ext uri="{FF2B5EF4-FFF2-40B4-BE49-F238E27FC236}">
-                <a16:creationId xmlns:a16="http://schemas.microsoft.com/office/drawing/2014/main" id="{41F54DB8-C21B-46BA-86E6-8E3FFBB7BFD5}"/>
+                <a16:creationId xmlns:a16="http://schemas.microsoft.com/office/drawing/2014/main" id="{25EAC628-50AC-42C6-9357-1E30D6728A22}"/>
               </a:ext>
             </a:extLst>
           </p:cNvPr>
@@ -2423,7 +2423,7 @@
           <p:cNvPr id="3" name="bullet-0">
             <a:extLst xmlns:a="http://schemas.openxmlformats.org/drawingml/2006/main">
               <a:ext uri="{FF2B5EF4-FFF2-40B4-BE49-F238E27FC236}">
-                <a16:creationId xmlns:a16="http://schemas.microsoft.com/office/drawing/2014/main" id="{EDA0665C-583F-456F-A2BB-FDF20A57F5C4}"/>
+                <a16:creationId xmlns:a16="http://schemas.microsoft.com/office/drawing/2014/main" id="{223FB2E0-2641-430C-81CA-7E8558DDFF3F}"/>
               </a:ext>
             </a:extLst>
           </p:cNvPr>
@@ -2468,7 +2468,7 @@
           <p:cNvPr id="4" name="bullet-1">
             <a:extLst xmlns:a="http://schemas.openxmlformats.org/drawingml/2006/main">
               <a:ext uri="{FF2B5EF4-FFF2-40B4-BE49-F238E27FC236}">
-                <a16:creationId xmlns:a16="http://schemas.microsoft.com/office/drawing/2014/main" id="{344F61F1-F31B-447D-9228-47F0266D849F}"/>
+                <a16:creationId xmlns:a16="http://schemas.microsoft.com/office/drawing/2014/main" id="{4C97958E-9778-4BAD-A174-140C2502A46A}"/>
               </a:ext>
             </a:extLst>
           </p:cNvPr>
@@ -2513,7 +2513,7 @@
           <p:cNvPr id="5" name="bullet-2">
             <a:extLst xmlns:a="http://schemas.openxmlformats.org/drawingml/2006/main">
               <a:ext uri="{FF2B5EF4-FFF2-40B4-BE49-F238E27FC236}">
-                <a16:creationId xmlns:a16="http://schemas.microsoft.com/office/drawing/2014/main" id="{F738B29F-9B6F-44FF-9CAC-44C2D5A7750F}"/>
+                <a16:creationId xmlns:a16="http://schemas.microsoft.com/office/drawing/2014/main" id="{255B7AEE-2CCF-4602-A3E8-53EDF14D2440}"/>
               </a:ext>
             </a:extLst>
           </p:cNvPr>
@@ -2558,7 +2558,7 @@
           <p:cNvPr id="6" name="bullet-3">
             <a:extLst xmlns:a="http://schemas.openxmlformats.org/drawingml/2006/main">
               <a:ext uri="{FF2B5EF4-FFF2-40B4-BE49-F238E27FC236}">
-                <a16:creationId xmlns:a16="http://schemas.microsoft.com/office/drawing/2014/main" id="{FB809046-68E7-4128-8F17-A6120453ADA8}"/>
+                <a16:creationId xmlns:a16="http://schemas.microsoft.com/office/drawing/2014/main" id="{EF8F71BB-1A61-4FBF-A747-B6140EC57789}"/>
               </a:ext>
             </a:extLst>
           </p:cNvPr>
@@ -2603,7 +2603,7 @@
           <p:cNvPr id="7" name="bullet-4">
             <a:extLst xmlns:a="http://schemas.openxmlformats.org/drawingml/2006/main">
               <a:ext uri="{FF2B5EF4-FFF2-40B4-BE49-F238E27FC236}">
-                <a16:creationId xmlns:a16="http://schemas.microsoft.com/office/drawing/2014/main" id="{8DC3E127-44B2-4940-B8D5-E982339AF4EB}"/>
+                <a16:creationId xmlns:a16="http://schemas.microsoft.com/office/drawing/2014/main" id="{D9FE6660-96E7-4278-B9B0-5C2C984BDEBE}"/>
               </a:ext>
             </a:extLst>
           </p:cNvPr>
@@ -2648,7 +2648,7 @@
           <p:cNvPr id="8" name="bullet-0">
             <a:extLst xmlns:a="http://schemas.openxmlformats.org/drawingml/2006/main">
               <a:ext uri="{FF2B5EF4-FFF2-40B4-BE49-F238E27FC236}">
-                <a16:creationId xmlns:a16="http://schemas.microsoft.com/office/drawing/2014/main" id="{EB6313DC-0DC6-4647-8469-820B0F74252E}"/>
+                <a16:creationId xmlns:a16="http://schemas.microsoft.com/office/drawing/2014/main" id="{48014A44-C117-4A71-A281-7498FFCA8EEA}"/>
               </a:ext>
             </a:extLst>
           </p:cNvPr>
@@ -2693,7 +2693,7 @@
           <p:cNvPr id="9" name="bullet-1">
             <a:extLst xmlns:a="http://schemas.openxmlformats.org/drawingml/2006/main">
               <a:ext uri="{FF2B5EF4-FFF2-40B4-BE49-F238E27FC236}">
-                <a16:creationId xmlns:a16="http://schemas.microsoft.com/office/drawing/2014/main" id="{1899866A-5ABE-4EC7-B6AE-8F5BDC06F724}"/>
+                <a16:creationId xmlns:a16="http://schemas.microsoft.com/office/drawing/2014/main" id="{042533C8-0304-4599-A288-5A1FE1E7179D}"/>
               </a:ext>
             </a:extLst>
           </p:cNvPr>
@@ -2738,7 +2738,7 @@
           <p:cNvPr id="10" name="bullet-2">
             <a:extLst xmlns:a="http://schemas.openxmlformats.org/drawingml/2006/main">
               <a:ext uri="{FF2B5EF4-FFF2-40B4-BE49-F238E27FC236}">
-                <a16:creationId xmlns:a16="http://schemas.microsoft.com/office/drawing/2014/main" id="{19AA9595-709E-4315-873F-E58B089C6F77}"/>
+                <a16:creationId xmlns:a16="http://schemas.microsoft.com/office/drawing/2014/main" id="{FC20D685-6F2B-47F1-9018-4F43C7B38BC2}"/>
               </a:ext>
             </a:extLst>
           </p:cNvPr>
@@ -2783,7 +2783,7 @@
           <p:cNvPr id="11" name="bullet-3">
             <a:extLst xmlns:a="http://schemas.openxmlformats.org/drawingml/2006/main">
               <a:ext uri="{FF2B5EF4-FFF2-40B4-BE49-F238E27FC236}">
-                <a16:creationId xmlns:a16="http://schemas.microsoft.com/office/drawing/2014/main" id="{C351FA87-E26D-4434-86C4-1817643520EE}"/>
+                <a16:creationId xmlns:a16="http://schemas.microsoft.com/office/drawing/2014/main" id="{354B3A50-6A37-4CF8-B9B3-B798D78B5C2F}"/>
               </a:ext>
             </a:extLst>
           </p:cNvPr>
@@ -2819,6 +2819,51 @@
                 </a:solidFill>
               </a:rPr>
               <a:t>Simple coordinators: WinnerTakeAll, OneShotFit, AthenaMAB</a:t>
+            </a:r>
+          </a:p>
+        </p:txBody>
+      </p:sp>
+      <p:sp>
+        <p:nvSpPr>
+          <p:cNvPr id="12" name="protocol-footer">
+            <a:extLst xmlns:a="http://schemas.openxmlformats.org/drawingml/2006/main">
+              <a:ext uri="{FF2B5EF4-FFF2-40B4-BE49-F238E27FC236}">
+                <a16:creationId xmlns:a16="http://schemas.microsoft.com/office/drawing/2014/main" id="{5E529179-81D8-4172-84B8-083387BF3AFD}"/>
+              </a:ext>
+            </a:extLst>
+          </p:cNvPr>
+          <p:cNvSpPr>
+            <a:spLocks xmlns:a="http://schemas.openxmlformats.org/drawingml/2006/main" noGrp="1"/>
+          </p:cNvSpPr>
+          <p:nvPr/>
+        </p:nvSpPr>
+        <p:spPr>
+          <a:xfrm xmlns:a="http://schemas.openxmlformats.org/drawingml/2006/main">
+            <a:off x="876300" y="9372600"/>
+            <a:ext cx="16535400" cy="266700"/>
+          </a:xfrm>
+          <a:prstGeom xmlns:a="http://schemas.openxmlformats.org/drawingml/2006/main" prst="rect">
+            <a:avLst/>
+          </a:prstGeom>
+        </p:spPr>
+        <p:txBody>
+          <a:bodyPr xmlns:a="http://schemas.openxmlformats.org/drawingml/2006/main" lIns="0" tIns="0" rIns="0" bIns="0"/>
+          <a:lstStyle xmlns:a="http://schemas.openxmlformats.org/drawingml/2006/main"/>
+          <a:p xmlns:a="http://schemas.openxmlformats.org/drawingml/2006/main">
+            <a:pPr>
+              <a:defRPr sz="1650">
+                <a:solidFill>
+                  <a:srgbClr val="000000"/>
+                </a:solidFill>
+              </a:defRPr>
+            </a:pPr>
+            <a:r>
+              <a:rPr sz="1650">
+                <a:solidFill>
+                  <a:srgbClr val="000000"/>
+                </a:solidFill>
+              </a:rPr>
+              <a:t>Selection used train/search surfaces. Heldout appears only after the seed is fixed.</a:t>
             </a:r>
           </a:p>
         </p:txBody>
@@ -2826,7 +2871,7 @@
     </p:spTree>
     <p:extLst>
       <p:ext uri="{BB962C8B-B14F-4D97-AF65-F5344CB8AC3E}">
-        <p14:creationId xmlns:p14="http://schemas.microsoft.com/office/powerpoint/2010/main" val="846832683"/>
+        <p14:creationId xmlns:p14="http://schemas.microsoft.com/office/powerpoint/2010/main" val="237605026"/>
       </p:ext>
     </p:extLst>
   </p:cSld>
@@ -2850,7 +2895,7 @@
           <p:cNvPr id="1" name="slide-title">
             <a:extLst xmlns:a="http://schemas.openxmlformats.org/drawingml/2006/main">
               <a:ext uri="{FF2B5EF4-FFF2-40B4-BE49-F238E27FC236}">
-                <a16:creationId xmlns:a16="http://schemas.microsoft.com/office/drawing/2014/main" id="{546972A5-8911-4C97-8B5B-A268211FAC57}"/>
+                <a16:creationId xmlns:a16="http://schemas.microsoft.com/office/drawing/2014/main" id="{53879717-2C1A-4B17-85D2-E5829F68CB42}"/>
               </a:ext>
             </a:extLst>
           </p:cNvPr>
@@ -2895,7 +2940,7 @@
           <p:cNvPr id="2" name="slide-subtitle">
             <a:extLst xmlns:a="http://schemas.openxmlformats.org/drawingml/2006/main">
               <a:ext uri="{FF2B5EF4-FFF2-40B4-BE49-F238E27FC236}">
-                <a16:creationId xmlns:a16="http://schemas.microsoft.com/office/drawing/2014/main" id="{2D910EE9-E821-420E-95AD-FA782B7866F7}"/>
+                <a16:creationId xmlns:a16="http://schemas.microsoft.com/office/drawing/2014/main" id="{A1184FF6-EEB2-4548-837F-65E181AA23F1}"/>
               </a:ext>
             </a:extLst>
           </p:cNvPr>
@@ -2930,7 +2975,7 @@
                   <a:srgbClr val="000000"/>
                 </a:solidFill>
               </a:rPr>
-              <a:t>The same MLOP + SPP+PPF pair is compared before and after OpenEvolve.</a:t>
+              <a:t>MoP-V1.3 improves both train-window comparators, then shows a smaller heldout lift.</a:t>
             </a:r>
           </a:p>
         </p:txBody>
@@ -2944,7 +2989,7 @@
           <p:nvPr/>
         </p:nvPicPr>
         <p:blipFill>
-          <a:blip xmlns:r="http://schemas.openxmlformats.org/officeDocument/2006/relationships" xmlns:a="http://schemas.openxmlformats.org/drawingml/2006/main" r:embed="R11c367ce4b6e4b3f"/>
+          <a:blip xmlns:r="http://schemas.openxmlformats.org/officeDocument/2006/relationships" xmlns:a="http://schemas.openxmlformats.org/drawingml/2006/main" r:embed="R3a101acb160b4b5a"/>
           <a:stretch xmlns:a="http://schemas.openxmlformats.org/drawingml/2006/main"/>
         </p:blipFill>
         <p:spPr>
@@ -2960,7 +3005,7 @@
     </p:spTree>
     <p:extLst>
       <p:ext uri="{BB962C8B-B14F-4D97-AF65-F5344CB8AC3E}">
-        <p14:creationId xmlns:p14="http://schemas.microsoft.com/office/powerpoint/2010/main" val="1923906222"/>
+        <p14:creationId xmlns:p14="http://schemas.microsoft.com/office/powerpoint/2010/main" val="999501044"/>
       </p:ext>
     </p:extLst>
   </p:cSld>
@@ -2984,7 +3029,7 @@
           <p:cNvPr id="1" name="slide-title">
             <a:extLst xmlns:a="http://schemas.openxmlformats.org/drawingml/2006/main">
               <a:ext uri="{FF2B5EF4-FFF2-40B4-BE49-F238E27FC236}">
-                <a16:creationId xmlns:a16="http://schemas.microsoft.com/office/drawing/2014/main" id="{686430AB-7751-4F91-8FEF-3BED147AA82D}"/>
+                <a16:creationId xmlns:a16="http://schemas.microsoft.com/office/drawing/2014/main" id="{EA5CA4FA-E8EB-4FCA-8101-7A6296B9E601}"/>
               </a:ext>
             </a:extLst>
           </p:cNvPr>
@@ -3019,7 +3064,7 @@
                   <a:srgbClr val="000000"/>
                 </a:solidFill>
               </a:rPr>
-              <a:t>Heldout shows the balanced-router story</a:t>
+              <a:t>Heldout shows a modest geomean lift</a:t>
             </a:r>
           </a:p>
         </p:txBody>
@@ -3029,7 +3074,7 @@
           <p:cNvPr id="2" name="slide-subtitle">
             <a:extLst xmlns:a="http://schemas.openxmlformats.org/drawingml/2006/main">
               <a:ext uri="{FF2B5EF4-FFF2-40B4-BE49-F238E27FC236}">
-                <a16:creationId xmlns:a16="http://schemas.microsoft.com/office/drawing/2014/main" id="{AABF3F0C-19AC-4B22-98F4-C7FF36BC2E99}"/>
+                <a16:creationId xmlns:a16="http://schemas.microsoft.com/office/drawing/2014/main" id="{CCD03C7D-CC85-4455-B3F3-46373D043E4C}"/>
               </a:ext>
             </a:extLst>
           </p:cNvPr>
@@ -3064,7 +3109,7 @@
                   <a:srgbClr val="000000"/>
                 </a:solidFill>
               </a:rPr>
-              <a:t>The router clears no-prefetch in geomean and remains below the stronger single expert.</a:t>
+              <a:t>Heldout clears no-prefetch by geomean, while trace-level placement shows why pair-best remains the upper bar.</a:t>
             </a:r>
           </a:p>
         </p:txBody>
@@ -3078,7 +3123,7 @@
           <p:nvPr/>
         </p:nvPicPr>
         <p:blipFill>
-          <a:blip xmlns:r="http://schemas.openxmlformats.org/officeDocument/2006/relationships" xmlns:a="http://schemas.openxmlformats.org/drawingml/2006/main" r:embed="R830889b29eb542e1"/>
+          <a:blip xmlns:r="http://schemas.openxmlformats.org/officeDocument/2006/relationships" xmlns:a="http://schemas.openxmlformats.org/drawingml/2006/main" r:embed="R4d86b48ca0cd4722"/>
           <a:stretch xmlns:a="http://schemas.openxmlformats.org/drawingml/2006/main"/>
         </p:blipFill>
         <p:spPr>
@@ -3094,7 +3139,7 @@
     </p:spTree>
     <p:extLst>
       <p:ext uri="{BB962C8B-B14F-4D97-AF65-F5344CB8AC3E}">
-        <p14:creationId xmlns:p14="http://schemas.microsoft.com/office/powerpoint/2010/main" val="977376244"/>
+        <p14:creationId xmlns:p14="http://schemas.microsoft.com/office/powerpoint/2010/main" val="1382187727"/>
       </p:ext>
     </p:extLst>
   </p:cSld>
@@ -3118,7 +3163,7 @@
           <p:cNvPr id="1" name="slide-title">
             <a:extLst xmlns:a="http://schemas.openxmlformats.org/drawingml/2006/main">
               <a:ext uri="{FF2B5EF4-FFF2-40B4-BE49-F238E27FC236}">
-                <a16:creationId xmlns:a16="http://schemas.microsoft.com/office/drawing/2014/main" id="{5D58D88E-AAC3-4CA5-B458-3568B8CC5F4E}"/>
+                <a16:creationId xmlns:a16="http://schemas.microsoft.com/office/drawing/2014/main" id="{01624A67-BEF8-494E-B9EC-723B75D8852C}"/>
               </a:ext>
             </a:extLst>
           </p:cNvPr>
@@ -3153,7 +3198,7 @@
                   <a:srgbClr val="000000"/>
                 </a:solidFill>
               </a:rPr>
-              <a:t>Three model sweeps found nearby policies</a:t>
+              <a:t>Model sweeps improved screens, confirmation kept the seed</a:t>
             </a:r>
           </a:p>
         </p:txBody>
@@ -3163,7 +3208,7 @@
           <p:cNvPr id="2" name="slide-subtitle">
             <a:extLst xmlns:a="http://schemas.openxmlformats.org/drawingml/2006/main">
               <a:ext uri="{FF2B5EF4-FFF2-40B4-BE49-F238E27FC236}">
-                <a16:creationId xmlns:a16="http://schemas.microsoft.com/office/drawing/2014/main" id="{E62091A5-FAF8-467D-A537-AD773ED24694}"/>
+                <a16:creationId xmlns:a16="http://schemas.microsoft.com/office/drawing/2014/main" id="{5537EC2E-9125-4CBF-A90A-1586C6ABFDCB}"/>
               </a:ext>
             </a:extLst>
           </p:cNvPr>
@@ -3198,7 +3243,7 @@
                   <a:srgbClr val="000000"/>
                 </a:solidFill>
               </a:rPr>
-              <a:t>Scaled search improved the cheap screen, and wider confirmation kept the frozen seed.</a:t>
+              <a:t>Scaled search found similar cheap-screen candidates, then 10-trace confirmation preserved the active seed at 0.9801x.</a:t>
             </a:r>
           </a:p>
         </p:txBody>
@@ -3212,7 +3257,7 @@
           <p:nvPr/>
         </p:nvPicPr>
         <p:blipFill>
-          <a:blip xmlns:r="http://schemas.openxmlformats.org/officeDocument/2006/relationships" xmlns:a="http://schemas.openxmlformats.org/drawingml/2006/main" r:embed="R42c749d950fa4ed3"/>
+          <a:blip xmlns:r="http://schemas.openxmlformats.org/officeDocument/2006/relationships" xmlns:a="http://schemas.openxmlformats.org/drawingml/2006/main" r:embed="R7dfa601f35ad4636"/>
           <a:stretch xmlns:a="http://schemas.openxmlformats.org/drawingml/2006/main"/>
         </p:blipFill>
         <p:spPr>
@@ -3228,7 +3273,7 @@
     </p:spTree>
     <p:extLst>
       <p:ext uri="{BB962C8B-B14F-4D97-AF65-F5344CB8AC3E}">
-        <p14:creationId xmlns:p14="http://schemas.microsoft.com/office/powerpoint/2010/main" val="1887188336"/>
+        <p14:creationId xmlns:p14="http://schemas.microsoft.com/office/powerpoint/2010/main" val="1991084861"/>
       </p:ext>
     </p:extLst>
   </p:cSld>
@@ -3252,7 +3297,7 @@
           <p:cNvPr id="1" name="slide-title">
             <a:extLst xmlns:a="http://schemas.openxmlformats.org/drawingml/2006/main">
               <a:ext uri="{FF2B5EF4-FFF2-40B4-BE49-F238E27FC236}">
-                <a16:creationId xmlns:a16="http://schemas.microsoft.com/office/drawing/2014/main" id="{9494FC69-4FF5-47D0-9AE0-8E6C61A2F4B1}"/>
+                <a16:creationId xmlns:a16="http://schemas.microsoft.com/office/drawing/2014/main" id="{059BE67E-57A7-4620-868F-1B02B9113AAA}"/>
               </a:ext>
             </a:extLst>
           </p:cNvPr>
@@ -3297,7 +3342,7 @@
           <p:cNvPr id="2" name="slide-subtitle">
             <a:extLst xmlns:a="http://schemas.openxmlformats.org/drawingml/2006/main">
               <a:ext uri="{FF2B5EF4-FFF2-40B4-BE49-F238E27FC236}">
-                <a16:creationId xmlns:a16="http://schemas.microsoft.com/office/drawing/2014/main" id="{3E770028-B24A-4BAA-AE31-330666A1BC3D}"/>
+                <a16:creationId xmlns:a16="http://schemas.microsoft.com/office/drawing/2014/main" id="{200D3706-0A33-440F-9394-C91B91BB1F82}"/>
               </a:ext>
             </a:extLst>
           </p:cNvPr>
@@ -3342,7 +3387,7 @@
           <p:cNvPr id="3" name="bullet-0">
             <a:extLst xmlns:a="http://schemas.openxmlformats.org/drawingml/2006/main">
               <a:ext uri="{FF2B5EF4-FFF2-40B4-BE49-F238E27FC236}">
-                <a16:creationId xmlns:a16="http://schemas.microsoft.com/office/drawing/2014/main" id="{78522323-F737-476D-AAA2-59F108893076}"/>
+                <a16:creationId xmlns:a16="http://schemas.microsoft.com/office/drawing/2014/main" id="{B837558C-FF5B-4EF8-B790-2474E9AF50C7}"/>
               </a:ext>
             </a:extLst>
           </p:cNvPr>
@@ -3387,7 +3432,7 @@
           <p:cNvPr id="4" name="bullet-1">
             <a:extLst xmlns:a="http://schemas.openxmlformats.org/drawingml/2006/main">
               <a:ext uri="{FF2B5EF4-FFF2-40B4-BE49-F238E27FC236}">
-                <a16:creationId xmlns:a16="http://schemas.microsoft.com/office/drawing/2014/main" id="{EC1EC770-7C0D-4F0D-A265-842BA384CA45}"/>
+                <a16:creationId xmlns:a16="http://schemas.microsoft.com/office/drawing/2014/main" id="{39E537AF-0074-4138-BF39-E879E635D163}"/>
               </a:ext>
             </a:extLst>
           </p:cNvPr>
@@ -3432,7 +3477,7 @@
           <p:cNvPr id="5" name="bullet-2">
             <a:extLst xmlns:a="http://schemas.openxmlformats.org/drawingml/2006/main">
               <a:ext uri="{FF2B5EF4-FFF2-40B4-BE49-F238E27FC236}">
-                <a16:creationId xmlns:a16="http://schemas.microsoft.com/office/drawing/2014/main" id="{620BAA25-EF16-4F09-9284-CA4F55F2962A}"/>
+                <a16:creationId xmlns:a16="http://schemas.microsoft.com/office/drawing/2014/main" id="{4D1CC32D-FD95-4991-AA8C-26F342436A56}"/>
               </a:ext>
             </a:extLst>
           </p:cNvPr>
@@ -3477,7 +3522,7 @@
           <p:cNvPr id="6" name="bullet-3">
             <a:extLst xmlns:a="http://schemas.openxmlformats.org/drawingml/2006/main">
               <a:ext uri="{FF2B5EF4-FFF2-40B4-BE49-F238E27FC236}">
-                <a16:creationId xmlns:a16="http://schemas.microsoft.com/office/drawing/2014/main" id="{4A7DF3F2-9C45-4AB5-8064-8A835F4FB29B}"/>
+                <a16:creationId xmlns:a16="http://schemas.microsoft.com/office/drawing/2014/main" id="{6202887A-13A8-4604-9636-338429E0E913}"/>
               </a:ext>
             </a:extLst>
           </p:cNvPr>
@@ -3522,7 +3567,7 @@
           <p:cNvPr id="7" name="bullet-4">
             <a:extLst xmlns:a="http://schemas.openxmlformats.org/drawingml/2006/main">
               <a:ext uri="{FF2B5EF4-FFF2-40B4-BE49-F238E27FC236}">
-                <a16:creationId xmlns:a16="http://schemas.microsoft.com/office/drawing/2014/main" id="{C2AF8E94-8693-45B2-B2EE-875B51A77404}"/>
+                <a16:creationId xmlns:a16="http://schemas.microsoft.com/office/drawing/2014/main" id="{4744D77D-AE0D-4D78-BE8A-D7F047E072A4}"/>
               </a:ext>
             </a:extLst>
           </p:cNvPr>
@@ -3567,7 +3612,7 @@
           <p:cNvPr id="8" name="bullet-0">
             <a:extLst xmlns:a="http://schemas.openxmlformats.org/drawingml/2006/main">
               <a:ext uri="{FF2B5EF4-FFF2-40B4-BE49-F238E27FC236}">
-                <a16:creationId xmlns:a16="http://schemas.microsoft.com/office/drawing/2014/main" id="{94DA4864-2E57-464C-979B-2F01DD047E5D}"/>
+                <a16:creationId xmlns:a16="http://schemas.microsoft.com/office/drawing/2014/main" id="{8663253C-D99F-459A-952A-3370B59C9FAB}"/>
               </a:ext>
             </a:extLst>
           </p:cNvPr>
@@ -3612,7 +3657,7 @@
           <p:cNvPr id="9" name="bullet-1">
             <a:extLst xmlns:a="http://schemas.openxmlformats.org/drawingml/2006/main">
               <a:ext uri="{FF2B5EF4-FFF2-40B4-BE49-F238E27FC236}">
-                <a16:creationId xmlns:a16="http://schemas.microsoft.com/office/drawing/2014/main" id="{575EC8A1-67EE-4D33-B3AC-DF2564113889}"/>
+                <a16:creationId xmlns:a16="http://schemas.microsoft.com/office/drawing/2014/main" id="{5656CA13-A510-4D57-8C68-8E7CB9630370}"/>
               </a:ext>
             </a:extLst>
           </p:cNvPr>
@@ -3657,7 +3702,7 @@
           <p:cNvPr id="10" name="bullet-2">
             <a:extLst xmlns:a="http://schemas.openxmlformats.org/drawingml/2006/main">
               <a:ext uri="{FF2B5EF4-FFF2-40B4-BE49-F238E27FC236}">
-                <a16:creationId xmlns:a16="http://schemas.microsoft.com/office/drawing/2014/main" id="{791B5648-9442-4D5A-B57A-DC3AB3172A5F}"/>
+                <a16:creationId xmlns:a16="http://schemas.microsoft.com/office/drawing/2014/main" id="{3423E923-E3FA-4D62-BBB5-C3F66D3D6D33}"/>
               </a:ext>
             </a:extLst>
           </p:cNvPr>
@@ -3702,7 +3747,7 @@
           <p:cNvPr id="11" name="bullet-3">
             <a:extLst xmlns:a="http://schemas.openxmlformats.org/drawingml/2006/main">
               <a:ext uri="{FF2B5EF4-FFF2-40B4-BE49-F238E27FC236}">
-                <a16:creationId xmlns:a16="http://schemas.microsoft.com/office/drawing/2014/main" id="{E26C23C4-C408-4574-AC1F-99086C648646}"/>
+                <a16:creationId xmlns:a16="http://schemas.microsoft.com/office/drawing/2014/main" id="{88822A33-1164-43AB-8753-50F9CC8D13C2}"/>
               </a:ext>
             </a:extLst>
           </p:cNvPr>
@@ -3747,7 +3792,7 @@
           <p:cNvPr id="12" name="bullet-4">
             <a:extLst xmlns:a="http://schemas.openxmlformats.org/drawingml/2006/main">
               <a:ext uri="{FF2B5EF4-FFF2-40B4-BE49-F238E27FC236}">
-                <a16:creationId xmlns:a16="http://schemas.microsoft.com/office/drawing/2014/main" id="{86D19A15-E552-4942-B886-A1E33998C570}"/>
+                <a16:creationId xmlns:a16="http://schemas.microsoft.com/office/drawing/2014/main" id="{410C9636-3CC2-4763-8CBC-04323CA10BC0}"/>
               </a:ext>
             </a:extLst>
           </p:cNvPr>
@@ -3783,6 +3828,51 @@
                 </a:solidFill>
               </a:rPr>
               <a:t>Missing evolve markers</a:t>
+            </a:r>
+          </a:p>
+        </p:txBody>
+      </p:sp>
+      <p:sp>
+        <p:nvSpPr>
+          <p:cNvPr id="13" name="audit-footer">
+            <a:extLst xmlns:a="http://schemas.openxmlformats.org/drawingml/2006/main">
+              <a:ext uri="{FF2B5EF4-FFF2-40B4-BE49-F238E27FC236}">
+                <a16:creationId xmlns:a16="http://schemas.microsoft.com/office/drawing/2014/main" id="{23562AB2-8337-4EC3-9C84-843878EC37B0}"/>
+              </a:ext>
+            </a:extLst>
+          </p:cNvPr>
+          <p:cNvSpPr>
+            <a:spLocks xmlns:a="http://schemas.openxmlformats.org/drawingml/2006/main" noGrp="1"/>
+          </p:cNvSpPr>
+          <p:nvPr/>
+        </p:nvSpPr>
+        <p:spPr>
+          <a:xfrm xmlns:a="http://schemas.openxmlformats.org/drawingml/2006/main">
+            <a:off x="876300" y="9372600"/>
+            <a:ext cx="16535400" cy="266700"/>
+          </a:xfrm>
+          <a:prstGeom xmlns:a="http://schemas.openxmlformats.org/drawingml/2006/main" prst="rect">
+            <a:avLst/>
+          </a:prstGeom>
+        </p:spPr>
+        <p:txBody>
+          <a:bodyPr xmlns:a="http://schemas.openxmlformats.org/drawingml/2006/main" lIns="0" tIns="0" rIns="0" bIns="0"/>
+          <a:lstStyle xmlns:a="http://schemas.openxmlformats.org/drawingml/2006/main"/>
+          <a:p xmlns:a="http://schemas.openxmlformats.org/drawingml/2006/main">
+            <a:pPr>
+              <a:defRPr sz="1650">
+                <a:solidFill>
+                  <a:srgbClr val="000000"/>
+                </a:solidFill>
+              </a:defRPr>
+            </a:pPr>
+            <a:r>
+              <a:rPr sz="1650">
+                <a:solidFill>
+                  <a:srgbClr val="000000"/>
+                </a:solidFill>
+              </a:rPr>
+              <a:t>Ledger: 290 candidates, 225 valid scored rows, 65 fail-closed rows. Malformed or crashed candidates receive combined_score = -10.0.</a:t>
             </a:r>
           </a:p>
         </p:txBody>
@@ -3790,7 +3880,7 @@
     </p:spTree>
     <p:extLst>
       <p:ext uri="{BB962C8B-B14F-4D97-AF65-F5344CB8AC3E}">
-        <p14:creationId xmlns:p14="http://schemas.microsoft.com/office/powerpoint/2010/main" val="781709768"/>
+        <p14:creationId xmlns:p14="http://schemas.microsoft.com/office/powerpoint/2010/main" val="1720311171"/>
       </p:ext>
     </p:extLst>
   </p:cSld>
@@ -3814,7 +3904,7 @@
           <p:cNvPr id="1" name="slide-title">
             <a:extLst xmlns:a="http://schemas.openxmlformats.org/drawingml/2006/main">
               <a:ext uri="{FF2B5EF4-FFF2-40B4-BE49-F238E27FC236}">
-                <a16:creationId xmlns:a16="http://schemas.microsoft.com/office/drawing/2014/main" id="{7EF305AC-C119-4131-8C8C-1D267CFC46FF}"/>
+                <a16:creationId xmlns:a16="http://schemas.microsoft.com/office/drawing/2014/main" id="{E9007733-2C31-4541-8E03-95D1EF891B39}"/>
               </a:ext>
             </a:extLst>
           </p:cNvPr>
@@ -3859,7 +3949,7 @@
           <p:cNvPr id="2" name="title-rule">
             <a:extLst xmlns:a="http://schemas.openxmlformats.org/drawingml/2006/main">
               <a:ext uri="{FF2B5EF4-FFF2-40B4-BE49-F238E27FC236}">
-                <a16:creationId xmlns:a16="http://schemas.microsoft.com/office/drawing/2014/main" id="{3654A95B-DAE1-4485-BEBE-74E56F2C3205}"/>
+                <a16:creationId xmlns:a16="http://schemas.microsoft.com/office/drawing/2014/main" id="{D9CA3DA7-0301-400E-8C4F-DD70F896FE88}"/>
               </a:ext>
             </a:extLst>
           </p:cNvPr>
@@ -3892,7 +3982,7 @@
           <p:cNvPr id="3" name="bullet-0">
             <a:extLst xmlns:a="http://schemas.openxmlformats.org/drawingml/2006/main">
               <a:ext uri="{FF2B5EF4-FFF2-40B4-BE49-F238E27FC236}">
-                <a16:creationId xmlns:a16="http://schemas.microsoft.com/office/drawing/2014/main" id="{EFFE83F0-4AAA-4D60-A91F-00C2844C14BA}"/>
+                <a16:creationId xmlns:a16="http://schemas.microsoft.com/office/drawing/2014/main" id="{DA335108-832B-4E51-8C38-7C8781D03CD5}"/>
               </a:ext>
             </a:extLst>
           </p:cNvPr>
@@ -3927,7 +4017,7 @@
                   <a:srgbClr val="000000"/>
                 </a:solidFill>
               </a:rPr>
-              <a:t>Stage 2 improved the Stage 1 router family on train-window evidence.</a:t>
+              <a:t>Primary defended claim: Stage 2 closes the train-window gap against pair-best single.</a:t>
             </a:r>
           </a:p>
         </p:txBody>
@@ -3937,7 +4027,7 @@
           <p:cNvPr id="4" name="bullet-1">
             <a:extLst xmlns:a="http://schemas.openxmlformats.org/drawingml/2006/main">
               <a:ext uri="{FF2B5EF4-FFF2-40B4-BE49-F238E27FC236}">
-                <a16:creationId xmlns:a16="http://schemas.microsoft.com/office/drawing/2014/main" id="{94880F7A-8B88-4400-8BC0-67CE90CD9D01}"/>
+                <a16:creationId xmlns:a16="http://schemas.microsoft.com/office/drawing/2014/main" id="{94C8C1AF-001D-4B4B-96B7-EC42C17ABFDD}"/>
               </a:ext>
             </a:extLst>
           </p:cNvPr>
@@ -3972,7 +4062,7 @@
                   <a:srgbClr val="000000"/>
                 </a:solidFill>
               </a:rPr>
-              <a:t>The selected router beats no-prefetch in train-window and heldout geomean.</a:t>
+              <a:t>Heldout claim: the selected router clears no-prefetch in geomean.</a:t>
             </a:r>
           </a:p>
         </p:txBody>
@@ -3982,7 +4072,7 @@
           <p:cNvPr id="5" name="bullet-2">
             <a:extLst xmlns:a="http://schemas.openxmlformats.org/drawingml/2006/main">
               <a:ext uri="{FF2B5EF4-FFF2-40B4-BE49-F238E27FC236}">
-                <a16:creationId xmlns:a16="http://schemas.microsoft.com/office/drawing/2014/main" id="{69D0B22F-086A-4616-B362-5A8AAD29D1EF}"/>
+                <a16:creationId xmlns:a16="http://schemas.microsoft.com/office/drawing/2014/main" id="{675C358D-ADD1-49DE-B215-28292D7FE3E9}"/>
               </a:ext>
             </a:extLst>
           </p:cNvPr>
@@ -4027,7 +4117,7 @@
           <p:cNvPr id="6" name="bullet-3">
             <a:extLst xmlns:a="http://schemas.openxmlformats.org/drawingml/2006/main">
               <a:ext uri="{FF2B5EF4-FFF2-40B4-BE49-F238E27FC236}">
-                <a16:creationId xmlns:a16="http://schemas.microsoft.com/office/drawing/2014/main" id="{0A647AB1-0875-4783-985E-893E29A66B86}"/>
+                <a16:creationId xmlns:a16="http://schemas.microsoft.com/office/drawing/2014/main" id="{7589EFB7-420C-4336-BD8B-06DD62A512CF}"/>
               </a:ext>
             </a:extLst>
           </p:cNvPr>
@@ -4072,7 +4162,7 @@
           <p:cNvPr id="7" name="bullet-4">
             <a:extLst xmlns:a="http://schemas.openxmlformats.org/drawingml/2006/main">
               <a:ext uri="{FF2B5EF4-FFF2-40B4-BE49-F238E27FC236}">
-                <a16:creationId xmlns:a16="http://schemas.microsoft.com/office/drawing/2014/main" id="{D4A337C2-6934-4858-AE3A-9B78F941BCD2}"/>
+                <a16:creationId xmlns:a16="http://schemas.microsoft.com/office/drawing/2014/main" id="{3BD6D933-3FE6-45A8-B449-EA5C406DE896}"/>
               </a:ext>
             </a:extLst>
           </p:cNvPr>
@@ -4115,7 +4205,7 @@
     </p:spTree>
     <p:extLst>
       <p:ext uri="{BB962C8B-B14F-4D97-AF65-F5344CB8AC3E}">
-        <p14:creationId xmlns:p14="http://schemas.microsoft.com/office/powerpoint/2010/main" val="1811074665"/>
+        <p14:creationId xmlns:p14="http://schemas.microsoft.com/office/powerpoint/2010/main" val="1416011399"/>
       </p:ext>
     </p:extLst>
   </p:cSld>

</xml_diff>

<commit_message>
Polish OpenEvolve report and visuals
</commit_message>
<xml_diff>
--- a/slides/mop_stage2_final/output/output.pptx
+++ b/slides/mop_stage2_final/output/output.pptx
@@ -2,20 +2,20 @@
 <file path=ppt/presentation.xml><?xml version="1.0" encoding="utf-8"?>
 <p:presentation xmlns:p="http://schemas.openxmlformats.org/presentationml/2006/main">
   <p:sldMasterIdLst>
-    <p:sldMasterId xmlns:r="http://schemas.openxmlformats.org/officeDocument/2006/relationships" id="2147483648" r:id="R9d056e3f6eaa43e6"/>
+    <p:sldMasterId xmlns:r="http://schemas.openxmlformats.org/officeDocument/2006/relationships" id="2147483648" r:id="Rcf019af433b04efd"/>
   </p:sldMasterIdLst>
   <p:notesMasterIdLst>
-    <p:notesMasterId xmlns:r="http://schemas.openxmlformats.org/officeDocument/2006/relationships" r:id="R4d1f1986ef284f10"/>
+    <p:notesMasterId xmlns:r="http://schemas.openxmlformats.org/officeDocument/2006/relationships" r:id="R6d936477a8a74063"/>
   </p:notesMasterIdLst>
   <p:sldIdLst>
-    <p:sldId xmlns:r="http://schemas.openxmlformats.org/officeDocument/2006/relationships" id="256" r:id="Rc9fba26c2bfd4d9c"/>
-    <p:sldId xmlns:r="http://schemas.openxmlformats.org/officeDocument/2006/relationships" id="257" r:id="Rfc6dc8397d874df0"/>
-    <p:sldId xmlns:r="http://schemas.openxmlformats.org/officeDocument/2006/relationships" id="258" r:id="R70ec9d0814274419"/>
-    <p:sldId xmlns:r="http://schemas.openxmlformats.org/officeDocument/2006/relationships" id="259" r:id="R5379ecf69a634d2f"/>
-    <p:sldId xmlns:r="http://schemas.openxmlformats.org/officeDocument/2006/relationships" id="260" r:id="Rdec4330402864d8a"/>
-    <p:sldId xmlns:r="http://schemas.openxmlformats.org/officeDocument/2006/relationships" id="261" r:id="Rec3ea2e7925b49d8"/>
-    <p:sldId xmlns:r="http://schemas.openxmlformats.org/officeDocument/2006/relationships" id="262" r:id="Rcc9228c613ac4b38"/>
-    <p:sldId xmlns:r="http://schemas.openxmlformats.org/officeDocument/2006/relationships" id="263" r:id="Rb00e074e2a4f4ef7"/>
+    <p:sldId xmlns:r="http://schemas.openxmlformats.org/officeDocument/2006/relationships" id="256" r:id="Rb74c2666575d4261"/>
+    <p:sldId xmlns:r="http://schemas.openxmlformats.org/officeDocument/2006/relationships" id="257" r:id="R0d672db6e9b24a0a"/>
+    <p:sldId xmlns:r="http://schemas.openxmlformats.org/officeDocument/2006/relationships" id="258" r:id="R36a08f214930491f"/>
+    <p:sldId xmlns:r="http://schemas.openxmlformats.org/officeDocument/2006/relationships" id="259" r:id="R1f32f15770c4489f"/>
+    <p:sldId xmlns:r="http://schemas.openxmlformats.org/officeDocument/2006/relationships" id="260" r:id="R71e984da5e4d44b1"/>
+    <p:sldId xmlns:r="http://schemas.openxmlformats.org/officeDocument/2006/relationships" id="261" r:id="R7fce0d0ad4424518"/>
+    <p:sldId xmlns:r="http://schemas.openxmlformats.org/officeDocument/2006/relationships" id="262" r:id="R0b5bbd31bb5946e6"/>
+    <p:sldId xmlns:r="http://schemas.openxmlformats.org/officeDocument/2006/relationships" id="263" r:id="R4612e2c51b2f453b"/>
   </p:sldIdLst>
   <p:sldSz cx="18288000" cy="10287000"/>
   <p:notesSz cx="6858000" cy="9144000"/>
@@ -1024,7 +1024,7 @@
   </p:cSld>
   <p:clrMap bg1="lt1" tx1="dk1" bg2="lt2" tx2="dk2" accent1="accent1" accent2="accent2" accent3="accent3" accent4="accent4" accent5="accent5" accent6="accent6" hlink="hlink" folHlink="folHlink"/>
   <p:sldLayoutIdLst>
-    <p:sldLayoutId xmlns:r="http://schemas.openxmlformats.org/officeDocument/2006/relationships" id="2147483649" r:id="R368124988b454d44"/>
+    <p:sldLayoutId xmlns:r="http://schemas.openxmlformats.org/officeDocument/2006/relationships" id="2147483649" r:id="Raea05c48b4e94a0f"/>
   </p:sldLayoutIdLst>
   <p:txStyles>
     <p:titleStyle>
@@ -1323,7 +1323,7 @@
           <p:cNvPr id="1" name="cover-title">
             <a:extLst xmlns:a="http://schemas.openxmlformats.org/drawingml/2006/main">
               <a:ext uri="{FF2B5EF4-FFF2-40B4-BE49-F238E27FC236}">
-                <a16:creationId xmlns:a16="http://schemas.microsoft.com/office/drawing/2014/main" id="{5AA06128-D2C3-49C7-9799-2139AF6C81C9}"/>
+                <a16:creationId xmlns:a16="http://schemas.microsoft.com/office/drawing/2014/main" id="{FC3F70BA-69A3-48E4-9DC3-B218FC1507D7}"/>
               </a:ext>
             </a:extLst>
           </p:cNvPr>
@@ -1368,7 +1368,7 @@
           <p:cNvPr id="2" name="cover-rule">
             <a:extLst xmlns:a="http://schemas.openxmlformats.org/drawingml/2006/main">
               <a:ext uri="{FF2B5EF4-FFF2-40B4-BE49-F238E27FC236}">
-                <a16:creationId xmlns:a16="http://schemas.microsoft.com/office/drawing/2014/main" id="{FCCCE44D-FD62-4161-950B-2D654A09B08D}"/>
+                <a16:creationId xmlns:a16="http://schemas.microsoft.com/office/drawing/2014/main" id="{F1D64169-877F-4E30-BB04-EDE9B86BE11D}"/>
               </a:ext>
             </a:extLst>
           </p:cNvPr>
@@ -1401,7 +1401,7 @@
           <p:cNvPr id="3" name="cover-thesis">
             <a:extLst xmlns:a="http://schemas.openxmlformats.org/drawingml/2006/main">
               <a:ext uri="{FF2B5EF4-FFF2-40B4-BE49-F238E27FC236}">
-                <a16:creationId xmlns:a16="http://schemas.microsoft.com/office/drawing/2014/main" id="{665B6407-59C4-4F13-AFE2-5FADA6D092D3}"/>
+                <a16:creationId xmlns:a16="http://schemas.microsoft.com/office/drawing/2014/main" id="{B3424CBF-8046-4E04-BB2A-2B9A7BD96305}"/>
               </a:ext>
             </a:extLst>
           </p:cNvPr>
@@ -1436,7 +1436,7 @@
                   <a:srgbClr val="000000"/>
                 </a:solidFill>
               </a:rPr>
-              <a:t>A small L2C router that closes the train-window pair-best gap and clears no-prefetch on heldout</a:t>
+              <a:t>A small L2-cache router that improves IPC over disabled prefetching and tracks an oracle best-prefetcher cap</a:t>
             </a:r>
           </a:p>
         </p:txBody>
@@ -1446,7 +1446,7 @@
           <p:cNvPr id="4" name="cover-metric-1">
             <a:extLst xmlns:a="http://schemas.openxmlformats.org/drawingml/2006/main">
               <a:ext uri="{FF2B5EF4-FFF2-40B4-BE49-F238E27FC236}">
-                <a16:creationId xmlns:a16="http://schemas.microsoft.com/office/drawing/2014/main" id="{9D731DA8-0CC3-4E15-B60C-689346423C1A}"/>
+                <a16:creationId xmlns:a16="http://schemas.microsoft.com/office/drawing/2014/main" id="{28A270F6-9797-4440-AADB-C9EBB3236654}"/>
               </a:ext>
             </a:extLst>
           </p:cNvPr>
@@ -1481,7 +1481,7 @@
                   <a:srgbClr val="DC267F"/>
                 </a:solidFill>
               </a:rPr>
-              <a:t>0.9829x</a:t>
+              <a:t>1.0662x</a:t>
             </a:r>
           </a:p>
         </p:txBody>
@@ -1491,7 +1491,7 @@
           <p:cNvPr id="5" name="cover-label-1">
             <a:extLst xmlns:a="http://schemas.openxmlformats.org/drawingml/2006/main">
               <a:ext uri="{FF2B5EF4-FFF2-40B4-BE49-F238E27FC236}">
-                <a16:creationId xmlns:a16="http://schemas.microsoft.com/office/drawing/2014/main" id="{C9DC9791-195F-43D5-BD4B-D7FFB21E3C3F}"/>
+                <a16:creationId xmlns:a16="http://schemas.microsoft.com/office/drawing/2014/main" id="{F47744C3-0AF6-40D7-9366-0874FEB8AB18}"/>
               </a:ext>
             </a:extLst>
           </p:cNvPr>
@@ -1526,7 +1526,7 @@
                   <a:srgbClr val="000000"/>
                 </a:solidFill>
               </a:rPr>
-              <a:t>train-window vs pair-best</a:t>
+              <a:t>13-trace training validation vs disabled prefetching</a:t>
             </a:r>
           </a:p>
         </p:txBody>
@@ -1536,7 +1536,7 @@
           <p:cNvPr id="6" name="cover-metric-2">
             <a:extLst xmlns:a="http://schemas.openxmlformats.org/drawingml/2006/main">
               <a:ext uri="{FF2B5EF4-FFF2-40B4-BE49-F238E27FC236}">
-                <a16:creationId xmlns:a16="http://schemas.microsoft.com/office/drawing/2014/main" id="{F5EFE05B-DF10-4F08-811C-C7E20B9DE350}"/>
+                <a16:creationId xmlns:a16="http://schemas.microsoft.com/office/drawing/2014/main" id="{9C728EE8-8E8D-4B62-901B-A4568E41FEF8}"/>
               </a:ext>
             </a:extLst>
           </p:cNvPr>
@@ -1581,7 +1581,7 @@
           <p:cNvPr id="7" name="cover-label-2">
             <a:extLst xmlns:a="http://schemas.openxmlformats.org/drawingml/2006/main">
               <a:ext uri="{FF2B5EF4-FFF2-40B4-BE49-F238E27FC236}">
-                <a16:creationId xmlns:a16="http://schemas.microsoft.com/office/drawing/2014/main" id="{E8035DC6-83C4-4C66-8665-AEBA0DE6748C}"/>
+                <a16:creationId xmlns:a16="http://schemas.microsoft.com/office/drawing/2014/main" id="{704F9724-61DA-4580-BD2E-248604413E20}"/>
               </a:ext>
             </a:extLst>
           </p:cNvPr>
@@ -1616,7 +1616,7 @@
                   <a:srgbClr val="000000"/>
                 </a:solidFill>
               </a:rPr>
-              <a:t>heldout vs no-prefetch</a:t>
+              <a:t>7-trace heldout vs disabled prefetching</a:t>
             </a:r>
           </a:p>
         </p:txBody>
@@ -1626,7 +1626,7 @@
           <p:cNvPr id="8" name="cover-footer">
             <a:extLst xmlns:a="http://schemas.openxmlformats.org/drawingml/2006/main">
               <a:ext uri="{FF2B5EF4-FFF2-40B4-BE49-F238E27FC236}">
-                <a16:creationId xmlns:a16="http://schemas.microsoft.com/office/drawing/2014/main" id="{B2A557B4-39B7-49C3-B8CE-DC3EB7AE01F6}"/>
+                <a16:creationId xmlns:a16="http://schemas.microsoft.com/office/drawing/2014/main" id="{B74547B2-DCB2-4B3B-AF31-89D6282A80BE}"/>
               </a:ext>
             </a:extLst>
           </p:cNvPr>
@@ -1661,7 +1661,7 @@
                   <a:srgbClr val="000000"/>
                 </a:solidFill>
               </a:rPr>
-              <a:t>CMU 15-740 class project, Stage 2 OpenEvolve report</a:t>
+              <a:t>CMU 15-740 class project, OpenEvolve training-validation report</a:t>
             </a:r>
           </a:p>
         </p:txBody>
@@ -1669,7 +1669,7 @@
     </p:spTree>
     <p:extLst>
       <p:ext uri="{BB962C8B-B14F-4D97-AF65-F5344CB8AC3E}">
-        <p14:creationId xmlns:p14="http://schemas.microsoft.com/office/powerpoint/2010/main" val="275022592"/>
+        <p14:creationId xmlns:p14="http://schemas.microsoft.com/office/powerpoint/2010/main" val="1104381730"/>
       </p:ext>
     </p:extLst>
   </p:cSld>
@@ -1693,7 +1693,7 @@
           <p:cNvPr id="1" name="slide-title">
             <a:extLst xmlns:a="http://schemas.openxmlformats.org/drawingml/2006/main">
               <a:ext uri="{FF2B5EF4-FFF2-40B4-BE49-F238E27FC236}">
-                <a16:creationId xmlns:a16="http://schemas.microsoft.com/office/drawing/2014/main" id="{8A8C3815-8D57-431A-A058-7F48B585F763}"/>
+                <a16:creationId xmlns:a16="http://schemas.microsoft.com/office/drawing/2014/main" id="{A661C991-FF9E-4CAE-B8D3-709D3B6B2C6A}"/>
               </a:ext>
             </a:extLst>
           </p:cNvPr>
@@ -1738,7 +1738,7 @@
           <p:cNvPr id="2" name="slide-subtitle">
             <a:extLst xmlns:a="http://schemas.openxmlformats.org/drawingml/2006/main">
               <a:ext uri="{FF2B5EF4-FFF2-40B4-BE49-F238E27FC236}">
-                <a16:creationId xmlns:a16="http://schemas.microsoft.com/office/drawing/2014/main" id="{D12D3449-1FB1-4135-B3AE-50D879CB0281}"/>
+                <a16:creationId xmlns:a16="http://schemas.microsoft.com/office/drawing/2014/main" id="{7AD4A1EA-38C6-46F4-917B-DE6DFE230F54}"/>
               </a:ext>
             </a:extLst>
           </p:cNvPr>
@@ -1783,7 +1783,7 @@
           <p:cNvPr id="3" name="bullet-0">
             <a:extLst xmlns:a="http://schemas.openxmlformats.org/drawingml/2006/main">
               <a:ext uri="{FF2B5EF4-FFF2-40B4-BE49-F238E27FC236}">
-                <a16:creationId xmlns:a16="http://schemas.microsoft.com/office/drawing/2014/main" id="{D259D593-04AE-4D22-B8CD-97982D9F48DE}"/>
+                <a16:creationId xmlns:a16="http://schemas.microsoft.com/office/drawing/2014/main" id="{690A56A9-9C7A-4371-BA54-B21DF7FAD334}"/>
               </a:ext>
             </a:extLst>
           </p:cNvPr>
@@ -1828,7 +1828,7 @@
           <p:cNvPr id="4" name="bullet-1">
             <a:extLst xmlns:a="http://schemas.openxmlformats.org/drawingml/2006/main">
               <a:ext uri="{FF2B5EF4-FFF2-40B4-BE49-F238E27FC236}">
-                <a16:creationId xmlns:a16="http://schemas.microsoft.com/office/drawing/2014/main" id="{6722DAC3-8B70-44E9-91CB-63E38EC0A422}"/>
+                <a16:creationId xmlns:a16="http://schemas.microsoft.com/office/drawing/2014/main" id="{E4E5A085-F112-4C48-BF81-087405140AAE}"/>
               </a:ext>
             </a:extLst>
           </p:cNvPr>
@@ -1873,7 +1873,7 @@
           <p:cNvPr id="5" name="bullet-2">
             <a:extLst xmlns:a="http://schemas.openxmlformats.org/drawingml/2006/main">
               <a:ext uri="{FF2B5EF4-FFF2-40B4-BE49-F238E27FC236}">
-                <a16:creationId xmlns:a16="http://schemas.microsoft.com/office/drawing/2014/main" id="{18FCBE21-8C28-42ED-9323-D9FB22B7B753}"/>
+                <a16:creationId xmlns:a16="http://schemas.microsoft.com/office/drawing/2014/main" id="{722EF609-F1A0-4F11-9E47-374C68AAD3E5}"/>
               </a:ext>
             </a:extLst>
           </p:cNvPr>
@@ -1918,7 +1918,7 @@
           <p:cNvPr id="6" name="bullet-3">
             <a:extLst xmlns:a="http://schemas.openxmlformats.org/drawingml/2006/main">
               <a:ext uri="{FF2B5EF4-FFF2-40B4-BE49-F238E27FC236}">
-                <a16:creationId xmlns:a16="http://schemas.microsoft.com/office/drawing/2014/main" id="{57D3A22C-54BA-430B-94D8-C49685877DC6}"/>
+                <a16:creationId xmlns:a16="http://schemas.microsoft.com/office/drawing/2014/main" id="{0AB18D15-C05B-43F3-9D5C-AFB98D203D78}"/>
               </a:ext>
             </a:extLst>
           </p:cNvPr>
@@ -1963,7 +1963,7 @@
           <p:cNvPr id="7" name="bullet-0">
             <a:extLst xmlns:a="http://schemas.openxmlformats.org/drawingml/2006/main">
               <a:ext uri="{FF2B5EF4-FFF2-40B4-BE49-F238E27FC236}">
-                <a16:creationId xmlns:a16="http://schemas.microsoft.com/office/drawing/2014/main" id="{7D21B9FF-1173-400C-87E7-F09AD9C38FA4}"/>
+                <a16:creationId xmlns:a16="http://schemas.microsoft.com/office/drawing/2014/main" id="{CF4E15CC-079A-4995-8E36-7AA9D30A2FD7}"/>
               </a:ext>
             </a:extLst>
           </p:cNvPr>
@@ -1998,7 +1998,7 @@
                   <a:srgbClr val="000000"/>
                 </a:solidFill>
               </a:rPr>
-              <a:t>Our MoP layer</a:t>
+              <a:t>Our router layer</a:t>
             </a:r>
           </a:p>
         </p:txBody>
@@ -2008,7 +2008,7 @@
           <p:cNvPr id="8" name="bullet-1">
             <a:extLst xmlns:a="http://schemas.openxmlformats.org/drawingml/2006/main">
               <a:ext uri="{FF2B5EF4-FFF2-40B4-BE49-F238E27FC236}">
-                <a16:creationId xmlns:a16="http://schemas.microsoft.com/office/drawing/2014/main" id="{F3E2172A-8E2A-4659-B352-A45BC8779387}"/>
+                <a16:creationId xmlns:a16="http://schemas.microsoft.com/office/drawing/2014/main" id="{2CBC30CF-8310-44E8-B530-48F3C2EA9005}"/>
               </a:ext>
             </a:extLst>
           </p:cNvPr>
@@ -2043,7 +2043,7 @@
                   <a:srgbClr val="000000"/>
                 </a:solidFill>
               </a:rPr>
-              <a:t>Router aliases V0 through V1.3</a:t>
+              <a:t>MoP-V1.2 manual router</a:t>
             </a:r>
           </a:p>
         </p:txBody>
@@ -2053,7 +2053,7 @@
           <p:cNvPr id="9" name="bullet-2">
             <a:extLst xmlns:a="http://schemas.openxmlformats.org/drawingml/2006/main">
               <a:ext uri="{FF2B5EF4-FFF2-40B4-BE49-F238E27FC236}">
-                <a16:creationId xmlns:a16="http://schemas.microsoft.com/office/drawing/2014/main" id="{FC209193-F756-4B4E-BFD4-AE0C359D2E3A}"/>
+                <a16:creationId xmlns:a16="http://schemas.microsoft.com/office/drawing/2014/main" id="{1ED5938D-A8E6-458C-8F87-AE9234363F9F}"/>
               </a:ext>
             </a:extLst>
           </p:cNvPr>
@@ -2088,7 +2088,7 @@
                   <a:srgbClr val="000000"/>
                 </a:solidFill>
               </a:rPr>
-              <a:t>Epoch action logging</a:t>
+              <a:t>MoP-V1.3 sticky router</a:t>
             </a:r>
           </a:p>
         </p:txBody>
@@ -2098,7 +2098,7 @@
           <p:cNvPr id="10" name="bullet-3">
             <a:extLst xmlns:a="http://schemas.openxmlformats.org/drawingml/2006/main">
               <a:ext uri="{FF2B5EF4-FFF2-40B4-BE49-F238E27FC236}">
-                <a16:creationId xmlns:a16="http://schemas.microsoft.com/office/drawing/2014/main" id="{55A1FCBB-3D2D-4741-BAA6-310DFDF7935A}"/>
+                <a16:creationId xmlns:a16="http://schemas.microsoft.com/office/drawing/2014/main" id="{8046B547-3D99-4980-9F81-88DC9EB67CA1}"/>
               </a:ext>
             </a:extLst>
           </p:cNvPr>
@@ -2133,7 +2133,7 @@
                   <a:srgbClr val="000000"/>
                 </a:solidFill>
               </a:rPr>
-              <a:t>Budget and sticky controls</a:t>
+              <a:t>Epoch counters and budget controls</a:t>
             </a:r>
           </a:p>
         </p:txBody>
@@ -2143,7 +2143,7 @@
           <p:cNvPr id="11" name="bullet-0">
             <a:extLst xmlns:a="http://schemas.openxmlformats.org/drawingml/2006/main">
               <a:ext uri="{FF2B5EF4-FFF2-40B4-BE49-F238E27FC236}">
-                <a16:creationId xmlns:a16="http://schemas.microsoft.com/office/drawing/2014/main" id="{858C6237-3079-4EA8-AEE9-A853006B711E}"/>
+                <a16:creationId xmlns:a16="http://schemas.microsoft.com/office/drawing/2014/main" id="{9A1C7D8A-252E-465D-8958-51F2E01171C5}"/>
               </a:ext>
             </a:extLst>
           </p:cNvPr>
@@ -2188,7 +2188,7 @@
           <p:cNvPr id="12" name="bullet-1">
             <a:extLst xmlns:a="http://schemas.openxmlformats.org/drawingml/2006/main">
               <a:ext uri="{FF2B5EF4-FFF2-40B4-BE49-F238E27FC236}">
-                <a16:creationId xmlns:a16="http://schemas.microsoft.com/office/drawing/2014/main" id="{8EBCC444-1FD5-4764-82D2-F8151F84FFD9}"/>
+                <a16:creationId xmlns:a16="http://schemas.microsoft.com/office/drawing/2014/main" id="{F7F3D0D7-7A6A-4130-97CC-453357C6C530}"/>
               </a:ext>
             </a:extLst>
           </p:cNvPr>
@@ -2223,7 +2223,7 @@
                   <a:srgbClr val="000000"/>
                 </a:solidFill>
               </a:rPr>
-              <a:t>Frozen train/heldout split</a:t>
+              <a:t>17 train traces, 7 heldout traces</a:t>
             </a:r>
           </a:p>
         </p:txBody>
@@ -2233,7 +2233,7 @@
           <p:cNvPr id="13" name="bullet-2">
             <a:extLst xmlns:a="http://schemas.openxmlformats.org/drawingml/2006/main">
               <a:ext uri="{FF2B5EF4-FFF2-40B4-BE49-F238E27FC236}">
-                <a16:creationId xmlns:a16="http://schemas.microsoft.com/office/drawing/2014/main" id="{7DB1B36A-0B4E-4A13-8111-107380124CF9}"/>
+                <a16:creationId xmlns:a16="http://schemas.microsoft.com/office/drawing/2014/main" id="{D93869D6-E4AB-4BAF-A65C-9FBC539D4C34}"/>
               </a:ext>
             </a:extLst>
           </p:cNvPr>
@@ -2278,7 +2278,7 @@
           <p:cNvPr id="14" name="bullet-3">
             <a:extLst xmlns:a="http://schemas.openxmlformats.org/drawingml/2006/main">
               <a:ext uri="{FF2B5EF4-FFF2-40B4-BE49-F238E27FC236}">
-                <a16:creationId xmlns:a16="http://schemas.microsoft.com/office/drawing/2014/main" id="{E93617EC-B7BF-4845-A917-3A77B47436A0}"/>
+                <a16:creationId xmlns:a16="http://schemas.microsoft.com/office/drawing/2014/main" id="{3425DC19-70DB-49D6-8A2A-35ACA910D87F}"/>
               </a:ext>
             </a:extLst>
           </p:cNvPr>
@@ -2313,7 +2313,7 @@
                   <a:srgbClr val="000000"/>
                 </a:solidFill>
               </a:rPr>
-              <a:t>Parser-preserving report assets</a:t>
+              <a:t>Generated tables and figures</a:t>
             </a:r>
           </a:p>
         </p:txBody>
@@ -2321,7 +2321,7 @@
     </p:spTree>
     <p:extLst>
       <p:ext uri="{BB962C8B-B14F-4D97-AF65-F5344CB8AC3E}">
-        <p14:creationId xmlns:p14="http://schemas.microsoft.com/office/powerpoint/2010/main" val="1325640862"/>
+        <p14:creationId xmlns:p14="http://schemas.microsoft.com/office/powerpoint/2010/main" val="2045583822"/>
       </p:ext>
     </p:extLst>
   </p:cSld>
@@ -2345,7 +2345,7 @@
           <p:cNvPr id="1" name="slide-title">
             <a:extLst xmlns:a="http://schemas.openxmlformats.org/drawingml/2006/main">
               <a:ext uri="{FF2B5EF4-FFF2-40B4-BE49-F238E27FC236}">
-                <a16:creationId xmlns:a16="http://schemas.microsoft.com/office/drawing/2014/main" id="{9FD0ED3C-3839-4B60-8498-37FE7D3D35B6}"/>
+                <a16:creationId xmlns:a16="http://schemas.microsoft.com/office/drawing/2014/main" id="{C805CFDF-1FC7-425C-938A-955C9412A932}"/>
               </a:ext>
             </a:extLst>
           </p:cNvPr>
@@ -2380,7 +2380,7 @@
                   <a:srgbClr val="000000"/>
                 </a:solidFill>
               </a:rPr>
-              <a:t>Protocol: pair-best first, no-prefetch second</a:t>
+              <a:t>Protocol: disabled prefetching is 1x</a:t>
             </a:r>
           </a:p>
         </p:txBody>
@@ -2390,7 +2390,7 @@
           <p:cNvPr id="2" name="title-rule">
             <a:extLst xmlns:a="http://schemas.openxmlformats.org/drawingml/2006/main">
               <a:ext uri="{FF2B5EF4-FFF2-40B4-BE49-F238E27FC236}">
-                <a16:creationId xmlns:a16="http://schemas.microsoft.com/office/drawing/2014/main" id="{25EAC628-50AC-42C6-9357-1E30D6728A22}"/>
+                <a16:creationId xmlns:a16="http://schemas.microsoft.com/office/drawing/2014/main" id="{F642F3EC-0662-4850-91E9-ED876BDC927D}"/>
               </a:ext>
             </a:extLst>
           </p:cNvPr>
@@ -2423,7 +2423,7 @@
           <p:cNvPr id="3" name="bullet-0">
             <a:extLst xmlns:a="http://schemas.openxmlformats.org/drawingml/2006/main">
               <a:ext uri="{FF2B5EF4-FFF2-40B4-BE49-F238E27FC236}">
-                <a16:creationId xmlns:a16="http://schemas.microsoft.com/office/drawing/2014/main" id="{223FB2E0-2641-430C-81CA-7E8558DDFF3F}"/>
+                <a16:creationId xmlns:a16="http://schemas.microsoft.com/office/drawing/2014/main" id="{BC69E0DA-078E-4D99-8D45-3CF9F4382883}"/>
               </a:ext>
             </a:extLst>
           </p:cNvPr>
@@ -2468,7 +2468,7 @@
           <p:cNvPr id="4" name="bullet-1">
             <a:extLst xmlns:a="http://schemas.openxmlformats.org/drawingml/2006/main">
               <a:ext uri="{FF2B5EF4-FFF2-40B4-BE49-F238E27FC236}">
-                <a16:creationId xmlns:a16="http://schemas.microsoft.com/office/drawing/2014/main" id="{4C97958E-9778-4BAD-A174-140C2502A46A}"/>
+                <a16:creationId xmlns:a16="http://schemas.microsoft.com/office/drawing/2014/main" id="{002E7275-6F6E-49CC-9F3D-5EB43AB718C3}"/>
               </a:ext>
             </a:extLst>
           </p:cNvPr>
@@ -2513,7 +2513,7 @@
           <p:cNvPr id="5" name="bullet-2">
             <a:extLst xmlns:a="http://schemas.openxmlformats.org/drawingml/2006/main">
               <a:ext uri="{FF2B5EF4-FFF2-40B4-BE49-F238E27FC236}">
-                <a16:creationId xmlns:a16="http://schemas.microsoft.com/office/drawing/2014/main" id="{255B7AEE-2CCF-4602-A3E8-53EDF14D2440}"/>
+                <a16:creationId xmlns:a16="http://schemas.microsoft.com/office/drawing/2014/main" id="{F7229593-CAE6-4DC5-AFFC-D4E097BD0E75}"/>
               </a:ext>
             </a:extLst>
           </p:cNvPr>
@@ -2548,7 +2548,7 @@
                   <a:srgbClr val="000000"/>
                 </a:solidFill>
               </a:rPr>
-              <a:t>17 train traces</a:t>
+              <a:t>Search: 10 training traces</a:t>
             </a:r>
           </a:p>
         </p:txBody>
@@ -2558,7 +2558,7 @@
           <p:cNvPr id="6" name="bullet-3">
             <a:extLst xmlns:a="http://schemas.openxmlformats.org/drawingml/2006/main">
               <a:ext uri="{FF2B5EF4-FFF2-40B4-BE49-F238E27FC236}">
-                <a16:creationId xmlns:a16="http://schemas.microsoft.com/office/drawing/2014/main" id="{EF8F71BB-1A61-4FBF-A747-B6140EC57789}"/>
+                <a16:creationId xmlns:a16="http://schemas.microsoft.com/office/drawing/2014/main" id="{EFF88650-7CD6-4F51-A706-3768507A59AC}"/>
               </a:ext>
             </a:extLst>
           </p:cNvPr>
@@ -2593,7 +2593,7 @@
                   <a:srgbClr val="000000"/>
                 </a:solidFill>
               </a:rPr>
-              <a:t>7 heldout traces</a:t>
+              <a:t>Training validation: 13 traces</a:t>
             </a:r>
           </a:p>
         </p:txBody>
@@ -2603,7 +2603,7 @@
           <p:cNvPr id="7" name="bullet-4">
             <a:extLst xmlns:a="http://schemas.openxmlformats.org/drawingml/2006/main">
               <a:ext uri="{FF2B5EF4-FFF2-40B4-BE49-F238E27FC236}">
-                <a16:creationId xmlns:a16="http://schemas.microsoft.com/office/drawing/2014/main" id="{D9FE6660-96E7-4278-B9B0-5C2C984BDEBE}"/>
+                <a16:creationId xmlns:a16="http://schemas.microsoft.com/office/drawing/2014/main" id="{1859336B-06CF-47C9-A121-52992E0F9DDE}"/>
               </a:ext>
             </a:extLst>
           </p:cNvPr>
@@ -2638,7 +2638,7 @@
                   <a:srgbClr val="000000"/>
                 </a:solidFill>
               </a:rPr>
-              <a:t>Heldout used after selection freeze</a:t>
+              <a:t>Heldout: 7 traces after policy selection</a:t>
             </a:r>
           </a:p>
         </p:txBody>
@@ -2648,7 +2648,7 @@
           <p:cNvPr id="8" name="bullet-0">
             <a:extLst xmlns:a="http://schemas.openxmlformats.org/drawingml/2006/main">
               <a:ext uri="{FF2B5EF4-FFF2-40B4-BE49-F238E27FC236}">
-                <a16:creationId xmlns:a16="http://schemas.microsoft.com/office/drawing/2014/main" id="{48014A44-C117-4A71-A281-7498FFCA8EEA}"/>
+                <a16:creationId xmlns:a16="http://schemas.microsoft.com/office/drawing/2014/main" id="{01D40BB8-3E6C-4DBF-B8FA-ABFCD025B4BE}"/>
               </a:ext>
             </a:extLst>
           </p:cNvPr>
@@ -2683,7 +2683,7 @@
                   <a:srgbClr val="000000"/>
                 </a:solidFill>
               </a:rPr>
-              <a:t>Primary comparator: pair-best single</a:t>
+              <a:t>Performance baseline: disabled prefetching</a:t>
             </a:r>
           </a:p>
         </p:txBody>
@@ -2693,7 +2693,7 @@
           <p:cNvPr id="9" name="bullet-1">
             <a:extLst xmlns:a="http://schemas.openxmlformats.org/drawingml/2006/main">
               <a:ext uri="{FF2B5EF4-FFF2-40B4-BE49-F238E27FC236}">
-                <a16:creationId xmlns:a16="http://schemas.microsoft.com/office/drawing/2014/main" id="{042533C8-0304-4599-A288-5A1FE1E7179D}"/>
+                <a16:creationId xmlns:a16="http://schemas.microsoft.com/office/drawing/2014/main" id="{6398165E-77AF-4938-A0B8-A9EE26C3AAB0}"/>
               </a:ext>
             </a:extLst>
           </p:cNvPr>
@@ -2728,7 +2728,7 @@
                   <a:srgbClr val="000000"/>
                 </a:solidFill>
               </a:rPr>
-              <a:t>Secondary comparator: no-prefetch</a:t>
+              <a:t>Oracle cap: max(MLOP, SPP+PPF) per trace</a:t>
             </a:r>
           </a:p>
         </p:txBody>
@@ -2738,7 +2738,7 @@
           <p:cNvPr id="10" name="bullet-2">
             <a:extLst xmlns:a="http://schemas.openxmlformats.org/drawingml/2006/main">
               <a:ext uri="{FF2B5EF4-FFF2-40B4-BE49-F238E27FC236}">
-                <a16:creationId xmlns:a16="http://schemas.microsoft.com/office/drawing/2014/main" id="{FC20D685-6F2B-47F1-9018-4F43C7B38BC2}"/>
+                <a16:creationId xmlns:a16="http://schemas.microsoft.com/office/drawing/2014/main" id="{5BB26571-F24C-4EA1-8CE8-D75ACA60B620}"/>
               </a:ext>
             </a:extLst>
           </p:cNvPr>
@@ -2773,7 +2773,7 @@
                   <a:srgbClr val="000000"/>
                 </a:solidFill>
               </a:rPr>
-              <a:t>Practical floor: weaker expert</a:t>
+              <a:t>Minimum check: beat the worse prefetcher</a:t>
             </a:r>
           </a:p>
         </p:txBody>
@@ -2783,7 +2783,7 @@
           <p:cNvPr id="11" name="bullet-3">
             <a:extLst xmlns:a="http://schemas.openxmlformats.org/drawingml/2006/main">
               <a:ext uri="{FF2B5EF4-FFF2-40B4-BE49-F238E27FC236}">
-                <a16:creationId xmlns:a16="http://schemas.microsoft.com/office/drawing/2014/main" id="{354B3A50-6A37-4CF8-B9B3-B798D78B5C2F}"/>
+                <a16:creationId xmlns:a16="http://schemas.microsoft.com/office/drawing/2014/main" id="{F8FDF17B-CE5A-4644-8594-C74B52C6EE21}"/>
               </a:ext>
             </a:extLst>
           </p:cNvPr>
@@ -2818,7 +2818,7 @@
                   <a:srgbClr val="000000"/>
                 </a:solidFill>
               </a:rPr>
-              <a:t>Simple coordinators: WinnerTakeAll, OneShotFit, AthenaMAB</a:t>
+              <a:t>Simple routers: WinnerTakeAll, OneShotFit, AthenaMAB</a:t>
             </a:r>
           </a:p>
         </p:txBody>
@@ -2828,7 +2828,7 @@
           <p:cNvPr id="12" name="protocol-footer">
             <a:extLst xmlns:a="http://schemas.openxmlformats.org/drawingml/2006/main">
               <a:ext uri="{FF2B5EF4-FFF2-40B4-BE49-F238E27FC236}">
-                <a16:creationId xmlns:a16="http://schemas.microsoft.com/office/drawing/2014/main" id="{5E529179-81D8-4172-84B8-083387BF3AFD}"/>
+                <a16:creationId xmlns:a16="http://schemas.microsoft.com/office/drawing/2014/main" id="{5E05F74C-FEAD-4C52-9F69-26726F81DF60}"/>
               </a:ext>
             </a:extLst>
           </p:cNvPr>
@@ -2863,7 +2863,7 @@
                   <a:srgbClr val="000000"/>
                 </a:solidFill>
               </a:rPr>
-              <a:t>Selection used train/search surfaces. Heldout appears only after the seed is fixed.</a:t>
+              <a:t>Quick evaluation used 3 training traces. Wider validation used 10 training traces. Heldout runs after policy selection.</a:t>
             </a:r>
           </a:p>
         </p:txBody>
@@ -2871,7 +2871,7 @@
     </p:spTree>
     <p:extLst>
       <p:ext uri="{BB962C8B-B14F-4D97-AF65-F5344CB8AC3E}">
-        <p14:creationId xmlns:p14="http://schemas.microsoft.com/office/powerpoint/2010/main" val="237605026"/>
+        <p14:creationId xmlns:p14="http://schemas.microsoft.com/office/powerpoint/2010/main" val="434929475"/>
       </p:ext>
     </p:extLst>
   </p:cSld>
@@ -2895,7 +2895,7 @@
           <p:cNvPr id="1" name="slide-title">
             <a:extLst xmlns:a="http://schemas.openxmlformats.org/drawingml/2006/main">
               <a:ext uri="{FF2B5EF4-FFF2-40B4-BE49-F238E27FC236}">
-                <a16:creationId xmlns:a16="http://schemas.microsoft.com/office/drawing/2014/main" id="{53879717-2C1A-4B17-85D2-E5829F68CB42}"/>
+                <a16:creationId xmlns:a16="http://schemas.microsoft.com/office/drawing/2014/main" id="{CA9F5598-BF5E-4E5B-BC93-5C158C26C853}"/>
               </a:ext>
             </a:extLst>
           </p:cNvPr>
@@ -2930,7 +2930,7 @@
                   <a:srgbClr val="000000"/>
                 </a:solidFill>
               </a:rPr>
-              <a:t>OpenEvolve improved the train-window router</a:t>
+              <a:t>OpenEvolve improved the router</a:t>
             </a:r>
           </a:p>
         </p:txBody>
@@ -2940,7 +2940,7 @@
           <p:cNvPr id="2" name="slide-subtitle">
             <a:extLst xmlns:a="http://schemas.openxmlformats.org/drawingml/2006/main">
               <a:ext uri="{FF2B5EF4-FFF2-40B4-BE49-F238E27FC236}">
-                <a16:creationId xmlns:a16="http://schemas.microsoft.com/office/drawing/2014/main" id="{A1184FF6-EEB2-4548-837F-65E181AA23F1}"/>
+                <a16:creationId xmlns:a16="http://schemas.microsoft.com/office/drawing/2014/main" id="{F86A1024-A6F8-4094-B3D7-BED3AB8345F6}"/>
               </a:ext>
             </a:extLst>
           </p:cNvPr>
@@ -2975,7 +2975,7 @@
                   <a:srgbClr val="000000"/>
                 </a:solidFill>
               </a:rPr>
-              <a:t>MoP-V1.3 improves both train-window comparators, then shows a smaller heldout lift.</a:t>
+              <a:t>Bars use disabled prefetching as 1x. Black caps show the per-trace oracle best prefetcher.</a:t>
             </a:r>
           </a:p>
         </p:txBody>
@@ -2989,13 +2989,13 @@
           <p:nvPr/>
         </p:nvPicPr>
         <p:blipFill>
-          <a:blip xmlns:r="http://schemas.openxmlformats.org/officeDocument/2006/relationships" xmlns:a="http://schemas.openxmlformats.org/drawingml/2006/main" r:embed="R3a101acb160b4b5a"/>
+          <a:blip xmlns:r="http://schemas.openxmlformats.org/officeDocument/2006/relationships" xmlns:a="http://schemas.openxmlformats.org/drawingml/2006/main" r:embed="Rb3e3ff7ec0fe4cf0"/>
           <a:stretch xmlns:a="http://schemas.openxmlformats.org/drawingml/2006/main"/>
         </p:blipFill>
         <p:spPr>
           <a:xfrm xmlns:a="http://schemas.openxmlformats.org/drawingml/2006/main">
-            <a:off x="666750" y="2002155"/>
-            <a:ext cx="16954500" cy="7459980"/>
+            <a:off x="765969" y="1710690"/>
+            <a:ext cx="16756063" cy="8042910"/>
           </a:xfrm>
           <a:prstGeom xmlns:a="http://schemas.openxmlformats.org/drawingml/2006/main" prst="rect">
             <a:avLst/>
@@ -3005,7 +3005,7 @@
     </p:spTree>
     <p:extLst>
       <p:ext uri="{BB962C8B-B14F-4D97-AF65-F5344CB8AC3E}">
-        <p14:creationId xmlns:p14="http://schemas.microsoft.com/office/powerpoint/2010/main" val="999501044"/>
+        <p14:creationId xmlns:p14="http://schemas.microsoft.com/office/powerpoint/2010/main" val="1290538841"/>
       </p:ext>
     </p:extLst>
   </p:cSld>
@@ -3029,7 +3029,7 @@
           <p:cNvPr id="1" name="slide-title">
             <a:extLst xmlns:a="http://schemas.openxmlformats.org/drawingml/2006/main">
               <a:ext uri="{FF2B5EF4-FFF2-40B4-BE49-F238E27FC236}">
-                <a16:creationId xmlns:a16="http://schemas.microsoft.com/office/drawing/2014/main" id="{EA5CA4FA-E8EB-4FCA-8101-7A6296B9E601}"/>
+                <a16:creationId xmlns:a16="http://schemas.microsoft.com/office/drawing/2014/main" id="{D9525116-0EB7-47EB-8D30-F0CC4D1458E7}"/>
               </a:ext>
             </a:extLst>
           </p:cNvPr>
@@ -3074,7 +3074,7 @@
           <p:cNvPr id="2" name="slide-subtitle">
             <a:extLst xmlns:a="http://schemas.openxmlformats.org/drawingml/2006/main">
               <a:ext uri="{FF2B5EF4-FFF2-40B4-BE49-F238E27FC236}">
-                <a16:creationId xmlns:a16="http://schemas.microsoft.com/office/drawing/2014/main" id="{CCD03C7D-CC85-4455-B3F3-46373D043E4C}"/>
+                <a16:creationId xmlns:a16="http://schemas.microsoft.com/office/drawing/2014/main" id="{2487093B-9423-42D9-AC99-8F4B9C83CA42}"/>
               </a:ext>
             </a:extLst>
           </p:cNvPr>
@@ -3109,7 +3109,7 @@
                   <a:srgbClr val="000000"/>
                 </a:solidFill>
               </a:rPr>
-              <a:t>Heldout clears no-prefetch by geomean, while trace-level placement shows why pair-best remains the upper bar.</a:t>
+              <a:t>Each trace uses disabled prefetching as 1x, with the oracle cap marked separately.</a:t>
             </a:r>
           </a:p>
         </p:txBody>
@@ -3123,7 +3123,7 @@
           <p:nvPr/>
         </p:nvPicPr>
         <p:blipFill>
-          <a:blip xmlns:r="http://schemas.openxmlformats.org/officeDocument/2006/relationships" xmlns:a="http://schemas.openxmlformats.org/drawingml/2006/main" r:embed="R4d86b48ca0cd4722"/>
+          <a:blip xmlns:r="http://schemas.openxmlformats.org/officeDocument/2006/relationships" xmlns:a="http://schemas.openxmlformats.org/drawingml/2006/main" r:embed="R5e8f6bdca19c416b"/>
           <a:stretch xmlns:a="http://schemas.openxmlformats.org/drawingml/2006/main"/>
         </p:blipFill>
         <p:spPr>
@@ -3139,7 +3139,7 @@
     </p:spTree>
     <p:extLst>
       <p:ext uri="{BB962C8B-B14F-4D97-AF65-F5344CB8AC3E}">
-        <p14:creationId xmlns:p14="http://schemas.microsoft.com/office/powerpoint/2010/main" val="1382187727"/>
+        <p14:creationId xmlns:p14="http://schemas.microsoft.com/office/powerpoint/2010/main" val="2002574659"/>
       </p:ext>
     </p:extLst>
   </p:cSld>
@@ -3163,7 +3163,7 @@
           <p:cNvPr id="1" name="slide-title">
             <a:extLst xmlns:a="http://schemas.openxmlformats.org/drawingml/2006/main">
               <a:ext uri="{FF2B5EF4-FFF2-40B4-BE49-F238E27FC236}">
-                <a16:creationId xmlns:a16="http://schemas.microsoft.com/office/drawing/2014/main" id="{01624A67-BEF8-494E-B9EC-723B75D8852C}"/>
+                <a16:creationId xmlns:a16="http://schemas.microsoft.com/office/drawing/2014/main" id="{E8214986-D9E4-4EA0-9632-9F422B2145A0}"/>
               </a:ext>
             </a:extLst>
           </p:cNvPr>
@@ -3198,7 +3198,7 @@
                   <a:srgbClr val="000000"/>
                 </a:solidFill>
               </a:rPr>
-              <a:t>Model sweeps improved screens, confirmation kept the seed</a:t>
+              <a:t>OpenEvolve search trajectory</a:t>
             </a:r>
           </a:p>
         </p:txBody>
@@ -3208,7 +3208,7 @@
           <p:cNvPr id="2" name="slide-subtitle">
             <a:extLst xmlns:a="http://schemas.openxmlformats.org/drawingml/2006/main">
               <a:ext uri="{FF2B5EF4-FFF2-40B4-BE49-F238E27FC236}">
-                <a16:creationId xmlns:a16="http://schemas.microsoft.com/office/drawing/2014/main" id="{5537EC2E-9125-4CBF-A90A-1586C6ABFDCB}"/>
+                <a16:creationId xmlns:a16="http://schemas.microsoft.com/office/drawing/2014/main" id="{B9D6594B-389F-4B1E-B17A-B07873FCB226}"/>
               </a:ext>
             </a:extLst>
           </p:cNvPr>
@@ -3243,7 +3243,7 @@
                   <a:srgbClr val="000000"/>
                 </a:solidFill>
               </a:rPr>
-              <a:t>Scaled search found similar cheap-screen candidates, then 10-trace confirmation preserved the active seed at 0.9801x.</a:t>
+              <a:t>Faint points are valid generated candidates. Lines show best-so-far by weighted score.</a:t>
             </a:r>
           </a:p>
         </p:txBody>
@@ -3257,13 +3257,13 @@
           <p:nvPr/>
         </p:nvPicPr>
         <p:blipFill>
-          <a:blip xmlns:r="http://schemas.openxmlformats.org/officeDocument/2006/relationships" xmlns:a="http://schemas.openxmlformats.org/drawingml/2006/main" r:embed="R7dfa601f35ad4636"/>
+          <a:blip xmlns:r="http://schemas.openxmlformats.org/officeDocument/2006/relationships" xmlns:a="http://schemas.openxmlformats.org/drawingml/2006/main" r:embed="Rf59bf4a53a634669"/>
           <a:stretch xmlns:a="http://schemas.openxmlformats.org/drawingml/2006/main"/>
         </p:blipFill>
         <p:spPr>
           <a:xfrm xmlns:a="http://schemas.openxmlformats.org/drawingml/2006/main">
-            <a:off x="666750" y="2495377"/>
-            <a:ext cx="16954500" cy="6473536"/>
+            <a:off x="666750" y="2277195"/>
+            <a:ext cx="16954500" cy="6909901"/>
           </a:xfrm>
           <a:prstGeom xmlns:a="http://schemas.openxmlformats.org/drawingml/2006/main" prst="rect">
             <a:avLst/>
@@ -3273,7 +3273,7 @@
     </p:spTree>
     <p:extLst>
       <p:ext uri="{BB962C8B-B14F-4D97-AF65-F5344CB8AC3E}">
-        <p14:creationId xmlns:p14="http://schemas.microsoft.com/office/powerpoint/2010/main" val="1991084861"/>
+        <p14:creationId xmlns:p14="http://schemas.microsoft.com/office/powerpoint/2010/main" val="372933722"/>
       </p:ext>
     </p:extLst>
   </p:cSld>
@@ -3297,7 +3297,7 @@
           <p:cNvPr id="1" name="slide-title">
             <a:extLst xmlns:a="http://schemas.openxmlformats.org/drawingml/2006/main">
               <a:ext uri="{FF2B5EF4-FFF2-40B4-BE49-F238E27FC236}">
-                <a16:creationId xmlns:a16="http://schemas.microsoft.com/office/drawing/2014/main" id="{059BE67E-57A7-4620-868F-1B02B9113AAA}"/>
+                <a16:creationId xmlns:a16="http://schemas.microsoft.com/office/drawing/2014/main" id="{323C2E3C-1C90-4764-88B0-5CCD504D310B}"/>
               </a:ext>
             </a:extLst>
           </p:cNvPr>
@@ -3342,7 +3342,7 @@
           <p:cNvPr id="2" name="slide-subtitle">
             <a:extLst xmlns:a="http://schemas.openxmlformats.org/drawingml/2006/main">
               <a:ext uri="{FF2B5EF4-FFF2-40B4-BE49-F238E27FC236}">
-                <a16:creationId xmlns:a16="http://schemas.microsoft.com/office/drawing/2014/main" id="{200D3706-0A33-440F-9394-C91B91BB1F82}"/>
+                <a16:creationId xmlns:a16="http://schemas.microsoft.com/office/drawing/2014/main" id="{D64FB2E2-A48D-405B-B2B7-D1844D10A54A}"/>
               </a:ext>
             </a:extLst>
           </p:cNvPr>
@@ -3377,7 +3377,7 @@
                   <a:srgbClr val="000000"/>
                 </a:solidFill>
               </a:rPr>
-              <a:t>Candidate programs were allowed to change only a literal policy dictionary.</a:t>
+              <a:t>Candidate programs changed a literal policy dictionary.</a:t>
             </a:r>
           </a:p>
         </p:txBody>
@@ -3387,7 +3387,7 @@
           <p:cNvPr id="3" name="bullet-0">
             <a:extLst xmlns:a="http://schemas.openxmlformats.org/drawingml/2006/main">
               <a:ext uri="{FF2B5EF4-FFF2-40B4-BE49-F238E27FC236}">
-                <a16:creationId xmlns:a16="http://schemas.microsoft.com/office/drawing/2014/main" id="{B837558C-FF5B-4EF8-B790-2474E9AF50C7}"/>
+                <a16:creationId xmlns:a16="http://schemas.microsoft.com/office/drawing/2014/main" id="{DF56953A-0BBE-484A-8CBE-188E85E755B4}"/>
               </a:ext>
             </a:extLst>
           </p:cNvPr>
@@ -3432,7 +3432,7 @@
           <p:cNvPr id="4" name="bullet-1">
             <a:extLst xmlns:a="http://schemas.openxmlformats.org/drawingml/2006/main">
               <a:ext uri="{FF2B5EF4-FFF2-40B4-BE49-F238E27FC236}">
-                <a16:creationId xmlns:a16="http://schemas.microsoft.com/office/drawing/2014/main" id="{39E537AF-0074-4138-BF39-E879E635D163}"/>
+                <a16:creationId xmlns:a16="http://schemas.microsoft.com/office/drawing/2014/main" id="{B19A5BBC-E264-4823-8848-F1ACE251DDA0}"/>
               </a:ext>
             </a:extLst>
           </p:cNvPr>
@@ -3477,7 +3477,7 @@
           <p:cNvPr id="5" name="bullet-2">
             <a:extLst xmlns:a="http://schemas.openxmlformats.org/drawingml/2006/main">
               <a:ext uri="{FF2B5EF4-FFF2-40B4-BE49-F238E27FC236}">
-                <a16:creationId xmlns:a16="http://schemas.microsoft.com/office/drawing/2014/main" id="{4D1CC32D-FD95-4991-AA8C-26F342436A56}"/>
+                <a16:creationId xmlns:a16="http://schemas.microsoft.com/office/drawing/2014/main" id="{96FA1477-47B0-4E1E-8B54-BDFD1E771AD8}"/>
               </a:ext>
             </a:extLst>
           </p:cNvPr>
@@ -3522,7 +3522,7 @@
           <p:cNvPr id="6" name="bullet-3">
             <a:extLst xmlns:a="http://schemas.openxmlformats.org/drawingml/2006/main">
               <a:ext uri="{FF2B5EF4-FFF2-40B4-BE49-F238E27FC236}">
-                <a16:creationId xmlns:a16="http://schemas.microsoft.com/office/drawing/2014/main" id="{6202887A-13A8-4604-9636-338429E0E913}"/>
+                <a16:creationId xmlns:a16="http://schemas.microsoft.com/office/drawing/2014/main" id="{59D4CED5-2218-4964-AD26-F545792674CC}"/>
               </a:ext>
             </a:extLst>
           </p:cNvPr>
@@ -3567,7 +3567,7 @@
           <p:cNvPr id="7" name="bullet-4">
             <a:extLst xmlns:a="http://schemas.openxmlformats.org/drawingml/2006/main">
               <a:ext uri="{FF2B5EF4-FFF2-40B4-BE49-F238E27FC236}">
-                <a16:creationId xmlns:a16="http://schemas.microsoft.com/office/drawing/2014/main" id="{4744D77D-AE0D-4D78-BE8A-D7F047E072A4}"/>
+                <a16:creationId xmlns:a16="http://schemas.microsoft.com/office/drawing/2014/main" id="{4A9D07BF-FC84-4416-9B87-04F82C0CCAD9}"/>
               </a:ext>
             </a:extLst>
           </p:cNvPr>
@@ -3612,7 +3612,7 @@
           <p:cNvPr id="8" name="bullet-0">
             <a:extLst xmlns:a="http://schemas.openxmlformats.org/drawingml/2006/main">
               <a:ext uri="{FF2B5EF4-FFF2-40B4-BE49-F238E27FC236}">
-                <a16:creationId xmlns:a16="http://schemas.microsoft.com/office/drawing/2014/main" id="{8663253C-D99F-459A-952A-3370B59C9FAB}"/>
+                <a16:creationId xmlns:a16="http://schemas.microsoft.com/office/drawing/2014/main" id="{6F28B9DA-85B0-4247-A0EC-C4BDAE4423BD}"/>
               </a:ext>
             </a:extLst>
           </p:cNvPr>
@@ -3657,7 +3657,7 @@
           <p:cNvPr id="9" name="bullet-1">
             <a:extLst xmlns:a="http://schemas.openxmlformats.org/drawingml/2006/main">
               <a:ext uri="{FF2B5EF4-FFF2-40B4-BE49-F238E27FC236}">
-                <a16:creationId xmlns:a16="http://schemas.microsoft.com/office/drawing/2014/main" id="{5656CA13-A510-4D57-8C68-8E7CB9630370}"/>
+                <a16:creationId xmlns:a16="http://schemas.microsoft.com/office/drawing/2014/main" id="{65A09F95-931F-4014-9DEE-F46C9679A0FC}"/>
               </a:ext>
             </a:extLst>
           </p:cNvPr>
@@ -3692,7 +3692,7 @@
                   <a:srgbClr val="000000"/>
                 </a:solidFill>
               </a:rPr>
-              <a:t>Simulator SIGBUS rows</a:t>
+              <a:t>Simulator failures</a:t>
             </a:r>
           </a:p>
         </p:txBody>
@@ -3702,7 +3702,7 @@
           <p:cNvPr id="10" name="bullet-2">
             <a:extLst xmlns:a="http://schemas.openxmlformats.org/drawingml/2006/main">
               <a:ext uri="{FF2B5EF4-FFF2-40B4-BE49-F238E27FC236}">
-                <a16:creationId xmlns:a16="http://schemas.microsoft.com/office/drawing/2014/main" id="{3423E923-E3FA-4D62-BBB5-C3F66D3D6D33}"/>
+                <a16:creationId xmlns:a16="http://schemas.microsoft.com/office/drawing/2014/main" id="{A81928B6-E080-410F-8874-9F28A87C2D3B}"/>
               </a:ext>
             </a:extLst>
           </p:cNvPr>
@@ -3747,7 +3747,7 @@
           <p:cNvPr id="11" name="bullet-3">
             <a:extLst xmlns:a="http://schemas.openxmlformats.org/drawingml/2006/main">
               <a:ext uri="{FF2B5EF4-FFF2-40B4-BE49-F238E27FC236}">
-                <a16:creationId xmlns:a16="http://schemas.microsoft.com/office/drawing/2014/main" id="{88822A33-1164-43AB-8753-50F9CC8D13C2}"/>
+                <a16:creationId xmlns:a16="http://schemas.microsoft.com/office/drawing/2014/main" id="{B8C4D755-3C14-450F-B4AC-98322BC2F0F4}"/>
               </a:ext>
             </a:extLst>
           </p:cNvPr>
@@ -3792,7 +3792,7 @@
           <p:cNvPr id="12" name="bullet-4">
             <a:extLst xmlns:a="http://schemas.openxmlformats.org/drawingml/2006/main">
               <a:ext uri="{FF2B5EF4-FFF2-40B4-BE49-F238E27FC236}">
-                <a16:creationId xmlns:a16="http://schemas.microsoft.com/office/drawing/2014/main" id="{410C9636-3CC2-4763-8CBC-04323CA10BC0}"/>
+                <a16:creationId xmlns:a16="http://schemas.microsoft.com/office/drawing/2014/main" id="{FFC7CD12-8F3F-4B56-81D8-FD5026CF9939}"/>
               </a:ext>
             </a:extLst>
           </p:cNvPr>
@@ -3837,7 +3837,7 @@
           <p:cNvPr id="13" name="audit-footer">
             <a:extLst xmlns:a="http://schemas.openxmlformats.org/drawingml/2006/main">
               <a:ext uri="{FF2B5EF4-FFF2-40B4-BE49-F238E27FC236}">
-                <a16:creationId xmlns:a16="http://schemas.microsoft.com/office/drawing/2014/main" id="{23562AB2-8337-4EC3-9C84-843878EC37B0}"/>
+                <a16:creationId xmlns:a16="http://schemas.microsoft.com/office/drawing/2014/main" id="{EDF40885-3530-45B3-8528-367CFA75994A}"/>
               </a:ext>
             </a:extLst>
           </p:cNvPr>
@@ -3880,7 +3880,7 @@
     </p:spTree>
     <p:extLst>
       <p:ext uri="{BB962C8B-B14F-4D97-AF65-F5344CB8AC3E}">
-        <p14:creationId xmlns:p14="http://schemas.microsoft.com/office/powerpoint/2010/main" val="1720311171"/>
+        <p14:creationId xmlns:p14="http://schemas.microsoft.com/office/powerpoint/2010/main" val="1974124328"/>
       </p:ext>
     </p:extLst>
   </p:cSld>
@@ -3904,7 +3904,7 @@
           <p:cNvPr id="1" name="slide-title">
             <a:extLst xmlns:a="http://schemas.openxmlformats.org/drawingml/2006/main">
               <a:ext uri="{FF2B5EF4-FFF2-40B4-BE49-F238E27FC236}">
-                <a16:creationId xmlns:a16="http://schemas.microsoft.com/office/drawing/2014/main" id="{E9007733-2C31-4541-8E03-95D1EF891B39}"/>
+                <a16:creationId xmlns:a16="http://schemas.microsoft.com/office/drawing/2014/main" id="{19259C1E-A69E-4274-A302-5F2B359F9DC5}"/>
               </a:ext>
             </a:extLst>
           </p:cNvPr>
@@ -3949,7 +3949,7 @@
           <p:cNvPr id="2" name="title-rule">
             <a:extLst xmlns:a="http://schemas.openxmlformats.org/drawingml/2006/main">
               <a:ext uri="{FF2B5EF4-FFF2-40B4-BE49-F238E27FC236}">
-                <a16:creationId xmlns:a16="http://schemas.microsoft.com/office/drawing/2014/main" id="{D9CA3DA7-0301-400E-8C4F-DD70F896FE88}"/>
+                <a16:creationId xmlns:a16="http://schemas.microsoft.com/office/drawing/2014/main" id="{6E04370D-F7D2-40C2-80B1-B99CFA7E3E06}"/>
               </a:ext>
             </a:extLst>
           </p:cNvPr>
@@ -3982,7 +3982,7 @@
           <p:cNvPr id="3" name="bullet-0">
             <a:extLst xmlns:a="http://schemas.openxmlformats.org/drawingml/2006/main">
               <a:ext uri="{FF2B5EF4-FFF2-40B4-BE49-F238E27FC236}">
-                <a16:creationId xmlns:a16="http://schemas.microsoft.com/office/drawing/2014/main" id="{DA335108-832B-4E51-8C38-7C8781D03CD5}"/>
+                <a16:creationId xmlns:a16="http://schemas.microsoft.com/office/drawing/2014/main" id="{E711528A-4243-4C4B-A49F-D4691157637E}"/>
               </a:ext>
             </a:extLst>
           </p:cNvPr>
@@ -4017,7 +4017,7 @@
                   <a:srgbClr val="000000"/>
                 </a:solidFill>
               </a:rPr>
-              <a:t>Primary defended claim: Stage 2 closes the train-window gap against pair-best single.</a:t>
+              <a:t>Primary claim: OpenEvolve improves IPC speedup over disabled prefetching on 13 training-validation traces.</a:t>
             </a:r>
           </a:p>
         </p:txBody>
@@ -4027,7 +4027,7 @@
           <p:cNvPr id="4" name="bullet-1">
             <a:extLst xmlns:a="http://schemas.openxmlformats.org/drawingml/2006/main">
               <a:ext uri="{FF2B5EF4-FFF2-40B4-BE49-F238E27FC236}">
-                <a16:creationId xmlns:a16="http://schemas.microsoft.com/office/drawing/2014/main" id="{94C8C1AF-001D-4B4B-96B7-EC42C17ABFDD}"/>
+                <a16:creationId xmlns:a16="http://schemas.microsoft.com/office/drawing/2014/main" id="{82979D49-91FF-4385-8686-F429738594B0}"/>
               </a:ext>
             </a:extLst>
           </p:cNvPr>
@@ -4062,7 +4062,7 @@
                   <a:srgbClr val="000000"/>
                 </a:solidFill>
               </a:rPr>
-              <a:t>Heldout claim: the selected router clears no-prefetch in geomean.</a:t>
+              <a:t>Heldout claim: the selected router reaches 1.0033x over disabled prefetching on seven heldout traces.</a:t>
             </a:r>
           </a:p>
         </p:txBody>
@@ -4072,7 +4072,7 @@
           <p:cNvPr id="5" name="bullet-2">
             <a:extLst xmlns:a="http://schemas.openxmlformats.org/drawingml/2006/main">
               <a:ext uri="{FF2B5EF4-FFF2-40B4-BE49-F238E27FC236}">
-                <a16:creationId xmlns:a16="http://schemas.microsoft.com/office/drawing/2014/main" id="{675C358D-ADD1-49DE-B215-28292D7FE3E9}"/>
+                <a16:creationId xmlns:a16="http://schemas.microsoft.com/office/drawing/2014/main" id="{3AB83AD8-3429-42E2-9F13-93ADD8600ED6}"/>
               </a:ext>
             </a:extLst>
           </p:cNvPr>
@@ -4107,7 +4107,7 @@
                   <a:srgbClr val="000000"/>
                 </a:solidFill>
               </a:rPr>
-              <a:t>The selected router beats simple coordination baselines on the 13-trace train-window surface.</a:t>
+              <a:t>Instruction-count ratios stay at 0.999999462x on training validation and 1.000000009x on heldout.</a:t>
             </a:r>
           </a:p>
         </p:txBody>
@@ -4117,7 +4117,7 @@
           <p:cNvPr id="6" name="bullet-3">
             <a:extLst xmlns:a="http://schemas.openxmlformats.org/drawingml/2006/main">
               <a:ext uri="{FF2B5EF4-FFF2-40B4-BE49-F238E27FC236}">
-                <a16:creationId xmlns:a16="http://schemas.microsoft.com/office/drawing/2014/main" id="{7589EFB7-420C-4336-BD8B-06DD62A512CF}"/>
+                <a16:creationId xmlns:a16="http://schemas.microsoft.com/office/drawing/2014/main" id="{A87EE8C4-75C4-4B08-8A06-2F23EC997FC8}"/>
               </a:ext>
             </a:extLst>
           </p:cNvPr>
@@ -4152,7 +4152,7 @@
                   <a:srgbClr val="000000"/>
                 </a:solidFill>
               </a:rPr>
-              <a:t>Pair-best single remains the upper comparator, which keeps the claim honest.</a:t>
+              <a:t>The oracle best prefetcher remains a cap, which keeps the claim sized correctly.</a:t>
             </a:r>
           </a:p>
         </p:txBody>
@@ -4162,7 +4162,7 @@
           <p:cNvPr id="7" name="bullet-4">
             <a:extLst xmlns:a="http://schemas.openxmlformats.org/drawingml/2006/main">
               <a:ext uri="{FF2B5EF4-FFF2-40B4-BE49-F238E27FC236}">
-                <a16:creationId xmlns:a16="http://schemas.microsoft.com/office/drawing/2014/main" id="{3BD6D933-3FE6-45A8-B449-EA5C406DE896}"/>
+                <a16:creationId xmlns:a16="http://schemas.microsoft.com/office/drawing/2014/main" id="{1A6DDB2C-9BD3-4DE5-BBD4-3C12862AA331}"/>
               </a:ext>
             </a:extLst>
           </p:cNvPr>
@@ -4197,7 +4197,7 @@
                   <a:srgbClr val="000000"/>
                 </a:solidFill>
               </a:rPr>
-              <a:t>The final artifacts preserve raw metric paths, ledgers, configs, and generated figures.</a:t>
+              <a:t>Reproduction paths and naming details live in report/writing_logistics.md.</a:t>
             </a:r>
           </a:p>
         </p:txBody>
@@ -4205,7 +4205,7 @@
     </p:spTree>
     <p:extLst>
       <p:ext uri="{BB962C8B-B14F-4D97-AF65-F5344CB8AC3E}">
-        <p14:creationId xmlns:p14="http://schemas.microsoft.com/office/powerpoint/2010/main" val="1416011399"/>
+        <p14:creationId xmlns:p14="http://schemas.microsoft.com/office/powerpoint/2010/main" val="1057278392"/>
       </p:ext>
     </p:extLst>
   </p:cSld>

</xml_diff>

<commit_message>
Finalize MoP OpenEvolve report artifacts
</commit_message>
<xml_diff>
--- a/slides/mop_stage2_final/output/output.pptx
+++ b/slides/mop_stage2_final/output/output.pptx
@@ -2,20 +2,20 @@
 <file path=ppt/presentation.xml><?xml version="1.0" encoding="utf-8"?>
 <p:presentation xmlns:p="http://schemas.openxmlformats.org/presentationml/2006/main">
   <p:sldMasterIdLst>
-    <p:sldMasterId xmlns:r="http://schemas.openxmlformats.org/officeDocument/2006/relationships" id="2147483648" r:id="Rcf019af433b04efd"/>
+    <p:sldMasterId xmlns:r="http://schemas.openxmlformats.org/officeDocument/2006/relationships" id="2147483648" r:id="Rb97ea5b5fba541e7"/>
   </p:sldMasterIdLst>
   <p:notesMasterIdLst>
-    <p:notesMasterId xmlns:r="http://schemas.openxmlformats.org/officeDocument/2006/relationships" r:id="R6d936477a8a74063"/>
+    <p:notesMasterId xmlns:r="http://schemas.openxmlformats.org/officeDocument/2006/relationships" r:id="Rcaa9089045eb4ea3"/>
   </p:notesMasterIdLst>
   <p:sldIdLst>
-    <p:sldId xmlns:r="http://schemas.openxmlformats.org/officeDocument/2006/relationships" id="256" r:id="Rb74c2666575d4261"/>
-    <p:sldId xmlns:r="http://schemas.openxmlformats.org/officeDocument/2006/relationships" id="257" r:id="R0d672db6e9b24a0a"/>
-    <p:sldId xmlns:r="http://schemas.openxmlformats.org/officeDocument/2006/relationships" id="258" r:id="R36a08f214930491f"/>
-    <p:sldId xmlns:r="http://schemas.openxmlformats.org/officeDocument/2006/relationships" id="259" r:id="R1f32f15770c4489f"/>
-    <p:sldId xmlns:r="http://schemas.openxmlformats.org/officeDocument/2006/relationships" id="260" r:id="R71e984da5e4d44b1"/>
-    <p:sldId xmlns:r="http://schemas.openxmlformats.org/officeDocument/2006/relationships" id="261" r:id="R7fce0d0ad4424518"/>
-    <p:sldId xmlns:r="http://schemas.openxmlformats.org/officeDocument/2006/relationships" id="262" r:id="R0b5bbd31bb5946e6"/>
-    <p:sldId xmlns:r="http://schemas.openxmlformats.org/officeDocument/2006/relationships" id="263" r:id="R4612e2c51b2f453b"/>
+    <p:sldId xmlns:r="http://schemas.openxmlformats.org/officeDocument/2006/relationships" id="256" r:id="R541fef04852c485e"/>
+    <p:sldId xmlns:r="http://schemas.openxmlformats.org/officeDocument/2006/relationships" id="257" r:id="R86a59238c36246b1"/>
+    <p:sldId xmlns:r="http://schemas.openxmlformats.org/officeDocument/2006/relationships" id="258" r:id="R2e4970b645d745c7"/>
+    <p:sldId xmlns:r="http://schemas.openxmlformats.org/officeDocument/2006/relationships" id="259" r:id="Reed6a62ee5974450"/>
+    <p:sldId xmlns:r="http://schemas.openxmlformats.org/officeDocument/2006/relationships" id="260" r:id="Rb032cefd191f4b88"/>
+    <p:sldId xmlns:r="http://schemas.openxmlformats.org/officeDocument/2006/relationships" id="261" r:id="R9980df2e40fa4837"/>
+    <p:sldId xmlns:r="http://schemas.openxmlformats.org/officeDocument/2006/relationships" id="262" r:id="Re37d376f8b9a4df7"/>
+    <p:sldId xmlns:r="http://schemas.openxmlformats.org/officeDocument/2006/relationships" id="263" r:id="Rdf5c3f8aa7d54882"/>
   </p:sldIdLst>
   <p:sldSz cx="18288000" cy="10287000"/>
   <p:notesSz cx="6858000" cy="9144000"/>
@@ -1024,7 +1024,7 @@
   </p:cSld>
   <p:clrMap bg1="lt1" tx1="dk1" bg2="lt2" tx2="dk2" accent1="accent1" accent2="accent2" accent3="accent3" accent4="accent4" accent5="accent5" accent6="accent6" hlink="hlink" folHlink="folHlink"/>
   <p:sldLayoutIdLst>
-    <p:sldLayoutId xmlns:r="http://schemas.openxmlformats.org/officeDocument/2006/relationships" id="2147483649" r:id="Raea05c48b4e94a0f"/>
+    <p:sldLayoutId xmlns:r="http://schemas.openxmlformats.org/officeDocument/2006/relationships" id="2147483649" r:id="R4d1c8fdab5ba444f"/>
   </p:sldLayoutIdLst>
   <p:txStyles>
     <p:titleStyle>
@@ -1323,7 +1323,7 @@
           <p:cNvPr id="1" name="cover-title">
             <a:extLst xmlns:a="http://schemas.openxmlformats.org/drawingml/2006/main">
               <a:ext uri="{FF2B5EF4-FFF2-40B4-BE49-F238E27FC236}">
-                <a16:creationId xmlns:a16="http://schemas.microsoft.com/office/drawing/2014/main" id="{FC3F70BA-69A3-48E4-9DC3-B218FC1507D7}"/>
+                <a16:creationId xmlns:a16="http://schemas.microsoft.com/office/drawing/2014/main" id="{B1D9E271-6B7D-4ABF-86DD-5BF09263D4FC}"/>
               </a:ext>
             </a:extLst>
           </p:cNvPr>
@@ -1368,7 +1368,7 @@
           <p:cNvPr id="2" name="cover-rule">
             <a:extLst xmlns:a="http://schemas.openxmlformats.org/drawingml/2006/main">
               <a:ext uri="{FF2B5EF4-FFF2-40B4-BE49-F238E27FC236}">
-                <a16:creationId xmlns:a16="http://schemas.microsoft.com/office/drawing/2014/main" id="{F1D64169-877F-4E30-BB04-EDE9B86BE11D}"/>
+                <a16:creationId xmlns:a16="http://schemas.microsoft.com/office/drawing/2014/main" id="{CC0A59B2-C07C-46F2-BB48-211DC64B981F}"/>
               </a:ext>
             </a:extLst>
           </p:cNvPr>
@@ -1401,7 +1401,7 @@
           <p:cNvPr id="3" name="cover-thesis">
             <a:extLst xmlns:a="http://schemas.openxmlformats.org/drawingml/2006/main">
               <a:ext uri="{FF2B5EF4-FFF2-40B4-BE49-F238E27FC236}">
-                <a16:creationId xmlns:a16="http://schemas.microsoft.com/office/drawing/2014/main" id="{B3424CBF-8046-4E04-BB2A-2B9A7BD96305}"/>
+                <a16:creationId xmlns:a16="http://schemas.microsoft.com/office/drawing/2014/main" id="{C5168F11-3B63-474C-B39F-174542514AD2}"/>
               </a:ext>
             </a:extLst>
           </p:cNvPr>
@@ -1436,7 +1436,7 @@
                   <a:srgbClr val="000000"/>
                 </a:solidFill>
               </a:rPr>
-              <a:t>A small L2-cache router that improves IPC over disabled prefetching and tracks an oracle best-prefetcher cap</a:t>
+              <a:t>A small L2-cache router that improves IPC over disabled prefetching and tracks a max-prefetcher cap</a:t>
             </a:r>
           </a:p>
         </p:txBody>
@@ -1446,7 +1446,7 @@
           <p:cNvPr id="4" name="cover-metric-1">
             <a:extLst xmlns:a="http://schemas.openxmlformats.org/drawingml/2006/main">
               <a:ext uri="{FF2B5EF4-FFF2-40B4-BE49-F238E27FC236}">
-                <a16:creationId xmlns:a16="http://schemas.microsoft.com/office/drawing/2014/main" id="{28A270F6-9797-4440-AADB-C9EBB3236654}"/>
+                <a16:creationId xmlns:a16="http://schemas.microsoft.com/office/drawing/2014/main" id="{323C0642-ED9A-40CD-BDFB-3D55A7D548B4}"/>
               </a:ext>
             </a:extLst>
           </p:cNvPr>
@@ -1481,7 +1481,7 @@
                   <a:srgbClr val="DC267F"/>
                 </a:solidFill>
               </a:rPr>
-              <a:t>1.0662x</a:t>
+              <a:t>1.066x</a:t>
             </a:r>
           </a:p>
         </p:txBody>
@@ -1491,7 +1491,7 @@
           <p:cNvPr id="5" name="cover-label-1">
             <a:extLst xmlns:a="http://schemas.openxmlformats.org/drawingml/2006/main">
               <a:ext uri="{FF2B5EF4-FFF2-40B4-BE49-F238E27FC236}">
-                <a16:creationId xmlns:a16="http://schemas.microsoft.com/office/drawing/2014/main" id="{F47744C3-0AF6-40D7-9366-0874FEB8AB18}"/>
+                <a16:creationId xmlns:a16="http://schemas.microsoft.com/office/drawing/2014/main" id="{58C0DB40-2B37-4F21-B043-0CE20E4EE8EC}"/>
               </a:ext>
             </a:extLst>
           </p:cNvPr>
@@ -1526,7 +1526,7 @@
                   <a:srgbClr val="000000"/>
                 </a:solidFill>
               </a:rPr>
-              <a:t>13-trace training validation vs disabled prefetching</a:t>
+              <a:t>13-trace training-split validation vs disabled prefetching</a:t>
             </a:r>
           </a:p>
         </p:txBody>
@@ -1536,7 +1536,7 @@
           <p:cNvPr id="6" name="cover-metric-2">
             <a:extLst xmlns:a="http://schemas.openxmlformats.org/drawingml/2006/main">
               <a:ext uri="{FF2B5EF4-FFF2-40B4-BE49-F238E27FC236}">
-                <a16:creationId xmlns:a16="http://schemas.microsoft.com/office/drawing/2014/main" id="{9C728EE8-8E8D-4B62-901B-A4568E41FEF8}"/>
+                <a16:creationId xmlns:a16="http://schemas.microsoft.com/office/drawing/2014/main" id="{A28CD40B-EA0A-4617-9D26-00637960FA2B}"/>
               </a:ext>
             </a:extLst>
           </p:cNvPr>
@@ -1571,7 +1571,7 @@
                   <a:srgbClr val="648FFF"/>
                 </a:solidFill>
               </a:rPr>
-              <a:t>1.0033x</a:t>
+              <a:t>1.003x</a:t>
             </a:r>
           </a:p>
         </p:txBody>
@@ -1581,7 +1581,7 @@
           <p:cNvPr id="7" name="cover-label-2">
             <a:extLst xmlns:a="http://schemas.openxmlformats.org/drawingml/2006/main">
               <a:ext uri="{FF2B5EF4-FFF2-40B4-BE49-F238E27FC236}">
-                <a16:creationId xmlns:a16="http://schemas.microsoft.com/office/drawing/2014/main" id="{704F9724-61DA-4580-BD2E-248604413E20}"/>
+                <a16:creationId xmlns:a16="http://schemas.microsoft.com/office/drawing/2014/main" id="{4967FA06-2230-47D9-BD95-3208BCC233AC}"/>
               </a:ext>
             </a:extLst>
           </p:cNvPr>
@@ -1626,7 +1626,7 @@
           <p:cNvPr id="8" name="cover-footer">
             <a:extLst xmlns:a="http://schemas.openxmlformats.org/drawingml/2006/main">
               <a:ext uri="{FF2B5EF4-FFF2-40B4-BE49-F238E27FC236}">
-                <a16:creationId xmlns:a16="http://schemas.microsoft.com/office/drawing/2014/main" id="{B74547B2-DCB2-4B3B-AF31-89D6282A80BE}"/>
+                <a16:creationId xmlns:a16="http://schemas.microsoft.com/office/drawing/2014/main" id="{8E72C5E5-5072-4143-B898-2CCAF8A15392}"/>
               </a:ext>
             </a:extLst>
           </p:cNvPr>
@@ -1661,7 +1661,7 @@
                   <a:srgbClr val="000000"/>
                 </a:solidFill>
               </a:rPr>
-              <a:t>CMU 15-740 class project, OpenEvolve training-validation report</a:t>
+              <a:t>CMU 15-740 class project, OpenEvolve training-split report</a:t>
             </a:r>
           </a:p>
         </p:txBody>
@@ -1669,7 +1669,7 @@
     </p:spTree>
     <p:extLst>
       <p:ext uri="{BB962C8B-B14F-4D97-AF65-F5344CB8AC3E}">
-        <p14:creationId xmlns:p14="http://schemas.microsoft.com/office/powerpoint/2010/main" val="1104381730"/>
+        <p14:creationId xmlns:p14="http://schemas.microsoft.com/office/powerpoint/2010/main" val="1897524092"/>
       </p:ext>
     </p:extLst>
   </p:cSld>
@@ -1693,7 +1693,7 @@
           <p:cNvPr id="1" name="slide-title">
             <a:extLst xmlns:a="http://schemas.openxmlformats.org/drawingml/2006/main">
               <a:ext uri="{FF2B5EF4-FFF2-40B4-BE49-F238E27FC236}">
-                <a16:creationId xmlns:a16="http://schemas.microsoft.com/office/drawing/2014/main" id="{A661C991-FF9E-4CAE-B8D3-709D3B6B2C6A}"/>
+                <a16:creationId xmlns:a16="http://schemas.microsoft.com/office/drawing/2014/main" id="{EF4478CD-5C94-4315-9E02-A0B4D87C8B47}"/>
               </a:ext>
             </a:extLst>
           </p:cNvPr>
@@ -1738,7 +1738,7 @@
           <p:cNvPr id="2" name="slide-subtitle">
             <a:extLst xmlns:a="http://schemas.openxmlformats.org/drawingml/2006/main">
               <a:ext uri="{FF2B5EF4-FFF2-40B4-BE49-F238E27FC236}">
-                <a16:creationId xmlns:a16="http://schemas.microsoft.com/office/drawing/2014/main" id="{7AD4A1EA-38C6-46F4-917B-DE6DFE230F54}"/>
+                <a16:creationId xmlns:a16="http://schemas.microsoft.com/office/drawing/2014/main" id="{1DE4A1F0-6B6D-4E54-811F-E294F4B53B16}"/>
               </a:ext>
             </a:extLst>
           </p:cNvPr>
@@ -1783,7 +1783,7 @@
           <p:cNvPr id="3" name="bullet-0">
             <a:extLst xmlns:a="http://schemas.openxmlformats.org/drawingml/2006/main">
               <a:ext uri="{FF2B5EF4-FFF2-40B4-BE49-F238E27FC236}">
-                <a16:creationId xmlns:a16="http://schemas.microsoft.com/office/drawing/2014/main" id="{690A56A9-9C7A-4371-BA54-B21DF7FAD334}"/>
+                <a16:creationId xmlns:a16="http://schemas.microsoft.com/office/drawing/2014/main" id="{FD584007-CB25-4888-9E69-6F8C6596BD06}"/>
               </a:ext>
             </a:extLst>
           </p:cNvPr>
@@ -1828,7 +1828,7 @@
           <p:cNvPr id="4" name="bullet-1">
             <a:extLst xmlns:a="http://schemas.openxmlformats.org/drawingml/2006/main">
               <a:ext uri="{FF2B5EF4-FFF2-40B4-BE49-F238E27FC236}">
-                <a16:creationId xmlns:a16="http://schemas.microsoft.com/office/drawing/2014/main" id="{E4E5A085-F112-4C48-BF81-087405140AAE}"/>
+                <a16:creationId xmlns:a16="http://schemas.microsoft.com/office/drawing/2014/main" id="{8E3F2E55-AAA3-438F-A136-E5759318D387}"/>
               </a:ext>
             </a:extLst>
           </p:cNvPr>
@@ -1873,7 +1873,7 @@
           <p:cNvPr id="5" name="bullet-2">
             <a:extLst xmlns:a="http://schemas.openxmlformats.org/drawingml/2006/main">
               <a:ext uri="{FF2B5EF4-FFF2-40B4-BE49-F238E27FC236}">
-                <a16:creationId xmlns:a16="http://schemas.microsoft.com/office/drawing/2014/main" id="{722EF609-F1A0-4F11-9E47-374C68AAD3E5}"/>
+                <a16:creationId xmlns:a16="http://schemas.microsoft.com/office/drawing/2014/main" id="{F140D8F2-0FFE-455B-92C0-7EACFB658276}"/>
               </a:ext>
             </a:extLst>
           </p:cNvPr>
@@ -1918,7 +1918,7 @@
           <p:cNvPr id="6" name="bullet-3">
             <a:extLst xmlns:a="http://schemas.openxmlformats.org/drawingml/2006/main">
               <a:ext uri="{FF2B5EF4-FFF2-40B4-BE49-F238E27FC236}">
-                <a16:creationId xmlns:a16="http://schemas.microsoft.com/office/drawing/2014/main" id="{0AB18D15-C05B-43F3-9D5C-AFB98D203D78}"/>
+                <a16:creationId xmlns:a16="http://schemas.microsoft.com/office/drawing/2014/main" id="{DCB61D84-44F2-45CF-B670-84DE40AC7D8B}"/>
               </a:ext>
             </a:extLst>
           </p:cNvPr>
@@ -1963,7 +1963,7 @@
           <p:cNvPr id="7" name="bullet-0">
             <a:extLst xmlns:a="http://schemas.openxmlformats.org/drawingml/2006/main">
               <a:ext uri="{FF2B5EF4-FFF2-40B4-BE49-F238E27FC236}">
-                <a16:creationId xmlns:a16="http://schemas.microsoft.com/office/drawing/2014/main" id="{CF4E15CC-079A-4995-8E36-7AA9D30A2FD7}"/>
+                <a16:creationId xmlns:a16="http://schemas.microsoft.com/office/drawing/2014/main" id="{CD5B43D6-74DB-4289-8AB6-E1729A49A731}"/>
               </a:ext>
             </a:extLst>
           </p:cNvPr>
@@ -2008,7 +2008,7 @@
           <p:cNvPr id="8" name="bullet-1">
             <a:extLst xmlns:a="http://schemas.openxmlformats.org/drawingml/2006/main">
               <a:ext uri="{FF2B5EF4-FFF2-40B4-BE49-F238E27FC236}">
-                <a16:creationId xmlns:a16="http://schemas.microsoft.com/office/drawing/2014/main" id="{2CBC30CF-8310-44E8-B530-48F3C2EA9005}"/>
+                <a16:creationId xmlns:a16="http://schemas.microsoft.com/office/drawing/2014/main" id="{AFB4DE54-1214-443C-A297-BCE926B99E3C}"/>
               </a:ext>
             </a:extLst>
           </p:cNvPr>
@@ -2043,7 +2043,7 @@
                   <a:srgbClr val="000000"/>
                 </a:solidFill>
               </a:rPr>
-              <a:t>MoP-V1.2 manual router</a:t>
+              <a:t>MoP-V1 manual router</a:t>
             </a:r>
           </a:p>
         </p:txBody>
@@ -2053,7 +2053,7 @@
           <p:cNvPr id="9" name="bullet-2">
             <a:extLst xmlns:a="http://schemas.openxmlformats.org/drawingml/2006/main">
               <a:ext uri="{FF2B5EF4-FFF2-40B4-BE49-F238E27FC236}">
-                <a16:creationId xmlns:a16="http://schemas.microsoft.com/office/drawing/2014/main" id="{1ED5938D-A8E6-458C-8F87-AE9234363F9F}"/>
+                <a16:creationId xmlns:a16="http://schemas.microsoft.com/office/drawing/2014/main" id="{272942B9-B42F-46DB-8C16-88E6BCDB710C}"/>
               </a:ext>
             </a:extLst>
           </p:cNvPr>
@@ -2088,7 +2088,7 @@
                   <a:srgbClr val="000000"/>
                 </a:solidFill>
               </a:rPr>
-              <a:t>MoP-V1.3 sticky router</a:t>
+              <a:t>MoP-V2 OpenEvolve-tuned router</a:t>
             </a:r>
           </a:p>
         </p:txBody>
@@ -2098,7 +2098,7 @@
           <p:cNvPr id="10" name="bullet-3">
             <a:extLst xmlns:a="http://schemas.openxmlformats.org/drawingml/2006/main">
               <a:ext uri="{FF2B5EF4-FFF2-40B4-BE49-F238E27FC236}">
-                <a16:creationId xmlns:a16="http://schemas.microsoft.com/office/drawing/2014/main" id="{8046B547-3D99-4980-9F81-88DC9EB67CA1}"/>
+                <a16:creationId xmlns:a16="http://schemas.microsoft.com/office/drawing/2014/main" id="{005BC0AA-1179-465F-BA6E-E1B193A013FF}"/>
               </a:ext>
             </a:extLst>
           </p:cNvPr>
@@ -2143,7 +2143,7 @@
           <p:cNvPr id="11" name="bullet-0">
             <a:extLst xmlns:a="http://schemas.openxmlformats.org/drawingml/2006/main">
               <a:ext uri="{FF2B5EF4-FFF2-40B4-BE49-F238E27FC236}">
-                <a16:creationId xmlns:a16="http://schemas.microsoft.com/office/drawing/2014/main" id="{9A1C7D8A-252E-465D-8958-51F2E01171C5}"/>
+                <a16:creationId xmlns:a16="http://schemas.microsoft.com/office/drawing/2014/main" id="{FBB50F64-84DB-408E-A770-254FAF7A6FEC}"/>
               </a:ext>
             </a:extLst>
           </p:cNvPr>
@@ -2188,7 +2188,7 @@
           <p:cNvPr id="12" name="bullet-1">
             <a:extLst xmlns:a="http://schemas.openxmlformats.org/drawingml/2006/main">
               <a:ext uri="{FF2B5EF4-FFF2-40B4-BE49-F238E27FC236}">
-                <a16:creationId xmlns:a16="http://schemas.microsoft.com/office/drawing/2014/main" id="{F7F3D0D7-7A6A-4130-97CC-453357C6C530}"/>
+                <a16:creationId xmlns:a16="http://schemas.microsoft.com/office/drawing/2014/main" id="{D70FA189-B11D-40CB-83E2-4BB9D5D9A799}"/>
               </a:ext>
             </a:extLst>
           </p:cNvPr>
@@ -2233,7 +2233,7 @@
           <p:cNvPr id="13" name="bullet-2">
             <a:extLst xmlns:a="http://schemas.openxmlformats.org/drawingml/2006/main">
               <a:ext uri="{FF2B5EF4-FFF2-40B4-BE49-F238E27FC236}">
-                <a16:creationId xmlns:a16="http://schemas.microsoft.com/office/drawing/2014/main" id="{D93869D6-E4AB-4BAF-A65C-9FBC539D4C34}"/>
+                <a16:creationId xmlns:a16="http://schemas.microsoft.com/office/drawing/2014/main" id="{23A863B5-8D42-48DB-A7EC-E597CAC7F995}"/>
               </a:ext>
             </a:extLst>
           </p:cNvPr>
@@ -2278,7 +2278,7 @@
           <p:cNvPr id="14" name="bullet-3">
             <a:extLst xmlns:a="http://schemas.openxmlformats.org/drawingml/2006/main">
               <a:ext uri="{FF2B5EF4-FFF2-40B4-BE49-F238E27FC236}">
-                <a16:creationId xmlns:a16="http://schemas.microsoft.com/office/drawing/2014/main" id="{3425DC19-70DB-49D6-8A2A-35ACA910D87F}"/>
+                <a16:creationId xmlns:a16="http://schemas.microsoft.com/office/drawing/2014/main" id="{88694F18-B65C-4E5C-925C-C96CB01E099F}"/>
               </a:ext>
             </a:extLst>
           </p:cNvPr>
@@ -2321,7 +2321,7 @@
     </p:spTree>
     <p:extLst>
       <p:ext uri="{BB962C8B-B14F-4D97-AF65-F5344CB8AC3E}">
-        <p14:creationId xmlns:p14="http://schemas.microsoft.com/office/powerpoint/2010/main" val="2045583822"/>
+        <p14:creationId xmlns:p14="http://schemas.microsoft.com/office/powerpoint/2010/main" val="1491779600"/>
       </p:ext>
     </p:extLst>
   </p:cSld>
@@ -2345,7 +2345,7 @@
           <p:cNvPr id="1" name="slide-title">
             <a:extLst xmlns:a="http://schemas.openxmlformats.org/drawingml/2006/main">
               <a:ext uri="{FF2B5EF4-FFF2-40B4-BE49-F238E27FC236}">
-                <a16:creationId xmlns:a16="http://schemas.microsoft.com/office/drawing/2014/main" id="{C805CFDF-1FC7-425C-938A-955C9412A932}"/>
+                <a16:creationId xmlns:a16="http://schemas.microsoft.com/office/drawing/2014/main" id="{D0982A84-43E7-45DD-9973-3B8E1D2B2E66}"/>
               </a:ext>
             </a:extLst>
           </p:cNvPr>
@@ -2390,7 +2390,7 @@
           <p:cNvPr id="2" name="title-rule">
             <a:extLst xmlns:a="http://schemas.openxmlformats.org/drawingml/2006/main">
               <a:ext uri="{FF2B5EF4-FFF2-40B4-BE49-F238E27FC236}">
-                <a16:creationId xmlns:a16="http://schemas.microsoft.com/office/drawing/2014/main" id="{F642F3EC-0662-4850-91E9-ED876BDC927D}"/>
+                <a16:creationId xmlns:a16="http://schemas.microsoft.com/office/drawing/2014/main" id="{18EF9D30-CAF1-4BB3-AC24-1672EB7C73E6}"/>
               </a:ext>
             </a:extLst>
           </p:cNvPr>
@@ -2423,7 +2423,7 @@
           <p:cNvPr id="3" name="bullet-0">
             <a:extLst xmlns:a="http://schemas.openxmlformats.org/drawingml/2006/main">
               <a:ext uri="{FF2B5EF4-FFF2-40B4-BE49-F238E27FC236}">
-                <a16:creationId xmlns:a16="http://schemas.microsoft.com/office/drawing/2014/main" id="{BC69E0DA-078E-4D99-8D45-3CF9F4382883}"/>
+                <a16:creationId xmlns:a16="http://schemas.microsoft.com/office/drawing/2014/main" id="{34D49833-2636-436E-BB93-F6F0F472D69F}"/>
               </a:ext>
             </a:extLst>
           </p:cNvPr>
@@ -2468,7 +2468,7 @@
           <p:cNvPr id="4" name="bullet-1">
             <a:extLst xmlns:a="http://schemas.openxmlformats.org/drawingml/2006/main">
               <a:ext uri="{FF2B5EF4-FFF2-40B4-BE49-F238E27FC236}">
-                <a16:creationId xmlns:a16="http://schemas.microsoft.com/office/drawing/2014/main" id="{002E7275-6F6E-49CC-9F3D-5EB43AB718C3}"/>
+                <a16:creationId xmlns:a16="http://schemas.microsoft.com/office/drawing/2014/main" id="{A36CBF26-BD67-4A1C-9ED6-2BC3E93102ED}"/>
               </a:ext>
             </a:extLst>
           </p:cNvPr>
@@ -2513,7 +2513,7 @@
           <p:cNvPr id="5" name="bullet-2">
             <a:extLst xmlns:a="http://schemas.openxmlformats.org/drawingml/2006/main">
               <a:ext uri="{FF2B5EF4-FFF2-40B4-BE49-F238E27FC236}">
-                <a16:creationId xmlns:a16="http://schemas.microsoft.com/office/drawing/2014/main" id="{F7229593-CAE6-4DC5-AFFC-D4E097BD0E75}"/>
+                <a16:creationId xmlns:a16="http://schemas.microsoft.com/office/drawing/2014/main" id="{125B4177-125F-4B67-91CA-545D986D4A23}"/>
               </a:ext>
             </a:extLst>
           </p:cNvPr>
@@ -2558,7 +2558,7 @@
           <p:cNvPr id="6" name="bullet-3">
             <a:extLst xmlns:a="http://schemas.openxmlformats.org/drawingml/2006/main">
               <a:ext uri="{FF2B5EF4-FFF2-40B4-BE49-F238E27FC236}">
-                <a16:creationId xmlns:a16="http://schemas.microsoft.com/office/drawing/2014/main" id="{EFF88650-7CD6-4F51-A706-3768507A59AC}"/>
+                <a16:creationId xmlns:a16="http://schemas.microsoft.com/office/drawing/2014/main" id="{AA721705-F2D2-49D6-8A6E-5E6919CC6C0F}"/>
               </a:ext>
             </a:extLst>
           </p:cNvPr>
@@ -2593,7 +2593,7 @@
                   <a:srgbClr val="000000"/>
                 </a:solidFill>
               </a:rPr>
-              <a:t>Training validation: 13 traces</a:t>
+              <a:t>Training-split validation: 13 local traces</a:t>
             </a:r>
           </a:p>
         </p:txBody>
@@ -2603,7 +2603,7 @@
           <p:cNvPr id="7" name="bullet-4">
             <a:extLst xmlns:a="http://schemas.openxmlformats.org/drawingml/2006/main">
               <a:ext uri="{FF2B5EF4-FFF2-40B4-BE49-F238E27FC236}">
-                <a16:creationId xmlns:a16="http://schemas.microsoft.com/office/drawing/2014/main" id="{1859336B-06CF-47C9-A121-52992E0F9DDE}"/>
+                <a16:creationId xmlns:a16="http://schemas.microsoft.com/office/drawing/2014/main" id="{7700925D-EF51-4B69-B0B6-584AECBA668A}"/>
               </a:ext>
             </a:extLst>
           </p:cNvPr>
@@ -2648,7 +2648,7 @@
           <p:cNvPr id="8" name="bullet-0">
             <a:extLst xmlns:a="http://schemas.openxmlformats.org/drawingml/2006/main">
               <a:ext uri="{FF2B5EF4-FFF2-40B4-BE49-F238E27FC236}">
-                <a16:creationId xmlns:a16="http://schemas.microsoft.com/office/drawing/2014/main" id="{01D40BB8-3E6C-4DBF-B8FA-ABFCD025B4BE}"/>
+                <a16:creationId xmlns:a16="http://schemas.microsoft.com/office/drawing/2014/main" id="{C1C48BC9-7C8F-4252-8792-CB408A1F6FD6}"/>
               </a:ext>
             </a:extLst>
           </p:cNvPr>
@@ -2693,7 +2693,7 @@
           <p:cNvPr id="9" name="bullet-1">
             <a:extLst xmlns:a="http://schemas.openxmlformats.org/drawingml/2006/main">
               <a:ext uri="{FF2B5EF4-FFF2-40B4-BE49-F238E27FC236}">
-                <a16:creationId xmlns:a16="http://schemas.microsoft.com/office/drawing/2014/main" id="{6398165E-77AF-4938-A0B8-A9EE26C3AAB0}"/>
+                <a16:creationId xmlns:a16="http://schemas.microsoft.com/office/drawing/2014/main" id="{27A04A6D-EEDE-4497-902C-40AC710D33CE}"/>
               </a:ext>
             </a:extLst>
           </p:cNvPr>
@@ -2728,7 +2728,7 @@
                   <a:srgbClr val="000000"/>
                 </a:solidFill>
               </a:rPr>
-              <a:t>Oracle cap: max(MLOP, SPP+PPF) per trace</a:t>
+              <a:t>Max-prefetcher cap: max(MLOP, SPP+PPF) per trace</a:t>
             </a:r>
           </a:p>
         </p:txBody>
@@ -2738,7 +2738,7 @@
           <p:cNvPr id="10" name="bullet-2">
             <a:extLst xmlns:a="http://schemas.openxmlformats.org/drawingml/2006/main">
               <a:ext uri="{FF2B5EF4-FFF2-40B4-BE49-F238E27FC236}">
-                <a16:creationId xmlns:a16="http://schemas.microsoft.com/office/drawing/2014/main" id="{5BB26571-F24C-4EA1-8CE8-D75ACA60B620}"/>
+                <a16:creationId xmlns:a16="http://schemas.microsoft.com/office/drawing/2014/main" id="{1DC49729-D92C-42B3-8200-1324FA66E9DF}"/>
               </a:ext>
             </a:extLst>
           </p:cNvPr>
@@ -2783,7 +2783,7 @@
           <p:cNvPr id="11" name="bullet-3">
             <a:extLst xmlns:a="http://schemas.openxmlformats.org/drawingml/2006/main">
               <a:ext uri="{FF2B5EF4-FFF2-40B4-BE49-F238E27FC236}">
-                <a16:creationId xmlns:a16="http://schemas.microsoft.com/office/drawing/2014/main" id="{F8FDF17B-CE5A-4644-8594-C74B52C6EE21}"/>
+                <a16:creationId xmlns:a16="http://schemas.microsoft.com/office/drawing/2014/main" id="{5E94F1D2-F6D5-4413-A375-1165CE899642}"/>
               </a:ext>
             </a:extLst>
           </p:cNvPr>
@@ -2828,7 +2828,7 @@
           <p:cNvPr id="12" name="protocol-footer">
             <a:extLst xmlns:a="http://schemas.openxmlformats.org/drawingml/2006/main">
               <a:ext uri="{FF2B5EF4-FFF2-40B4-BE49-F238E27FC236}">
-                <a16:creationId xmlns:a16="http://schemas.microsoft.com/office/drawing/2014/main" id="{5E05F74C-FEAD-4C52-9F69-26726F81DF60}"/>
+                <a16:creationId xmlns:a16="http://schemas.microsoft.com/office/drawing/2014/main" id="{3CD03036-5F74-4740-B6BE-DE82F45A3849}"/>
               </a:ext>
             </a:extLst>
           </p:cNvPr>
@@ -2863,7 +2863,7 @@
                   <a:srgbClr val="000000"/>
                 </a:solidFill>
               </a:rPr>
-              <a:t>Quick evaluation used 3 training traces. Wider validation used 10 training traces. Heldout runs after policy selection.</a:t>
+              <a:t>The 13-trace training-split surface has complete local artifacts. The four other train traces are facesim, ligra_BFS, ligra_Triangle, and secret_compute_int_243.</a:t>
             </a:r>
           </a:p>
         </p:txBody>
@@ -2871,7 +2871,7 @@
     </p:spTree>
     <p:extLst>
       <p:ext uri="{BB962C8B-B14F-4D97-AF65-F5344CB8AC3E}">
-        <p14:creationId xmlns:p14="http://schemas.microsoft.com/office/powerpoint/2010/main" val="434929475"/>
+        <p14:creationId xmlns:p14="http://schemas.microsoft.com/office/powerpoint/2010/main" val="557165073"/>
       </p:ext>
     </p:extLst>
   </p:cSld>
@@ -2895,7 +2895,7 @@
           <p:cNvPr id="1" name="slide-title">
             <a:extLst xmlns:a="http://schemas.openxmlformats.org/drawingml/2006/main">
               <a:ext uri="{FF2B5EF4-FFF2-40B4-BE49-F238E27FC236}">
-                <a16:creationId xmlns:a16="http://schemas.microsoft.com/office/drawing/2014/main" id="{CA9F5598-BF5E-4E5B-BC93-5C158C26C853}"/>
+                <a16:creationId xmlns:a16="http://schemas.microsoft.com/office/drawing/2014/main" id="{CA9EDC0B-6380-4621-98DF-247DE2887323}"/>
               </a:ext>
             </a:extLst>
           </p:cNvPr>
@@ -2940,7 +2940,7 @@
           <p:cNvPr id="2" name="slide-subtitle">
             <a:extLst xmlns:a="http://schemas.openxmlformats.org/drawingml/2006/main">
               <a:ext uri="{FF2B5EF4-FFF2-40B4-BE49-F238E27FC236}">
-                <a16:creationId xmlns:a16="http://schemas.microsoft.com/office/drawing/2014/main" id="{F86A1024-A6F8-4094-B3D7-BED3AB8345F6}"/>
+                <a16:creationId xmlns:a16="http://schemas.microsoft.com/office/drawing/2014/main" id="{FA7E48F3-36B1-4C3C-BCC8-C0DCDF0FD116}"/>
               </a:ext>
             </a:extLst>
           </p:cNvPr>
@@ -2975,7 +2975,7 @@
                   <a:srgbClr val="000000"/>
                 </a:solidFill>
               </a:rPr>
-              <a:t>Bars use disabled prefetching as 1x. Black caps show the per-trace oracle best prefetcher.</a:t>
+              <a:t>Bars use disabled prefetching as 1x. Yellow caps show the per-trace max prefetcher.</a:t>
             </a:r>
           </a:p>
         </p:txBody>
@@ -2989,7 +2989,7 @@
           <p:nvPr/>
         </p:nvPicPr>
         <p:blipFill>
-          <a:blip xmlns:r="http://schemas.openxmlformats.org/officeDocument/2006/relationships" xmlns:a="http://schemas.openxmlformats.org/drawingml/2006/main" r:embed="Rb3e3ff7ec0fe4cf0"/>
+          <a:blip xmlns:r="http://schemas.openxmlformats.org/officeDocument/2006/relationships" xmlns:a="http://schemas.openxmlformats.org/drawingml/2006/main" r:embed="R39e152a34be74386"/>
           <a:stretch xmlns:a="http://schemas.openxmlformats.org/drawingml/2006/main"/>
         </p:blipFill>
         <p:spPr>
@@ -3005,7 +3005,7 @@
     </p:spTree>
     <p:extLst>
       <p:ext uri="{BB962C8B-B14F-4D97-AF65-F5344CB8AC3E}">
-        <p14:creationId xmlns:p14="http://schemas.microsoft.com/office/powerpoint/2010/main" val="1290538841"/>
+        <p14:creationId xmlns:p14="http://schemas.microsoft.com/office/powerpoint/2010/main" val="468390340"/>
       </p:ext>
     </p:extLst>
   </p:cSld>
@@ -3029,7 +3029,7 @@
           <p:cNvPr id="1" name="slide-title">
             <a:extLst xmlns:a="http://schemas.openxmlformats.org/drawingml/2006/main">
               <a:ext uri="{FF2B5EF4-FFF2-40B4-BE49-F238E27FC236}">
-                <a16:creationId xmlns:a16="http://schemas.microsoft.com/office/drawing/2014/main" id="{D9525116-0EB7-47EB-8D30-F0CC4D1458E7}"/>
+                <a16:creationId xmlns:a16="http://schemas.microsoft.com/office/drawing/2014/main" id="{FA46C543-C4F7-4EE6-BE99-CF72243B06A5}"/>
               </a:ext>
             </a:extLst>
           </p:cNvPr>
@@ -3074,7 +3074,7 @@
           <p:cNvPr id="2" name="slide-subtitle">
             <a:extLst xmlns:a="http://schemas.openxmlformats.org/drawingml/2006/main">
               <a:ext uri="{FF2B5EF4-FFF2-40B4-BE49-F238E27FC236}">
-                <a16:creationId xmlns:a16="http://schemas.microsoft.com/office/drawing/2014/main" id="{2487093B-9423-42D9-AC99-8F4B9C83CA42}"/>
+                <a16:creationId xmlns:a16="http://schemas.microsoft.com/office/drawing/2014/main" id="{53633801-AC32-46F4-B5C0-44221DB91F08}"/>
               </a:ext>
             </a:extLst>
           </p:cNvPr>
@@ -3109,7 +3109,7 @@
                   <a:srgbClr val="000000"/>
                 </a:solidFill>
               </a:rPr>
-              <a:t>Each trace uses disabled prefetching as 1x, with the oracle cap marked separately.</a:t>
+              <a:t>Horizontal bars compare MLOP, SPP+PPF, and MoP-V2 on each heldout trace.</a:t>
             </a:r>
           </a:p>
         </p:txBody>
@@ -3123,13 +3123,13 @@
           <p:nvPr/>
         </p:nvPicPr>
         <p:blipFill>
-          <a:blip xmlns:r="http://schemas.openxmlformats.org/officeDocument/2006/relationships" xmlns:a="http://schemas.openxmlformats.org/drawingml/2006/main" r:embed="R5e8f6bdca19c416b"/>
+          <a:blip xmlns:r="http://schemas.openxmlformats.org/officeDocument/2006/relationships" xmlns:a="http://schemas.openxmlformats.org/drawingml/2006/main" r:embed="Rab95d7784c884984"/>
           <a:stretch xmlns:a="http://schemas.openxmlformats.org/drawingml/2006/main"/>
         </p:blipFill>
         <p:spPr>
           <a:xfrm xmlns:a="http://schemas.openxmlformats.org/drawingml/2006/main">
-            <a:off x="1023754" y="1710690"/>
-            <a:ext cx="16240491" cy="8042910"/>
+            <a:off x="1226760" y="1710690"/>
+            <a:ext cx="15834479" cy="8042910"/>
           </a:xfrm>
           <a:prstGeom xmlns:a="http://schemas.openxmlformats.org/drawingml/2006/main" prst="rect">
             <a:avLst/>
@@ -3139,7 +3139,7 @@
     </p:spTree>
     <p:extLst>
       <p:ext uri="{BB962C8B-B14F-4D97-AF65-F5344CB8AC3E}">
-        <p14:creationId xmlns:p14="http://schemas.microsoft.com/office/powerpoint/2010/main" val="2002574659"/>
+        <p14:creationId xmlns:p14="http://schemas.microsoft.com/office/powerpoint/2010/main" val="699865382"/>
       </p:ext>
     </p:extLst>
   </p:cSld>
@@ -3163,7 +3163,7 @@
           <p:cNvPr id="1" name="slide-title">
             <a:extLst xmlns:a="http://schemas.openxmlformats.org/drawingml/2006/main">
               <a:ext uri="{FF2B5EF4-FFF2-40B4-BE49-F238E27FC236}">
-                <a16:creationId xmlns:a16="http://schemas.microsoft.com/office/drawing/2014/main" id="{E8214986-D9E4-4EA0-9632-9F422B2145A0}"/>
+                <a16:creationId xmlns:a16="http://schemas.microsoft.com/office/drawing/2014/main" id="{B0B800F4-C4CC-43A5-AB45-C6D845D035D8}"/>
               </a:ext>
             </a:extLst>
           </p:cNvPr>
@@ -3208,7 +3208,7 @@
           <p:cNvPr id="2" name="slide-subtitle">
             <a:extLst xmlns:a="http://schemas.openxmlformats.org/drawingml/2006/main">
               <a:ext uri="{FF2B5EF4-FFF2-40B4-BE49-F238E27FC236}">
-                <a16:creationId xmlns:a16="http://schemas.microsoft.com/office/drawing/2014/main" id="{B9D6594B-389F-4B1E-B17A-B07873FCB226}"/>
+                <a16:creationId xmlns:a16="http://schemas.microsoft.com/office/drawing/2014/main" id="{9B05E453-F86A-467E-A396-9ACE77DFA0E0}"/>
               </a:ext>
             </a:extLst>
           </p:cNvPr>
@@ -3243,7 +3243,7 @@
                   <a:srgbClr val="000000"/>
                 </a:solidFill>
               </a:rPr>
-              <a:t>Faint points are valid generated candidates. Lines show best-so-far by weighted score.</a:t>
+              <a:t>Left: 3-trace quick evaluation. Right: 10-trace wider validation. Lines show best-so-far by weighted score.</a:t>
             </a:r>
           </a:p>
         </p:txBody>
@@ -3257,13 +3257,13 @@
           <p:nvPr/>
         </p:nvPicPr>
         <p:blipFill>
-          <a:blip xmlns:r="http://schemas.openxmlformats.org/officeDocument/2006/relationships" xmlns:a="http://schemas.openxmlformats.org/drawingml/2006/main" r:embed="Rf59bf4a53a634669"/>
+          <a:blip xmlns:r="http://schemas.openxmlformats.org/officeDocument/2006/relationships" xmlns:a="http://schemas.openxmlformats.org/drawingml/2006/main" r:embed="Rcdd5c3f5d5c34591"/>
           <a:stretch xmlns:a="http://schemas.openxmlformats.org/drawingml/2006/main"/>
         </p:blipFill>
         <p:spPr>
           <a:xfrm xmlns:a="http://schemas.openxmlformats.org/drawingml/2006/main">
-            <a:off x="666750" y="2277195"/>
-            <a:ext cx="16954500" cy="6909901"/>
+            <a:off x="1101090" y="1710690"/>
+            <a:ext cx="16085820" cy="8042910"/>
           </a:xfrm>
           <a:prstGeom xmlns:a="http://schemas.openxmlformats.org/drawingml/2006/main" prst="rect">
             <a:avLst/>
@@ -3273,7 +3273,7 @@
     </p:spTree>
     <p:extLst>
       <p:ext uri="{BB962C8B-B14F-4D97-AF65-F5344CB8AC3E}">
-        <p14:creationId xmlns:p14="http://schemas.microsoft.com/office/powerpoint/2010/main" val="372933722"/>
+        <p14:creationId xmlns:p14="http://schemas.microsoft.com/office/powerpoint/2010/main" val="1147861995"/>
       </p:ext>
     </p:extLst>
   </p:cSld>
@@ -3297,7 +3297,7 @@
           <p:cNvPr id="1" name="slide-title">
             <a:extLst xmlns:a="http://schemas.openxmlformats.org/drawingml/2006/main">
               <a:ext uri="{FF2B5EF4-FFF2-40B4-BE49-F238E27FC236}">
-                <a16:creationId xmlns:a16="http://schemas.microsoft.com/office/drawing/2014/main" id="{323C2E3C-1C90-4764-88B0-5CCD504D310B}"/>
+                <a16:creationId xmlns:a16="http://schemas.microsoft.com/office/drawing/2014/main" id="{84999EF9-FB74-4569-8891-6EF54A8E1B52}"/>
               </a:ext>
             </a:extLst>
           </p:cNvPr>
@@ -3342,7 +3342,7 @@
           <p:cNvPr id="2" name="slide-subtitle">
             <a:extLst xmlns:a="http://schemas.openxmlformats.org/drawingml/2006/main">
               <a:ext uri="{FF2B5EF4-FFF2-40B4-BE49-F238E27FC236}">
-                <a16:creationId xmlns:a16="http://schemas.microsoft.com/office/drawing/2014/main" id="{D64FB2E2-A48D-405B-B2B7-D1844D10A54A}"/>
+                <a16:creationId xmlns:a16="http://schemas.microsoft.com/office/drawing/2014/main" id="{32B87372-D009-4A16-8351-D8C4479F11D4}"/>
               </a:ext>
             </a:extLst>
           </p:cNvPr>
@@ -3387,7 +3387,7 @@
           <p:cNvPr id="3" name="bullet-0">
             <a:extLst xmlns:a="http://schemas.openxmlformats.org/drawingml/2006/main">
               <a:ext uri="{FF2B5EF4-FFF2-40B4-BE49-F238E27FC236}">
-                <a16:creationId xmlns:a16="http://schemas.microsoft.com/office/drawing/2014/main" id="{DF56953A-0BBE-484A-8CBE-188E85E755B4}"/>
+                <a16:creationId xmlns:a16="http://schemas.microsoft.com/office/drawing/2014/main" id="{533A18A6-F9DA-4CF6-BD84-048C157783FC}"/>
               </a:ext>
             </a:extLst>
           </p:cNvPr>
@@ -3432,7 +3432,7 @@
           <p:cNvPr id="4" name="bullet-1">
             <a:extLst xmlns:a="http://schemas.openxmlformats.org/drawingml/2006/main">
               <a:ext uri="{FF2B5EF4-FFF2-40B4-BE49-F238E27FC236}">
-                <a16:creationId xmlns:a16="http://schemas.microsoft.com/office/drawing/2014/main" id="{B19A5BBC-E264-4823-8848-F1ACE251DDA0}"/>
+                <a16:creationId xmlns:a16="http://schemas.microsoft.com/office/drawing/2014/main" id="{AD575F2C-D2F4-4854-B99D-2F9B8492E383}"/>
               </a:ext>
             </a:extLst>
           </p:cNvPr>
@@ -3477,7 +3477,7 @@
           <p:cNvPr id="5" name="bullet-2">
             <a:extLst xmlns:a="http://schemas.openxmlformats.org/drawingml/2006/main">
               <a:ext uri="{FF2B5EF4-FFF2-40B4-BE49-F238E27FC236}">
-                <a16:creationId xmlns:a16="http://schemas.microsoft.com/office/drawing/2014/main" id="{96FA1477-47B0-4E1E-8B54-BDFD1E771AD8}"/>
+                <a16:creationId xmlns:a16="http://schemas.microsoft.com/office/drawing/2014/main" id="{60DA081A-5D40-44D5-9155-012090E6BF9F}"/>
               </a:ext>
             </a:extLst>
           </p:cNvPr>
@@ -3522,7 +3522,7 @@
           <p:cNvPr id="6" name="bullet-3">
             <a:extLst xmlns:a="http://schemas.openxmlformats.org/drawingml/2006/main">
               <a:ext uri="{FF2B5EF4-FFF2-40B4-BE49-F238E27FC236}">
-                <a16:creationId xmlns:a16="http://schemas.microsoft.com/office/drawing/2014/main" id="{59D4CED5-2218-4964-AD26-F545792674CC}"/>
+                <a16:creationId xmlns:a16="http://schemas.microsoft.com/office/drawing/2014/main" id="{9E211A04-BCDB-43FE-AA59-FC67B0A67D4B}"/>
               </a:ext>
             </a:extLst>
           </p:cNvPr>
@@ -3557,7 +3557,7 @@
                   <a:srgbClr val="000000"/>
                 </a:solidFill>
               </a:rPr>
-              <a:t>Sticky margin</a:t>
+              <a:t>Close-score tie margin</a:t>
             </a:r>
           </a:p>
         </p:txBody>
@@ -3567,7 +3567,7 @@
           <p:cNvPr id="7" name="bullet-4">
             <a:extLst xmlns:a="http://schemas.openxmlformats.org/drawingml/2006/main">
               <a:ext uri="{FF2B5EF4-FFF2-40B4-BE49-F238E27FC236}">
-                <a16:creationId xmlns:a16="http://schemas.microsoft.com/office/drawing/2014/main" id="{4A9D07BF-FC84-4416-9B87-04F82C0CCAD9}"/>
+                <a16:creationId xmlns:a16="http://schemas.microsoft.com/office/drawing/2014/main" id="{7BD16120-F230-4EEA-8D9B-16A7513558A1}"/>
               </a:ext>
             </a:extLst>
           </p:cNvPr>
@@ -3612,7 +3612,7 @@
           <p:cNvPr id="8" name="bullet-0">
             <a:extLst xmlns:a="http://schemas.openxmlformats.org/drawingml/2006/main">
               <a:ext uri="{FF2B5EF4-FFF2-40B4-BE49-F238E27FC236}">
-                <a16:creationId xmlns:a16="http://schemas.microsoft.com/office/drawing/2014/main" id="{6F28B9DA-85B0-4247-A0EC-C4BDAE4423BD}"/>
+                <a16:creationId xmlns:a16="http://schemas.microsoft.com/office/drawing/2014/main" id="{3E86E5AF-F942-46FA-A754-0F4CC4951B58}"/>
               </a:ext>
             </a:extLst>
           </p:cNvPr>
@@ -3657,7 +3657,7 @@
           <p:cNvPr id="9" name="bullet-1">
             <a:extLst xmlns:a="http://schemas.openxmlformats.org/drawingml/2006/main">
               <a:ext uri="{FF2B5EF4-FFF2-40B4-BE49-F238E27FC236}">
-                <a16:creationId xmlns:a16="http://schemas.microsoft.com/office/drawing/2014/main" id="{65A09F95-931F-4014-9DEE-F46C9679A0FC}"/>
+                <a16:creationId xmlns:a16="http://schemas.microsoft.com/office/drawing/2014/main" id="{A1328869-C281-470C-850B-1176798319A8}"/>
               </a:ext>
             </a:extLst>
           </p:cNvPr>
@@ -3702,7 +3702,7 @@
           <p:cNvPr id="10" name="bullet-2">
             <a:extLst xmlns:a="http://schemas.openxmlformats.org/drawingml/2006/main">
               <a:ext uri="{FF2B5EF4-FFF2-40B4-BE49-F238E27FC236}">
-                <a16:creationId xmlns:a16="http://schemas.microsoft.com/office/drawing/2014/main" id="{A81928B6-E080-410F-8874-9F28A87C2D3B}"/>
+                <a16:creationId xmlns:a16="http://schemas.microsoft.com/office/drawing/2014/main" id="{326EFBA0-BFF5-46EE-995E-729BE297F442}"/>
               </a:ext>
             </a:extLst>
           </p:cNvPr>
@@ -3747,7 +3747,7 @@
           <p:cNvPr id="11" name="bullet-3">
             <a:extLst xmlns:a="http://schemas.openxmlformats.org/drawingml/2006/main">
               <a:ext uri="{FF2B5EF4-FFF2-40B4-BE49-F238E27FC236}">
-                <a16:creationId xmlns:a16="http://schemas.microsoft.com/office/drawing/2014/main" id="{B8C4D755-3C14-450F-B4AC-98322BC2F0F4}"/>
+                <a16:creationId xmlns:a16="http://schemas.microsoft.com/office/drawing/2014/main" id="{FBCC179E-2C70-4D76-8AC5-204C0D769780}"/>
               </a:ext>
             </a:extLst>
           </p:cNvPr>
@@ -3792,7 +3792,7 @@
           <p:cNvPr id="12" name="bullet-4">
             <a:extLst xmlns:a="http://schemas.openxmlformats.org/drawingml/2006/main">
               <a:ext uri="{FF2B5EF4-FFF2-40B4-BE49-F238E27FC236}">
-                <a16:creationId xmlns:a16="http://schemas.microsoft.com/office/drawing/2014/main" id="{FFC7CD12-8F3F-4B56-81D8-FD5026CF9939}"/>
+                <a16:creationId xmlns:a16="http://schemas.microsoft.com/office/drawing/2014/main" id="{AC5DBCF9-B924-4F07-AA94-85CDB0DF3D19}"/>
               </a:ext>
             </a:extLst>
           </p:cNvPr>
@@ -3837,7 +3837,7 @@
           <p:cNvPr id="13" name="audit-footer">
             <a:extLst xmlns:a="http://schemas.openxmlformats.org/drawingml/2006/main">
               <a:ext uri="{FF2B5EF4-FFF2-40B4-BE49-F238E27FC236}">
-                <a16:creationId xmlns:a16="http://schemas.microsoft.com/office/drawing/2014/main" id="{EDF40885-3530-45B3-8528-367CFA75994A}"/>
+                <a16:creationId xmlns:a16="http://schemas.microsoft.com/office/drawing/2014/main" id="{78DE6711-6E06-448E-9DEC-71D768F56F71}"/>
               </a:ext>
             </a:extLst>
           </p:cNvPr>
@@ -3872,7 +3872,7 @@
                   <a:srgbClr val="000000"/>
                 </a:solidFill>
               </a:rPr>
-              <a:t>Ledger: 290 candidates, 225 valid scored rows, 65 fail-closed rows. Malformed or crashed candidates receive combined_score = -10.0.</a:t>
+              <a:t>Ledger: 374 candidates, 306 valid scored rows, 68 fail-closed rows. Malformed or crashed candidates receive combined_score = -10.0.</a:t>
             </a:r>
           </a:p>
         </p:txBody>
@@ -3880,7 +3880,7 @@
     </p:spTree>
     <p:extLst>
       <p:ext uri="{BB962C8B-B14F-4D97-AF65-F5344CB8AC3E}">
-        <p14:creationId xmlns:p14="http://schemas.microsoft.com/office/powerpoint/2010/main" val="1974124328"/>
+        <p14:creationId xmlns:p14="http://schemas.microsoft.com/office/powerpoint/2010/main" val="946590634"/>
       </p:ext>
     </p:extLst>
   </p:cSld>
@@ -3904,7 +3904,7 @@
           <p:cNvPr id="1" name="slide-title">
             <a:extLst xmlns:a="http://schemas.openxmlformats.org/drawingml/2006/main">
               <a:ext uri="{FF2B5EF4-FFF2-40B4-BE49-F238E27FC236}">
-                <a16:creationId xmlns:a16="http://schemas.microsoft.com/office/drawing/2014/main" id="{19259C1E-A69E-4274-A302-5F2B359F9DC5}"/>
+                <a16:creationId xmlns:a16="http://schemas.microsoft.com/office/drawing/2014/main" id="{CDE71314-FEF3-4012-9899-198067EE6C7F}"/>
               </a:ext>
             </a:extLst>
           </p:cNvPr>
@@ -3939,7 +3939,7 @@
                   <a:srgbClr val="000000"/>
                 </a:solidFill>
               </a:rPr>
-              <a:t>Defensible claims</a:t>
+              <a:t>Result scope</a:t>
             </a:r>
           </a:p>
         </p:txBody>
@@ -3949,7 +3949,7 @@
           <p:cNvPr id="2" name="title-rule">
             <a:extLst xmlns:a="http://schemas.openxmlformats.org/drawingml/2006/main">
               <a:ext uri="{FF2B5EF4-FFF2-40B4-BE49-F238E27FC236}">
-                <a16:creationId xmlns:a16="http://schemas.microsoft.com/office/drawing/2014/main" id="{6E04370D-F7D2-40C2-80B1-B99CFA7E3E06}"/>
+                <a16:creationId xmlns:a16="http://schemas.microsoft.com/office/drawing/2014/main" id="{22BF7ACC-F3B8-49DC-B9D5-9C4A9A860B71}"/>
               </a:ext>
             </a:extLst>
           </p:cNvPr>
@@ -3982,7 +3982,7 @@
           <p:cNvPr id="3" name="bullet-0">
             <a:extLst xmlns:a="http://schemas.openxmlformats.org/drawingml/2006/main">
               <a:ext uri="{FF2B5EF4-FFF2-40B4-BE49-F238E27FC236}">
-                <a16:creationId xmlns:a16="http://schemas.microsoft.com/office/drawing/2014/main" id="{E711528A-4243-4C4B-A49F-D4691157637E}"/>
+                <a16:creationId xmlns:a16="http://schemas.microsoft.com/office/drawing/2014/main" id="{7A83D5B1-9A72-451F-AE03-79FE2EBA9BC1}"/>
               </a:ext>
             </a:extLst>
           </p:cNvPr>
@@ -4017,7 +4017,7 @@
                   <a:srgbClr val="000000"/>
                 </a:solidFill>
               </a:rPr>
-              <a:t>Primary claim: OpenEvolve improves IPC speedup over disabled prefetching on 13 training-validation traces.</a:t>
+              <a:t>Primary claim: OpenEvolve improves IPC speedup over disabled prefetching on 13 training-split validation traces.</a:t>
             </a:r>
           </a:p>
         </p:txBody>
@@ -4027,7 +4027,7 @@
           <p:cNvPr id="4" name="bullet-1">
             <a:extLst xmlns:a="http://schemas.openxmlformats.org/drawingml/2006/main">
               <a:ext uri="{FF2B5EF4-FFF2-40B4-BE49-F238E27FC236}">
-                <a16:creationId xmlns:a16="http://schemas.microsoft.com/office/drawing/2014/main" id="{82979D49-91FF-4385-8686-F429738594B0}"/>
+                <a16:creationId xmlns:a16="http://schemas.microsoft.com/office/drawing/2014/main" id="{3A6EA030-49E3-4568-96F4-38A1D5C3D877}"/>
               </a:ext>
             </a:extLst>
           </p:cNvPr>
@@ -4062,7 +4062,7 @@
                   <a:srgbClr val="000000"/>
                 </a:solidFill>
               </a:rPr>
-              <a:t>Heldout claim: the selected router reaches 1.0033x over disabled prefetching on seven heldout traces.</a:t>
+              <a:t>Heldout claim: the selected router reaches 1.003x over disabled prefetching on seven heldout traces.</a:t>
             </a:r>
           </a:p>
         </p:txBody>
@@ -4072,7 +4072,7 @@
           <p:cNvPr id="5" name="bullet-2">
             <a:extLst xmlns:a="http://schemas.openxmlformats.org/drawingml/2006/main">
               <a:ext uri="{FF2B5EF4-FFF2-40B4-BE49-F238E27FC236}">
-                <a16:creationId xmlns:a16="http://schemas.microsoft.com/office/drawing/2014/main" id="{3AB83AD8-3429-42E2-9F13-93ADD8600ED6}"/>
+                <a16:creationId xmlns:a16="http://schemas.microsoft.com/office/drawing/2014/main" id="{23743BB2-0EA5-4A14-BAA0-68095196D8D6}"/>
               </a:ext>
             </a:extLst>
           </p:cNvPr>
@@ -4107,7 +4107,7 @@
                   <a:srgbClr val="000000"/>
                 </a:solidFill>
               </a:rPr>
-              <a:t>Instruction-count ratios stay at 0.999999462x on training validation and 1.000000009x on heldout.</a:t>
+              <a:t>Instruction-count ratios round to 1.000x on training-split validation and heldout.</a:t>
             </a:r>
           </a:p>
         </p:txBody>
@@ -4117,7 +4117,7 @@
           <p:cNvPr id="6" name="bullet-3">
             <a:extLst xmlns:a="http://schemas.openxmlformats.org/drawingml/2006/main">
               <a:ext uri="{FF2B5EF4-FFF2-40B4-BE49-F238E27FC236}">
-                <a16:creationId xmlns:a16="http://schemas.microsoft.com/office/drawing/2014/main" id="{A87EE8C4-75C4-4B08-8A06-2F23EC997FC8}"/>
+                <a16:creationId xmlns:a16="http://schemas.microsoft.com/office/drawing/2014/main" id="{8387B9DB-F188-48B2-ACA7-C565CA7BE3A1}"/>
               </a:ext>
             </a:extLst>
           </p:cNvPr>
@@ -4152,7 +4152,7 @@
                   <a:srgbClr val="000000"/>
                 </a:solidFill>
               </a:rPr>
-              <a:t>The oracle best prefetcher remains a cap, which keeps the claim sized correctly.</a:t>
+              <a:t>The max-prefetcher result remains a cap, which keeps the claim sized correctly.</a:t>
             </a:r>
           </a:p>
         </p:txBody>
@@ -4162,7 +4162,7 @@
           <p:cNvPr id="7" name="bullet-4">
             <a:extLst xmlns:a="http://schemas.openxmlformats.org/drawingml/2006/main">
               <a:ext uri="{FF2B5EF4-FFF2-40B4-BE49-F238E27FC236}">
-                <a16:creationId xmlns:a16="http://schemas.microsoft.com/office/drawing/2014/main" id="{1A6DDB2C-9BD3-4DE5-BBD4-3C12862AA331}"/>
+                <a16:creationId xmlns:a16="http://schemas.microsoft.com/office/drawing/2014/main" id="{F034C608-D0B5-459D-BFAA-F66453FEF673}"/>
               </a:ext>
             </a:extLst>
           </p:cNvPr>
@@ -4205,7 +4205,7 @@
     </p:spTree>
     <p:extLst>
       <p:ext uri="{BB962C8B-B14F-4D97-AF65-F5344CB8AC3E}">
-        <p14:creationId xmlns:p14="http://schemas.microsoft.com/office/powerpoint/2010/main" val="1057278392"/>
+        <p14:creationId xmlns:p14="http://schemas.microsoft.com/office/powerpoint/2010/main" val="171324396"/>
       </p:ext>
     </p:extLst>
   </p:cSld>

</xml_diff>

<commit_message>
Refine MoP report comparison labels
</commit_message>
<xml_diff>
--- a/slides/mop_stage2_final/output/output.pptx
+++ b/slides/mop_stage2_final/output/output.pptx
@@ -2,20 +2,20 @@
 <file path=ppt/presentation.xml><?xml version="1.0" encoding="utf-8"?>
 <p:presentation xmlns:p="http://schemas.openxmlformats.org/presentationml/2006/main">
   <p:sldMasterIdLst>
-    <p:sldMasterId xmlns:r="http://schemas.openxmlformats.org/officeDocument/2006/relationships" id="2147483648" r:id="Rb97ea5b5fba541e7"/>
+    <p:sldMasterId xmlns:r="http://schemas.openxmlformats.org/officeDocument/2006/relationships" id="2147483648" r:id="Rc34897b6653745ca"/>
   </p:sldMasterIdLst>
   <p:notesMasterIdLst>
-    <p:notesMasterId xmlns:r="http://schemas.openxmlformats.org/officeDocument/2006/relationships" r:id="Rcaa9089045eb4ea3"/>
+    <p:notesMasterId xmlns:r="http://schemas.openxmlformats.org/officeDocument/2006/relationships" r:id="R8de70ad532c54a6f"/>
   </p:notesMasterIdLst>
   <p:sldIdLst>
-    <p:sldId xmlns:r="http://schemas.openxmlformats.org/officeDocument/2006/relationships" id="256" r:id="R541fef04852c485e"/>
-    <p:sldId xmlns:r="http://schemas.openxmlformats.org/officeDocument/2006/relationships" id="257" r:id="R86a59238c36246b1"/>
-    <p:sldId xmlns:r="http://schemas.openxmlformats.org/officeDocument/2006/relationships" id="258" r:id="R2e4970b645d745c7"/>
-    <p:sldId xmlns:r="http://schemas.openxmlformats.org/officeDocument/2006/relationships" id="259" r:id="Reed6a62ee5974450"/>
-    <p:sldId xmlns:r="http://schemas.openxmlformats.org/officeDocument/2006/relationships" id="260" r:id="Rb032cefd191f4b88"/>
-    <p:sldId xmlns:r="http://schemas.openxmlformats.org/officeDocument/2006/relationships" id="261" r:id="R9980df2e40fa4837"/>
-    <p:sldId xmlns:r="http://schemas.openxmlformats.org/officeDocument/2006/relationships" id="262" r:id="Re37d376f8b9a4df7"/>
-    <p:sldId xmlns:r="http://schemas.openxmlformats.org/officeDocument/2006/relationships" id="263" r:id="Rdf5c3f8aa7d54882"/>
+    <p:sldId xmlns:r="http://schemas.openxmlformats.org/officeDocument/2006/relationships" id="256" r:id="Re54b36cd8d9745d0"/>
+    <p:sldId xmlns:r="http://schemas.openxmlformats.org/officeDocument/2006/relationships" id="257" r:id="Rc03fad26f12a4b4f"/>
+    <p:sldId xmlns:r="http://schemas.openxmlformats.org/officeDocument/2006/relationships" id="258" r:id="Rbddc7b3f5f2d4b58"/>
+    <p:sldId xmlns:r="http://schemas.openxmlformats.org/officeDocument/2006/relationships" id="259" r:id="R70cb93a8b180440a"/>
+    <p:sldId xmlns:r="http://schemas.openxmlformats.org/officeDocument/2006/relationships" id="260" r:id="Ra32f680f02e24ed1"/>
+    <p:sldId xmlns:r="http://schemas.openxmlformats.org/officeDocument/2006/relationships" id="261" r:id="R4498e938d85f4e52"/>
+    <p:sldId xmlns:r="http://schemas.openxmlformats.org/officeDocument/2006/relationships" id="262" r:id="Ra1c46d8d593a4d3b"/>
+    <p:sldId xmlns:r="http://schemas.openxmlformats.org/officeDocument/2006/relationships" id="263" r:id="R0beba393b7604a99"/>
   </p:sldIdLst>
   <p:sldSz cx="18288000" cy="10287000"/>
   <p:notesSz cx="6858000" cy="9144000"/>
@@ -1024,7 +1024,7 @@
   </p:cSld>
   <p:clrMap bg1="lt1" tx1="dk1" bg2="lt2" tx2="dk2" accent1="accent1" accent2="accent2" accent3="accent3" accent4="accent4" accent5="accent5" accent6="accent6" hlink="hlink" folHlink="folHlink"/>
   <p:sldLayoutIdLst>
-    <p:sldLayoutId xmlns:r="http://schemas.openxmlformats.org/officeDocument/2006/relationships" id="2147483649" r:id="R4d1c8fdab5ba444f"/>
+    <p:sldLayoutId xmlns:r="http://schemas.openxmlformats.org/officeDocument/2006/relationships" id="2147483649" r:id="R28acac464e484aaa"/>
   </p:sldLayoutIdLst>
   <p:txStyles>
     <p:titleStyle>
@@ -1323,7 +1323,7 @@
           <p:cNvPr id="1" name="cover-title">
             <a:extLst xmlns:a="http://schemas.openxmlformats.org/drawingml/2006/main">
               <a:ext uri="{FF2B5EF4-FFF2-40B4-BE49-F238E27FC236}">
-                <a16:creationId xmlns:a16="http://schemas.microsoft.com/office/drawing/2014/main" id="{B1D9E271-6B7D-4ABF-86DD-5BF09263D4FC}"/>
+                <a16:creationId xmlns:a16="http://schemas.microsoft.com/office/drawing/2014/main" id="{475C945D-8632-46F1-B80B-783EEFB74CA3}"/>
               </a:ext>
             </a:extLst>
           </p:cNvPr>
@@ -1368,7 +1368,7 @@
           <p:cNvPr id="2" name="cover-rule">
             <a:extLst xmlns:a="http://schemas.openxmlformats.org/drawingml/2006/main">
               <a:ext uri="{FF2B5EF4-FFF2-40B4-BE49-F238E27FC236}">
-                <a16:creationId xmlns:a16="http://schemas.microsoft.com/office/drawing/2014/main" id="{CC0A59B2-C07C-46F2-BB48-211DC64B981F}"/>
+                <a16:creationId xmlns:a16="http://schemas.microsoft.com/office/drawing/2014/main" id="{57E0E18A-83B9-4E30-B713-5276A1D430F2}"/>
               </a:ext>
             </a:extLst>
           </p:cNvPr>
@@ -1401,7 +1401,7 @@
           <p:cNvPr id="3" name="cover-thesis">
             <a:extLst xmlns:a="http://schemas.openxmlformats.org/drawingml/2006/main">
               <a:ext uri="{FF2B5EF4-FFF2-40B4-BE49-F238E27FC236}">
-                <a16:creationId xmlns:a16="http://schemas.microsoft.com/office/drawing/2014/main" id="{C5168F11-3B63-474C-B39F-174542514AD2}"/>
+                <a16:creationId xmlns:a16="http://schemas.microsoft.com/office/drawing/2014/main" id="{A22B6864-14CE-4D0A-9F8C-C26C11CAD8E1}"/>
               </a:ext>
             </a:extLst>
           </p:cNvPr>
@@ -1436,7 +1436,7 @@
                   <a:srgbClr val="000000"/>
                 </a:solidFill>
               </a:rPr>
-              <a:t>A small L2-cache router that improves IPC over disabled prefetching and tracks a max-prefetcher cap</a:t>
+              <a:t>A small L2-cache router that improves IPC over disabled prefetching and tracks a best expert</a:t>
             </a:r>
           </a:p>
         </p:txBody>
@@ -1446,7 +1446,7 @@
           <p:cNvPr id="4" name="cover-metric-1">
             <a:extLst xmlns:a="http://schemas.openxmlformats.org/drawingml/2006/main">
               <a:ext uri="{FF2B5EF4-FFF2-40B4-BE49-F238E27FC236}">
-                <a16:creationId xmlns:a16="http://schemas.microsoft.com/office/drawing/2014/main" id="{323C0642-ED9A-40CD-BDFB-3D55A7D548B4}"/>
+                <a16:creationId xmlns:a16="http://schemas.microsoft.com/office/drawing/2014/main" id="{BC4A56FF-C3E0-4676-AC82-6045907D2CDE}"/>
               </a:ext>
             </a:extLst>
           </p:cNvPr>
@@ -1491,7 +1491,7 @@
           <p:cNvPr id="5" name="cover-label-1">
             <a:extLst xmlns:a="http://schemas.openxmlformats.org/drawingml/2006/main">
               <a:ext uri="{FF2B5EF4-FFF2-40B4-BE49-F238E27FC236}">
-                <a16:creationId xmlns:a16="http://schemas.microsoft.com/office/drawing/2014/main" id="{58C0DB40-2B37-4F21-B043-0CE20E4EE8EC}"/>
+                <a16:creationId xmlns:a16="http://schemas.microsoft.com/office/drawing/2014/main" id="{E236BE90-4D18-4DAA-920E-EA3701305D4C}"/>
               </a:ext>
             </a:extLst>
           </p:cNvPr>
@@ -1536,7 +1536,7 @@
           <p:cNvPr id="6" name="cover-metric-2">
             <a:extLst xmlns:a="http://schemas.openxmlformats.org/drawingml/2006/main">
               <a:ext uri="{FF2B5EF4-FFF2-40B4-BE49-F238E27FC236}">
-                <a16:creationId xmlns:a16="http://schemas.microsoft.com/office/drawing/2014/main" id="{A28CD40B-EA0A-4617-9D26-00637960FA2B}"/>
+                <a16:creationId xmlns:a16="http://schemas.microsoft.com/office/drawing/2014/main" id="{96A094B9-91DF-49F2-B0DD-62F4C5338624}"/>
               </a:ext>
             </a:extLst>
           </p:cNvPr>
@@ -1581,7 +1581,7 @@
           <p:cNvPr id="7" name="cover-label-2">
             <a:extLst xmlns:a="http://schemas.openxmlformats.org/drawingml/2006/main">
               <a:ext uri="{FF2B5EF4-FFF2-40B4-BE49-F238E27FC236}">
-                <a16:creationId xmlns:a16="http://schemas.microsoft.com/office/drawing/2014/main" id="{4967FA06-2230-47D9-BD95-3208BCC233AC}"/>
+                <a16:creationId xmlns:a16="http://schemas.microsoft.com/office/drawing/2014/main" id="{8BD894AA-D2B9-4173-B8B0-8DF32F14B1E7}"/>
               </a:ext>
             </a:extLst>
           </p:cNvPr>
@@ -1626,7 +1626,7 @@
           <p:cNvPr id="8" name="cover-footer">
             <a:extLst xmlns:a="http://schemas.openxmlformats.org/drawingml/2006/main">
               <a:ext uri="{FF2B5EF4-FFF2-40B4-BE49-F238E27FC236}">
-                <a16:creationId xmlns:a16="http://schemas.microsoft.com/office/drawing/2014/main" id="{8E72C5E5-5072-4143-B898-2CCAF8A15392}"/>
+                <a16:creationId xmlns:a16="http://schemas.microsoft.com/office/drawing/2014/main" id="{C3D55F56-0AFB-43FD-B2E2-FFF95E6B3B66}"/>
               </a:ext>
             </a:extLst>
           </p:cNvPr>
@@ -1669,7 +1669,7 @@
     </p:spTree>
     <p:extLst>
       <p:ext uri="{BB962C8B-B14F-4D97-AF65-F5344CB8AC3E}">
-        <p14:creationId xmlns:p14="http://schemas.microsoft.com/office/powerpoint/2010/main" val="1897524092"/>
+        <p14:creationId xmlns:p14="http://schemas.microsoft.com/office/powerpoint/2010/main" val="329904110"/>
       </p:ext>
     </p:extLst>
   </p:cSld>
@@ -1693,7 +1693,7 @@
           <p:cNvPr id="1" name="slide-title">
             <a:extLst xmlns:a="http://schemas.openxmlformats.org/drawingml/2006/main">
               <a:ext uri="{FF2B5EF4-FFF2-40B4-BE49-F238E27FC236}">
-                <a16:creationId xmlns:a16="http://schemas.microsoft.com/office/drawing/2014/main" id="{EF4478CD-5C94-4315-9E02-A0B4D87C8B47}"/>
+                <a16:creationId xmlns:a16="http://schemas.microsoft.com/office/drawing/2014/main" id="{6AC8F621-532A-4912-A4F8-C2CF48E195F7}"/>
               </a:ext>
             </a:extLst>
           </p:cNvPr>
@@ -1738,7 +1738,7 @@
           <p:cNvPr id="2" name="slide-subtitle">
             <a:extLst xmlns:a="http://schemas.openxmlformats.org/drawingml/2006/main">
               <a:ext uri="{FF2B5EF4-FFF2-40B4-BE49-F238E27FC236}">
-                <a16:creationId xmlns:a16="http://schemas.microsoft.com/office/drawing/2014/main" id="{1DE4A1F0-6B6D-4E54-811F-E294F4B53B16}"/>
+                <a16:creationId xmlns:a16="http://schemas.microsoft.com/office/drawing/2014/main" id="{605A8200-A41B-43F7-9215-F6C6D4F55BC7}"/>
               </a:ext>
             </a:extLst>
           </p:cNvPr>
@@ -1783,7 +1783,7 @@
           <p:cNvPr id="3" name="bullet-0">
             <a:extLst xmlns:a="http://schemas.openxmlformats.org/drawingml/2006/main">
               <a:ext uri="{FF2B5EF4-FFF2-40B4-BE49-F238E27FC236}">
-                <a16:creationId xmlns:a16="http://schemas.microsoft.com/office/drawing/2014/main" id="{FD584007-CB25-4888-9E69-6F8C6596BD06}"/>
+                <a16:creationId xmlns:a16="http://schemas.microsoft.com/office/drawing/2014/main" id="{A7234944-4276-4D78-9807-E0C2F436251B}"/>
               </a:ext>
             </a:extLst>
           </p:cNvPr>
@@ -1828,7 +1828,7 @@
           <p:cNvPr id="4" name="bullet-1">
             <a:extLst xmlns:a="http://schemas.openxmlformats.org/drawingml/2006/main">
               <a:ext uri="{FF2B5EF4-FFF2-40B4-BE49-F238E27FC236}">
-                <a16:creationId xmlns:a16="http://schemas.microsoft.com/office/drawing/2014/main" id="{8E3F2E55-AAA3-438F-A136-E5759318D387}"/>
+                <a16:creationId xmlns:a16="http://schemas.microsoft.com/office/drawing/2014/main" id="{95DA2A30-07EB-4F53-B9A7-9613927EA34B}"/>
               </a:ext>
             </a:extLst>
           </p:cNvPr>
@@ -1873,7 +1873,7 @@
           <p:cNvPr id="5" name="bullet-2">
             <a:extLst xmlns:a="http://schemas.openxmlformats.org/drawingml/2006/main">
               <a:ext uri="{FF2B5EF4-FFF2-40B4-BE49-F238E27FC236}">
-                <a16:creationId xmlns:a16="http://schemas.microsoft.com/office/drawing/2014/main" id="{F140D8F2-0FFE-455B-92C0-7EACFB658276}"/>
+                <a16:creationId xmlns:a16="http://schemas.microsoft.com/office/drawing/2014/main" id="{65266A7C-8162-4DFD-8F15-93E54FF92440}"/>
               </a:ext>
             </a:extLst>
           </p:cNvPr>
@@ -1918,7 +1918,7 @@
           <p:cNvPr id="6" name="bullet-3">
             <a:extLst xmlns:a="http://schemas.openxmlformats.org/drawingml/2006/main">
               <a:ext uri="{FF2B5EF4-FFF2-40B4-BE49-F238E27FC236}">
-                <a16:creationId xmlns:a16="http://schemas.microsoft.com/office/drawing/2014/main" id="{DCB61D84-44F2-45CF-B670-84DE40AC7D8B}"/>
+                <a16:creationId xmlns:a16="http://schemas.microsoft.com/office/drawing/2014/main" id="{13ACDF4F-D97E-49C6-B473-7ADC9CB2FC94}"/>
               </a:ext>
             </a:extLst>
           </p:cNvPr>
@@ -1963,7 +1963,7 @@
           <p:cNvPr id="7" name="bullet-0">
             <a:extLst xmlns:a="http://schemas.openxmlformats.org/drawingml/2006/main">
               <a:ext uri="{FF2B5EF4-FFF2-40B4-BE49-F238E27FC236}">
-                <a16:creationId xmlns:a16="http://schemas.microsoft.com/office/drawing/2014/main" id="{CD5B43D6-74DB-4289-8AB6-E1729A49A731}"/>
+                <a16:creationId xmlns:a16="http://schemas.microsoft.com/office/drawing/2014/main" id="{9DF53EBD-3394-491C-A4FA-818B45BFE588}"/>
               </a:ext>
             </a:extLst>
           </p:cNvPr>
@@ -2008,7 +2008,7 @@
           <p:cNvPr id="8" name="bullet-1">
             <a:extLst xmlns:a="http://schemas.openxmlformats.org/drawingml/2006/main">
               <a:ext uri="{FF2B5EF4-FFF2-40B4-BE49-F238E27FC236}">
-                <a16:creationId xmlns:a16="http://schemas.microsoft.com/office/drawing/2014/main" id="{AFB4DE54-1214-443C-A297-BCE926B99E3C}"/>
+                <a16:creationId xmlns:a16="http://schemas.microsoft.com/office/drawing/2014/main" id="{9F029564-E27A-45FF-AD5F-B7E76F251E9D}"/>
               </a:ext>
             </a:extLst>
           </p:cNvPr>
@@ -2053,7 +2053,7 @@
           <p:cNvPr id="9" name="bullet-2">
             <a:extLst xmlns:a="http://schemas.openxmlformats.org/drawingml/2006/main">
               <a:ext uri="{FF2B5EF4-FFF2-40B4-BE49-F238E27FC236}">
-                <a16:creationId xmlns:a16="http://schemas.microsoft.com/office/drawing/2014/main" id="{272942B9-B42F-46DB-8C16-88E6BCDB710C}"/>
+                <a16:creationId xmlns:a16="http://schemas.microsoft.com/office/drawing/2014/main" id="{13EF5956-18B5-40BE-933B-8493027CF2F4}"/>
               </a:ext>
             </a:extLst>
           </p:cNvPr>
@@ -2098,7 +2098,7 @@
           <p:cNvPr id="10" name="bullet-3">
             <a:extLst xmlns:a="http://schemas.openxmlformats.org/drawingml/2006/main">
               <a:ext uri="{FF2B5EF4-FFF2-40B4-BE49-F238E27FC236}">
-                <a16:creationId xmlns:a16="http://schemas.microsoft.com/office/drawing/2014/main" id="{005BC0AA-1179-465F-BA6E-E1B193A013FF}"/>
+                <a16:creationId xmlns:a16="http://schemas.microsoft.com/office/drawing/2014/main" id="{E87C9C39-24A6-4473-AB54-D6E27EBF54A5}"/>
               </a:ext>
             </a:extLst>
           </p:cNvPr>
@@ -2143,7 +2143,7 @@
           <p:cNvPr id="11" name="bullet-0">
             <a:extLst xmlns:a="http://schemas.openxmlformats.org/drawingml/2006/main">
               <a:ext uri="{FF2B5EF4-FFF2-40B4-BE49-F238E27FC236}">
-                <a16:creationId xmlns:a16="http://schemas.microsoft.com/office/drawing/2014/main" id="{FBB50F64-84DB-408E-A770-254FAF7A6FEC}"/>
+                <a16:creationId xmlns:a16="http://schemas.microsoft.com/office/drawing/2014/main" id="{C07C0C43-EDD3-46A5-9278-97774879369F}"/>
               </a:ext>
             </a:extLst>
           </p:cNvPr>
@@ -2188,7 +2188,7 @@
           <p:cNvPr id="12" name="bullet-1">
             <a:extLst xmlns:a="http://schemas.openxmlformats.org/drawingml/2006/main">
               <a:ext uri="{FF2B5EF4-FFF2-40B4-BE49-F238E27FC236}">
-                <a16:creationId xmlns:a16="http://schemas.microsoft.com/office/drawing/2014/main" id="{D70FA189-B11D-40CB-83E2-4BB9D5D9A799}"/>
+                <a16:creationId xmlns:a16="http://schemas.microsoft.com/office/drawing/2014/main" id="{6359E46B-6B19-403D-824E-B3AA0762055F}"/>
               </a:ext>
             </a:extLst>
           </p:cNvPr>
@@ -2233,7 +2233,7 @@
           <p:cNvPr id="13" name="bullet-2">
             <a:extLst xmlns:a="http://schemas.openxmlformats.org/drawingml/2006/main">
               <a:ext uri="{FF2B5EF4-FFF2-40B4-BE49-F238E27FC236}">
-                <a16:creationId xmlns:a16="http://schemas.microsoft.com/office/drawing/2014/main" id="{23A863B5-8D42-48DB-A7EC-E597CAC7F995}"/>
+                <a16:creationId xmlns:a16="http://schemas.microsoft.com/office/drawing/2014/main" id="{0A19E10B-0F96-4C13-8923-8689584465FD}"/>
               </a:ext>
             </a:extLst>
           </p:cNvPr>
@@ -2278,7 +2278,7 @@
           <p:cNvPr id="14" name="bullet-3">
             <a:extLst xmlns:a="http://schemas.openxmlformats.org/drawingml/2006/main">
               <a:ext uri="{FF2B5EF4-FFF2-40B4-BE49-F238E27FC236}">
-                <a16:creationId xmlns:a16="http://schemas.microsoft.com/office/drawing/2014/main" id="{88694F18-B65C-4E5C-925C-C96CB01E099F}"/>
+                <a16:creationId xmlns:a16="http://schemas.microsoft.com/office/drawing/2014/main" id="{281ACC87-9F8E-4423-B922-38A227140252}"/>
               </a:ext>
             </a:extLst>
           </p:cNvPr>
@@ -2321,7 +2321,7 @@
     </p:spTree>
     <p:extLst>
       <p:ext uri="{BB962C8B-B14F-4D97-AF65-F5344CB8AC3E}">
-        <p14:creationId xmlns:p14="http://schemas.microsoft.com/office/powerpoint/2010/main" val="1491779600"/>
+        <p14:creationId xmlns:p14="http://schemas.microsoft.com/office/powerpoint/2010/main" val="1736625267"/>
       </p:ext>
     </p:extLst>
   </p:cSld>
@@ -2345,7 +2345,7 @@
           <p:cNvPr id="1" name="slide-title">
             <a:extLst xmlns:a="http://schemas.openxmlformats.org/drawingml/2006/main">
               <a:ext uri="{FF2B5EF4-FFF2-40B4-BE49-F238E27FC236}">
-                <a16:creationId xmlns:a16="http://schemas.microsoft.com/office/drawing/2014/main" id="{D0982A84-43E7-45DD-9973-3B8E1D2B2E66}"/>
+                <a16:creationId xmlns:a16="http://schemas.microsoft.com/office/drawing/2014/main" id="{9EC8D094-0DE6-4E02-89C2-FA1C78D29BA1}"/>
               </a:ext>
             </a:extLst>
           </p:cNvPr>
@@ -2390,7 +2390,7 @@
           <p:cNvPr id="2" name="title-rule">
             <a:extLst xmlns:a="http://schemas.openxmlformats.org/drawingml/2006/main">
               <a:ext uri="{FF2B5EF4-FFF2-40B4-BE49-F238E27FC236}">
-                <a16:creationId xmlns:a16="http://schemas.microsoft.com/office/drawing/2014/main" id="{18EF9D30-CAF1-4BB3-AC24-1672EB7C73E6}"/>
+                <a16:creationId xmlns:a16="http://schemas.microsoft.com/office/drawing/2014/main" id="{472254C1-B22F-4DE5-ABAB-087015A81FB9}"/>
               </a:ext>
             </a:extLst>
           </p:cNvPr>
@@ -2423,7 +2423,7 @@
           <p:cNvPr id="3" name="bullet-0">
             <a:extLst xmlns:a="http://schemas.openxmlformats.org/drawingml/2006/main">
               <a:ext uri="{FF2B5EF4-FFF2-40B4-BE49-F238E27FC236}">
-                <a16:creationId xmlns:a16="http://schemas.microsoft.com/office/drawing/2014/main" id="{34D49833-2636-436E-BB93-F6F0F472D69F}"/>
+                <a16:creationId xmlns:a16="http://schemas.microsoft.com/office/drawing/2014/main" id="{D5E9AEC3-8C02-4694-B543-EB9CEBE4B5EF}"/>
               </a:ext>
             </a:extLst>
           </p:cNvPr>
@@ -2468,7 +2468,7 @@
           <p:cNvPr id="4" name="bullet-1">
             <a:extLst xmlns:a="http://schemas.openxmlformats.org/drawingml/2006/main">
               <a:ext uri="{FF2B5EF4-FFF2-40B4-BE49-F238E27FC236}">
-                <a16:creationId xmlns:a16="http://schemas.microsoft.com/office/drawing/2014/main" id="{A36CBF26-BD67-4A1C-9ED6-2BC3E93102ED}"/>
+                <a16:creationId xmlns:a16="http://schemas.microsoft.com/office/drawing/2014/main" id="{F61ED92A-932B-4E2A-A09C-9A28628BBDB4}"/>
               </a:ext>
             </a:extLst>
           </p:cNvPr>
@@ -2513,7 +2513,7 @@
           <p:cNvPr id="5" name="bullet-2">
             <a:extLst xmlns:a="http://schemas.openxmlformats.org/drawingml/2006/main">
               <a:ext uri="{FF2B5EF4-FFF2-40B4-BE49-F238E27FC236}">
-                <a16:creationId xmlns:a16="http://schemas.microsoft.com/office/drawing/2014/main" id="{125B4177-125F-4B67-91CA-545D986D4A23}"/>
+                <a16:creationId xmlns:a16="http://schemas.microsoft.com/office/drawing/2014/main" id="{0EFC826F-4ED3-4522-A2F2-A7F7211F22AA}"/>
               </a:ext>
             </a:extLst>
           </p:cNvPr>
@@ -2558,7 +2558,7 @@
           <p:cNvPr id="6" name="bullet-3">
             <a:extLst xmlns:a="http://schemas.openxmlformats.org/drawingml/2006/main">
               <a:ext uri="{FF2B5EF4-FFF2-40B4-BE49-F238E27FC236}">
-                <a16:creationId xmlns:a16="http://schemas.microsoft.com/office/drawing/2014/main" id="{AA721705-F2D2-49D6-8A6E-5E6919CC6C0F}"/>
+                <a16:creationId xmlns:a16="http://schemas.microsoft.com/office/drawing/2014/main" id="{5EC19B2C-5691-4B55-A0FA-9C1CC9CBE1D5}"/>
               </a:ext>
             </a:extLst>
           </p:cNvPr>
@@ -2603,7 +2603,7 @@
           <p:cNvPr id="7" name="bullet-4">
             <a:extLst xmlns:a="http://schemas.openxmlformats.org/drawingml/2006/main">
               <a:ext uri="{FF2B5EF4-FFF2-40B4-BE49-F238E27FC236}">
-                <a16:creationId xmlns:a16="http://schemas.microsoft.com/office/drawing/2014/main" id="{7700925D-EF51-4B69-B0B6-584AECBA668A}"/>
+                <a16:creationId xmlns:a16="http://schemas.microsoft.com/office/drawing/2014/main" id="{0FB5EB21-C306-465B-ABB4-76E46B314129}"/>
               </a:ext>
             </a:extLst>
           </p:cNvPr>
@@ -2648,7 +2648,7 @@
           <p:cNvPr id="8" name="bullet-0">
             <a:extLst xmlns:a="http://schemas.openxmlformats.org/drawingml/2006/main">
               <a:ext uri="{FF2B5EF4-FFF2-40B4-BE49-F238E27FC236}">
-                <a16:creationId xmlns:a16="http://schemas.microsoft.com/office/drawing/2014/main" id="{C1C48BC9-7C8F-4252-8792-CB408A1F6FD6}"/>
+                <a16:creationId xmlns:a16="http://schemas.microsoft.com/office/drawing/2014/main" id="{2C8E04B7-8AEF-46CE-BF76-9AEE7AE63D9B}"/>
               </a:ext>
             </a:extLst>
           </p:cNvPr>
@@ -2693,7 +2693,7 @@
           <p:cNvPr id="9" name="bullet-1">
             <a:extLst xmlns:a="http://schemas.openxmlformats.org/drawingml/2006/main">
               <a:ext uri="{FF2B5EF4-FFF2-40B4-BE49-F238E27FC236}">
-                <a16:creationId xmlns:a16="http://schemas.microsoft.com/office/drawing/2014/main" id="{27A04A6D-EEDE-4497-902C-40AC710D33CE}"/>
+                <a16:creationId xmlns:a16="http://schemas.microsoft.com/office/drawing/2014/main" id="{9D522EAF-E059-402D-A02F-ECD0BE1145BF}"/>
               </a:ext>
             </a:extLst>
           </p:cNvPr>
@@ -2728,7 +2728,7 @@
                   <a:srgbClr val="000000"/>
                 </a:solidFill>
               </a:rPr>
-              <a:t>Max-prefetcher cap: max(MLOP, SPP+PPF) per trace</a:t>
+              <a:t>Best expert: max(MLOP, SPP+PPF) per trace</a:t>
             </a:r>
           </a:p>
         </p:txBody>
@@ -2738,7 +2738,7 @@
           <p:cNvPr id="10" name="bullet-2">
             <a:extLst xmlns:a="http://schemas.openxmlformats.org/drawingml/2006/main">
               <a:ext uri="{FF2B5EF4-FFF2-40B4-BE49-F238E27FC236}">
-                <a16:creationId xmlns:a16="http://schemas.microsoft.com/office/drawing/2014/main" id="{1DC49729-D92C-42B3-8200-1324FA66E9DF}"/>
+                <a16:creationId xmlns:a16="http://schemas.microsoft.com/office/drawing/2014/main" id="{8C487507-A9C0-4E56-B6B2-04FB0D3D4860}"/>
               </a:ext>
             </a:extLst>
           </p:cNvPr>
@@ -2783,7 +2783,7 @@
           <p:cNvPr id="11" name="bullet-3">
             <a:extLst xmlns:a="http://schemas.openxmlformats.org/drawingml/2006/main">
               <a:ext uri="{FF2B5EF4-FFF2-40B4-BE49-F238E27FC236}">
-                <a16:creationId xmlns:a16="http://schemas.microsoft.com/office/drawing/2014/main" id="{5E94F1D2-F6D5-4413-A375-1165CE899642}"/>
+                <a16:creationId xmlns:a16="http://schemas.microsoft.com/office/drawing/2014/main" id="{2BE09F97-C3B3-4873-9D67-962CAC7C57B4}"/>
               </a:ext>
             </a:extLst>
           </p:cNvPr>
@@ -2828,7 +2828,7 @@
           <p:cNvPr id="12" name="protocol-footer">
             <a:extLst xmlns:a="http://schemas.openxmlformats.org/drawingml/2006/main">
               <a:ext uri="{FF2B5EF4-FFF2-40B4-BE49-F238E27FC236}">
-                <a16:creationId xmlns:a16="http://schemas.microsoft.com/office/drawing/2014/main" id="{3CD03036-5F74-4740-B6BE-DE82F45A3849}"/>
+                <a16:creationId xmlns:a16="http://schemas.microsoft.com/office/drawing/2014/main" id="{98DE9E88-F372-4A45-A518-85466FF023E4}"/>
               </a:ext>
             </a:extLst>
           </p:cNvPr>
@@ -2871,7 +2871,7 @@
     </p:spTree>
     <p:extLst>
       <p:ext uri="{BB962C8B-B14F-4D97-AF65-F5344CB8AC3E}">
-        <p14:creationId xmlns:p14="http://schemas.microsoft.com/office/powerpoint/2010/main" val="557165073"/>
+        <p14:creationId xmlns:p14="http://schemas.microsoft.com/office/powerpoint/2010/main" val="460903134"/>
       </p:ext>
     </p:extLst>
   </p:cSld>
@@ -2895,7 +2895,7 @@
           <p:cNvPr id="1" name="slide-title">
             <a:extLst xmlns:a="http://schemas.openxmlformats.org/drawingml/2006/main">
               <a:ext uri="{FF2B5EF4-FFF2-40B4-BE49-F238E27FC236}">
-                <a16:creationId xmlns:a16="http://schemas.microsoft.com/office/drawing/2014/main" id="{CA9EDC0B-6380-4621-98DF-247DE2887323}"/>
+                <a16:creationId xmlns:a16="http://schemas.microsoft.com/office/drawing/2014/main" id="{8DBAC9F2-66B8-4F9E-A912-5965CC859243}"/>
               </a:ext>
             </a:extLst>
           </p:cNvPr>
@@ -2940,7 +2940,7 @@
           <p:cNvPr id="2" name="slide-subtitle">
             <a:extLst xmlns:a="http://schemas.openxmlformats.org/drawingml/2006/main">
               <a:ext uri="{FF2B5EF4-FFF2-40B4-BE49-F238E27FC236}">
-                <a16:creationId xmlns:a16="http://schemas.microsoft.com/office/drawing/2014/main" id="{FA7E48F3-36B1-4C3C-BCC8-C0DCDF0FD116}"/>
+                <a16:creationId xmlns:a16="http://schemas.microsoft.com/office/drawing/2014/main" id="{0465B30B-076D-430D-AAB5-D648CA75FE57}"/>
               </a:ext>
             </a:extLst>
           </p:cNvPr>
@@ -2975,7 +2975,7 @@
                   <a:srgbClr val="000000"/>
                 </a:solidFill>
               </a:rPr>
-              <a:t>Bars use disabled prefetching as 1x. Yellow caps show the per-trace max prefetcher.</a:t>
+              <a:t>Bars use disabled prefetching as 1x. Yellow marks show the per-trace best expert.</a:t>
             </a:r>
           </a:p>
         </p:txBody>
@@ -2989,7 +2989,7 @@
           <p:nvPr/>
         </p:nvPicPr>
         <p:blipFill>
-          <a:blip xmlns:r="http://schemas.openxmlformats.org/officeDocument/2006/relationships" xmlns:a="http://schemas.openxmlformats.org/drawingml/2006/main" r:embed="R39e152a34be74386"/>
+          <a:blip xmlns:r="http://schemas.openxmlformats.org/officeDocument/2006/relationships" xmlns:a="http://schemas.openxmlformats.org/drawingml/2006/main" r:embed="R1d929e717c5845bd"/>
           <a:stretch xmlns:a="http://schemas.openxmlformats.org/drawingml/2006/main"/>
         </p:blipFill>
         <p:spPr>
@@ -3005,7 +3005,7 @@
     </p:spTree>
     <p:extLst>
       <p:ext uri="{BB962C8B-B14F-4D97-AF65-F5344CB8AC3E}">
-        <p14:creationId xmlns:p14="http://schemas.microsoft.com/office/powerpoint/2010/main" val="468390340"/>
+        <p14:creationId xmlns:p14="http://schemas.microsoft.com/office/powerpoint/2010/main" val="2001568790"/>
       </p:ext>
     </p:extLst>
   </p:cSld>
@@ -3029,7 +3029,7 @@
           <p:cNvPr id="1" name="slide-title">
             <a:extLst xmlns:a="http://schemas.openxmlformats.org/drawingml/2006/main">
               <a:ext uri="{FF2B5EF4-FFF2-40B4-BE49-F238E27FC236}">
-                <a16:creationId xmlns:a16="http://schemas.microsoft.com/office/drawing/2014/main" id="{FA46C543-C4F7-4EE6-BE99-CF72243B06A5}"/>
+                <a16:creationId xmlns:a16="http://schemas.microsoft.com/office/drawing/2014/main" id="{01D5D576-C972-4891-AD3B-ED5651BCD9D6}"/>
               </a:ext>
             </a:extLst>
           </p:cNvPr>
@@ -3074,7 +3074,7 @@
           <p:cNvPr id="2" name="slide-subtitle">
             <a:extLst xmlns:a="http://schemas.openxmlformats.org/drawingml/2006/main">
               <a:ext uri="{FF2B5EF4-FFF2-40B4-BE49-F238E27FC236}">
-                <a16:creationId xmlns:a16="http://schemas.microsoft.com/office/drawing/2014/main" id="{53633801-AC32-46F4-B5C0-44221DB91F08}"/>
+                <a16:creationId xmlns:a16="http://schemas.microsoft.com/office/drawing/2014/main" id="{4EF6595D-9882-4739-A973-F4A9F5F79AA1}"/>
               </a:ext>
             </a:extLst>
           </p:cNvPr>
@@ -3109,7 +3109,7 @@
                   <a:srgbClr val="000000"/>
                 </a:solidFill>
               </a:rPr>
-              <a:t>Horizontal bars compare MLOP, SPP+PPF, and MoP-V2 on each heldout trace.</a:t>
+              <a:t>Horizontal bars compare MLOP, SPP+PPF, MoP-V1, and MoP-V2 on each heldout trace.</a:t>
             </a:r>
           </a:p>
         </p:txBody>
@@ -3123,13 +3123,13 @@
           <p:nvPr/>
         </p:nvPicPr>
         <p:blipFill>
-          <a:blip xmlns:r="http://schemas.openxmlformats.org/officeDocument/2006/relationships" xmlns:a="http://schemas.openxmlformats.org/drawingml/2006/main" r:embed="Rab95d7784c884984"/>
+          <a:blip xmlns:r="http://schemas.openxmlformats.org/officeDocument/2006/relationships" xmlns:a="http://schemas.openxmlformats.org/drawingml/2006/main" r:embed="R3cc8aa50121441f4"/>
           <a:stretch xmlns:a="http://schemas.openxmlformats.org/drawingml/2006/main"/>
         </p:blipFill>
         <p:spPr>
           <a:xfrm xmlns:a="http://schemas.openxmlformats.org/drawingml/2006/main">
-            <a:off x="1226760" y="1710690"/>
-            <a:ext cx="15834479" cy="8042910"/>
+            <a:off x="1574202" y="1710690"/>
+            <a:ext cx="15139595" cy="8042910"/>
           </a:xfrm>
           <a:prstGeom xmlns:a="http://schemas.openxmlformats.org/drawingml/2006/main" prst="rect">
             <a:avLst/>
@@ -3139,7 +3139,7 @@
     </p:spTree>
     <p:extLst>
       <p:ext uri="{BB962C8B-B14F-4D97-AF65-F5344CB8AC3E}">
-        <p14:creationId xmlns:p14="http://schemas.microsoft.com/office/powerpoint/2010/main" val="699865382"/>
+        <p14:creationId xmlns:p14="http://schemas.microsoft.com/office/powerpoint/2010/main" val="1481403496"/>
       </p:ext>
     </p:extLst>
   </p:cSld>
@@ -3163,7 +3163,7 @@
           <p:cNvPr id="1" name="slide-title">
             <a:extLst xmlns:a="http://schemas.openxmlformats.org/drawingml/2006/main">
               <a:ext uri="{FF2B5EF4-FFF2-40B4-BE49-F238E27FC236}">
-                <a16:creationId xmlns:a16="http://schemas.microsoft.com/office/drawing/2014/main" id="{B0B800F4-C4CC-43A5-AB45-C6D845D035D8}"/>
+                <a16:creationId xmlns:a16="http://schemas.microsoft.com/office/drawing/2014/main" id="{FE94A279-8780-4AF8-BCE5-88EF7B895EB3}"/>
               </a:ext>
             </a:extLst>
           </p:cNvPr>
@@ -3208,7 +3208,7 @@
           <p:cNvPr id="2" name="slide-subtitle">
             <a:extLst xmlns:a="http://schemas.openxmlformats.org/drawingml/2006/main">
               <a:ext uri="{FF2B5EF4-FFF2-40B4-BE49-F238E27FC236}">
-                <a16:creationId xmlns:a16="http://schemas.microsoft.com/office/drawing/2014/main" id="{9B05E453-F86A-467E-A396-9ACE77DFA0E0}"/>
+                <a16:creationId xmlns:a16="http://schemas.microsoft.com/office/drawing/2014/main" id="{10FA22B7-1924-4F24-9F45-F9AD237F4CAE}"/>
               </a:ext>
             </a:extLst>
           </p:cNvPr>
@@ -3257,7 +3257,7 @@
           <p:nvPr/>
         </p:nvPicPr>
         <p:blipFill>
-          <a:blip xmlns:r="http://schemas.openxmlformats.org/officeDocument/2006/relationships" xmlns:a="http://schemas.openxmlformats.org/drawingml/2006/main" r:embed="Rcdd5c3f5d5c34591"/>
+          <a:blip xmlns:r="http://schemas.openxmlformats.org/officeDocument/2006/relationships" xmlns:a="http://schemas.openxmlformats.org/drawingml/2006/main" r:embed="R0f43ebd600d64649"/>
           <a:stretch xmlns:a="http://schemas.openxmlformats.org/drawingml/2006/main"/>
         </p:blipFill>
         <p:spPr>
@@ -3273,7 +3273,7 @@
     </p:spTree>
     <p:extLst>
       <p:ext uri="{BB962C8B-B14F-4D97-AF65-F5344CB8AC3E}">
-        <p14:creationId xmlns:p14="http://schemas.microsoft.com/office/powerpoint/2010/main" val="1147861995"/>
+        <p14:creationId xmlns:p14="http://schemas.microsoft.com/office/powerpoint/2010/main" val="53420120"/>
       </p:ext>
     </p:extLst>
   </p:cSld>
@@ -3297,7 +3297,7 @@
           <p:cNvPr id="1" name="slide-title">
             <a:extLst xmlns:a="http://schemas.openxmlformats.org/drawingml/2006/main">
               <a:ext uri="{FF2B5EF4-FFF2-40B4-BE49-F238E27FC236}">
-                <a16:creationId xmlns:a16="http://schemas.microsoft.com/office/drawing/2014/main" id="{84999EF9-FB74-4569-8891-6EF54A8E1B52}"/>
+                <a16:creationId xmlns:a16="http://schemas.microsoft.com/office/drawing/2014/main" id="{2E8EC24F-313A-427D-B191-234826D5FB1F}"/>
               </a:ext>
             </a:extLst>
           </p:cNvPr>
@@ -3342,7 +3342,7 @@
           <p:cNvPr id="2" name="slide-subtitle">
             <a:extLst xmlns:a="http://schemas.openxmlformats.org/drawingml/2006/main">
               <a:ext uri="{FF2B5EF4-FFF2-40B4-BE49-F238E27FC236}">
-                <a16:creationId xmlns:a16="http://schemas.microsoft.com/office/drawing/2014/main" id="{32B87372-D009-4A16-8351-D8C4479F11D4}"/>
+                <a16:creationId xmlns:a16="http://schemas.microsoft.com/office/drawing/2014/main" id="{CCABFC6B-8895-48B5-B9F1-2C148816857D}"/>
               </a:ext>
             </a:extLst>
           </p:cNvPr>
@@ -3387,7 +3387,7 @@
           <p:cNvPr id="3" name="bullet-0">
             <a:extLst xmlns:a="http://schemas.openxmlformats.org/drawingml/2006/main">
               <a:ext uri="{FF2B5EF4-FFF2-40B4-BE49-F238E27FC236}">
-                <a16:creationId xmlns:a16="http://schemas.microsoft.com/office/drawing/2014/main" id="{533A18A6-F9DA-4CF6-BD84-048C157783FC}"/>
+                <a16:creationId xmlns:a16="http://schemas.microsoft.com/office/drawing/2014/main" id="{480F7898-FAB1-47CB-9B39-5359094162EB}"/>
               </a:ext>
             </a:extLst>
           </p:cNvPr>
@@ -3432,7 +3432,7 @@
           <p:cNvPr id="4" name="bullet-1">
             <a:extLst xmlns:a="http://schemas.openxmlformats.org/drawingml/2006/main">
               <a:ext uri="{FF2B5EF4-FFF2-40B4-BE49-F238E27FC236}">
-                <a16:creationId xmlns:a16="http://schemas.microsoft.com/office/drawing/2014/main" id="{AD575F2C-D2F4-4854-B99D-2F9B8492E383}"/>
+                <a16:creationId xmlns:a16="http://schemas.microsoft.com/office/drawing/2014/main" id="{783F427C-2E3A-418F-8F34-6135FCD15132}"/>
               </a:ext>
             </a:extLst>
           </p:cNvPr>
@@ -3477,7 +3477,7 @@
           <p:cNvPr id="5" name="bullet-2">
             <a:extLst xmlns:a="http://schemas.openxmlformats.org/drawingml/2006/main">
               <a:ext uri="{FF2B5EF4-FFF2-40B4-BE49-F238E27FC236}">
-                <a16:creationId xmlns:a16="http://schemas.microsoft.com/office/drawing/2014/main" id="{60DA081A-5D40-44D5-9155-012090E6BF9F}"/>
+                <a16:creationId xmlns:a16="http://schemas.microsoft.com/office/drawing/2014/main" id="{A6B438BF-1BBC-4DC8-8371-D3718EDC5FBF}"/>
               </a:ext>
             </a:extLst>
           </p:cNvPr>
@@ -3522,7 +3522,7 @@
           <p:cNvPr id="6" name="bullet-3">
             <a:extLst xmlns:a="http://schemas.openxmlformats.org/drawingml/2006/main">
               <a:ext uri="{FF2B5EF4-FFF2-40B4-BE49-F238E27FC236}">
-                <a16:creationId xmlns:a16="http://schemas.microsoft.com/office/drawing/2014/main" id="{9E211A04-BCDB-43FE-AA59-FC67B0A67D4B}"/>
+                <a16:creationId xmlns:a16="http://schemas.microsoft.com/office/drawing/2014/main" id="{23FCF8DA-75D7-4DB2-A7C8-25E584755D1D}"/>
               </a:ext>
             </a:extLst>
           </p:cNvPr>
@@ -3567,7 +3567,7 @@
           <p:cNvPr id="7" name="bullet-4">
             <a:extLst xmlns:a="http://schemas.openxmlformats.org/drawingml/2006/main">
               <a:ext uri="{FF2B5EF4-FFF2-40B4-BE49-F238E27FC236}">
-                <a16:creationId xmlns:a16="http://schemas.microsoft.com/office/drawing/2014/main" id="{7BD16120-F230-4EEA-8D9B-16A7513558A1}"/>
+                <a16:creationId xmlns:a16="http://schemas.microsoft.com/office/drawing/2014/main" id="{7B44A1ED-625F-4B92-A3AE-C07CA78C2357}"/>
               </a:ext>
             </a:extLst>
           </p:cNvPr>
@@ -3612,7 +3612,7 @@
           <p:cNvPr id="8" name="bullet-0">
             <a:extLst xmlns:a="http://schemas.openxmlformats.org/drawingml/2006/main">
               <a:ext uri="{FF2B5EF4-FFF2-40B4-BE49-F238E27FC236}">
-                <a16:creationId xmlns:a16="http://schemas.microsoft.com/office/drawing/2014/main" id="{3E86E5AF-F942-46FA-A754-0F4CC4951B58}"/>
+                <a16:creationId xmlns:a16="http://schemas.microsoft.com/office/drawing/2014/main" id="{0C522685-E64D-480D-972D-8B37D29C45F0}"/>
               </a:ext>
             </a:extLst>
           </p:cNvPr>
@@ -3657,7 +3657,7 @@
           <p:cNvPr id="9" name="bullet-1">
             <a:extLst xmlns:a="http://schemas.openxmlformats.org/drawingml/2006/main">
               <a:ext uri="{FF2B5EF4-FFF2-40B4-BE49-F238E27FC236}">
-                <a16:creationId xmlns:a16="http://schemas.microsoft.com/office/drawing/2014/main" id="{A1328869-C281-470C-850B-1176798319A8}"/>
+                <a16:creationId xmlns:a16="http://schemas.microsoft.com/office/drawing/2014/main" id="{B39F0488-E7DF-423D-A6FB-FEF22645AE2E}"/>
               </a:ext>
             </a:extLst>
           </p:cNvPr>
@@ -3702,7 +3702,7 @@
           <p:cNvPr id="10" name="bullet-2">
             <a:extLst xmlns:a="http://schemas.openxmlformats.org/drawingml/2006/main">
               <a:ext uri="{FF2B5EF4-FFF2-40B4-BE49-F238E27FC236}">
-                <a16:creationId xmlns:a16="http://schemas.microsoft.com/office/drawing/2014/main" id="{326EFBA0-BFF5-46EE-995E-729BE297F442}"/>
+                <a16:creationId xmlns:a16="http://schemas.microsoft.com/office/drawing/2014/main" id="{8D8F7C5F-4417-4CA5-8217-D2342EE130F5}"/>
               </a:ext>
             </a:extLst>
           </p:cNvPr>
@@ -3747,7 +3747,7 @@
           <p:cNvPr id="11" name="bullet-3">
             <a:extLst xmlns:a="http://schemas.openxmlformats.org/drawingml/2006/main">
               <a:ext uri="{FF2B5EF4-FFF2-40B4-BE49-F238E27FC236}">
-                <a16:creationId xmlns:a16="http://schemas.microsoft.com/office/drawing/2014/main" id="{FBCC179E-2C70-4D76-8AC5-204C0D769780}"/>
+                <a16:creationId xmlns:a16="http://schemas.microsoft.com/office/drawing/2014/main" id="{D2387CFA-A6DA-461C-9272-4EBFC347698D}"/>
               </a:ext>
             </a:extLst>
           </p:cNvPr>
@@ -3792,7 +3792,7 @@
           <p:cNvPr id="12" name="bullet-4">
             <a:extLst xmlns:a="http://schemas.openxmlformats.org/drawingml/2006/main">
               <a:ext uri="{FF2B5EF4-FFF2-40B4-BE49-F238E27FC236}">
-                <a16:creationId xmlns:a16="http://schemas.microsoft.com/office/drawing/2014/main" id="{AC5DBCF9-B924-4F07-AA94-85CDB0DF3D19}"/>
+                <a16:creationId xmlns:a16="http://schemas.microsoft.com/office/drawing/2014/main" id="{8C027996-C90C-4A3D-AABC-D48069C9AD44}"/>
               </a:ext>
             </a:extLst>
           </p:cNvPr>
@@ -3837,7 +3837,7 @@
           <p:cNvPr id="13" name="audit-footer">
             <a:extLst xmlns:a="http://schemas.openxmlformats.org/drawingml/2006/main">
               <a:ext uri="{FF2B5EF4-FFF2-40B4-BE49-F238E27FC236}">
-                <a16:creationId xmlns:a16="http://schemas.microsoft.com/office/drawing/2014/main" id="{78DE6711-6E06-448E-9DEC-71D768F56F71}"/>
+                <a16:creationId xmlns:a16="http://schemas.microsoft.com/office/drawing/2014/main" id="{98112161-75C0-400A-ACDE-854D30E433B9}"/>
               </a:ext>
             </a:extLst>
           </p:cNvPr>
@@ -3880,7 +3880,7 @@
     </p:spTree>
     <p:extLst>
       <p:ext uri="{BB962C8B-B14F-4D97-AF65-F5344CB8AC3E}">
-        <p14:creationId xmlns:p14="http://schemas.microsoft.com/office/powerpoint/2010/main" val="946590634"/>
+        <p14:creationId xmlns:p14="http://schemas.microsoft.com/office/powerpoint/2010/main" val="790877928"/>
       </p:ext>
     </p:extLst>
   </p:cSld>
@@ -3904,7 +3904,7 @@
           <p:cNvPr id="1" name="slide-title">
             <a:extLst xmlns:a="http://schemas.openxmlformats.org/drawingml/2006/main">
               <a:ext uri="{FF2B5EF4-FFF2-40B4-BE49-F238E27FC236}">
-                <a16:creationId xmlns:a16="http://schemas.microsoft.com/office/drawing/2014/main" id="{CDE71314-FEF3-4012-9899-198067EE6C7F}"/>
+                <a16:creationId xmlns:a16="http://schemas.microsoft.com/office/drawing/2014/main" id="{56A3AAA0-DBCF-464E-8435-806F385F2B87}"/>
               </a:ext>
             </a:extLst>
           </p:cNvPr>
@@ -3949,7 +3949,7 @@
           <p:cNvPr id="2" name="title-rule">
             <a:extLst xmlns:a="http://schemas.openxmlformats.org/drawingml/2006/main">
               <a:ext uri="{FF2B5EF4-FFF2-40B4-BE49-F238E27FC236}">
-                <a16:creationId xmlns:a16="http://schemas.microsoft.com/office/drawing/2014/main" id="{22BF7ACC-F3B8-49DC-B9D5-9C4A9A860B71}"/>
+                <a16:creationId xmlns:a16="http://schemas.microsoft.com/office/drawing/2014/main" id="{E7E01B54-30E8-43A4-8C7A-1971D26A685D}"/>
               </a:ext>
             </a:extLst>
           </p:cNvPr>
@@ -3982,7 +3982,7 @@
           <p:cNvPr id="3" name="bullet-0">
             <a:extLst xmlns:a="http://schemas.openxmlformats.org/drawingml/2006/main">
               <a:ext uri="{FF2B5EF4-FFF2-40B4-BE49-F238E27FC236}">
-                <a16:creationId xmlns:a16="http://schemas.microsoft.com/office/drawing/2014/main" id="{7A83D5B1-9A72-451F-AE03-79FE2EBA9BC1}"/>
+                <a16:creationId xmlns:a16="http://schemas.microsoft.com/office/drawing/2014/main" id="{AE0FC5FF-6706-4161-B32A-290883B3010C}"/>
               </a:ext>
             </a:extLst>
           </p:cNvPr>
@@ -4027,7 +4027,7 @@
           <p:cNvPr id="4" name="bullet-1">
             <a:extLst xmlns:a="http://schemas.openxmlformats.org/drawingml/2006/main">
               <a:ext uri="{FF2B5EF4-FFF2-40B4-BE49-F238E27FC236}">
-                <a16:creationId xmlns:a16="http://schemas.microsoft.com/office/drawing/2014/main" id="{3A6EA030-49E3-4568-96F4-38A1D5C3D877}"/>
+                <a16:creationId xmlns:a16="http://schemas.microsoft.com/office/drawing/2014/main" id="{674627A8-8DC8-4504-A1B0-F1F8531C7339}"/>
               </a:ext>
             </a:extLst>
           </p:cNvPr>
@@ -4072,7 +4072,7 @@
           <p:cNvPr id="5" name="bullet-2">
             <a:extLst xmlns:a="http://schemas.openxmlformats.org/drawingml/2006/main">
               <a:ext uri="{FF2B5EF4-FFF2-40B4-BE49-F238E27FC236}">
-                <a16:creationId xmlns:a16="http://schemas.microsoft.com/office/drawing/2014/main" id="{23743BB2-0EA5-4A14-BAA0-68095196D8D6}"/>
+                <a16:creationId xmlns:a16="http://schemas.microsoft.com/office/drawing/2014/main" id="{5AE9F139-1FF5-4C67-8445-D8F5CCFE2EFB}"/>
               </a:ext>
             </a:extLst>
           </p:cNvPr>
@@ -4117,7 +4117,7 @@
           <p:cNvPr id="6" name="bullet-3">
             <a:extLst xmlns:a="http://schemas.openxmlformats.org/drawingml/2006/main">
               <a:ext uri="{FF2B5EF4-FFF2-40B4-BE49-F238E27FC236}">
-                <a16:creationId xmlns:a16="http://schemas.microsoft.com/office/drawing/2014/main" id="{8387B9DB-F188-48B2-ACA7-C565CA7BE3A1}"/>
+                <a16:creationId xmlns:a16="http://schemas.microsoft.com/office/drawing/2014/main" id="{B50D22F6-A233-4BEB-A276-9B9C7C5592D1}"/>
               </a:ext>
             </a:extLst>
           </p:cNvPr>
@@ -4152,7 +4152,7 @@
                   <a:srgbClr val="000000"/>
                 </a:solidFill>
               </a:rPr>
-              <a:t>The max-prefetcher result remains a cap, which keeps the claim sized correctly.</a:t>
+              <a:t>The best expert result stays as a separate reference, which keeps the claim sized correctly.</a:t>
             </a:r>
           </a:p>
         </p:txBody>
@@ -4162,7 +4162,7 @@
           <p:cNvPr id="7" name="bullet-4">
             <a:extLst xmlns:a="http://schemas.openxmlformats.org/drawingml/2006/main">
               <a:ext uri="{FF2B5EF4-FFF2-40B4-BE49-F238E27FC236}">
-                <a16:creationId xmlns:a16="http://schemas.microsoft.com/office/drawing/2014/main" id="{F034C608-D0B5-459D-BFAA-F66453FEF673}"/>
+                <a16:creationId xmlns:a16="http://schemas.microsoft.com/office/drawing/2014/main" id="{539B3C43-149B-4E81-A409-77CEDB554A49}"/>
               </a:ext>
             </a:extLst>
           </p:cNvPr>
@@ -4205,7 +4205,7 @@
     </p:spTree>
     <p:extLst>
       <p:ext uri="{BB962C8B-B14F-4D97-AF65-F5344CB8AC3E}">
-        <p14:creationId xmlns:p14="http://schemas.microsoft.com/office/powerpoint/2010/main" val="171324396"/>
+        <p14:creationId xmlns:p14="http://schemas.microsoft.com/office/powerpoint/2010/main" val="1552252384"/>
       </p:ext>
     </p:extLst>
   </p:cSld>

</xml_diff>

<commit_message>
Clarify router performance colors
</commit_message>
<xml_diff>
--- a/slides/mop_stage2_final/output/output.pptx
+++ b/slides/mop_stage2_final/output/output.pptx
@@ -2,20 +2,20 @@
 <file path=ppt/presentation.xml><?xml version="1.0" encoding="utf-8"?>
 <p:presentation xmlns:p="http://schemas.openxmlformats.org/presentationml/2006/main">
   <p:sldMasterIdLst>
-    <p:sldMasterId xmlns:r="http://schemas.openxmlformats.org/officeDocument/2006/relationships" id="2147483648" r:id="Rc34897b6653745ca"/>
+    <p:sldMasterId xmlns:r="http://schemas.openxmlformats.org/officeDocument/2006/relationships" id="2147483648" r:id="R41d604f2ad8d4dac"/>
   </p:sldMasterIdLst>
   <p:notesMasterIdLst>
-    <p:notesMasterId xmlns:r="http://schemas.openxmlformats.org/officeDocument/2006/relationships" r:id="R8de70ad532c54a6f"/>
+    <p:notesMasterId xmlns:r="http://schemas.openxmlformats.org/officeDocument/2006/relationships" r:id="R229392969a1641e6"/>
   </p:notesMasterIdLst>
   <p:sldIdLst>
-    <p:sldId xmlns:r="http://schemas.openxmlformats.org/officeDocument/2006/relationships" id="256" r:id="Re54b36cd8d9745d0"/>
-    <p:sldId xmlns:r="http://schemas.openxmlformats.org/officeDocument/2006/relationships" id="257" r:id="Rc03fad26f12a4b4f"/>
-    <p:sldId xmlns:r="http://schemas.openxmlformats.org/officeDocument/2006/relationships" id="258" r:id="Rbddc7b3f5f2d4b58"/>
-    <p:sldId xmlns:r="http://schemas.openxmlformats.org/officeDocument/2006/relationships" id="259" r:id="R70cb93a8b180440a"/>
-    <p:sldId xmlns:r="http://schemas.openxmlformats.org/officeDocument/2006/relationships" id="260" r:id="Ra32f680f02e24ed1"/>
-    <p:sldId xmlns:r="http://schemas.openxmlformats.org/officeDocument/2006/relationships" id="261" r:id="R4498e938d85f4e52"/>
-    <p:sldId xmlns:r="http://schemas.openxmlformats.org/officeDocument/2006/relationships" id="262" r:id="Ra1c46d8d593a4d3b"/>
-    <p:sldId xmlns:r="http://schemas.openxmlformats.org/officeDocument/2006/relationships" id="263" r:id="R0beba393b7604a99"/>
+    <p:sldId xmlns:r="http://schemas.openxmlformats.org/officeDocument/2006/relationships" id="256" r:id="R5863beff42844f83"/>
+    <p:sldId xmlns:r="http://schemas.openxmlformats.org/officeDocument/2006/relationships" id="257" r:id="R70e3820ca45c4c8d"/>
+    <p:sldId xmlns:r="http://schemas.openxmlformats.org/officeDocument/2006/relationships" id="258" r:id="Ra11e86026d924d24"/>
+    <p:sldId xmlns:r="http://schemas.openxmlformats.org/officeDocument/2006/relationships" id="259" r:id="R88fc264c67e24c01"/>
+    <p:sldId xmlns:r="http://schemas.openxmlformats.org/officeDocument/2006/relationships" id="260" r:id="R03297268302b4509"/>
+    <p:sldId xmlns:r="http://schemas.openxmlformats.org/officeDocument/2006/relationships" id="261" r:id="R2478ab221263467d"/>
+    <p:sldId xmlns:r="http://schemas.openxmlformats.org/officeDocument/2006/relationships" id="262" r:id="R6ade8a826c3041f5"/>
+    <p:sldId xmlns:r="http://schemas.openxmlformats.org/officeDocument/2006/relationships" id="263" r:id="R6d80aa0b00ac4d28"/>
   </p:sldIdLst>
   <p:sldSz cx="18288000" cy="10287000"/>
   <p:notesSz cx="6858000" cy="9144000"/>
@@ -1024,7 +1024,7 @@
   </p:cSld>
   <p:clrMap bg1="lt1" tx1="dk1" bg2="lt2" tx2="dk2" accent1="accent1" accent2="accent2" accent3="accent3" accent4="accent4" accent5="accent5" accent6="accent6" hlink="hlink" folHlink="folHlink"/>
   <p:sldLayoutIdLst>
-    <p:sldLayoutId xmlns:r="http://schemas.openxmlformats.org/officeDocument/2006/relationships" id="2147483649" r:id="R28acac464e484aaa"/>
+    <p:sldLayoutId xmlns:r="http://schemas.openxmlformats.org/officeDocument/2006/relationships" id="2147483649" r:id="R96df0cfde3cc43f4"/>
   </p:sldLayoutIdLst>
   <p:txStyles>
     <p:titleStyle>
@@ -1323,7 +1323,7 @@
           <p:cNvPr id="1" name="cover-title">
             <a:extLst xmlns:a="http://schemas.openxmlformats.org/drawingml/2006/main">
               <a:ext uri="{FF2B5EF4-FFF2-40B4-BE49-F238E27FC236}">
-                <a16:creationId xmlns:a16="http://schemas.microsoft.com/office/drawing/2014/main" id="{475C945D-8632-46F1-B80B-783EEFB74CA3}"/>
+                <a16:creationId xmlns:a16="http://schemas.microsoft.com/office/drawing/2014/main" id="{E9E3762B-33BF-47B5-B980-7207449BDF51}"/>
               </a:ext>
             </a:extLst>
           </p:cNvPr>
@@ -1368,7 +1368,7 @@
           <p:cNvPr id="2" name="cover-rule">
             <a:extLst xmlns:a="http://schemas.openxmlformats.org/drawingml/2006/main">
               <a:ext uri="{FF2B5EF4-FFF2-40B4-BE49-F238E27FC236}">
-                <a16:creationId xmlns:a16="http://schemas.microsoft.com/office/drawing/2014/main" id="{57E0E18A-83B9-4E30-B713-5276A1D430F2}"/>
+                <a16:creationId xmlns:a16="http://schemas.microsoft.com/office/drawing/2014/main" id="{9FCF0678-5DA3-48C3-9EBF-70C2B4549E02}"/>
               </a:ext>
             </a:extLst>
           </p:cNvPr>
@@ -1401,7 +1401,7 @@
           <p:cNvPr id="3" name="cover-thesis">
             <a:extLst xmlns:a="http://schemas.openxmlformats.org/drawingml/2006/main">
               <a:ext uri="{FF2B5EF4-FFF2-40B4-BE49-F238E27FC236}">
-                <a16:creationId xmlns:a16="http://schemas.microsoft.com/office/drawing/2014/main" id="{A22B6864-14CE-4D0A-9F8C-C26C11CAD8E1}"/>
+                <a16:creationId xmlns:a16="http://schemas.microsoft.com/office/drawing/2014/main" id="{AF458420-EAB3-4A84-910C-B1EF2B748D68}"/>
               </a:ext>
             </a:extLst>
           </p:cNvPr>
@@ -1446,7 +1446,7 @@
           <p:cNvPr id="4" name="cover-metric-1">
             <a:extLst xmlns:a="http://schemas.openxmlformats.org/drawingml/2006/main">
               <a:ext uri="{FF2B5EF4-FFF2-40B4-BE49-F238E27FC236}">
-                <a16:creationId xmlns:a16="http://schemas.microsoft.com/office/drawing/2014/main" id="{BC4A56FF-C3E0-4676-AC82-6045907D2CDE}"/>
+                <a16:creationId xmlns:a16="http://schemas.microsoft.com/office/drawing/2014/main" id="{9CDE8440-A185-468C-BFD5-16A8B0E9C772}"/>
               </a:ext>
             </a:extLst>
           </p:cNvPr>
@@ -1491,7 +1491,7 @@
           <p:cNvPr id="5" name="cover-label-1">
             <a:extLst xmlns:a="http://schemas.openxmlformats.org/drawingml/2006/main">
               <a:ext uri="{FF2B5EF4-FFF2-40B4-BE49-F238E27FC236}">
-                <a16:creationId xmlns:a16="http://schemas.microsoft.com/office/drawing/2014/main" id="{E236BE90-4D18-4DAA-920E-EA3701305D4C}"/>
+                <a16:creationId xmlns:a16="http://schemas.microsoft.com/office/drawing/2014/main" id="{9A0DA18A-E21F-4539-A003-5856C34FF99F}"/>
               </a:ext>
             </a:extLst>
           </p:cNvPr>
@@ -1536,7 +1536,7 @@
           <p:cNvPr id="6" name="cover-metric-2">
             <a:extLst xmlns:a="http://schemas.openxmlformats.org/drawingml/2006/main">
               <a:ext uri="{FF2B5EF4-FFF2-40B4-BE49-F238E27FC236}">
-                <a16:creationId xmlns:a16="http://schemas.microsoft.com/office/drawing/2014/main" id="{96A094B9-91DF-49F2-B0DD-62F4C5338624}"/>
+                <a16:creationId xmlns:a16="http://schemas.microsoft.com/office/drawing/2014/main" id="{E4FBF75D-0376-48B3-B87B-64B1D5F00C69}"/>
               </a:ext>
             </a:extLst>
           </p:cNvPr>
@@ -1581,7 +1581,7 @@
           <p:cNvPr id="7" name="cover-label-2">
             <a:extLst xmlns:a="http://schemas.openxmlformats.org/drawingml/2006/main">
               <a:ext uri="{FF2B5EF4-FFF2-40B4-BE49-F238E27FC236}">
-                <a16:creationId xmlns:a16="http://schemas.microsoft.com/office/drawing/2014/main" id="{8BD894AA-D2B9-4173-B8B0-8DF32F14B1E7}"/>
+                <a16:creationId xmlns:a16="http://schemas.microsoft.com/office/drawing/2014/main" id="{25D31144-5D87-4BA0-AD99-8B8168F75480}"/>
               </a:ext>
             </a:extLst>
           </p:cNvPr>
@@ -1626,7 +1626,7 @@
           <p:cNvPr id="8" name="cover-footer">
             <a:extLst xmlns:a="http://schemas.openxmlformats.org/drawingml/2006/main">
               <a:ext uri="{FF2B5EF4-FFF2-40B4-BE49-F238E27FC236}">
-                <a16:creationId xmlns:a16="http://schemas.microsoft.com/office/drawing/2014/main" id="{C3D55F56-0AFB-43FD-B2E2-FFF95E6B3B66}"/>
+                <a16:creationId xmlns:a16="http://schemas.microsoft.com/office/drawing/2014/main" id="{5CFF5CF6-208C-4263-92B0-1F1185D8E7A4}"/>
               </a:ext>
             </a:extLst>
           </p:cNvPr>
@@ -1669,7 +1669,7 @@
     </p:spTree>
     <p:extLst>
       <p:ext uri="{BB962C8B-B14F-4D97-AF65-F5344CB8AC3E}">
-        <p14:creationId xmlns:p14="http://schemas.microsoft.com/office/powerpoint/2010/main" val="329904110"/>
+        <p14:creationId xmlns:p14="http://schemas.microsoft.com/office/powerpoint/2010/main" val="179364293"/>
       </p:ext>
     </p:extLst>
   </p:cSld>
@@ -1693,7 +1693,7 @@
           <p:cNvPr id="1" name="slide-title">
             <a:extLst xmlns:a="http://schemas.openxmlformats.org/drawingml/2006/main">
               <a:ext uri="{FF2B5EF4-FFF2-40B4-BE49-F238E27FC236}">
-                <a16:creationId xmlns:a16="http://schemas.microsoft.com/office/drawing/2014/main" id="{6AC8F621-532A-4912-A4F8-C2CF48E195F7}"/>
+                <a16:creationId xmlns:a16="http://schemas.microsoft.com/office/drawing/2014/main" id="{2C2D9EA3-E6FD-482F-80A7-35F5EFE488A1}"/>
               </a:ext>
             </a:extLst>
           </p:cNvPr>
@@ -1738,7 +1738,7 @@
           <p:cNvPr id="2" name="slide-subtitle">
             <a:extLst xmlns:a="http://schemas.openxmlformats.org/drawingml/2006/main">
               <a:ext uri="{FF2B5EF4-FFF2-40B4-BE49-F238E27FC236}">
-                <a16:creationId xmlns:a16="http://schemas.microsoft.com/office/drawing/2014/main" id="{605A8200-A41B-43F7-9215-F6C6D4F55BC7}"/>
+                <a16:creationId xmlns:a16="http://schemas.microsoft.com/office/drawing/2014/main" id="{2BE82851-DCEB-4B5A-B885-C737C0ED3031}"/>
               </a:ext>
             </a:extLst>
           </p:cNvPr>
@@ -1783,7 +1783,7 @@
           <p:cNvPr id="3" name="bullet-0">
             <a:extLst xmlns:a="http://schemas.openxmlformats.org/drawingml/2006/main">
               <a:ext uri="{FF2B5EF4-FFF2-40B4-BE49-F238E27FC236}">
-                <a16:creationId xmlns:a16="http://schemas.microsoft.com/office/drawing/2014/main" id="{A7234944-4276-4D78-9807-E0C2F436251B}"/>
+                <a16:creationId xmlns:a16="http://schemas.microsoft.com/office/drawing/2014/main" id="{5F7D0960-A51D-4F09-B040-6D5BFC4FBE3A}"/>
               </a:ext>
             </a:extLst>
           </p:cNvPr>
@@ -1828,7 +1828,7 @@
           <p:cNvPr id="4" name="bullet-1">
             <a:extLst xmlns:a="http://schemas.openxmlformats.org/drawingml/2006/main">
               <a:ext uri="{FF2B5EF4-FFF2-40B4-BE49-F238E27FC236}">
-                <a16:creationId xmlns:a16="http://schemas.microsoft.com/office/drawing/2014/main" id="{95DA2A30-07EB-4F53-B9A7-9613927EA34B}"/>
+                <a16:creationId xmlns:a16="http://schemas.microsoft.com/office/drawing/2014/main" id="{5E75341D-3F57-4EDD-82FB-B6BF713BC7C8}"/>
               </a:ext>
             </a:extLst>
           </p:cNvPr>
@@ -1873,7 +1873,7 @@
           <p:cNvPr id="5" name="bullet-2">
             <a:extLst xmlns:a="http://schemas.openxmlformats.org/drawingml/2006/main">
               <a:ext uri="{FF2B5EF4-FFF2-40B4-BE49-F238E27FC236}">
-                <a16:creationId xmlns:a16="http://schemas.microsoft.com/office/drawing/2014/main" id="{65266A7C-8162-4DFD-8F15-93E54FF92440}"/>
+                <a16:creationId xmlns:a16="http://schemas.microsoft.com/office/drawing/2014/main" id="{FEB625AF-8E1D-4911-A12E-63199986A456}"/>
               </a:ext>
             </a:extLst>
           </p:cNvPr>
@@ -1918,7 +1918,7 @@
           <p:cNvPr id="6" name="bullet-3">
             <a:extLst xmlns:a="http://schemas.openxmlformats.org/drawingml/2006/main">
               <a:ext uri="{FF2B5EF4-FFF2-40B4-BE49-F238E27FC236}">
-                <a16:creationId xmlns:a16="http://schemas.microsoft.com/office/drawing/2014/main" id="{13ACDF4F-D97E-49C6-B473-7ADC9CB2FC94}"/>
+                <a16:creationId xmlns:a16="http://schemas.microsoft.com/office/drawing/2014/main" id="{EA6C2B86-C089-4D07-87FA-516A85D1DC06}"/>
               </a:ext>
             </a:extLst>
           </p:cNvPr>
@@ -1963,7 +1963,7 @@
           <p:cNvPr id="7" name="bullet-0">
             <a:extLst xmlns:a="http://schemas.openxmlformats.org/drawingml/2006/main">
               <a:ext uri="{FF2B5EF4-FFF2-40B4-BE49-F238E27FC236}">
-                <a16:creationId xmlns:a16="http://schemas.microsoft.com/office/drawing/2014/main" id="{9DF53EBD-3394-491C-A4FA-818B45BFE588}"/>
+                <a16:creationId xmlns:a16="http://schemas.microsoft.com/office/drawing/2014/main" id="{6761ECB7-067A-42BF-9AB3-9EBE0D2EA3C7}"/>
               </a:ext>
             </a:extLst>
           </p:cNvPr>
@@ -2008,7 +2008,7 @@
           <p:cNvPr id="8" name="bullet-1">
             <a:extLst xmlns:a="http://schemas.openxmlformats.org/drawingml/2006/main">
               <a:ext uri="{FF2B5EF4-FFF2-40B4-BE49-F238E27FC236}">
-                <a16:creationId xmlns:a16="http://schemas.microsoft.com/office/drawing/2014/main" id="{9F029564-E27A-45FF-AD5F-B7E76F251E9D}"/>
+                <a16:creationId xmlns:a16="http://schemas.microsoft.com/office/drawing/2014/main" id="{BCEF3C82-DEC8-4FE9-B078-03791722467B}"/>
               </a:ext>
             </a:extLst>
           </p:cNvPr>
@@ -2053,7 +2053,7 @@
           <p:cNvPr id="9" name="bullet-2">
             <a:extLst xmlns:a="http://schemas.openxmlformats.org/drawingml/2006/main">
               <a:ext uri="{FF2B5EF4-FFF2-40B4-BE49-F238E27FC236}">
-                <a16:creationId xmlns:a16="http://schemas.microsoft.com/office/drawing/2014/main" id="{13EF5956-18B5-40BE-933B-8493027CF2F4}"/>
+                <a16:creationId xmlns:a16="http://schemas.microsoft.com/office/drawing/2014/main" id="{AC0F4995-4576-430C-95A8-2E2AA3D081F4}"/>
               </a:ext>
             </a:extLst>
           </p:cNvPr>
@@ -2098,7 +2098,7 @@
           <p:cNvPr id="10" name="bullet-3">
             <a:extLst xmlns:a="http://schemas.openxmlformats.org/drawingml/2006/main">
               <a:ext uri="{FF2B5EF4-FFF2-40B4-BE49-F238E27FC236}">
-                <a16:creationId xmlns:a16="http://schemas.microsoft.com/office/drawing/2014/main" id="{E87C9C39-24A6-4473-AB54-D6E27EBF54A5}"/>
+                <a16:creationId xmlns:a16="http://schemas.microsoft.com/office/drawing/2014/main" id="{93E65DE0-DF16-4F1C-8591-F9E1B8247B72}"/>
               </a:ext>
             </a:extLst>
           </p:cNvPr>
@@ -2143,7 +2143,7 @@
           <p:cNvPr id="11" name="bullet-0">
             <a:extLst xmlns:a="http://schemas.openxmlformats.org/drawingml/2006/main">
               <a:ext uri="{FF2B5EF4-FFF2-40B4-BE49-F238E27FC236}">
-                <a16:creationId xmlns:a16="http://schemas.microsoft.com/office/drawing/2014/main" id="{C07C0C43-EDD3-46A5-9278-97774879369F}"/>
+                <a16:creationId xmlns:a16="http://schemas.microsoft.com/office/drawing/2014/main" id="{D74FE309-7996-4D7E-88CD-593DC9FE3037}"/>
               </a:ext>
             </a:extLst>
           </p:cNvPr>
@@ -2188,7 +2188,7 @@
           <p:cNvPr id="12" name="bullet-1">
             <a:extLst xmlns:a="http://schemas.openxmlformats.org/drawingml/2006/main">
               <a:ext uri="{FF2B5EF4-FFF2-40B4-BE49-F238E27FC236}">
-                <a16:creationId xmlns:a16="http://schemas.microsoft.com/office/drawing/2014/main" id="{6359E46B-6B19-403D-824E-B3AA0762055F}"/>
+                <a16:creationId xmlns:a16="http://schemas.microsoft.com/office/drawing/2014/main" id="{DF30B93D-AD8A-4DF1-B85F-A4728E6AC434}"/>
               </a:ext>
             </a:extLst>
           </p:cNvPr>
@@ -2233,7 +2233,7 @@
           <p:cNvPr id="13" name="bullet-2">
             <a:extLst xmlns:a="http://schemas.openxmlformats.org/drawingml/2006/main">
               <a:ext uri="{FF2B5EF4-FFF2-40B4-BE49-F238E27FC236}">
-                <a16:creationId xmlns:a16="http://schemas.microsoft.com/office/drawing/2014/main" id="{0A19E10B-0F96-4C13-8923-8689584465FD}"/>
+                <a16:creationId xmlns:a16="http://schemas.microsoft.com/office/drawing/2014/main" id="{62D084BB-D290-40FF-BFF0-8D3BC67D7F4E}"/>
               </a:ext>
             </a:extLst>
           </p:cNvPr>
@@ -2278,7 +2278,7 @@
           <p:cNvPr id="14" name="bullet-3">
             <a:extLst xmlns:a="http://schemas.openxmlformats.org/drawingml/2006/main">
               <a:ext uri="{FF2B5EF4-FFF2-40B4-BE49-F238E27FC236}">
-                <a16:creationId xmlns:a16="http://schemas.microsoft.com/office/drawing/2014/main" id="{281ACC87-9F8E-4423-B922-38A227140252}"/>
+                <a16:creationId xmlns:a16="http://schemas.microsoft.com/office/drawing/2014/main" id="{1107181C-1C07-4842-AD34-262B88309A45}"/>
               </a:ext>
             </a:extLst>
           </p:cNvPr>
@@ -2321,7 +2321,7 @@
     </p:spTree>
     <p:extLst>
       <p:ext uri="{BB962C8B-B14F-4D97-AF65-F5344CB8AC3E}">
-        <p14:creationId xmlns:p14="http://schemas.microsoft.com/office/powerpoint/2010/main" val="1736625267"/>
+        <p14:creationId xmlns:p14="http://schemas.microsoft.com/office/powerpoint/2010/main" val="1554074246"/>
       </p:ext>
     </p:extLst>
   </p:cSld>
@@ -2345,7 +2345,7 @@
           <p:cNvPr id="1" name="slide-title">
             <a:extLst xmlns:a="http://schemas.openxmlformats.org/drawingml/2006/main">
               <a:ext uri="{FF2B5EF4-FFF2-40B4-BE49-F238E27FC236}">
-                <a16:creationId xmlns:a16="http://schemas.microsoft.com/office/drawing/2014/main" id="{9EC8D094-0DE6-4E02-89C2-FA1C78D29BA1}"/>
+                <a16:creationId xmlns:a16="http://schemas.microsoft.com/office/drawing/2014/main" id="{70DB212F-F367-4072-875C-C4D8A7B0F2DB}"/>
               </a:ext>
             </a:extLst>
           </p:cNvPr>
@@ -2390,7 +2390,7 @@
           <p:cNvPr id="2" name="title-rule">
             <a:extLst xmlns:a="http://schemas.openxmlformats.org/drawingml/2006/main">
               <a:ext uri="{FF2B5EF4-FFF2-40B4-BE49-F238E27FC236}">
-                <a16:creationId xmlns:a16="http://schemas.microsoft.com/office/drawing/2014/main" id="{472254C1-B22F-4DE5-ABAB-087015A81FB9}"/>
+                <a16:creationId xmlns:a16="http://schemas.microsoft.com/office/drawing/2014/main" id="{5B208A43-20C2-4982-9B39-DED45295B093}"/>
               </a:ext>
             </a:extLst>
           </p:cNvPr>
@@ -2423,7 +2423,7 @@
           <p:cNvPr id="3" name="bullet-0">
             <a:extLst xmlns:a="http://schemas.openxmlformats.org/drawingml/2006/main">
               <a:ext uri="{FF2B5EF4-FFF2-40B4-BE49-F238E27FC236}">
-                <a16:creationId xmlns:a16="http://schemas.microsoft.com/office/drawing/2014/main" id="{D5E9AEC3-8C02-4694-B543-EB9CEBE4B5EF}"/>
+                <a16:creationId xmlns:a16="http://schemas.microsoft.com/office/drawing/2014/main" id="{C65D4C71-54D8-4A25-AADE-B03D8E0C1059}"/>
               </a:ext>
             </a:extLst>
           </p:cNvPr>
@@ -2468,7 +2468,7 @@
           <p:cNvPr id="4" name="bullet-1">
             <a:extLst xmlns:a="http://schemas.openxmlformats.org/drawingml/2006/main">
               <a:ext uri="{FF2B5EF4-FFF2-40B4-BE49-F238E27FC236}">
-                <a16:creationId xmlns:a16="http://schemas.microsoft.com/office/drawing/2014/main" id="{F61ED92A-932B-4E2A-A09C-9A28628BBDB4}"/>
+                <a16:creationId xmlns:a16="http://schemas.microsoft.com/office/drawing/2014/main" id="{2D97471F-B799-45DC-A784-B03671820D94}"/>
               </a:ext>
             </a:extLst>
           </p:cNvPr>
@@ -2513,7 +2513,7 @@
           <p:cNvPr id="5" name="bullet-2">
             <a:extLst xmlns:a="http://schemas.openxmlformats.org/drawingml/2006/main">
               <a:ext uri="{FF2B5EF4-FFF2-40B4-BE49-F238E27FC236}">
-                <a16:creationId xmlns:a16="http://schemas.microsoft.com/office/drawing/2014/main" id="{0EFC826F-4ED3-4522-A2F2-A7F7211F22AA}"/>
+                <a16:creationId xmlns:a16="http://schemas.microsoft.com/office/drawing/2014/main" id="{1009E340-FADE-4092-A50B-218F49E8334D}"/>
               </a:ext>
             </a:extLst>
           </p:cNvPr>
@@ -2558,7 +2558,7 @@
           <p:cNvPr id="6" name="bullet-3">
             <a:extLst xmlns:a="http://schemas.openxmlformats.org/drawingml/2006/main">
               <a:ext uri="{FF2B5EF4-FFF2-40B4-BE49-F238E27FC236}">
-                <a16:creationId xmlns:a16="http://schemas.microsoft.com/office/drawing/2014/main" id="{5EC19B2C-5691-4B55-A0FA-9C1CC9CBE1D5}"/>
+                <a16:creationId xmlns:a16="http://schemas.microsoft.com/office/drawing/2014/main" id="{F2A0AEBA-7D15-4420-A41C-375CFBBE5343}"/>
               </a:ext>
             </a:extLst>
           </p:cNvPr>
@@ -2603,7 +2603,7 @@
           <p:cNvPr id="7" name="bullet-4">
             <a:extLst xmlns:a="http://schemas.openxmlformats.org/drawingml/2006/main">
               <a:ext uri="{FF2B5EF4-FFF2-40B4-BE49-F238E27FC236}">
-                <a16:creationId xmlns:a16="http://schemas.microsoft.com/office/drawing/2014/main" id="{0FB5EB21-C306-465B-ABB4-76E46B314129}"/>
+                <a16:creationId xmlns:a16="http://schemas.microsoft.com/office/drawing/2014/main" id="{3256B51B-4C60-45ED-86CC-BDA88D39C545}"/>
               </a:ext>
             </a:extLst>
           </p:cNvPr>
@@ -2648,7 +2648,7 @@
           <p:cNvPr id="8" name="bullet-0">
             <a:extLst xmlns:a="http://schemas.openxmlformats.org/drawingml/2006/main">
               <a:ext uri="{FF2B5EF4-FFF2-40B4-BE49-F238E27FC236}">
-                <a16:creationId xmlns:a16="http://schemas.microsoft.com/office/drawing/2014/main" id="{2C8E04B7-8AEF-46CE-BF76-9AEE7AE63D9B}"/>
+                <a16:creationId xmlns:a16="http://schemas.microsoft.com/office/drawing/2014/main" id="{D6549EB3-B152-435C-A335-156200616526}"/>
               </a:ext>
             </a:extLst>
           </p:cNvPr>
@@ -2693,7 +2693,7 @@
           <p:cNvPr id="9" name="bullet-1">
             <a:extLst xmlns:a="http://schemas.openxmlformats.org/drawingml/2006/main">
               <a:ext uri="{FF2B5EF4-FFF2-40B4-BE49-F238E27FC236}">
-                <a16:creationId xmlns:a16="http://schemas.microsoft.com/office/drawing/2014/main" id="{9D522EAF-E059-402D-A02F-ECD0BE1145BF}"/>
+                <a16:creationId xmlns:a16="http://schemas.microsoft.com/office/drawing/2014/main" id="{2A70479B-9E5D-4FEB-B509-FAD7EB936882}"/>
               </a:ext>
             </a:extLst>
           </p:cNvPr>
@@ -2738,7 +2738,7 @@
           <p:cNvPr id="10" name="bullet-2">
             <a:extLst xmlns:a="http://schemas.openxmlformats.org/drawingml/2006/main">
               <a:ext uri="{FF2B5EF4-FFF2-40B4-BE49-F238E27FC236}">
-                <a16:creationId xmlns:a16="http://schemas.microsoft.com/office/drawing/2014/main" id="{8C487507-A9C0-4E56-B6B2-04FB0D3D4860}"/>
+                <a16:creationId xmlns:a16="http://schemas.microsoft.com/office/drawing/2014/main" id="{EF42F35B-0AC3-4CF8-B627-69283985A043}"/>
               </a:ext>
             </a:extLst>
           </p:cNvPr>
@@ -2783,7 +2783,7 @@
           <p:cNvPr id="11" name="bullet-3">
             <a:extLst xmlns:a="http://schemas.openxmlformats.org/drawingml/2006/main">
               <a:ext uri="{FF2B5EF4-FFF2-40B4-BE49-F238E27FC236}">
-                <a16:creationId xmlns:a16="http://schemas.microsoft.com/office/drawing/2014/main" id="{2BE09F97-C3B3-4873-9D67-962CAC7C57B4}"/>
+                <a16:creationId xmlns:a16="http://schemas.microsoft.com/office/drawing/2014/main" id="{CE64E229-A5F4-418E-A104-3B632C5ACB8E}"/>
               </a:ext>
             </a:extLst>
           </p:cNvPr>
@@ -2828,7 +2828,7 @@
           <p:cNvPr id="12" name="protocol-footer">
             <a:extLst xmlns:a="http://schemas.openxmlformats.org/drawingml/2006/main">
               <a:ext uri="{FF2B5EF4-FFF2-40B4-BE49-F238E27FC236}">
-                <a16:creationId xmlns:a16="http://schemas.microsoft.com/office/drawing/2014/main" id="{98DE9E88-F372-4A45-A518-85466FF023E4}"/>
+                <a16:creationId xmlns:a16="http://schemas.microsoft.com/office/drawing/2014/main" id="{3DA69A02-6815-444D-BABA-4CCF04742622}"/>
               </a:ext>
             </a:extLst>
           </p:cNvPr>
@@ -2871,7 +2871,7 @@
     </p:spTree>
     <p:extLst>
       <p:ext uri="{BB962C8B-B14F-4D97-AF65-F5344CB8AC3E}">
-        <p14:creationId xmlns:p14="http://schemas.microsoft.com/office/powerpoint/2010/main" val="460903134"/>
+        <p14:creationId xmlns:p14="http://schemas.microsoft.com/office/powerpoint/2010/main" val="384730241"/>
       </p:ext>
     </p:extLst>
   </p:cSld>
@@ -2895,7 +2895,7 @@
           <p:cNvPr id="1" name="slide-title">
             <a:extLst xmlns:a="http://schemas.openxmlformats.org/drawingml/2006/main">
               <a:ext uri="{FF2B5EF4-FFF2-40B4-BE49-F238E27FC236}">
-                <a16:creationId xmlns:a16="http://schemas.microsoft.com/office/drawing/2014/main" id="{8DBAC9F2-66B8-4F9E-A912-5965CC859243}"/>
+                <a16:creationId xmlns:a16="http://schemas.microsoft.com/office/drawing/2014/main" id="{74FBD647-6AE3-4F8C-B0DB-DD1239BF5AAD}"/>
               </a:ext>
             </a:extLst>
           </p:cNvPr>
@@ -2940,7 +2940,7 @@
           <p:cNvPr id="2" name="slide-subtitle">
             <a:extLst xmlns:a="http://schemas.openxmlformats.org/drawingml/2006/main">
               <a:ext uri="{FF2B5EF4-FFF2-40B4-BE49-F238E27FC236}">
-                <a16:creationId xmlns:a16="http://schemas.microsoft.com/office/drawing/2014/main" id="{0465B30B-076D-430D-AAB5-D648CA75FE57}"/>
+                <a16:creationId xmlns:a16="http://schemas.microsoft.com/office/drawing/2014/main" id="{00710CB7-9B56-416E-8375-03E10F2A7491}"/>
               </a:ext>
             </a:extLst>
           </p:cNvPr>
@@ -2989,7 +2989,7 @@
           <p:nvPr/>
         </p:nvPicPr>
         <p:blipFill>
-          <a:blip xmlns:r="http://schemas.openxmlformats.org/officeDocument/2006/relationships" xmlns:a="http://schemas.openxmlformats.org/drawingml/2006/main" r:embed="R1d929e717c5845bd"/>
+          <a:blip xmlns:r="http://schemas.openxmlformats.org/officeDocument/2006/relationships" xmlns:a="http://schemas.openxmlformats.org/drawingml/2006/main" r:embed="Rd653157f12eb443f"/>
           <a:stretch xmlns:a="http://schemas.openxmlformats.org/drawingml/2006/main"/>
         </p:blipFill>
         <p:spPr>
@@ -3005,7 +3005,7 @@
     </p:spTree>
     <p:extLst>
       <p:ext uri="{BB962C8B-B14F-4D97-AF65-F5344CB8AC3E}">
-        <p14:creationId xmlns:p14="http://schemas.microsoft.com/office/powerpoint/2010/main" val="2001568790"/>
+        <p14:creationId xmlns:p14="http://schemas.microsoft.com/office/powerpoint/2010/main" val="919447288"/>
       </p:ext>
     </p:extLst>
   </p:cSld>
@@ -3029,7 +3029,7 @@
           <p:cNvPr id="1" name="slide-title">
             <a:extLst xmlns:a="http://schemas.openxmlformats.org/drawingml/2006/main">
               <a:ext uri="{FF2B5EF4-FFF2-40B4-BE49-F238E27FC236}">
-                <a16:creationId xmlns:a16="http://schemas.microsoft.com/office/drawing/2014/main" id="{01D5D576-C972-4891-AD3B-ED5651BCD9D6}"/>
+                <a16:creationId xmlns:a16="http://schemas.microsoft.com/office/drawing/2014/main" id="{80F4EC86-18F3-4E37-B8A1-09B82CECD07B}"/>
               </a:ext>
             </a:extLst>
           </p:cNvPr>
@@ -3074,7 +3074,7 @@
           <p:cNvPr id="2" name="slide-subtitle">
             <a:extLst xmlns:a="http://schemas.openxmlformats.org/drawingml/2006/main">
               <a:ext uri="{FF2B5EF4-FFF2-40B4-BE49-F238E27FC236}">
-                <a16:creationId xmlns:a16="http://schemas.microsoft.com/office/drawing/2014/main" id="{4EF6595D-9882-4739-A973-F4A9F5F79AA1}"/>
+                <a16:creationId xmlns:a16="http://schemas.microsoft.com/office/drawing/2014/main" id="{80BBD089-83B5-43E9-88B8-8303DBCA0770}"/>
               </a:ext>
             </a:extLst>
           </p:cNvPr>
@@ -3123,7 +3123,7 @@
           <p:nvPr/>
         </p:nvPicPr>
         <p:blipFill>
-          <a:blip xmlns:r="http://schemas.openxmlformats.org/officeDocument/2006/relationships" xmlns:a="http://schemas.openxmlformats.org/drawingml/2006/main" r:embed="R3cc8aa50121441f4"/>
+          <a:blip xmlns:r="http://schemas.openxmlformats.org/officeDocument/2006/relationships" xmlns:a="http://schemas.openxmlformats.org/drawingml/2006/main" r:embed="R5e8c08fc57714e6a"/>
           <a:stretch xmlns:a="http://schemas.openxmlformats.org/drawingml/2006/main"/>
         </p:blipFill>
         <p:spPr>
@@ -3139,7 +3139,7 @@
     </p:spTree>
     <p:extLst>
       <p:ext uri="{BB962C8B-B14F-4D97-AF65-F5344CB8AC3E}">
-        <p14:creationId xmlns:p14="http://schemas.microsoft.com/office/powerpoint/2010/main" val="1481403496"/>
+        <p14:creationId xmlns:p14="http://schemas.microsoft.com/office/powerpoint/2010/main" val="1731745421"/>
       </p:ext>
     </p:extLst>
   </p:cSld>
@@ -3163,7 +3163,7 @@
           <p:cNvPr id="1" name="slide-title">
             <a:extLst xmlns:a="http://schemas.openxmlformats.org/drawingml/2006/main">
               <a:ext uri="{FF2B5EF4-FFF2-40B4-BE49-F238E27FC236}">
-                <a16:creationId xmlns:a16="http://schemas.microsoft.com/office/drawing/2014/main" id="{FE94A279-8780-4AF8-BCE5-88EF7B895EB3}"/>
+                <a16:creationId xmlns:a16="http://schemas.microsoft.com/office/drawing/2014/main" id="{FA5999B9-B6A0-422B-8683-A495843730F3}"/>
               </a:ext>
             </a:extLst>
           </p:cNvPr>
@@ -3208,7 +3208,7 @@
           <p:cNvPr id="2" name="slide-subtitle">
             <a:extLst xmlns:a="http://schemas.openxmlformats.org/drawingml/2006/main">
               <a:ext uri="{FF2B5EF4-FFF2-40B4-BE49-F238E27FC236}">
-                <a16:creationId xmlns:a16="http://schemas.microsoft.com/office/drawing/2014/main" id="{10FA22B7-1924-4F24-9F45-F9AD237F4CAE}"/>
+                <a16:creationId xmlns:a16="http://schemas.microsoft.com/office/drawing/2014/main" id="{DEE1DEE5-E3A7-4497-9F14-705BCA5B5655}"/>
               </a:ext>
             </a:extLst>
           </p:cNvPr>
@@ -3257,7 +3257,7 @@
           <p:nvPr/>
         </p:nvPicPr>
         <p:blipFill>
-          <a:blip xmlns:r="http://schemas.openxmlformats.org/officeDocument/2006/relationships" xmlns:a="http://schemas.openxmlformats.org/drawingml/2006/main" r:embed="R0f43ebd600d64649"/>
+          <a:blip xmlns:r="http://schemas.openxmlformats.org/officeDocument/2006/relationships" xmlns:a="http://schemas.openxmlformats.org/drawingml/2006/main" r:embed="R8616add91aee48b8"/>
           <a:stretch xmlns:a="http://schemas.openxmlformats.org/drawingml/2006/main"/>
         </p:blipFill>
         <p:spPr>
@@ -3273,7 +3273,7 @@
     </p:spTree>
     <p:extLst>
       <p:ext uri="{BB962C8B-B14F-4D97-AF65-F5344CB8AC3E}">
-        <p14:creationId xmlns:p14="http://schemas.microsoft.com/office/powerpoint/2010/main" val="53420120"/>
+        <p14:creationId xmlns:p14="http://schemas.microsoft.com/office/powerpoint/2010/main" val="1789640309"/>
       </p:ext>
     </p:extLst>
   </p:cSld>
@@ -3297,7 +3297,7 @@
           <p:cNvPr id="1" name="slide-title">
             <a:extLst xmlns:a="http://schemas.openxmlformats.org/drawingml/2006/main">
               <a:ext uri="{FF2B5EF4-FFF2-40B4-BE49-F238E27FC236}">
-                <a16:creationId xmlns:a16="http://schemas.microsoft.com/office/drawing/2014/main" id="{2E8EC24F-313A-427D-B191-234826D5FB1F}"/>
+                <a16:creationId xmlns:a16="http://schemas.microsoft.com/office/drawing/2014/main" id="{6518F807-0C15-4F9B-B199-383D36DFFEE9}"/>
               </a:ext>
             </a:extLst>
           </p:cNvPr>
@@ -3342,7 +3342,7 @@
           <p:cNvPr id="2" name="slide-subtitle">
             <a:extLst xmlns:a="http://schemas.openxmlformats.org/drawingml/2006/main">
               <a:ext uri="{FF2B5EF4-FFF2-40B4-BE49-F238E27FC236}">
-                <a16:creationId xmlns:a16="http://schemas.microsoft.com/office/drawing/2014/main" id="{CCABFC6B-8895-48B5-B9F1-2C148816857D}"/>
+                <a16:creationId xmlns:a16="http://schemas.microsoft.com/office/drawing/2014/main" id="{13022133-752D-4BB3-B8AA-C1621D6BD191}"/>
               </a:ext>
             </a:extLst>
           </p:cNvPr>
@@ -3387,7 +3387,7 @@
           <p:cNvPr id="3" name="bullet-0">
             <a:extLst xmlns:a="http://schemas.openxmlformats.org/drawingml/2006/main">
               <a:ext uri="{FF2B5EF4-FFF2-40B4-BE49-F238E27FC236}">
-                <a16:creationId xmlns:a16="http://schemas.microsoft.com/office/drawing/2014/main" id="{480F7898-FAB1-47CB-9B39-5359094162EB}"/>
+                <a16:creationId xmlns:a16="http://schemas.microsoft.com/office/drawing/2014/main" id="{1C7E2466-7327-4226-9D91-D4CED1102A86}"/>
               </a:ext>
             </a:extLst>
           </p:cNvPr>
@@ -3432,7 +3432,7 @@
           <p:cNvPr id="4" name="bullet-1">
             <a:extLst xmlns:a="http://schemas.openxmlformats.org/drawingml/2006/main">
               <a:ext uri="{FF2B5EF4-FFF2-40B4-BE49-F238E27FC236}">
-                <a16:creationId xmlns:a16="http://schemas.microsoft.com/office/drawing/2014/main" id="{783F427C-2E3A-418F-8F34-6135FCD15132}"/>
+                <a16:creationId xmlns:a16="http://schemas.microsoft.com/office/drawing/2014/main" id="{DD0FF99E-5CA1-4BC9-971C-EEBB3B44C3F2}"/>
               </a:ext>
             </a:extLst>
           </p:cNvPr>
@@ -3477,7 +3477,7 @@
           <p:cNvPr id="5" name="bullet-2">
             <a:extLst xmlns:a="http://schemas.openxmlformats.org/drawingml/2006/main">
               <a:ext uri="{FF2B5EF4-FFF2-40B4-BE49-F238E27FC236}">
-                <a16:creationId xmlns:a16="http://schemas.microsoft.com/office/drawing/2014/main" id="{A6B438BF-1BBC-4DC8-8371-D3718EDC5FBF}"/>
+                <a16:creationId xmlns:a16="http://schemas.microsoft.com/office/drawing/2014/main" id="{F94D9D8B-A872-4631-8563-73F4E240A9BB}"/>
               </a:ext>
             </a:extLst>
           </p:cNvPr>
@@ -3522,7 +3522,7 @@
           <p:cNvPr id="6" name="bullet-3">
             <a:extLst xmlns:a="http://schemas.openxmlformats.org/drawingml/2006/main">
               <a:ext uri="{FF2B5EF4-FFF2-40B4-BE49-F238E27FC236}">
-                <a16:creationId xmlns:a16="http://schemas.microsoft.com/office/drawing/2014/main" id="{23FCF8DA-75D7-4DB2-A7C8-25E584755D1D}"/>
+                <a16:creationId xmlns:a16="http://schemas.microsoft.com/office/drawing/2014/main" id="{C279219F-EF60-49A0-B3B4-78F91DC15402}"/>
               </a:ext>
             </a:extLst>
           </p:cNvPr>
@@ -3567,7 +3567,7 @@
           <p:cNvPr id="7" name="bullet-4">
             <a:extLst xmlns:a="http://schemas.openxmlformats.org/drawingml/2006/main">
               <a:ext uri="{FF2B5EF4-FFF2-40B4-BE49-F238E27FC236}">
-                <a16:creationId xmlns:a16="http://schemas.microsoft.com/office/drawing/2014/main" id="{7B44A1ED-625F-4B92-A3AE-C07CA78C2357}"/>
+                <a16:creationId xmlns:a16="http://schemas.microsoft.com/office/drawing/2014/main" id="{2F5BEB86-66B8-4D2B-BD30-4B7EE8975C25}"/>
               </a:ext>
             </a:extLst>
           </p:cNvPr>
@@ -3612,7 +3612,7 @@
           <p:cNvPr id="8" name="bullet-0">
             <a:extLst xmlns:a="http://schemas.openxmlformats.org/drawingml/2006/main">
               <a:ext uri="{FF2B5EF4-FFF2-40B4-BE49-F238E27FC236}">
-                <a16:creationId xmlns:a16="http://schemas.microsoft.com/office/drawing/2014/main" id="{0C522685-E64D-480D-972D-8B37D29C45F0}"/>
+                <a16:creationId xmlns:a16="http://schemas.microsoft.com/office/drawing/2014/main" id="{CAC47D35-6485-4226-867C-390C2934B9C6}"/>
               </a:ext>
             </a:extLst>
           </p:cNvPr>
@@ -3657,7 +3657,7 @@
           <p:cNvPr id="9" name="bullet-1">
             <a:extLst xmlns:a="http://schemas.openxmlformats.org/drawingml/2006/main">
               <a:ext uri="{FF2B5EF4-FFF2-40B4-BE49-F238E27FC236}">
-                <a16:creationId xmlns:a16="http://schemas.microsoft.com/office/drawing/2014/main" id="{B39F0488-E7DF-423D-A6FB-FEF22645AE2E}"/>
+                <a16:creationId xmlns:a16="http://schemas.microsoft.com/office/drawing/2014/main" id="{17A73E26-FAB0-441F-8959-FE13744E1054}"/>
               </a:ext>
             </a:extLst>
           </p:cNvPr>
@@ -3702,7 +3702,7 @@
           <p:cNvPr id="10" name="bullet-2">
             <a:extLst xmlns:a="http://schemas.openxmlformats.org/drawingml/2006/main">
               <a:ext uri="{FF2B5EF4-FFF2-40B4-BE49-F238E27FC236}">
-                <a16:creationId xmlns:a16="http://schemas.microsoft.com/office/drawing/2014/main" id="{8D8F7C5F-4417-4CA5-8217-D2342EE130F5}"/>
+                <a16:creationId xmlns:a16="http://schemas.microsoft.com/office/drawing/2014/main" id="{67E0BE1A-D7FE-41F1-8F09-B4503D6A6594}"/>
               </a:ext>
             </a:extLst>
           </p:cNvPr>
@@ -3747,7 +3747,7 @@
           <p:cNvPr id="11" name="bullet-3">
             <a:extLst xmlns:a="http://schemas.openxmlformats.org/drawingml/2006/main">
               <a:ext uri="{FF2B5EF4-FFF2-40B4-BE49-F238E27FC236}">
-                <a16:creationId xmlns:a16="http://schemas.microsoft.com/office/drawing/2014/main" id="{D2387CFA-A6DA-461C-9272-4EBFC347698D}"/>
+                <a16:creationId xmlns:a16="http://schemas.microsoft.com/office/drawing/2014/main" id="{A197B1D9-31E4-4C9A-90D7-5674F927880A}"/>
               </a:ext>
             </a:extLst>
           </p:cNvPr>
@@ -3792,7 +3792,7 @@
           <p:cNvPr id="12" name="bullet-4">
             <a:extLst xmlns:a="http://schemas.openxmlformats.org/drawingml/2006/main">
               <a:ext uri="{FF2B5EF4-FFF2-40B4-BE49-F238E27FC236}">
-                <a16:creationId xmlns:a16="http://schemas.microsoft.com/office/drawing/2014/main" id="{8C027996-C90C-4A3D-AABC-D48069C9AD44}"/>
+                <a16:creationId xmlns:a16="http://schemas.microsoft.com/office/drawing/2014/main" id="{76B8E222-3F4A-4AAF-8213-7F11042C806F}"/>
               </a:ext>
             </a:extLst>
           </p:cNvPr>
@@ -3837,7 +3837,7 @@
           <p:cNvPr id="13" name="audit-footer">
             <a:extLst xmlns:a="http://schemas.openxmlformats.org/drawingml/2006/main">
               <a:ext uri="{FF2B5EF4-FFF2-40B4-BE49-F238E27FC236}">
-                <a16:creationId xmlns:a16="http://schemas.microsoft.com/office/drawing/2014/main" id="{98112161-75C0-400A-ACDE-854D30E433B9}"/>
+                <a16:creationId xmlns:a16="http://schemas.microsoft.com/office/drawing/2014/main" id="{4C9892D8-3674-4494-9BFD-F9BBDF6C2B78}"/>
               </a:ext>
             </a:extLst>
           </p:cNvPr>
@@ -3880,7 +3880,7 @@
     </p:spTree>
     <p:extLst>
       <p:ext uri="{BB962C8B-B14F-4D97-AF65-F5344CB8AC3E}">
-        <p14:creationId xmlns:p14="http://schemas.microsoft.com/office/powerpoint/2010/main" val="790877928"/>
+        <p14:creationId xmlns:p14="http://schemas.microsoft.com/office/powerpoint/2010/main" val="29978904"/>
       </p:ext>
     </p:extLst>
   </p:cSld>
@@ -3904,7 +3904,7 @@
           <p:cNvPr id="1" name="slide-title">
             <a:extLst xmlns:a="http://schemas.openxmlformats.org/drawingml/2006/main">
               <a:ext uri="{FF2B5EF4-FFF2-40B4-BE49-F238E27FC236}">
-                <a16:creationId xmlns:a16="http://schemas.microsoft.com/office/drawing/2014/main" id="{56A3AAA0-DBCF-464E-8435-806F385F2B87}"/>
+                <a16:creationId xmlns:a16="http://schemas.microsoft.com/office/drawing/2014/main" id="{47B0A662-A3D4-4BB8-A381-0273CB4A554F}"/>
               </a:ext>
             </a:extLst>
           </p:cNvPr>
@@ -3949,7 +3949,7 @@
           <p:cNvPr id="2" name="title-rule">
             <a:extLst xmlns:a="http://schemas.openxmlformats.org/drawingml/2006/main">
               <a:ext uri="{FF2B5EF4-FFF2-40B4-BE49-F238E27FC236}">
-                <a16:creationId xmlns:a16="http://schemas.microsoft.com/office/drawing/2014/main" id="{E7E01B54-30E8-43A4-8C7A-1971D26A685D}"/>
+                <a16:creationId xmlns:a16="http://schemas.microsoft.com/office/drawing/2014/main" id="{DECA9C25-3785-4166-BE2A-182637281D8B}"/>
               </a:ext>
             </a:extLst>
           </p:cNvPr>
@@ -3982,7 +3982,7 @@
           <p:cNvPr id="3" name="bullet-0">
             <a:extLst xmlns:a="http://schemas.openxmlformats.org/drawingml/2006/main">
               <a:ext uri="{FF2B5EF4-FFF2-40B4-BE49-F238E27FC236}">
-                <a16:creationId xmlns:a16="http://schemas.microsoft.com/office/drawing/2014/main" id="{AE0FC5FF-6706-4161-B32A-290883B3010C}"/>
+                <a16:creationId xmlns:a16="http://schemas.microsoft.com/office/drawing/2014/main" id="{ED1C44ED-C535-4C61-A594-6D6F3232C4D1}"/>
               </a:ext>
             </a:extLst>
           </p:cNvPr>
@@ -4027,7 +4027,7 @@
           <p:cNvPr id="4" name="bullet-1">
             <a:extLst xmlns:a="http://schemas.openxmlformats.org/drawingml/2006/main">
               <a:ext uri="{FF2B5EF4-FFF2-40B4-BE49-F238E27FC236}">
-                <a16:creationId xmlns:a16="http://schemas.microsoft.com/office/drawing/2014/main" id="{674627A8-8DC8-4504-A1B0-F1F8531C7339}"/>
+                <a16:creationId xmlns:a16="http://schemas.microsoft.com/office/drawing/2014/main" id="{61A3DC56-A24D-4FFD-BCFD-5E1925896736}"/>
               </a:ext>
             </a:extLst>
           </p:cNvPr>
@@ -4072,7 +4072,7 @@
           <p:cNvPr id="5" name="bullet-2">
             <a:extLst xmlns:a="http://schemas.openxmlformats.org/drawingml/2006/main">
               <a:ext uri="{FF2B5EF4-FFF2-40B4-BE49-F238E27FC236}">
-                <a16:creationId xmlns:a16="http://schemas.microsoft.com/office/drawing/2014/main" id="{5AE9F139-1FF5-4C67-8445-D8F5CCFE2EFB}"/>
+                <a16:creationId xmlns:a16="http://schemas.microsoft.com/office/drawing/2014/main" id="{51E49126-3A53-498B-A481-1187E7D220D9}"/>
               </a:ext>
             </a:extLst>
           </p:cNvPr>
@@ -4117,7 +4117,7 @@
           <p:cNvPr id="6" name="bullet-3">
             <a:extLst xmlns:a="http://schemas.openxmlformats.org/drawingml/2006/main">
               <a:ext uri="{FF2B5EF4-FFF2-40B4-BE49-F238E27FC236}">
-                <a16:creationId xmlns:a16="http://schemas.microsoft.com/office/drawing/2014/main" id="{B50D22F6-A233-4BEB-A276-9B9C7C5592D1}"/>
+                <a16:creationId xmlns:a16="http://schemas.microsoft.com/office/drawing/2014/main" id="{3314B64C-98B4-44BE-9EA5-CED2DE36CE05}"/>
               </a:ext>
             </a:extLst>
           </p:cNvPr>
@@ -4162,7 +4162,7 @@
           <p:cNvPr id="7" name="bullet-4">
             <a:extLst xmlns:a="http://schemas.openxmlformats.org/drawingml/2006/main">
               <a:ext uri="{FF2B5EF4-FFF2-40B4-BE49-F238E27FC236}">
-                <a16:creationId xmlns:a16="http://schemas.microsoft.com/office/drawing/2014/main" id="{539B3C43-149B-4E81-A409-77CEDB554A49}"/>
+                <a16:creationId xmlns:a16="http://schemas.microsoft.com/office/drawing/2014/main" id="{AAD2A684-FDE1-47A5-BE41-97AC4F152DD2}"/>
               </a:ext>
             </a:extLst>
           </p:cNvPr>
@@ -4205,7 +4205,7 @@
     </p:spTree>
     <p:extLst>
       <p:ext uri="{BB962C8B-B14F-4D97-AF65-F5344CB8AC3E}">
-        <p14:creationId xmlns:p14="http://schemas.microsoft.com/office/powerpoint/2010/main" val="1552252384"/>
+        <p14:creationId xmlns:p14="http://schemas.microsoft.com/office/powerpoint/2010/main" val="492165868"/>
       </p:ext>
     </p:extLst>
   </p:cSld>

</xml_diff>

<commit_message>
Separate trajectory reference color
</commit_message>
<xml_diff>
--- a/slides/mop_stage2_final/output/output.pptx
+++ b/slides/mop_stage2_final/output/output.pptx
@@ -2,20 +2,20 @@
 <file path=ppt/presentation.xml><?xml version="1.0" encoding="utf-8"?>
 <p:presentation xmlns:p="http://schemas.openxmlformats.org/presentationml/2006/main">
   <p:sldMasterIdLst>
-    <p:sldMasterId xmlns:r="http://schemas.openxmlformats.org/officeDocument/2006/relationships" id="2147483648" r:id="R41d604f2ad8d4dac"/>
+    <p:sldMasterId xmlns:r="http://schemas.openxmlformats.org/officeDocument/2006/relationships" id="2147483648" r:id="R141995165eab4e63"/>
   </p:sldMasterIdLst>
   <p:notesMasterIdLst>
-    <p:notesMasterId xmlns:r="http://schemas.openxmlformats.org/officeDocument/2006/relationships" r:id="R229392969a1641e6"/>
+    <p:notesMasterId xmlns:r="http://schemas.openxmlformats.org/officeDocument/2006/relationships" r:id="R4c817baf35fd4cd2"/>
   </p:notesMasterIdLst>
   <p:sldIdLst>
-    <p:sldId xmlns:r="http://schemas.openxmlformats.org/officeDocument/2006/relationships" id="256" r:id="R5863beff42844f83"/>
-    <p:sldId xmlns:r="http://schemas.openxmlformats.org/officeDocument/2006/relationships" id="257" r:id="R70e3820ca45c4c8d"/>
-    <p:sldId xmlns:r="http://schemas.openxmlformats.org/officeDocument/2006/relationships" id="258" r:id="Ra11e86026d924d24"/>
-    <p:sldId xmlns:r="http://schemas.openxmlformats.org/officeDocument/2006/relationships" id="259" r:id="R88fc264c67e24c01"/>
-    <p:sldId xmlns:r="http://schemas.openxmlformats.org/officeDocument/2006/relationships" id="260" r:id="R03297268302b4509"/>
-    <p:sldId xmlns:r="http://schemas.openxmlformats.org/officeDocument/2006/relationships" id="261" r:id="R2478ab221263467d"/>
-    <p:sldId xmlns:r="http://schemas.openxmlformats.org/officeDocument/2006/relationships" id="262" r:id="R6ade8a826c3041f5"/>
-    <p:sldId xmlns:r="http://schemas.openxmlformats.org/officeDocument/2006/relationships" id="263" r:id="R6d80aa0b00ac4d28"/>
+    <p:sldId xmlns:r="http://schemas.openxmlformats.org/officeDocument/2006/relationships" id="256" r:id="R3666d678ab8d4ba1"/>
+    <p:sldId xmlns:r="http://schemas.openxmlformats.org/officeDocument/2006/relationships" id="257" r:id="R12f8b41444c34741"/>
+    <p:sldId xmlns:r="http://schemas.openxmlformats.org/officeDocument/2006/relationships" id="258" r:id="R205c14edb270449d"/>
+    <p:sldId xmlns:r="http://schemas.openxmlformats.org/officeDocument/2006/relationships" id="259" r:id="Rb8b25cf309cd4bec"/>
+    <p:sldId xmlns:r="http://schemas.openxmlformats.org/officeDocument/2006/relationships" id="260" r:id="R2077c79ef7ee4550"/>
+    <p:sldId xmlns:r="http://schemas.openxmlformats.org/officeDocument/2006/relationships" id="261" r:id="Redca9f1dce6d4fb5"/>
+    <p:sldId xmlns:r="http://schemas.openxmlformats.org/officeDocument/2006/relationships" id="262" r:id="Rdcfe4a7a2a0d412a"/>
+    <p:sldId xmlns:r="http://schemas.openxmlformats.org/officeDocument/2006/relationships" id="263" r:id="R5f1c3f020e7d42f0"/>
   </p:sldIdLst>
   <p:sldSz cx="18288000" cy="10287000"/>
   <p:notesSz cx="6858000" cy="9144000"/>
@@ -1024,7 +1024,7 @@
   </p:cSld>
   <p:clrMap bg1="lt1" tx1="dk1" bg2="lt2" tx2="dk2" accent1="accent1" accent2="accent2" accent3="accent3" accent4="accent4" accent5="accent5" accent6="accent6" hlink="hlink" folHlink="folHlink"/>
   <p:sldLayoutIdLst>
-    <p:sldLayoutId xmlns:r="http://schemas.openxmlformats.org/officeDocument/2006/relationships" id="2147483649" r:id="R96df0cfde3cc43f4"/>
+    <p:sldLayoutId xmlns:r="http://schemas.openxmlformats.org/officeDocument/2006/relationships" id="2147483649" r:id="Rfbcb971495e2466a"/>
   </p:sldLayoutIdLst>
   <p:txStyles>
     <p:titleStyle>
@@ -1323,7 +1323,7 @@
           <p:cNvPr id="1" name="cover-title">
             <a:extLst xmlns:a="http://schemas.openxmlformats.org/drawingml/2006/main">
               <a:ext uri="{FF2B5EF4-FFF2-40B4-BE49-F238E27FC236}">
-                <a16:creationId xmlns:a16="http://schemas.microsoft.com/office/drawing/2014/main" id="{E9E3762B-33BF-47B5-B980-7207449BDF51}"/>
+                <a16:creationId xmlns:a16="http://schemas.microsoft.com/office/drawing/2014/main" id="{F9DEEF6B-13BA-4401-8FAE-018B61144AE3}"/>
               </a:ext>
             </a:extLst>
           </p:cNvPr>
@@ -1368,7 +1368,7 @@
           <p:cNvPr id="2" name="cover-rule">
             <a:extLst xmlns:a="http://schemas.openxmlformats.org/drawingml/2006/main">
               <a:ext uri="{FF2B5EF4-FFF2-40B4-BE49-F238E27FC236}">
-                <a16:creationId xmlns:a16="http://schemas.microsoft.com/office/drawing/2014/main" id="{9FCF0678-5DA3-48C3-9EBF-70C2B4549E02}"/>
+                <a16:creationId xmlns:a16="http://schemas.microsoft.com/office/drawing/2014/main" id="{26DBE35A-A6F7-4C8F-B87C-A49E6755C65B}"/>
               </a:ext>
             </a:extLst>
           </p:cNvPr>
@@ -1401,7 +1401,7 @@
           <p:cNvPr id="3" name="cover-thesis">
             <a:extLst xmlns:a="http://schemas.openxmlformats.org/drawingml/2006/main">
               <a:ext uri="{FF2B5EF4-FFF2-40B4-BE49-F238E27FC236}">
-                <a16:creationId xmlns:a16="http://schemas.microsoft.com/office/drawing/2014/main" id="{AF458420-EAB3-4A84-910C-B1EF2B748D68}"/>
+                <a16:creationId xmlns:a16="http://schemas.microsoft.com/office/drawing/2014/main" id="{40A79FFA-C621-4FAE-A4F5-64ECDAD2A86A}"/>
               </a:ext>
             </a:extLst>
           </p:cNvPr>
@@ -1446,7 +1446,7 @@
           <p:cNvPr id="4" name="cover-metric-1">
             <a:extLst xmlns:a="http://schemas.openxmlformats.org/drawingml/2006/main">
               <a:ext uri="{FF2B5EF4-FFF2-40B4-BE49-F238E27FC236}">
-                <a16:creationId xmlns:a16="http://schemas.microsoft.com/office/drawing/2014/main" id="{9CDE8440-A185-468C-BFD5-16A8B0E9C772}"/>
+                <a16:creationId xmlns:a16="http://schemas.microsoft.com/office/drawing/2014/main" id="{2B793557-ADDD-4CAC-A9E9-7FC3EB12B4FE}"/>
               </a:ext>
             </a:extLst>
           </p:cNvPr>
@@ -1491,7 +1491,7 @@
           <p:cNvPr id="5" name="cover-label-1">
             <a:extLst xmlns:a="http://schemas.openxmlformats.org/drawingml/2006/main">
               <a:ext uri="{FF2B5EF4-FFF2-40B4-BE49-F238E27FC236}">
-                <a16:creationId xmlns:a16="http://schemas.microsoft.com/office/drawing/2014/main" id="{9A0DA18A-E21F-4539-A003-5856C34FF99F}"/>
+                <a16:creationId xmlns:a16="http://schemas.microsoft.com/office/drawing/2014/main" id="{4B479B6E-531D-4DBA-B2D4-E5566A4EDB01}"/>
               </a:ext>
             </a:extLst>
           </p:cNvPr>
@@ -1536,7 +1536,7 @@
           <p:cNvPr id="6" name="cover-metric-2">
             <a:extLst xmlns:a="http://schemas.openxmlformats.org/drawingml/2006/main">
               <a:ext uri="{FF2B5EF4-FFF2-40B4-BE49-F238E27FC236}">
-                <a16:creationId xmlns:a16="http://schemas.microsoft.com/office/drawing/2014/main" id="{E4FBF75D-0376-48B3-B87B-64B1D5F00C69}"/>
+                <a16:creationId xmlns:a16="http://schemas.microsoft.com/office/drawing/2014/main" id="{DC59C764-CC20-4B76-9E49-ADD8D1A5B08A}"/>
               </a:ext>
             </a:extLst>
           </p:cNvPr>
@@ -1581,7 +1581,7 @@
           <p:cNvPr id="7" name="cover-label-2">
             <a:extLst xmlns:a="http://schemas.openxmlformats.org/drawingml/2006/main">
               <a:ext uri="{FF2B5EF4-FFF2-40B4-BE49-F238E27FC236}">
-                <a16:creationId xmlns:a16="http://schemas.microsoft.com/office/drawing/2014/main" id="{25D31144-5D87-4BA0-AD99-8B8168F75480}"/>
+                <a16:creationId xmlns:a16="http://schemas.microsoft.com/office/drawing/2014/main" id="{0C1B7047-F1CD-43A1-8CC4-EC7562E08F82}"/>
               </a:ext>
             </a:extLst>
           </p:cNvPr>
@@ -1626,7 +1626,7 @@
           <p:cNvPr id="8" name="cover-footer">
             <a:extLst xmlns:a="http://schemas.openxmlformats.org/drawingml/2006/main">
               <a:ext uri="{FF2B5EF4-FFF2-40B4-BE49-F238E27FC236}">
-                <a16:creationId xmlns:a16="http://schemas.microsoft.com/office/drawing/2014/main" id="{5CFF5CF6-208C-4263-92B0-1F1185D8E7A4}"/>
+                <a16:creationId xmlns:a16="http://schemas.microsoft.com/office/drawing/2014/main" id="{082CB0C1-E1BE-4992-A02D-933BC29C7B45}"/>
               </a:ext>
             </a:extLst>
           </p:cNvPr>
@@ -1669,7 +1669,7 @@
     </p:spTree>
     <p:extLst>
       <p:ext uri="{BB962C8B-B14F-4D97-AF65-F5344CB8AC3E}">
-        <p14:creationId xmlns:p14="http://schemas.microsoft.com/office/powerpoint/2010/main" val="179364293"/>
+        <p14:creationId xmlns:p14="http://schemas.microsoft.com/office/powerpoint/2010/main" val="1733807063"/>
       </p:ext>
     </p:extLst>
   </p:cSld>
@@ -1693,7 +1693,7 @@
           <p:cNvPr id="1" name="slide-title">
             <a:extLst xmlns:a="http://schemas.openxmlformats.org/drawingml/2006/main">
               <a:ext uri="{FF2B5EF4-FFF2-40B4-BE49-F238E27FC236}">
-                <a16:creationId xmlns:a16="http://schemas.microsoft.com/office/drawing/2014/main" id="{2C2D9EA3-E6FD-482F-80A7-35F5EFE488A1}"/>
+                <a16:creationId xmlns:a16="http://schemas.microsoft.com/office/drawing/2014/main" id="{7AA1A503-C3BA-4155-B76C-E6673CEE6F18}"/>
               </a:ext>
             </a:extLst>
           </p:cNvPr>
@@ -1738,7 +1738,7 @@
           <p:cNvPr id="2" name="slide-subtitle">
             <a:extLst xmlns:a="http://schemas.openxmlformats.org/drawingml/2006/main">
               <a:ext uri="{FF2B5EF4-FFF2-40B4-BE49-F238E27FC236}">
-                <a16:creationId xmlns:a16="http://schemas.microsoft.com/office/drawing/2014/main" id="{2BE82851-DCEB-4B5A-B885-C737C0ED3031}"/>
+                <a16:creationId xmlns:a16="http://schemas.microsoft.com/office/drawing/2014/main" id="{70168450-034C-44ED-B7C7-10906CA05340}"/>
               </a:ext>
             </a:extLst>
           </p:cNvPr>
@@ -1783,7 +1783,7 @@
           <p:cNvPr id="3" name="bullet-0">
             <a:extLst xmlns:a="http://schemas.openxmlformats.org/drawingml/2006/main">
               <a:ext uri="{FF2B5EF4-FFF2-40B4-BE49-F238E27FC236}">
-                <a16:creationId xmlns:a16="http://schemas.microsoft.com/office/drawing/2014/main" id="{5F7D0960-A51D-4F09-B040-6D5BFC4FBE3A}"/>
+                <a16:creationId xmlns:a16="http://schemas.microsoft.com/office/drawing/2014/main" id="{6F899B2D-9753-45D9-A159-04DD16888352}"/>
               </a:ext>
             </a:extLst>
           </p:cNvPr>
@@ -1828,7 +1828,7 @@
           <p:cNvPr id="4" name="bullet-1">
             <a:extLst xmlns:a="http://schemas.openxmlformats.org/drawingml/2006/main">
               <a:ext uri="{FF2B5EF4-FFF2-40B4-BE49-F238E27FC236}">
-                <a16:creationId xmlns:a16="http://schemas.microsoft.com/office/drawing/2014/main" id="{5E75341D-3F57-4EDD-82FB-B6BF713BC7C8}"/>
+                <a16:creationId xmlns:a16="http://schemas.microsoft.com/office/drawing/2014/main" id="{77CAF496-DF6A-4359-A8E0-A38B8F36E40C}"/>
               </a:ext>
             </a:extLst>
           </p:cNvPr>
@@ -1873,7 +1873,7 @@
           <p:cNvPr id="5" name="bullet-2">
             <a:extLst xmlns:a="http://schemas.openxmlformats.org/drawingml/2006/main">
               <a:ext uri="{FF2B5EF4-FFF2-40B4-BE49-F238E27FC236}">
-                <a16:creationId xmlns:a16="http://schemas.microsoft.com/office/drawing/2014/main" id="{FEB625AF-8E1D-4911-A12E-63199986A456}"/>
+                <a16:creationId xmlns:a16="http://schemas.microsoft.com/office/drawing/2014/main" id="{ACCA5F22-E8E2-4F89-AFE9-A330C5BB2865}"/>
               </a:ext>
             </a:extLst>
           </p:cNvPr>
@@ -1918,7 +1918,7 @@
           <p:cNvPr id="6" name="bullet-3">
             <a:extLst xmlns:a="http://schemas.openxmlformats.org/drawingml/2006/main">
               <a:ext uri="{FF2B5EF4-FFF2-40B4-BE49-F238E27FC236}">
-                <a16:creationId xmlns:a16="http://schemas.microsoft.com/office/drawing/2014/main" id="{EA6C2B86-C089-4D07-87FA-516A85D1DC06}"/>
+                <a16:creationId xmlns:a16="http://schemas.microsoft.com/office/drawing/2014/main" id="{1E6496AD-661B-4FA7-AF5A-E1912CA4A5C4}"/>
               </a:ext>
             </a:extLst>
           </p:cNvPr>
@@ -1963,7 +1963,7 @@
           <p:cNvPr id="7" name="bullet-0">
             <a:extLst xmlns:a="http://schemas.openxmlformats.org/drawingml/2006/main">
               <a:ext uri="{FF2B5EF4-FFF2-40B4-BE49-F238E27FC236}">
-                <a16:creationId xmlns:a16="http://schemas.microsoft.com/office/drawing/2014/main" id="{6761ECB7-067A-42BF-9AB3-9EBE0D2EA3C7}"/>
+                <a16:creationId xmlns:a16="http://schemas.microsoft.com/office/drawing/2014/main" id="{28BD0B58-887E-414C-8639-7FAF1C17E1CA}"/>
               </a:ext>
             </a:extLst>
           </p:cNvPr>
@@ -2008,7 +2008,7 @@
           <p:cNvPr id="8" name="bullet-1">
             <a:extLst xmlns:a="http://schemas.openxmlformats.org/drawingml/2006/main">
               <a:ext uri="{FF2B5EF4-FFF2-40B4-BE49-F238E27FC236}">
-                <a16:creationId xmlns:a16="http://schemas.microsoft.com/office/drawing/2014/main" id="{BCEF3C82-DEC8-4FE9-B078-03791722467B}"/>
+                <a16:creationId xmlns:a16="http://schemas.microsoft.com/office/drawing/2014/main" id="{2D2254D4-10A5-472F-A565-9EDD1C380100}"/>
               </a:ext>
             </a:extLst>
           </p:cNvPr>
@@ -2053,7 +2053,7 @@
           <p:cNvPr id="9" name="bullet-2">
             <a:extLst xmlns:a="http://schemas.openxmlformats.org/drawingml/2006/main">
               <a:ext uri="{FF2B5EF4-FFF2-40B4-BE49-F238E27FC236}">
-                <a16:creationId xmlns:a16="http://schemas.microsoft.com/office/drawing/2014/main" id="{AC0F4995-4576-430C-95A8-2E2AA3D081F4}"/>
+                <a16:creationId xmlns:a16="http://schemas.microsoft.com/office/drawing/2014/main" id="{F81ABEDC-26E1-4DD7-8BCF-EC1C23D2D719}"/>
               </a:ext>
             </a:extLst>
           </p:cNvPr>
@@ -2098,7 +2098,7 @@
           <p:cNvPr id="10" name="bullet-3">
             <a:extLst xmlns:a="http://schemas.openxmlformats.org/drawingml/2006/main">
               <a:ext uri="{FF2B5EF4-FFF2-40B4-BE49-F238E27FC236}">
-                <a16:creationId xmlns:a16="http://schemas.microsoft.com/office/drawing/2014/main" id="{93E65DE0-DF16-4F1C-8591-F9E1B8247B72}"/>
+                <a16:creationId xmlns:a16="http://schemas.microsoft.com/office/drawing/2014/main" id="{124312DF-4E9F-4BEC-9367-1E96C44ACBFE}"/>
               </a:ext>
             </a:extLst>
           </p:cNvPr>
@@ -2143,7 +2143,7 @@
           <p:cNvPr id="11" name="bullet-0">
             <a:extLst xmlns:a="http://schemas.openxmlformats.org/drawingml/2006/main">
               <a:ext uri="{FF2B5EF4-FFF2-40B4-BE49-F238E27FC236}">
-                <a16:creationId xmlns:a16="http://schemas.microsoft.com/office/drawing/2014/main" id="{D74FE309-7996-4D7E-88CD-593DC9FE3037}"/>
+                <a16:creationId xmlns:a16="http://schemas.microsoft.com/office/drawing/2014/main" id="{EC9BD5B5-F007-4680-A1EF-6CB478AD146F}"/>
               </a:ext>
             </a:extLst>
           </p:cNvPr>
@@ -2188,7 +2188,7 @@
           <p:cNvPr id="12" name="bullet-1">
             <a:extLst xmlns:a="http://schemas.openxmlformats.org/drawingml/2006/main">
               <a:ext uri="{FF2B5EF4-FFF2-40B4-BE49-F238E27FC236}">
-                <a16:creationId xmlns:a16="http://schemas.microsoft.com/office/drawing/2014/main" id="{DF30B93D-AD8A-4DF1-B85F-A4728E6AC434}"/>
+                <a16:creationId xmlns:a16="http://schemas.microsoft.com/office/drawing/2014/main" id="{0BFBDA2C-5DDA-4C45-A559-15EC85836EF0}"/>
               </a:ext>
             </a:extLst>
           </p:cNvPr>
@@ -2233,7 +2233,7 @@
           <p:cNvPr id="13" name="bullet-2">
             <a:extLst xmlns:a="http://schemas.openxmlformats.org/drawingml/2006/main">
               <a:ext uri="{FF2B5EF4-FFF2-40B4-BE49-F238E27FC236}">
-                <a16:creationId xmlns:a16="http://schemas.microsoft.com/office/drawing/2014/main" id="{62D084BB-D290-40FF-BFF0-8D3BC67D7F4E}"/>
+                <a16:creationId xmlns:a16="http://schemas.microsoft.com/office/drawing/2014/main" id="{016AB3CA-69B5-4ED4-B18E-7F555FF81C30}"/>
               </a:ext>
             </a:extLst>
           </p:cNvPr>
@@ -2278,7 +2278,7 @@
           <p:cNvPr id="14" name="bullet-3">
             <a:extLst xmlns:a="http://schemas.openxmlformats.org/drawingml/2006/main">
               <a:ext uri="{FF2B5EF4-FFF2-40B4-BE49-F238E27FC236}">
-                <a16:creationId xmlns:a16="http://schemas.microsoft.com/office/drawing/2014/main" id="{1107181C-1C07-4842-AD34-262B88309A45}"/>
+                <a16:creationId xmlns:a16="http://schemas.microsoft.com/office/drawing/2014/main" id="{25037C7E-7165-411B-8C89-58823D088BF1}"/>
               </a:ext>
             </a:extLst>
           </p:cNvPr>
@@ -2321,7 +2321,7 @@
     </p:spTree>
     <p:extLst>
       <p:ext uri="{BB962C8B-B14F-4D97-AF65-F5344CB8AC3E}">
-        <p14:creationId xmlns:p14="http://schemas.microsoft.com/office/powerpoint/2010/main" val="1554074246"/>
+        <p14:creationId xmlns:p14="http://schemas.microsoft.com/office/powerpoint/2010/main" val="721387547"/>
       </p:ext>
     </p:extLst>
   </p:cSld>
@@ -2345,7 +2345,7 @@
           <p:cNvPr id="1" name="slide-title">
             <a:extLst xmlns:a="http://schemas.openxmlformats.org/drawingml/2006/main">
               <a:ext uri="{FF2B5EF4-FFF2-40B4-BE49-F238E27FC236}">
-                <a16:creationId xmlns:a16="http://schemas.microsoft.com/office/drawing/2014/main" id="{70DB212F-F367-4072-875C-C4D8A7B0F2DB}"/>
+                <a16:creationId xmlns:a16="http://schemas.microsoft.com/office/drawing/2014/main" id="{BF20AA21-A975-4BDE-A538-19D76BFC28A5}"/>
               </a:ext>
             </a:extLst>
           </p:cNvPr>
@@ -2390,7 +2390,7 @@
           <p:cNvPr id="2" name="title-rule">
             <a:extLst xmlns:a="http://schemas.openxmlformats.org/drawingml/2006/main">
               <a:ext uri="{FF2B5EF4-FFF2-40B4-BE49-F238E27FC236}">
-                <a16:creationId xmlns:a16="http://schemas.microsoft.com/office/drawing/2014/main" id="{5B208A43-20C2-4982-9B39-DED45295B093}"/>
+                <a16:creationId xmlns:a16="http://schemas.microsoft.com/office/drawing/2014/main" id="{ED5B8A74-7891-45AF-A57F-13D4A6F35A14}"/>
               </a:ext>
             </a:extLst>
           </p:cNvPr>
@@ -2423,7 +2423,7 @@
           <p:cNvPr id="3" name="bullet-0">
             <a:extLst xmlns:a="http://schemas.openxmlformats.org/drawingml/2006/main">
               <a:ext uri="{FF2B5EF4-FFF2-40B4-BE49-F238E27FC236}">
-                <a16:creationId xmlns:a16="http://schemas.microsoft.com/office/drawing/2014/main" id="{C65D4C71-54D8-4A25-AADE-B03D8E0C1059}"/>
+                <a16:creationId xmlns:a16="http://schemas.microsoft.com/office/drawing/2014/main" id="{1EFD14CD-13BE-4F26-8CEB-B8579AB6231D}"/>
               </a:ext>
             </a:extLst>
           </p:cNvPr>
@@ -2468,7 +2468,7 @@
           <p:cNvPr id="4" name="bullet-1">
             <a:extLst xmlns:a="http://schemas.openxmlformats.org/drawingml/2006/main">
               <a:ext uri="{FF2B5EF4-FFF2-40B4-BE49-F238E27FC236}">
-                <a16:creationId xmlns:a16="http://schemas.microsoft.com/office/drawing/2014/main" id="{2D97471F-B799-45DC-A784-B03671820D94}"/>
+                <a16:creationId xmlns:a16="http://schemas.microsoft.com/office/drawing/2014/main" id="{57392DA8-D4B4-4D04-BBDF-79439836EF1B}"/>
               </a:ext>
             </a:extLst>
           </p:cNvPr>
@@ -2513,7 +2513,7 @@
           <p:cNvPr id="5" name="bullet-2">
             <a:extLst xmlns:a="http://schemas.openxmlformats.org/drawingml/2006/main">
               <a:ext uri="{FF2B5EF4-FFF2-40B4-BE49-F238E27FC236}">
-                <a16:creationId xmlns:a16="http://schemas.microsoft.com/office/drawing/2014/main" id="{1009E340-FADE-4092-A50B-218F49E8334D}"/>
+                <a16:creationId xmlns:a16="http://schemas.microsoft.com/office/drawing/2014/main" id="{8BF04B73-0330-4F16-BAAA-99DE301C90B6}"/>
               </a:ext>
             </a:extLst>
           </p:cNvPr>
@@ -2558,7 +2558,7 @@
           <p:cNvPr id="6" name="bullet-3">
             <a:extLst xmlns:a="http://schemas.openxmlformats.org/drawingml/2006/main">
               <a:ext uri="{FF2B5EF4-FFF2-40B4-BE49-F238E27FC236}">
-                <a16:creationId xmlns:a16="http://schemas.microsoft.com/office/drawing/2014/main" id="{F2A0AEBA-7D15-4420-A41C-375CFBBE5343}"/>
+                <a16:creationId xmlns:a16="http://schemas.microsoft.com/office/drawing/2014/main" id="{344BBADF-8B7F-43DA-A291-5E22DBA5C9F5}"/>
               </a:ext>
             </a:extLst>
           </p:cNvPr>
@@ -2603,7 +2603,7 @@
           <p:cNvPr id="7" name="bullet-4">
             <a:extLst xmlns:a="http://schemas.openxmlformats.org/drawingml/2006/main">
               <a:ext uri="{FF2B5EF4-FFF2-40B4-BE49-F238E27FC236}">
-                <a16:creationId xmlns:a16="http://schemas.microsoft.com/office/drawing/2014/main" id="{3256B51B-4C60-45ED-86CC-BDA88D39C545}"/>
+                <a16:creationId xmlns:a16="http://schemas.microsoft.com/office/drawing/2014/main" id="{11BD239B-F5D3-4BAB-B3B1-1EC3EFF361B3}"/>
               </a:ext>
             </a:extLst>
           </p:cNvPr>
@@ -2648,7 +2648,7 @@
           <p:cNvPr id="8" name="bullet-0">
             <a:extLst xmlns:a="http://schemas.openxmlformats.org/drawingml/2006/main">
               <a:ext uri="{FF2B5EF4-FFF2-40B4-BE49-F238E27FC236}">
-                <a16:creationId xmlns:a16="http://schemas.microsoft.com/office/drawing/2014/main" id="{D6549EB3-B152-435C-A335-156200616526}"/>
+                <a16:creationId xmlns:a16="http://schemas.microsoft.com/office/drawing/2014/main" id="{0D2418F3-178B-4113-B7C9-B99591B013DD}"/>
               </a:ext>
             </a:extLst>
           </p:cNvPr>
@@ -2693,7 +2693,7 @@
           <p:cNvPr id="9" name="bullet-1">
             <a:extLst xmlns:a="http://schemas.openxmlformats.org/drawingml/2006/main">
               <a:ext uri="{FF2B5EF4-FFF2-40B4-BE49-F238E27FC236}">
-                <a16:creationId xmlns:a16="http://schemas.microsoft.com/office/drawing/2014/main" id="{2A70479B-9E5D-4FEB-B509-FAD7EB936882}"/>
+                <a16:creationId xmlns:a16="http://schemas.microsoft.com/office/drawing/2014/main" id="{4D62D812-5524-4EB1-AFAB-2741BFCB31EE}"/>
               </a:ext>
             </a:extLst>
           </p:cNvPr>
@@ -2738,7 +2738,7 @@
           <p:cNvPr id="10" name="bullet-2">
             <a:extLst xmlns:a="http://schemas.openxmlformats.org/drawingml/2006/main">
               <a:ext uri="{FF2B5EF4-FFF2-40B4-BE49-F238E27FC236}">
-                <a16:creationId xmlns:a16="http://schemas.microsoft.com/office/drawing/2014/main" id="{EF42F35B-0AC3-4CF8-B627-69283985A043}"/>
+                <a16:creationId xmlns:a16="http://schemas.microsoft.com/office/drawing/2014/main" id="{2EC7F772-DD90-444A-90E3-EFAD4EAD7D3F}"/>
               </a:ext>
             </a:extLst>
           </p:cNvPr>
@@ -2783,7 +2783,7 @@
           <p:cNvPr id="11" name="bullet-3">
             <a:extLst xmlns:a="http://schemas.openxmlformats.org/drawingml/2006/main">
               <a:ext uri="{FF2B5EF4-FFF2-40B4-BE49-F238E27FC236}">
-                <a16:creationId xmlns:a16="http://schemas.microsoft.com/office/drawing/2014/main" id="{CE64E229-A5F4-418E-A104-3B632C5ACB8E}"/>
+                <a16:creationId xmlns:a16="http://schemas.microsoft.com/office/drawing/2014/main" id="{0CDA19DF-6866-47BB-B7DA-7F9A03BF38C3}"/>
               </a:ext>
             </a:extLst>
           </p:cNvPr>
@@ -2828,7 +2828,7 @@
           <p:cNvPr id="12" name="protocol-footer">
             <a:extLst xmlns:a="http://schemas.openxmlformats.org/drawingml/2006/main">
               <a:ext uri="{FF2B5EF4-FFF2-40B4-BE49-F238E27FC236}">
-                <a16:creationId xmlns:a16="http://schemas.microsoft.com/office/drawing/2014/main" id="{3DA69A02-6815-444D-BABA-4CCF04742622}"/>
+                <a16:creationId xmlns:a16="http://schemas.microsoft.com/office/drawing/2014/main" id="{D8BDC782-DFD2-4711-AE41-18CE356273A4}"/>
               </a:ext>
             </a:extLst>
           </p:cNvPr>
@@ -2871,7 +2871,7 @@
     </p:spTree>
     <p:extLst>
       <p:ext uri="{BB962C8B-B14F-4D97-AF65-F5344CB8AC3E}">
-        <p14:creationId xmlns:p14="http://schemas.microsoft.com/office/powerpoint/2010/main" val="384730241"/>
+        <p14:creationId xmlns:p14="http://schemas.microsoft.com/office/powerpoint/2010/main" val="2110822239"/>
       </p:ext>
     </p:extLst>
   </p:cSld>
@@ -2895,7 +2895,7 @@
           <p:cNvPr id="1" name="slide-title">
             <a:extLst xmlns:a="http://schemas.openxmlformats.org/drawingml/2006/main">
               <a:ext uri="{FF2B5EF4-FFF2-40B4-BE49-F238E27FC236}">
-                <a16:creationId xmlns:a16="http://schemas.microsoft.com/office/drawing/2014/main" id="{74FBD647-6AE3-4F8C-B0DB-DD1239BF5AAD}"/>
+                <a16:creationId xmlns:a16="http://schemas.microsoft.com/office/drawing/2014/main" id="{6333E10E-CE7D-480E-BD02-6BD795F12FC4}"/>
               </a:ext>
             </a:extLst>
           </p:cNvPr>
@@ -2940,7 +2940,7 @@
           <p:cNvPr id="2" name="slide-subtitle">
             <a:extLst xmlns:a="http://schemas.openxmlformats.org/drawingml/2006/main">
               <a:ext uri="{FF2B5EF4-FFF2-40B4-BE49-F238E27FC236}">
-                <a16:creationId xmlns:a16="http://schemas.microsoft.com/office/drawing/2014/main" id="{00710CB7-9B56-416E-8375-03E10F2A7491}"/>
+                <a16:creationId xmlns:a16="http://schemas.microsoft.com/office/drawing/2014/main" id="{57208B3F-F4F6-4C81-99A0-8126194ADDBA}"/>
               </a:ext>
             </a:extLst>
           </p:cNvPr>
@@ -2989,7 +2989,7 @@
           <p:nvPr/>
         </p:nvPicPr>
         <p:blipFill>
-          <a:blip xmlns:r="http://schemas.openxmlformats.org/officeDocument/2006/relationships" xmlns:a="http://schemas.openxmlformats.org/drawingml/2006/main" r:embed="Rd653157f12eb443f"/>
+          <a:blip xmlns:r="http://schemas.openxmlformats.org/officeDocument/2006/relationships" xmlns:a="http://schemas.openxmlformats.org/drawingml/2006/main" r:embed="Re068149242d14a02"/>
           <a:stretch xmlns:a="http://schemas.openxmlformats.org/drawingml/2006/main"/>
         </p:blipFill>
         <p:spPr>
@@ -3005,7 +3005,7 @@
     </p:spTree>
     <p:extLst>
       <p:ext uri="{BB962C8B-B14F-4D97-AF65-F5344CB8AC3E}">
-        <p14:creationId xmlns:p14="http://schemas.microsoft.com/office/powerpoint/2010/main" val="919447288"/>
+        <p14:creationId xmlns:p14="http://schemas.microsoft.com/office/powerpoint/2010/main" val="204381365"/>
       </p:ext>
     </p:extLst>
   </p:cSld>
@@ -3029,7 +3029,7 @@
           <p:cNvPr id="1" name="slide-title">
             <a:extLst xmlns:a="http://schemas.openxmlformats.org/drawingml/2006/main">
               <a:ext uri="{FF2B5EF4-FFF2-40B4-BE49-F238E27FC236}">
-                <a16:creationId xmlns:a16="http://schemas.microsoft.com/office/drawing/2014/main" id="{80F4EC86-18F3-4E37-B8A1-09B82CECD07B}"/>
+                <a16:creationId xmlns:a16="http://schemas.microsoft.com/office/drawing/2014/main" id="{0BC2B67C-54F1-4EA8-B2D9-06684A000900}"/>
               </a:ext>
             </a:extLst>
           </p:cNvPr>
@@ -3074,7 +3074,7 @@
           <p:cNvPr id="2" name="slide-subtitle">
             <a:extLst xmlns:a="http://schemas.openxmlformats.org/drawingml/2006/main">
               <a:ext uri="{FF2B5EF4-FFF2-40B4-BE49-F238E27FC236}">
-                <a16:creationId xmlns:a16="http://schemas.microsoft.com/office/drawing/2014/main" id="{80BBD089-83B5-43E9-88B8-8303DBCA0770}"/>
+                <a16:creationId xmlns:a16="http://schemas.microsoft.com/office/drawing/2014/main" id="{5F0F1A16-2085-44DB-B8BA-7CE8B39EA971}"/>
               </a:ext>
             </a:extLst>
           </p:cNvPr>
@@ -3123,7 +3123,7 @@
           <p:nvPr/>
         </p:nvPicPr>
         <p:blipFill>
-          <a:blip xmlns:r="http://schemas.openxmlformats.org/officeDocument/2006/relationships" xmlns:a="http://schemas.openxmlformats.org/drawingml/2006/main" r:embed="R5e8c08fc57714e6a"/>
+          <a:blip xmlns:r="http://schemas.openxmlformats.org/officeDocument/2006/relationships" xmlns:a="http://schemas.openxmlformats.org/drawingml/2006/main" r:embed="R3be4f65862c3444c"/>
           <a:stretch xmlns:a="http://schemas.openxmlformats.org/drawingml/2006/main"/>
         </p:blipFill>
         <p:spPr>
@@ -3139,7 +3139,7 @@
     </p:spTree>
     <p:extLst>
       <p:ext uri="{BB962C8B-B14F-4D97-AF65-F5344CB8AC3E}">
-        <p14:creationId xmlns:p14="http://schemas.microsoft.com/office/powerpoint/2010/main" val="1731745421"/>
+        <p14:creationId xmlns:p14="http://schemas.microsoft.com/office/powerpoint/2010/main" val="1877790779"/>
       </p:ext>
     </p:extLst>
   </p:cSld>
@@ -3163,7 +3163,7 @@
           <p:cNvPr id="1" name="slide-title">
             <a:extLst xmlns:a="http://schemas.openxmlformats.org/drawingml/2006/main">
               <a:ext uri="{FF2B5EF4-FFF2-40B4-BE49-F238E27FC236}">
-                <a16:creationId xmlns:a16="http://schemas.microsoft.com/office/drawing/2014/main" id="{FA5999B9-B6A0-422B-8683-A495843730F3}"/>
+                <a16:creationId xmlns:a16="http://schemas.microsoft.com/office/drawing/2014/main" id="{DCFC723F-C6C5-4011-A968-1DF83D5AB39D}"/>
               </a:ext>
             </a:extLst>
           </p:cNvPr>
@@ -3208,7 +3208,7 @@
           <p:cNvPr id="2" name="slide-subtitle">
             <a:extLst xmlns:a="http://schemas.openxmlformats.org/drawingml/2006/main">
               <a:ext uri="{FF2B5EF4-FFF2-40B4-BE49-F238E27FC236}">
-                <a16:creationId xmlns:a16="http://schemas.microsoft.com/office/drawing/2014/main" id="{DEE1DEE5-E3A7-4497-9F14-705BCA5B5655}"/>
+                <a16:creationId xmlns:a16="http://schemas.microsoft.com/office/drawing/2014/main" id="{332162A7-1DBC-4F27-BE8B-4E6C94BADEF4}"/>
               </a:ext>
             </a:extLst>
           </p:cNvPr>
@@ -3257,7 +3257,7 @@
           <p:nvPr/>
         </p:nvPicPr>
         <p:blipFill>
-          <a:blip xmlns:r="http://schemas.openxmlformats.org/officeDocument/2006/relationships" xmlns:a="http://schemas.openxmlformats.org/drawingml/2006/main" r:embed="R8616add91aee48b8"/>
+          <a:blip xmlns:r="http://schemas.openxmlformats.org/officeDocument/2006/relationships" xmlns:a="http://schemas.openxmlformats.org/drawingml/2006/main" r:embed="Rb70c3980effe44c1"/>
           <a:stretch xmlns:a="http://schemas.openxmlformats.org/drawingml/2006/main"/>
         </p:blipFill>
         <p:spPr>
@@ -3273,7 +3273,7 @@
     </p:spTree>
     <p:extLst>
       <p:ext uri="{BB962C8B-B14F-4D97-AF65-F5344CB8AC3E}">
-        <p14:creationId xmlns:p14="http://schemas.microsoft.com/office/powerpoint/2010/main" val="1789640309"/>
+        <p14:creationId xmlns:p14="http://schemas.microsoft.com/office/powerpoint/2010/main" val="1852561434"/>
       </p:ext>
     </p:extLst>
   </p:cSld>
@@ -3297,7 +3297,7 @@
           <p:cNvPr id="1" name="slide-title">
             <a:extLst xmlns:a="http://schemas.openxmlformats.org/drawingml/2006/main">
               <a:ext uri="{FF2B5EF4-FFF2-40B4-BE49-F238E27FC236}">
-                <a16:creationId xmlns:a16="http://schemas.microsoft.com/office/drawing/2014/main" id="{6518F807-0C15-4F9B-B199-383D36DFFEE9}"/>
+                <a16:creationId xmlns:a16="http://schemas.microsoft.com/office/drawing/2014/main" id="{D91CF758-0DB8-4B70-9B83-D8B470E1DCF4}"/>
               </a:ext>
             </a:extLst>
           </p:cNvPr>
@@ -3342,7 +3342,7 @@
           <p:cNvPr id="2" name="slide-subtitle">
             <a:extLst xmlns:a="http://schemas.openxmlformats.org/drawingml/2006/main">
               <a:ext uri="{FF2B5EF4-FFF2-40B4-BE49-F238E27FC236}">
-                <a16:creationId xmlns:a16="http://schemas.microsoft.com/office/drawing/2014/main" id="{13022133-752D-4BB3-B8AA-C1621D6BD191}"/>
+                <a16:creationId xmlns:a16="http://schemas.microsoft.com/office/drawing/2014/main" id="{1332639B-43A3-478A-97A7-55B29974D68C}"/>
               </a:ext>
             </a:extLst>
           </p:cNvPr>
@@ -3387,7 +3387,7 @@
           <p:cNvPr id="3" name="bullet-0">
             <a:extLst xmlns:a="http://schemas.openxmlformats.org/drawingml/2006/main">
               <a:ext uri="{FF2B5EF4-FFF2-40B4-BE49-F238E27FC236}">
-                <a16:creationId xmlns:a16="http://schemas.microsoft.com/office/drawing/2014/main" id="{1C7E2466-7327-4226-9D91-D4CED1102A86}"/>
+                <a16:creationId xmlns:a16="http://schemas.microsoft.com/office/drawing/2014/main" id="{7F10E008-F259-4BEE-A483-C8EA3FDA4250}"/>
               </a:ext>
             </a:extLst>
           </p:cNvPr>
@@ -3432,7 +3432,7 @@
           <p:cNvPr id="4" name="bullet-1">
             <a:extLst xmlns:a="http://schemas.openxmlformats.org/drawingml/2006/main">
               <a:ext uri="{FF2B5EF4-FFF2-40B4-BE49-F238E27FC236}">
-                <a16:creationId xmlns:a16="http://schemas.microsoft.com/office/drawing/2014/main" id="{DD0FF99E-5CA1-4BC9-971C-EEBB3B44C3F2}"/>
+                <a16:creationId xmlns:a16="http://schemas.microsoft.com/office/drawing/2014/main" id="{DC5848C1-C085-41C1-B651-8EB67A416ED8}"/>
               </a:ext>
             </a:extLst>
           </p:cNvPr>
@@ -3477,7 +3477,7 @@
           <p:cNvPr id="5" name="bullet-2">
             <a:extLst xmlns:a="http://schemas.openxmlformats.org/drawingml/2006/main">
               <a:ext uri="{FF2B5EF4-FFF2-40B4-BE49-F238E27FC236}">
-                <a16:creationId xmlns:a16="http://schemas.microsoft.com/office/drawing/2014/main" id="{F94D9D8B-A872-4631-8563-73F4E240A9BB}"/>
+                <a16:creationId xmlns:a16="http://schemas.microsoft.com/office/drawing/2014/main" id="{8CF48609-8EEC-4D8A-8DAF-0A64BF3DC1A2}"/>
               </a:ext>
             </a:extLst>
           </p:cNvPr>
@@ -3522,7 +3522,7 @@
           <p:cNvPr id="6" name="bullet-3">
             <a:extLst xmlns:a="http://schemas.openxmlformats.org/drawingml/2006/main">
               <a:ext uri="{FF2B5EF4-FFF2-40B4-BE49-F238E27FC236}">
-                <a16:creationId xmlns:a16="http://schemas.microsoft.com/office/drawing/2014/main" id="{C279219F-EF60-49A0-B3B4-78F91DC15402}"/>
+                <a16:creationId xmlns:a16="http://schemas.microsoft.com/office/drawing/2014/main" id="{01D6B8C8-7E75-4E01-ABE4-FAB1EF199054}"/>
               </a:ext>
             </a:extLst>
           </p:cNvPr>
@@ -3567,7 +3567,7 @@
           <p:cNvPr id="7" name="bullet-4">
             <a:extLst xmlns:a="http://schemas.openxmlformats.org/drawingml/2006/main">
               <a:ext uri="{FF2B5EF4-FFF2-40B4-BE49-F238E27FC236}">
-                <a16:creationId xmlns:a16="http://schemas.microsoft.com/office/drawing/2014/main" id="{2F5BEB86-66B8-4D2B-BD30-4B7EE8975C25}"/>
+                <a16:creationId xmlns:a16="http://schemas.microsoft.com/office/drawing/2014/main" id="{2FEE4246-1825-4A77-BEB6-E2FD345AE97C}"/>
               </a:ext>
             </a:extLst>
           </p:cNvPr>
@@ -3612,7 +3612,7 @@
           <p:cNvPr id="8" name="bullet-0">
             <a:extLst xmlns:a="http://schemas.openxmlformats.org/drawingml/2006/main">
               <a:ext uri="{FF2B5EF4-FFF2-40B4-BE49-F238E27FC236}">
-                <a16:creationId xmlns:a16="http://schemas.microsoft.com/office/drawing/2014/main" id="{CAC47D35-6485-4226-867C-390C2934B9C6}"/>
+                <a16:creationId xmlns:a16="http://schemas.microsoft.com/office/drawing/2014/main" id="{72A95794-68C6-4B58-BD12-962BCC1FEA45}"/>
               </a:ext>
             </a:extLst>
           </p:cNvPr>
@@ -3657,7 +3657,7 @@
           <p:cNvPr id="9" name="bullet-1">
             <a:extLst xmlns:a="http://schemas.openxmlformats.org/drawingml/2006/main">
               <a:ext uri="{FF2B5EF4-FFF2-40B4-BE49-F238E27FC236}">
-                <a16:creationId xmlns:a16="http://schemas.microsoft.com/office/drawing/2014/main" id="{17A73E26-FAB0-441F-8959-FE13744E1054}"/>
+                <a16:creationId xmlns:a16="http://schemas.microsoft.com/office/drawing/2014/main" id="{49635023-7898-46F4-9D31-F607D88A3B17}"/>
               </a:ext>
             </a:extLst>
           </p:cNvPr>
@@ -3702,7 +3702,7 @@
           <p:cNvPr id="10" name="bullet-2">
             <a:extLst xmlns:a="http://schemas.openxmlformats.org/drawingml/2006/main">
               <a:ext uri="{FF2B5EF4-FFF2-40B4-BE49-F238E27FC236}">
-                <a16:creationId xmlns:a16="http://schemas.microsoft.com/office/drawing/2014/main" id="{67E0BE1A-D7FE-41F1-8F09-B4503D6A6594}"/>
+                <a16:creationId xmlns:a16="http://schemas.microsoft.com/office/drawing/2014/main" id="{5CE40898-110C-4CF7-95D5-5055B02A73BE}"/>
               </a:ext>
             </a:extLst>
           </p:cNvPr>
@@ -3747,7 +3747,7 @@
           <p:cNvPr id="11" name="bullet-3">
             <a:extLst xmlns:a="http://schemas.openxmlformats.org/drawingml/2006/main">
               <a:ext uri="{FF2B5EF4-FFF2-40B4-BE49-F238E27FC236}">
-                <a16:creationId xmlns:a16="http://schemas.microsoft.com/office/drawing/2014/main" id="{A197B1D9-31E4-4C9A-90D7-5674F927880A}"/>
+                <a16:creationId xmlns:a16="http://schemas.microsoft.com/office/drawing/2014/main" id="{D9F8B00C-E04E-48C1-B6B8-DE596D7070A9}"/>
               </a:ext>
             </a:extLst>
           </p:cNvPr>
@@ -3792,7 +3792,7 @@
           <p:cNvPr id="12" name="bullet-4">
             <a:extLst xmlns:a="http://schemas.openxmlformats.org/drawingml/2006/main">
               <a:ext uri="{FF2B5EF4-FFF2-40B4-BE49-F238E27FC236}">
-                <a16:creationId xmlns:a16="http://schemas.microsoft.com/office/drawing/2014/main" id="{76B8E222-3F4A-4AAF-8213-7F11042C806F}"/>
+                <a16:creationId xmlns:a16="http://schemas.microsoft.com/office/drawing/2014/main" id="{1F02EA04-CE13-4E2B-9C93-191D8364E724}"/>
               </a:ext>
             </a:extLst>
           </p:cNvPr>
@@ -3837,7 +3837,7 @@
           <p:cNvPr id="13" name="audit-footer">
             <a:extLst xmlns:a="http://schemas.openxmlformats.org/drawingml/2006/main">
               <a:ext uri="{FF2B5EF4-FFF2-40B4-BE49-F238E27FC236}">
-                <a16:creationId xmlns:a16="http://schemas.microsoft.com/office/drawing/2014/main" id="{4C9892D8-3674-4494-9BFD-F9BBDF6C2B78}"/>
+                <a16:creationId xmlns:a16="http://schemas.microsoft.com/office/drawing/2014/main" id="{FB2F3119-2EE4-487F-8094-950C02A0AA74}"/>
               </a:ext>
             </a:extLst>
           </p:cNvPr>
@@ -3880,7 +3880,7 @@
     </p:spTree>
     <p:extLst>
       <p:ext uri="{BB962C8B-B14F-4D97-AF65-F5344CB8AC3E}">
-        <p14:creationId xmlns:p14="http://schemas.microsoft.com/office/powerpoint/2010/main" val="29978904"/>
+        <p14:creationId xmlns:p14="http://schemas.microsoft.com/office/powerpoint/2010/main" val="742132315"/>
       </p:ext>
     </p:extLst>
   </p:cSld>
@@ -3904,7 +3904,7 @@
           <p:cNvPr id="1" name="slide-title">
             <a:extLst xmlns:a="http://schemas.openxmlformats.org/drawingml/2006/main">
               <a:ext uri="{FF2B5EF4-FFF2-40B4-BE49-F238E27FC236}">
-                <a16:creationId xmlns:a16="http://schemas.microsoft.com/office/drawing/2014/main" id="{47B0A662-A3D4-4BB8-A381-0273CB4A554F}"/>
+                <a16:creationId xmlns:a16="http://schemas.microsoft.com/office/drawing/2014/main" id="{2A841057-EDAE-4C49-8B7B-86730BECB3A3}"/>
               </a:ext>
             </a:extLst>
           </p:cNvPr>
@@ -3949,7 +3949,7 @@
           <p:cNvPr id="2" name="title-rule">
             <a:extLst xmlns:a="http://schemas.openxmlformats.org/drawingml/2006/main">
               <a:ext uri="{FF2B5EF4-FFF2-40B4-BE49-F238E27FC236}">
-                <a16:creationId xmlns:a16="http://schemas.microsoft.com/office/drawing/2014/main" id="{DECA9C25-3785-4166-BE2A-182637281D8B}"/>
+                <a16:creationId xmlns:a16="http://schemas.microsoft.com/office/drawing/2014/main" id="{079429C8-B800-4FC1-9486-B11801020F9E}"/>
               </a:ext>
             </a:extLst>
           </p:cNvPr>
@@ -3982,7 +3982,7 @@
           <p:cNvPr id="3" name="bullet-0">
             <a:extLst xmlns:a="http://schemas.openxmlformats.org/drawingml/2006/main">
               <a:ext uri="{FF2B5EF4-FFF2-40B4-BE49-F238E27FC236}">
-                <a16:creationId xmlns:a16="http://schemas.microsoft.com/office/drawing/2014/main" id="{ED1C44ED-C535-4C61-A594-6D6F3232C4D1}"/>
+                <a16:creationId xmlns:a16="http://schemas.microsoft.com/office/drawing/2014/main" id="{4F72F931-CBAD-4024-BFCC-21B8608226CB}"/>
               </a:ext>
             </a:extLst>
           </p:cNvPr>
@@ -4027,7 +4027,7 @@
           <p:cNvPr id="4" name="bullet-1">
             <a:extLst xmlns:a="http://schemas.openxmlformats.org/drawingml/2006/main">
               <a:ext uri="{FF2B5EF4-FFF2-40B4-BE49-F238E27FC236}">
-                <a16:creationId xmlns:a16="http://schemas.microsoft.com/office/drawing/2014/main" id="{61A3DC56-A24D-4FFD-BCFD-5E1925896736}"/>
+                <a16:creationId xmlns:a16="http://schemas.microsoft.com/office/drawing/2014/main" id="{1FF835D9-7ED4-4F29-95BF-FE2DAFF3FA3F}"/>
               </a:ext>
             </a:extLst>
           </p:cNvPr>
@@ -4072,7 +4072,7 @@
           <p:cNvPr id="5" name="bullet-2">
             <a:extLst xmlns:a="http://schemas.openxmlformats.org/drawingml/2006/main">
               <a:ext uri="{FF2B5EF4-FFF2-40B4-BE49-F238E27FC236}">
-                <a16:creationId xmlns:a16="http://schemas.microsoft.com/office/drawing/2014/main" id="{51E49126-3A53-498B-A481-1187E7D220D9}"/>
+                <a16:creationId xmlns:a16="http://schemas.microsoft.com/office/drawing/2014/main" id="{A6E69C5C-F3EC-4F4C-9267-D07F313E6394}"/>
               </a:ext>
             </a:extLst>
           </p:cNvPr>
@@ -4117,7 +4117,7 @@
           <p:cNvPr id="6" name="bullet-3">
             <a:extLst xmlns:a="http://schemas.openxmlformats.org/drawingml/2006/main">
               <a:ext uri="{FF2B5EF4-FFF2-40B4-BE49-F238E27FC236}">
-                <a16:creationId xmlns:a16="http://schemas.microsoft.com/office/drawing/2014/main" id="{3314B64C-98B4-44BE-9EA5-CED2DE36CE05}"/>
+                <a16:creationId xmlns:a16="http://schemas.microsoft.com/office/drawing/2014/main" id="{8DE98E72-F3B8-4419-B511-7C2FD80CFF29}"/>
               </a:ext>
             </a:extLst>
           </p:cNvPr>
@@ -4162,7 +4162,7 @@
           <p:cNvPr id="7" name="bullet-4">
             <a:extLst xmlns:a="http://schemas.openxmlformats.org/drawingml/2006/main">
               <a:ext uri="{FF2B5EF4-FFF2-40B4-BE49-F238E27FC236}">
-                <a16:creationId xmlns:a16="http://schemas.microsoft.com/office/drawing/2014/main" id="{AAD2A684-FDE1-47A5-BE41-97AC4F152DD2}"/>
+                <a16:creationId xmlns:a16="http://schemas.microsoft.com/office/drawing/2014/main" id="{8D08EC7D-2BBB-49EF-B170-400A2BD47EBB}"/>
               </a:ext>
             </a:extLst>
           </p:cNvPr>
@@ -4205,7 +4205,7 @@
     </p:spTree>
     <p:extLst>
       <p:ext uri="{BB962C8B-B14F-4D97-AF65-F5344CB8AC3E}">
-        <p14:creationId xmlns:p14="http://schemas.microsoft.com/office/powerpoint/2010/main" val="492165868"/>
+        <p14:creationId xmlns:p14="http://schemas.microsoft.com/office/powerpoint/2010/main" val="706866640"/>
       </p:ext>
     </p:extLst>
   </p:cSld>

</xml_diff>

<commit_message>
Add bootstrap intervals to MoP report
</commit_message>
<xml_diff>
--- a/slides/mop_stage2_final/output/output.pptx
+++ b/slides/mop_stage2_final/output/output.pptx
@@ -2,20 +2,20 @@
 <file path=ppt/presentation.xml><?xml version="1.0" encoding="utf-8"?>
 <p:presentation xmlns:p="http://schemas.openxmlformats.org/presentationml/2006/main">
   <p:sldMasterIdLst>
-    <p:sldMasterId xmlns:r="http://schemas.openxmlformats.org/officeDocument/2006/relationships" id="2147483648" r:id="R141995165eab4e63"/>
+    <p:sldMasterId xmlns:r="http://schemas.openxmlformats.org/officeDocument/2006/relationships" id="2147483648" r:id="R60cce4f986f94473"/>
   </p:sldMasterIdLst>
   <p:notesMasterIdLst>
-    <p:notesMasterId xmlns:r="http://schemas.openxmlformats.org/officeDocument/2006/relationships" r:id="R4c817baf35fd4cd2"/>
+    <p:notesMasterId xmlns:r="http://schemas.openxmlformats.org/officeDocument/2006/relationships" r:id="R583d673759ba400b"/>
   </p:notesMasterIdLst>
   <p:sldIdLst>
-    <p:sldId xmlns:r="http://schemas.openxmlformats.org/officeDocument/2006/relationships" id="256" r:id="R3666d678ab8d4ba1"/>
-    <p:sldId xmlns:r="http://schemas.openxmlformats.org/officeDocument/2006/relationships" id="257" r:id="R12f8b41444c34741"/>
-    <p:sldId xmlns:r="http://schemas.openxmlformats.org/officeDocument/2006/relationships" id="258" r:id="R205c14edb270449d"/>
-    <p:sldId xmlns:r="http://schemas.openxmlformats.org/officeDocument/2006/relationships" id="259" r:id="Rb8b25cf309cd4bec"/>
-    <p:sldId xmlns:r="http://schemas.openxmlformats.org/officeDocument/2006/relationships" id="260" r:id="R2077c79ef7ee4550"/>
-    <p:sldId xmlns:r="http://schemas.openxmlformats.org/officeDocument/2006/relationships" id="261" r:id="Redca9f1dce6d4fb5"/>
-    <p:sldId xmlns:r="http://schemas.openxmlformats.org/officeDocument/2006/relationships" id="262" r:id="Rdcfe4a7a2a0d412a"/>
-    <p:sldId xmlns:r="http://schemas.openxmlformats.org/officeDocument/2006/relationships" id="263" r:id="R5f1c3f020e7d42f0"/>
+    <p:sldId xmlns:r="http://schemas.openxmlformats.org/officeDocument/2006/relationships" id="256" r:id="R7b30e49bcf984b1e"/>
+    <p:sldId xmlns:r="http://schemas.openxmlformats.org/officeDocument/2006/relationships" id="257" r:id="Rdadb04d80831429f"/>
+    <p:sldId xmlns:r="http://schemas.openxmlformats.org/officeDocument/2006/relationships" id="258" r:id="R574064e85915434c"/>
+    <p:sldId xmlns:r="http://schemas.openxmlformats.org/officeDocument/2006/relationships" id="259" r:id="R9e0de4de1b204941"/>
+    <p:sldId xmlns:r="http://schemas.openxmlformats.org/officeDocument/2006/relationships" id="260" r:id="Ra383a77e103443b9"/>
+    <p:sldId xmlns:r="http://schemas.openxmlformats.org/officeDocument/2006/relationships" id="261" r:id="Rcb179e27f7e945f3"/>
+    <p:sldId xmlns:r="http://schemas.openxmlformats.org/officeDocument/2006/relationships" id="262" r:id="R520b45006af34874"/>
+    <p:sldId xmlns:r="http://schemas.openxmlformats.org/officeDocument/2006/relationships" id="263" r:id="Rf64cfa7956194eac"/>
   </p:sldIdLst>
   <p:sldSz cx="18288000" cy="10287000"/>
   <p:notesSz cx="6858000" cy="9144000"/>
@@ -1024,7 +1024,7 @@
   </p:cSld>
   <p:clrMap bg1="lt1" tx1="dk1" bg2="lt2" tx2="dk2" accent1="accent1" accent2="accent2" accent3="accent3" accent4="accent4" accent5="accent5" accent6="accent6" hlink="hlink" folHlink="folHlink"/>
   <p:sldLayoutIdLst>
-    <p:sldLayoutId xmlns:r="http://schemas.openxmlformats.org/officeDocument/2006/relationships" id="2147483649" r:id="Rfbcb971495e2466a"/>
+    <p:sldLayoutId xmlns:r="http://schemas.openxmlformats.org/officeDocument/2006/relationships" id="2147483649" r:id="R6241e9bc41704228"/>
   </p:sldLayoutIdLst>
   <p:txStyles>
     <p:titleStyle>
@@ -1323,7 +1323,7 @@
           <p:cNvPr id="1" name="cover-title">
             <a:extLst xmlns:a="http://schemas.openxmlformats.org/drawingml/2006/main">
               <a:ext uri="{FF2B5EF4-FFF2-40B4-BE49-F238E27FC236}">
-                <a16:creationId xmlns:a16="http://schemas.microsoft.com/office/drawing/2014/main" id="{F9DEEF6B-13BA-4401-8FAE-018B61144AE3}"/>
+                <a16:creationId xmlns:a16="http://schemas.microsoft.com/office/drawing/2014/main" id="{E2FC62C6-146A-44EC-A519-2DD892365B3F}"/>
               </a:ext>
             </a:extLst>
           </p:cNvPr>
@@ -1368,7 +1368,7 @@
           <p:cNvPr id="2" name="cover-rule">
             <a:extLst xmlns:a="http://schemas.openxmlformats.org/drawingml/2006/main">
               <a:ext uri="{FF2B5EF4-FFF2-40B4-BE49-F238E27FC236}">
-                <a16:creationId xmlns:a16="http://schemas.microsoft.com/office/drawing/2014/main" id="{26DBE35A-A6F7-4C8F-B87C-A49E6755C65B}"/>
+                <a16:creationId xmlns:a16="http://schemas.microsoft.com/office/drawing/2014/main" id="{80D25308-2E96-42E4-BB14-0F8C84F9F3F4}"/>
               </a:ext>
             </a:extLst>
           </p:cNvPr>
@@ -1401,7 +1401,7 @@
           <p:cNvPr id="3" name="cover-thesis">
             <a:extLst xmlns:a="http://schemas.openxmlformats.org/drawingml/2006/main">
               <a:ext uri="{FF2B5EF4-FFF2-40B4-BE49-F238E27FC236}">
-                <a16:creationId xmlns:a16="http://schemas.microsoft.com/office/drawing/2014/main" id="{40A79FFA-C621-4FAE-A4F5-64ECDAD2A86A}"/>
+                <a16:creationId xmlns:a16="http://schemas.microsoft.com/office/drawing/2014/main" id="{9ED1D3F3-D531-456B-84C8-68C3EEDA91C0}"/>
               </a:ext>
             </a:extLst>
           </p:cNvPr>
@@ -1446,7 +1446,7 @@
           <p:cNvPr id="4" name="cover-metric-1">
             <a:extLst xmlns:a="http://schemas.openxmlformats.org/drawingml/2006/main">
               <a:ext uri="{FF2B5EF4-FFF2-40B4-BE49-F238E27FC236}">
-                <a16:creationId xmlns:a16="http://schemas.microsoft.com/office/drawing/2014/main" id="{2B793557-ADDD-4CAC-A9E9-7FC3EB12B4FE}"/>
+                <a16:creationId xmlns:a16="http://schemas.microsoft.com/office/drawing/2014/main" id="{A6DA1B04-8221-4E4E-AFFD-884CB7188460}"/>
               </a:ext>
             </a:extLst>
           </p:cNvPr>
@@ -1491,7 +1491,7 @@
           <p:cNvPr id="5" name="cover-label-1">
             <a:extLst xmlns:a="http://schemas.openxmlformats.org/drawingml/2006/main">
               <a:ext uri="{FF2B5EF4-FFF2-40B4-BE49-F238E27FC236}">
-                <a16:creationId xmlns:a16="http://schemas.microsoft.com/office/drawing/2014/main" id="{4B479B6E-531D-4DBA-B2D4-E5566A4EDB01}"/>
+                <a16:creationId xmlns:a16="http://schemas.microsoft.com/office/drawing/2014/main" id="{2DC50C7E-6475-422E-AA82-2790D3D7DA20}"/>
               </a:ext>
             </a:extLst>
           </p:cNvPr>
@@ -1536,7 +1536,7 @@
           <p:cNvPr id="6" name="cover-metric-2">
             <a:extLst xmlns:a="http://schemas.openxmlformats.org/drawingml/2006/main">
               <a:ext uri="{FF2B5EF4-FFF2-40B4-BE49-F238E27FC236}">
-                <a16:creationId xmlns:a16="http://schemas.microsoft.com/office/drawing/2014/main" id="{DC59C764-CC20-4B76-9E49-ADD8D1A5B08A}"/>
+                <a16:creationId xmlns:a16="http://schemas.microsoft.com/office/drawing/2014/main" id="{301202E5-C3AC-4EF8-AC33-6908315E089B}"/>
               </a:ext>
             </a:extLst>
           </p:cNvPr>
@@ -1581,7 +1581,7 @@
           <p:cNvPr id="7" name="cover-label-2">
             <a:extLst xmlns:a="http://schemas.openxmlformats.org/drawingml/2006/main">
               <a:ext uri="{FF2B5EF4-FFF2-40B4-BE49-F238E27FC236}">
-                <a16:creationId xmlns:a16="http://schemas.microsoft.com/office/drawing/2014/main" id="{0C1B7047-F1CD-43A1-8CC4-EC7562E08F82}"/>
+                <a16:creationId xmlns:a16="http://schemas.microsoft.com/office/drawing/2014/main" id="{A8F153A7-D706-4F0E-AB10-2CA2AC43FFD9}"/>
               </a:ext>
             </a:extLst>
           </p:cNvPr>
@@ -1626,7 +1626,7 @@
           <p:cNvPr id="8" name="cover-footer">
             <a:extLst xmlns:a="http://schemas.openxmlformats.org/drawingml/2006/main">
               <a:ext uri="{FF2B5EF4-FFF2-40B4-BE49-F238E27FC236}">
-                <a16:creationId xmlns:a16="http://schemas.microsoft.com/office/drawing/2014/main" id="{082CB0C1-E1BE-4992-A02D-933BC29C7B45}"/>
+                <a16:creationId xmlns:a16="http://schemas.microsoft.com/office/drawing/2014/main" id="{87AD1827-E40C-4FA9-B9E0-75D28FF3B7A8}"/>
               </a:ext>
             </a:extLst>
           </p:cNvPr>
@@ -1669,7 +1669,7 @@
     </p:spTree>
     <p:extLst>
       <p:ext uri="{BB962C8B-B14F-4D97-AF65-F5344CB8AC3E}">
-        <p14:creationId xmlns:p14="http://schemas.microsoft.com/office/powerpoint/2010/main" val="1733807063"/>
+        <p14:creationId xmlns:p14="http://schemas.microsoft.com/office/powerpoint/2010/main" val="1994483401"/>
       </p:ext>
     </p:extLst>
   </p:cSld>
@@ -1693,7 +1693,7 @@
           <p:cNvPr id="1" name="slide-title">
             <a:extLst xmlns:a="http://schemas.openxmlformats.org/drawingml/2006/main">
               <a:ext uri="{FF2B5EF4-FFF2-40B4-BE49-F238E27FC236}">
-                <a16:creationId xmlns:a16="http://schemas.microsoft.com/office/drawing/2014/main" id="{7AA1A503-C3BA-4155-B76C-E6673CEE6F18}"/>
+                <a16:creationId xmlns:a16="http://schemas.microsoft.com/office/drawing/2014/main" id="{D574C47A-1564-40FD-9A53-10883221421E}"/>
               </a:ext>
             </a:extLst>
           </p:cNvPr>
@@ -1738,7 +1738,7 @@
           <p:cNvPr id="2" name="slide-subtitle">
             <a:extLst xmlns:a="http://schemas.openxmlformats.org/drawingml/2006/main">
               <a:ext uri="{FF2B5EF4-FFF2-40B4-BE49-F238E27FC236}">
-                <a16:creationId xmlns:a16="http://schemas.microsoft.com/office/drawing/2014/main" id="{70168450-034C-44ED-B7C7-10906CA05340}"/>
+                <a16:creationId xmlns:a16="http://schemas.microsoft.com/office/drawing/2014/main" id="{1CC45660-3A20-4D30-8C64-5FF81BFDB214}"/>
               </a:ext>
             </a:extLst>
           </p:cNvPr>
@@ -1783,7 +1783,7 @@
           <p:cNvPr id="3" name="bullet-0">
             <a:extLst xmlns:a="http://schemas.openxmlformats.org/drawingml/2006/main">
               <a:ext uri="{FF2B5EF4-FFF2-40B4-BE49-F238E27FC236}">
-                <a16:creationId xmlns:a16="http://schemas.microsoft.com/office/drawing/2014/main" id="{6F899B2D-9753-45D9-A159-04DD16888352}"/>
+                <a16:creationId xmlns:a16="http://schemas.microsoft.com/office/drawing/2014/main" id="{FFF83B3E-9974-47C7-96B5-9A989053CAF4}"/>
               </a:ext>
             </a:extLst>
           </p:cNvPr>
@@ -1828,7 +1828,7 @@
           <p:cNvPr id="4" name="bullet-1">
             <a:extLst xmlns:a="http://schemas.openxmlformats.org/drawingml/2006/main">
               <a:ext uri="{FF2B5EF4-FFF2-40B4-BE49-F238E27FC236}">
-                <a16:creationId xmlns:a16="http://schemas.microsoft.com/office/drawing/2014/main" id="{77CAF496-DF6A-4359-A8E0-A38B8F36E40C}"/>
+                <a16:creationId xmlns:a16="http://schemas.microsoft.com/office/drawing/2014/main" id="{79A10AC3-E114-4707-B63B-A774EE2A6569}"/>
               </a:ext>
             </a:extLst>
           </p:cNvPr>
@@ -1873,7 +1873,7 @@
           <p:cNvPr id="5" name="bullet-2">
             <a:extLst xmlns:a="http://schemas.openxmlformats.org/drawingml/2006/main">
               <a:ext uri="{FF2B5EF4-FFF2-40B4-BE49-F238E27FC236}">
-                <a16:creationId xmlns:a16="http://schemas.microsoft.com/office/drawing/2014/main" id="{ACCA5F22-E8E2-4F89-AFE9-A330C5BB2865}"/>
+                <a16:creationId xmlns:a16="http://schemas.microsoft.com/office/drawing/2014/main" id="{4771DFA0-2B33-49CF-8167-498109FB8A30}"/>
               </a:ext>
             </a:extLst>
           </p:cNvPr>
@@ -1918,7 +1918,7 @@
           <p:cNvPr id="6" name="bullet-3">
             <a:extLst xmlns:a="http://schemas.openxmlformats.org/drawingml/2006/main">
               <a:ext uri="{FF2B5EF4-FFF2-40B4-BE49-F238E27FC236}">
-                <a16:creationId xmlns:a16="http://schemas.microsoft.com/office/drawing/2014/main" id="{1E6496AD-661B-4FA7-AF5A-E1912CA4A5C4}"/>
+                <a16:creationId xmlns:a16="http://schemas.microsoft.com/office/drawing/2014/main" id="{03A4AF6B-BC01-42AD-9EFC-5BD113AA1935}"/>
               </a:ext>
             </a:extLst>
           </p:cNvPr>
@@ -1963,7 +1963,7 @@
           <p:cNvPr id="7" name="bullet-0">
             <a:extLst xmlns:a="http://schemas.openxmlformats.org/drawingml/2006/main">
               <a:ext uri="{FF2B5EF4-FFF2-40B4-BE49-F238E27FC236}">
-                <a16:creationId xmlns:a16="http://schemas.microsoft.com/office/drawing/2014/main" id="{28BD0B58-887E-414C-8639-7FAF1C17E1CA}"/>
+                <a16:creationId xmlns:a16="http://schemas.microsoft.com/office/drawing/2014/main" id="{FF352737-AE31-4E9B-B95F-1BD4E007BF60}"/>
               </a:ext>
             </a:extLst>
           </p:cNvPr>
@@ -2008,7 +2008,7 @@
           <p:cNvPr id="8" name="bullet-1">
             <a:extLst xmlns:a="http://schemas.openxmlformats.org/drawingml/2006/main">
               <a:ext uri="{FF2B5EF4-FFF2-40B4-BE49-F238E27FC236}">
-                <a16:creationId xmlns:a16="http://schemas.microsoft.com/office/drawing/2014/main" id="{2D2254D4-10A5-472F-A565-9EDD1C380100}"/>
+                <a16:creationId xmlns:a16="http://schemas.microsoft.com/office/drawing/2014/main" id="{404DD6BE-1DB0-45A3-BF76-1B3F04E94396}"/>
               </a:ext>
             </a:extLst>
           </p:cNvPr>
@@ -2053,7 +2053,7 @@
           <p:cNvPr id="9" name="bullet-2">
             <a:extLst xmlns:a="http://schemas.openxmlformats.org/drawingml/2006/main">
               <a:ext uri="{FF2B5EF4-FFF2-40B4-BE49-F238E27FC236}">
-                <a16:creationId xmlns:a16="http://schemas.microsoft.com/office/drawing/2014/main" id="{F81ABEDC-26E1-4DD7-8BCF-EC1C23D2D719}"/>
+                <a16:creationId xmlns:a16="http://schemas.microsoft.com/office/drawing/2014/main" id="{574ADE4F-7A25-4B5A-BA12-94DAD9D21C9B}"/>
               </a:ext>
             </a:extLst>
           </p:cNvPr>
@@ -2098,7 +2098,7 @@
           <p:cNvPr id="10" name="bullet-3">
             <a:extLst xmlns:a="http://schemas.openxmlformats.org/drawingml/2006/main">
               <a:ext uri="{FF2B5EF4-FFF2-40B4-BE49-F238E27FC236}">
-                <a16:creationId xmlns:a16="http://schemas.microsoft.com/office/drawing/2014/main" id="{124312DF-4E9F-4BEC-9367-1E96C44ACBFE}"/>
+                <a16:creationId xmlns:a16="http://schemas.microsoft.com/office/drawing/2014/main" id="{9B5913DB-7380-4C43-B81E-0361AD0520B1}"/>
               </a:ext>
             </a:extLst>
           </p:cNvPr>
@@ -2143,7 +2143,7 @@
           <p:cNvPr id="11" name="bullet-0">
             <a:extLst xmlns:a="http://schemas.openxmlformats.org/drawingml/2006/main">
               <a:ext uri="{FF2B5EF4-FFF2-40B4-BE49-F238E27FC236}">
-                <a16:creationId xmlns:a16="http://schemas.microsoft.com/office/drawing/2014/main" id="{EC9BD5B5-F007-4680-A1EF-6CB478AD146F}"/>
+                <a16:creationId xmlns:a16="http://schemas.microsoft.com/office/drawing/2014/main" id="{D09B7FE2-332B-4DAE-B351-D4E821B99D91}"/>
               </a:ext>
             </a:extLst>
           </p:cNvPr>
@@ -2188,7 +2188,7 @@
           <p:cNvPr id="12" name="bullet-1">
             <a:extLst xmlns:a="http://schemas.openxmlformats.org/drawingml/2006/main">
               <a:ext uri="{FF2B5EF4-FFF2-40B4-BE49-F238E27FC236}">
-                <a16:creationId xmlns:a16="http://schemas.microsoft.com/office/drawing/2014/main" id="{0BFBDA2C-5DDA-4C45-A559-15EC85836EF0}"/>
+                <a16:creationId xmlns:a16="http://schemas.microsoft.com/office/drawing/2014/main" id="{6B32CF6B-048A-4041-99F4-6164660C8F87}"/>
               </a:ext>
             </a:extLst>
           </p:cNvPr>
@@ -2233,7 +2233,7 @@
           <p:cNvPr id="13" name="bullet-2">
             <a:extLst xmlns:a="http://schemas.openxmlformats.org/drawingml/2006/main">
               <a:ext uri="{FF2B5EF4-FFF2-40B4-BE49-F238E27FC236}">
-                <a16:creationId xmlns:a16="http://schemas.microsoft.com/office/drawing/2014/main" id="{016AB3CA-69B5-4ED4-B18E-7F555FF81C30}"/>
+                <a16:creationId xmlns:a16="http://schemas.microsoft.com/office/drawing/2014/main" id="{60B6A94D-9A18-4811-ACFC-3D585FE20BEE}"/>
               </a:ext>
             </a:extLst>
           </p:cNvPr>
@@ -2278,7 +2278,7 @@
           <p:cNvPr id="14" name="bullet-3">
             <a:extLst xmlns:a="http://schemas.openxmlformats.org/drawingml/2006/main">
               <a:ext uri="{FF2B5EF4-FFF2-40B4-BE49-F238E27FC236}">
-                <a16:creationId xmlns:a16="http://schemas.microsoft.com/office/drawing/2014/main" id="{25037C7E-7165-411B-8C89-58823D088BF1}"/>
+                <a16:creationId xmlns:a16="http://schemas.microsoft.com/office/drawing/2014/main" id="{838C8E7A-B139-4483-8C45-31AE1F0E4918}"/>
               </a:ext>
             </a:extLst>
           </p:cNvPr>
@@ -2321,7 +2321,7 @@
     </p:spTree>
     <p:extLst>
       <p:ext uri="{BB962C8B-B14F-4D97-AF65-F5344CB8AC3E}">
-        <p14:creationId xmlns:p14="http://schemas.microsoft.com/office/powerpoint/2010/main" val="721387547"/>
+        <p14:creationId xmlns:p14="http://schemas.microsoft.com/office/powerpoint/2010/main" val="786829360"/>
       </p:ext>
     </p:extLst>
   </p:cSld>
@@ -2345,7 +2345,7 @@
           <p:cNvPr id="1" name="slide-title">
             <a:extLst xmlns:a="http://schemas.openxmlformats.org/drawingml/2006/main">
               <a:ext uri="{FF2B5EF4-FFF2-40B4-BE49-F238E27FC236}">
-                <a16:creationId xmlns:a16="http://schemas.microsoft.com/office/drawing/2014/main" id="{BF20AA21-A975-4BDE-A538-19D76BFC28A5}"/>
+                <a16:creationId xmlns:a16="http://schemas.microsoft.com/office/drawing/2014/main" id="{6353F6DD-92E9-4BF0-81A8-728A890681BA}"/>
               </a:ext>
             </a:extLst>
           </p:cNvPr>
@@ -2390,7 +2390,7 @@
           <p:cNvPr id="2" name="title-rule">
             <a:extLst xmlns:a="http://schemas.openxmlformats.org/drawingml/2006/main">
               <a:ext uri="{FF2B5EF4-FFF2-40B4-BE49-F238E27FC236}">
-                <a16:creationId xmlns:a16="http://schemas.microsoft.com/office/drawing/2014/main" id="{ED5B8A74-7891-45AF-A57F-13D4A6F35A14}"/>
+                <a16:creationId xmlns:a16="http://schemas.microsoft.com/office/drawing/2014/main" id="{40BCACF8-F88D-44CD-8734-1A0CB4F49564}"/>
               </a:ext>
             </a:extLst>
           </p:cNvPr>
@@ -2423,7 +2423,7 @@
           <p:cNvPr id="3" name="bullet-0">
             <a:extLst xmlns:a="http://schemas.openxmlformats.org/drawingml/2006/main">
               <a:ext uri="{FF2B5EF4-FFF2-40B4-BE49-F238E27FC236}">
-                <a16:creationId xmlns:a16="http://schemas.microsoft.com/office/drawing/2014/main" id="{1EFD14CD-13BE-4F26-8CEB-B8579AB6231D}"/>
+                <a16:creationId xmlns:a16="http://schemas.microsoft.com/office/drawing/2014/main" id="{B27176EB-09B6-415E-B01D-1E0E5934DDA0}"/>
               </a:ext>
             </a:extLst>
           </p:cNvPr>
@@ -2435,25 +2435,25 @@
         <p:spPr>
           <a:xfrm xmlns:a="http://schemas.openxmlformats.org/drawingml/2006/main">
             <a:off x="876300" y="1771650"/>
-            <a:ext cx="7200900" cy="342900"/>
-          </a:xfrm>
-          <a:prstGeom xmlns:a="http://schemas.openxmlformats.org/drawingml/2006/main" prst="rect">
-            <a:avLst/>
-          </a:prstGeom>
-        </p:spPr>
-        <p:txBody>
-          <a:bodyPr xmlns:a="http://schemas.openxmlformats.org/drawingml/2006/main" lIns="0" tIns="0" rIns="0" bIns="0"/>
-          <a:lstStyle xmlns:a="http://schemas.openxmlformats.org/drawingml/2006/main"/>
-          <a:p xmlns:a="http://schemas.openxmlformats.org/drawingml/2006/main">
-            <a:pPr>
-              <a:defRPr sz="2175">
-                <a:solidFill>
-                  <a:srgbClr val="000000"/>
-                </a:solidFill>
-              </a:defRPr>
-            </a:pPr>
-            <a:r>
-              <a:rPr sz="2175">
+            <a:ext cx="7200900" cy="323850"/>
+          </a:xfrm>
+          <a:prstGeom xmlns:a="http://schemas.openxmlformats.org/drawingml/2006/main" prst="rect">
+            <a:avLst/>
+          </a:prstGeom>
+        </p:spPr>
+        <p:txBody>
+          <a:bodyPr xmlns:a="http://schemas.openxmlformats.org/drawingml/2006/main" lIns="0" tIns="0" rIns="0" bIns="0"/>
+          <a:lstStyle xmlns:a="http://schemas.openxmlformats.org/drawingml/2006/main"/>
+          <a:p xmlns:a="http://schemas.openxmlformats.org/drawingml/2006/main">
+            <a:pPr>
+              <a:defRPr sz="2100">
+                <a:solidFill>
+                  <a:srgbClr val="000000"/>
+                </a:solidFill>
+              </a:defRPr>
+            </a:pPr>
+            <a:r>
+              <a:rPr sz="2100">
                 <a:solidFill>
                   <a:srgbClr val="000000"/>
                 </a:solidFill>
@@ -2468,7 +2468,7 @@
           <p:cNvPr id="4" name="bullet-1">
             <a:extLst xmlns:a="http://schemas.openxmlformats.org/drawingml/2006/main">
               <a:ext uri="{FF2B5EF4-FFF2-40B4-BE49-F238E27FC236}">
-                <a16:creationId xmlns:a16="http://schemas.microsoft.com/office/drawing/2014/main" id="{57392DA8-D4B4-4D04-BBDF-79439836EF1B}"/>
+                <a16:creationId xmlns:a16="http://schemas.microsoft.com/office/drawing/2014/main" id="{6FACCED3-7166-45EE-9529-500732A13449}"/>
               </a:ext>
             </a:extLst>
           </p:cNvPr>
@@ -2480,25 +2480,25 @@
         <p:spPr>
           <a:xfrm xmlns:a="http://schemas.openxmlformats.org/drawingml/2006/main">
             <a:off x="876300" y="2247900"/>
-            <a:ext cx="7200900" cy="342900"/>
-          </a:xfrm>
-          <a:prstGeom xmlns:a="http://schemas.openxmlformats.org/drawingml/2006/main" prst="rect">
-            <a:avLst/>
-          </a:prstGeom>
-        </p:spPr>
-        <p:txBody>
-          <a:bodyPr xmlns:a="http://schemas.openxmlformats.org/drawingml/2006/main" lIns="0" tIns="0" rIns="0" bIns="0"/>
-          <a:lstStyle xmlns:a="http://schemas.openxmlformats.org/drawingml/2006/main"/>
-          <a:p xmlns:a="http://schemas.openxmlformats.org/drawingml/2006/main">
-            <a:pPr>
-              <a:defRPr sz="2175">
-                <a:solidFill>
-                  <a:srgbClr val="000000"/>
-                </a:solidFill>
-              </a:defRPr>
-            </a:pPr>
-            <a:r>
-              <a:rPr sz="2175">
+            <a:ext cx="7200900" cy="323850"/>
+          </a:xfrm>
+          <a:prstGeom xmlns:a="http://schemas.openxmlformats.org/drawingml/2006/main" prst="rect">
+            <a:avLst/>
+          </a:prstGeom>
+        </p:spPr>
+        <p:txBody>
+          <a:bodyPr xmlns:a="http://schemas.openxmlformats.org/drawingml/2006/main" lIns="0" tIns="0" rIns="0" bIns="0"/>
+          <a:lstStyle xmlns:a="http://schemas.openxmlformats.org/drawingml/2006/main"/>
+          <a:p xmlns:a="http://schemas.openxmlformats.org/drawingml/2006/main">
+            <a:pPr>
+              <a:defRPr sz="2100">
+                <a:solidFill>
+                  <a:srgbClr val="000000"/>
+                </a:solidFill>
+              </a:defRPr>
+            </a:pPr>
+            <a:r>
+              <a:rPr sz="2100">
                 <a:solidFill>
                   <a:srgbClr val="000000"/>
                 </a:solidFill>
@@ -2513,42 +2513,42 @@
           <p:cNvPr id="5" name="bullet-2">
             <a:extLst xmlns:a="http://schemas.openxmlformats.org/drawingml/2006/main">
               <a:ext uri="{FF2B5EF4-FFF2-40B4-BE49-F238E27FC236}">
-                <a16:creationId xmlns:a16="http://schemas.microsoft.com/office/drawing/2014/main" id="{8BF04B73-0330-4F16-BAAA-99DE301C90B6}"/>
-              </a:ext>
-            </a:extLst>
-          </p:cNvPr>
-          <p:cNvSpPr>
-            <a:spLocks xmlns:a="http://schemas.openxmlformats.org/drawingml/2006/main" noGrp="1"/>
-          </p:cNvSpPr>
-          <p:nvPr/>
-        </p:nvSpPr>
-        <p:spPr>
-          <a:xfrm xmlns:a="http://schemas.openxmlformats.org/drawingml/2006/main">
-            <a:off x="876300" y="2743200"/>
-            <a:ext cx="7200900" cy="342900"/>
-          </a:xfrm>
-          <a:prstGeom xmlns:a="http://schemas.openxmlformats.org/drawingml/2006/main" prst="rect">
-            <a:avLst/>
-          </a:prstGeom>
-        </p:spPr>
-        <p:txBody>
-          <a:bodyPr xmlns:a="http://schemas.openxmlformats.org/drawingml/2006/main" lIns="0" tIns="0" rIns="0" bIns="0"/>
-          <a:lstStyle xmlns:a="http://schemas.openxmlformats.org/drawingml/2006/main"/>
-          <a:p xmlns:a="http://schemas.openxmlformats.org/drawingml/2006/main">
-            <a:pPr>
-              <a:defRPr sz="2175">
-                <a:solidFill>
-                  <a:srgbClr val="000000"/>
-                </a:solidFill>
-              </a:defRPr>
-            </a:pPr>
-            <a:r>
-              <a:rPr sz="2175">
-                <a:solidFill>
-                  <a:srgbClr val="000000"/>
-                </a:solidFill>
-              </a:rPr>
-              <a:t>Search: 10 training traces</a:t>
+                <a16:creationId xmlns:a16="http://schemas.microsoft.com/office/drawing/2014/main" id="{B3F87F2C-DAFB-4D5F-80AF-927D5F7E76F6}"/>
+              </a:ext>
+            </a:extLst>
+          </p:cNvPr>
+          <p:cNvSpPr>
+            <a:spLocks xmlns:a="http://schemas.openxmlformats.org/drawingml/2006/main" noGrp="1"/>
+          </p:cNvSpPr>
+          <p:nvPr/>
+        </p:nvSpPr>
+        <p:spPr>
+          <a:xfrm xmlns:a="http://schemas.openxmlformats.org/drawingml/2006/main">
+            <a:off x="876300" y="2724150"/>
+            <a:ext cx="7200900" cy="323850"/>
+          </a:xfrm>
+          <a:prstGeom xmlns:a="http://schemas.openxmlformats.org/drawingml/2006/main" prst="rect">
+            <a:avLst/>
+          </a:prstGeom>
+        </p:spPr>
+        <p:txBody>
+          <a:bodyPr xmlns:a="http://schemas.openxmlformats.org/drawingml/2006/main" lIns="0" tIns="0" rIns="0" bIns="0"/>
+          <a:lstStyle xmlns:a="http://schemas.openxmlformats.org/drawingml/2006/main"/>
+          <a:p xmlns:a="http://schemas.openxmlformats.org/drawingml/2006/main">
+            <a:pPr>
+              <a:defRPr sz="2100">
+                <a:solidFill>
+                  <a:srgbClr val="000000"/>
+                </a:solidFill>
+              </a:defRPr>
+            </a:pPr>
+            <a:r>
+              <a:rPr sz="2100">
+                <a:solidFill>
+                  <a:srgbClr val="000000"/>
+                </a:solidFill>
+              </a:rPr>
+              <a:t>Most candidate iterations: 3 training traces</a:t>
             </a:r>
           </a:p>
         </p:txBody>
@@ -2558,42 +2558,42 @@
           <p:cNvPr id="6" name="bullet-3">
             <a:extLst xmlns:a="http://schemas.openxmlformats.org/drawingml/2006/main">
               <a:ext uri="{FF2B5EF4-FFF2-40B4-BE49-F238E27FC236}">
-                <a16:creationId xmlns:a16="http://schemas.microsoft.com/office/drawing/2014/main" id="{344BBADF-8B7F-43DA-A291-5E22DBA5C9F5}"/>
-              </a:ext>
-            </a:extLst>
-          </p:cNvPr>
-          <p:cNvSpPr>
-            <a:spLocks xmlns:a="http://schemas.openxmlformats.org/drawingml/2006/main" noGrp="1"/>
-          </p:cNvSpPr>
-          <p:nvPr/>
-        </p:nvSpPr>
-        <p:spPr>
-          <a:xfrm xmlns:a="http://schemas.openxmlformats.org/drawingml/2006/main">
-            <a:off x="876300" y="3219450"/>
-            <a:ext cx="7200900" cy="342900"/>
-          </a:xfrm>
-          <a:prstGeom xmlns:a="http://schemas.openxmlformats.org/drawingml/2006/main" prst="rect">
-            <a:avLst/>
-          </a:prstGeom>
-        </p:spPr>
-        <p:txBody>
-          <a:bodyPr xmlns:a="http://schemas.openxmlformats.org/drawingml/2006/main" lIns="0" tIns="0" rIns="0" bIns="0"/>
-          <a:lstStyle xmlns:a="http://schemas.openxmlformats.org/drawingml/2006/main"/>
-          <a:p xmlns:a="http://schemas.openxmlformats.org/drawingml/2006/main">
-            <a:pPr>
-              <a:defRPr sz="2175">
-                <a:solidFill>
-                  <a:srgbClr val="000000"/>
-                </a:solidFill>
-              </a:defRPr>
-            </a:pPr>
-            <a:r>
-              <a:rPr sz="2175">
-                <a:solidFill>
-                  <a:srgbClr val="000000"/>
-                </a:solidFill>
-              </a:rPr>
-              <a:t>Training-split validation: 13 local traces</a:t>
+                <a16:creationId xmlns:a16="http://schemas.microsoft.com/office/drawing/2014/main" id="{E82BBF2A-209C-4AC2-A41C-0117D9DF3B22}"/>
+              </a:ext>
+            </a:extLst>
+          </p:cNvPr>
+          <p:cNvSpPr>
+            <a:spLocks xmlns:a="http://schemas.openxmlformats.org/drawingml/2006/main" noGrp="1"/>
+          </p:cNvSpPr>
+          <p:nvPr/>
+        </p:nvSpPr>
+        <p:spPr>
+          <a:xfrm xmlns:a="http://schemas.openxmlformats.org/drawingml/2006/main">
+            <a:off x="876300" y="3181350"/>
+            <a:ext cx="7200900" cy="323850"/>
+          </a:xfrm>
+          <a:prstGeom xmlns:a="http://schemas.openxmlformats.org/drawingml/2006/main" prst="rect">
+            <a:avLst/>
+          </a:prstGeom>
+        </p:spPr>
+        <p:txBody>
+          <a:bodyPr xmlns:a="http://schemas.openxmlformats.org/drawingml/2006/main" lIns="0" tIns="0" rIns="0" bIns="0"/>
+          <a:lstStyle xmlns:a="http://schemas.openxmlformats.org/drawingml/2006/main"/>
+          <a:p xmlns:a="http://schemas.openxmlformats.org/drawingml/2006/main">
+            <a:pPr>
+              <a:defRPr sz="2100">
+                <a:solidFill>
+                  <a:srgbClr val="000000"/>
+                </a:solidFill>
+              </a:defRPr>
+            </a:pPr>
+            <a:r>
+              <a:rPr sz="2100">
+                <a:solidFill>
+                  <a:srgbClr val="000000"/>
+                </a:solidFill>
+              </a:rPr>
+              <a:t>Promising candidates: 10 training traces</a:t>
             </a:r>
           </a:p>
         </p:txBody>
@@ -2603,37 +2603,82 @@
           <p:cNvPr id="7" name="bullet-4">
             <a:extLst xmlns:a="http://schemas.openxmlformats.org/drawingml/2006/main">
               <a:ext uri="{FF2B5EF4-FFF2-40B4-BE49-F238E27FC236}">
-                <a16:creationId xmlns:a16="http://schemas.microsoft.com/office/drawing/2014/main" id="{11BD239B-F5D3-4BAB-B3B1-1EC3EFF361B3}"/>
-              </a:ext>
-            </a:extLst>
-          </p:cNvPr>
-          <p:cNvSpPr>
-            <a:spLocks xmlns:a="http://schemas.openxmlformats.org/drawingml/2006/main" noGrp="1"/>
-          </p:cNvSpPr>
-          <p:nvPr/>
-        </p:nvSpPr>
-        <p:spPr>
-          <a:xfrm xmlns:a="http://schemas.openxmlformats.org/drawingml/2006/main">
-            <a:off x="876300" y="3714750"/>
-            <a:ext cx="7200900" cy="342900"/>
-          </a:xfrm>
-          <a:prstGeom xmlns:a="http://schemas.openxmlformats.org/drawingml/2006/main" prst="rect">
-            <a:avLst/>
-          </a:prstGeom>
-        </p:spPr>
-        <p:txBody>
-          <a:bodyPr xmlns:a="http://schemas.openxmlformats.org/drawingml/2006/main" lIns="0" tIns="0" rIns="0" bIns="0"/>
-          <a:lstStyle xmlns:a="http://schemas.openxmlformats.org/drawingml/2006/main"/>
-          <a:p xmlns:a="http://schemas.openxmlformats.org/drawingml/2006/main">
-            <a:pPr>
-              <a:defRPr sz="2175">
-                <a:solidFill>
-                  <a:srgbClr val="000000"/>
-                </a:solidFill>
-              </a:defRPr>
-            </a:pPr>
-            <a:r>
-              <a:rPr sz="2175">
+                <a16:creationId xmlns:a16="http://schemas.microsoft.com/office/drawing/2014/main" id="{5640E5C8-86FE-4E7C-9416-1916E72E1F04}"/>
+              </a:ext>
+            </a:extLst>
+          </p:cNvPr>
+          <p:cNvSpPr>
+            <a:spLocks xmlns:a="http://schemas.openxmlformats.org/drawingml/2006/main" noGrp="1"/>
+          </p:cNvSpPr>
+          <p:nvPr/>
+        </p:nvSpPr>
+        <p:spPr>
+          <a:xfrm xmlns:a="http://schemas.openxmlformats.org/drawingml/2006/main">
+            <a:off x="876300" y="3657600"/>
+            <a:ext cx="7200900" cy="323850"/>
+          </a:xfrm>
+          <a:prstGeom xmlns:a="http://schemas.openxmlformats.org/drawingml/2006/main" prst="rect">
+            <a:avLst/>
+          </a:prstGeom>
+        </p:spPr>
+        <p:txBody>
+          <a:bodyPr xmlns:a="http://schemas.openxmlformats.org/drawingml/2006/main" lIns="0" tIns="0" rIns="0" bIns="0"/>
+          <a:lstStyle xmlns:a="http://schemas.openxmlformats.org/drawingml/2006/main"/>
+          <a:p xmlns:a="http://schemas.openxmlformats.org/drawingml/2006/main">
+            <a:pPr>
+              <a:defRPr sz="2100">
+                <a:solidFill>
+                  <a:srgbClr val="000000"/>
+                </a:solidFill>
+              </a:defRPr>
+            </a:pPr>
+            <a:r>
+              <a:rPr sz="2100">
+                <a:solidFill>
+                  <a:srgbClr val="000000"/>
+                </a:solidFill>
+              </a:rPr>
+              <a:t>Final training-split validation: 13 traces</a:t>
+            </a:r>
+          </a:p>
+        </p:txBody>
+      </p:sp>
+      <p:sp>
+        <p:nvSpPr>
+          <p:cNvPr id="8" name="bullet-5">
+            <a:extLst xmlns:a="http://schemas.openxmlformats.org/drawingml/2006/main">
+              <a:ext uri="{FF2B5EF4-FFF2-40B4-BE49-F238E27FC236}">
+                <a16:creationId xmlns:a16="http://schemas.microsoft.com/office/drawing/2014/main" id="{987D2E4A-29C5-4CB5-A6D3-C7206CE63F80}"/>
+              </a:ext>
+            </a:extLst>
+          </p:cNvPr>
+          <p:cNvSpPr>
+            <a:spLocks xmlns:a="http://schemas.openxmlformats.org/drawingml/2006/main" noGrp="1"/>
+          </p:cNvSpPr>
+          <p:nvPr/>
+        </p:nvSpPr>
+        <p:spPr>
+          <a:xfrm xmlns:a="http://schemas.openxmlformats.org/drawingml/2006/main">
+            <a:off x="876300" y="4133850"/>
+            <a:ext cx="7200900" cy="323850"/>
+          </a:xfrm>
+          <a:prstGeom xmlns:a="http://schemas.openxmlformats.org/drawingml/2006/main" prst="rect">
+            <a:avLst/>
+          </a:prstGeom>
+        </p:spPr>
+        <p:txBody>
+          <a:bodyPr xmlns:a="http://schemas.openxmlformats.org/drawingml/2006/main" lIns="0" tIns="0" rIns="0" bIns="0"/>
+          <a:lstStyle xmlns:a="http://schemas.openxmlformats.org/drawingml/2006/main"/>
+          <a:p xmlns:a="http://schemas.openxmlformats.org/drawingml/2006/main">
+            <a:pPr>
+              <a:defRPr sz="2100">
+                <a:solidFill>
+                  <a:srgbClr val="000000"/>
+                </a:solidFill>
+              </a:defRPr>
+            </a:pPr>
+            <a:r>
+              <a:rPr sz="2100">
                 <a:solidFill>
                   <a:srgbClr val="000000"/>
                 </a:solidFill>
@@ -2645,10 +2690,10 @@
       </p:sp>
       <p:sp>
         <p:nvSpPr>
-          <p:cNvPr id="8" name="bullet-0">
-            <a:extLst xmlns:a="http://schemas.openxmlformats.org/drawingml/2006/main">
-              <a:ext uri="{FF2B5EF4-FFF2-40B4-BE49-F238E27FC236}">
-                <a16:creationId xmlns:a16="http://schemas.microsoft.com/office/drawing/2014/main" id="{0D2418F3-178B-4113-B7C9-B99591B013DD}"/>
+          <p:cNvPr id="9" name="bullet-0">
+            <a:extLst xmlns:a="http://schemas.openxmlformats.org/drawingml/2006/main">
+              <a:ext uri="{FF2B5EF4-FFF2-40B4-BE49-F238E27FC236}">
+                <a16:creationId xmlns:a16="http://schemas.microsoft.com/office/drawing/2014/main" id="{B3E913AC-5D80-4CAA-AC1F-B231CE7D3E85}"/>
               </a:ext>
             </a:extLst>
           </p:cNvPr>
@@ -2690,10 +2735,10 @@
       </p:sp>
       <p:sp>
         <p:nvSpPr>
-          <p:cNvPr id="9" name="bullet-1">
-            <a:extLst xmlns:a="http://schemas.openxmlformats.org/drawingml/2006/main">
-              <a:ext uri="{FF2B5EF4-FFF2-40B4-BE49-F238E27FC236}">
-                <a16:creationId xmlns:a16="http://schemas.microsoft.com/office/drawing/2014/main" id="{4D62D812-5524-4EB1-AFAB-2741BFCB31EE}"/>
+          <p:cNvPr id="10" name="bullet-1">
+            <a:extLst xmlns:a="http://schemas.openxmlformats.org/drawingml/2006/main">
+              <a:ext uri="{FF2B5EF4-FFF2-40B4-BE49-F238E27FC236}">
+                <a16:creationId xmlns:a16="http://schemas.microsoft.com/office/drawing/2014/main" id="{4345BD07-C5C5-4433-B930-5942213E81D4}"/>
               </a:ext>
             </a:extLst>
           </p:cNvPr>
@@ -2735,10 +2780,10 @@
       </p:sp>
       <p:sp>
         <p:nvSpPr>
-          <p:cNvPr id="10" name="bullet-2">
-            <a:extLst xmlns:a="http://schemas.openxmlformats.org/drawingml/2006/main">
-              <a:ext uri="{FF2B5EF4-FFF2-40B4-BE49-F238E27FC236}">
-                <a16:creationId xmlns:a16="http://schemas.microsoft.com/office/drawing/2014/main" id="{2EC7F772-DD90-444A-90E3-EFAD4EAD7D3F}"/>
+          <p:cNvPr id="11" name="bullet-2">
+            <a:extLst xmlns:a="http://schemas.openxmlformats.org/drawingml/2006/main">
+              <a:ext uri="{FF2B5EF4-FFF2-40B4-BE49-F238E27FC236}">
+                <a16:creationId xmlns:a16="http://schemas.microsoft.com/office/drawing/2014/main" id="{BBC52DB9-87A7-4E5A-8864-E5E0F9C47C02}"/>
               </a:ext>
             </a:extLst>
           </p:cNvPr>
@@ -2780,10 +2825,10 @@
       </p:sp>
       <p:sp>
         <p:nvSpPr>
-          <p:cNvPr id="11" name="bullet-3">
-            <a:extLst xmlns:a="http://schemas.openxmlformats.org/drawingml/2006/main">
-              <a:ext uri="{FF2B5EF4-FFF2-40B4-BE49-F238E27FC236}">
-                <a16:creationId xmlns:a16="http://schemas.microsoft.com/office/drawing/2014/main" id="{0CDA19DF-6866-47BB-B7DA-7F9A03BF38C3}"/>
+          <p:cNvPr id="12" name="bullet-3">
+            <a:extLst xmlns:a="http://schemas.openxmlformats.org/drawingml/2006/main">
+              <a:ext uri="{FF2B5EF4-FFF2-40B4-BE49-F238E27FC236}">
+                <a16:creationId xmlns:a16="http://schemas.microsoft.com/office/drawing/2014/main" id="{EAA7347F-125D-4A54-A962-CD1B51B613A8}"/>
               </a:ext>
             </a:extLst>
           </p:cNvPr>
@@ -2825,10 +2870,10 @@
       </p:sp>
       <p:sp>
         <p:nvSpPr>
-          <p:cNvPr id="12" name="protocol-footer">
-            <a:extLst xmlns:a="http://schemas.openxmlformats.org/drawingml/2006/main">
-              <a:ext uri="{FF2B5EF4-FFF2-40B4-BE49-F238E27FC236}">
-                <a16:creationId xmlns:a16="http://schemas.microsoft.com/office/drawing/2014/main" id="{D8BDC782-DFD2-4711-AE41-18CE356273A4}"/>
+          <p:cNvPr id="13" name="protocol-footer">
+            <a:extLst xmlns:a="http://schemas.openxmlformats.org/drawingml/2006/main">
+              <a:ext uri="{FF2B5EF4-FFF2-40B4-BE49-F238E27FC236}">
+                <a16:creationId xmlns:a16="http://schemas.microsoft.com/office/drawing/2014/main" id="{62BD5987-8A7B-4731-BF17-8B3971EFD870}"/>
               </a:ext>
             </a:extLst>
           </p:cNvPr>
@@ -2871,7 +2916,7 @@
     </p:spTree>
     <p:extLst>
       <p:ext uri="{BB962C8B-B14F-4D97-AF65-F5344CB8AC3E}">
-        <p14:creationId xmlns:p14="http://schemas.microsoft.com/office/powerpoint/2010/main" val="2110822239"/>
+        <p14:creationId xmlns:p14="http://schemas.microsoft.com/office/powerpoint/2010/main" val="81353145"/>
       </p:ext>
     </p:extLst>
   </p:cSld>
@@ -2895,7 +2940,7 @@
           <p:cNvPr id="1" name="slide-title">
             <a:extLst xmlns:a="http://schemas.openxmlformats.org/drawingml/2006/main">
               <a:ext uri="{FF2B5EF4-FFF2-40B4-BE49-F238E27FC236}">
-                <a16:creationId xmlns:a16="http://schemas.microsoft.com/office/drawing/2014/main" id="{6333E10E-CE7D-480E-BD02-6BD795F12FC4}"/>
+                <a16:creationId xmlns:a16="http://schemas.microsoft.com/office/drawing/2014/main" id="{6EC42E3C-D740-4056-A1C1-787CC8180BD2}"/>
               </a:ext>
             </a:extLst>
           </p:cNvPr>
@@ -2940,7 +2985,7 @@
           <p:cNvPr id="2" name="slide-subtitle">
             <a:extLst xmlns:a="http://schemas.openxmlformats.org/drawingml/2006/main">
               <a:ext uri="{FF2B5EF4-FFF2-40B4-BE49-F238E27FC236}">
-                <a16:creationId xmlns:a16="http://schemas.microsoft.com/office/drawing/2014/main" id="{57208B3F-F4F6-4C81-99A0-8126194ADDBA}"/>
+                <a16:creationId xmlns:a16="http://schemas.microsoft.com/office/drawing/2014/main" id="{06AF53AA-FF7C-4871-8C71-A4E2B387AE1C}"/>
               </a:ext>
             </a:extLst>
           </p:cNvPr>
@@ -2975,7 +3020,7 @@
                   <a:srgbClr val="000000"/>
                 </a:solidFill>
               </a:rPr>
-              <a:t>Bars use disabled prefetching as 1x. Yellow marks show the per-trace best expert.</a:t>
+              <a:t>Bars use disabled prefetching as 1x. Error bars are trace-bootstrap 95% CIs.</a:t>
             </a:r>
           </a:p>
         </p:txBody>
@@ -2989,7 +3034,7 @@
           <p:nvPr/>
         </p:nvPicPr>
         <p:blipFill>
-          <a:blip xmlns:r="http://schemas.openxmlformats.org/officeDocument/2006/relationships" xmlns:a="http://schemas.openxmlformats.org/drawingml/2006/main" r:embed="Re068149242d14a02"/>
+          <a:blip xmlns:r="http://schemas.openxmlformats.org/officeDocument/2006/relationships" xmlns:a="http://schemas.openxmlformats.org/drawingml/2006/main" r:embed="Rcf128b08314f4e4f"/>
           <a:stretch xmlns:a="http://schemas.openxmlformats.org/drawingml/2006/main"/>
         </p:blipFill>
         <p:spPr>
@@ -3005,7 +3050,7 @@
     </p:spTree>
     <p:extLst>
       <p:ext uri="{BB962C8B-B14F-4D97-AF65-F5344CB8AC3E}">
-        <p14:creationId xmlns:p14="http://schemas.microsoft.com/office/powerpoint/2010/main" val="204381365"/>
+        <p14:creationId xmlns:p14="http://schemas.microsoft.com/office/powerpoint/2010/main" val="1511686111"/>
       </p:ext>
     </p:extLst>
   </p:cSld>
@@ -3029,7 +3074,7 @@
           <p:cNvPr id="1" name="slide-title">
             <a:extLst xmlns:a="http://schemas.openxmlformats.org/drawingml/2006/main">
               <a:ext uri="{FF2B5EF4-FFF2-40B4-BE49-F238E27FC236}">
-                <a16:creationId xmlns:a16="http://schemas.microsoft.com/office/drawing/2014/main" id="{0BC2B67C-54F1-4EA8-B2D9-06684A000900}"/>
+                <a16:creationId xmlns:a16="http://schemas.microsoft.com/office/drawing/2014/main" id="{515DD3A3-0B78-46AC-80AE-BBE9ACF2A153}"/>
               </a:ext>
             </a:extLst>
           </p:cNvPr>
@@ -3074,7 +3119,7 @@
           <p:cNvPr id="2" name="slide-subtitle">
             <a:extLst xmlns:a="http://schemas.openxmlformats.org/drawingml/2006/main">
               <a:ext uri="{FF2B5EF4-FFF2-40B4-BE49-F238E27FC236}">
-                <a16:creationId xmlns:a16="http://schemas.microsoft.com/office/drawing/2014/main" id="{5F0F1A16-2085-44DB-B8BA-7CE8B39EA971}"/>
+                <a16:creationId xmlns:a16="http://schemas.microsoft.com/office/drawing/2014/main" id="{FC5DA9FA-12DF-4549-8ED0-07F0DE05808D}"/>
               </a:ext>
             </a:extLst>
           </p:cNvPr>
@@ -3123,7 +3168,7 @@
           <p:nvPr/>
         </p:nvPicPr>
         <p:blipFill>
-          <a:blip xmlns:r="http://schemas.openxmlformats.org/officeDocument/2006/relationships" xmlns:a="http://schemas.openxmlformats.org/drawingml/2006/main" r:embed="R3be4f65862c3444c"/>
+          <a:blip xmlns:r="http://schemas.openxmlformats.org/officeDocument/2006/relationships" xmlns:a="http://schemas.openxmlformats.org/drawingml/2006/main" r:embed="Rc353ec1a7b304847"/>
           <a:stretch xmlns:a="http://schemas.openxmlformats.org/drawingml/2006/main"/>
         </p:blipFill>
         <p:spPr>
@@ -3139,7 +3184,7 @@
     </p:spTree>
     <p:extLst>
       <p:ext uri="{BB962C8B-B14F-4D97-AF65-F5344CB8AC3E}">
-        <p14:creationId xmlns:p14="http://schemas.microsoft.com/office/powerpoint/2010/main" val="1877790779"/>
+        <p14:creationId xmlns:p14="http://schemas.microsoft.com/office/powerpoint/2010/main" val="2001530194"/>
       </p:ext>
     </p:extLst>
   </p:cSld>
@@ -3163,7 +3208,7 @@
           <p:cNvPr id="1" name="slide-title">
             <a:extLst xmlns:a="http://schemas.openxmlformats.org/drawingml/2006/main">
               <a:ext uri="{FF2B5EF4-FFF2-40B4-BE49-F238E27FC236}">
-                <a16:creationId xmlns:a16="http://schemas.microsoft.com/office/drawing/2014/main" id="{DCFC723F-C6C5-4011-A968-1DF83D5AB39D}"/>
+                <a16:creationId xmlns:a16="http://schemas.microsoft.com/office/drawing/2014/main" id="{8BC61091-2E91-48DD-B239-5F4929A71601}"/>
               </a:ext>
             </a:extLst>
           </p:cNvPr>
@@ -3208,7 +3253,7 @@
           <p:cNvPr id="2" name="slide-subtitle">
             <a:extLst xmlns:a="http://schemas.openxmlformats.org/drawingml/2006/main">
               <a:ext uri="{FF2B5EF4-FFF2-40B4-BE49-F238E27FC236}">
-                <a16:creationId xmlns:a16="http://schemas.microsoft.com/office/drawing/2014/main" id="{332162A7-1DBC-4F27-BE8B-4E6C94BADEF4}"/>
+                <a16:creationId xmlns:a16="http://schemas.microsoft.com/office/drawing/2014/main" id="{9A59BB9E-1737-4055-9064-05250A8F5DB3}"/>
               </a:ext>
             </a:extLst>
           </p:cNvPr>
@@ -3243,7 +3288,7 @@
                   <a:srgbClr val="000000"/>
                 </a:solidFill>
               </a:rPr>
-              <a:t>Left: 3-trace quick evaluation. Right: 10-trace wider validation. Lines show best-so-far by weighted score.</a:t>
+              <a:t>Faint dashed lines are score-selected incumbent IPC. Solid lines are best IPC seen so far.</a:t>
             </a:r>
           </a:p>
         </p:txBody>
@@ -3257,7 +3302,7 @@
           <p:nvPr/>
         </p:nvPicPr>
         <p:blipFill>
-          <a:blip xmlns:r="http://schemas.openxmlformats.org/officeDocument/2006/relationships" xmlns:a="http://schemas.openxmlformats.org/drawingml/2006/main" r:embed="Rb70c3980effe44c1"/>
+          <a:blip xmlns:r="http://schemas.openxmlformats.org/officeDocument/2006/relationships" xmlns:a="http://schemas.openxmlformats.org/drawingml/2006/main" r:embed="R1eca9cc1ea534932"/>
           <a:stretch xmlns:a="http://schemas.openxmlformats.org/drawingml/2006/main"/>
         </p:blipFill>
         <p:spPr>
@@ -3273,7 +3318,7 @@
     </p:spTree>
     <p:extLst>
       <p:ext uri="{BB962C8B-B14F-4D97-AF65-F5344CB8AC3E}">
-        <p14:creationId xmlns:p14="http://schemas.microsoft.com/office/powerpoint/2010/main" val="1852561434"/>
+        <p14:creationId xmlns:p14="http://schemas.microsoft.com/office/powerpoint/2010/main" val="1204723668"/>
       </p:ext>
     </p:extLst>
   </p:cSld>
@@ -3297,7 +3342,7 @@
           <p:cNvPr id="1" name="slide-title">
             <a:extLst xmlns:a="http://schemas.openxmlformats.org/drawingml/2006/main">
               <a:ext uri="{FF2B5EF4-FFF2-40B4-BE49-F238E27FC236}">
-                <a16:creationId xmlns:a16="http://schemas.microsoft.com/office/drawing/2014/main" id="{D91CF758-0DB8-4B70-9B83-D8B470E1DCF4}"/>
+                <a16:creationId xmlns:a16="http://schemas.microsoft.com/office/drawing/2014/main" id="{65EEEE16-F478-43B1-B90F-E1B88E1D8F1A}"/>
               </a:ext>
             </a:extLst>
           </p:cNvPr>
@@ -3342,7 +3387,7 @@
           <p:cNvPr id="2" name="slide-subtitle">
             <a:extLst xmlns:a="http://schemas.openxmlformats.org/drawingml/2006/main">
               <a:ext uri="{FF2B5EF4-FFF2-40B4-BE49-F238E27FC236}">
-                <a16:creationId xmlns:a16="http://schemas.microsoft.com/office/drawing/2014/main" id="{1332639B-43A3-478A-97A7-55B29974D68C}"/>
+                <a16:creationId xmlns:a16="http://schemas.microsoft.com/office/drawing/2014/main" id="{39C69878-9F3F-4EB9-84E3-857E2E8CE23F}"/>
               </a:ext>
             </a:extLst>
           </p:cNvPr>
@@ -3377,7 +3422,7 @@
                   <a:srgbClr val="000000"/>
                 </a:solidFill>
               </a:rPr>
-              <a:t>Candidate programs changed a literal policy dictionary.</a:t>
+              <a:t>Candidate programs changed a literal policy dictionary. Weighted score combines best-expert closeness, IPC, weaker-prefetcher margin, and tail-loss penalties.</a:t>
             </a:r>
           </a:p>
         </p:txBody>
@@ -3387,7 +3432,7 @@
           <p:cNvPr id="3" name="bullet-0">
             <a:extLst xmlns:a="http://schemas.openxmlformats.org/drawingml/2006/main">
               <a:ext uri="{FF2B5EF4-FFF2-40B4-BE49-F238E27FC236}">
-                <a16:creationId xmlns:a16="http://schemas.microsoft.com/office/drawing/2014/main" id="{7F10E008-F259-4BEE-A483-C8EA3FDA4250}"/>
+                <a16:creationId xmlns:a16="http://schemas.microsoft.com/office/drawing/2014/main" id="{978CA6D3-DDE6-45AC-A382-B2D2253D3FB2}"/>
               </a:ext>
             </a:extLst>
           </p:cNvPr>
@@ -3432,7 +3477,7 @@
           <p:cNvPr id="4" name="bullet-1">
             <a:extLst xmlns:a="http://schemas.openxmlformats.org/drawingml/2006/main">
               <a:ext uri="{FF2B5EF4-FFF2-40B4-BE49-F238E27FC236}">
-                <a16:creationId xmlns:a16="http://schemas.microsoft.com/office/drawing/2014/main" id="{DC5848C1-C085-41C1-B651-8EB67A416ED8}"/>
+                <a16:creationId xmlns:a16="http://schemas.microsoft.com/office/drawing/2014/main" id="{45C0F5D5-E839-4464-B3CC-9E293A372CA5}"/>
               </a:ext>
             </a:extLst>
           </p:cNvPr>
@@ -3477,7 +3522,7 @@
           <p:cNvPr id="5" name="bullet-2">
             <a:extLst xmlns:a="http://schemas.openxmlformats.org/drawingml/2006/main">
               <a:ext uri="{FF2B5EF4-FFF2-40B4-BE49-F238E27FC236}">
-                <a16:creationId xmlns:a16="http://schemas.microsoft.com/office/drawing/2014/main" id="{8CF48609-8EEC-4D8A-8DAF-0A64BF3DC1A2}"/>
+                <a16:creationId xmlns:a16="http://schemas.microsoft.com/office/drawing/2014/main" id="{73459FE7-C894-464F-BEEF-BD5182AED191}"/>
               </a:ext>
             </a:extLst>
           </p:cNvPr>
@@ -3522,7 +3567,7 @@
           <p:cNvPr id="6" name="bullet-3">
             <a:extLst xmlns:a="http://schemas.openxmlformats.org/drawingml/2006/main">
               <a:ext uri="{FF2B5EF4-FFF2-40B4-BE49-F238E27FC236}">
-                <a16:creationId xmlns:a16="http://schemas.microsoft.com/office/drawing/2014/main" id="{01D6B8C8-7E75-4E01-ABE4-FAB1EF199054}"/>
+                <a16:creationId xmlns:a16="http://schemas.microsoft.com/office/drawing/2014/main" id="{222DB438-EBA6-49DB-9E4B-59AAE269FBF1}"/>
               </a:ext>
             </a:extLst>
           </p:cNvPr>
@@ -3567,7 +3612,7 @@
           <p:cNvPr id="7" name="bullet-4">
             <a:extLst xmlns:a="http://schemas.openxmlformats.org/drawingml/2006/main">
               <a:ext uri="{FF2B5EF4-FFF2-40B4-BE49-F238E27FC236}">
-                <a16:creationId xmlns:a16="http://schemas.microsoft.com/office/drawing/2014/main" id="{2FEE4246-1825-4A77-BEB6-E2FD345AE97C}"/>
+                <a16:creationId xmlns:a16="http://schemas.microsoft.com/office/drawing/2014/main" id="{D86D1D9E-8128-4C3F-9381-6C1B9D2E4ED9}"/>
               </a:ext>
             </a:extLst>
           </p:cNvPr>
@@ -3612,7 +3657,7 @@
           <p:cNvPr id="8" name="bullet-0">
             <a:extLst xmlns:a="http://schemas.openxmlformats.org/drawingml/2006/main">
               <a:ext uri="{FF2B5EF4-FFF2-40B4-BE49-F238E27FC236}">
-                <a16:creationId xmlns:a16="http://schemas.microsoft.com/office/drawing/2014/main" id="{72A95794-68C6-4B58-BD12-962BCC1FEA45}"/>
+                <a16:creationId xmlns:a16="http://schemas.microsoft.com/office/drawing/2014/main" id="{D10DDBE0-AB2C-4646-80CA-5A75E9ECD8C6}"/>
               </a:ext>
             </a:extLst>
           </p:cNvPr>
@@ -3657,7 +3702,7 @@
           <p:cNvPr id="9" name="bullet-1">
             <a:extLst xmlns:a="http://schemas.openxmlformats.org/drawingml/2006/main">
               <a:ext uri="{FF2B5EF4-FFF2-40B4-BE49-F238E27FC236}">
-                <a16:creationId xmlns:a16="http://schemas.microsoft.com/office/drawing/2014/main" id="{49635023-7898-46F4-9D31-F607D88A3B17}"/>
+                <a16:creationId xmlns:a16="http://schemas.microsoft.com/office/drawing/2014/main" id="{4BAA111B-DF12-4991-9CE2-B973106B5DEE}"/>
               </a:ext>
             </a:extLst>
           </p:cNvPr>
@@ -3702,7 +3747,7 @@
           <p:cNvPr id="10" name="bullet-2">
             <a:extLst xmlns:a="http://schemas.openxmlformats.org/drawingml/2006/main">
               <a:ext uri="{FF2B5EF4-FFF2-40B4-BE49-F238E27FC236}">
-                <a16:creationId xmlns:a16="http://schemas.microsoft.com/office/drawing/2014/main" id="{5CE40898-110C-4CF7-95D5-5055B02A73BE}"/>
+                <a16:creationId xmlns:a16="http://schemas.microsoft.com/office/drawing/2014/main" id="{CB3F32D7-7218-48AA-B9D9-F98B7F32881B}"/>
               </a:ext>
             </a:extLst>
           </p:cNvPr>
@@ -3747,7 +3792,7 @@
           <p:cNvPr id="11" name="bullet-3">
             <a:extLst xmlns:a="http://schemas.openxmlformats.org/drawingml/2006/main">
               <a:ext uri="{FF2B5EF4-FFF2-40B4-BE49-F238E27FC236}">
-                <a16:creationId xmlns:a16="http://schemas.microsoft.com/office/drawing/2014/main" id="{D9F8B00C-E04E-48C1-B6B8-DE596D7070A9}"/>
+                <a16:creationId xmlns:a16="http://schemas.microsoft.com/office/drawing/2014/main" id="{31499375-5758-43C1-A9AE-09B756B36113}"/>
               </a:ext>
             </a:extLst>
           </p:cNvPr>
@@ -3792,7 +3837,7 @@
           <p:cNvPr id="12" name="bullet-4">
             <a:extLst xmlns:a="http://schemas.openxmlformats.org/drawingml/2006/main">
               <a:ext uri="{FF2B5EF4-FFF2-40B4-BE49-F238E27FC236}">
-                <a16:creationId xmlns:a16="http://schemas.microsoft.com/office/drawing/2014/main" id="{1F02EA04-CE13-4E2B-9C93-191D8364E724}"/>
+                <a16:creationId xmlns:a16="http://schemas.microsoft.com/office/drawing/2014/main" id="{381FA29B-5E8A-47C1-A4DA-179870D56F76}"/>
               </a:ext>
             </a:extLst>
           </p:cNvPr>
@@ -3837,7 +3882,7 @@
           <p:cNvPr id="13" name="audit-footer">
             <a:extLst xmlns:a="http://schemas.openxmlformats.org/drawingml/2006/main">
               <a:ext uri="{FF2B5EF4-FFF2-40B4-BE49-F238E27FC236}">
-                <a16:creationId xmlns:a16="http://schemas.microsoft.com/office/drawing/2014/main" id="{FB2F3119-2EE4-487F-8094-950C02A0AA74}"/>
+                <a16:creationId xmlns:a16="http://schemas.microsoft.com/office/drawing/2014/main" id="{38EFDF14-6075-4A7A-9FFF-12FA8446A03C}"/>
               </a:ext>
             </a:extLst>
           </p:cNvPr>
@@ -3872,7 +3917,7 @@
                   <a:srgbClr val="000000"/>
                 </a:solidFill>
               </a:rPr>
-              <a:t>Ledger: 374 candidates, 306 valid scored rows, 68 fail-closed rows. Malformed or crashed candidates receive combined_score = -10.0.</a:t>
+              <a:t>Ledger: 374 candidates, 306 valid scored rows, 68 fail-closed rows. Invalid or crashed candidates received the configured failure score and stayed in the audit ledger.</a:t>
             </a:r>
           </a:p>
         </p:txBody>
@@ -3880,7 +3925,7 @@
     </p:spTree>
     <p:extLst>
       <p:ext uri="{BB962C8B-B14F-4D97-AF65-F5344CB8AC3E}">
-        <p14:creationId xmlns:p14="http://schemas.microsoft.com/office/powerpoint/2010/main" val="742132315"/>
+        <p14:creationId xmlns:p14="http://schemas.microsoft.com/office/powerpoint/2010/main" val="755766074"/>
       </p:ext>
     </p:extLst>
   </p:cSld>
@@ -3904,7 +3949,7 @@
           <p:cNvPr id="1" name="slide-title">
             <a:extLst xmlns:a="http://schemas.openxmlformats.org/drawingml/2006/main">
               <a:ext uri="{FF2B5EF4-FFF2-40B4-BE49-F238E27FC236}">
-                <a16:creationId xmlns:a16="http://schemas.microsoft.com/office/drawing/2014/main" id="{2A841057-EDAE-4C49-8B7B-86730BECB3A3}"/>
+                <a16:creationId xmlns:a16="http://schemas.microsoft.com/office/drawing/2014/main" id="{0417DF28-4613-4F42-8EE4-893121010D3C}"/>
               </a:ext>
             </a:extLst>
           </p:cNvPr>
@@ -3949,7 +3994,7 @@
           <p:cNvPr id="2" name="title-rule">
             <a:extLst xmlns:a="http://schemas.openxmlformats.org/drawingml/2006/main">
               <a:ext uri="{FF2B5EF4-FFF2-40B4-BE49-F238E27FC236}">
-                <a16:creationId xmlns:a16="http://schemas.microsoft.com/office/drawing/2014/main" id="{079429C8-B800-4FC1-9486-B11801020F9E}"/>
+                <a16:creationId xmlns:a16="http://schemas.microsoft.com/office/drawing/2014/main" id="{54237075-E376-4A1D-8E45-347647D32951}"/>
               </a:ext>
             </a:extLst>
           </p:cNvPr>
@@ -3982,7 +4027,7 @@
           <p:cNvPr id="3" name="bullet-0">
             <a:extLst xmlns:a="http://schemas.openxmlformats.org/drawingml/2006/main">
               <a:ext uri="{FF2B5EF4-FFF2-40B4-BE49-F238E27FC236}">
-                <a16:creationId xmlns:a16="http://schemas.microsoft.com/office/drawing/2014/main" id="{4F72F931-CBAD-4024-BFCC-21B8608226CB}"/>
+                <a16:creationId xmlns:a16="http://schemas.microsoft.com/office/drawing/2014/main" id="{0981D791-1B51-48BB-AC0F-86D56E6160E3}"/>
               </a:ext>
             </a:extLst>
           </p:cNvPr>
@@ -4027,7 +4072,7 @@
           <p:cNvPr id="4" name="bullet-1">
             <a:extLst xmlns:a="http://schemas.openxmlformats.org/drawingml/2006/main">
               <a:ext uri="{FF2B5EF4-FFF2-40B4-BE49-F238E27FC236}">
-                <a16:creationId xmlns:a16="http://schemas.microsoft.com/office/drawing/2014/main" id="{1FF835D9-7ED4-4F29-95BF-FE2DAFF3FA3F}"/>
+                <a16:creationId xmlns:a16="http://schemas.microsoft.com/office/drawing/2014/main" id="{CCAA2681-9089-4796-951C-935D3F1D9F68}"/>
               </a:ext>
             </a:extLst>
           </p:cNvPr>
@@ -4072,7 +4117,7 @@
           <p:cNvPr id="5" name="bullet-2">
             <a:extLst xmlns:a="http://schemas.openxmlformats.org/drawingml/2006/main">
               <a:ext uri="{FF2B5EF4-FFF2-40B4-BE49-F238E27FC236}">
-                <a16:creationId xmlns:a16="http://schemas.microsoft.com/office/drawing/2014/main" id="{A6E69C5C-F3EC-4F4C-9267-D07F313E6394}"/>
+                <a16:creationId xmlns:a16="http://schemas.microsoft.com/office/drawing/2014/main" id="{803CF45C-B1F1-414F-BCC4-59B8471D1972}"/>
               </a:ext>
             </a:extLst>
           </p:cNvPr>
@@ -4117,7 +4162,7 @@
           <p:cNvPr id="6" name="bullet-3">
             <a:extLst xmlns:a="http://schemas.openxmlformats.org/drawingml/2006/main">
               <a:ext uri="{FF2B5EF4-FFF2-40B4-BE49-F238E27FC236}">
-                <a16:creationId xmlns:a16="http://schemas.microsoft.com/office/drawing/2014/main" id="{8DE98E72-F3B8-4419-B511-7C2FD80CFF29}"/>
+                <a16:creationId xmlns:a16="http://schemas.microsoft.com/office/drawing/2014/main" id="{5D30B09C-F53C-4396-B628-8AB7068AC3FB}"/>
               </a:ext>
             </a:extLst>
           </p:cNvPr>
@@ -4162,7 +4207,7 @@
           <p:cNvPr id="7" name="bullet-4">
             <a:extLst xmlns:a="http://schemas.openxmlformats.org/drawingml/2006/main">
               <a:ext uri="{FF2B5EF4-FFF2-40B4-BE49-F238E27FC236}">
-                <a16:creationId xmlns:a16="http://schemas.microsoft.com/office/drawing/2014/main" id="{8D08EC7D-2BBB-49EF-B170-400A2BD47EBB}"/>
+                <a16:creationId xmlns:a16="http://schemas.microsoft.com/office/drawing/2014/main" id="{4B6AA880-2730-4A38-AE86-CC2D2AB57C3C}"/>
               </a:ext>
             </a:extLst>
           </p:cNvPr>
@@ -4205,7 +4250,7 @@
     </p:spTree>
     <p:extLst>
       <p:ext uri="{BB962C8B-B14F-4D97-AF65-F5344CB8AC3E}">
-        <p14:creationId xmlns:p14="http://schemas.microsoft.com/office/powerpoint/2010/main" val="706866640"/>
+        <p14:creationId xmlns:p14="http://schemas.microsoft.com/office/powerpoint/2010/main" val="59381970"/>
       </p:ext>
     </p:extLst>
   </p:cSld>

</xml_diff>

<commit_message>
Clean MoP report visuals
</commit_message>
<xml_diff>
--- a/slides/mop_stage2_final/output/output.pptx
+++ b/slides/mop_stage2_final/output/output.pptx
@@ -2,20 +2,20 @@
 <file path=ppt/presentation.xml><?xml version="1.0" encoding="utf-8"?>
 <p:presentation xmlns:p="http://schemas.openxmlformats.org/presentationml/2006/main">
   <p:sldMasterIdLst>
-    <p:sldMasterId xmlns:r="http://schemas.openxmlformats.org/officeDocument/2006/relationships" id="2147483648" r:id="R60cce4f986f94473"/>
+    <p:sldMasterId xmlns:r="http://schemas.openxmlformats.org/officeDocument/2006/relationships" id="2147483648" r:id="R2f69f911492d4536"/>
   </p:sldMasterIdLst>
   <p:notesMasterIdLst>
-    <p:notesMasterId xmlns:r="http://schemas.openxmlformats.org/officeDocument/2006/relationships" r:id="R583d673759ba400b"/>
+    <p:notesMasterId xmlns:r="http://schemas.openxmlformats.org/officeDocument/2006/relationships" r:id="R525ab306be8642e2"/>
   </p:notesMasterIdLst>
   <p:sldIdLst>
-    <p:sldId xmlns:r="http://schemas.openxmlformats.org/officeDocument/2006/relationships" id="256" r:id="R7b30e49bcf984b1e"/>
-    <p:sldId xmlns:r="http://schemas.openxmlformats.org/officeDocument/2006/relationships" id="257" r:id="Rdadb04d80831429f"/>
-    <p:sldId xmlns:r="http://schemas.openxmlformats.org/officeDocument/2006/relationships" id="258" r:id="R574064e85915434c"/>
-    <p:sldId xmlns:r="http://schemas.openxmlformats.org/officeDocument/2006/relationships" id="259" r:id="R9e0de4de1b204941"/>
-    <p:sldId xmlns:r="http://schemas.openxmlformats.org/officeDocument/2006/relationships" id="260" r:id="Ra383a77e103443b9"/>
-    <p:sldId xmlns:r="http://schemas.openxmlformats.org/officeDocument/2006/relationships" id="261" r:id="Rcb179e27f7e945f3"/>
-    <p:sldId xmlns:r="http://schemas.openxmlformats.org/officeDocument/2006/relationships" id="262" r:id="R520b45006af34874"/>
-    <p:sldId xmlns:r="http://schemas.openxmlformats.org/officeDocument/2006/relationships" id="263" r:id="Rf64cfa7956194eac"/>
+    <p:sldId xmlns:r="http://schemas.openxmlformats.org/officeDocument/2006/relationships" id="256" r:id="R5ab54ac3ab8b406b"/>
+    <p:sldId xmlns:r="http://schemas.openxmlformats.org/officeDocument/2006/relationships" id="257" r:id="R37a20a67f7e94191"/>
+    <p:sldId xmlns:r="http://schemas.openxmlformats.org/officeDocument/2006/relationships" id="258" r:id="R1139a747e2eb4473"/>
+    <p:sldId xmlns:r="http://schemas.openxmlformats.org/officeDocument/2006/relationships" id="259" r:id="R20b0ae66009d4aaa"/>
+    <p:sldId xmlns:r="http://schemas.openxmlformats.org/officeDocument/2006/relationships" id="260" r:id="R118f3ac2c43b44a8"/>
+    <p:sldId xmlns:r="http://schemas.openxmlformats.org/officeDocument/2006/relationships" id="261" r:id="R1b1c737912834c9b"/>
+    <p:sldId xmlns:r="http://schemas.openxmlformats.org/officeDocument/2006/relationships" id="262" r:id="Rad3c13aba11e4684"/>
+    <p:sldId xmlns:r="http://schemas.openxmlformats.org/officeDocument/2006/relationships" id="263" r:id="R07d9a4d458874ba9"/>
   </p:sldIdLst>
   <p:sldSz cx="18288000" cy="10287000"/>
   <p:notesSz cx="6858000" cy="9144000"/>
@@ -1024,7 +1024,7 @@
   </p:cSld>
   <p:clrMap bg1="lt1" tx1="dk1" bg2="lt2" tx2="dk2" accent1="accent1" accent2="accent2" accent3="accent3" accent4="accent4" accent5="accent5" accent6="accent6" hlink="hlink" folHlink="folHlink"/>
   <p:sldLayoutIdLst>
-    <p:sldLayoutId xmlns:r="http://schemas.openxmlformats.org/officeDocument/2006/relationships" id="2147483649" r:id="R6241e9bc41704228"/>
+    <p:sldLayoutId xmlns:r="http://schemas.openxmlformats.org/officeDocument/2006/relationships" id="2147483649" r:id="R370a2d495ae84f21"/>
   </p:sldLayoutIdLst>
   <p:txStyles>
     <p:titleStyle>
@@ -1323,7 +1323,7 @@
           <p:cNvPr id="1" name="cover-title">
             <a:extLst xmlns:a="http://schemas.openxmlformats.org/drawingml/2006/main">
               <a:ext uri="{FF2B5EF4-FFF2-40B4-BE49-F238E27FC236}">
-                <a16:creationId xmlns:a16="http://schemas.microsoft.com/office/drawing/2014/main" id="{E2FC62C6-146A-44EC-A519-2DD892365B3F}"/>
+                <a16:creationId xmlns:a16="http://schemas.microsoft.com/office/drawing/2014/main" id="{104842F8-13F0-49CA-94FB-789117233FD1}"/>
               </a:ext>
             </a:extLst>
           </p:cNvPr>
@@ -1368,7 +1368,7 @@
           <p:cNvPr id="2" name="cover-rule">
             <a:extLst xmlns:a="http://schemas.openxmlformats.org/drawingml/2006/main">
               <a:ext uri="{FF2B5EF4-FFF2-40B4-BE49-F238E27FC236}">
-                <a16:creationId xmlns:a16="http://schemas.microsoft.com/office/drawing/2014/main" id="{80D25308-2E96-42E4-BB14-0F8C84F9F3F4}"/>
+                <a16:creationId xmlns:a16="http://schemas.microsoft.com/office/drawing/2014/main" id="{8B6A56EF-ACF5-4A7B-BE32-311734B28BFD}"/>
               </a:ext>
             </a:extLst>
           </p:cNvPr>
@@ -1401,7 +1401,7 @@
           <p:cNvPr id="3" name="cover-thesis">
             <a:extLst xmlns:a="http://schemas.openxmlformats.org/drawingml/2006/main">
               <a:ext uri="{FF2B5EF4-FFF2-40B4-BE49-F238E27FC236}">
-                <a16:creationId xmlns:a16="http://schemas.microsoft.com/office/drawing/2014/main" id="{9ED1D3F3-D531-456B-84C8-68C3EEDA91C0}"/>
+                <a16:creationId xmlns:a16="http://schemas.microsoft.com/office/drawing/2014/main" id="{2E3A7692-5574-4B0C-A94F-B43489F47BC5}"/>
               </a:ext>
             </a:extLst>
           </p:cNvPr>
@@ -1446,7 +1446,7 @@
           <p:cNvPr id="4" name="cover-metric-1">
             <a:extLst xmlns:a="http://schemas.openxmlformats.org/drawingml/2006/main">
               <a:ext uri="{FF2B5EF4-FFF2-40B4-BE49-F238E27FC236}">
-                <a16:creationId xmlns:a16="http://schemas.microsoft.com/office/drawing/2014/main" id="{A6DA1B04-8221-4E4E-AFFD-884CB7188460}"/>
+                <a16:creationId xmlns:a16="http://schemas.microsoft.com/office/drawing/2014/main" id="{1AD879E6-B6CF-48F6-9D33-749409677089}"/>
               </a:ext>
             </a:extLst>
           </p:cNvPr>
@@ -1491,7 +1491,7 @@
           <p:cNvPr id="5" name="cover-label-1">
             <a:extLst xmlns:a="http://schemas.openxmlformats.org/drawingml/2006/main">
               <a:ext uri="{FF2B5EF4-FFF2-40B4-BE49-F238E27FC236}">
-                <a16:creationId xmlns:a16="http://schemas.microsoft.com/office/drawing/2014/main" id="{2DC50C7E-6475-422E-AA82-2790D3D7DA20}"/>
+                <a16:creationId xmlns:a16="http://schemas.microsoft.com/office/drawing/2014/main" id="{95C5C27B-31BC-4C81-A5D2-DA19884B7F9C}"/>
               </a:ext>
             </a:extLst>
           </p:cNvPr>
@@ -1536,7 +1536,7 @@
           <p:cNvPr id="6" name="cover-metric-2">
             <a:extLst xmlns:a="http://schemas.openxmlformats.org/drawingml/2006/main">
               <a:ext uri="{FF2B5EF4-FFF2-40B4-BE49-F238E27FC236}">
-                <a16:creationId xmlns:a16="http://schemas.microsoft.com/office/drawing/2014/main" id="{301202E5-C3AC-4EF8-AC33-6908315E089B}"/>
+                <a16:creationId xmlns:a16="http://schemas.microsoft.com/office/drawing/2014/main" id="{2BCCED98-2B17-479C-9FBB-239B8AC300E7}"/>
               </a:ext>
             </a:extLst>
           </p:cNvPr>
@@ -1581,7 +1581,7 @@
           <p:cNvPr id="7" name="cover-label-2">
             <a:extLst xmlns:a="http://schemas.openxmlformats.org/drawingml/2006/main">
               <a:ext uri="{FF2B5EF4-FFF2-40B4-BE49-F238E27FC236}">
-                <a16:creationId xmlns:a16="http://schemas.microsoft.com/office/drawing/2014/main" id="{A8F153A7-D706-4F0E-AB10-2CA2AC43FFD9}"/>
+                <a16:creationId xmlns:a16="http://schemas.microsoft.com/office/drawing/2014/main" id="{DBBC1A02-655C-49D4-83C5-0545EE3F6449}"/>
               </a:ext>
             </a:extLst>
           </p:cNvPr>
@@ -1626,7 +1626,7 @@
           <p:cNvPr id="8" name="cover-footer">
             <a:extLst xmlns:a="http://schemas.openxmlformats.org/drawingml/2006/main">
               <a:ext uri="{FF2B5EF4-FFF2-40B4-BE49-F238E27FC236}">
-                <a16:creationId xmlns:a16="http://schemas.microsoft.com/office/drawing/2014/main" id="{87AD1827-E40C-4FA9-B9E0-75D28FF3B7A8}"/>
+                <a16:creationId xmlns:a16="http://schemas.microsoft.com/office/drawing/2014/main" id="{4987FD90-0063-42A0-83F9-754BE822781D}"/>
               </a:ext>
             </a:extLst>
           </p:cNvPr>
@@ -1669,7 +1669,7 @@
     </p:spTree>
     <p:extLst>
       <p:ext uri="{BB962C8B-B14F-4D97-AF65-F5344CB8AC3E}">
-        <p14:creationId xmlns:p14="http://schemas.microsoft.com/office/powerpoint/2010/main" val="1994483401"/>
+        <p14:creationId xmlns:p14="http://schemas.microsoft.com/office/powerpoint/2010/main" val="1958937230"/>
       </p:ext>
     </p:extLst>
   </p:cSld>
@@ -1693,7 +1693,7 @@
           <p:cNvPr id="1" name="slide-title">
             <a:extLst xmlns:a="http://schemas.openxmlformats.org/drawingml/2006/main">
               <a:ext uri="{FF2B5EF4-FFF2-40B4-BE49-F238E27FC236}">
-                <a16:creationId xmlns:a16="http://schemas.microsoft.com/office/drawing/2014/main" id="{D574C47A-1564-40FD-9A53-10883221421E}"/>
+                <a16:creationId xmlns:a16="http://schemas.microsoft.com/office/drawing/2014/main" id="{69C07125-37CB-4DB4-8BC9-2DF696A9379B}"/>
               </a:ext>
             </a:extLst>
           </p:cNvPr>
@@ -1738,7 +1738,7 @@
           <p:cNvPr id="2" name="slide-subtitle">
             <a:extLst xmlns:a="http://schemas.openxmlformats.org/drawingml/2006/main">
               <a:ext uri="{FF2B5EF4-FFF2-40B4-BE49-F238E27FC236}">
-                <a16:creationId xmlns:a16="http://schemas.microsoft.com/office/drawing/2014/main" id="{1CC45660-3A20-4D30-8C64-5FF81BFDB214}"/>
+                <a16:creationId xmlns:a16="http://schemas.microsoft.com/office/drawing/2014/main" id="{9CB0A143-1522-4015-B6A5-77AF7C19E238}"/>
               </a:ext>
             </a:extLst>
           </p:cNvPr>
@@ -1783,7 +1783,7 @@
           <p:cNvPr id="3" name="bullet-0">
             <a:extLst xmlns:a="http://schemas.openxmlformats.org/drawingml/2006/main">
               <a:ext uri="{FF2B5EF4-FFF2-40B4-BE49-F238E27FC236}">
-                <a16:creationId xmlns:a16="http://schemas.microsoft.com/office/drawing/2014/main" id="{FFF83B3E-9974-47C7-96B5-9A989053CAF4}"/>
+                <a16:creationId xmlns:a16="http://schemas.microsoft.com/office/drawing/2014/main" id="{26D257C6-DCA9-461F-BEED-9DC1ACC52881}"/>
               </a:ext>
             </a:extLst>
           </p:cNvPr>
@@ -1828,7 +1828,7 @@
           <p:cNvPr id="4" name="bullet-1">
             <a:extLst xmlns:a="http://schemas.openxmlformats.org/drawingml/2006/main">
               <a:ext uri="{FF2B5EF4-FFF2-40B4-BE49-F238E27FC236}">
-                <a16:creationId xmlns:a16="http://schemas.microsoft.com/office/drawing/2014/main" id="{79A10AC3-E114-4707-B63B-A774EE2A6569}"/>
+                <a16:creationId xmlns:a16="http://schemas.microsoft.com/office/drawing/2014/main" id="{29D32503-7DF1-41D5-8841-EE08C28A5D3D}"/>
               </a:ext>
             </a:extLst>
           </p:cNvPr>
@@ -1873,7 +1873,7 @@
           <p:cNvPr id="5" name="bullet-2">
             <a:extLst xmlns:a="http://schemas.openxmlformats.org/drawingml/2006/main">
               <a:ext uri="{FF2B5EF4-FFF2-40B4-BE49-F238E27FC236}">
-                <a16:creationId xmlns:a16="http://schemas.microsoft.com/office/drawing/2014/main" id="{4771DFA0-2B33-49CF-8167-498109FB8A30}"/>
+                <a16:creationId xmlns:a16="http://schemas.microsoft.com/office/drawing/2014/main" id="{BC6C7295-0D78-498E-8932-483114B6F721}"/>
               </a:ext>
             </a:extLst>
           </p:cNvPr>
@@ -1918,7 +1918,7 @@
           <p:cNvPr id="6" name="bullet-3">
             <a:extLst xmlns:a="http://schemas.openxmlformats.org/drawingml/2006/main">
               <a:ext uri="{FF2B5EF4-FFF2-40B4-BE49-F238E27FC236}">
-                <a16:creationId xmlns:a16="http://schemas.microsoft.com/office/drawing/2014/main" id="{03A4AF6B-BC01-42AD-9EFC-5BD113AA1935}"/>
+                <a16:creationId xmlns:a16="http://schemas.microsoft.com/office/drawing/2014/main" id="{2842230B-4F91-4C6C-8348-AC132E854BC1}"/>
               </a:ext>
             </a:extLst>
           </p:cNvPr>
@@ -1963,7 +1963,7 @@
           <p:cNvPr id="7" name="bullet-0">
             <a:extLst xmlns:a="http://schemas.openxmlformats.org/drawingml/2006/main">
               <a:ext uri="{FF2B5EF4-FFF2-40B4-BE49-F238E27FC236}">
-                <a16:creationId xmlns:a16="http://schemas.microsoft.com/office/drawing/2014/main" id="{FF352737-AE31-4E9B-B95F-1BD4E007BF60}"/>
+                <a16:creationId xmlns:a16="http://schemas.microsoft.com/office/drawing/2014/main" id="{BAAEED9A-7FA0-46BE-A028-899BB117A58F}"/>
               </a:ext>
             </a:extLst>
           </p:cNvPr>
@@ -2008,7 +2008,7 @@
           <p:cNvPr id="8" name="bullet-1">
             <a:extLst xmlns:a="http://schemas.openxmlformats.org/drawingml/2006/main">
               <a:ext uri="{FF2B5EF4-FFF2-40B4-BE49-F238E27FC236}">
-                <a16:creationId xmlns:a16="http://schemas.microsoft.com/office/drawing/2014/main" id="{404DD6BE-1DB0-45A3-BF76-1B3F04E94396}"/>
+                <a16:creationId xmlns:a16="http://schemas.microsoft.com/office/drawing/2014/main" id="{4D79007E-73CF-4F3F-872F-641C19FB1E88}"/>
               </a:ext>
             </a:extLst>
           </p:cNvPr>
@@ -2053,7 +2053,7 @@
           <p:cNvPr id="9" name="bullet-2">
             <a:extLst xmlns:a="http://schemas.openxmlformats.org/drawingml/2006/main">
               <a:ext uri="{FF2B5EF4-FFF2-40B4-BE49-F238E27FC236}">
-                <a16:creationId xmlns:a16="http://schemas.microsoft.com/office/drawing/2014/main" id="{574ADE4F-7A25-4B5A-BA12-94DAD9D21C9B}"/>
+                <a16:creationId xmlns:a16="http://schemas.microsoft.com/office/drawing/2014/main" id="{77F80584-C12B-4511-A9EC-6E390B3831BF}"/>
               </a:ext>
             </a:extLst>
           </p:cNvPr>
@@ -2098,7 +2098,7 @@
           <p:cNvPr id="10" name="bullet-3">
             <a:extLst xmlns:a="http://schemas.openxmlformats.org/drawingml/2006/main">
               <a:ext uri="{FF2B5EF4-FFF2-40B4-BE49-F238E27FC236}">
-                <a16:creationId xmlns:a16="http://schemas.microsoft.com/office/drawing/2014/main" id="{9B5913DB-7380-4C43-B81E-0361AD0520B1}"/>
+                <a16:creationId xmlns:a16="http://schemas.microsoft.com/office/drawing/2014/main" id="{8312EEE0-7FC9-45BF-A0CD-C7EC508B7315}"/>
               </a:ext>
             </a:extLst>
           </p:cNvPr>
@@ -2143,7 +2143,7 @@
           <p:cNvPr id="11" name="bullet-0">
             <a:extLst xmlns:a="http://schemas.openxmlformats.org/drawingml/2006/main">
               <a:ext uri="{FF2B5EF4-FFF2-40B4-BE49-F238E27FC236}">
-                <a16:creationId xmlns:a16="http://schemas.microsoft.com/office/drawing/2014/main" id="{D09B7FE2-332B-4DAE-B351-D4E821B99D91}"/>
+                <a16:creationId xmlns:a16="http://schemas.microsoft.com/office/drawing/2014/main" id="{05D53889-931C-495D-AAAE-4AB2210B4CCF}"/>
               </a:ext>
             </a:extLst>
           </p:cNvPr>
@@ -2188,7 +2188,7 @@
           <p:cNvPr id="12" name="bullet-1">
             <a:extLst xmlns:a="http://schemas.openxmlformats.org/drawingml/2006/main">
               <a:ext uri="{FF2B5EF4-FFF2-40B4-BE49-F238E27FC236}">
-                <a16:creationId xmlns:a16="http://schemas.microsoft.com/office/drawing/2014/main" id="{6B32CF6B-048A-4041-99F4-6164660C8F87}"/>
+                <a16:creationId xmlns:a16="http://schemas.microsoft.com/office/drawing/2014/main" id="{94B0F1CE-F555-40F3-96FF-FEC839EDD72D}"/>
               </a:ext>
             </a:extLst>
           </p:cNvPr>
@@ -2233,7 +2233,7 @@
           <p:cNvPr id="13" name="bullet-2">
             <a:extLst xmlns:a="http://schemas.openxmlformats.org/drawingml/2006/main">
               <a:ext uri="{FF2B5EF4-FFF2-40B4-BE49-F238E27FC236}">
-                <a16:creationId xmlns:a16="http://schemas.microsoft.com/office/drawing/2014/main" id="{60B6A94D-9A18-4811-ACFC-3D585FE20BEE}"/>
+                <a16:creationId xmlns:a16="http://schemas.microsoft.com/office/drawing/2014/main" id="{F268CF17-51C1-4255-B79E-360906E9A70B}"/>
               </a:ext>
             </a:extLst>
           </p:cNvPr>
@@ -2278,7 +2278,7 @@
           <p:cNvPr id="14" name="bullet-3">
             <a:extLst xmlns:a="http://schemas.openxmlformats.org/drawingml/2006/main">
               <a:ext uri="{FF2B5EF4-FFF2-40B4-BE49-F238E27FC236}">
-                <a16:creationId xmlns:a16="http://schemas.microsoft.com/office/drawing/2014/main" id="{838C8E7A-B139-4483-8C45-31AE1F0E4918}"/>
+                <a16:creationId xmlns:a16="http://schemas.microsoft.com/office/drawing/2014/main" id="{21DFE1AA-2741-46DE-9135-B89DFCE2D142}"/>
               </a:ext>
             </a:extLst>
           </p:cNvPr>
@@ -2321,7 +2321,7 @@
     </p:spTree>
     <p:extLst>
       <p:ext uri="{BB962C8B-B14F-4D97-AF65-F5344CB8AC3E}">
-        <p14:creationId xmlns:p14="http://schemas.microsoft.com/office/powerpoint/2010/main" val="786829360"/>
+        <p14:creationId xmlns:p14="http://schemas.microsoft.com/office/powerpoint/2010/main" val="2000307137"/>
       </p:ext>
     </p:extLst>
   </p:cSld>
@@ -2345,7 +2345,7 @@
           <p:cNvPr id="1" name="slide-title">
             <a:extLst xmlns:a="http://schemas.openxmlformats.org/drawingml/2006/main">
               <a:ext uri="{FF2B5EF4-FFF2-40B4-BE49-F238E27FC236}">
-                <a16:creationId xmlns:a16="http://schemas.microsoft.com/office/drawing/2014/main" id="{6353F6DD-92E9-4BF0-81A8-728A890681BA}"/>
+                <a16:creationId xmlns:a16="http://schemas.microsoft.com/office/drawing/2014/main" id="{95312A3B-A6A8-4212-9281-001BBA61C7C8}"/>
               </a:ext>
             </a:extLst>
           </p:cNvPr>
@@ -2390,7 +2390,7 @@
           <p:cNvPr id="2" name="title-rule">
             <a:extLst xmlns:a="http://schemas.openxmlformats.org/drawingml/2006/main">
               <a:ext uri="{FF2B5EF4-FFF2-40B4-BE49-F238E27FC236}">
-                <a16:creationId xmlns:a16="http://schemas.microsoft.com/office/drawing/2014/main" id="{40BCACF8-F88D-44CD-8734-1A0CB4F49564}"/>
+                <a16:creationId xmlns:a16="http://schemas.microsoft.com/office/drawing/2014/main" id="{A1E48ED5-CCE4-4AC9-8EBC-7842F1C0B684}"/>
               </a:ext>
             </a:extLst>
           </p:cNvPr>
@@ -2423,7 +2423,7 @@
           <p:cNvPr id="3" name="bullet-0">
             <a:extLst xmlns:a="http://schemas.openxmlformats.org/drawingml/2006/main">
               <a:ext uri="{FF2B5EF4-FFF2-40B4-BE49-F238E27FC236}">
-                <a16:creationId xmlns:a16="http://schemas.microsoft.com/office/drawing/2014/main" id="{B27176EB-09B6-415E-B01D-1E0E5934DDA0}"/>
+                <a16:creationId xmlns:a16="http://schemas.microsoft.com/office/drawing/2014/main" id="{C21EB791-4DCF-409D-A642-2D97F96C147D}"/>
               </a:ext>
             </a:extLst>
           </p:cNvPr>
@@ -2468,7 +2468,7 @@
           <p:cNvPr id="4" name="bullet-1">
             <a:extLst xmlns:a="http://schemas.openxmlformats.org/drawingml/2006/main">
               <a:ext uri="{FF2B5EF4-FFF2-40B4-BE49-F238E27FC236}">
-                <a16:creationId xmlns:a16="http://schemas.microsoft.com/office/drawing/2014/main" id="{6FACCED3-7166-45EE-9529-500732A13449}"/>
+                <a16:creationId xmlns:a16="http://schemas.microsoft.com/office/drawing/2014/main" id="{75CB7F39-1947-4056-B905-20C080EA3CB3}"/>
               </a:ext>
             </a:extLst>
           </p:cNvPr>
@@ -2513,7 +2513,7 @@
           <p:cNvPr id="5" name="bullet-2">
             <a:extLst xmlns:a="http://schemas.openxmlformats.org/drawingml/2006/main">
               <a:ext uri="{FF2B5EF4-FFF2-40B4-BE49-F238E27FC236}">
-                <a16:creationId xmlns:a16="http://schemas.microsoft.com/office/drawing/2014/main" id="{B3F87F2C-DAFB-4D5F-80AF-927D5F7E76F6}"/>
+                <a16:creationId xmlns:a16="http://schemas.microsoft.com/office/drawing/2014/main" id="{3109ABD6-515E-4976-A13A-8CB804465C8F}"/>
               </a:ext>
             </a:extLst>
           </p:cNvPr>
@@ -2558,7 +2558,7 @@
           <p:cNvPr id="6" name="bullet-3">
             <a:extLst xmlns:a="http://schemas.openxmlformats.org/drawingml/2006/main">
               <a:ext uri="{FF2B5EF4-FFF2-40B4-BE49-F238E27FC236}">
-                <a16:creationId xmlns:a16="http://schemas.microsoft.com/office/drawing/2014/main" id="{E82BBF2A-209C-4AC2-A41C-0117D9DF3B22}"/>
+                <a16:creationId xmlns:a16="http://schemas.microsoft.com/office/drawing/2014/main" id="{1690D3D3-C554-46FC-8D58-D47BDCD5A4DF}"/>
               </a:ext>
             </a:extLst>
           </p:cNvPr>
@@ -2603,7 +2603,7 @@
           <p:cNvPr id="7" name="bullet-4">
             <a:extLst xmlns:a="http://schemas.openxmlformats.org/drawingml/2006/main">
               <a:ext uri="{FF2B5EF4-FFF2-40B4-BE49-F238E27FC236}">
-                <a16:creationId xmlns:a16="http://schemas.microsoft.com/office/drawing/2014/main" id="{5640E5C8-86FE-4E7C-9416-1916E72E1F04}"/>
+                <a16:creationId xmlns:a16="http://schemas.microsoft.com/office/drawing/2014/main" id="{8D7178FA-5BA6-479F-86CD-EE1A622431AD}"/>
               </a:ext>
             </a:extLst>
           </p:cNvPr>
@@ -2648,7 +2648,7 @@
           <p:cNvPr id="8" name="bullet-5">
             <a:extLst xmlns:a="http://schemas.openxmlformats.org/drawingml/2006/main">
               <a:ext uri="{FF2B5EF4-FFF2-40B4-BE49-F238E27FC236}">
-                <a16:creationId xmlns:a16="http://schemas.microsoft.com/office/drawing/2014/main" id="{987D2E4A-29C5-4CB5-A6D3-C7206CE63F80}"/>
+                <a16:creationId xmlns:a16="http://schemas.microsoft.com/office/drawing/2014/main" id="{332AB083-C940-48DC-ABAE-3B100911098D}"/>
               </a:ext>
             </a:extLst>
           </p:cNvPr>
@@ -2693,7 +2693,7 @@
           <p:cNvPr id="9" name="bullet-0">
             <a:extLst xmlns:a="http://schemas.openxmlformats.org/drawingml/2006/main">
               <a:ext uri="{FF2B5EF4-FFF2-40B4-BE49-F238E27FC236}">
-                <a16:creationId xmlns:a16="http://schemas.microsoft.com/office/drawing/2014/main" id="{B3E913AC-5D80-4CAA-AC1F-B231CE7D3E85}"/>
+                <a16:creationId xmlns:a16="http://schemas.microsoft.com/office/drawing/2014/main" id="{30AD1104-228E-4BA0-AE7F-610ECE258898}"/>
               </a:ext>
             </a:extLst>
           </p:cNvPr>
@@ -2705,25 +2705,25 @@
         <p:spPr>
           <a:xfrm xmlns:a="http://schemas.openxmlformats.org/drawingml/2006/main">
             <a:off x="8610600" y="1771650"/>
-            <a:ext cx="8801100" cy="342900"/>
-          </a:xfrm>
-          <a:prstGeom xmlns:a="http://schemas.openxmlformats.org/drawingml/2006/main" prst="rect">
-            <a:avLst/>
-          </a:prstGeom>
-        </p:spPr>
-        <p:txBody>
-          <a:bodyPr xmlns:a="http://schemas.openxmlformats.org/drawingml/2006/main" lIns="0" tIns="0" rIns="0" bIns="0"/>
-          <a:lstStyle xmlns:a="http://schemas.openxmlformats.org/drawingml/2006/main"/>
-          <a:p xmlns:a="http://schemas.openxmlformats.org/drawingml/2006/main">
-            <a:pPr>
-              <a:defRPr sz="2175">
-                <a:solidFill>
-                  <a:srgbClr val="000000"/>
-                </a:solidFill>
-              </a:defRPr>
-            </a:pPr>
-            <a:r>
-              <a:rPr sz="2175">
+            <a:ext cx="8801100" cy="323850"/>
+          </a:xfrm>
+          <a:prstGeom xmlns:a="http://schemas.openxmlformats.org/drawingml/2006/main" prst="rect">
+            <a:avLst/>
+          </a:prstGeom>
+        </p:spPr>
+        <p:txBody>
+          <a:bodyPr xmlns:a="http://schemas.openxmlformats.org/drawingml/2006/main" lIns="0" tIns="0" rIns="0" bIns="0"/>
+          <a:lstStyle xmlns:a="http://schemas.openxmlformats.org/drawingml/2006/main"/>
+          <a:p xmlns:a="http://schemas.openxmlformats.org/drawingml/2006/main">
+            <a:pPr>
+              <a:defRPr sz="2100">
+                <a:solidFill>
+                  <a:srgbClr val="000000"/>
+                </a:solidFill>
+              </a:defRPr>
+            </a:pPr>
+            <a:r>
+              <a:rPr sz="2100">
                 <a:solidFill>
                   <a:srgbClr val="000000"/>
                 </a:solidFill>
@@ -2738,7 +2738,7 @@
           <p:cNvPr id="10" name="bullet-1">
             <a:extLst xmlns:a="http://schemas.openxmlformats.org/drawingml/2006/main">
               <a:ext uri="{FF2B5EF4-FFF2-40B4-BE49-F238E27FC236}">
-                <a16:creationId xmlns:a16="http://schemas.microsoft.com/office/drawing/2014/main" id="{4345BD07-C5C5-4433-B930-5942213E81D4}"/>
+                <a16:creationId xmlns:a16="http://schemas.microsoft.com/office/drawing/2014/main" id="{E01C0F83-1F67-4473-ADAC-AF734BDBEF5F}"/>
               </a:ext>
             </a:extLst>
           </p:cNvPr>
@@ -2750,25 +2750,25 @@
         <p:spPr>
           <a:xfrm xmlns:a="http://schemas.openxmlformats.org/drawingml/2006/main">
             <a:off x="8610600" y="2247900"/>
-            <a:ext cx="8801100" cy="342900"/>
-          </a:xfrm>
-          <a:prstGeom xmlns:a="http://schemas.openxmlformats.org/drawingml/2006/main" prst="rect">
-            <a:avLst/>
-          </a:prstGeom>
-        </p:spPr>
-        <p:txBody>
-          <a:bodyPr xmlns:a="http://schemas.openxmlformats.org/drawingml/2006/main" lIns="0" tIns="0" rIns="0" bIns="0"/>
-          <a:lstStyle xmlns:a="http://schemas.openxmlformats.org/drawingml/2006/main"/>
-          <a:p xmlns:a="http://schemas.openxmlformats.org/drawingml/2006/main">
-            <a:pPr>
-              <a:defRPr sz="2175">
-                <a:solidFill>
-                  <a:srgbClr val="000000"/>
-                </a:solidFill>
-              </a:defRPr>
-            </a:pPr>
-            <a:r>
-              <a:rPr sz="2175">
+            <a:ext cx="8801100" cy="323850"/>
+          </a:xfrm>
+          <a:prstGeom xmlns:a="http://schemas.openxmlformats.org/drawingml/2006/main" prst="rect">
+            <a:avLst/>
+          </a:prstGeom>
+        </p:spPr>
+        <p:txBody>
+          <a:bodyPr xmlns:a="http://schemas.openxmlformats.org/drawingml/2006/main" lIns="0" tIns="0" rIns="0" bIns="0"/>
+          <a:lstStyle xmlns:a="http://schemas.openxmlformats.org/drawingml/2006/main"/>
+          <a:p xmlns:a="http://schemas.openxmlformats.org/drawingml/2006/main">
+            <a:pPr>
+              <a:defRPr sz="2100">
+                <a:solidFill>
+                  <a:srgbClr val="000000"/>
+                </a:solidFill>
+              </a:defRPr>
+            </a:pPr>
+            <a:r>
+              <a:rPr sz="2100">
                 <a:solidFill>
                   <a:srgbClr val="000000"/>
                 </a:solidFill>
@@ -2783,42 +2783,42 @@
           <p:cNvPr id="11" name="bullet-2">
             <a:extLst xmlns:a="http://schemas.openxmlformats.org/drawingml/2006/main">
               <a:ext uri="{FF2B5EF4-FFF2-40B4-BE49-F238E27FC236}">
-                <a16:creationId xmlns:a16="http://schemas.microsoft.com/office/drawing/2014/main" id="{BBC52DB9-87A7-4E5A-8864-E5E0F9C47C02}"/>
-              </a:ext>
-            </a:extLst>
-          </p:cNvPr>
-          <p:cNvSpPr>
-            <a:spLocks xmlns:a="http://schemas.openxmlformats.org/drawingml/2006/main" noGrp="1"/>
-          </p:cNvSpPr>
-          <p:nvPr/>
-        </p:nvSpPr>
-        <p:spPr>
-          <a:xfrm xmlns:a="http://schemas.openxmlformats.org/drawingml/2006/main">
-            <a:off x="8610600" y="2743200"/>
-            <a:ext cx="8801100" cy="342900"/>
-          </a:xfrm>
-          <a:prstGeom xmlns:a="http://schemas.openxmlformats.org/drawingml/2006/main" prst="rect">
-            <a:avLst/>
-          </a:prstGeom>
-        </p:spPr>
-        <p:txBody>
-          <a:bodyPr xmlns:a="http://schemas.openxmlformats.org/drawingml/2006/main" lIns="0" tIns="0" rIns="0" bIns="0"/>
-          <a:lstStyle xmlns:a="http://schemas.openxmlformats.org/drawingml/2006/main"/>
-          <a:p xmlns:a="http://schemas.openxmlformats.org/drawingml/2006/main">
-            <a:pPr>
-              <a:defRPr sz="2175">
-                <a:solidFill>
-                  <a:srgbClr val="000000"/>
-                </a:solidFill>
-              </a:defRPr>
-            </a:pPr>
-            <a:r>
-              <a:rPr sz="2175">
-                <a:solidFill>
-                  <a:srgbClr val="000000"/>
-                </a:solidFill>
-              </a:rPr>
-              <a:t>Minimum check: beat the worse prefetcher</a:t>
+                <a16:creationId xmlns:a16="http://schemas.microsoft.com/office/drawing/2014/main" id="{0C272645-435F-4475-B9C8-6CD6260DA7A0}"/>
+              </a:ext>
+            </a:extLst>
+          </p:cNvPr>
+          <p:cNvSpPr>
+            <a:spLocks xmlns:a="http://schemas.openxmlformats.org/drawingml/2006/main" noGrp="1"/>
+          </p:cNvSpPr>
+          <p:nvPr/>
+        </p:nvSpPr>
+        <p:spPr>
+          <a:xfrm xmlns:a="http://schemas.openxmlformats.org/drawingml/2006/main">
+            <a:off x="8610600" y="2724150"/>
+            <a:ext cx="8801100" cy="323850"/>
+          </a:xfrm>
+          <a:prstGeom xmlns:a="http://schemas.openxmlformats.org/drawingml/2006/main" prst="rect">
+            <a:avLst/>
+          </a:prstGeom>
+        </p:spPr>
+        <p:txBody>
+          <a:bodyPr xmlns:a="http://schemas.openxmlformats.org/drawingml/2006/main" lIns="0" tIns="0" rIns="0" bIns="0"/>
+          <a:lstStyle xmlns:a="http://schemas.openxmlformats.org/drawingml/2006/main"/>
+          <a:p xmlns:a="http://schemas.openxmlformats.org/drawingml/2006/main">
+            <a:pPr>
+              <a:defRPr sz="2100">
+                <a:solidFill>
+                  <a:srgbClr val="000000"/>
+                </a:solidFill>
+              </a:defRPr>
+            </a:pPr>
+            <a:r>
+              <a:rPr sz="2100">
+                <a:solidFill>
+                  <a:srgbClr val="000000"/>
+                </a:solidFill>
+              </a:rPr>
+              <a:t>WinnerTakeAll: use the previous-epoch winner</a:t>
             </a:r>
           </a:p>
         </p:txBody>
@@ -2828,64 +2828,109 @@
           <p:cNvPr id="12" name="bullet-3">
             <a:extLst xmlns:a="http://schemas.openxmlformats.org/drawingml/2006/main">
               <a:ext uri="{FF2B5EF4-FFF2-40B4-BE49-F238E27FC236}">
-                <a16:creationId xmlns:a16="http://schemas.microsoft.com/office/drawing/2014/main" id="{EAA7347F-125D-4A54-A962-CD1B51B613A8}"/>
-              </a:ext>
-            </a:extLst>
-          </p:cNvPr>
-          <p:cNvSpPr>
-            <a:spLocks xmlns:a="http://schemas.openxmlformats.org/drawingml/2006/main" noGrp="1"/>
-          </p:cNvSpPr>
-          <p:nvPr/>
-        </p:nvSpPr>
-        <p:spPr>
-          <a:xfrm xmlns:a="http://schemas.openxmlformats.org/drawingml/2006/main">
-            <a:off x="8610600" y="3219450"/>
-            <a:ext cx="8801100" cy="342900"/>
-          </a:xfrm>
-          <a:prstGeom xmlns:a="http://schemas.openxmlformats.org/drawingml/2006/main" prst="rect">
-            <a:avLst/>
-          </a:prstGeom>
-        </p:spPr>
-        <p:txBody>
-          <a:bodyPr xmlns:a="http://schemas.openxmlformats.org/drawingml/2006/main" lIns="0" tIns="0" rIns="0" bIns="0"/>
-          <a:lstStyle xmlns:a="http://schemas.openxmlformats.org/drawingml/2006/main"/>
-          <a:p xmlns:a="http://schemas.openxmlformats.org/drawingml/2006/main">
-            <a:pPr>
-              <a:defRPr sz="2175">
-                <a:solidFill>
-                  <a:srgbClr val="000000"/>
-                </a:solidFill>
-              </a:defRPr>
-            </a:pPr>
-            <a:r>
-              <a:rPr sz="2175">
-                <a:solidFill>
-                  <a:srgbClr val="000000"/>
-                </a:solidFill>
-              </a:rPr>
-              <a:t>Simple routers: WinnerTakeAll, OneShotFit, AthenaMAB</a:t>
-            </a:r>
-          </a:p>
-        </p:txBody>
-      </p:sp>
-      <p:sp>
-        <p:nvSpPr>
-          <p:cNvPr id="13" name="protocol-footer">
-            <a:extLst xmlns:a="http://schemas.openxmlformats.org/drawingml/2006/main">
-              <a:ext uri="{FF2B5EF4-FFF2-40B4-BE49-F238E27FC236}">
-                <a16:creationId xmlns:a16="http://schemas.microsoft.com/office/drawing/2014/main" id="{62BD5987-8A7B-4731-BF17-8B3971EFD870}"/>
-              </a:ext>
-            </a:extLst>
-          </p:cNvPr>
-          <p:cNvSpPr>
-            <a:spLocks xmlns:a="http://schemas.openxmlformats.org/drawingml/2006/main" noGrp="1"/>
-          </p:cNvSpPr>
-          <p:nvPr/>
-        </p:nvSpPr>
-        <p:spPr>
-          <a:xfrm xmlns:a="http://schemas.openxmlformats.org/drawingml/2006/main">
-            <a:off x="876300" y="9372600"/>
-            <a:ext cx="16535400" cy="266700"/>
+                <a16:creationId xmlns:a16="http://schemas.microsoft.com/office/drawing/2014/main" id="{7B60406E-BEA3-45D0-A41C-2B0909858F71}"/>
+              </a:ext>
+            </a:extLst>
+          </p:cNvPr>
+          <p:cNvSpPr>
+            <a:spLocks xmlns:a="http://schemas.openxmlformats.org/drawingml/2006/main" noGrp="1"/>
+          </p:cNvSpPr>
+          <p:nvPr/>
+        </p:nvSpPr>
+        <p:spPr>
+          <a:xfrm xmlns:a="http://schemas.openxmlformats.org/drawingml/2006/main">
+            <a:off x="8610600" y="3181350"/>
+            <a:ext cx="8801100" cy="323850"/>
+          </a:xfrm>
+          <a:prstGeom xmlns:a="http://schemas.openxmlformats.org/drawingml/2006/main" prst="rect">
+            <a:avLst/>
+          </a:prstGeom>
+        </p:spPr>
+        <p:txBody>
+          <a:bodyPr xmlns:a="http://schemas.openxmlformats.org/drawingml/2006/main" lIns="0" tIns="0" rIns="0" bIns="0"/>
+          <a:lstStyle xmlns:a="http://schemas.openxmlformats.org/drawingml/2006/main"/>
+          <a:p xmlns:a="http://schemas.openxmlformats.org/drawingml/2006/main">
+            <a:pPr>
+              <a:defRPr sz="2100">
+                <a:solidFill>
+                  <a:srgbClr val="000000"/>
+                </a:solidFill>
+              </a:defRPr>
+            </a:pPr>
+            <a:r>
+              <a:rPr sz="2100">
+                <a:solidFill>
+                  <a:srgbClr val="000000"/>
+                </a:solidFill>
+              </a:rPr>
+              <a:t>OneShotFit: probe once, then keep the early winner</a:t>
+            </a:r>
+          </a:p>
+        </p:txBody>
+      </p:sp>
+      <p:sp>
+        <p:nvSpPr>
+          <p:cNvPr id="13" name="bullet-4">
+            <a:extLst xmlns:a="http://schemas.openxmlformats.org/drawingml/2006/main">
+              <a:ext uri="{FF2B5EF4-FFF2-40B4-BE49-F238E27FC236}">
+                <a16:creationId xmlns:a16="http://schemas.microsoft.com/office/drawing/2014/main" id="{EFF426E2-1684-4B17-BB0D-8E63BAC33FF5}"/>
+              </a:ext>
+            </a:extLst>
+          </p:cNvPr>
+          <p:cNvSpPr>
+            <a:spLocks xmlns:a="http://schemas.openxmlformats.org/drawingml/2006/main" noGrp="1"/>
+          </p:cNvSpPr>
+          <p:nvPr/>
+        </p:nvSpPr>
+        <p:spPr>
+          <a:xfrm xmlns:a="http://schemas.openxmlformats.org/drawingml/2006/main">
+            <a:off x="8610600" y="3657600"/>
+            <a:ext cx="8801100" cy="323850"/>
+          </a:xfrm>
+          <a:prstGeom xmlns:a="http://schemas.openxmlformats.org/drawingml/2006/main" prst="rect">
+            <a:avLst/>
+          </a:prstGeom>
+        </p:spPr>
+        <p:txBody>
+          <a:bodyPr xmlns:a="http://schemas.openxmlformats.org/drawingml/2006/main" lIns="0" tIns="0" rIns="0" bIns="0"/>
+          <a:lstStyle xmlns:a="http://schemas.openxmlformats.org/drawingml/2006/main"/>
+          <a:p xmlns:a="http://schemas.openxmlformats.org/drawingml/2006/main">
+            <a:pPr>
+              <a:defRPr sz="2100">
+                <a:solidFill>
+                  <a:srgbClr val="000000"/>
+                </a:solidFill>
+              </a:defRPr>
+            </a:pPr>
+            <a:r>
+              <a:rPr sz="2100">
+                <a:solidFill>
+                  <a:srgbClr val="000000"/>
+                </a:solidFill>
+              </a:rPr>
+              <a:t>AthenaMAB: Athena's bandit router baseline</a:t>
+            </a:r>
+          </a:p>
+        </p:txBody>
+      </p:sp>
+      <p:sp>
+        <p:nvSpPr>
+          <p:cNvPr id="14" name="protocol-footer">
+            <a:extLst xmlns:a="http://schemas.openxmlformats.org/drawingml/2006/main">
+              <a:ext uri="{FF2B5EF4-FFF2-40B4-BE49-F238E27FC236}">
+                <a16:creationId xmlns:a16="http://schemas.microsoft.com/office/drawing/2014/main" id="{52C2C8AD-6285-48C3-9406-F6479B817C12}"/>
+              </a:ext>
+            </a:extLst>
+          </p:cNvPr>
+          <p:cNvSpPr>
+            <a:spLocks xmlns:a="http://schemas.openxmlformats.org/drawingml/2006/main" noGrp="1"/>
+          </p:cNvSpPr>
+          <p:nvPr/>
+        </p:nvSpPr>
+        <p:spPr>
+          <a:xfrm xmlns:a="http://schemas.openxmlformats.org/drawingml/2006/main">
+            <a:off x="876300" y="9124950"/>
+            <a:ext cx="16535400" cy="514350"/>
           </a:xfrm>
           <a:prstGeom xmlns:a="http://schemas.openxmlformats.org/drawingml/2006/main" prst="rect">
             <a:avLst/>
@@ -2908,7 +2953,7 @@
                   <a:srgbClr val="000000"/>
                 </a:solidFill>
               </a:rPr>
-              <a:t>The 13-trace training-split surface has complete local artifacts. The four other train traces are facesim, ligra_BFS, ligra_Triangle, and secret_compute_int_243.</a:t>
+              <a:t>The 13-trace training-split surface has complete simulator evidence in the submitted artifact. The four other train traces are facesim, ligra_BFS, ligra_Triangle, and secret_compute_int_243.</a:t>
             </a:r>
           </a:p>
         </p:txBody>
@@ -2916,7 +2961,7 @@
     </p:spTree>
     <p:extLst>
       <p:ext uri="{BB962C8B-B14F-4D97-AF65-F5344CB8AC3E}">
-        <p14:creationId xmlns:p14="http://schemas.microsoft.com/office/powerpoint/2010/main" val="81353145"/>
+        <p14:creationId xmlns:p14="http://schemas.microsoft.com/office/powerpoint/2010/main" val="986342257"/>
       </p:ext>
     </p:extLst>
   </p:cSld>
@@ -2940,7 +2985,7 @@
           <p:cNvPr id="1" name="slide-title">
             <a:extLst xmlns:a="http://schemas.openxmlformats.org/drawingml/2006/main">
               <a:ext uri="{FF2B5EF4-FFF2-40B4-BE49-F238E27FC236}">
-                <a16:creationId xmlns:a16="http://schemas.microsoft.com/office/drawing/2014/main" id="{6EC42E3C-D740-4056-A1C1-787CC8180BD2}"/>
+                <a16:creationId xmlns:a16="http://schemas.microsoft.com/office/drawing/2014/main" id="{306A2238-A3F3-4060-A987-776B75E62F5C}"/>
               </a:ext>
             </a:extLst>
           </p:cNvPr>
@@ -2985,7 +3030,7 @@
           <p:cNvPr id="2" name="slide-subtitle">
             <a:extLst xmlns:a="http://schemas.openxmlformats.org/drawingml/2006/main">
               <a:ext uri="{FF2B5EF4-FFF2-40B4-BE49-F238E27FC236}">
-                <a16:creationId xmlns:a16="http://schemas.microsoft.com/office/drawing/2014/main" id="{06AF53AA-FF7C-4871-8C71-A4E2B387AE1C}"/>
+                <a16:creationId xmlns:a16="http://schemas.microsoft.com/office/drawing/2014/main" id="{7B6CACE4-73AE-4028-A81F-F826DE9C9FA7}"/>
               </a:ext>
             </a:extLst>
           </p:cNvPr>
@@ -3020,7 +3065,7 @@
                   <a:srgbClr val="000000"/>
                 </a:solidFill>
               </a:rPr>
-              <a:t>Bars use disabled prefetching as 1x. Error bars are trace-bootstrap 95% CIs.</a:t>
+              <a:t>Bars use disabled prefetching as 1x. Yellow marks show the per-trace best expert.</a:t>
             </a:r>
           </a:p>
         </p:txBody>
@@ -3034,7 +3079,7 @@
           <p:nvPr/>
         </p:nvPicPr>
         <p:blipFill>
-          <a:blip xmlns:r="http://schemas.openxmlformats.org/officeDocument/2006/relationships" xmlns:a="http://schemas.openxmlformats.org/drawingml/2006/main" r:embed="Rcf128b08314f4e4f"/>
+          <a:blip xmlns:r="http://schemas.openxmlformats.org/officeDocument/2006/relationships" xmlns:a="http://schemas.openxmlformats.org/drawingml/2006/main" r:embed="Rb6eb624e6bed43c6"/>
           <a:stretch xmlns:a="http://schemas.openxmlformats.org/drawingml/2006/main"/>
         </p:blipFill>
         <p:spPr>
@@ -3050,7 +3095,7 @@
     </p:spTree>
     <p:extLst>
       <p:ext uri="{BB962C8B-B14F-4D97-AF65-F5344CB8AC3E}">
-        <p14:creationId xmlns:p14="http://schemas.microsoft.com/office/powerpoint/2010/main" val="1511686111"/>
+        <p14:creationId xmlns:p14="http://schemas.microsoft.com/office/powerpoint/2010/main" val="1429022769"/>
       </p:ext>
     </p:extLst>
   </p:cSld>
@@ -3074,7 +3119,7 @@
           <p:cNvPr id="1" name="slide-title">
             <a:extLst xmlns:a="http://schemas.openxmlformats.org/drawingml/2006/main">
               <a:ext uri="{FF2B5EF4-FFF2-40B4-BE49-F238E27FC236}">
-                <a16:creationId xmlns:a16="http://schemas.microsoft.com/office/drawing/2014/main" id="{515DD3A3-0B78-46AC-80AE-BBE9ACF2A153}"/>
+                <a16:creationId xmlns:a16="http://schemas.microsoft.com/office/drawing/2014/main" id="{A9267DDB-8E7A-4155-8B20-BCB2C543B1B1}"/>
               </a:ext>
             </a:extLst>
           </p:cNvPr>
@@ -3119,7 +3164,7 @@
           <p:cNvPr id="2" name="slide-subtitle">
             <a:extLst xmlns:a="http://schemas.openxmlformats.org/drawingml/2006/main">
               <a:ext uri="{FF2B5EF4-FFF2-40B4-BE49-F238E27FC236}">
-                <a16:creationId xmlns:a16="http://schemas.microsoft.com/office/drawing/2014/main" id="{FC5DA9FA-12DF-4549-8ED0-07F0DE05808D}"/>
+                <a16:creationId xmlns:a16="http://schemas.microsoft.com/office/drawing/2014/main" id="{FF7B64AD-73B5-4620-981C-E15BCC3EE8B0}"/>
               </a:ext>
             </a:extLst>
           </p:cNvPr>
@@ -3168,7 +3213,7 @@
           <p:nvPr/>
         </p:nvPicPr>
         <p:blipFill>
-          <a:blip xmlns:r="http://schemas.openxmlformats.org/officeDocument/2006/relationships" xmlns:a="http://schemas.openxmlformats.org/drawingml/2006/main" r:embed="Rc353ec1a7b304847"/>
+          <a:blip xmlns:r="http://schemas.openxmlformats.org/officeDocument/2006/relationships" xmlns:a="http://schemas.openxmlformats.org/drawingml/2006/main" r:embed="Rc45661af8d934617"/>
           <a:stretch xmlns:a="http://schemas.openxmlformats.org/drawingml/2006/main"/>
         </p:blipFill>
         <p:spPr>
@@ -3184,7 +3229,7 @@
     </p:spTree>
     <p:extLst>
       <p:ext uri="{BB962C8B-B14F-4D97-AF65-F5344CB8AC3E}">
-        <p14:creationId xmlns:p14="http://schemas.microsoft.com/office/powerpoint/2010/main" val="2001530194"/>
+        <p14:creationId xmlns:p14="http://schemas.microsoft.com/office/powerpoint/2010/main" val="1340915007"/>
       </p:ext>
     </p:extLst>
   </p:cSld>
@@ -3208,7 +3253,7 @@
           <p:cNvPr id="1" name="slide-title">
             <a:extLst xmlns:a="http://schemas.openxmlformats.org/drawingml/2006/main">
               <a:ext uri="{FF2B5EF4-FFF2-40B4-BE49-F238E27FC236}">
-                <a16:creationId xmlns:a16="http://schemas.microsoft.com/office/drawing/2014/main" id="{8BC61091-2E91-48DD-B239-5F4929A71601}"/>
+                <a16:creationId xmlns:a16="http://schemas.microsoft.com/office/drawing/2014/main" id="{49A6B293-8E6A-4A99-B971-A5DCC68C28A2}"/>
               </a:ext>
             </a:extLst>
           </p:cNvPr>
@@ -3253,7 +3298,7 @@
           <p:cNvPr id="2" name="slide-subtitle">
             <a:extLst xmlns:a="http://schemas.openxmlformats.org/drawingml/2006/main">
               <a:ext uri="{FF2B5EF4-FFF2-40B4-BE49-F238E27FC236}">
-                <a16:creationId xmlns:a16="http://schemas.microsoft.com/office/drawing/2014/main" id="{9A59BB9E-1737-4055-9064-05250A8F5DB3}"/>
+                <a16:creationId xmlns:a16="http://schemas.microsoft.com/office/drawing/2014/main" id="{781F8880-A2D9-4E4E-872B-25E16B2F60FA}"/>
               </a:ext>
             </a:extLst>
           </p:cNvPr>
@@ -3302,7 +3347,7 @@
           <p:nvPr/>
         </p:nvPicPr>
         <p:blipFill>
-          <a:blip xmlns:r="http://schemas.openxmlformats.org/officeDocument/2006/relationships" xmlns:a="http://schemas.openxmlformats.org/drawingml/2006/main" r:embed="R1eca9cc1ea534932"/>
+          <a:blip xmlns:r="http://schemas.openxmlformats.org/officeDocument/2006/relationships" xmlns:a="http://schemas.openxmlformats.org/drawingml/2006/main" r:embed="Re8aa4613c0e845af"/>
           <a:stretch xmlns:a="http://schemas.openxmlformats.org/drawingml/2006/main"/>
         </p:blipFill>
         <p:spPr>
@@ -3318,7 +3363,7 @@
     </p:spTree>
     <p:extLst>
       <p:ext uri="{BB962C8B-B14F-4D97-AF65-F5344CB8AC3E}">
-        <p14:creationId xmlns:p14="http://schemas.microsoft.com/office/powerpoint/2010/main" val="1204723668"/>
+        <p14:creationId xmlns:p14="http://schemas.microsoft.com/office/powerpoint/2010/main" val="1438646429"/>
       </p:ext>
     </p:extLst>
   </p:cSld>
@@ -3342,7 +3387,7 @@
           <p:cNvPr id="1" name="slide-title">
             <a:extLst xmlns:a="http://schemas.openxmlformats.org/drawingml/2006/main">
               <a:ext uri="{FF2B5EF4-FFF2-40B4-BE49-F238E27FC236}">
-                <a16:creationId xmlns:a16="http://schemas.microsoft.com/office/drawing/2014/main" id="{65EEEE16-F478-43B1-B90F-E1B88E1D8F1A}"/>
+                <a16:creationId xmlns:a16="http://schemas.microsoft.com/office/drawing/2014/main" id="{7CADD791-C915-491C-BA7F-9BE31A36733E}"/>
               </a:ext>
             </a:extLst>
           </p:cNvPr>
@@ -3387,7 +3432,7 @@
           <p:cNvPr id="2" name="slide-subtitle">
             <a:extLst xmlns:a="http://schemas.openxmlformats.org/drawingml/2006/main">
               <a:ext uri="{FF2B5EF4-FFF2-40B4-BE49-F238E27FC236}">
-                <a16:creationId xmlns:a16="http://schemas.microsoft.com/office/drawing/2014/main" id="{39C69878-9F3F-4EB9-84E3-857E2E8CE23F}"/>
+                <a16:creationId xmlns:a16="http://schemas.microsoft.com/office/drawing/2014/main" id="{5708BF2E-3DF6-499E-BC14-8418397015E0}"/>
               </a:ext>
             </a:extLst>
           </p:cNvPr>
@@ -3432,7 +3477,7 @@
           <p:cNvPr id="3" name="bullet-0">
             <a:extLst xmlns:a="http://schemas.openxmlformats.org/drawingml/2006/main">
               <a:ext uri="{FF2B5EF4-FFF2-40B4-BE49-F238E27FC236}">
-                <a16:creationId xmlns:a16="http://schemas.microsoft.com/office/drawing/2014/main" id="{978CA6D3-DDE6-45AC-A382-B2D2253D3FB2}"/>
+                <a16:creationId xmlns:a16="http://schemas.microsoft.com/office/drawing/2014/main" id="{A080C14A-EBFD-4233-9AD1-B4612FD7C146}"/>
               </a:ext>
             </a:extLst>
           </p:cNvPr>
@@ -3477,7 +3522,7 @@
           <p:cNvPr id="4" name="bullet-1">
             <a:extLst xmlns:a="http://schemas.openxmlformats.org/drawingml/2006/main">
               <a:ext uri="{FF2B5EF4-FFF2-40B4-BE49-F238E27FC236}">
-                <a16:creationId xmlns:a16="http://schemas.microsoft.com/office/drawing/2014/main" id="{45C0F5D5-E839-4464-B3CC-9E293A372CA5}"/>
+                <a16:creationId xmlns:a16="http://schemas.microsoft.com/office/drawing/2014/main" id="{FF1B4997-3DA8-456F-8DCC-D46156031319}"/>
               </a:ext>
             </a:extLst>
           </p:cNvPr>
@@ -3522,7 +3567,7 @@
           <p:cNvPr id="5" name="bullet-2">
             <a:extLst xmlns:a="http://schemas.openxmlformats.org/drawingml/2006/main">
               <a:ext uri="{FF2B5EF4-FFF2-40B4-BE49-F238E27FC236}">
-                <a16:creationId xmlns:a16="http://schemas.microsoft.com/office/drawing/2014/main" id="{73459FE7-C894-464F-BEEF-BD5182AED191}"/>
+                <a16:creationId xmlns:a16="http://schemas.microsoft.com/office/drawing/2014/main" id="{95F2ECF5-E4BD-4A8E-BC16-844BFF5AF742}"/>
               </a:ext>
             </a:extLst>
           </p:cNvPr>
@@ -3567,7 +3612,7 @@
           <p:cNvPr id="6" name="bullet-3">
             <a:extLst xmlns:a="http://schemas.openxmlformats.org/drawingml/2006/main">
               <a:ext uri="{FF2B5EF4-FFF2-40B4-BE49-F238E27FC236}">
-                <a16:creationId xmlns:a16="http://schemas.microsoft.com/office/drawing/2014/main" id="{222DB438-EBA6-49DB-9E4B-59AAE269FBF1}"/>
+                <a16:creationId xmlns:a16="http://schemas.microsoft.com/office/drawing/2014/main" id="{B3A583E9-E943-4196-A5F5-9FF8A5EBF544}"/>
               </a:ext>
             </a:extLst>
           </p:cNvPr>
@@ -3612,7 +3657,7 @@
           <p:cNvPr id="7" name="bullet-4">
             <a:extLst xmlns:a="http://schemas.openxmlformats.org/drawingml/2006/main">
               <a:ext uri="{FF2B5EF4-FFF2-40B4-BE49-F238E27FC236}">
-                <a16:creationId xmlns:a16="http://schemas.microsoft.com/office/drawing/2014/main" id="{D86D1D9E-8128-4C3F-9381-6C1B9D2E4ED9}"/>
+                <a16:creationId xmlns:a16="http://schemas.microsoft.com/office/drawing/2014/main" id="{687C08A9-BAD2-43AA-B9AE-B3F157706646}"/>
               </a:ext>
             </a:extLst>
           </p:cNvPr>
@@ -3657,7 +3702,7 @@
           <p:cNvPr id="8" name="bullet-0">
             <a:extLst xmlns:a="http://schemas.openxmlformats.org/drawingml/2006/main">
               <a:ext uri="{FF2B5EF4-FFF2-40B4-BE49-F238E27FC236}">
-                <a16:creationId xmlns:a16="http://schemas.microsoft.com/office/drawing/2014/main" id="{D10DDBE0-AB2C-4646-80CA-5A75E9ECD8C6}"/>
+                <a16:creationId xmlns:a16="http://schemas.microsoft.com/office/drawing/2014/main" id="{C648851A-7539-4AED-B86E-FD751FEE8579}"/>
               </a:ext>
             </a:extLst>
           </p:cNvPr>
@@ -3702,7 +3747,7 @@
           <p:cNvPr id="9" name="bullet-1">
             <a:extLst xmlns:a="http://schemas.openxmlformats.org/drawingml/2006/main">
               <a:ext uri="{FF2B5EF4-FFF2-40B4-BE49-F238E27FC236}">
-                <a16:creationId xmlns:a16="http://schemas.microsoft.com/office/drawing/2014/main" id="{4BAA111B-DF12-4991-9CE2-B973106B5DEE}"/>
+                <a16:creationId xmlns:a16="http://schemas.microsoft.com/office/drawing/2014/main" id="{2D5504E1-0905-4849-8A5C-88E35DB46149}"/>
               </a:ext>
             </a:extLst>
           </p:cNvPr>
@@ -3747,7 +3792,7 @@
           <p:cNvPr id="10" name="bullet-2">
             <a:extLst xmlns:a="http://schemas.openxmlformats.org/drawingml/2006/main">
               <a:ext uri="{FF2B5EF4-FFF2-40B4-BE49-F238E27FC236}">
-                <a16:creationId xmlns:a16="http://schemas.microsoft.com/office/drawing/2014/main" id="{CB3F32D7-7218-48AA-B9D9-F98B7F32881B}"/>
+                <a16:creationId xmlns:a16="http://schemas.microsoft.com/office/drawing/2014/main" id="{8411D9CF-F82C-4B50-AA46-A3E80E1302A7}"/>
               </a:ext>
             </a:extLst>
           </p:cNvPr>
@@ -3792,7 +3837,7 @@
           <p:cNvPr id="11" name="bullet-3">
             <a:extLst xmlns:a="http://schemas.openxmlformats.org/drawingml/2006/main">
               <a:ext uri="{FF2B5EF4-FFF2-40B4-BE49-F238E27FC236}">
-                <a16:creationId xmlns:a16="http://schemas.microsoft.com/office/drawing/2014/main" id="{31499375-5758-43C1-A9AE-09B756B36113}"/>
+                <a16:creationId xmlns:a16="http://schemas.microsoft.com/office/drawing/2014/main" id="{4388D130-623E-4F24-92B7-48151E7EE008}"/>
               </a:ext>
             </a:extLst>
           </p:cNvPr>
@@ -3837,7 +3882,7 @@
           <p:cNvPr id="12" name="bullet-4">
             <a:extLst xmlns:a="http://schemas.openxmlformats.org/drawingml/2006/main">
               <a:ext uri="{FF2B5EF4-FFF2-40B4-BE49-F238E27FC236}">
-                <a16:creationId xmlns:a16="http://schemas.microsoft.com/office/drawing/2014/main" id="{381FA29B-5E8A-47C1-A4DA-179870D56F76}"/>
+                <a16:creationId xmlns:a16="http://schemas.microsoft.com/office/drawing/2014/main" id="{A1FE0D1D-36AF-4AE3-86EA-FB477D392DF5}"/>
               </a:ext>
             </a:extLst>
           </p:cNvPr>
@@ -3882,7 +3927,7 @@
           <p:cNvPr id="13" name="audit-footer">
             <a:extLst xmlns:a="http://schemas.openxmlformats.org/drawingml/2006/main">
               <a:ext uri="{FF2B5EF4-FFF2-40B4-BE49-F238E27FC236}">
-                <a16:creationId xmlns:a16="http://schemas.microsoft.com/office/drawing/2014/main" id="{38EFDF14-6075-4A7A-9FFF-12FA8446A03C}"/>
+                <a16:creationId xmlns:a16="http://schemas.microsoft.com/office/drawing/2014/main" id="{6779B243-AF73-4E35-A897-8A5CDCB7F5B6}"/>
               </a:ext>
             </a:extLst>
           </p:cNvPr>
@@ -3925,7 +3970,7 @@
     </p:spTree>
     <p:extLst>
       <p:ext uri="{BB962C8B-B14F-4D97-AF65-F5344CB8AC3E}">
-        <p14:creationId xmlns:p14="http://schemas.microsoft.com/office/powerpoint/2010/main" val="755766074"/>
+        <p14:creationId xmlns:p14="http://schemas.microsoft.com/office/powerpoint/2010/main" val="1713037047"/>
       </p:ext>
     </p:extLst>
   </p:cSld>
@@ -3949,7 +3994,7 @@
           <p:cNvPr id="1" name="slide-title">
             <a:extLst xmlns:a="http://schemas.openxmlformats.org/drawingml/2006/main">
               <a:ext uri="{FF2B5EF4-FFF2-40B4-BE49-F238E27FC236}">
-                <a16:creationId xmlns:a16="http://schemas.microsoft.com/office/drawing/2014/main" id="{0417DF28-4613-4F42-8EE4-893121010D3C}"/>
+                <a16:creationId xmlns:a16="http://schemas.microsoft.com/office/drawing/2014/main" id="{7D370412-37AF-4586-8CA0-4854D3DBBC4C}"/>
               </a:ext>
             </a:extLst>
           </p:cNvPr>
@@ -3994,7 +4039,7 @@
           <p:cNvPr id="2" name="title-rule">
             <a:extLst xmlns:a="http://schemas.openxmlformats.org/drawingml/2006/main">
               <a:ext uri="{FF2B5EF4-FFF2-40B4-BE49-F238E27FC236}">
-                <a16:creationId xmlns:a16="http://schemas.microsoft.com/office/drawing/2014/main" id="{54237075-E376-4A1D-8E45-347647D32951}"/>
+                <a16:creationId xmlns:a16="http://schemas.microsoft.com/office/drawing/2014/main" id="{E2A10BF2-0BF8-4A2D-B1B0-7664A088A107}"/>
               </a:ext>
             </a:extLst>
           </p:cNvPr>
@@ -4027,7 +4072,7 @@
           <p:cNvPr id="3" name="bullet-0">
             <a:extLst xmlns:a="http://schemas.openxmlformats.org/drawingml/2006/main">
               <a:ext uri="{FF2B5EF4-FFF2-40B4-BE49-F238E27FC236}">
-                <a16:creationId xmlns:a16="http://schemas.microsoft.com/office/drawing/2014/main" id="{0981D791-1B51-48BB-AC0F-86D56E6160E3}"/>
+                <a16:creationId xmlns:a16="http://schemas.microsoft.com/office/drawing/2014/main" id="{6B0CADB3-D1AC-4622-B107-9DF567937840}"/>
               </a:ext>
             </a:extLst>
           </p:cNvPr>
@@ -4072,7 +4117,7 @@
           <p:cNvPr id="4" name="bullet-1">
             <a:extLst xmlns:a="http://schemas.openxmlformats.org/drawingml/2006/main">
               <a:ext uri="{FF2B5EF4-FFF2-40B4-BE49-F238E27FC236}">
-                <a16:creationId xmlns:a16="http://schemas.microsoft.com/office/drawing/2014/main" id="{CCAA2681-9089-4796-951C-935D3F1D9F68}"/>
+                <a16:creationId xmlns:a16="http://schemas.microsoft.com/office/drawing/2014/main" id="{A74C144B-DDCD-4EFB-AE2A-A2489EF62EBC}"/>
               </a:ext>
             </a:extLst>
           </p:cNvPr>
@@ -4117,7 +4162,7 @@
           <p:cNvPr id="5" name="bullet-2">
             <a:extLst xmlns:a="http://schemas.openxmlformats.org/drawingml/2006/main">
               <a:ext uri="{FF2B5EF4-FFF2-40B4-BE49-F238E27FC236}">
-                <a16:creationId xmlns:a16="http://schemas.microsoft.com/office/drawing/2014/main" id="{803CF45C-B1F1-414F-BCC4-59B8471D1972}"/>
+                <a16:creationId xmlns:a16="http://schemas.microsoft.com/office/drawing/2014/main" id="{8577D07C-AD29-40CA-B993-8703F895AF3E}"/>
               </a:ext>
             </a:extLst>
           </p:cNvPr>
@@ -4162,7 +4207,7 @@
           <p:cNvPr id="6" name="bullet-3">
             <a:extLst xmlns:a="http://schemas.openxmlformats.org/drawingml/2006/main">
               <a:ext uri="{FF2B5EF4-FFF2-40B4-BE49-F238E27FC236}">
-                <a16:creationId xmlns:a16="http://schemas.microsoft.com/office/drawing/2014/main" id="{5D30B09C-F53C-4396-B628-8AB7068AC3FB}"/>
+                <a16:creationId xmlns:a16="http://schemas.microsoft.com/office/drawing/2014/main" id="{A9ED7E0C-DBAF-4FE6-8912-C0D6D4381F78}"/>
               </a:ext>
             </a:extLst>
           </p:cNvPr>
@@ -4207,7 +4252,7 @@
           <p:cNvPr id="7" name="bullet-4">
             <a:extLst xmlns:a="http://schemas.openxmlformats.org/drawingml/2006/main">
               <a:ext uri="{FF2B5EF4-FFF2-40B4-BE49-F238E27FC236}">
-                <a16:creationId xmlns:a16="http://schemas.microsoft.com/office/drawing/2014/main" id="{4B6AA880-2730-4A38-AE86-CC2D2AB57C3C}"/>
+                <a16:creationId xmlns:a16="http://schemas.microsoft.com/office/drawing/2014/main" id="{3391A94A-DD80-41E9-93A5-7E61C4E2E54A}"/>
               </a:ext>
             </a:extLst>
           </p:cNvPr>
@@ -4250,7 +4295,7 @@
     </p:spTree>
     <p:extLst>
       <p:ext uri="{BB962C8B-B14F-4D97-AF65-F5344CB8AC3E}">
-        <p14:creationId xmlns:p14="http://schemas.microsoft.com/office/powerpoint/2010/main" val="59381970"/>
+        <p14:creationId xmlns:p14="http://schemas.microsoft.com/office/powerpoint/2010/main" val="414174806"/>
       </p:ext>
     </p:extLst>
   </p:cSld>

</xml_diff>

<commit_message>
Clarify MoP router plot labels
</commit_message>
<xml_diff>
--- a/slides/mop_stage2_final/output/output.pptx
+++ b/slides/mop_stage2_final/output/output.pptx
@@ -2,20 +2,20 @@
 <file path=ppt/presentation.xml><?xml version="1.0" encoding="utf-8"?>
 <p:presentation xmlns:p="http://schemas.openxmlformats.org/presentationml/2006/main">
   <p:sldMasterIdLst>
-    <p:sldMasterId xmlns:r="http://schemas.openxmlformats.org/officeDocument/2006/relationships" id="2147483648" r:id="R2f69f911492d4536"/>
+    <p:sldMasterId xmlns:r="http://schemas.openxmlformats.org/officeDocument/2006/relationships" id="2147483648" r:id="Rd3e15b785e50462b"/>
   </p:sldMasterIdLst>
   <p:notesMasterIdLst>
-    <p:notesMasterId xmlns:r="http://schemas.openxmlformats.org/officeDocument/2006/relationships" r:id="R525ab306be8642e2"/>
+    <p:notesMasterId xmlns:r="http://schemas.openxmlformats.org/officeDocument/2006/relationships" r:id="R36d49982acb44ed5"/>
   </p:notesMasterIdLst>
   <p:sldIdLst>
-    <p:sldId xmlns:r="http://schemas.openxmlformats.org/officeDocument/2006/relationships" id="256" r:id="R5ab54ac3ab8b406b"/>
-    <p:sldId xmlns:r="http://schemas.openxmlformats.org/officeDocument/2006/relationships" id="257" r:id="R37a20a67f7e94191"/>
-    <p:sldId xmlns:r="http://schemas.openxmlformats.org/officeDocument/2006/relationships" id="258" r:id="R1139a747e2eb4473"/>
-    <p:sldId xmlns:r="http://schemas.openxmlformats.org/officeDocument/2006/relationships" id="259" r:id="R20b0ae66009d4aaa"/>
-    <p:sldId xmlns:r="http://schemas.openxmlformats.org/officeDocument/2006/relationships" id="260" r:id="R118f3ac2c43b44a8"/>
-    <p:sldId xmlns:r="http://schemas.openxmlformats.org/officeDocument/2006/relationships" id="261" r:id="R1b1c737912834c9b"/>
-    <p:sldId xmlns:r="http://schemas.openxmlformats.org/officeDocument/2006/relationships" id="262" r:id="Rad3c13aba11e4684"/>
-    <p:sldId xmlns:r="http://schemas.openxmlformats.org/officeDocument/2006/relationships" id="263" r:id="R07d9a4d458874ba9"/>
+    <p:sldId xmlns:r="http://schemas.openxmlformats.org/officeDocument/2006/relationships" id="256" r:id="R4ac05675976b4e3a"/>
+    <p:sldId xmlns:r="http://schemas.openxmlformats.org/officeDocument/2006/relationships" id="257" r:id="R72a9e0ab83324203"/>
+    <p:sldId xmlns:r="http://schemas.openxmlformats.org/officeDocument/2006/relationships" id="258" r:id="R3a4b48a1a0574249"/>
+    <p:sldId xmlns:r="http://schemas.openxmlformats.org/officeDocument/2006/relationships" id="259" r:id="Rabb48fb249924105"/>
+    <p:sldId xmlns:r="http://schemas.openxmlformats.org/officeDocument/2006/relationships" id="260" r:id="R776cd6609c8c4682"/>
+    <p:sldId xmlns:r="http://schemas.openxmlformats.org/officeDocument/2006/relationships" id="261" r:id="Re62bec6870df435b"/>
+    <p:sldId xmlns:r="http://schemas.openxmlformats.org/officeDocument/2006/relationships" id="262" r:id="Rdb59ffd070c44a13"/>
+    <p:sldId xmlns:r="http://schemas.openxmlformats.org/officeDocument/2006/relationships" id="263" r:id="R1412f957de1c462a"/>
   </p:sldIdLst>
   <p:sldSz cx="18288000" cy="10287000"/>
   <p:notesSz cx="6858000" cy="9144000"/>
@@ -1024,7 +1024,7 @@
   </p:cSld>
   <p:clrMap bg1="lt1" tx1="dk1" bg2="lt2" tx2="dk2" accent1="accent1" accent2="accent2" accent3="accent3" accent4="accent4" accent5="accent5" accent6="accent6" hlink="hlink" folHlink="folHlink"/>
   <p:sldLayoutIdLst>
-    <p:sldLayoutId xmlns:r="http://schemas.openxmlformats.org/officeDocument/2006/relationships" id="2147483649" r:id="R370a2d495ae84f21"/>
+    <p:sldLayoutId xmlns:r="http://schemas.openxmlformats.org/officeDocument/2006/relationships" id="2147483649" r:id="R62e8a3ce50ac4562"/>
   </p:sldLayoutIdLst>
   <p:txStyles>
     <p:titleStyle>
@@ -1323,7 +1323,7 @@
           <p:cNvPr id="1" name="cover-title">
             <a:extLst xmlns:a="http://schemas.openxmlformats.org/drawingml/2006/main">
               <a:ext uri="{FF2B5EF4-FFF2-40B4-BE49-F238E27FC236}">
-                <a16:creationId xmlns:a16="http://schemas.microsoft.com/office/drawing/2014/main" id="{104842F8-13F0-49CA-94FB-789117233FD1}"/>
+                <a16:creationId xmlns:a16="http://schemas.microsoft.com/office/drawing/2014/main" id="{F212F7CA-5FFD-4DF9-B59E-89E0F08A1527}"/>
               </a:ext>
             </a:extLst>
           </p:cNvPr>
@@ -1368,7 +1368,7 @@
           <p:cNvPr id="2" name="cover-rule">
             <a:extLst xmlns:a="http://schemas.openxmlformats.org/drawingml/2006/main">
               <a:ext uri="{FF2B5EF4-FFF2-40B4-BE49-F238E27FC236}">
-                <a16:creationId xmlns:a16="http://schemas.microsoft.com/office/drawing/2014/main" id="{8B6A56EF-ACF5-4A7B-BE32-311734B28BFD}"/>
+                <a16:creationId xmlns:a16="http://schemas.microsoft.com/office/drawing/2014/main" id="{D5397BED-37AA-41F5-B059-0E63C6DFF241}"/>
               </a:ext>
             </a:extLst>
           </p:cNvPr>
@@ -1401,7 +1401,7 @@
           <p:cNvPr id="3" name="cover-thesis">
             <a:extLst xmlns:a="http://schemas.openxmlformats.org/drawingml/2006/main">
               <a:ext uri="{FF2B5EF4-FFF2-40B4-BE49-F238E27FC236}">
-                <a16:creationId xmlns:a16="http://schemas.microsoft.com/office/drawing/2014/main" id="{2E3A7692-5574-4B0C-A94F-B43489F47BC5}"/>
+                <a16:creationId xmlns:a16="http://schemas.microsoft.com/office/drawing/2014/main" id="{08E9C42C-3652-49F5-AFBD-A08B6120E94A}"/>
               </a:ext>
             </a:extLst>
           </p:cNvPr>
@@ -1446,7 +1446,7 @@
           <p:cNvPr id="4" name="cover-metric-1">
             <a:extLst xmlns:a="http://schemas.openxmlformats.org/drawingml/2006/main">
               <a:ext uri="{FF2B5EF4-FFF2-40B4-BE49-F238E27FC236}">
-                <a16:creationId xmlns:a16="http://schemas.microsoft.com/office/drawing/2014/main" id="{1AD879E6-B6CF-48F6-9D33-749409677089}"/>
+                <a16:creationId xmlns:a16="http://schemas.microsoft.com/office/drawing/2014/main" id="{9CADEE43-C060-4C6D-8932-37F73A1A726F}"/>
               </a:ext>
             </a:extLst>
           </p:cNvPr>
@@ -1491,7 +1491,7 @@
           <p:cNvPr id="5" name="cover-label-1">
             <a:extLst xmlns:a="http://schemas.openxmlformats.org/drawingml/2006/main">
               <a:ext uri="{FF2B5EF4-FFF2-40B4-BE49-F238E27FC236}">
-                <a16:creationId xmlns:a16="http://schemas.microsoft.com/office/drawing/2014/main" id="{95C5C27B-31BC-4C81-A5D2-DA19884B7F9C}"/>
+                <a16:creationId xmlns:a16="http://schemas.microsoft.com/office/drawing/2014/main" id="{B65247F8-30AB-4686-9F28-25638CB520BE}"/>
               </a:ext>
             </a:extLst>
           </p:cNvPr>
@@ -1536,7 +1536,7 @@
           <p:cNvPr id="6" name="cover-metric-2">
             <a:extLst xmlns:a="http://schemas.openxmlformats.org/drawingml/2006/main">
               <a:ext uri="{FF2B5EF4-FFF2-40B4-BE49-F238E27FC236}">
-                <a16:creationId xmlns:a16="http://schemas.microsoft.com/office/drawing/2014/main" id="{2BCCED98-2B17-479C-9FBB-239B8AC300E7}"/>
+                <a16:creationId xmlns:a16="http://schemas.microsoft.com/office/drawing/2014/main" id="{843CBEE3-3E2F-4D63-9736-95BA61A4036B}"/>
               </a:ext>
             </a:extLst>
           </p:cNvPr>
@@ -1581,7 +1581,7 @@
           <p:cNvPr id="7" name="cover-label-2">
             <a:extLst xmlns:a="http://schemas.openxmlformats.org/drawingml/2006/main">
               <a:ext uri="{FF2B5EF4-FFF2-40B4-BE49-F238E27FC236}">
-                <a16:creationId xmlns:a16="http://schemas.microsoft.com/office/drawing/2014/main" id="{DBBC1A02-655C-49D4-83C5-0545EE3F6449}"/>
+                <a16:creationId xmlns:a16="http://schemas.microsoft.com/office/drawing/2014/main" id="{0D174311-0BB5-40E8-8108-B2ED80AFE289}"/>
               </a:ext>
             </a:extLst>
           </p:cNvPr>
@@ -1626,7 +1626,7 @@
           <p:cNvPr id="8" name="cover-footer">
             <a:extLst xmlns:a="http://schemas.openxmlformats.org/drawingml/2006/main">
               <a:ext uri="{FF2B5EF4-FFF2-40B4-BE49-F238E27FC236}">
-                <a16:creationId xmlns:a16="http://schemas.microsoft.com/office/drawing/2014/main" id="{4987FD90-0063-42A0-83F9-754BE822781D}"/>
+                <a16:creationId xmlns:a16="http://schemas.microsoft.com/office/drawing/2014/main" id="{6ECB142E-22CE-40B4-9740-19656D4DE6AF}"/>
               </a:ext>
             </a:extLst>
           </p:cNvPr>
@@ -1669,7 +1669,7 @@
     </p:spTree>
     <p:extLst>
       <p:ext uri="{BB962C8B-B14F-4D97-AF65-F5344CB8AC3E}">
-        <p14:creationId xmlns:p14="http://schemas.microsoft.com/office/powerpoint/2010/main" val="1958937230"/>
+        <p14:creationId xmlns:p14="http://schemas.microsoft.com/office/powerpoint/2010/main" val="1363124364"/>
       </p:ext>
     </p:extLst>
   </p:cSld>
@@ -1693,7 +1693,7 @@
           <p:cNvPr id="1" name="slide-title">
             <a:extLst xmlns:a="http://schemas.openxmlformats.org/drawingml/2006/main">
               <a:ext uri="{FF2B5EF4-FFF2-40B4-BE49-F238E27FC236}">
-                <a16:creationId xmlns:a16="http://schemas.microsoft.com/office/drawing/2014/main" id="{69C07125-37CB-4DB4-8BC9-2DF696A9379B}"/>
+                <a16:creationId xmlns:a16="http://schemas.microsoft.com/office/drawing/2014/main" id="{9A7E6820-A45A-4407-B38B-F9A6C9322DE3}"/>
               </a:ext>
             </a:extLst>
           </p:cNvPr>
@@ -1738,7 +1738,7 @@
           <p:cNvPr id="2" name="slide-subtitle">
             <a:extLst xmlns:a="http://schemas.openxmlformats.org/drawingml/2006/main">
               <a:ext uri="{FF2B5EF4-FFF2-40B4-BE49-F238E27FC236}">
-                <a16:creationId xmlns:a16="http://schemas.microsoft.com/office/drawing/2014/main" id="{9CB0A143-1522-4015-B6A5-77AF7C19E238}"/>
+                <a16:creationId xmlns:a16="http://schemas.microsoft.com/office/drawing/2014/main" id="{BBFAFFBE-B35A-42FD-8E57-40F26FB379FF}"/>
               </a:ext>
             </a:extLst>
           </p:cNvPr>
@@ -1783,7 +1783,7 @@
           <p:cNvPr id="3" name="bullet-0">
             <a:extLst xmlns:a="http://schemas.openxmlformats.org/drawingml/2006/main">
               <a:ext uri="{FF2B5EF4-FFF2-40B4-BE49-F238E27FC236}">
-                <a16:creationId xmlns:a16="http://schemas.microsoft.com/office/drawing/2014/main" id="{26D257C6-DCA9-461F-BEED-9DC1ACC52881}"/>
+                <a16:creationId xmlns:a16="http://schemas.microsoft.com/office/drawing/2014/main" id="{C6F87FD8-0AC8-42FD-8A6A-78CDB05A88B9}"/>
               </a:ext>
             </a:extLst>
           </p:cNvPr>
@@ -1828,7 +1828,7 @@
           <p:cNvPr id="4" name="bullet-1">
             <a:extLst xmlns:a="http://schemas.openxmlformats.org/drawingml/2006/main">
               <a:ext uri="{FF2B5EF4-FFF2-40B4-BE49-F238E27FC236}">
-                <a16:creationId xmlns:a16="http://schemas.microsoft.com/office/drawing/2014/main" id="{29D32503-7DF1-41D5-8841-EE08C28A5D3D}"/>
+                <a16:creationId xmlns:a16="http://schemas.microsoft.com/office/drawing/2014/main" id="{91CE9EA1-384F-4D07-8A40-AA6C68ACDF6C}"/>
               </a:ext>
             </a:extLst>
           </p:cNvPr>
@@ -1873,7 +1873,7 @@
           <p:cNvPr id="5" name="bullet-2">
             <a:extLst xmlns:a="http://schemas.openxmlformats.org/drawingml/2006/main">
               <a:ext uri="{FF2B5EF4-FFF2-40B4-BE49-F238E27FC236}">
-                <a16:creationId xmlns:a16="http://schemas.microsoft.com/office/drawing/2014/main" id="{BC6C7295-0D78-498E-8932-483114B6F721}"/>
+                <a16:creationId xmlns:a16="http://schemas.microsoft.com/office/drawing/2014/main" id="{E7A99DF7-24AC-4A30-8032-98BA90DD6B54}"/>
               </a:ext>
             </a:extLst>
           </p:cNvPr>
@@ -1918,7 +1918,7 @@
           <p:cNvPr id="6" name="bullet-3">
             <a:extLst xmlns:a="http://schemas.openxmlformats.org/drawingml/2006/main">
               <a:ext uri="{FF2B5EF4-FFF2-40B4-BE49-F238E27FC236}">
-                <a16:creationId xmlns:a16="http://schemas.microsoft.com/office/drawing/2014/main" id="{2842230B-4F91-4C6C-8348-AC132E854BC1}"/>
+                <a16:creationId xmlns:a16="http://schemas.microsoft.com/office/drawing/2014/main" id="{AE5500B7-CBAF-4D93-90E1-BC0AFE7126D0}"/>
               </a:ext>
             </a:extLst>
           </p:cNvPr>
@@ -1963,7 +1963,7 @@
           <p:cNvPr id="7" name="bullet-0">
             <a:extLst xmlns:a="http://schemas.openxmlformats.org/drawingml/2006/main">
               <a:ext uri="{FF2B5EF4-FFF2-40B4-BE49-F238E27FC236}">
-                <a16:creationId xmlns:a16="http://schemas.microsoft.com/office/drawing/2014/main" id="{BAAEED9A-7FA0-46BE-A028-899BB117A58F}"/>
+                <a16:creationId xmlns:a16="http://schemas.microsoft.com/office/drawing/2014/main" id="{5BB70139-ABF0-462D-AF77-70DD5C9861CC}"/>
               </a:ext>
             </a:extLst>
           </p:cNvPr>
@@ -2008,7 +2008,7 @@
           <p:cNvPr id="8" name="bullet-1">
             <a:extLst xmlns:a="http://schemas.openxmlformats.org/drawingml/2006/main">
               <a:ext uri="{FF2B5EF4-FFF2-40B4-BE49-F238E27FC236}">
-                <a16:creationId xmlns:a16="http://schemas.microsoft.com/office/drawing/2014/main" id="{4D79007E-73CF-4F3F-872F-641C19FB1E88}"/>
+                <a16:creationId xmlns:a16="http://schemas.microsoft.com/office/drawing/2014/main" id="{BDFE9C8F-F346-4611-996C-909B8538799E}"/>
               </a:ext>
             </a:extLst>
           </p:cNvPr>
@@ -2053,7 +2053,7 @@
           <p:cNvPr id="9" name="bullet-2">
             <a:extLst xmlns:a="http://schemas.openxmlformats.org/drawingml/2006/main">
               <a:ext uri="{FF2B5EF4-FFF2-40B4-BE49-F238E27FC236}">
-                <a16:creationId xmlns:a16="http://schemas.microsoft.com/office/drawing/2014/main" id="{77F80584-C12B-4511-A9EC-6E390B3831BF}"/>
+                <a16:creationId xmlns:a16="http://schemas.microsoft.com/office/drawing/2014/main" id="{07622DDE-3438-405C-B665-C14395D0D8C8}"/>
               </a:ext>
             </a:extLst>
           </p:cNvPr>
@@ -2098,7 +2098,7 @@
           <p:cNvPr id="10" name="bullet-3">
             <a:extLst xmlns:a="http://schemas.openxmlformats.org/drawingml/2006/main">
               <a:ext uri="{FF2B5EF4-FFF2-40B4-BE49-F238E27FC236}">
-                <a16:creationId xmlns:a16="http://schemas.microsoft.com/office/drawing/2014/main" id="{8312EEE0-7FC9-45BF-A0CD-C7EC508B7315}"/>
+                <a16:creationId xmlns:a16="http://schemas.microsoft.com/office/drawing/2014/main" id="{8F9B6B40-C0BC-46EB-8331-067FF7CD2D19}"/>
               </a:ext>
             </a:extLst>
           </p:cNvPr>
@@ -2143,7 +2143,7 @@
           <p:cNvPr id="11" name="bullet-0">
             <a:extLst xmlns:a="http://schemas.openxmlformats.org/drawingml/2006/main">
               <a:ext uri="{FF2B5EF4-FFF2-40B4-BE49-F238E27FC236}">
-                <a16:creationId xmlns:a16="http://schemas.microsoft.com/office/drawing/2014/main" id="{05D53889-931C-495D-AAAE-4AB2210B4CCF}"/>
+                <a16:creationId xmlns:a16="http://schemas.microsoft.com/office/drawing/2014/main" id="{2A79F255-8238-4DC1-A777-DB5AEE70566F}"/>
               </a:ext>
             </a:extLst>
           </p:cNvPr>
@@ -2188,7 +2188,7 @@
           <p:cNvPr id="12" name="bullet-1">
             <a:extLst xmlns:a="http://schemas.openxmlformats.org/drawingml/2006/main">
               <a:ext uri="{FF2B5EF4-FFF2-40B4-BE49-F238E27FC236}">
-                <a16:creationId xmlns:a16="http://schemas.microsoft.com/office/drawing/2014/main" id="{94B0F1CE-F555-40F3-96FF-FEC839EDD72D}"/>
+                <a16:creationId xmlns:a16="http://schemas.microsoft.com/office/drawing/2014/main" id="{3DEDACB3-AC72-40FE-9D4D-B785CE2DDFC4}"/>
               </a:ext>
             </a:extLst>
           </p:cNvPr>
@@ -2233,7 +2233,7 @@
           <p:cNvPr id="13" name="bullet-2">
             <a:extLst xmlns:a="http://schemas.openxmlformats.org/drawingml/2006/main">
               <a:ext uri="{FF2B5EF4-FFF2-40B4-BE49-F238E27FC236}">
-                <a16:creationId xmlns:a16="http://schemas.microsoft.com/office/drawing/2014/main" id="{F268CF17-51C1-4255-B79E-360906E9A70B}"/>
+                <a16:creationId xmlns:a16="http://schemas.microsoft.com/office/drawing/2014/main" id="{92D7C18A-03E5-475E-B949-EE16BBB7FF06}"/>
               </a:ext>
             </a:extLst>
           </p:cNvPr>
@@ -2278,7 +2278,7 @@
           <p:cNvPr id="14" name="bullet-3">
             <a:extLst xmlns:a="http://schemas.openxmlformats.org/drawingml/2006/main">
               <a:ext uri="{FF2B5EF4-FFF2-40B4-BE49-F238E27FC236}">
-                <a16:creationId xmlns:a16="http://schemas.microsoft.com/office/drawing/2014/main" id="{21DFE1AA-2741-46DE-9135-B89DFCE2D142}"/>
+                <a16:creationId xmlns:a16="http://schemas.microsoft.com/office/drawing/2014/main" id="{A9A4F5E0-775A-4C69-94EB-A975ACBC3F57}"/>
               </a:ext>
             </a:extLst>
           </p:cNvPr>
@@ -2321,7 +2321,7 @@
     </p:spTree>
     <p:extLst>
       <p:ext uri="{BB962C8B-B14F-4D97-AF65-F5344CB8AC3E}">
-        <p14:creationId xmlns:p14="http://schemas.microsoft.com/office/powerpoint/2010/main" val="2000307137"/>
+        <p14:creationId xmlns:p14="http://schemas.microsoft.com/office/powerpoint/2010/main" val="544722709"/>
       </p:ext>
     </p:extLst>
   </p:cSld>
@@ -2345,7 +2345,7 @@
           <p:cNvPr id="1" name="slide-title">
             <a:extLst xmlns:a="http://schemas.openxmlformats.org/drawingml/2006/main">
               <a:ext uri="{FF2B5EF4-FFF2-40B4-BE49-F238E27FC236}">
-                <a16:creationId xmlns:a16="http://schemas.microsoft.com/office/drawing/2014/main" id="{95312A3B-A6A8-4212-9281-001BBA61C7C8}"/>
+                <a16:creationId xmlns:a16="http://schemas.microsoft.com/office/drawing/2014/main" id="{0D113D2F-F7A5-4B25-BF21-90225155B9D2}"/>
               </a:ext>
             </a:extLst>
           </p:cNvPr>
@@ -2390,7 +2390,7 @@
           <p:cNvPr id="2" name="title-rule">
             <a:extLst xmlns:a="http://schemas.openxmlformats.org/drawingml/2006/main">
               <a:ext uri="{FF2B5EF4-FFF2-40B4-BE49-F238E27FC236}">
-                <a16:creationId xmlns:a16="http://schemas.microsoft.com/office/drawing/2014/main" id="{A1E48ED5-CCE4-4AC9-8EBC-7842F1C0B684}"/>
+                <a16:creationId xmlns:a16="http://schemas.microsoft.com/office/drawing/2014/main" id="{E7BE33C1-6130-4F75-87B1-239B9C71C4E5}"/>
               </a:ext>
             </a:extLst>
           </p:cNvPr>
@@ -2423,7 +2423,7 @@
           <p:cNvPr id="3" name="bullet-0">
             <a:extLst xmlns:a="http://schemas.openxmlformats.org/drawingml/2006/main">
               <a:ext uri="{FF2B5EF4-FFF2-40B4-BE49-F238E27FC236}">
-                <a16:creationId xmlns:a16="http://schemas.microsoft.com/office/drawing/2014/main" id="{C21EB791-4DCF-409D-A642-2D97F96C147D}"/>
+                <a16:creationId xmlns:a16="http://schemas.microsoft.com/office/drawing/2014/main" id="{14EC44B0-8EE5-4055-9B7E-9D303DA09E3E}"/>
               </a:ext>
             </a:extLst>
           </p:cNvPr>
@@ -2468,7 +2468,7 @@
           <p:cNvPr id="4" name="bullet-1">
             <a:extLst xmlns:a="http://schemas.openxmlformats.org/drawingml/2006/main">
               <a:ext uri="{FF2B5EF4-FFF2-40B4-BE49-F238E27FC236}">
-                <a16:creationId xmlns:a16="http://schemas.microsoft.com/office/drawing/2014/main" id="{75CB7F39-1947-4056-B905-20C080EA3CB3}"/>
+                <a16:creationId xmlns:a16="http://schemas.microsoft.com/office/drawing/2014/main" id="{85710E09-912B-4EE9-A424-5BCEA81DC7ED}"/>
               </a:ext>
             </a:extLst>
           </p:cNvPr>
@@ -2513,7 +2513,7 @@
           <p:cNvPr id="5" name="bullet-2">
             <a:extLst xmlns:a="http://schemas.openxmlformats.org/drawingml/2006/main">
               <a:ext uri="{FF2B5EF4-FFF2-40B4-BE49-F238E27FC236}">
-                <a16:creationId xmlns:a16="http://schemas.microsoft.com/office/drawing/2014/main" id="{3109ABD6-515E-4976-A13A-8CB804465C8F}"/>
+                <a16:creationId xmlns:a16="http://schemas.microsoft.com/office/drawing/2014/main" id="{59EEA449-C06F-439A-8450-D1D1370AE399}"/>
               </a:ext>
             </a:extLst>
           </p:cNvPr>
@@ -2558,7 +2558,7 @@
           <p:cNvPr id="6" name="bullet-3">
             <a:extLst xmlns:a="http://schemas.openxmlformats.org/drawingml/2006/main">
               <a:ext uri="{FF2B5EF4-FFF2-40B4-BE49-F238E27FC236}">
-                <a16:creationId xmlns:a16="http://schemas.microsoft.com/office/drawing/2014/main" id="{1690D3D3-C554-46FC-8D58-D47BDCD5A4DF}"/>
+                <a16:creationId xmlns:a16="http://schemas.microsoft.com/office/drawing/2014/main" id="{7BC095C2-951D-4B4A-A6F2-E0159BE57C49}"/>
               </a:ext>
             </a:extLst>
           </p:cNvPr>
@@ -2603,7 +2603,7 @@
           <p:cNvPr id="7" name="bullet-4">
             <a:extLst xmlns:a="http://schemas.openxmlformats.org/drawingml/2006/main">
               <a:ext uri="{FF2B5EF4-FFF2-40B4-BE49-F238E27FC236}">
-                <a16:creationId xmlns:a16="http://schemas.microsoft.com/office/drawing/2014/main" id="{8D7178FA-5BA6-479F-86CD-EE1A622431AD}"/>
+                <a16:creationId xmlns:a16="http://schemas.microsoft.com/office/drawing/2014/main" id="{D22157F3-5F65-434E-8EEF-31E2CCF58029}"/>
               </a:ext>
             </a:extLst>
           </p:cNvPr>
@@ -2648,7 +2648,7 @@
           <p:cNvPr id="8" name="bullet-5">
             <a:extLst xmlns:a="http://schemas.openxmlformats.org/drawingml/2006/main">
               <a:ext uri="{FF2B5EF4-FFF2-40B4-BE49-F238E27FC236}">
-                <a16:creationId xmlns:a16="http://schemas.microsoft.com/office/drawing/2014/main" id="{332AB083-C940-48DC-ABAE-3B100911098D}"/>
+                <a16:creationId xmlns:a16="http://schemas.microsoft.com/office/drawing/2014/main" id="{CF10E400-1958-4A64-A653-14242F80817F}"/>
               </a:ext>
             </a:extLst>
           </p:cNvPr>
@@ -2693,7 +2693,7 @@
           <p:cNvPr id="9" name="bullet-0">
             <a:extLst xmlns:a="http://schemas.openxmlformats.org/drawingml/2006/main">
               <a:ext uri="{FF2B5EF4-FFF2-40B4-BE49-F238E27FC236}">
-                <a16:creationId xmlns:a16="http://schemas.microsoft.com/office/drawing/2014/main" id="{30AD1104-228E-4BA0-AE7F-610ECE258898}"/>
+                <a16:creationId xmlns:a16="http://schemas.microsoft.com/office/drawing/2014/main" id="{984513EA-0EA8-48FE-8A21-F2E857581F46}"/>
               </a:ext>
             </a:extLst>
           </p:cNvPr>
@@ -2738,7 +2738,7 @@
           <p:cNvPr id="10" name="bullet-1">
             <a:extLst xmlns:a="http://schemas.openxmlformats.org/drawingml/2006/main">
               <a:ext uri="{FF2B5EF4-FFF2-40B4-BE49-F238E27FC236}">
-                <a16:creationId xmlns:a16="http://schemas.microsoft.com/office/drawing/2014/main" id="{E01C0F83-1F67-4473-ADAC-AF734BDBEF5F}"/>
+                <a16:creationId xmlns:a16="http://schemas.microsoft.com/office/drawing/2014/main" id="{EECB0C37-3424-4F61-9971-B3F4E6C8CE9E}"/>
               </a:ext>
             </a:extLst>
           </p:cNvPr>
@@ -2783,7 +2783,7 @@
           <p:cNvPr id="11" name="bullet-2">
             <a:extLst xmlns:a="http://schemas.openxmlformats.org/drawingml/2006/main">
               <a:ext uri="{FF2B5EF4-FFF2-40B4-BE49-F238E27FC236}">
-                <a16:creationId xmlns:a16="http://schemas.microsoft.com/office/drawing/2014/main" id="{0C272645-435F-4475-B9C8-6CD6260DA7A0}"/>
+                <a16:creationId xmlns:a16="http://schemas.microsoft.com/office/drawing/2014/main" id="{7BD83221-8FE9-48C1-BF8D-41A6F6DE503D}"/>
               </a:ext>
             </a:extLst>
           </p:cNvPr>
@@ -2828,7 +2828,7 @@
           <p:cNvPr id="12" name="bullet-3">
             <a:extLst xmlns:a="http://schemas.openxmlformats.org/drawingml/2006/main">
               <a:ext uri="{FF2B5EF4-FFF2-40B4-BE49-F238E27FC236}">
-                <a16:creationId xmlns:a16="http://schemas.microsoft.com/office/drawing/2014/main" id="{7B60406E-BEA3-45D0-A41C-2B0909858F71}"/>
+                <a16:creationId xmlns:a16="http://schemas.microsoft.com/office/drawing/2014/main" id="{6F8C5096-D161-4C99-A918-6B76680F82CE}"/>
               </a:ext>
             </a:extLst>
           </p:cNvPr>
@@ -2873,7 +2873,7 @@
           <p:cNvPr id="13" name="bullet-4">
             <a:extLst xmlns:a="http://schemas.openxmlformats.org/drawingml/2006/main">
               <a:ext uri="{FF2B5EF4-FFF2-40B4-BE49-F238E27FC236}">
-                <a16:creationId xmlns:a16="http://schemas.microsoft.com/office/drawing/2014/main" id="{EFF426E2-1684-4B17-BB0D-8E63BAC33FF5}"/>
+                <a16:creationId xmlns:a16="http://schemas.microsoft.com/office/drawing/2014/main" id="{A914F031-08D5-4F4B-A645-D7DC9486E0E7}"/>
               </a:ext>
             </a:extLst>
           </p:cNvPr>
@@ -2918,7 +2918,7 @@
           <p:cNvPr id="14" name="protocol-footer">
             <a:extLst xmlns:a="http://schemas.openxmlformats.org/drawingml/2006/main">
               <a:ext uri="{FF2B5EF4-FFF2-40B4-BE49-F238E27FC236}">
-                <a16:creationId xmlns:a16="http://schemas.microsoft.com/office/drawing/2014/main" id="{52C2C8AD-6285-48C3-9406-F6479B817C12}"/>
+                <a16:creationId xmlns:a16="http://schemas.microsoft.com/office/drawing/2014/main" id="{089B3FB8-0505-4635-BA67-81C4CE2A75C6}"/>
               </a:ext>
             </a:extLst>
           </p:cNvPr>
@@ -2961,7 +2961,7 @@
     </p:spTree>
     <p:extLst>
       <p:ext uri="{BB962C8B-B14F-4D97-AF65-F5344CB8AC3E}">
-        <p14:creationId xmlns:p14="http://schemas.microsoft.com/office/powerpoint/2010/main" val="986342257"/>
+        <p14:creationId xmlns:p14="http://schemas.microsoft.com/office/powerpoint/2010/main" val="733094581"/>
       </p:ext>
     </p:extLst>
   </p:cSld>
@@ -2985,7 +2985,7 @@
           <p:cNvPr id="1" name="slide-title">
             <a:extLst xmlns:a="http://schemas.openxmlformats.org/drawingml/2006/main">
               <a:ext uri="{FF2B5EF4-FFF2-40B4-BE49-F238E27FC236}">
-                <a16:creationId xmlns:a16="http://schemas.microsoft.com/office/drawing/2014/main" id="{306A2238-A3F3-4060-A987-776B75E62F5C}"/>
+                <a16:creationId xmlns:a16="http://schemas.microsoft.com/office/drawing/2014/main" id="{3C3AB468-67DB-4FDF-9C8A-7791C074C067}"/>
               </a:ext>
             </a:extLst>
           </p:cNvPr>
@@ -3030,7 +3030,7 @@
           <p:cNvPr id="2" name="slide-subtitle">
             <a:extLst xmlns:a="http://schemas.openxmlformats.org/drawingml/2006/main">
               <a:ext uri="{FF2B5EF4-FFF2-40B4-BE49-F238E27FC236}">
-                <a16:creationId xmlns:a16="http://schemas.microsoft.com/office/drawing/2014/main" id="{7B6CACE4-73AE-4028-A81F-F826DE9C9FA7}"/>
+                <a16:creationId xmlns:a16="http://schemas.microsoft.com/office/drawing/2014/main" id="{9D382E67-32E2-4530-A476-98EC12991FF4}"/>
               </a:ext>
             </a:extLst>
           </p:cNvPr>
@@ -3079,7 +3079,7 @@
           <p:nvPr/>
         </p:nvPicPr>
         <p:blipFill>
-          <a:blip xmlns:r="http://schemas.openxmlformats.org/officeDocument/2006/relationships" xmlns:a="http://schemas.openxmlformats.org/drawingml/2006/main" r:embed="Rb6eb624e6bed43c6"/>
+          <a:blip xmlns:r="http://schemas.openxmlformats.org/officeDocument/2006/relationships" xmlns:a="http://schemas.openxmlformats.org/drawingml/2006/main" r:embed="R9b306c4dd3c34e0f"/>
           <a:stretch xmlns:a="http://schemas.openxmlformats.org/drawingml/2006/main"/>
         </p:blipFill>
         <p:spPr>
@@ -3095,7 +3095,7 @@
     </p:spTree>
     <p:extLst>
       <p:ext uri="{BB962C8B-B14F-4D97-AF65-F5344CB8AC3E}">
-        <p14:creationId xmlns:p14="http://schemas.microsoft.com/office/powerpoint/2010/main" val="1429022769"/>
+        <p14:creationId xmlns:p14="http://schemas.microsoft.com/office/powerpoint/2010/main" val="2049289954"/>
       </p:ext>
     </p:extLst>
   </p:cSld>
@@ -3119,7 +3119,7 @@
           <p:cNvPr id="1" name="slide-title">
             <a:extLst xmlns:a="http://schemas.openxmlformats.org/drawingml/2006/main">
               <a:ext uri="{FF2B5EF4-FFF2-40B4-BE49-F238E27FC236}">
-                <a16:creationId xmlns:a16="http://schemas.microsoft.com/office/drawing/2014/main" id="{A9267DDB-8E7A-4155-8B20-BCB2C543B1B1}"/>
+                <a16:creationId xmlns:a16="http://schemas.microsoft.com/office/drawing/2014/main" id="{38608995-13E5-4149-9B52-E7214D4BBEF4}"/>
               </a:ext>
             </a:extLst>
           </p:cNvPr>
@@ -3164,7 +3164,7 @@
           <p:cNvPr id="2" name="slide-subtitle">
             <a:extLst xmlns:a="http://schemas.openxmlformats.org/drawingml/2006/main">
               <a:ext uri="{FF2B5EF4-FFF2-40B4-BE49-F238E27FC236}">
-                <a16:creationId xmlns:a16="http://schemas.microsoft.com/office/drawing/2014/main" id="{FF7B64AD-73B5-4620-981C-E15BCC3EE8B0}"/>
+                <a16:creationId xmlns:a16="http://schemas.microsoft.com/office/drawing/2014/main" id="{3C0402C9-5FFD-4753-A94A-46E867C12C18}"/>
               </a:ext>
             </a:extLst>
           </p:cNvPr>
@@ -3199,7 +3199,7 @@
                   <a:srgbClr val="000000"/>
                 </a:solidFill>
               </a:rPr>
-              <a:t>Horizontal bars compare MLOP, SPP+PPF, MoP-V1, and MoP-V2 on each heldout trace.</a:t>
+              <a:t>Each trace row is ordered Expert 1, Expert 2, MoP-V1, then MoP-V2.</a:t>
             </a:r>
           </a:p>
         </p:txBody>
@@ -3213,7 +3213,7 @@
           <p:nvPr/>
         </p:nvPicPr>
         <p:blipFill>
-          <a:blip xmlns:r="http://schemas.openxmlformats.org/officeDocument/2006/relationships" xmlns:a="http://schemas.openxmlformats.org/drawingml/2006/main" r:embed="Rc45661af8d934617"/>
+          <a:blip xmlns:r="http://schemas.openxmlformats.org/officeDocument/2006/relationships" xmlns:a="http://schemas.openxmlformats.org/drawingml/2006/main" r:embed="R1fe85374a05f4591"/>
           <a:stretch xmlns:a="http://schemas.openxmlformats.org/drawingml/2006/main"/>
         </p:blipFill>
         <p:spPr>
@@ -3229,7 +3229,7 @@
     </p:spTree>
     <p:extLst>
       <p:ext uri="{BB962C8B-B14F-4D97-AF65-F5344CB8AC3E}">
-        <p14:creationId xmlns:p14="http://schemas.microsoft.com/office/powerpoint/2010/main" val="1340915007"/>
+        <p14:creationId xmlns:p14="http://schemas.microsoft.com/office/powerpoint/2010/main" val="108135087"/>
       </p:ext>
     </p:extLst>
   </p:cSld>
@@ -3253,7 +3253,7 @@
           <p:cNvPr id="1" name="slide-title">
             <a:extLst xmlns:a="http://schemas.openxmlformats.org/drawingml/2006/main">
               <a:ext uri="{FF2B5EF4-FFF2-40B4-BE49-F238E27FC236}">
-                <a16:creationId xmlns:a16="http://schemas.microsoft.com/office/drawing/2014/main" id="{49A6B293-8E6A-4A99-B971-A5DCC68C28A2}"/>
+                <a16:creationId xmlns:a16="http://schemas.microsoft.com/office/drawing/2014/main" id="{32E2F9C5-726F-4DA5-B695-D9F871410B1E}"/>
               </a:ext>
             </a:extLst>
           </p:cNvPr>
@@ -3298,7 +3298,7 @@
           <p:cNvPr id="2" name="slide-subtitle">
             <a:extLst xmlns:a="http://schemas.openxmlformats.org/drawingml/2006/main">
               <a:ext uri="{FF2B5EF4-FFF2-40B4-BE49-F238E27FC236}">
-                <a16:creationId xmlns:a16="http://schemas.microsoft.com/office/drawing/2014/main" id="{781F8880-A2D9-4E4E-872B-25E16B2F60FA}"/>
+                <a16:creationId xmlns:a16="http://schemas.microsoft.com/office/drawing/2014/main" id="{D34CFE5E-70C7-414A-B690-2CF0927D3355}"/>
               </a:ext>
             </a:extLst>
           </p:cNvPr>
@@ -3347,7 +3347,7 @@
           <p:nvPr/>
         </p:nvPicPr>
         <p:blipFill>
-          <a:blip xmlns:r="http://schemas.openxmlformats.org/officeDocument/2006/relationships" xmlns:a="http://schemas.openxmlformats.org/drawingml/2006/main" r:embed="Re8aa4613c0e845af"/>
+          <a:blip xmlns:r="http://schemas.openxmlformats.org/officeDocument/2006/relationships" xmlns:a="http://schemas.openxmlformats.org/drawingml/2006/main" r:embed="R20c4e6bb75b54a80"/>
           <a:stretch xmlns:a="http://schemas.openxmlformats.org/drawingml/2006/main"/>
         </p:blipFill>
         <p:spPr>
@@ -3363,7 +3363,7 @@
     </p:spTree>
     <p:extLst>
       <p:ext uri="{BB962C8B-B14F-4D97-AF65-F5344CB8AC3E}">
-        <p14:creationId xmlns:p14="http://schemas.microsoft.com/office/powerpoint/2010/main" val="1438646429"/>
+        <p14:creationId xmlns:p14="http://schemas.microsoft.com/office/powerpoint/2010/main" val="1840466722"/>
       </p:ext>
     </p:extLst>
   </p:cSld>
@@ -3387,7 +3387,7 @@
           <p:cNvPr id="1" name="slide-title">
             <a:extLst xmlns:a="http://schemas.openxmlformats.org/drawingml/2006/main">
               <a:ext uri="{FF2B5EF4-FFF2-40B4-BE49-F238E27FC236}">
-                <a16:creationId xmlns:a16="http://schemas.microsoft.com/office/drawing/2014/main" id="{7CADD791-C915-491C-BA7F-9BE31A36733E}"/>
+                <a16:creationId xmlns:a16="http://schemas.microsoft.com/office/drawing/2014/main" id="{99ABCE61-DD1D-4B14-8638-3ADE31898BCA}"/>
               </a:ext>
             </a:extLst>
           </p:cNvPr>
@@ -3432,7 +3432,7 @@
           <p:cNvPr id="2" name="slide-subtitle">
             <a:extLst xmlns:a="http://schemas.openxmlformats.org/drawingml/2006/main">
               <a:ext uri="{FF2B5EF4-FFF2-40B4-BE49-F238E27FC236}">
-                <a16:creationId xmlns:a16="http://schemas.microsoft.com/office/drawing/2014/main" id="{5708BF2E-3DF6-499E-BC14-8418397015E0}"/>
+                <a16:creationId xmlns:a16="http://schemas.microsoft.com/office/drawing/2014/main" id="{525155BF-9BC1-4909-9417-B5CE4A4484E3}"/>
               </a:ext>
             </a:extLst>
           </p:cNvPr>
@@ -3477,7 +3477,7 @@
           <p:cNvPr id="3" name="bullet-0">
             <a:extLst xmlns:a="http://schemas.openxmlformats.org/drawingml/2006/main">
               <a:ext uri="{FF2B5EF4-FFF2-40B4-BE49-F238E27FC236}">
-                <a16:creationId xmlns:a16="http://schemas.microsoft.com/office/drawing/2014/main" id="{A080C14A-EBFD-4233-9AD1-B4612FD7C146}"/>
+                <a16:creationId xmlns:a16="http://schemas.microsoft.com/office/drawing/2014/main" id="{42000C8F-BE45-427B-8908-97F245480007}"/>
               </a:ext>
             </a:extLst>
           </p:cNvPr>
@@ -3522,7 +3522,7 @@
           <p:cNvPr id="4" name="bullet-1">
             <a:extLst xmlns:a="http://schemas.openxmlformats.org/drawingml/2006/main">
               <a:ext uri="{FF2B5EF4-FFF2-40B4-BE49-F238E27FC236}">
-                <a16:creationId xmlns:a16="http://schemas.microsoft.com/office/drawing/2014/main" id="{FF1B4997-3DA8-456F-8DCC-D46156031319}"/>
+                <a16:creationId xmlns:a16="http://schemas.microsoft.com/office/drawing/2014/main" id="{F8F63EE7-1A22-4852-B0D3-CAA2B0D75EAB}"/>
               </a:ext>
             </a:extLst>
           </p:cNvPr>
@@ -3567,7 +3567,7 @@
           <p:cNvPr id="5" name="bullet-2">
             <a:extLst xmlns:a="http://schemas.openxmlformats.org/drawingml/2006/main">
               <a:ext uri="{FF2B5EF4-FFF2-40B4-BE49-F238E27FC236}">
-                <a16:creationId xmlns:a16="http://schemas.microsoft.com/office/drawing/2014/main" id="{95F2ECF5-E4BD-4A8E-BC16-844BFF5AF742}"/>
+                <a16:creationId xmlns:a16="http://schemas.microsoft.com/office/drawing/2014/main" id="{D4E1F446-02B6-464D-8D05-546075DFAD65}"/>
               </a:ext>
             </a:extLst>
           </p:cNvPr>
@@ -3612,7 +3612,7 @@
           <p:cNvPr id="6" name="bullet-3">
             <a:extLst xmlns:a="http://schemas.openxmlformats.org/drawingml/2006/main">
               <a:ext uri="{FF2B5EF4-FFF2-40B4-BE49-F238E27FC236}">
-                <a16:creationId xmlns:a16="http://schemas.microsoft.com/office/drawing/2014/main" id="{B3A583E9-E943-4196-A5F5-9FF8A5EBF544}"/>
+                <a16:creationId xmlns:a16="http://schemas.microsoft.com/office/drawing/2014/main" id="{CD095594-A07F-4E35-B5F3-999E4C593036}"/>
               </a:ext>
             </a:extLst>
           </p:cNvPr>
@@ -3657,7 +3657,7 @@
           <p:cNvPr id="7" name="bullet-4">
             <a:extLst xmlns:a="http://schemas.openxmlformats.org/drawingml/2006/main">
               <a:ext uri="{FF2B5EF4-FFF2-40B4-BE49-F238E27FC236}">
-                <a16:creationId xmlns:a16="http://schemas.microsoft.com/office/drawing/2014/main" id="{687C08A9-BAD2-43AA-B9AE-B3F157706646}"/>
+                <a16:creationId xmlns:a16="http://schemas.microsoft.com/office/drawing/2014/main" id="{1E092B11-F8DB-4782-984B-FC5D4CC5E429}"/>
               </a:ext>
             </a:extLst>
           </p:cNvPr>
@@ -3702,7 +3702,7 @@
           <p:cNvPr id="8" name="bullet-0">
             <a:extLst xmlns:a="http://schemas.openxmlformats.org/drawingml/2006/main">
               <a:ext uri="{FF2B5EF4-FFF2-40B4-BE49-F238E27FC236}">
-                <a16:creationId xmlns:a16="http://schemas.microsoft.com/office/drawing/2014/main" id="{C648851A-7539-4AED-B86E-FD751FEE8579}"/>
+                <a16:creationId xmlns:a16="http://schemas.microsoft.com/office/drawing/2014/main" id="{DEB37964-C5C8-437F-BF72-48BBE42229A3}"/>
               </a:ext>
             </a:extLst>
           </p:cNvPr>
@@ -3747,7 +3747,7 @@
           <p:cNvPr id="9" name="bullet-1">
             <a:extLst xmlns:a="http://schemas.openxmlformats.org/drawingml/2006/main">
               <a:ext uri="{FF2B5EF4-FFF2-40B4-BE49-F238E27FC236}">
-                <a16:creationId xmlns:a16="http://schemas.microsoft.com/office/drawing/2014/main" id="{2D5504E1-0905-4849-8A5C-88E35DB46149}"/>
+                <a16:creationId xmlns:a16="http://schemas.microsoft.com/office/drawing/2014/main" id="{C5A3F7D7-0F58-481F-BCD8-37C0EC772A19}"/>
               </a:ext>
             </a:extLst>
           </p:cNvPr>
@@ -3792,7 +3792,7 @@
           <p:cNvPr id="10" name="bullet-2">
             <a:extLst xmlns:a="http://schemas.openxmlformats.org/drawingml/2006/main">
               <a:ext uri="{FF2B5EF4-FFF2-40B4-BE49-F238E27FC236}">
-                <a16:creationId xmlns:a16="http://schemas.microsoft.com/office/drawing/2014/main" id="{8411D9CF-F82C-4B50-AA46-A3E80E1302A7}"/>
+                <a16:creationId xmlns:a16="http://schemas.microsoft.com/office/drawing/2014/main" id="{06D2D52C-6409-4CC1-8236-21241C70DAFD}"/>
               </a:ext>
             </a:extLst>
           </p:cNvPr>
@@ -3837,7 +3837,7 @@
           <p:cNvPr id="11" name="bullet-3">
             <a:extLst xmlns:a="http://schemas.openxmlformats.org/drawingml/2006/main">
               <a:ext uri="{FF2B5EF4-FFF2-40B4-BE49-F238E27FC236}">
-                <a16:creationId xmlns:a16="http://schemas.microsoft.com/office/drawing/2014/main" id="{4388D130-623E-4F24-92B7-48151E7EE008}"/>
+                <a16:creationId xmlns:a16="http://schemas.microsoft.com/office/drawing/2014/main" id="{F31CF10A-712F-44CB-BA1A-52485E5D7EA2}"/>
               </a:ext>
             </a:extLst>
           </p:cNvPr>
@@ -3882,7 +3882,7 @@
           <p:cNvPr id="12" name="bullet-4">
             <a:extLst xmlns:a="http://schemas.openxmlformats.org/drawingml/2006/main">
               <a:ext uri="{FF2B5EF4-FFF2-40B4-BE49-F238E27FC236}">
-                <a16:creationId xmlns:a16="http://schemas.microsoft.com/office/drawing/2014/main" id="{A1FE0D1D-36AF-4AE3-86EA-FB477D392DF5}"/>
+                <a16:creationId xmlns:a16="http://schemas.microsoft.com/office/drawing/2014/main" id="{73FB21A3-5745-46F8-8311-53B10E262A0E}"/>
               </a:ext>
             </a:extLst>
           </p:cNvPr>
@@ -3927,7 +3927,7 @@
           <p:cNvPr id="13" name="audit-footer">
             <a:extLst xmlns:a="http://schemas.openxmlformats.org/drawingml/2006/main">
               <a:ext uri="{FF2B5EF4-FFF2-40B4-BE49-F238E27FC236}">
-                <a16:creationId xmlns:a16="http://schemas.microsoft.com/office/drawing/2014/main" id="{6779B243-AF73-4E35-A897-8A5CDCB7F5B6}"/>
+                <a16:creationId xmlns:a16="http://schemas.microsoft.com/office/drawing/2014/main" id="{9037988D-7AD3-4EFA-919A-2E1F0F85F1B2}"/>
               </a:ext>
             </a:extLst>
           </p:cNvPr>
@@ -3970,7 +3970,7 @@
     </p:spTree>
     <p:extLst>
       <p:ext uri="{BB962C8B-B14F-4D97-AF65-F5344CB8AC3E}">
-        <p14:creationId xmlns:p14="http://schemas.microsoft.com/office/powerpoint/2010/main" val="1713037047"/>
+        <p14:creationId xmlns:p14="http://schemas.microsoft.com/office/powerpoint/2010/main" val="747566990"/>
       </p:ext>
     </p:extLst>
   </p:cSld>
@@ -3994,7 +3994,7 @@
           <p:cNvPr id="1" name="slide-title">
             <a:extLst xmlns:a="http://schemas.openxmlformats.org/drawingml/2006/main">
               <a:ext uri="{FF2B5EF4-FFF2-40B4-BE49-F238E27FC236}">
-                <a16:creationId xmlns:a16="http://schemas.microsoft.com/office/drawing/2014/main" id="{7D370412-37AF-4586-8CA0-4854D3DBBC4C}"/>
+                <a16:creationId xmlns:a16="http://schemas.microsoft.com/office/drawing/2014/main" id="{9FC537BD-93F4-43FF-90ED-D068620E7715}"/>
               </a:ext>
             </a:extLst>
           </p:cNvPr>
@@ -4039,7 +4039,7 @@
           <p:cNvPr id="2" name="title-rule">
             <a:extLst xmlns:a="http://schemas.openxmlformats.org/drawingml/2006/main">
               <a:ext uri="{FF2B5EF4-FFF2-40B4-BE49-F238E27FC236}">
-                <a16:creationId xmlns:a16="http://schemas.microsoft.com/office/drawing/2014/main" id="{E2A10BF2-0BF8-4A2D-B1B0-7664A088A107}"/>
+                <a16:creationId xmlns:a16="http://schemas.microsoft.com/office/drawing/2014/main" id="{5C40746E-DCCB-4A2C-BF64-A7C5B0084609}"/>
               </a:ext>
             </a:extLst>
           </p:cNvPr>
@@ -4072,7 +4072,7 @@
           <p:cNvPr id="3" name="bullet-0">
             <a:extLst xmlns:a="http://schemas.openxmlformats.org/drawingml/2006/main">
               <a:ext uri="{FF2B5EF4-FFF2-40B4-BE49-F238E27FC236}">
-                <a16:creationId xmlns:a16="http://schemas.microsoft.com/office/drawing/2014/main" id="{6B0CADB3-D1AC-4622-B107-9DF567937840}"/>
+                <a16:creationId xmlns:a16="http://schemas.microsoft.com/office/drawing/2014/main" id="{7AECCD9E-38B4-4C0B-9261-4F4BF369DB51}"/>
               </a:ext>
             </a:extLst>
           </p:cNvPr>
@@ -4117,7 +4117,7 @@
           <p:cNvPr id="4" name="bullet-1">
             <a:extLst xmlns:a="http://schemas.openxmlformats.org/drawingml/2006/main">
               <a:ext uri="{FF2B5EF4-FFF2-40B4-BE49-F238E27FC236}">
-                <a16:creationId xmlns:a16="http://schemas.microsoft.com/office/drawing/2014/main" id="{A74C144B-DDCD-4EFB-AE2A-A2489EF62EBC}"/>
+                <a16:creationId xmlns:a16="http://schemas.microsoft.com/office/drawing/2014/main" id="{0122A8A3-7001-44A6-8A15-6CD447CDC98C}"/>
               </a:ext>
             </a:extLst>
           </p:cNvPr>
@@ -4162,7 +4162,7 @@
           <p:cNvPr id="5" name="bullet-2">
             <a:extLst xmlns:a="http://schemas.openxmlformats.org/drawingml/2006/main">
               <a:ext uri="{FF2B5EF4-FFF2-40B4-BE49-F238E27FC236}">
-                <a16:creationId xmlns:a16="http://schemas.microsoft.com/office/drawing/2014/main" id="{8577D07C-AD29-40CA-B993-8703F895AF3E}"/>
+                <a16:creationId xmlns:a16="http://schemas.microsoft.com/office/drawing/2014/main" id="{CC39F68F-A748-4CAB-A2FF-06E72D672B57}"/>
               </a:ext>
             </a:extLst>
           </p:cNvPr>
@@ -4207,7 +4207,7 @@
           <p:cNvPr id="6" name="bullet-3">
             <a:extLst xmlns:a="http://schemas.openxmlformats.org/drawingml/2006/main">
               <a:ext uri="{FF2B5EF4-FFF2-40B4-BE49-F238E27FC236}">
-                <a16:creationId xmlns:a16="http://schemas.microsoft.com/office/drawing/2014/main" id="{A9ED7E0C-DBAF-4FE6-8912-C0D6D4381F78}"/>
+                <a16:creationId xmlns:a16="http://schemas.microsoft.com/office/drawing/2014/main" id="{578CECC2-82E4-4DC0-AA78-80A88F5614D7}"/>
               </a:ext>
             </a:extLst>
           </p:cNvPr>
@@ -4252,7 +4252,7 @@
           <p:cNvPr id="7" name="bullet-4">
             <a:extLst xmlns:a="http://schemas.openxmlformats.org/drawingml/2006/main">
               <a:ext uri="{FF2B5EF4-FFF2-40B4-BE49-F238E27FC236}">
-                <a16:creationId xmlns:a16="http://schemas.microsoft.com/office/drawing/2014/main" id="{3391A94A-DD80-41E9-93A5-7E61C4E2E54A}"/>
+                <a16:creationId xmlns:a16="http://schemas.microsoft.com/office/drawing/2014/main" id="{BACBAE01-666D-4068-A127-4F3FF014D01D}"/>
               </a:ext>
             </a:extLst>
           </p:cNvPr>
@@ -4295,7 +4295,7 @@
     </p:spTree>
     <p:extLst>
       <p:ext uri="{BB962C8B-B14F-4D97-AF65-F5344CB8AC3E}">
-        <p14:creationId xmlns:p14="http://schemas.microsoft.com/office/powerpoint/2010/main" val="414174806"/>
+        <p14:creationId xmlns:p14="http://schemas.microsoft.com/office/powerpoint/2010/main" val="1820663386"/>
       </p:ext>
     </p:extLst>
   </p:cSld>

</xml_diff>

<commit_message>
Use dark blue best expert references
</commit_message>
<xml_diff>
--- a/slides/mop_stage2_final/output/output.pptx
+++ b/slides/mop_stage2_final/output/output.pptx
@@ -2,20 +2,20 @@
 <file path=ppt/presentation.xml><?xml version="1.0" encoding="utf-8"?>
 <p:presentation xmlns:p="http://schemas.openxmlformats.org/presentationml/2006/main">
   <p:sldMasterIdLst>
-    <p:sldMasterId xmlns:r="http://schemas.openxmlformats.org/officeDocument/2006/relationships" id="2147483648" r:id="Rd3e15b785e50462b"/>
+    <p:sldMasterId xmlns:r="http://schemas.openxmlformats.org/officeDocument/2006/relationships" id="2147483648" r:id="R6683ce269f5944ed"/>
   </p:sldMasterIdLst>
   <p:notesMasterIdLst>
-    <p:notesMasterId xmlns:r="http://schemas.openxmlformats.org/officeDocument/2006/relationships" r:id="R36d49982acb44ed5"/>
+    <p:notesMasterId xmlns:r="http://schemas.openxmlformats.org/officeDocument/2006/relationships" r:id="Rb25610d4f2614833"/>
   </p:notesMasterIdLst>
   <p:sldIdLst>
-    <p:sldId xmlns:r="http://schemas.openxmlformats.org/officeDocument/2006/relationships" id="256" r:id="R4ac05675976b4e3a"/>
-    <p:sldId xmlns:r="http://schemas.openxmlformats.org/officeDocument/2006/relationships" id="257" r:id="R72a9e0ab83324203"/>
-    <p:sldId xmlns:r="http://schemas.openxmlformats.org/officeDocument/2006/relationships" id="258" r:id="R3a4b48a1a0574249"/>
-    <p:sldId xmlns:r="http://schemas.openxmlformats.org/officeDocument/2006/relationships" id="259" r:id="Rabb48fb249924105"/>
-    <p:sldId xmlns:r="http://schemas.openxmlformats.org/officeDocument/2006/relationships" id="260" r:id="R776cd6609c8c4682"/>
-    <p:sldId xmlns:r="http://schemas.openxmlformats.org/officeDocument/2006/relationships" id="261" r:id="Re62bec6870df435b"/>
-    <p:sldId xmlns:r="http://schemas.openxmlformats.org/officeDocument/2006/relationships" id="262" r:id="Rdb59ffd070c44a13"/>
-    <p:sldId xmlns:r="http://schemas.openxmlformats.org/officeDocument/2006/relationships" id="263" r:id="R1412f957de1c462a"/>
+    <p:sldId xmlns:r="http://schemas.openxmlformats.org/officeDocument/2006/relationships" id="256" r:id="R768e5260a039488b"/>
+    <p:sldId xmlns:r="http://schemas.openxmlformats.org/officeDocument/2006/relationships" id="257" r:id="R34448978551f4506"/>
+    <p:sldId xmlns:r="http://schemas.openxmlformats.org/officeDocument/2006/relationships" id="258" r:id="Rdefb8498b2ea46ba"/>
+    <p:sldId xmlns:r="http://schemas.openxmlformats.org/officeDocument/2006/relationships" id="259" r:id="Rd6c1a7e1d9644e42"/>
+    <p:sldId xmlns:r="http://schemas.openxmlformats.org/officeDocument/2006/relationships" id="260" r:id="Rda8782502f0140b2"/>
+    <p:sldId xmlns:r="http://schemas.openxmlformats.org/officeDocument/2006/relationships" id="261" r:id="R62c8d1ea175d4b8b"/>
+    <p:sldId xmlns:r="http://schemas.openxmlformats.org/officeDocument/2006/relationships" id="262" r:id="R38d5d737f08042a3"/>
+    <p:sldId xmlns:r="http://schemas.openxmlformats.org/officeDocument/2006/relationships" id="263" r:id="Ra03fadf2bae44ee5"/>
   </p:sldIdLst>
   <p:sldSz cx="18288000" cy="10287000"/>
   <p:notesSz cx="6858000" cy="9144000"/>
@@ -1024,7 +1024,7 @@
   </p:cSld>
   <p:clrMap bg1="lt1" tx1="dk1" bg2="lt2" tx2="dk2" accent1="accent1" accent2="accent2" accent3="accent3" accent4="accent4" accent5="accent5" accent6="accent6" hlink="hlink" folHlink="folHlink"/>
   <p:sldLayoutIdLst>
-    <p:sldLayoutId xmlns:r="http://schemas.openxmlformats.org/officeDocument/2006/relationships" id="2147483649" r:id="R62e8a3ce50ac4562"/>
+    <p:sldLayoutId xmlns:r="http://schemas.openxmlformats.org/officeDocument/2006/relationships" id="2147483649" r:id="Rcb5a31b04c2744af"/>
   </p:sldLayoutIdLst>
   <p:txStyles>
     <p:titleStyle>
@@ -1323,7 +1323,7 @@
           <p:cNvPr id="1" name="cover-title">
             <a:extLst xmlns:a="http://schemas.openxmlformats.org/drawingml/2006/main">
               <a:ext uri="{FF2B5EF4-FFF2-40B4-BE49-F238E27FC236}">
-                <a16:creationId xmlns:a16="http://schemas.microsoft.com/office/drawing/2014/main" id="{F212F7CA-5FFD-4DF9-B59E-89E0F08A1527}"/>
+                <a16:creationId xmlns:a16="http://schemas.microsoft.com/office/drawing/2014/main" id="{F60FFA0A-333B-468E-8901-C9A2AFBEC4DF}"/>
               </a:ext>
             </a:extLst>
           </p:cNvPr>
@@ -1368,7 +1368,7 @@
           <p:cNvPr id="2" name="cover-rule">
             <a:extLst xmlns:a="http://schemas.openxmlformats.org/drawingml/2006/main">
               <a:ext uri="{FF2B5EF4-FFF2-40B4-BE49-F238E27FC236}">
-                <a16:creationId xmlns:a16="http://schemas.microsoft.com/office/drawing/2014/main" id="{D5397BED-37AA-41F5-B059-0E63C6DFF241}"/>
+                <a16:creationId xmlns:a16="http://schemas.microsoft.com/office/drawing/2014/main" id="{71DE660D-9389-4F27-88CA-FAC2C0317E54}"/>
               </a:ext>
             </a:extLst>
           </p:cNvPr>
@@ -1401,7 +1401,7 @@
           <p:cNvPr id="3" name="cover-thesis">
             <a:extLst xmlns:a="http://schemas.openxmlformats.org/drawingml/2006/main">
               <a:ext uri="{FF2B5EF4-FFF2-40B4-BE49-F238E27FC236}">
-                <a16:creationId xmlns:a16="http://schemas.microsoft.com/office/drawing/2014/main" id="{08E9C42C-3652-49F5-AFBD-A08B6120E94A}"/>
+                <a16:creationId xmlns:a16="http://schemas.microsoft.com/office/drawing/2014/main" id="{9B93E9C0-CF34-439E-9590-9493746900C4}"/>
               </a:ext>
             </a:extLst>
           </p:cNvPr>
@@ -1446,7 +1446,7 @@
           <p:cNvPr id="4" name="cover-metric-1">
             <a:extLst xmlns:a="http://schemas.openxmlformats.org/drawingml/2006/main">
               <a:ext uri="{FF2B5EF4-FFF2-40B4-BE49-F238E27FC236}">
-                <a16:creationId xmlns:a16="http://schemas.microsoft.com/office/drawing/2014/main" id="{9CADEE43-C060-4C6D-8932-37F73A1A726F}"/>
+                <a16:creationId xmlns:a16="http://schemas.microsoft.com/office/drawing/2014/main" id="{0AAF37FD-77CB-4533-8B69-59A58534A032}"/>
               </a:ext>
             </a:extLst>
           </p:cNvPr>
@@ -1491,7 +1491,7 @@
           <p:cNvPr id="5" name="cover-label-1">
             <a:extLst xmlns:a="http://schemas.openxmlformats.org/drawingml/2006/main">
               <a:ext uri="{FF2B5EF4-FFF2-40B4-BE49-F238E27FC236}">
-                <a16:creationId xmlns:a16="http://schemas.microsoft.com/office/drawing/2014/main" id="{B65247F8-30AB-4686-9F28-25638CB520BE}"/>
+                <a16:creationId xmlns:a16="http://schemas.microsoft.com/office/drawing/2014/main" id="{2B932005-22B0-4172-9425-E9261DA93052}"/>
               </a:ext>
             </a:extLst>
           </p:cNvPr>
@@ -1536,7 +1536,7 @@
           <p:cNvPr id="6" name="cover-metric-2">
             <a:extLst xmlns:a="http://schemas.openxmlformats.org/drawingml/2006/main">
               <a:ext uri="{FF2B5EF4-FFF2-40B4-BE49-F238E27FC236}">
-                <a16:creationId xmlns:a16="http://schemas.microsoft.com/office/drawing/2014/main" id="{843CBEE3-3E2F-4D63-9736-95BA61A4036B}"/>
+                <a16:creationId xmlns:a16="http://schemas.microsoft.com/office/drawing/2014/main" id="{CAE2C728-3CAD-4994-81FF-8F66CEAC62EF}"/>
               </a:ext>
             </a:extLst>
           </p:cNvPr>
@@ -1581,7 +1581,7 @@
           <p:cNvPr id="7" name="cover-label-2">
             <a:extLst xmlns:a="http://schemas.openxmlformats.org/drawingml/2006/main">
               <a:ext uri="{FF2B5EF4-FFF2-40B4-BE49-F238E27FC236}">
-                <a16:creationId xmlns:a16="http://schemas.microsoft.com/office/drawing/2014/main" id="{0D174311-0BB5-40E8-8108-B2ED80AFE289}"/>
+                <a16:creationId xmlns:a16="http://schemas.microsoft.com/office/drawing/2014/main" id="{F4A9B5A4-210E-48D6-ABFB-5372162DA752}"/>
               </a:ext>
             </a:extLst>
           </p:cNvPr>
@@ -1626,7 +1626,7 @@
           <p:cNvPr id="8" name="cover-footer">
             <a:extLst xmlns:a="http://schemas.openxmlformats.org/drawingml/2006/main">
               <a:ext uri="{FF2B5EF4-FFF2-40B4-BE49-F238E27FC236}">
-                <a16:creationId xmlns:a16="http://schemas.microsoft.com/office/drawing/2014/main" id="{6ECB142E-22CE-40B4-9740-19656D4DE6AF}"/>
+                <a16:creationId xmlns:a16="http://schemas.microsoft.com/office/drawing/2014/main" id="{40D1322E-2844-4E8A-8C7C-FFF898157302}"/>
               </a:ext>
             </a:extLst>
           </p:cNvPr>
@@ -1669,7 +1669,7 @@
     </p:spTree>
     <p:extLst>
       <p:ext uri="{BB962C8B-B14F-4D97-AF65-F5344CB8AC3E}">
-        <p14:creationId xmlns:p14="http://schemas.microsoft.com/office/powerpoint/2010/main" val="1363124364"/>
+        <p14:creationId xmlns:p14="http://schemas.microsoft.com/office/powerpoint/2010/main" val="417969294"/>
       </p:ext>
     </p:extLst>
   </p:cSld>
@@ -1693,7 +1693,7 @@
           <p:cNvPr id="1" name="slide-title">
             <a:extLst xmlns:a="http://schemas.openxmlformats.org/drawingml/2006/main">
               <a:ext uri="{FF2B5EF4-FFF2-40B4-BE49-F238E27FC236}">
-                <a16:creationId xmlns:a16="http://schemas.microsoft.com/office/drawing/2014/main" id="{9A7E6820-A45A-4407-B38B-F9A6C9322DE3}"/>
+                <a16:creationId xmlns:a16="http://schemas.microsoft.com/office/drawing/2014/main" id="{0AD178BB-7B07-42A3-93FC-C79853755C10}"/>
               </a:ext>
             </a:extLst>
           </p:cNvPr>
@@ -1738,7 +1738,7 @@
           <p:cNvPr id="2" name="slide-subtitle">
             <a:extLst xmlns:a="http://schemas.openxmlformats.org/drawingml/2006/main">
               <a:ext uri="{FF2B5EF4-FFF2-40B4-BE49-F238E27FC236}">
-                <a16:creationId xmlns:a16="http://schemas.microsoft.com/office/drawing/2014/main" id="{BBFAFFBE-B35A-42FD-8E57-40F26FB379FF}"/>
+                <a16:creationId xmlns:a16="http://schemas.microsoft.com/office/drawing/2014/main" id="{45799322-1B42-499F-945B-92CB1A11CBE0}"/>
               </a:ext>
             </a:extLst>
           </p:cNvPr>
@@ -1783,7 +1783,7 @@
           <p:cNvPr id="3" name="bullet-0">
             <a:extLst xmlns:a="http://schemas.openxmlformats.org/drawingml/2006/main">
               <a:ext uri="{FF2B5EF4-FFF2-40B4-BE49-F238E27FC236}">
-                <a16:creationId xmlns:a16="http://schemas.microsoft.com/office/drawing/2014/main" id="{C6F87FD8-0AC8-42FD-8A6A-78CDB05A88B9}"/>
+                <a16:creationId xmlns:a16="http://schemas.microsoft.com/office/drawing/2014/main" id="{17CCB4D7-FC6A-401F-9919-11EB98429AE4}"/>
               </a:ext>
             </a:extLst>
           </p:cNvPr>
@@ -1828,7 +1828,7 @@
           <p:cNvPr id="4" name="bullet-1">
             <a:extLst xmlns:a="http://schemas.openxmlformats.org/drawingml/2006/main">
               <a:ext uri="{FF2B5EF4-FFF2-40B4-BE49-F238E27FC236}">
-                <a16:creationId xmlns:a16="http://schemas.microsoft.com/office/drawing/2014/main" id="{91CE9EA1-384F-4D07-8A40-AA6C68ACDF6C}"/>
+                <a16:creationId xmlns:a16="http://schemas.microsoft.com/office/drawing/2014/main" id="{F9AD71F2-DDBA-4C6B-BF95-826AF07552BE}"/>
               </a:ext>
             </a:extLst>
           </p:cNvPr>
@@ -1873,7 +1873,7 @@
           <p:cNvPr id="5" name="bullet-2">
             <a:extLst xmlns:a="http://schemas.openxmlformats.org/drawingml/2006/main">
               <a:ext uri="{FF2B5EF4-FFF2-40B4-BE49-F238E27FC236}">
-                <a16:creationId xmlns:a16="http://schemas.microsoft.com/office/drawing/2014/main" id="{E7A99DF7-24AC-4A30-8032-98BA90DD6B54}"/>
+                <a16:creationId xmlns:a16="http://schemas.microsoft.com/office/drawing/2014/main" id="{A7D4EAD4-C1E8-492A-ADCF-2EB29ACDEF96}"/>
               </a:ext>
             </a:extLst>
           </p:cNvPr>
@@ -1918,7 +1918,7 @@
           <p:cNvPr id="6" name="bullet-3">
             <a:extLst xmlns:a="http://schemas.openxmlformats.org/drawingml/2006/main">
               <a:ext uri="{FF2B5EF4-FFF2-40B4-BE49-F238E27FC236}">
-                <a16:creationId xmlns:a16="http://schemas.microsoft.com/office/drawing/2014/main" id="{AE5500B7-CBAF-4D93-90E1-BC0AFE7126D0}"/>
+                <a16:creationId xmlns:a16="http://schemas.microsoft.com/office/drawing/2014/main" id="{E3D5F164-E9B2-44C6-A5A6-E520D86C0A1C}"/>
               </a:ext>
             </a:extLst>
           </p:cNvPr>
@@ -1963,7 +1963,7 @@
           <p:cNvPr id="7" name="bullet-0">
             <a:extLst xmlns:a="http://schemas.openxmlformats.org/drawingml/2006/main">
               <a:ext uri="{FF2B5EF4-FFF2-40B4-BE49-F238E27FC236}">
-                <a16:creationId xmlns:a16="http://schemas.microsoft.com/office/drawing/2014/main" id="{5BB70139-ABF0-462D-AF77-70DD5C9861CC}"/>
+                <a16:creationId xmlns:a16="http://schemas.microsoft.com/office/drawing/2014/main" id="{45B542EB-933B-437C-B138-1BECB666797F}"/>
               </a:ext>
             </a:extLst>
           </p:cNvPr>
@@ -2008,7 +2008,7 @@
           <p:cNvPr id="8" name="bullet-1">
             <a:extLst xmlns:a="http://schemas.openxmlformats.org/drawingml/2006/main">
               <a:ext uri="{FF2B5EF4-FFF2-40B4-BE49-F238E27FC236}">
-                <a16:creationId xmlns:a16="http://schemas.microsoft.com/office/drawing/2014/main" id="{BDFE9C8F-F346-4611-996C-909B8538799E}"/>
+                <a16:creationId xmlns:a16="http://schemas.microsoft.com/office/drawing/2014/main" id="{94CAD20E-C55D-4FEF-8DE1-8DF88FF19ED0}"/>
               </a:ext>
             </a:extLst>
           </p:cNvPr>
@@ -2053,7 +2053,7 @@
           <p:cNvPr id="9" name="bullet-2">
             <a:extLst xmlns:a="http://schemas.openxmlformats.org/drawingml/2006/main">
               <a:ext uri="{FF2B5EF4-FFF2-40B4-BE49-F238E27FC236}">
-                <a16:creationId xmlns:a16="http://schemas.microsoft.com/office/drawing/2014/main" id="{07622DDE-3438-405C-B665-C14395D0D8C8}"/>
+                <a16:creationId xmlns:a16="http://schemas.microsoft.com/office/drawing/2014/main" id="{252BFD17-61FC-49D5-8D18-FBF8E878B671}"/>
               </a:ext>
             </a:extLst>
           </p:cNvPr>
@@ -2098,7 +2098,7 @@
           <p:cNvPr id="10" name="bullet-3">
             <a:extLst xmlns:a="http://schemas.openxmlformats.org/drawingml/2006/main">
               <a:ext uri="{FF2B5EF4-FFF2-40B4-BE49-F238E27FC236}">
-                <a16:creationId xmlns:a16="http://schemas.microsoft.com/office/drawing/2014/main" id="{8F9B6B40-C0BC-46EB-8331-067FF7CD2D19}"/>
+                <a16:creationId xmlns:a16="http://schemas.microsoft.com/office/drawing/2014/main" id="{C4CCAA17-C083-476C-9014-E8A580A126FC}"/>
               </a:ext>
             </a:extLst>
           </p:cNvPr>
@@ -2143,7 +2143,7 @@
           <p:cNvPr id="11" name="bullet-0">
             <a:extLst xmlns:a="http://schemas.openxmlformats.org/drawingml/2006/main">
               <a:ext uri="{FF2B5EF4-FFF2-40B4-BE49-F238E27FC236}">
-                <a16:creationId xmlns:a16="http://schemas.microsoft.com/office/drawing/2014/main" id="{2A79F255-8238-4DC1-A777-DB5AEE70566F}"/>
+                <a16:creationId xmlns:a16="http://schemas.microsoft.com/office/drawing/2014/main" id="{9C5E9F15-9415-4030-B667-2CF2EF2A0579}"/>
               </a:ext>
             </a:extLst>
           </p:cNvPr>
@@ -2188,7 +2188,7 @@
           <p:cNvPr id="12" name="bullet-1">
             <a:extLst xmlns:a="http://schemas.openxmlformats.org/drawingml/2006/main">
               <a:ext uri="{FF2B5EF4-FFF2-40B4-BE49-F238E27FC236}">
-                <a16:creationId xmlns:a16="http://schemas.microsoft.com/office/drawing/2014/main" id="{3DEDACB3-AC72-40FE-9D4D-B785CE2DDFC4}"/>
+                <a16:creationId xmlns:a16="http://schemas.microsoft.com/office/drawing/2014/main" id="{51936781-1DC6-488E-B637-37ECDA219C46}"/>
               </a:ext>
             </a:extLst>
           </p:cNvPr>
@@ -2233,7 +2233,7 @@
           <p:cNvPr id="13" name="bullet-2">
             <a:extLst xmlns:a="http://schemas.openxmlformats.org/drawingml/2006/main">
               <a:ext uri="{FF2B5EF4-FFF2-40B4-BE49-F238E27FC236}">
-                <a16:creationId xmlns:a16="http://schemas.microsoft.com/office/drawing/2014/main" id="{92D7C18A-03E5-475E-B949-EE16BBB7FF06}"/>
+                <a16:creationId xmlns:a16="http://schemas.microsoft.com/office/drawing/2014/main" id="{2F3E9E49-2BBA-45D4-A0BD-B2CA263422B2}"/>
               </a:ext>
             </a:extLst>
           </p:cNvPr>
@@ -2278,7 +2278,7 @@
           <p:cNvPr id="14" name="bullet-3">
             <a:extLst xmlns:a="http://schemas.openxmlformats.org/drawingml/2006/main">
               <a:ext uri="{FF2B5EF4-FFF2-40B4-BE49-F238E27FC236}">
-                <a16:creationId xmlns:a16="http://schemas.microsoft.com/office/drawing/2014/main" id="{A9A4F5E0-775A-4C69-94EB-A975ACBC3F57}"/>
+                <a16:creationId xmlns:a16="http://schemas.microsoft.com/office/drawing/2014/main" id="{5C737E06-57CB-4C1C-A698-AC9D61C65FDF}"/>
               </a:ext>
             </a:extLst>
           </p:cNvPr>
@@ -2321,7 +2321,7 @@
     </p:spTree>
     <p:extLst>
       <p:ext uri="{BB962C8B-B14F-4D97-AF65-F5344CB8AC3E}">
-        <p14:creationId xmlns:p14="http://schemas.microsoft.com/office/powerpoint/2010/main" val="544722709"/>
+        <p14:creationId xmlns:p14="http://schemas.microsoft.com/office/powerpoint/2010/main" val="1612228302"/>
       </p:ext>
     </p:extLst>
   </p:cSld>
@@ -2345,7 +2345,7 @@
           <p:cNvPr id="1" name="slide-title">
             <a:extLst xmlns:a="http://schemas.openxmlformats.org/drawingml/2006/main">
               <a:ext uri="{FF2B5EF4-FFF2-40B4-BE49-F238E27FC236}">
-                <a16:creationId xmlns:a16="http://schemas.microsoft.com/office/drawing/2014/main" id="{0D113D2F-F7A5-4B25-BF21-90225155B9D2}"/>
+                <a16:creationId xmlns:a16="http://schemas.microsoft.com/office/drawing/2014/main" id="{49268A0B-5BAF-4735-9A17-4D2F2593165D}"/>
               </a:ext>
             </a:extLst>
           </p:cNvPr>
@@ -2390,7 +2390,7 @@
           <p:cNvPr id="2" name="title-rule">
             <a:extLst xmlns:a="http://schemas.openxmlformats.org/drawingml/2006/main">
               <a:ext uri="{FF2B5EF4-FFF2-40B4-BE49-F238E27FC236}">
-                <a16:creationId xmlns:a16="http://schemas.microsoft.com/office/drawing/2014/main" id="{E7BE33C1-6130-4F75-87B1-239B9C71C4E5}"/>
+                <a16:creationId xmlns:a16="http://schemas.microsoft.com/office/drawing/2014/main" id="{EAD8944F-0B39-48FA-986B-5D010C0A256D}"/>
               </a:ext>
             </a:extLst>
           </p:cNvPr>
@@ -2423,7 +2423,7 @@
           <p:cNvPr id="3" name="bullet-0">
             <a:extLst xmlns:a="http://schemas.openxmlformats.org/drawingml/2006/main">
               <a:ext uri="{FF2B5EF4-FFF2-40B4-BE49-F238E27FC236}">
-                <a16:creationId xmlns:a16="http://schemas.microsoft.com/office/drawing/2014/main" id="{14EC44B0-8EE5-4055-9B7E-9D303DA09E3E}"/>
+                <a16:creationId xmlns:a16="http://schemas.microsoft.com/office/drawing/2014/main" id="{B0059973-B5A0-44A6-80B4-850715741C0C}"/>
               </a:ext>
             </a:extLst>
           </p:cNvPr>
@@ -2468,7 +2468,7 @@
           <p:cNvPr id="4" name="bullet-1">
             <a:extLst xmlns:a="http://schemas.openxmlformats.org/drawingml/2006/main">
               <a:ext uri="{FF2B5EF4-FFF2-40B4-BE49-F238E27FC236}">
-                <a16:creationId xmlns:a16="http://schemas.microsoft.com/office/drawing/2014/main" id="{85710E09-912B-4EE9-A424-5BCEA81DC7ED}"/>
+                <a16:creationId xmlns:a16="http://schemas.microsoft.com/office/drawing/2014/main" id="{8935F293-7747-4895-BD10-65EDA6F8F4F9}"/>
               </a:ext>
             </a:extLst>
           </p:cNvPr>
@@ -2513,7 +2513,7 @@
           <p:cNvPr id="5" name="bullet-2">
             <a:extLst xmlns:a="http://schemas.openxmlformats.org/drawingml/2006/main">
               <a:ext uri="{FF2B5EF4-FFF2-40B4-BE49-F238E27FC236}">
-                <a16:creationId xmlns:a16="http://schemas.microsoft.com/office/drawing/2014/main" id="{59EEA449-C06F-439A-8450-D1D1370AE399}"/>
+                <a16:creationId xmlns:a16="http://schemas.microsoft.com/office/drawing/2014/main" id="{6287FC2B-F3CD-4AB0-9632-06D49372E862}"/>
               </a:ext>
             </a:extLst>
           </p:cNvPr>
@@ -2558,7 +2558,7 @@
           <p:cNvPr id="6" name="bullet-3">
             <a:extLst xmlns:a="http://schemas.openxmlformats.org/drawingml/2006/main">
               <a:ext uri="{FF2B5EF4-FFF2-40B4-BE49-F238E27FC236}">
-                <a16:creationId xmlns:a16="http://schemas.microsoft.com/office/drawing/2014/main" id="{7BC095C2-951D-4B4A-A6F2-E0159BE57C49}"/>
+                <a16:creationId xmlns:a16="http://schemas.microsoft.com/office/drawing/2014/main" id="{80C7DD1D-A8FE-444D-8340-D941A75F8971}"/>
               </a:ext>
             </a:extLst>
           </p:cNvPr>
@@ -2603,7 +2603,7 @@
           <p:cNvPr id="7" name="bullet-4">
             <a:extLst xmlns:a="http://schemas.openxmlformats.org/drawingml/2006/main">
               <a:ext uri="{FF2B5EF4-FFF2-40B4-BE49-F238E27FC236}">
-                <a16:creationId xmlns:a16="http://schemas.microsoft.com/office/drawing/2014/main" id="{D22157F3-5F65-434E-8EEF-31E2CCF58029}"/>
+                <a16:creationId xmlns:a16="http://schemas.microsoft.com/office/drawing/2014/main" id="{C02A6667-B152-46B3-B51F-EA6BE26CEDEE}"/>
               </a:ext>
             </a:extLst>
           </p:cNvPr>
@@ -2648,7 +2648,7 @@
           <p:cNvPr id="8" name="bullet-5">
             <a:extLst xmlns:a="http://schemas.openxmlformats.org/drawingml/2006/main">
               <a:ext uri="{FF2B5EF4-FFF2-40B4-BE49-F238E27FC236}">
-                <a16:creationId xmlns:a16="http://schemas.microsoft.com/office/drawing/2014/main" id="{CF10E400-1958-4A64-A653-14242F80817F}"/>
+                <a16:creationId xmlns:a16="http://schemas.microsoft.com/office/drawing/2014/main" id="{FF989ABB-33A4-4210-B375-0FE64E18FFEB}"/>
               </a:ext>
             </a:extLst>
           </p:cNvPr>
@@ -2693,7 +2693,7 @@
           <p:cNvPr id="9" name="bullet-0">
             <a:extLst xmlns:a="http://schemas.openxmlformats.org/drawingml/2006/main">
               <a:ext uri="{FF2B5EF4-FFF2-40B4-BE49-F238E27FC236}">
-                <a16:creationId xmlns:a16="http://schemas.microsoft.com/office/drawing/2014/main" id="{984513EA-0EA8-48FE-8A21-F2E857581F46}"/>
+                <a16:creationId xmlns:a16="http://schemas.microsoft.com/office/drawing/2014/main" id="{1545D795-A88F-4F3D-8BBE-37CFF0146A0F}"/>
               </a:ext>
             </a:extLst>
           </p:cNvPr>
@@ -2738,7 +2738,7 @@
           <p:cNvPr id="10" name="bullet-1">
             <a:extLst xmlns:a="http://schemas.openxmlformats.org/drawingml/2006/main">
               <a:ext uri="{FF2B5EF4-FFF2-40B4-BE49-F238E27FC236}">
-                <a16:creationId xmlns:a16="http://schemas.microsoft.com/office/drawing/2014/main" id="{EECB0C37-3424-4F61-9971-B3F4E6C8CE9E}"/>
+                <a16:creationId xmlns:a16="http://schemas.microsoft.com/office/drawing/2014/main" id="{505ACA83-8A95-4F91-ABA4-F99FAADB3757}"/>
               </a:ext>
             </a:extLst>
           </p:cNvPr>
@@ -2783,7 +2783,7 @@
           <p:cNvPr id="11" name="bullet-2">
             <a:extLst xmlns:a="http://schemas.openxmlformats.org/drawingml/2006/main">
               <a:ext uri="{FF2B5EF4-FFF2-40B4-BE49-F238E27FC236}">
-                <a16:creationId xmlns:a16="http://schemas.microsoft.com/office/drawing/2014/main" id="{7BD83221-8FE9-48C1-BF8D-41A6F6DE503D}"/>
+                <a16:creationId xmlns:a16="http://schemas.microsoft.com/office/drawing/2014/main" id="{FE15165E-B372-46D6-8BB6-BE346041C4B0}"/>
               </a:ext>
             </a:extLst>
           </p:cNvPr>
@@ -2828,7 +2828,7 @@
           <p:cNvPr id="12" name="bullet-3">
             <a:extLst xmlns:a="http://schemas.openxmlformats.org/drawingml/2006/main">
               <a:ext uri="{FF2B5EF4-FFF2-40B4-BE49-F238E27FC236}">
-                <a16:creationId xmlns:a16="http://schemas.microsoft.com/office/drawing/2014/main" id="{6F8C5096-D161-4C99-A918-6B76680F82CE}"/>
+                <a16:creationId xmlns:a16="http://schemas.microsoft.com/office/drawing/2014/main" id="{50F3EE28-0CA0-4453-96AE-0F413DC25C91}"/>
               </a:ext>
             </a:extLst>
           </p:cNvPr>
@@ -2873,7 +2873,7 @@
           <p:cNvPr id="13" name="bullet-4">
             <a:extLst xmlns:a="http://schemas.openxmlformats.org/drawingml/2006/main">
               <a:ext uri="{FF2B5EF4-FFF2-40B4-BE49-F238E27FC236}">
-                <a16:creationId xmlns:a16="http://schemas.microsoft.com/office/drawing/2014/main" id="{A914F031-08D5-4F4B-A645-D7DC9486E0E7}"/>
+                <a16:creationId xmlns:a16="http://schemas.microsoft.com/office/drawing/2014/main" id="{1B64E281-5F2F-4723-B330-93F9676991A7}"/>
               </a:ext>
             </a:extLst>
           </p:cNvPr>
@@ -2918,7 +2918,7 @@
           <p:cNvPr id="14" name="protocol-footer">
             <a:extLst xmlns:a="http://schemas.openxmlformats.org/drawingml/2006/main">
               <a:ext uri="{FF2B5EF4-FFF2-40B4-BE49-F238E27FC236}">
-                <a16:creationId xmlns:a16="http://schemas.microsoft.com/office/drawing/2014/main" id="{089B3FB8-0505-4635-BA67-81C4CE2A75C6}"/>
+                <a16:creationId xmlns:a16="http://schemas.microsoft.com/office/drawing/2014/main" id="{6ECC0A02-EB8D-4450-BE58-FC79CDDB20C1}"/>
               </a:ext>
             </a:extLst>
           </p:cNvPr>
@@ -2961,7 +2961,7 @@
     </p:spTree>
     <p:extLst>
       <p:ext uri="{BB962C8B-B14F-4D97-AF65-F5344CB8AC3E}">
-        <p14:creationId xmlns:p14="http://schemas.microsoft.com/office/powerpoint/2010/main" val="733094581"/>
+        <p14:creationId xmlns:p14="http://schemas.microsoft.com/office/powerpoint/2010/main" val="620316855"/>
       </p:ext>
     </p:extLst>
   </p:cSld>
@@ -2985,7 +2985,7 @@
           <p:cNvPr id="1" name="slide-title">
             <a:extLst xmlns:a="http://schemas.openxmlformats.org/drawingml/2006/main">
               <a:ext uri="{FF2B5EF4-FFF2-40B4-BE49-F238E27FC236}">
-                <a16:creationId xmlns:a16="http://schemas.microsoft.com/office/drawing/2014/main" id="{3C3AB468-67DB-4FDF-9C8A-7791C074C067}"/>
+                <a16:creationId xmlns:a16="http://schemas.microsoft.com/office/drawing/2014/main" id="{534E7FDF-D6E3-4603-82F9-0339781071A6}"/>
               </a:ext>
             </a:extLst>
           </p:cNvPr>
@@ -3030,7 +3030,7 @@
           <p:cNvPr id="2" name="slide-subtitle">
             <a:extLst xmlns:a="http://schemas.openxmlformats.org/drawingml/2006/main">
               <a:ext uri="{FF2B5EF4-FFF2-40B4-BE49-F238E27FC236}">
-                <a16:creationId xmlns:a16="http://schemas.microsoft.com/office/drawing/2014/main" id="{9D382E67-32E2-4530-A476-98EC12991FF4}"/>
+                <a16:creationId xmlns:a16="http://schemas.microsoft.com/office/drawing/2014/main" id="{CAD7720E-7D52-47E3-80CD-61D5F5009D99}"/>
               </a:ext>
             </a:extLst>
           </p:cNvPr>
@@ -3065,7 +3065,7 @@
                   <a:srgbClr val="000000"/>
                 </a:solidFill>
               </a:rPr>
-              <a:t>Bars use disabled prefetching as 1x. Yellow marks show the per-trace best expert.</a:t>
+              <a:t>Bars use disabled prefetching as 1x. Dark blue marks the per-trace best expert.</a:t>
             </a:r>
           </a:p>
         </p:txBody>
@@ -3079,7 +3079,7 @@
           <p:nvPr/>
         </p:nvPicPr>
         <p:blipFill>
-          <a:blip xmlns:r="http://schemas.openxmlformats.org/officeDocument/2006/relationships" xmlns:a="http://schemas.openxmlformats.org/drawingml/2006/main" r:embed="R9b306c4dd3c34e0f"/>
+          <a:blip xmlns:r="http://schemas.openxmlformats.org/officeDocument/2006/relationships" xmlns:a="http://schemas.openxmlformats.org/drawingml/2006/main" r:embed="R5f476c87da05456e"/>
           <a:stretch xmlns:a="http://schemas.openxmlformats.org/drawingml/2006/main"/>
         </p:blipFill>
         <p:spPr>
@@ -3095,7 +3095,7 @@
     </p:spTree>
     <p:extLst>
       <p:ext uri="{BB962C8B-B14F-4D97-AF65-F5344CB8AC3E}">
-        <p14:creationId xmlns:p14="http://schemas.microsoft.com/office/powerpoint/2010/main" val="2049289954"/>
+        <p14:creationId xmlns:p14="http://schemas.microsoft.com/office/powerpoint/2010/main" val="1467387942"/>
       </p:ext>
     </p:extLst>
   </p:cSld>
@@ -3119,7 +3119,7 @@
           <p:cNvPr id="1" name="slide-title">
             <a:extLst xmlns:a="http://schemas.openxmlformats.org/drawingml/2006/main">
               <a:ext uri="{FF2B5EF4-FFF2-40B4-BE49-F238E27FC236}">
-                <a16:creationId xmlns:a16="http://schemas.microsoft.com/office/drawing/2014/main" id="{38608995-13E5-4149-9B52-E7214D4BBEF4}"/>
+                <a16:creationId xmlns:a16="http://schemas.microsoft.com/office/drawing/2014/main" id="{71EC6F11-44E8-43E9-AA74-1FB5149B4D28}"/>
               </a:ext>
             </a:extLst>
           </p:cNvPr>
@@ -3164,7 +3164,7 @@
           <p:cNvPr id="2" name="slide-subtitle">
             <a:extLst xmlns:a="http://schemas.openxmlformats.org/drawingml/2006/main">
               <a:ext uri="{FF2B5EF4-FFF2-40B4-BE49-F238E27FC236}">
-                <a16:creationId xmlns:a16="http://schemas.microsoft.com/office/drawing/2014/main" id="{3C0402C9-5FFD-4753-A94A-46E867C12C18}"/>
+                <a16:creationId xmlns:a16="http://schemas.microsoft.com/office/drawing/2014/main" id="{3B3BD76B-45DE-40F8-943B-B3737F70FB1E}"/>
               </a:ext>
             </a:extLst>
           </p:cNvPr>
@@ -3213,7 +3213,7 @@
           <p:nvPr/>
         </p:nvPicPr>
         <p:blipFill>
-          <a:blip xmlns:r="http://schemas.openxmlformats.org/officeDocument/2006/relationships" xmlns:a="http://schemas.openxmlformats.org/drawingml/2006/main" r:embed="R1fe85374a05f4591"/>
+          <a:blip xmlns:r="http://schemas.openxmlformats.org/officeDocument/2006/relationships" xmlns:a="http://schemas.openxmlformats.org/drawingml/2006/main" r:embed="R27936e6d041e472e"/>
           <a:stretch xmlns:a="http://schemas.openxmlformats.org/drawingml/2006/main"/>
         </p:blipFill>
         <p:spPr>
@@ -3229,7 +3229,7 @@
     </p:spTree>
     <p:extLst>
       <p:ext uri="{BB962C8B-B14F-4D97-AF65-F5344CB8AC3E}">
-        <p14:creationId xmlns:p14="http://schemas.microsoft.com/office/powerpoint/2010/main" val="108135087"/>
+        <p14:creationId xmlns:p14="http://schemas.microsoft.com/office/powerpoint/2010/main" val="756955836"/>
       </p:ext>
     </p:extLst>
   </p:cSld>
@@ -3253,7 +3253,7 @@
           <p:cNvPr id="1" name="slide-title">
             <a:extLst xmlns:a="http://schemas.openxmlformats.org/drawingml/2006/main">
               <a:ext uri="{FF2B5EF4-FFF2-40B4-BE49-F238E27FC236}">
-                <a16:creationId xmlns:a16="http://schemas.microsoft.com/office/drawing/2014/main" id="{32E2F9C5-726F-4DA5-B695-D9F871410B1E}"/>
+                <a16:creationId xmlns:a16="http://schemas.microsoft.com/office/drawing/2014/main" id="{BC24BCA0-9BDE-4B56-8767-F1C98816DDF7}"/>
               </a:ext>
             </a:extLst>
           </p:cNvPr>
@@ -3298,7 +3298,7 @@
           <p:cNvPr id="2" name="slide-subtitle">
             <a:extLst xmlns:a="http://schemas.openxmlformats.org/drawingml/2006/main">
               <a:ext uri="{FF2B5EF4-FFF2-40B4-BE49-F238E27FC236}">
-                <a16:creationId xmlns:a16="http://schemas.microsoft.com/office/drawing/2014/main" id="{D34CFE5E-70C7-414A-B690-2CF0927D3355}"/>
+                <a16:creationId xmlns:a16="http://schemas.microsoft.com/office/drawing/2014/main" id="{C5F113EC-DDEA-4ACC-91B3-DB18982F8BB3}"/>
               </a:ext>
             </a:extLst>
           </p:cNvPr>
@@ -3347,7 +3347,7 @@
           <p:nvPr/>
         </p:nvPicPr>
         <p:blipFill>
-          <a:blip xmlns:r="http://schemas.openxmlformats.org/officeDocument/2006/relationships" xmlns:a="http://schemas.openxmlformats.org/drawingml/2006/main" r:embed="R20c4e6bb75b54a80"/>
+          <a:blip xmlns:r="http://schemas.openxmlformats.org/officeDocument/2006/relationships" xmlns:a="http://schemas.openxmlformats.org/drawingml/2006/main" r:embed="R7929cb69b5e24f2d"/>
           <a:stretch xmlns:a="http://schemas.openxmlformats.org/drawingml/2006/main"/>
         </p:blipFill>
         <p:spPr>
@@ -3363,7 +3363,7 @@
     </p:spTree>
     <p:extLst>
       <p:ext uri="{BB962C8B-B14F-4D97-AF65-F5344CB8AC3E}">
-        <p14:creationId xmlns:p14="http://schemas.microsoft.com/office/powerpoint/2010/main" val="1840466722"/>
+        <p14:creationId xmlns:p14="http://schemas.microsoft.com/office/powerpoint/2010/main" val="1341111914"/>
       </p:ext>
     </p:extLst>
   </p:cSld>
@@ -3387,7 +3387,7 @@
           <p:cNvPr id="1" name="slide-title">
             <a:extLst xmlns:a="http://schemas.openxmlformats.org/drawingml/2006/main">
               <a:ext uri="{FF2B5EF4-FFF2-40B4-BE49-F238E27FC236}">
-                <a16:creationId xmlns:a16="http://schemas.microsoft.com/office/drawing/2014/main" id="{99ABCE61-DD1D-4B14-8638-3ADE31898BCA}"/>
+                <a16:creationId xmlns:a16="http://schemas.microsoft.com/office/drawing/2014/main" id="{2C6A4A15-0DE5-4199-B46F-B1567DD3C203}"/>
               </a:ext>
             </a:extLst>
           </p:cNvPr>
@@ -3432,7 +3432,7 @@
           <p:cNvPr id="2" name="slide-subtitle">
             <a:extLst xmlns:a="http://schemas.openxmlformats.org/drawingml/2006/main">
               <a:ext uri="{FF2B5EF4-FFF2-40B4-BE49-F238E27FC236}">
-                <a16:creationId xmlns:a16="http://schemas.microsoft.com/office/drawing/2014/main" id="{525155BF-9BC1-4909-9417-B5CE4A4484E3}"/>
+                <a16:creationId xmlns:a16="http://schemas.microsoft.com/office/drawing/2014/main" id="{254F2867-69DA-4BE1-9D7A-1F91196B753D}"/>
               </a:ext>
             </a:extLst>
           </p:cNvPr>
@@ -3477,7 +3477,7 @@
           <p:cNvPr id="3" name="bullet-0">
             <a:extLst xmlns:a="http://schemas.openxmlformats.org/drawingml/2006/main">
               <a:ext uri="{FF2B5EF4-FFF2-40B4-BE49-F238E27FC236}">
-                <a16:creationId xmlns:a16="http://schemas.microsoft.com/office/drawing/2014/main" id="{42000C8F-BE45-427B-8908-97F245480007}"/>
+                <a16:creationId xmlns:a16="http://schemas.microsoft.com/office/drawing/2014/main" id="{811F8901-E9E9-4F09-9284-CA07E0B6795F}"/>
               </a:ext>
             </a:extLst>
           </p:cNvPr>
@@ -3522,7 +3522,7 @@
           <p:cNvPr id="4" name="bullet-1">
             <a:extLst xmlns:a="http://schemas.openxmlformats.org/drawingml/2006/main">
               <a:ext uri="{FF2B5EF4-FFF2-40B4-BE49-F238E27FC236}">
-                <a16:creationId xmlns:a16="http://schemas.microsoft.com/office/drawing/2014/main" id="{F8F63EE7-1A22-4852-B0D3-CAA2B0D75EAB}"/>
+                <a16:creationId xmlns:a16="http://schemas.microsoft.com/office/drawing/2014/main" id="{59603BFB-D2D2-49BF-BA14-4804AC31EAC6}"/>
               </a:ext>
             </a:extLst>
           </p:cNvPr>
@@ -3567,7 +3567,7 @@
           <p:cNvPr id="5" name="bullet-2">
             <a:extLst xmlns:a="http://schemas.openxmlformats.org/drawingml/2006/main">
               <a:ext uri="{FF2B5EF4-FFF2-40B4-BE49-F238E27FC236}">
-                <a16:creationId xmlns:a16="http://schemas.microsoft.com/office/drawing/2014/main" id="{D4E1F446-02B6-464D-8D05-546075DFAD65}"/>
+                <a16:creationId xmlns:a16="http://schemas.microsoft.com/office/drawing/2014/main" id="{7CA08B62-45E2-4571-9DF8-D07FDDAC295A}"/>
               </a:ext>
             </a:extLst>
           </p:cNvPr>
@@ -3612,7 +3612,7 @@
           <p:cNvPr id="6" name="bullet-3">
             <a:extLst xmlns:a="http://schemas.openxmlformats.org/drawingml/2006/main">
               <a:ext uri="{FF2B5EF4-FFF2-40B4-BE49-F238E27FC236}">
-                <a16:creationId xmlns:a16="http://schemas.microsoft.com/office/drawing/2014/main" id="{CD095594-A07F-4E35-B5F3-999E4C593036}"/>
+                <a16:creationId xmlns:a16="http://schemas.microsoft.com/office/drawing/2014/main" id="{F829D3B0-9429-4A36-BEEC-6820EDA27B2F}"/>
               </a:ext>
             </a:extLst>
           </p:cNvPr>
@@ -3657,7 +3657,7 @@
           <p:cNvPr id="7" name="bullet-4">
             <a:extLst xmlns:a="http://schemas.openxmlformats.org/drawingml/2006/main">
               <a:ext uri="{FF2B5EF4-FFF2-40B4-BE49-F238E27FC236}">
-                <a16:creationId xmlns:a16="http://schemas.microsoft.com/office/drawing/2014/main" id="{1E092B11-F8DB-4782-984B-FC5D4CC5E429}"/>
+                <a16:creationId xmlns:a16="http://schemas.microsoft.com/office/drawing/2014/main" id="{2A0A1D64-6C56-4AAA-BE3C-AE7166E8A4D8}"/>
               </a:ext>
             </a:extLst>
           </p:cNvPr>
@@ -3702,7 +3702,7 @@
           <p:cNvPr id="8" name="bullet-0">
             <a:extLst xmlns:a="http://schemas.openxmlformats.org/drawingml/2006/main">
               <a:ext uri="{FF2B5EF4-FFF2-40B4-BE49-F238E27FC236}">
-                <a16:creationId xmlns:a16="http://schemas.microsoft.com/office/drawing/2014/main" id="{DEB37964-C5C8-437F-BF72-48BBE42229A3}"/>
+                <a16:creationId xmlns:a16="http://schemas.microsoft.com/office/drawing/2014/main" id="{E81CEB81-707D-4F91-A842-D355FFD53CFD}"/>
               </a:ext>
             </a:extLst>
           </p:cNvPr>
@@ -3747,7 +3747,7 @@
           <p:cNvPr id="9" name="bullet-1">
             <a:extLst xmlns:a="http://schemas.openxmlformats.org/drawingml/2006/main">
               <a:ext uri="{FF2B5EF4-FFF2-40B4-BE49-F238E27FC236}">
-                <a16:creationId xmlns:a16="http://schemas.microsoft.com/office/drawing/2014/main" id="{C5A3F7D7-0F58-481F-BCD8-37C0EC772A19}"/>
+                <a16:creationId xmlns:a16="http://schemas.microsoft.com/office/drawing/2014/main" id="{DCDF2228-3BCE-4157-802C-20E8902DD8AE}"/>
               </a:ext>
             </a:extLst>
           </p:cNvPr>
@@ -3792,7 +3792,7 @@
           <p:cNvPr id="10" name="bullet-2">
             <a:extLst xmlns:a="http://schemas.openxmlformats.org/drawingml/2006/main">
               <a:ext uri="{FF2B5EF4-FFF2-40B4-BE49-F238E27FC236}">
-                <a16:creationId xmlns:a16="http://schemas.microsoft.com/office/drawing/2014/main" id="{06D2D52C-6409-4CC1-8236-21241C70DAFD}"/>
+                <a16:creationId xmlns:a16="http://schemas.microsoft.com/office/drawing/2014/main" id="{0801D6A1-D144-462A-A7CE-630277EDF982}"/>
               </a:ext>
             </a:extLst>
           </p:cNvPr>
@@ -3837,7 +3837,7 @@
           <p:cNvPr id="11" name="bullet-3">
             <a:extLst xmlns:a="http://schemas.openxmlformats.org/drawingml/2006/main">
               <a:ext uri="{FF2B5EF4-FFF2-40B4-BE49-F238E27FC236}">
-                <a16:creationId xmlns:a16="http://schemas.microsoft.com/office/drawing/2014/main" id="{F31CF10A-712F-44CB-BA1A-52485E5D7EA2}"/>
+                <a16:creationId xmlns:a16="http://schemas.microsoft.com/office/drawing/2014/main" id="{10F21A01-B832-408C-9770-CD2EE0009D97}"/>
               </a:ext>
             </a:extLst>
           </p:cNvPr>
@@ -3882,7 +3882,7 @@
           <p:cNvPr id="12" name="bullet-4">
             <a:extLst xmlns:a="http://schemas.openxmlformats.org/drawingml/2006/main">
               <a:ext uri="{FF2B5EF4-FFF2-40B4-BE49-F238E27FC236}">
-                <a16:creationId xmlns:a16="http://schemas.microsoft.com/office/drawing/2014/main" id="{73FB21A3-5745-46F8-8311-53B10E262A0E}"/>
+                <a16:creationId xmlns:a16="http://schemas.microsoft.com/office/drawing/2014/main" id="{EFE8CDBF-C764-4679-8375-4114D90330B3}"/>
               </a:ext>
             </a:extLst>
           </p:cNvPr>
@@ -3927,7 +3927,7 @@
           <p:cNvPr id="13" name="audit-footer">
             <a:extLst xmlns:a="http://schemas.openxmlformats.org/drawingml/2006/main">
               <a:ext uri="{FF2B5EF4-FFF2-40B4-BE49-F238E27FC236}">
-                <a16:creationId xmlns:a16="http://schemas.microsoft.com/office/drawing/2014/main" id="{9037988D-7AD3-4EFA-919A-2E1F0F85F1B2}"/>
+                <a16:creationId xmlns:a16="http://schemas.microsoft.com/office/drawing/2014/main" id="{964DCE75-D3D7-43D7-AE7F-E33863E331A2}"/>
               </a:ext>
             </a:extLst>
           </p:cNvPr>
@@ -3970,7 +3970,7 @@
     </p:spTree>
     <p:extLst>
       <p:ext uri="{BB962C8B-B14F-4D97-AF65-F5344CB8AC3E}">
-        <p14:creationId xmlns:p14="http://schemas.microsoft.com/office/powerpoint/2010/main" val="747566990"/>
+        <p14:creationId xmlns:p14="http://schemas.microsoft.com/office/powerpoint/2010/main" val="1682079500"/>
       </p:ext>
     </p:extLst>
   </p:cSld>
@@ -3994,7 +3994,7 @@
           <p:cNvPr id="1" name="slide-title">
             <a:extLst xmlns:a="http://schemas.openxmlformats.org/drawingml/2006/main">
               <a:ext uri="{FF2B5EF4-FFF2-40B4-BE49-F238E27FC236}">
-                <a16:creationId xmlns:a16="http://schemas.microsoft.com/office/drawing/2014/main" id="{9FC537BD-93F4-43FF-90ED-D068620E7715}"/>
+                <a16:creationId xmlns:a16="http://schemas.microsoft.com/office/drawing/2014/main" id="{067F2D80-59AF-4CBD-B4AE-176B1109C008}"/>
               </a:ext>
             </a:extLst>
           </p:cNvPr>
@@ -4039,7 +4039,7 @@
           <p:cNvPr id="2" name="title-rule">
             <a:extLst xmlns:a="http://schemas.openxmlformats.org/drawingml/2006/main">
               <a:ext uri="{FF2B5EF4-FFF2-40B4-BE49-F238E27FC236}">
-                <a16:creationId xmlns:a16="http://schemas.microsoft.com/office/drawing/2014/main" id="{5C40746E-DCCB-4A2C-BF64-A7C5B0084609}"/>
+                <a16:creationId xmlns:a16="http://schemas.microsoft.com/office/drawing/2014/main" id="{BA60B06B-71D7-40B6-AB24-0BF5E0283BBC}"/>
               </a:ext>
             </a:extLst>
           </p:cNvPr>
@@ -4072,7 +4072,7 @@
           <p:cNvPr id="3" name="bullet-0">
             <a:extLst xmlns:a="http://schemas.openxmlformats.org/drawingml/2006/main">
               <a:ext uri="{FF2B5EF4-FFF2-40B4-BE49-F238E27FC236}">
-                <a16:creationId xmlns:a16="http://schemas.microsoft.com/office/drawing/2014/main" id="{7AECCD9E-38B4-4C0B-9261-4F4BF369DB51}"/>
+                <a16:creationId xmlns:a16="http://schemas.microsoft.com/office/drawing/2014/main" id="{52B513DC-4ECC-4FEE-BC0C-A50CB37E6CBB}"/>
               </a:ext>
             </a:extLst>
           </p:cNvPr>
@@ -4117,7 +4117,7 @@
           <p:cNvPr id="4" name="bullet-1">
             <a:extLst xmlns:a="http://schemas.openxmlformats.org/drawingml/2006/main">
               <a:ext uri="{FF2B5EF4-FFF2-40B4-BE49-F238E27FC236}">
-                <a16:creationId xmlns:a16="http://schemas.microsoft.com/office/drawing/2014/main" id="{0122A8A3-7001-44A6-8A15-6CD447CDC98C}"/>
+                <a16:creationId xmlns:a16="http://schemas.microsoft.com/office/drawing/2014/main" id="{2F089840-0FA2-419A-A4B7-D97095552FC4}"/>
               </a:ext>
             </a:extLst>
           </p:cNvPr>
@@ -4162,7 +4162,7 @@
           <p:cNvPr id="5" name="bullet-2">
             <a:extLst xmlns:a="http://schemas.openxmlformats.org/drawingml/2006/main">
               <a:ext uri="{FF2B5EF4-FFF2-40B4-BE49-F238E27FC236}">
-                <a16:creationId xmlns:a16="http://schemas.microsoft.com/office/drawing/2014/main" id="{CC39F68F-A748-4CAB-A2FF-06E72D672B57}"/>
+                <a16:creationId xmlns:a16="http://schemas.microsoft.com/office/drawing/2014/main" id="{8B55C34C-7AFC-455F-9924-01AFBE103565}"/>
               </a:ext>
             </a:extLst>
           </p:cNvPr>
@@ -4207,7 +4207,7 @@
           <p:cNvPr id="6" name="bullet-3">
             <a:extLst xmlns:a="http://schemas.openxmlformats.org/drawingml/2006/main">
               <a:ext uri="{FF2B5EF4-FFF2-40B4-BE49-F238E27FC236}">
-                <a16:creationId xmlns:a16="http://schemas.microsoft.com/office/drawing/2014/main" id="{578CECC2-82E4-4DC0-AA78-80A88F5614D7}"/>
+                <a16:creationId xmlns:a16="http://schemas.microsoft.com/office/drawing/2014/main" id="{8FFE7DAF-740C-46F2-8DA3-3CBBF9139C25}"/>
               </a:ext>
             </a:extLst>
           </p:cNvPr>
@@ -4252,7 +4252,7 @@
           <p:cNvPr id="7" name="bullet-4">
             <a:extLst xmlns:a="http://schemas.openxmlformats.org/drawingml/2006/main">
               <a:ext uri="{FF2B5EF4-FFF2-40B4-BE49-F238E27FC236}">
-                <a16:creationId xmlns:a16="http://schemas.microsoft.com/office/drawing/2014/main" id="{BACBAE01-666D-4068-A127-4F3FF014D01D}"/>
+                <a16:creationId xmlns:a16="http://schemas.microsoft.com/office/drawing/2014/main" id="{A5D7D28B-6BD7-4165-9F17-64D3F5D94054}"/>
               </a:ext>
             </a:extLst>
           </p:cNvPr>
@@ -4295,7 +4295,7 @@
     </p:spTree>
     <p:extLst>
       <p:ext uri="{BB962C8B-B14F-4D97-AF65-F5344CB8AC3E}">
-        <p14:creationId xmlns:p14="http://schemas.microsoft.com/office/powerpoint/2010/main" val="1820663386"/>
+        <p14:creationId xmlns:p14="http://schemas.microsoft.com/office/powerpoint/2010/main" val="48345682"/>
       </p:ext>
     </p:extLst>
   </p:cSld>

</xml_diff>

<commit_message>
Clarify OpenEvolve reference lines
</commit_message>
<xml_diff>
--- a/slides/mop_stage2_final/output/output.pptx
+++ b/slides/mop_stage2_final/output/output.pptx
@@ -2,20 +2,20 @@
 <file path=ppt/presentation.xml><?xml version="1.0" encoding="utf-8"?>
 <p:presentation xmlns:p="http://schemas.openxmlformats.org/presentationml/2006/main">
   <p:sldMasterIdLst>
-    <p:sldMasterId xmlns:r="http://schemas.openxmlformats.org/officeDocument/2006/relationships" id="2147483648" r:id="R6683ce269f5944ed"/>
+    <p:sldMasterId xmlns:r="http://schemas.openxmlformats.org/officeDocument/2006/relationships" id="2147483648" r:id="R9f8d06cf781b447c"/>
   </p:sldMasterIdLst>
   <p:notesMasterIdLst>
-    <p:notesMasterId xmlns:r="http://schemas.openxmlformats.org/officeDocument/2006/relationships" r:id="Rb25610d4f2614833"/>
+    <p:notesMasterId xmlns:r="http://schemas.openxmlformats.org/officeDocument/2006/relationships" r:id="R3d7384a93acc4d57"/>
   </p:notesMasterIdLst>
   <p:sldIdLst>
-    <p:sldId xmlns:r="http://schemas.openxmlformats.org/officeDocument/2006/relationships" id="256" r:id="R768e5260a039488b"/>
-    <p:sldId xmlns:r="http://schemas.openxmlformats.org/officeDocument/2006/relationships" id="257" r:id="R34448978551f4506"/>
-    <p:sldId xmlns:r="http://schemas.openxmlformats.org/officeDocument/2006/relationships" id="258" r:id="Rdefb8498b2ea46ba"/>
-    <p:sldId xmlns:r="http://schemas.openxmlformats.org/officeDocument/2006/relationships" id="259" r:id="Rd6c1a7e1d9644e42"/>
-    <p:sldId xmlns:r="http://schemas.openxmlformats.org/officeDocument/2006/relationships" id="260" r:id="Rda8782502f0140b2"/>
-    <p:sldId xmlns:r="http://schemas.openxmlformats.org/officeDocument/2006/relationships" id="261" r:id="R62c8d1ea175d4b8b"/>
-    <p:sldId xmlns:r="http://schemas.openxmlformats.org/officeDocument/2006/relationships" id="262" r:id="R38d5d737f08042a3"/>
-    <p:sldId xmlns:r="http://schemas.openxmlformats.org/officeDocument/2006/relationships" id="263" r:id="Ra03fadf2bae44ee5"/>
+    <p:sldId xmlns:r="http://schemas.openxmlformats.org/officeDocument/2006/relationships" id="256" r:id="Rc7736d1f5b7b4427"/>
+    <p:sldId xmlns:r="http://schemas.openxmlformats.org/officeDocument/2006/relationships" id="257" r:id="R02a2ff7692614330"/>
+    <p:sldId xmlns:r="http://schemas.openxmlformats.org/officeDocument/2006/relationships" id="258" r:id="R163c3d58cc7c41f5"/>
+    <p:sldId xmlns:r="http://schemas.openxmlformats.org/officeDocument/2006/relationships" id="259" r:id="R18c98dd4179749f3"/>
+    <p:sldId xmlns:r="http://schemas.openxmlformats.org/officeDocument/2006/relationships" id="260" r:id="R457ffcccfddc4dfe"/>
+    <p:sldId xmlns:r="http://schemas.openxmlformats.org/officeDocument/2006/relationships" id="261" r:id="Rf9f913921fbd4314"/>
+    <p:sldId xmlns:r="http://schemas.openxmlformats.org/officeDocument/2006/relationships" id="262" r:id="R2abc9531a587477f"/>
+    <p:sldId xmlns:r="http://schemas.openxmlformats.org/officeDocument/2006/relationships" id="263" r:id="R78f5c3c2a6d44884"/>
   </p:sldIdLst>
   <p:sldSz cx="18288000" cy="10287000"/>
   <p:notesSz cx="6858000" cy="9144000"/>
@@ -1024,7 +1024,7 @@
   </p:cSld>
   <p:clrMap bg1="lt1" tx1="dk1" bg2="lt2" tx2="dk2" accent1="accent1" accent2="accent2" accent3="accent3" accent4="accent4" accent5="accent5" accent6="accent6" hlink="hlink" folHlink="folHlink"/>
   <p:sldLayoutIdLst>
-    <p:sldLayoutId xmlns:r="http://schemas.openxmlformats.org/officeDocument/2006/relationships" id="2147483649" r:id="Rcb5a31b04c2744af"/>
+    <p:sldLayoutId xmlns:r="http://schemas.openxmlformats.org/officeDocument/2006/relationships" id="2147483649" r:id="R7be917e06d854b54"/>
   </p:sldLayoutIdLst>
   <p:txStyles>
     <p:titleStyle>
@@ -1323,7 +1323,7 @@
           <p:cNvPr id="1" name="cover-title">
             <a:extLst xmlns:a="http://schemas.openxmlformats.org/drawingml/2006/main">
               <a:ext uri="{FF2B5EF4-FFF2-40B4-BE49-F238E27FC236}">
-                <a16:creationId xmlns:a16="http://schemas.microsoft.com/office/drawing/2014/main" id="{F60FFA0A-333B-468E-8901-C9A2AFBEC4DF}"/>
+                <a16:creationId xmlns:a16="http://schemas.microsoft.com/office/drawing/2014/main" id="{9E85C540-6054-47D5-AB01-EF638CF87192}"/>
               </a:ext>
             </a:extLst>
           </p:cNvPr>
@@ -1368,7 +1368,7 @@
           <p:cNvPr id="2" name="cover-rule">
             <a:extLst xmlns:a="http://schemas.openxmlformats.org/drawingml/2006/main">
               <a:ext uri="{FF2B5EF4-FFF2-40B4-BE49-F238E27FC236}">
-                <a16:creationId xmlns:a16="http://schemas.microsoft.com/office/drawing/2014/main" id="{71DE660D-9389-4F27-88CA-FAC2C0317E54}"/>
+                <a16:creationId xmlns:a16="http://schemas.microsoft.com/office/drawing/2014/main" id="{D1DE38CC-447C-423A-A69C-88A631ED32EC}"/>
               </a:ext>
             </a:extLst>
           </p:cNvPr>
@@ -1401,7 +1401,7 @@
           <p:cNvPr id="3" name="cover-thesis">
             <a:extLst xmlns:a="http://schemas.openxmlformats.org/drawingml/2006/main">
               <a:ext uri="{FF2B5EF4-FFF2-40B4-BE49-F238E27FC236}">
-                <a16:creationId xmlns:a16="http://schemas.microsoft.com/office/drawing/2014/main" id="{9B93E9C0-CF34-439E-9590-9493746900C4}"/>
+                <a16:creationId xmlns:a16="http://schemas.microsoft.com/office/drawing/2014/main" id="{74CD6947-ADFB-44CE-826A-4A71C41BAF6B}"/>
               </a:ext>
             </a:extLst>
           </p:cNvPr>
@@ -1446,7 +1446,7 @@
           <p:cNvPr id="4" name="cover-metric-1">
             <a:extLst xmlns:a="http://schemas.openxmlformats.org/drawingml/2006/main">
               <a:ext uri="{FF2B5EF4-FFF2-40B4-BE49-F238E27FC236}">
-                <a16:creationId xmlns:a16="http://schemas.microsoft.com/office/drawing/2014/main" id="{0AAF37FD-77CB-4533-8B69-59A58534A032}"/>
+                <a16:creationId xmlns:a16="http://schemas.microsoft.com/office/drawing/2014/main" id="{8840A80B-3A72-48BD-A7B6-C69CD3CE088B}"/>
               </a:ext>
             </a:extLst>
           </p:cNvPr>
@@ -1491,7 +1491,7 @@
           <p:cNvPr id="5" name="cover-label-1">
             <a:extLst xmlns:a="http://schemas.openxmlformats.org/drawingml/2006/main">
               <a:ext uri="{FF2B5EF4-FFF2-40B4-BE49-F238E27FC236}">
-                <a16:creationId xmlns:a16="http://schemas.microsoft.com/office/drawing/2014/main" id="{2B932005-22B0-4172-9425-E9261DA93052}"/>
+                <a16:creationId xmlns:a16="http://schemas.microsoft.com/office/drawing/2014/main" id="{42BF373C-82D0-493A-981E-2DAE3F4D9AE5}"/>
               </a:ext>
             </a:extLst>
           </p:cNvPr>
@@ -1536,7 +1536,7 @@
           <p:cNvPr id="6" name="cover-metric-2">
             <a:extLst xmlns:a="http://schemas.openxmlformats.org/drawingml/2006/main">
               <a:ext uri="{FF2B5EF4-FFF2-40B4-BE49-F238E27FC236}">
-                <a16:creationId xmlns:a16="http://schemas.microsoft.com/office/drawing/2014/main" id="{CAE2C728-3CAD-4994-81FF-8F66CEAC62EF}"/>
+                <a16:creationId xmlns:a16="http://schemas.microsoft.com/office/drawing/2014/main" id="{A06284F7-07AE-4932-A869-CBEC7B91037A}"/>
               </a:ext>
             </a:extLst>
           </p:cNvPr>
@@ -1581,7 +1581,7 @@
           <p:cNvPr id="7" name="cover-label-2">
             <a:extLst xmlns:a="http://schemas.openxmlformats.org/drawingml/2006/main">
               <a:ext uri="{FF2B5EF4-FFF2-40B4-BE49-F238E27FC236}">
-                <a16:creationId xmlns:a16="http://schemas.microsoft.com/office/drawing/2014/main" id="{F4A9B5A4-210E-48D6-ABFB-5372162DA752}"/>
+                <a16:creationId xmlns:a16="http://schemas.microsoft.com/office/drawing/2014/main" id="{828B7ED5-5095-4E98-9924-A86EE9B971CE}"/>
               </a:ext>
             </a:extLst>
           </p:cNvPr>
@@ -1626,7 +1626,7 @@
           <p:cNvPr id="8" name="cover-footer">
             <a:extLst xmlns:a="http://schemas.openxmlformats.org/drawingml/2006/main">
               <a:ext uri="{FF2B5EF4-FFF2-40B4-BE49-F238E27FC236}">
-                <a16:creationId xmlns:a16="http://schemas.microsoft.com/office/drawing/2014/main" id="{40D1322E-2844-4E8A-8C7C-FFF898157302}"/>
+                <a16:creationId xmlns:a16="http://schemas.microsoft.com/office/drawing/2014/main" id="{7E3FB207-B7EC-418F-A3E4-8A4E1A77F19E}"/>
               </a:ext>
             </a:extLst>
           </p:cNvPr>
@@ -1669,7 +1669,7 @@
     </p:spTree>
     <p:extLst>
       <p:ext uri="{BB962C8B-B14F-4D97-AF65-F5344CB8AC3E}">
-        <p14:creationId xmlns:p14="http://schemas.microsoft.com/office/powerpoint/2010/main" val="417969294"/>
+        <p14:creationId xmlns:p14="http://schemas.microsoft.com/office/powerpoint/2010/main" val="974636913"/>
       </p:ext>
     </p:extLst>
   </p:cSld>
@@ -1693,7 +1693,7 @@
           <p:cNvPr id="1" name="slide-title">
             <a:extLst xmlns:a="http://schemas.openxmlformats.org/drawingml/2006/main">
               <a:ext uri="{FF2B5EF4-FFF2-40B4-BE49-F238E27FC236}">
-                <a16:creationId xmlns:a16="http://schemas.microsoft.com/office/drawing/2014/main" id="{0AD178BB-7B07-42A3-93FC-C79853755C10}"/>
+                <a16:creationId xmlns:a16="http://schemas.microsoft.com/office/drawing/2014/main" id="{9184B238-6F2B-4423-AD08-3B37DA5FA438}"/>
               </a:ext>
             </a:extLst>
           </p:cNvPr>
@@ -1738,7 +1738,7 @@
           <p:cNvPr id="2" name="slide-subtitle">
             <a:extLst xmlns:a="http://schemas.openxmlformats.org/drawingml/2006/main">
               <a:ext uri="{FF2B5EF4-FFF2-40B4-BE49-F238E27FC236}">
-                <a16:creationId xmlns:a16="http://schemas.microsoft.com/office/drawing/2014/main" id="{45799322-1B42-499F-945B-92CB1A11CBE0}"/>
+                <a16:creationId xmlns:a16="http://schemas.microsoft.com/office/drawing/2014/main" id="{BF231385-04B9-4A54-AD23-F06687794CCE}"/>
               </a:ext>
             </a:extLst>
           </p:cNvPr>
@@ -1783,7 +1783,7 @@
           <p:cNvPr id="3" name="bullet-0">
             <a:extLst xmlns:a="http://schemas.openxmlformats.org/drawingml/2006/main">
               <a:ext uri="{FF2B5EF4-FFF2-40B4-BE49-F238E27FC236}">
-                <a16:creationId xmlns:a16="http://schemas.microsoft.com/office/drawing/2014/main" id="{17CCB4D7-FC6A-401F-9919-11EB98429AE4}"/>
+                <a16:creationId xmlns:a16="http://schemas.microsoft.com/office/drawing/2014/main" id="{84120686-88C8-4DFF-BB71-81B12F62E9FC}"/>
               </a:ext>
             </a:extLst>
           </p:cNvPr>
@@ -1828,7 +1828,7 @@
           <p:cNvPr id="4" name="bullet-1">
             <a:extLst xmlns:a="http://schemas.openxmlformats.org/drawingml/2006/main">
               <a:ext uri="{FF2B5EF4-FFF2-40B4-BE49-F238E27FC236}">
-                <a16:creationId xmlns:a16="http://schemas.microsoft.com/office/drawing/2014/main" id="{F9AD71F2-DDBA-4C6B-BF95-826AF07552BE}"/>
+                <a16:creationId xmlns:a16="http://schemas.microsoft.com/office/drawing/2014/main" id="{FC945FEA-0CDE-405E-8F62-8C003C9EDA2F}"/>
               </a:ext>
             </a:extLst>
           </p:cNvPr>
@@ -1873,7 +1873,7 @@
           <p:cNvPr id="5" name="bullet-2">
             <a:extLst xmlns:a="http://schemas.openxmlformats.org/drawingml/2006/main">
               <a:ext uri="{FF2B5EF4-FFF2-40B4-BE49-F238E27FC236}">
-                <a16:creationId xmlns:a16="http://schemas.microsoft.com/office/drawing/2014/main" id="{A7D4EAD4-C1E8-492A-ADCF-2EB29ACDEF96}"/>
+                <a16:creationId xmlns:a16="http://schemas.microsoft.com/office/drawing/2014/main" id="{C1AD7BC4-B9FA-4B78-8E9C-EC9F5969734C}"/>
               </a:ext>
             </a:extLst>
           </p:cNvPr>
@@ -1918,7 +1918,7 @@
           <p:cNvPr id="6" name="bullet-3">
             <a:extLst xmlns:a="http://schemas.openxmlformats.org/drawingml/2006/main">
               <a:ext uri="{FF2B5EF4-FFF2-40B4-BE49-F238E27FC236}">
-                <a16:creationId xmlns:a16="http://schemas.microsoft.com/office/drawing/2014/main" id="{E3D5F164-E9B2-44C6-A5A6-E520D86C0A1C}"/>
+                <a16:creationId xmlns:a16="http://schemas.microsoft.com/office/drawing/2014/main" id="{8CBD249C-CE55-4261-B95C-14A20EEB8D59}"/>
               </a:ext>
             </a:extLst>
           </p:cNvPr>
@@ -1963,7 +1963,7 @@
           <p:cNvPr id="7" name="bullet-0">
             <a:extLst xmlns:a="http://schemas.openxmlformats.org/drawingml/2006/main">
               <a:ext uri="{FF2B5EF4-FFF2-40B4-BE49-F238E27FC236}">
-                <a16:creationId xmlns:a16="http://schemas.microsoft.com/office/drawing/2014/main" id="{45B542EB-933B-437C-B138-1BECB666797F}"/>
+                <a16:creationId xmlns:a16="http://schemas.microsoft.com/office/drawing/2014/main" id="{D1061793-605F-4CA5-93BC-8543EE4538B0}"/>
               </a:ext>
             </a:extLst>
           </p:cNvPr>
@@ -2008,7 +2008,7 @@
           <p:cNvPr id="8" name="bullet-1">
             <a:extLst xmlns:a="http://schemas.openxmlformats.org/drawingml/2006/main">
               <a:ext uri="{FF2B5EF4-FFF2-40B4-BE49-F238E27FC236}">
-                <a16:creationId xmlns:a16="http://schemas.microsoft.com/office/drawing/2014/main" id="{94CAD20E-C55D-4FEF-8DE1-8DF88FF19ED0}"/>
+                <a16:creationId xmlns:a16="http://schemas.microsoft.com/office/drawing/2014/main" id="{AE05A1C9-5E5D-48E3-9AA7-759A5A720347}"/>
               </a:ext>
             </a:extLst>
           </p:cNvPr>
@@ -2053,7 +2053,7 @@
           <p:cNvPr id="9" name="bullet-2">
             <a:extLst xmlns:a="http://schemas.openxmlformats.org/drawingml/2006/main">
               <a:ext uri="{FF2B5EF4-FFF2-40B4-BE49-F238E27FC236}">
-                <a16:creationId xmlns:a16="http://schemas.microsoft.com/office/drawing/2014/main" id="{252BFD17-61FC-49D5-8D18-FBF8E878B671}"/>
+                <a16:creationId xmlns:a16="http://schemas.microsoft.com/office/drawing/2014/main" id="{F04DF201-4F47-431B-88A3-6C217DEAC141}"/>
               </a:ext>
             </a:extLst>
           </p:cNvPr>
@@ -2098,7 +2098,7 @@
           <p:cNvPr id="10" name="bullet-3">
             <a:extLst xmlns:a="http://schemas.openxmlformats.org/drawingml/2006/main">
               <a:ext uri="{FF2B5EF4-FFF2-40B4-BE49-F238E27FC236}">
-                <a16:creationId xmlns:a16="http://schemas.microsoft.com/office/drawing/2014/main" id="{C4CCAA17-C083-476C-9014-E8A580A126FC}"/>
+                <a16:creationId xmlns:a16="http://schemas.microsoft.com/office/drawing/2014/main" id="{18AFF89C-5AE0-49EE-BB9A-C5CE8D8CB145}"/>
               </a:ext>
             </a:extLst>
           </p:cNvPr>
@@ -2143,7 +2143,7 @@
           <p:cNvPr id="11" name="bullet-0">
             <a:extLst xmlns:a="http://schemas.openxmlformats.org/drawingml/2006/main">
               <a:ext uri="{FF2B5EF4-FFF2-40B4-BE49-F238E27FC236}">
-                <a16:creationId xmlns:a16="http://schemas.microsoft.com/office/drawing/2014/main" id="{9C5E9F15-9415-4030-B667-2CF2EF2A0579}"/>
+                <a16:creationId xmlns:a16="http://schemas.microsoft.com/office/drawing/2014/main" id="{34C33073-53A3-414F-B6C6-C46B4A12E0F5}"/>
               </a:ext>
             </a:extLst>
           </p:cNvPr>
@@ -2188,7 +2188,7 @@
           <p:cNvPr id="12" name="bullet-1">
             <a:extLst xmlns:a="http://schemas.openxmlformats.org/drawingml/2006/main">
               <a:ext uri="{FF2B5EF4-FFF2-40B4-BE49-F238E27FC236}">
-                <a16:creationId xmlns:a16="http://schemas.microsoft.com/office/drawing/2014/main" id="{51936781-1DC6-488E-B637-37ECDA219C46}"/>
+                <a16:creationId xmlns:a16="http://schemas.microsoft.com/office/drawing/2014/main" id="{3B8C8E93-B4E3-46D9-87DD-82CBC685A449}"/>
               </a:ext>
             </a:extLst>
           </p:cNvPr>
@@ -2233,7 +2233,7 @@
           <p:cNvPr id="13" name="bullet-2">
             <a:extLst xmlns:a="http://schemas.openxmlformats.org/drawingml/2006/main">
               <a:ext uri="{FF2B5EF4-FFF2-40B4-BE49-F238E27FC236}">
-                <a16:creationId xmlns:a16="http://schemas.microsoft.com/office/drawing/2014/main" id="{2F3E9E49-2BBA-45D4-A0BD-B2CA263422B2}"/>
+                <a16:creationId xmlns:a16="http://schemas.microsoft.com/office/drawing/2014/main" id="{0F4D6EB9-336C-4103-ADDA-B7AD68F3DAAB}"/>
               </a:ext>
             </a:extLst>
           </p:cNvPr>
@@ -2278,7 +2278,7 @@
           <p:cNvPr id="14" name="bullet-3">
             <a:extLst xmlns:a="http://schemas.openxmlformats.org/drawingml/2006/main">
               <a:ext uri="{FF2B5EF4-FFF2-40B4-BE49-F238E27FC236}">
-                <a16:creationId xmlns:a16="http://schemas.microsoft.com/office/drawing/2014/main" id="{5C737E06-57CB-4C1C-A698-AC9D61C65FDF}"/>
+                <a16:creationId xmlns:a16="http://schemas.microsoft.com/office/drawing/2014/main" id="{73CE3D50-DE83-4604-A344-9FC32B386259}"/>
               </a:ext>
             </a:extLst>
           </p:cNvPr>
@@ -2321,7 +2321,7 @@
     </p:spTree>
     <p:extLst>
       <p:ext uri="{BB962C8B-B14F-4D97-AF65-F5344CB8AC3E}">
-        <p14:creationId xmlns:p14="http://schemas.microsoft.com/office/powerpoint/2010/main" val="1612228302"/>
+        <p14:creationId xmlns:p14="http://schemas.microsoft.com/office/powerpoint/2010/main" val="230007942"/>
       </p:ext>
     </p:extLst>
   </p:cSld>
@@ -2345,7 +2345,7 @@
           <p:cNvPr id="1" name="slide-title">
             <a:extLst xmlns:a="http://schemas.openxmlformats.org/drawingml/2006/main">
               <a:ext uri="{FF2B5EF4-FFF2-40B4-BE49-F238E27FC236}">
-                <a16:creationId xmlns:a16="http://schemas.microsoft.com/office/drawing/2014/main" id="{49268A0B-5BAF-4735-9A17-4D2F2593165D}"/>
+                <a16:creationId xmlns:a16="http://schemas.microsoft.com/office/drawing/2014/main" id="{24E2CEED-AEB7-4AE3-B4D8-6D935C1F43E6}"/>
               </a:ext>
             </a:extLst>
           </p:cNvPr>
@@ -2390,7 +2390,7 @@
           <p:cNvPr id="2" name="title-rule">
             <a:extLst xmlns:a="http://schemas.openxmlformats.org/drawingml/2006/main">
               <a:ext uri="{FF2B5EF4-FFF2-40B4-BE49-F238E27FC236}">
-                <a16:creationId xmlns:a16="http://schemas.microsoft.com/office/drawing/2014/main" id="{EAD8944F-0B39-48FA-986B-5D010C0A256D}"/>
+                <a16:creationId xmlns:a16="http://schemas.microsoft.com/office/drawing/2014/main" id="{31A5F905-9145-45E2-AF6E-0FC65A1870A2}"/>
               </a:ext>
             </a:extLst>
           </p:cNvPr>
@@ -2423,7 +2423,7 @@
           <p:cNvPr id="3" name="bullet-0">
             <a:extLst xmlns:a="http://schemas.openxmlformats.org/drawingml/2006/main">
               <a:ext uri="{FF2B5EF4-FFF2-40B4-BE49-F238E27FC236}">
-                <a16:creationId xmlns:a16="http://schemas.microsoft.com/office/drawing/2014/main" id="{B0059973-B5A0-44A6-80B4-850715741C0C}"/>
+                <a16:creationId xmlns:a16="http://schemas.microsoft.com/office/drawing/2014/main" id="{BF8ABBC1-1E20-4CB4-8A0C-E789DD33806B}"/>
               </a:ext>
             </a:extLst>
           </p:cNvPr>
@@ -2468,7 +2468,7 @@
           <p:cNvPr id="4" name="bullet-1">
             <a:extLst xmlns:a="http://schemas.openxmlformats.org/drawingml/2006/main">
               <a:ext uri="{FF2B5EF4-FFF2-40B4-BE49-F238E27FC236}">
-                <a16:creationId xmlns:a16="http://schemas.microsoft.com/office/drawing/2014/main" id="{8935F293-7747-4895-BD10-65EDA6F8F4F9}"/>
+                <a16:creationId xmlns:a16="http://schemas.microsoft.com/office/drawing/2014/main" id="{794088DC-F9DC-4EA0-95EE-B0B128DE3B19}"/>
               </a:ext>
             </a:extLst>
           </p:cNvPr>
@@ -2513,7 +2513,7 @@
           <p:cNvPr id="5" name="bullet-2">
             <a:extLst xmlns:a="http://schemas.openxmlformats.org/drawingml/2006/main">
               <a:ext uri="{FF2B5EF4-FFF2-40B4-BE49-F238E27FC236}">
-                <a16:creationId xmlns:a16="http://schemas.microsoft.com/office/drawing/2014/main" id="{6287FC2B-F3CD-4AB0-9632-06D49372E862}"/>
+                <a16:creationId xmlns:a16="http://schemas.microsoft.com/office/drawing/2014/main" id="{23A4C596-B423-4D31-93F6-DE4C19FEBDEB}"/>
               </a:ext>
             </a:extLst>
           </p:cNvPr>
@@ -2558,7 +2558,7 @@
           <p:cNvPr id="6" name="bullet-3">
             <a:extLst xmlns:a="http://schemas.openxmlformats.org/drawingml/2006/main">
               <a:ext uri="{FF2B5EF4-FFF2-40B4-BE49-F238E27FC236}">
-                <a16:creationId xmlns:a16="http://schemas.microsoft.com/office/drawing/2014/main" id="{80C7DD1D-A8FE-444D-8340-D941A75F8971}"/>
+                <a16:creationId xmlns:a16="http://schemas.microsoft.com/office/drawing/2014/main" id="{B9717D3F-8939-476C-9AA7-58C6680C78B1}"/>
               </a:ext>
             </a:extLst>
           </p:cNvPr>
@@ -2603,7 +2603,7 @@
           <p:cNvPr id="7" name="bullet-4">
             <a:extLst xmlns:a="http://schemas.openxmlformats.org/drawingml/2006/main">
               <a:ext uri="{FF2B5EF4-FFF2-40B4-BE49-F238E27FC236}">
-                <a16:creationId xmlns:a16="http://schemas.microsoft.com/office/drawing/2014/main" id="{C02A6667-B152-46B3-B51F-EA6BE26CEDEE}"/>
+                <a16:creationId xmlns:a16="http://schemas.microsoft.com/office/drawing/2014/main" id="{DE45AF3C-9306-474F-B97C-F70CF5460C6F}"/>
               </a:ext>
             </a:extLst>
           </p:cNvPr>
@@ -2648,7 +2648,7 @@
           <p:cNvPr id="8" name="bullet-5">
             <a:extLst xmlns:a="http://schemas.openxmlformats.org/drawingml/2006/main">
               <a:ext uri="{FF2B5EF4-FFF2-40B4-BE49-F238E27FC236}">
-                <a16:creationId xmlns:a16="http://schemas.microsoft.com/office/drawing/2014/main" id="{FF989ABB-33A4-4210-B375-0FE64E18FFEB}"/>
+                <a16:creationId xmlns:a16="http://schemas.microsoft.com/office/drawing/2014/main" id="{6520B7E4-268E-4E71-B332-B23972D194A0}"/>
               </a:ext>
             </a:extLst>
           </p:cNvPr>
@@ -2693,7 +2693,7 @@
           <p:cNvPr id="9" name="bullet-0">
             <a:extLst xmlns:a="http://schemas.openxmlformats.org/drawingml/2006/main">
               <a:ext uri="{FF2B5EF4-FFF2-40B4-BE49-F238E27FC236}">
-                <a16:creationId xmlns:a16="http://schemas.microsoft.com/office/drawing/2014/main" id="{1545D795-A88F-4F3D-8BBE-37CFF0146A0F}"/>
+                <a16:creationId xmlns:a16="http://schemas.microsoft.com/office/drawing/2014/main" id="{72FD7B87-1180-41C8-88CA-801AB9F0EFF9}"/>
               </a:ext>
             </a:extLst>
           </p:cNvPr>
@@ -2738,7 +2738,7 @@
           <p:cNvPr id="10" name="bullet-1">
             <a:extLst xmlns:a="http://schemas.openxmlformats.org/drawingml/2006/main">
               <a:ext uri="{FF2B5EF4-FFF2-40B4-BE49-F238E27FC236}">
-                <a16:creationId xmlns:a16="http://schemas.microsoft.com/office/drawing/2014/main" id="{505ACA83-8A95-4F91-ABA4-F99FAADB3757}"/>
+                <a16:creationId xmlns:a16="http://schemas.microsoft.com/office/drawing/2014/main" id="{316A26A5-1B38-4A38-B2BE-AACF9BBB1C23}"/>
               </a:ext>
             </a:extLst>
           </p:cNvPr>
@@ -2783,7 +2783,7 @@
           <p:cNvPr id="11" name="bullet-2">
             <a:extLst xmlns:a="http://schemas.openxmlformats.org/drawingml/2006/main">
               <a:ext uri="{FF2B5EF4-FFF2-40B4-BE49-F238E27FC236}">
-                <a16:creationId xmlns:a16="http://schemas.microsoft.com/office/drawing/2014/main" id="{FE15165E-B372-46D6-8BB6-BE346041C4B0}"/>
+                <a16:creationId xmlns:a16="http://schemas.microsoft.com/office/drawing/2014/main" id="{F61C8342-32F3-4E90-BD85-FB4A7E7B161F}"/>
               </a:ext>
             </a:extLst>
           </p:cNvPr>
@@ -2828,7 +2828,7 @@
           <p:cNvPr id="12" name="bullet-3">
             <a:extLst xmlns:a="http://schemas.openxmlformats.org/drawingml/2006/main">
               <a:ext uri="{FF2B5EF4-FFF2-40B4-BE49-F238E27FC236}">
-                <a16:creationId xmlns:a16="http://schemas.microsoft.com/office/drawing/2014/main" id="{50F3EE28-0CA0-4453-96AE-0F413DC25C91}"/>
+                <a16:creationId xmlns:a16="http://schemas.microsoft.com/office/drawing/2014/main" id="{F77112A6-73D4-4288-8EB9-EEBFDDBE736A}"/>
               </a:ext>
             </a:extLst>
           </p:cNvPr>
@@ -2873,7 +2873,7 @@
           <p:cNvPr id="13" name="bullet-4">
             <a:extLst xmlns:a="http://schemas.openxmlformats.org/drawingml/2006/main">
               <a:ext uri="{FF2B5EF4-FFF2-40B4-BE49-F238E27FC236}">
-                <a16:creationId xmlns:a16="http://schemas.microsoft.com/office/drawing/2014/main" id="{1B64E281-5F2F-4723-B330-93F9676991A7}"/>
+                <a16:creationId xmlns:a16="http://schemas.microsoft.com/office/drawing/2014/main" id="{6C7D695C-926D-4586-B81B-7413EC74B44A}"/>
               </a:ext>
             </a:extLst>
           </p:cNvPr>
@@ -2918,7 +2918,7 @@
           <p:cNvPr id="14" name="protocol-footer">
             <a:extLst xmlns:a="http://schemas.openxmlformats.org/drawingml/2006/main">
               <a:ext uri="{FF2B5EF4-FFF2-40B4-BE49-F238E27FC236}">
-                <a16:creationId xmlns:a16="http://schemas.microsoft.com/office/drawing/2014/main" id="{6ECC0A02-EB8D-4450-BE58-FC79CDDB20C1}"/>
+                <a16:creationId xmlns:a16="http://schemas.microsoft.com/office/drawing/2014/main" id="{D033FAE2-D268-4C8B-8F96-95D639FE8431}"/>
               </a:ext>
             </a:extLst>
           </p:cNvPr>
@@ -2961,7 +2961,7 @@
     </p:spTree>
     <p:extLst>
       <p:ext uri="{BB962C8B-B14F-4D97-AF65-F5344CB8AC3E}">
-        <p14:creationId xmlns:p14="http://schemas.microsoft.com/office/powerpoint/2010/main" val="620316855"/>
+        <p14:creationId xmlns:p14="http://schemas.microsoft.com/office/powerpoint/2010/main" val="1636717227"/>
       </p:ext>
     </p:extLst>
   </p:cSld>
@@ -2985,7 +2985,7 @@
           <p:cNvPr id="1" name="slide-title">
             <a:extLst xmlns:a="http://schemas.openxmlformats.org/drawingml/2006/main">
               <a:ext uri="{FF2B5EF4-FFF2-40B4-BE49-F238E27FC236}">
-                <a16:creationId xmlns:a16="http://schemas.microsoft.com/office/drawing/2014/main" id="{534E7FDF-D6E3-4603-82F9-0339781071A6}"/>
+                <a16:creationId xmlns:a16="http://schemas.microsoft.com/office/drawing/2014/main" id="{CBCE1212-06AB-4EDA-963E-BBF8AB3D1EAD}"/>
               </a:ext>
             </a:extLst>
           </p:cNvPr>
@@ -3030,7 +3030,7 @@
           <p:cNvPr id="2" name="slide-subtitle">
             <a:extLst xmlns:a="http://schemas.openxmlformats.org/drawingml/2006/main">
               <a:ext uri="{FF2B5EF4-FFF2-40B4-BE49-F238E27FC236}">
-                <a16:creationId xmlns:a16="http://schemas.microsoft.com/office/drawing/2014/main" id="{CAD7720E-7D52-47E3-80CD-61D5F5009D99}"/>
+                <a16:creationId xmlns:a16="http://schemas.microsoft.com/office/drawing/2014/main" id="{0688DAB7-64A7-4D9E-8B7A-547064B30585}"/>
               </a:ext>
             </a:extLst>
           </p:cNvPr>
@@ -3079,7 +3079,7 @@
           <p:nvPr/>
         </p:nvPicPr>
         <p:blipFill>
-          <a:blip xmlns:r="http://schemas.openxmlformats.org/officeDocument/2006/relationships" xmlns:a="http://schemas.openxmlformats.org/drawingml/2006/main" r:embed="R5f476c87da05456e"/>
+          <a:blip xmlns:r="http://schemas.openxmlformats.org/officeDocument/2006/relationships" xmlns:a="http://schemas.openxmlformats.org/drawingml/2006/main" r:embed="Ra759e270e5084855"/>
           <a:stretch xmlns:a="http://schemas.openxmlformats.org/drawingml/2006/main"/>
         </p:blipFill>
         <p:spPr>
@@ -3095,7 +3095,7 @@
     </p:spTree>
     <p:extLst>
       <p:ext uri="{BB962C8B-B14F-4D97-AF65-F5344CB8AC3E}">
-        <p14:creationId xmlns:p14="http://schemas.microsoft.com/office/powerpoint/2010/main" val="1467387942"/>
+        <p14:creationId xmlns:p14="http://schemas.microsoft.com/office/powerpoint/2010/main" val="440492780"/>
       </p:ext>
     </p:extLst>
   </p:cSld>
@@ -3119,7 +3119,7 @@
           <p:cNvPr id="1" name="slide-title">
             <a:extLst xmlns:a="http://schemas.openxmlformats.org/drawingml/2006/main">
               <a:ext uri="{FF2B5EF4-FFF2-40B4-BE49-F238E27FC236}">
-                <a16:creationId xmlns:a16="http://schemas.microsoft.com/office/drawing/2014/main" id="{71EC6F11-44E8-43E9-AA74-1FB5149B4D28}"/>
+                <a16:creationId xmlns:a16="http://schemas.microsoft.com/office/drawing/2014/main" id="{E950C5F1-124B-4323-9469-C2C6ACE5CFB4}"/>
               </a:ext>
             </a:extLst>
           </p:cNvPr>
@@ -3164,7 +3164,7 @@
           <p:cNvPr id="2" name="slide-subtitle">
             <a:extLst xmlns:a="http://schemas.openxmlformats.org/drawingml/2006/main">
               <a:ext uri="{FF2B5EF4-FFF2-40B4-BE49-F238E27FC236}">
-                <a16:creationId xmlns:a16="http://schemas.microsoft.com/office/drawing/2014/main" id="{3B3BD76B-45DE-40F8-943B-B3737F70FB1E}"/>
+                <a16:creationId xmlns:a16="http://schemas.microsoft.com/office/drawing/2014/main" id="{ED32F41D-419C-4F7E-B52A-5B47FC0991BE}"/>
               </a:ext>
             </a:extLst>
           </p:cNvPr>
@@ -3213,7 +3213,7 @@
           <p:nvPr/>
         </p:nvPicPr>
         <p:blipFill>
-          <a:blip xmlns:r="http://schemas.openxmlformats.org/officeDocument/2006/relationships" xmlns:a="http://schemas.openxmlformats.org/drawingml/2006/main" r:embed="R27936e6d041e472e"/>
+          <a:blip xmlns:r="http://schemas.openxmlformats.org/officeDocument/2006/relationships" xmlns:a="http://schemas.openxmlformats.org/drawingml/2006/main" r:embed="R24d1e100f7004be4"/>
           <a:stretch xmlns:a="http://schemas.openxmlformats.org/drawingml/2006/main"/>
         </p:blipFill>
         <p:spPr>
@@ -3229,7 +3229,7 @@
     </p:spTree>
     <p:extLst>
       <p:ext uri="{BB962C8B-B14F-4D97-AF65-F5344CB8AC3E}">
-        <p14:creationId xmlns:p14="http://schemas.microsoft.com/office/powerpoint/2010/main" val="756955836"/>
+        <p14:creationId xmlns:p14="http://schemas.microsoft.com/office/powerpoint/2010/main" val="399860184"/>
       </p:ext>
     </p:extLst>
   </p:cSld>
@@ -3253,7 +3253,7 @@
           <p:cNvPr id="1" name="slide-title">
             <a:extLst xmlns:a="http://schemas.openxmlformats.org/drawingml/2006/main">
               <a:ext uri="{FF2B5EF4-FFF2-40B4-BE49-F238E27FC236}">
-                <a16:creationId xmlns:a16="http://schemas.microsoft.com/office/drawing/2014/main" id="{BC24BCA0-9BDE-4B56-8767-F1C98816DDF7}"/>
+                <a16:creationId xmlns:a16="http://schemas.microsoft.com/office/drawing/2014/main" id="{6E2DFA68-8E6B-41D3-873A-322333EAEEBD}"/>
               </a:ext>
             </a:extLst>
           </p:cNvPr>
@@ -3298,7 +3298,7 @@
           <p:cNvPr id="2" name="slide-subtitle">
             <a:extLst xmlns:a="http://schemas.openxmlformats.org/drawingml/2006/main">
               <a:ext uri="{FF2B5EF4-FFF2-40B4-BE49-F238E27FC236}">
-                <a16:creationId xmlns:a16="http://schemas.microsoft.com/office/drawing/2014/main" id="{C5F113EC-DDEA-4ACC-91B3-DB18982F8BB3}"/>
+                <a16:creationId xmlns:a16="http://schemas.microsoft.com/office/drawing/2014/main" id="{3FC2D888-7CFC-4529-A6BD-6EBEF15C73BE}"/>
               </a:ext>
             </a:extLst>
           </p:cNvPr>
@@ -3347,7 +3347,7 @@
           <p:nvPr/>
         </p:nvPicPr>
         <p:blipFill>
-          <a:blip xmlns:r="http://schemas.openxmlformats.org/officeDocument/2006/relationships" xmlns:a="http://schemas.openxmlformats.org/drawingml/2006/main" r:embed="R7929cb69b5e24f2d"/>
+          <a:blip xmlns:r="http://schemas.openxmlformats.org/officeDocument/2006/relationships" xmlns:a="http://schemas.openxmlformats.org/drawingml/2006/main" r:embed="R83110ef1ab7444fa"/>
           <a:stretch xmlns:a="http://schemas.openxmlformats.org/drawingml/2006/main"/>
         </p:blipFill>
         <p:spPr>
@@ -3363,7 +3363,7 @@
     </p:spTree>
     <p:extLst>
       <p:ext uri="{BB962C8B-B14F-4D97-AF65-F5344CB8AC3E}">
-        <p14:creationId xmlns:p14="http://schemas.microsoft.com/office/powerpoint/2010/main" val="1341111914"/>
+        <p14:creationId xmlns:p14="http://schemas.microsoft.com/office/powerpoint/2010/main" val="1442920886"/>
       </p:ext>
     </p:extLst>
   </p:cSld>
@@ -3387,7 +3387,7 @@
           <p:cNvPr id="1" name="slide-title">
             <a:extLst xmlns:a="http://schemas.openxmlformats.org/drawingml/2006/main">
               <a:ext uri="{FF2B5EF4-FFF2-40B4-BE49-F238E27FC236}">
-                <a16:creationId xmlns:a16="http://schemas.microsoft.com/office/drawing/2014/main" id="{2C6A4A15-0DE5-4199-B46F-B1567DD3C203}"/>
+                <a16:creationId xmlns:a16="http://schemas.microsoft.com/office/drawing/2014/main" id="{000F5E5E-8E21-4AEC-83E1-AD2F55D4D36F}"/>
               </a:ext>
             </a:extLst>
           </p:cNvPr>
@@ -3432,7 +3432,7 @@
           <p:cNvPr id="2" name="slide-subtitle">
             <a:extLst xmlns:a="http://schemas.openxmlformats.org/drawingml/2006/main">
               <a:ext uri="{FF2B5EF4-FFF2-40B4-BE49-F238E27FC236}">
-                <a16:creationId xmlns:a16="http://schemas.microsoft.com/office/drawing/2014/main" id="{254F2867-69DA-4BE1-9D7A-1F91196B753D}"/>
+                <a16:creationId xmlns:a16="http://schemas.microsoft.com/office/drawing/2014/main" id="{2DD0FDA8-8B04-4353-90D0-D29DB3CC027E}"/>
               </a:ext>
             </a:extLst>
           </p:cNvPr>
@@ -3477,7 +3477,7 @@
           <p:cNvPr id="3" name="bullet-0">
             <a:extLst xmlns:a="http://schemas.openxmlformats.org/drawingml/2006/main">
               <a:ext uri="{FF2B5EF4-FFF2-40B4-BE49-F238E27FC236}">
-                <a16:creationId xmlns:a16="http://schemas.microsoft.com/office/drawing/2014/main" id="{811F8901-E9E9-4F09-9284-CA07E0B6795F}"/>
+                <a16:creationId xmlns:a16="http://schemas.microsoft.com/office/drawing/2014/main" id="{C32996A6-0B53-4874-988D-B440C8A4B2D8}"/>
               </a:ext>
             </a:extLst>
           </p:cNvPr>
@@ -3522,7 +3522,7 @@
           <p:cNvPr id="4" name="bullet-1">
             <a:extLst xmlns:a="http://schemas.openxmlformats.org/drawingml/2006/main">
               <a:ext uri="{FF2B5EF4-FFF2-40B4-BE49-F238E27FC236}">
-                <a16:creationId xmlns:a16="http://schemas.microsoft.com/office/drawing/2014/main" id="{59603BFB-D2D2-49BF-BA14-4804AC31EAC6}"/>
+                <a16:creationId xmlns:a16="http://schemas.microsoft.com/office/drawing/2014/main" id="{9C16E75B-B7CB-4662-AE5A-287EAC50F3E6}"/>
               </a:ext>
             </a:extLst>
           </p:cNvPr>
@@ -3567,7 +3567,7 @@
           <p:cNvPr id="5" name="bullet-2">
             <a:extLst xmlns:a="http://schemas.openxmlformats.org/drawingml/2006/main">
               <a:ext uri="{FF2B5EF4-FFF2-40B4-BE49-F238E27FC236}">
-                <a16:creationId xmlns:a16="http://schemas.microsoft.com/office/drawing/2014/main" id="{7CA08B62-45E2-4571-9DF8-D07FDDAC295A}"/>
+                <a16:creationId xmlns:a16="http://schemas.microsoft.com/office/drawing/2014/main" id="{488778DA-31E4-4B18-8788-73E5732A6898}"/>
               </a:ext>
             </a:extLst>
           </p:cNvPr>
@@ -3612,7 +3612,7 @@
           <p:cNvPr id="6" name="bullet-3">
             <a:extLst xmlns:a="http://schemas.openxmlformats.org/drawingml/2006/main">
               <a:ext uri="{FF2B5EF4-FFF2-40B4-BE49-F238E27FC236}">
-                <a16:creationId xmlns:a16="http://schemas.microsoft.com/office/drawing/2014/main" id="{F829D3B0-9429-4A36-BEEC-6820EDA27B2F}"/>
+                <a16:creationId xmlns:a16="http://schemas.microsoft.com/office/drawing/2014/main" id="{D4ED2043-FD0C-4DA1-9EEA-33FB4887FB54}"/>
               </a:ext>
             </a:extLst>
           </p:cNvPr>
@@ -3657,7 +3657,7 @@
           <p:cNvPr id="7" name="bullet-4">
             <a:extLst xmlns:a="http://schemas.openxmlformats.org/drawingml/2006/main">
               <a:ext uri="{FF2B5EF4-FFF2-40B4-BE49-F238E27FC236}">
-                <a16:creationId xmlns:a16="http://schemas.microsoft.com/office/drawing/2014/main" id="{2A0A1D64-6C56-4AAA-BE3C-AE7166E8A4D8}"/>
+                <a16:creationId xmlns:a16="http://schemas.microsoft.com/office/drawing/2014/main" id="{51F869DE-20F8-47C2-860D-63C7DF0CA5DC}"/>
               </a:ext>
             </a:extLst>
           </p:cNvPr>
@@ -3702,7 +3702,7 @@
           <p:cNvPr id="8" name="bullet-0">
             <a:extLst xmlns:a="http://schemas.openxmlformats.org/drawingml/2006/main">
               <a:ext uri="{FF2B5EF4-FFF2-40B4-BE49-F238E27FC236}">
-                <a16:creationId xmlns:a16="http://schemas.microsoft.com/office/drawing/2014/main" id="{E81CEB81-707D-4F91-A842-D355FFD53CFD}"/>
+                <a16:creationId xmlns:a16="http://schemas.microsoft.com/office/drawing/2014/main" id="{CA9DF642-2564-4598-B5F8-41BFF1C7E18E}"/>
               </a:ext>
             </a:extLst>
           </p:cNvPr>
@@ -3747,7 +3747,7 @@
           <p:cNvPr id="9" name="bullet-1">
             <a:extLst xmlns:a="http://schemas.openxmlformats.org/drawingml/2006/main">
               <a:ext uri="{FF2B5EF4-FFF2-40B4-BE49-F238E27FC236}">
-                <a16:creationId xmlns:a16="http://schemas.microsoft.com/office/drawing/2014/main" id="{DCDF2228-3BCE-4157-802C-20E8902DD8AE}"/>
+                <a16:creationId xmlns:a16="http://schemas.microsoft.com/office/drawing/2014/main" id="{2E2673D8-A6E8-468C-BCE7-CAB479941BC2}"/>
               </a:ext>
             </a:extLst>
           </p:cNvPr>
@@ -3792,7 +3792,7 @@
           <p:cNvPr id="10" name="bullet-2">
             <a:extLst xmlns:a="http://schemas.openxmlformats.org/drawingml/2006/main">
               <a:ext uri="{FF2B5EF4-FFF2-40B4-BE49-F238E27FC236}">
-                <a16:creationId xmlns:a16="http://schemas.microsoft.com/office/drawing/2014/main" id="{0801D6A1-D144-462A-A7CE-630277EDF982}"/>
+                <a16:creationId xmlns:a16="http://schemas.microsoft.com/office/drawing/2014/main" id="{365C386C-4897-4712-9636-A4E4CD8F1760}"/>
               </a:ext>
             </a:extLst>
           </p:cNvPr>
@@ -3837,7 +3837,7 @@
           <p:cNvPr id="11" name="bullet-3">
             <a:extLst xmlns:a="http://schemas.openxmlformats.org/drawingml/2006/main">
               <a:ext uri="{FF2B5EF4-FFF2-40B4-BE49-F238E27FC236}">
-                <a16:creationId xmlns:a16="http://schemas.microsoft.com/office/drawing/2014/main" id="{10F21A01-B832-408C-9770-CD2EE0009D97}"/>
+                <a16:creationId xmlns:a16="http://schemas.microsoft.com/office/drawing/2014/main" id="{F3166050-883F-4BFE-A803-799DF8EF3BBC}"/>
               </a:ext>
             </a:extLst>
           </p:cNvPr>
@@ -3882,7 +3882,7 @@
           <p:cNvPr id="12" name="bullet-4">
             <a:extLst xmlns:a="http://schemas.openxmlformats.org/drawingml/2006/main">
               <a:ext uri="{FF2B5EF4-FFF2-40B4-BE49-F238E27FC236}">
-                <a16:creationId xmlns:a16="http://schemas.microsoft.com/office/drawing/2014/main" id="{EFE8CDBF-C764-4679-8375-4114D90330B3}"/>
+                <a16:creationId xmlns:a16="http://schemas.microsoft.com/office/drawing/2014/main" id="{990BD278-ABD3-4F9D-A611-9E02F2BEC894}"/>
               </a:ext>
             </a:extLst>
           </p:cNvPr>
@@ -3927,7 +3927,7 @@
           <p:cNvPr id="13" name="audit-footer">
             <a:extLst xmlns:a="http://schemas.openxmlformats.org/drawingml/2006/main">
               <a:ext uri="{FF2B5EF4-FFF2-40B4-BE49-F238E27FC236}">
-                <a16:creationId xmlns:a16="http://schemas.microsoft.com/office/drawing/2014/main" id="{964DCE75-D3D7-43D7-AE7F-E33863E331A2}"/>
+                <a16:creationId xmlns:a16="http://schemas.microsoft.com/office/drawing/2014/main" id="{993C976F-C5F6-4BB8-817E-DA24320D0446}"/>
               </a:ext>
             </a:extLst>
           </p:cNvPr>
@@ -3970,7 +3970,7 @@
     </p:spTree>
     <p:extLst>
       <p:ext uri="{BB962C8B-B14F-4D97-AF65-F5344CB8AC3E}">
-        <p14:creationId xmlns:p14="http://schemas.microsoft.com/office/powerpoint/2010/main" val="1682079500"/>
+        <p14:creationId xmlns:p14="http://schemas.microsoft.com/office/powerpoint/2010/main" val="476761019"/>
       </p:ext>
     </p:extLst>
   </p:cSld>
@@ -3994,7 +3994,7 @@
           <p:cNvPr id="1" name="slide-title">
             <a:extLst xmlns:a="http://schemas.openxmlformats.org/drawingml/2006/main">
               <a:ext uri="{FF2B5EF4-FFF2-40B4-BE49-F238E27FC236}">
-                <a16:creationId xmlns:a16="http://schemas.microsoft.com/office/drawing/2014/main" id="{067F2D80-59AF-4CBD-B4AE-176B1109C008}"/>
+                <a16:creationId xmlns:a16="http://schemas.microsoft.com/office/drawing/2014/main" id="{2428B180-30AD-45EA-9E87-E5132050258B}"/>
               </a:ext>
             </a:extLst>
           </p:cNvPr>
@@ -4039,7 +4039,7 @@
           <p:cNvPr id="2" name="title-rule">
             <a:extLst xmlns:a="http://schemas.openxmlformats.org/drawingml/2006/main">
               <a:ext uri="{FF2B5EF4-FFF2-40B4-BE49-F238E27FC236}">
-                <a16:creationId xmlns:a16="http://schemas.microsoft.com/office/drawing/2014/main" id="{BA60B06B-71D7-40B6-AB24-0BF5E0283BBC}"/>
+                <a16:creationId xmlns:a16="http://schemas.microsoft.com/office/drawing/2014/main" id="{FC63F8AA-ABB6-4EE5-816A-6ED5B878A766}"/>
               </a:ext>
             </a:extLst>
           </p:cNvPr>
@@ -4072,7 +4072,7 @@
           <p:cNvPr id="3" name="bullet-0">
             <a:extLst xmlns:a="http://schemas.openxmlformats.org/drawingml/2006/main">
               <a:ext uri="{FF2B5EF4-FFF2-40B4-BE49-F238E27FC236}">
-                <a16:creationId xmlns:a16="http://schemas.microsoft.com/office/drawing/2014/main" id="{52B513DC-4ECC-4FEE-BC0C-A50CB37E6CBB}"/>
+                <a16:creationId xmlns:a16="http://schemas.microsoft.com/office/drawing/2014/main" id="{ADB82CCE-352D-44E5-8E6C-489DAC1FF00E}"/>
               </a:ext>
             </a:extLst>
           </p:cNvPr>
@@ -4117,7 +4117,7 @@
           <p:cNvPr id="4" name="bullet-1">
             <a:extLst xmlns:a="http://schemas.openxmlformats.org/drawingml/2006/main">
               <a:ext uri="{FF2B5EF4-FFF2-40B4-BE49-F238E27FC236}">
-                <a16:creationId xmlns:a16="http://schemas.microsoft.com/office/drawing/2014/main" id="{2F089840-0FA2-419A-A4B7-D97095552FC4}"/>
+                <a16:creationId xmlns:a16="http://schemas.microsoft.com/office/drawing/2014/main" id="{24008145-5757-4914-B1D3-9A4774EA4664}"/>
               </a:ext>
             </a:extLst>
           </p:cNvPr>
@@ -4162,7 +4162,7 @@
           <p:cNvPr id="5" name="bullet-2">
             <a:extLst xmlns:a="http://schemas.openxmlformats.org/drawingml/2006/main">
               <a:ext uri="{FF2B5EF4-FFF2-40B4-BE49-F238E27FC236}">
-                <a16:creationId xmlns:a16="http://schemas.microsoft.com/office/drawing/2014/main" id="{8B55C34C-7AFC-455F-9924-01AFBE103565}"/>
+                <a16:creationId xmlns:a16="http://schemas.microsoft.com/office/drawing/2014/main" id="{45604809-E4A3-4666-AFB8-0E2CD93EE4CF}"/>
               </a:ext>
             </a:extLst>
           </p:cNvPr>
@@ -4207,7 +4207,7 @@
           <p:cNvPr id="6" name="bullet-3">
             <a:extLst xmlns:a="http://schemas.openxmlformats.org/drawingml/2006/main">
               <a:ext uri="{FF2B5EF4-FFF2-40B4-BE49-F238E27FC236}">
-                <a16:creationId xmlns:a16="http://schemas.microsoft.com/office/drawing/2014/main" id="{8FFE7DAF-740C-46F2-8DA3-3CBBF9139C25}"/>
+                <a16:creationId xmlns:a16="http://schemas.microsoft.com/office/drawing/2014/main" id="{062DEF26-74B1-4D91-A244-EF6EA3AEA71D}"/>
               </a:ext>
             </a:extLst>
           </p:cNvPr>
@@ -4252,7 +4252,7 @@
           <p:cNvPr id="7" name="bullet-4">
             <a:extLst xmlns:a="http://schemas.openxmlformats.org/drawingml/2006/main">
               <a:ext uri="{FF2B5EF4-FFF2-40B4-BE49-F238E27FC236}">
-                <a16:creationId xmlns:a16="http://schemas.microsoft.com/office/drawing/2014/main" id="{A5D7D28B-6BD7-4165-9F17-64D3F5D94054}"/>
+                <a16:creationId xmlns:a16="http://schemas.microsoft.com/office/drawing/2014/main" id="{012A2B8D-DE82-419D-8248-0474DCBDFF20}"/>
               </a:ext>
             </a:extLst>
           </p:cNvPr>
@@ -4295,7 +4295,7 @@
     </p:spTree>
     <p:extLst>
       <p:ext uri="{BB962C8B-B14F-4D97-AF65-F5344CB8AC3E}">
-        <p14:creationId xmlns:p14="http://schemas.microsoft.com/office/powerpoint/2010/main" val="48345682"/>
+        <p14:creationId xmlns:p14="http://schemas.microsoft.com/office/powerpoint/2010/main" val="162049671"/>
       </p:ext>
     </p:extLst>
   </p:cSld>

</xml_diff>

<commit_message>
Clean final MoP figures and labels
</commit_message>
<xml_diff>
--- a/slides/mop_stage2_final/output/output.pptx
+++ b/slides/mop_stage2_final/output/output.pptx
@@ -2,24 +2,24 @@
 <file path=ppt/presentation.xml><?xml version="1.0" encoding="utf-8"?>
 <p:presentation xmlns:p="http://schemas.openxmlformats.org/presentationml/2006/main">
   <p:sldMasterIdLst>
-    <p:sldMasterId xmlns:r="http://schemas.openxmlformats.org/officeDocument/2006/relationships" id="2147483648" r:id="Rbda33fbafcc9409c"/>
+    <p:sldMasterId xmlns:r="http://schemas.openxmlformats.org/officeDocument/2006/relationships" id="2147483648" r:id="Rc52f6eba7b6345ca"/>
   </p:sldMasterIdLst>
   <p:notesMasterIdLst>
-    <p:notesMasterId xmlns:r="http://schemas.openxmlformats.org/officeDocument/2006/relationships" r:id="R34cd7deb0bc54e06"/>
+    <p:notesMasterId xmlns:r="http://schemas.openxmlformats.org/officeDocument/2006/relationships" r:id="R713defd4d9674820"/>
   </p:notesMasterIdLst>
   <p:sldIdLst>
-    <p:sldId xmlns:r="http://schemas.openxmlformats.org/officeDocument/2006/relationships" id="256" r:id="R9a85c97fc87245b7"/>
-    <p:sldId xmlns:r="http://schemas.openxmlformats.org/officeDocument/2006/relationships" id="257" r:id="R80ca945afc644a44"/>
-    <p:sldId xmlns:r="http://schemas.openxmlformats.org/officeDocument/2006/relationships" id="258" r:id="R4d58be53c789419b"/>
-    <p:sldId xmlns:r="http://schemas.openxmlformats.org/officeDocument/2006/relationships" id="259" r:id="Rd77eb761a495447e"/>
-    <p:sldId xmlns:r="http://schemas.openxmlformats.org/officeDocument/2006/relationships" id="260" r:id="R9300e5a6e79c4563"/>
-    <p:sldId xmlns:r="http://schemas.openxmlformats.org/officeDocument/2006/relationships" id="261" r:id="Rd06931ad3bf04c27"/>
-    <p:sldId xmlns:r="http://schemas.openxmlformats.org/officeDocument/2006/relationships" id="262" r:id="Rc1ac44173cfd4aed"/>
-    <p:sldId xmlns:r="http://schemas.openxmlformats.org/officeDocument/2006/relationships" id="263" r:id="R36728d18253943f1"/>
-    <p:sldId xmlns:r="http://schemas.openxmlformats.org/officeDocument/2006/relationships" id="264" r:id="R4f6575ddbb3142a9"/>
-    <p:sldId xmlns:r="http://schemas.openxmlformats.org/officeDocument/2006/relationships" id="265" r:id="R492160151ca94786"/>
-    <p:sldId xmlns:r="http://schemas.openxmlformats.org/officeDocument/2006/relationships" id="266" r:id="R88adb371101a44e8"/>
-    <p:sldId xmlns:r="http://schemas.openxmlformats.org/officeDocument/2006/relationships" id="267" r:id="Rc19fccfbf2af4255"/>
+    <p:sldId xmlns:r="http://schemas.openxmlformats.org/officeDocument/2006/relationships" id="256" r:id="Re2c2cf0590f243a3"/>
+    <p:sldId xmlns:r="http://schemas.openxmlformats.org/officeDocument/2006/relationships" id="257" r:id="R4d09e51652274e15"/>
+    <p:sldId xmlns:r="http://schemas.openxmlformats.org/officeDocument/2006/relationships" id="258" r:id="Rc46f340ba98d46d3"/>
+    <p:sldId xmlns:r="http://schemas.openxmlformats.org/officeDocument/2006/relationships" id="259" r:id="R1ce298ff4969419c"/>
+    <p:sldId xmlns:r="http://schemas.openxmlformats.org/officeDocument/2006/relationships" id="260" r:id="R0a435af342be41ba"/>
+    <p:sldId xmlns:r="http://schemas.openxmlformats.org/officeDocument/2006/relationships" id="261" r:id="Rdf9db31642da4df2"/>
+    <p:sldId xmlns:r="http://schemas.openxmlformats.org/officeDocument/2006/relationships" id="262" r:id="R498e68cbe5e54a2b"/>
+    <p:sldId xmlns:r="http://schemas.openxmlformats.org/officeDocument/2006/relationships" id="263" r:id="Rc8f0a1550bec4922"/>
+    <p:sldId xmlns:r="http://schemas.openxmlformats.org/officeDocument/2006/relationships" id="264" r:id="Rd3ed013d81c0439b"/>
+    <p:sldId xmlns:r="http://schemas.openxmlformats.org/officeDocument/2006/relationships" id="265" r:id="R53243ce31459436b"/>
+    <p:sldId xmlns:r="http://schemas.openxmlformats.org/officeDocument/2006/relationships" id="266" r:id="Rce30196c86a94998"/>
+    <p:sldId xmlns:r="http://schemas.openxmlformats.org/officeDocument/2006/relationships" id="267" r:id="Rb61f57a7dbce4eaf"/>
   </p:sldIdLst>
   <p:sldSz cx="18288000" cy="10287000"/>
   <p:notesSz cx="6858000" cy="9144000"/>
@@ -1292,7 +1292,7 @@
   </p:cSld>
   <p:clrMap bg1="lt1" tx1="dk1" bg2="lt2" tx2="dk2" accent1="accent1" accent2="accent2" accent3="accent3" accent4="accent4" accent5="accent5" accent6="accent6" hlink="hlink" folHlink="folHlink"/>
   <p:sldLayoutIdLst>
-    <p:sldLayoutId xmlns:r="http://schemas.openxmlformats.org/officeDocument/2006/relationships" id="2147483649" r:id="Rcd9539473a3348cf"/>
+    <p:sldLayoutId xmlns:r="http://schemas.openxmlformats.org/officeDocument/2006/relationships" id="2147483649" r:id="R9c5533a578f44923"/>
   </p:sldLayoutIdLst>
   <p:txStyles>
     <p:titleStyle>
@@ -1591,7 +1591,7 @@
           <p:cNvPr id="1" name="eyebrow">
             <a:extLst xmlns:a="http://schemas.openxmlformats.org/drawingml/2006/main">
               <a:ext uri="{FF2B5EF4-FFF2-40B4-BE49-F238E27FC236}">
-                <a16:creationId xmlns:a16="http://schemas.microsoft.com/office/drawing/2014/main" id="{93A0D086-FF78-4E47-B157-BDF5391CF9BB}"/>
+                <a16:creationId xmlns:a16="http://schemas.microsoft.com/office/drawing/2014/main" id="{6D4B5CCC-1AC1-4BBB-AF3F-7FBF29ED21DD}"/>
               </a:ext>
             </a:extLst>
           </p:cNvPr>
@@ -1636,7 +1636,7 @@
           <p:cNvPr id="2" name="cover-title">
             <a:extLst xmlns:a="http://schemas.openxmlformats.org/drawingml/2006/main">
               <a:ext uri="{FF2B5EF4-FFF2-40B4-BE49-F238E27FC236}">
-                <a16:creationId xmlns:a16="http://schemas.microsoft.com/office/drawing/2014/main" id="{6221013F-4FF2-459F-90BD-7AA78032E832}"/>
+                <a16:creationId xmlns:a16="http://schemas.microsoft.com/office/drawing/2014/main" id="{D7EA5239-4C46-403D-9E7C-4765A7A5C7B7}"/>
               </a:ext>
             </a:extLst>
           </p:cNvPr>
@@ -1681,7 +1681,7 @@
           <p:cNvPr id="3" name="cover-rule">
             <a:extLst xmlns:a="http://schemas.openxmlformats.org/drawingml/2006/main">
               <a:ext uri="{FF2B5EF4-FFF2-40B4-BE49-F238E27FC236}">
-                <a16:creationId xmlns:a16="http://schemas.microsoft.com/office/drawing/2014/main" id="{992FF1E7-4F9D-4D74-9F40-491C4055950E}"/>
+                <a16:creationId xmlns:a16="http://schemas.microsoft.com/office/drawing/2014/main" id="{FAE95BCE-FFE5-42F7-84E8-910C990D5FBD}"/>
               </a:ext>
             </a:extLst>
           </p:cNvPr>
@@ -1714,7 +1714,7 @@
           <p:cNvPr id="4" name="cover-thesis">
             <a:extLst xmlns:a="http://schemas.openxmlformats.org/drawingml/2006/main">
               <a:ext uri="{FF2B5EF4-FFF2-40B4-BE49-F238E27FC236}">
-                <a16:creationId xmlns:a16="http://schemas.microsoft.com/office/drawing/2014/main" id="{F678377C-83D6-4E6C-960C-ECD48D8A53E7}"/>
+                <a16:creationId xmlns:a16="http://schemas.microsoft.com/office/drawing/2014/main" id="{00D5989D-E2CD-48A3-A8DF-E52EB689B5A6}"/>
               </a:ext>
             </a:extLst>
           </p:cNvPr>
@@ -1759,7 +1759,7 @@
           <p:cNvPr id="5" name="cover-scope">
             <a:extLst xmlns:a="http://schemas.openxmlformats.org/drawingml/2006/main">
               <a:ext uri="{FF2B5EF4-FFF2-40B4-BE49-F238E27FC236}">
-                <a16:creationId xmlns:a16="http://schemas.microsoft.com/office/drawing/2014/main" id="{ED7A7568-EE8D-4CE2-86DC-9375B12770E8}"/>
+                <a16:creationId xmlns:a16="http://schemas.microsoft.com/office/drawing/2014/main" id="{40D3B02E-B0C0-4B2B-9972-A5BA28EE3416}"/>
               </a:ext>
             </a:extLst>
           </p:cNvPr>
@@ -1808,7 +1808,7 @@
           <p:nvPr/>
         </p:nvPicPr>
         <p:blipFill>
-          <a:blip xmlns:r="http://schemas.openxmlformats.org/officeDocument/2006/relationships" xmlns:a="http://schemas.openxmlformats.org/drawingml/2006/main" r:embed="R239471b5ac9e4ca0"/>
+          <a:blip xmlns:r="http://schemas.openxmlformats.org/officeDocument/2006/relationships" xmlns:a="http://schemas.openxmlformats.org/drawingml/2006/main" r:embed="Re8e56196ce7a4817"/>
           <a:stretch xmlns:a="http://schemas.openxmlformats.org/drawingml/2006/main"/>
         </p:blipFill>
         <p:spPr>
@@ -1826,7 +1826,7 @@
           <p:cNvPr id="7" name="icon-heading-Route the next epoch">
             <a:extLst xmlns:a="http://schemas.openxmlformats.org/drawingml/2006/main">
               <a:ext uri="{FF2B5EF4-FFF2-40B4-BE49-F238E27FC236}">
-                <a16:creationId xmlns:a16="http://schemas.microsoft.com/office/drawing/2014/main" id="{E0DA82D1-A883-431C-B3D4-9A64DB950BF5}"/>
+                <a16:creationId xmlns:a16="http://schemas.microsoft.com/office/drawing/2014/main" id="{248C651C-29A6-4478-ACD1-6AD5EAF8E139}"/>
               </a:ext>
             </a:extLst>
           </p:cNvPr>
@@ -1871,7 +1871,7 @@
           <p:cNvPr id="8" name="icon-body-Route the next epoch">
             <a:extLst xmlns:a="http://schemas.openxmlformats.org/drawingml/2006/main">
               <a:ext uri="{FF2B5EF4-FFF2-40B4-BE49-F238E27FC236}">
-                <a16:creationId xmlns:a16="http://schemas.microsoft.com/office/drawing/2014/main" id="{6984D0AC-74A9-4A7F-9FC0-36E39BF23A3A}"/>
+                <a16:creationId xmlns:a16="http://schemas.microsoft.com/office/drawing/2014/main" id="{BBE176D3-9190-43D3-AF3F-03AC4F0F0A11}"/>
               </a:ext>
             </a:extLst>
           </p:cNvPr>
@@ -1920,7 +1920,7 @@
           <p:nvPr/>
         </p:nvPicPr>
         <p:blipFill>
-          <a:blip xmlns:r="http://schemas.openxmlformats.org/officeDocument/2006/relationships" xmlns:a="http://schemas.openxmlformats.org/drawingml/2006/main" r:embed="Red8917ec9d964cff"/>
+          <a:blip xmlns:r="http://schemas.openxmlformats.org/officeDocument/2006/relationships" xmlns:a="http://schemas.openxmlformats.org/drawingml/2006/main" r:embed="Red58a34dd16447a0"/>
           <a:stretch xmlns:a="http://schemas.openxmlformats.org/drawingml/2006/main"/>
         </p:blipFill>
         <p:spPr>
@@ -1938,7 +1938,7 @@
           <p:cNvPr id="10" name="icon-heading-Tune a small policy">
             <a:extLst xmlns:a="http://schemas.openxmlformats.org/drawingml/2006/main">
               <a:ext uri="{FF2B5EF4-FFF2-40B4-BE49-F238E27FC236}">
-                <a16:creationId xmlns:a16="http://schemas.microsoft.com/office/drawing/2014/main" id="{D4464403-C491-4EC2-B1B4-A1BD9090A6AD}"/>
+                <a16:creationId xmlns:a16="http://schemas.microsoft.com/office/drawing/2014/main" id="{92801473-DF80-494D-A4A4-17B10FFD6277}"/>
               </a:ext>
             </a:extLst>
           </p:cNvPr>
@@ -1983,7 +1983,7 @@
           <p:cNvPr id="11" name="icon-body-Tune a small policy">
             <a:extLst xmlns:a="http://schemas.openxmlformats.org/drawingml/2006/main">
               <a:ext uri="{FF2B5EF4-FFF2-40B4-BE49-F238E27FC236}">
-                <a16:creationId xmlns:a16="http://schemas.microsoft.com/office/drawing/2014/main" id="{D8392ABB-B03A-45CB-BD47-42184E9F52E7}"/>
+                <a16:creationId xmlns:a16="http://schemas.microsoft.com/office/drawing/2014/main" id="{9890ACA3-2DBC-4D0D-8B78-EC6A69B745BC}"/>
               </a:ext>
             </a:extLst>
           </p:cNvPr>
@@ -2032,7 +2032,7 @@
           <p:nvPr/>
         </p:nvPicPr>
         <p:blipFill>
-          <a:blip xmlns:r="http://schemas.openxmlformats.org/officeDocument/2006/relationships" xmlns:a="http://schemas.openxmlformats.org/drawingml/2006/main" r:embed="R942ccf26245d4a99"/>
+          <a:blip xmlns:r="http://schemas.openxmlformats.org/officeDocument/2006/relationships" xmlns:a="http://schemas.openxmlformats.org/drawingml/2006/main" r:embed="Ra35549c770724c6c"/>
           <a:stretch xmlns:a="http://schemas.openxmlformats.org/drawingml/2006/main"/>
         </p:blipFill>
         <p:spPr>
@@ -2050,7 +2050,7 @@
           <p:cNvPr id="13" name="icon-heading-Claim the right result size">
             <a:extLst xmlns:a="http://schemas.openxmlformats.org/drawingml/2006/main">
               <a:ext uri="{FF2B5EF4-FFF2-40B4-BE49-F238E27FC236}">
-                <a16:creationId xmlns:a16="http://schemas.microsoft.com/office/drawing/2014/main" id="{A5D4A2F1-6DF6-489B-9B8A-31A5C3A82F68}"/>
+                <a16:creationId xmlns:a16="http://schemas.microsoft.com/office/drawing/2014/main" id="{48E98387-ECB3-4B70-96A5-BB12144B596D}"/>
               </a:ext>
             </a:extLst>
           </p:cNvPr>
@@ -2095,7 +2095,7 @@
           <p:cNvPr id="14" name="icon-body-Claim the right result size">
             <a:extLst xmlns:a="http://schemas.openxmlformats.org/drawingml/2006/main">
               <a:ext uri="{FF2B5EF4-FFF2-40B4-BE49-F238E27FC236}">
-                <a16:creationId xmlns:a16="http://schemas.microsoft.com/office/drawing/2014/main" id="{B99621A0-8148-473A-9E12-0CC4B75B1E85}"/>
+                <a16:creationId xmlns:a16="http://schemas.microsoft.com/office/drawing/2014/main" id="{56735311-1735-4496-B501-74CB76C07D01}"/>
               </a:ext>
             </a:extLst>
           </p:cNvPr>
@@ -2140,7 +2140,7 @@
           <p:cNvPr id="15" name="cover-footer">
             <a:extLst xmlns:a="http://schemas.openxmlformats.org/drawingml/2006/main">
               <a:ext uri="{FF2B5EF4-FFF2-40B4-BE49-F238E27FC236}">
-                <a16:creationId xmlns:a16="http://schemas.microsoft.com/office/drawing/2014/main" id="{18991FD9-3BF8-42C9-9053-A0E36663A3BE}"/>
+                <a16:creationId xmlns:a16="http://schemas.microsoft.com/office/drawing/2014/main" id="{B2A2C8E7-3685-48E2-914B-3DDB3E97F0E5}"/>
               </a:ext>
             </a:extLst>
           </p:cNvPr>
@@ -2183,7 +2183,7 @@
     </p:spTree>
     <p:extLst>
       <p:ext uri="{BB962C8B-B14F-4D97-AF65-F5344CB8AC3E}">
-        <p14:creationId xmlns:p14="http://schemas.microsoft.com/office/powerpoint/2010/main" val="712783097"/>
+        <p14:creationId xmlns:p14="http://schemas.microsoft.com/office/powerpoint/2010/main" val="941944457"/>
       </p:ext>
     </p:extLst>
   </p:cSld>
@@ -2207,7 +2207,7 @@
           <p:cNvPr id="1" name="slide-title">
             <a:extLst xmlns:a="http://schemas.openxmlformats.org/drawingml/2006/main">
               <a:ext uri="{FF2B5EF4-FFF2-40B4-BE49-F238E27FC236}">
-                <a16:creationId xmlns:a16="http://schemas.microsoft.com/office/drawing/2014/main" id="{EE42D6CB-3426-4317-BA39-AB028C492C3B}"/>
+                <a16:creationId xmlns:a16="http://schemas.microsoft.com/office/drawing/2014/main" id="{82AF3980-1A09-458A-BB76-BF6B7E6E64F5}"/>
               </a:ext>
             </a:extLst>
           </p:cNvPr>
@@ -2252,7 +2252,7 @@
           <p:cNvPr id="2" name="slide-subtitle">
             <a:extLst xmlns:a="http://schemas.openxmlformats.org/drawingml/2006/main">
               <a:ext uri="{FF2B5EF4-FFF2-40B4-BE49-F238E27FC236}">
-                <a16:creationId xmlns:a16="http://schemas.microsoft.com/office/drawing/2014/main" id="{D67FDB77-F1BE-4FDE-8023-15773411BD1E}"/>
+                <a16:creationId xmlns:a16="http://schemas.microsoft.com/office/drawing/2014/main" id="{4EEDF2E6-3CC4-404A-A576-7EFAF62F690C}"/>
               </a:ext>
             </a:extLst>
           </p:cNvPr>
@@ -2297,7 +2297,7 @@
           <p:cNvPr id="3" name="blank-title-peer">
             <a:extLst xmlns:a="http://schemas.openxmlformats.org/drawingml/2006/main">
               <a:ext uri="{FF2B5EF4-FFF2-40B4-BE49-F238E27FC236}">
-                <a16:creationId xmlns:a16="http://schemas.microsoft.com/office/drawing/2014/main" id="{8C7F4D55-3F34-4BEB-B0C8-65350C4514D0}"/>
+                <a16:creationId xmlns:a16="http://schemas.microsoft.com/office/drawing/2014/main" id="{381A201B-A642-4C18-BAEB-7EFE9CB66A05}"/>
               </a:ext>
             </a:extLst>
           </p:cNvPr>
@@ -2334,7 +2334,7 @@
           <p:nvPr/>
         </p:nvPicPr>
         <p:blipFill>
-          <a:blip xmlns:r="http://schemas.openxmlformats.org/officeDocument/2006/relationships" xmlns:a="http://schemas.openxmlformats.org/drawingml/2006/main" r:embed="R2d0b8327d84a4075"/>
+          <a:blip xmlns:r="http://schemas.openxmlformats.org/officeDocument/2006/relationships" xmlns:a="http://schemas.openxmlformats.org/drawingml/2006/main" r:embed="R643850509f6e4535"/>
           <a:stretch xmlns:a="http://schemas.openxmlformats.org/drawingml/2006/main"/>
         </p:blipFill>
         <p:spPr>
@@ -2352,7 +2352,7 @@
           <p:cNvPr id="5" name="figure-caption">
             <a:extLst xmlns:a="http://schemas.openxmlformats.org/drawingml/2006/main">
               <a:ext uri="{FF2B5EF4-FFF2-40B4-BE49-F238E27FC236}">
-                <a16:creationId xmlns:a16="http://schemas.microsoft.com/office/drawing/2014/main" id="{05B9AA0C-244F-47EA-8C02-9155941DE12C}"/>
+                <a16:creationId xmlns:a16="http://schemas.microsoft.com/office/drawing/2014/main" id="{48466E56-0D11-413C-B63B-5B1847FAD1C4}"/>
               </a:ext>
             </a:extLst>
           </p:cNvPr>
@@ -2397,7 +2397,7 @@
           <p:cNvPr id="6" name="table-cell-0-0">
             <a:extLst xmlns:a="http://schemas.openxmlformats.org/drawingml/2006/main">
               <a:ext uri="{FF2B5EF4-FFF2-40B4-BE49-F238E27FC236}">
-                <a16:creationId xmlns:a16="http://schemas.microsoft.com/office/drawing/2014/main" id="{81AFE5CE-5D42-4AAA-854F-2742007CA7A6}"/>
+                <a16:creationId xmlns:a16="http://schemas.microsoft.com/office/drawing/2014/main" id="{657C1B23-37FE-443F-BB32-64E49C741C28}"/>
               </a:ext>
             </a:extLst>
           </p:cNvPr>
@@ -2442,7 +2442,7 @@
           <p:cNvPr id="7" name="table-cell-0-1">
             <a:extLst xmlns:a="http://schemas.openxmlformats.org/drawingml/2006/main">
               <a:ext uri="{FF2B5EF4-FFF2-40B4-BE49-F238E27FC236}">
-                <a16:creationId xmlns:a16="http://schemas.microsoft.com/office/drawing/2014/main" id="{0A7A737A-5CBF-4CF3-B0BA-EA8272CF878B}"/>
+                <a16:creationId xmlns:a16="http://schemas.microsoft.com/office/drawing/2014/main" id="{FC040AB5-251D-4C0A-9B7C-7880394560AD}"/>
               </a:ext>
             </a:extLst>
           </p:cNvPr>
@@ -2487,7 +2487,7 @@
           <p:cNvPr id="8" name="table-cell-0-2">
             <a:extLst xmlns:a="http://schemas.openxmlformats.org/drawingml/2006/main">
               <a:ext uri="{FF2B5EF4-FFF2-40B4-BE49-F238E27FC236}">
-                <a16:creationId xmlns:a16="http://schemas.microsoft.com/office/drawing/2014/main" id="{BB87E616-5422-47D2-B07F-8B1ADEE506C5}"/>
+                <a16:creationId xmlns:a16="http://schemas.microsoft.com/office/drawing/2014/main" id="{23C3A31D-80B8-44F6-9CDA-B1755BBF8773}"/>
               </a:ext>
             </a:extLst>
           </p:cNvPr>
@@ -2532,7 +2532,7 @@
           <p:cNvPr id="9" name="table-cell-1-0">
             <a:extLst xmlns:a="http://schemas.openxmlformats.org/drawingml/2006/main">
               <a:ext uri="{FF2B5EF4-FFF2-40B4-BE49-F238E27FC236}">
-                <a16:creationId xmlns:a16="http://schemas.microsoft.com/office/drawing/2014/main" id="{E45639E7-25F6-489B-B366-6C24ED1A63E8}"/>
+                <a16:creationId xmlns:a16="http://schemas.microsoft.com/office/drawing/2014/main" id="{77AE95D2-173F-468F-9735-74EB5C40C080}"/>
               </a:ext>
             </a:extLst>
           </p:cNvPr>
@@ -2577,7 +2577,7 @@
           <p:cNvPr id="10" name="table-cell-1-1">
             <a:extLst xmlns:a="http://schemas.openxmlformats.org/drawingml/2006/main">
               <a:ext uri="{FF2B5EF4-FFF2-40B4-BE49-F238E27FC236}">
-                <a16:creationId xmlns:a16="http://schemas.microsoft.com/office/drawing/2014/main" id="{81D25339-8672-4588-8662-FFCEE146367D}"/>
+                <a16:creationId xmlns:a16="http://schemas.microsoft.com/office/drawing/2014/main" id="{AC835CF0-B4F7-469C-A3A7-B3A23632714A}"/>
               </a:ext>
             </a:extLst>
           </p:cNvPr>
@@ -2622,7 +2622,7 @@
           <p:cNvPr id="11" name="table-cell-1-2">
             <a:extLst xmlns:a="http://schemas.openxmlformats.org/drawingml/2006/main">
               <a:ext uri="{FF2B5EF4-FFF2-40B4-BE49-F238E27FC236}">
-                <a16:creationId xmlns:a16="http://schemas.microsoft.com/office/drawing/2014/main" id="{DA0F75D5-977D-448A-A90B-06B07117856A}"/>
+                <a16:creationId xmlns:a16="http://schemas.microsoft.com/office/drawing/2014/main" id="{6616D83D-5B77-47B4-9495-F6516B5E8511}"/>
               </a:ext>
             </a:extLst>
           </p:cNvPr>
@@ -2667,7 +2667,7 @@
           <p:cNvPr id="12" name="table-cell-2-0">
             <a:extLst xmlns:a="http://schemas.openxmlformats.org/drawingml/2006/main">
               <a:ext uri="{FF2B5EF4-FFF2-40B4-BE49-F238E27FC236}">
-                <a16:creationId xmlns:a16="http://schemas.microsoft.com/office/drawing/2014/main" id="{AEBBD817-995F-4D62-B4B3-ABEF40517DBE}"/>
+                <a16:creationId xmlns:a16="http://schemas.microsoft.com/office/drawing/2014/main" id="{F80E5B33-0CE3-4632-AD51-3BF1E666A1B0}"/>
               </a:ext>
             </a:extLst>
           </p:cNvPr>
@@ -2712,7 +2712,7 @@
           <p:cNvPr id="13" name="table-cell-2-1">
             <a:extLst xmlns:a="http://schemas.openxmlformats.org/drawingml/2006/main">
               <a:ext uri="{FF2B5EF4-FFF2-40B4-BE49-F238E27FC236}">
-                <a16:creationId xmlns:a16="http://schemas.microsoft.com/office/drawing/2014/main" id="{9D7D1074-AB37-4BA3-9F27-956376D3EB82}"/>
+                <a16:creationId xmlns:a16="http://schemas.microsoft.com/office/drawing/2014/main" id="{87C09E45-34F9-417C-92FA-167F871F691E}"/>
               </a:ext>
             </a:extLst>
           </p:cNvPr>
@@ -2757,7 +2757,7 @@
           <p:cNvPr id="14" name="table-cell-2-2">
             <a:extLst xmlns:a="http://schemas.openxmlformats.org/drawingml/2006/main">
               <a:ext uri="{FF2B5EF4-FFF2-40B4-BE49-F238E27FC236}">
-                <a16:creationId xmlns:a16="http://schemas.microsoft.com/office/drawing/2014/main" id="{073C3840-5FA5-4350-B15C-6B92D4EEDD5F}"/>
+                <a16:creationId xmlns:a16="http://schemas.microsoft.com/office/drawing/2014/main" id="{B7F1F76E-265F-4534-816C-D9CD036BFC32}"/>
               </a:ext>
             </a:extLst>
           </p:cNvPr>
@@ -2802,7 +2802,7 @@
           <p:cNvPr id="15" name="table-cell-3-0">
             <a:extLst xmlns:a="http://schemas.openxmlformats.org/drawingml/2006/main">
               <a:ext uri="{FF2B5EF4-FFF2-40B4-BE49-F238E27FC236}">
-                <a16:creationId xmlns:a16="http://schemas.microsoft.com/office/drawing/2014/main" id="{BE53ABF8-6547-45D9-944F-510365E7FED7}"/>
+                <a16:creationId xmlns:a16="http://schemas.microsoft.com/office/drawing/2014/main" id="{6F057978-978B-4B5E-B235-BE1A5A2992AC}"/>
               </a:ext>
             </a:extLst>
           </p:cNvPr>
@@ -2847,7 +2847,7 @@
           <p:cNvPr id="16" name="table-cell-3-1">
             <a:extLst xmlns:a="http://schemas.openxmlformats.org/drawingml/2006/main">
               <a:ext uri="{FF2B5EF4-FFF2-40B4-BE49-F238E27FC236}">
-                <a16:creationId xmlns:a16="http://schemas.microsoft.com/office/drawing/2014/main" id="{91BDF4BB-BB2B-4390-A0B4-3DD50FA6AA72}"/>
+                <a16:creationId xmlns:a16="http://schemas.microsoft.com/office/drawing/2014/main" id="{284ED8E2-78CD-4F7F-A3EC-78860836C7BF}"/>
               </a:ext>
             </a:extLst>
           </p:cNvPr>
@@ -2892,7 +2892,7 @@
           <p:cNvPr id="17" name="table-cell-3-2">
             <a:extLst xmlns:a="http://schemas.openxmlformats.org/drawingml/2006/main">
               <a:ext uri="{FF2B5EF4-FFF2-40B4-BE49-F238E27FC236}">
-                <a16:creationId xmlns:a16="http://schemas.microsoft.com/office/drawing/2014/main" id="{FD67435C-7643-484F-87B1-BB6921B1697E}"/>
+                <a16:creationId xmlns:a16="http://schemas.microsoft.com/office/drawing/2014/main" id="{AEC8EBAD-2361-4466-BFB4-BAF8C5BFD312}"/>
               </a:ext>
             </a:extLst>
           </p:cNvPr>
@@ -2937,7 +2937,7 @@
           <p:cNvPr id="18" name="selected-policy">
             <a:extLst xmlns:a="http://schemas.openxmlformats.org/drawingml/2006/main">
               <a:ext uri="{FF2B5EF4-FFF2-40B4-BE49-F238E27FC236}">
-                <a16:creationId xmlns:a16="http://schemas.microsoft.com/office/drawing/2014/main" id="{0E6AB521-424E-4CDE-8522-166AF1D05622}"/>
+                <a16:creationId xmlns:a16="http://schemas.microsoft.com/office/drawing/2014/main" id="{DF588D8B-48B2-49C0-92FC-6267575C7C6B}"/>
               </a:ext>
             </a:extLst>
           </p:cNvPr>
@@ -2980,7 +2980,7 @@
     </p:spTree>
     <p:extLst>
       <p:ext uri="{BB962C8B-B14F-4D97-AF65-F5344CB8AC3E}">
-        <p14:creationId xmlns:p14="http://schemas.microsoft.com/office/powerpoint/2010/main" val="1694688494"/>
+        <p14:creationId xmlns:p14="http://schemas.microsoft.com/office/powerpoint/2010/main" val="323405844"/>
       </p:ext>
     </p:extLst>
   </p:cSld>
@@ -3004,7 +3004,7 @@
           <p:cNvPr id="1" name="slide-title">
             <a:extLst xmlns:a="http://schemas.openxmlformats.org/drawingml/2006/main">
               <a:ext uri="{FF2B5EF4-FFF2-40B4-BE49-F238E27FC236}">
-                <a16:creationId xmlns:a16="http://schemas.microsoft.com/office/drawing/2014/main" id="{B6CB6E32-54E5-471C-BB45-D7C6F4E414D8}"/>
+                <a16:creationId xmlns:a16="http://schemas.microsoft.com/office/drawing/2014/main" id="{C7AC78F1-969C-4E2B-8461-1321957DBD5D}"/>
               </a:ext>
             </a:extLst>
           </p:cNvPr>
@@ -3049,7 +3049,7 @@
           <p:cNvPr id="2" name="slide-subtitle">
             <a:extLst xmlns:a="http://schemas.openxmlformats.org/drawingml/2006/main">
               <a:ext uri="{FF2B5EF4-FFF2-40B4-BE49-F238E27FC236}">
-                <a16:creationId xmlns:a16="http://schemas.microsoft.com/office/drawing/2014/main" id="{D1609DA1-945F-442B-B47D-4B0AAB37442D}"/>
+                <a16:creationId xmlns:a16="http://schemas.microsoft.com/office/drawing/2014/main" id="{8A0B5627-FED5-4790-ADA7-398D8754D685}"/>
               </a:ext>
             </a:extLst>
           </p:cNvPr>
@@ -3094,7 +3094,7 @@
           <p:cNvPr id="3" name="blank-title-peer">
             <a:extLst xmlns:a="http://schemas.openxmlformats.org/drawingml/2006/main">
               <a:ext uri="{FF2B5EF4-FFF2-40B4-BE49-F238E27FC236}">
-                <a16:creationId xmlns:a16="http://schemas.microsoft.com/office/drawing/2014/main" id="{7D122272-49C4-415B-8DCC-5DC0473DF55E}"/>
+                <a16:creationId xmlns:a16="http://schemas.microsoft.com/office/drawing/2014/main" id="{D5EBE15F-809D-4E56-AB8E-3E125C2AF4C6}"/>
               </a:ext>
             </a:extLst>
           </p:cNvPr>
@@ -3131,13 +3131,13 @@
           <p:nvPr/>
         </p:nvPicPr>
         <p:blipFill>
-          <a:blip xmlns:r="http://schemas.openxmlformats.org/officeDocument/2006/relationships" xmlns:a="http://schemas.openxmlformats.org/drawingml/2006/main" r:embed="R3dd1ced64e0f4b7c"/>
+          <a:blip xmlns:r="http://schemas.openxmlformats.org/officeDocument/2006/relationships" xmlns:a="http://schemas.openxmlformats.org/drawingml/2006/main" r:embed="R8bcf29a245494475"/>
           <a:stretch xmlns:a="http://schemas.openxmlformats.org/drawingml/2006/main"/>
         </p:blipFill>
         <p:spPr>
           <a:xfrm xmlns:a="http://schemas.openxmlformats.org/drawingml/2006/main">
-            <a:off x="685800" y="3288697"/>
-            <a:ext cx="8621078" cy="5172646"/>
+            <a:off x="685800" y="4307551"/>
+            <a:ext cx="8621078" cy="3134937"/>
           </a:xfrm>
           <a:prstGeom xmlns:a="http://schemas.openxmlformats.org/drawingml/2006/main" prst="rect">
             <a:avLst/>
@@ -3149,7 +3149,7 @@
           <p:cNvPr id="5" name="figure-caption">
             <a:extLst xmlns:a="http://schemas.openxmlformats.org/drawingml/2006/main">
               <a:ext uri="{FF2B5EF4-FFF2-40B4-BE49-F238E27FC236}">
-                <a16:creationId xmlns:a16="http://schemas.microsoft.com/office/drawing/2014/main" id="{7E96E0A0-6DA9-41E1-8720-D02E9EB4B6FE}"/>
+                <a16:creationId xmlns:a16="http://schemas.microsoft.com/office/drawing/2014/main" id="{5F187BDC-51F0-483A-A44C-0D09756D307D}"/>
               </a:ext>
             </a:extLst>
           </p:cNvPr>
@@ -3184,7 +3184,7 @@
                   <a:srgbClr val="333333"/>
                 </a:solidFill>
               </a:rPr>
-              <a:t>Caption: The action distribution keeps the tuned policy interpretable by showing how often the router selects each action across final traces.</a:t>
+              <a:t>Caption: Final routing behavior stays interpretable: the plot shows how MoP-V1 and MoP-V2 allocate selected epochs, budget, and useful prefetches across the two experts.</a:t>
             </a:r>
           </a:p>
         </p:txBody>
@@ -3194,7 +3194,7 @@
           <p:cNvPr id="6" name="bullet-0">
             <a:extLst xmlns:a="http://schemas.openxmlformats.org/drawingml/2006/main">
               <a:ext uri="{FF2B5EF4-FFF2-40B4-BE49-F238E27FC236}">
-                <a16:creationId xmlns:a16="http://schemas.microsoft.com/office/drawing/2014/main" id="{748DF96E-C56B-4D1C-AB0A-1C9C32D59D34}"/>
+                <a16:creationId xmlns:a16="http://schemas.microsoft.com/office/drawing/2014/main" id="{6B25FFB9-81A4-49C3-A81D-8DC3806610D6}"/>
               </a:ext>
             </a:extLst>
           </p:cNvPr>
@@ -3239,7 +3239,7 @@
           <p:cNvPr id="7" name="bullet-1">
             <a:extLst xmlns:a="http://schemas.openxmlformats.org/drawingml/2006/main">
               <a:ext uri="{FF2B5EF4-FFF2-40B4-BE49-F238E27FC236}">
-                <a16:creationId xmlns:a16="http://schemas.microsoft.com/office/drawing/2014/main" id="{4DB6334D-9E40-4968-9FB0-8F963AFBEB7E}"/>
+                <a16:creationId xmlns:a16="http://schemas.microsoft.com/office/drawing/2014/main" id="{FD36B630-5DF4-48E1-BEE5-8609C8B9D8C2}"/>
               </a:ext>
             </a:extLst>
           </p:cNvPr>
@@ -3284,7 +3284,7 @@
           <p:cNvPr id="8" name="bullet-2">
             <a:extLst xmlns:a="http://schemas.openxmlformats.org/drawingml/2006/main">
               <a:ext uri="{FF2B5EF4-FFF2-40B4-BE49-F238E27FC236}">
-                <a16:creationId xmlns:a16="http://schemas.microsoft.com/office/drawing/2014/main" id="{3790681D-DF5A-4051-AACA-B6E6B2C43437}"/>
+                <a16:creationId xmlns:a16="http://schemas.microsoft.com/office/drawing/2014/main" id="{282B9D72-01AC-4F7E-A453-CAFD32B31488}"/>
               </a:ext>
             </a:extLst>
           </p:cNvPr>
@@ -3329,7 +3329,7 @@
           <p:cNvPr id="9" name="logistics-pointer">
             <a:extLst xmlns:a="http://schemas.openxmlformats.org/drawingml/2006/main">
               <a:ext uri="{FF2B5EF4-FFF2-40B4-BE49-F238E27FC236}">
-                <a16:creationId xmlns:a16="http://schemas.microsoft.com/office/drawing/2014/main" id="{9BA66C64-0550-441E-93E2-846E850E59B5}"/>
+                <a16:creationId xmlns:a16="http://schemas.microsoft.com/office/drawing/2014/main" id="{C3586137-E3DA-4AC9-B554-EB8F1CB56E2A}"/>
               </a:ext>
             </a:extLst>
           </p:cNvPr>
@@ -3372,7 +3372,7 @@
     </p:spTree>
     <p:extLst>
       <p:ext uri="{BB962C8B-B14F-4D97-AF65-F5344CB8AC3E}">
-        <p14:creationId xmlns:p14="http://schemas.microsoft.com/office/powerpoint/2010/main" val="372518448"/>
+        <p14:creationId xmlns:p14="http://schemas.microsoft.com/office/powerpoint/2010/main" val="904956276"/>
       </p:ext>
     </p:extLst>
   </p:cSld>
@@ -3396,7 +3396,7 @@
           <p:cNvPr id="1" name="slide-title">
             <a:extLst xmlns:a="http://schemas.openxmlformats.org/drawingml/2006/main">
               <a:ext uri="{FF2B5EF4-FFF2-40B4-BE49-F238E27FC236}">
-                <a16:creationId xmlns:a16="http://schemas.microsoft.com/office/drawing/2014/main" id="{48188D23-CC8C-4C7D-AE65-A7678A594044}"/>
+                <a16:creationId xmlns:a16="http://schemas.microsoft.com/office/drawing/2014/main" id="{F0A41B2C-1DC1-4579-A52E-D0AB18C5A8F4}"/>
               </a:ext>
             </a:extLst>
           </p:cNvPr>
@@ -3441,7 +3441,7 @@
           <p:cNvPr id="2" name="slide-subtitle">
             <a:extLst xmlns:a="http://schemas.openxmlformats.org/drawingml/2006/main">
               <a:ext uri="{FF2B5EF4-FFF2-40B4-BE49-F238E27FC236}">
-                <a16:creationId xmlns:a16="http://schemas.microsoft.com/office/drawing/2014/main" id="{FFF12D2D-77CB-40EF-8AF7-74D251166E4C}"/>
+                <a16:creationId xmlns:a16="http://schemas.microsoft.com/office/drawing/2014/main" id="{C41F1CF6-05F8-4694-A37B-3C85FBDAF3CE}"/>
               </a:ext>
             </a:extLst>
           </p:cNvPr>
@@ -3486,7 +3486,7 @@
           <p:cNvPr id="3" name="blank-title-peer">
             <a:extLst xmlns:a="http://schemas.openxmlformats.org/drawingml/2006/main">
               <a:ext uri="{FF2B5EF4-FFF2-40B4-BE49-F238E27FC236}">
-                <a16:creationId xmlns:a16="http://schemas.microsoft.com/office/drawing/2014/main" id="{00348D68-63E0-47B7-81D4-B9133991F16D}"/>
+                <a16:creationId xmlns:a16="http://schemas.microsoft.com/office/drawing/2014/main" id="{E7AC890A-589B-4910-8933-DB3001F855B4}"/>
               </a:ext>
             </a:extLst>
           </p:cNvPr>
@@ -3519,7 +3519,7 @@
           <p:cNvPr id="4" name="eyebrow">
             <a:extLst xmlns:a="http://schemas.openxmlformats.org/drawingml/2006/main">
               <a:ext uri="{FF2B5EF4-FFF2-40B4-BE49-F238E27FC236}">
-                <a16:creationId xmlns:a16="http://schemas.microsoft.com/office/drawing/2014/main" id="{EDB163B5-2603-4AB6-8FEF-77DD33C6CD06}"/>
+                <a16:creationId xmlns:a16="http://schemas.microsoft.com/office/drawing/2014/main" id="{A8EAF9B4-903F-42E4-ABBF-8FCA07CCB635}"/>
               </a:ext>
             </a:extLst>
           </p:cNvPr>
@@ -3564,7 +3564,7 @@
           <p:cNvPr id="5" name="bullet-0">
             <a:extLst xmlns:a="http://schemas.openxmlformats.org/drawingml/2006/main">
               <a:ext uri="{FF2B5EF4-FFF2-40B4-BE49-F238E27FC236}">
-                <a16:creationId xmlns:a16="http://schemas.microsoft.com/office/drawing/2014/main" id="{2CC89799-7ACB-45A3-A893-CD0FB3F8ED3E}"/>
+                <a16:creationId xmlns:a16="http://schemas.microsoft.com/office/drawing/2014/main" id="{FAECD08F-C36F-4E6C-9542-1E7070BA2487}"/>
               </a:ext>
             </a:extLst>
           </p:cNvPr>
@@ -3609,7 +3609,7 @@
           <p:cNvPr id="6" name="bullet-1">
             <a:extLst xmlns:a="http://schemas.openxmlformats.org/drawingml/2006/main">
               <a:ext uri="{FF2B5EF4-FFF2-40B4-BE49-F238E27FC236}">
-                <a16:creationId xmlns:a16="http://schemas.microsoft.com/office/drawing/2014/main" id="{3A3C7280-B35A-436E-8BFA-F40D3EC1E188}"/>
+                <a16:creationId xmlns:a16="http://schemas.microsoft.com/office/drawing/2014/main" id="{706EAAB6-9A22-40F1-8342-9DA281CA2CB8}"/>
               </a:ext>
             </a:extLst>
           </p:cNvPr>
@@ -3654,7 +3654,7 @@
           <p:cNvPr id="7" name="bullet-2">
             <a:extLst xmlns:a="http://schemas.openxmlformats.org/drawingml/2006/main">
               <a:ext uri="{FF2B5EF4-FFF2-40B4-BE49-F238E27FC236}">
-                <a16:creationId xmlns:a16="http://schemas.microsoft.com/office/drawing/2014/main" id="{6938305D-EDA0-4E9A-B4E8-17E8BA2BD5E0}"/>
+                <a16:creationId xmlns:a16="http://schemas.microsoft.com/office/drawing/2014/main" id="{616C1DA2-1F30-4304-9E7B-C7F3DDB0E755}"/>
               </a:ext>
             </a:extLst>
           </p:cNvPr>
@@ -3699,7 +3699,7 @@
           <p:cNvPr id="8" name="bullet-3">
             <a:extLst xmlns:a="http://schemas.openxmlformats.org/drawingml/2006/main">
               <a:ext uri="{FF2B5EF4-FFF2-40B4-BE49-F238E27FC236}">
-                <a16:creationId xmlns:a16="http://schemas.microsoft.com/office/drawing/2014/main" id="{82467B81-E11A-4E64-B675-49CDD53146EE}"/>
+                <a16:creationId xmlns:a16="http://schemas.microsoft.com/office/drawing/2014/main" id="{01AD8019-F2AE-4798-8088-3A2A3358EF60}"/>
               </a:ext>
             </a:extLst>
           </p:cNvPr>
@@ -3744,7 +3744,7 @@
           <p:cNvPr id="9" name="eyebrow">
             <a:extLst xmlns:a="http://schemas.openxmlformats.org/drawingml/2006/main">
               <a:ext uri="{FF2B5EF4-FFF2-40B4-BE49-F238E27FC236}">
-                <a16:creationId xmlns:a16="http://schemas.microsoft.com/office/drawing/2014/main" id="{7EE08FA9-88E5-4B13-9787-1BA490CBDC7A}"/>
+                <a16:creationId xmlns:a16="http://schemas.microsoft.com/office/drawing/2014/main" id="{6E547FD1-2176-4DE2-9838-681367B9C2FE}"/>
               </a:ext>
             </a:extLst>
           </p:cNvPr>
@@ -3789,7 +3789,7 @@
           <p:cNvPr id="10" name="bullet-0">
             <a:extLst xmlns:a="http://schemas.openxmlformats.org/drawingml/2006/main">
               <a:ext uri="{FF2B5EF4-FFF2-40B4-BE49-F238E27FC236}">
-                <a16:creationId xmlns:a16="http://schemas.microsoft.com/office/drawing/2014/main" id="{6E94BA94-4793-44F4-AAB5-6C9C7B217DBF}"/>
+                <a16:creationId xmlns:a16="http://schemas.microsoft.com/office/drawing/2014/main" id="{A9719540-29EF-4F93-A0C5-279824293E68}"/>
               </a:ext>
             </a:extLst>
           </p:cNvPr>
@@ -3834,7 +3834,7 @@
           <p:cNvPr id="11" name="bullet-1">
             <a:extLst xmlns:a="http://schemas.openxmlformats.org/drawingml/2006/main">
               <a:ext uri="{FF2B5EF4-FFF2-40B4-BE49-F238E27FC236}">
-                <a16:creationId xmlns:a16="http://schemas.microsoft.com/office/drawing/2014/main" id="{98447218-0488-4C72-82CC-565E4C95A103}"/>
+                <a16:creationId xmlns:a16="http://schemas.microsoft.com/office/drawing/2014/main" id="{24B7074E-96B4-46C4-9743-AA03BE227F9A}"/>
               </a:ext>
             </a:extLst>
           </p:cNvPr>
@@ -3879,7 +3879,7 @@
           <p:cNvPr id="12" name="bullet-2">
             <a:extLst xmlns:a="http://schemas.openxmlformats.org/drawingml/2006/main">
               <a:ext uri="{FF2B5EF4-FFF2-40B4-BE49-F238E27FC236}">
-                <a16:creationId xmlns:a16="http://schemas.microsoft.com/office/drawing/2014/main" id="{FD32A2E0-DA0C-4AB1-B233-2A35C93FBACB}"/>
+                <a16:creationId xmlns:a16="http://schemas.microsoft.com/office/drawing/2014/main" id="{66F5C54C-19A9-4838-9633-DF46F29A14C5}"/>
               </a:ext>
             </a:extLst>
           </p:cNvPr>
@@ -3924,7 +3924,7 @@
           <p:cNvPr id="13" name="bullet-3">
             <a:extLst xmlns:a="http://schemas.openxmlformats.org/drawingml/2006/main">
               <a:ext uri="{FF2B5EF4-FFF2-40B4-BE49-F238E27FC236}">
-                <a16:creationId xmlns:a16="http://schemas.microsoft.com/office/drawing/2014/main" id="{B31A7643-C5F1-4685-9196-51A2F3504D3C}"/>
+                <a16:creationId xmlns:a16="http://schemas.microsoft.com/office/drawing/2014/main" id="{486E4F52-2381-4058-A5C6-D8209FC71CAF}"/>
               </a:ext>
             </a:extLst>
           </p:cNvPr>
@@ -3967,7 +3967,7 @@
     </p:spTree>
     <p:extLst>
       <p:ext uri="{BB962C8B-B14F-4D97-AF65-F5344CB8AC3E}">
-        <p14:creationId xmlns:p14="http://schemas.microsoft.com/office/powerpoint/2010/main" val="1248678770"/>
+        <p14:creationId xmlns:p14="http://schemas.microsoft.com/office/powerpoint/2010/main" val="461664122"/>
       </p:ext>
     </p:extLst>
   </p:cSld>
@@ -3991,7 +3991,7 @@
           <p:cNvPr id="1" name="slide-title">
             <a:extLst xmlns:a="http://schemas.openxmlformats.org/drawingml/2006/main">
               <a:ext uri="{FF2B5EF4-FFF2-40B4-BE49-F238E27FC236}">
-                <a16:creationId xmlns:a16="http://schemas.microsoft.com/office/drawing/2014/main" id="{148C1763-AA09-474C-B1D1-13F199B42226}"/>
+                <a16:creationId xmlns:a16="http://schemas.microsoft.com/office/drawing/2014/main" id="{8DD208A2-F3B3-49F5-A14E-CC2AA45E172D}"/>
               </a:ext>
             </a:extLst>
           </p:cNvPr>
@@ -4036,7 +4036,7 @@
           <p:cNvPr id="2" name="slide-subtitle">
             <a:extLst xmlns:a="http://schemas.openxmlformats.org/drawingml/2006/main">
               <a:ext uri="{FF2B5EF4-FFF2-40B4-BE49-F238E27FC236}">
-                <a16:creationId xmlns:a16="http://schemas.microsoft.com/office/drawing/2014/main" id="{4417E108-8CF0-44C4-8637-B00ECD29D6F1}"/>
+                <a16:creationId xmlns:a16="http://schemas.microsoft.com/office/drawing/2014/main" id="{9D6126C3-C6F5-494A-856B-9ECED2CBBFAD}"/>
               </a:ext>
             </a:extLst>
           </p:cNvPr>
@@ -4081,7 +4081,7 @@
           <p:cNvPr id="3" name="blank-title-peer">
             <a:extLst xmlns:a="http://schemas.openxmlformats.org/drawingml/2006/main">
               <a:ext uri="{FF2B5EF4-FFF2-40B4-BE49-F238E27FC236}">
-                <a16:creationId xmlns:a16="http://schemas.microsoft.com/office/drawing/2014/main" id="{549D4100-5371-48D5-8E67-630E1356153E}"/>
+                <a16:creationId xmlns:a16="http://schemas.microsoft.com/office/drawing/2014/main" id="{79369890-3EB1-4E7C-B403-4546D8E86F35}"/>
               </a:ext>
             </a:extLst>
           </p:cNvPr>
@@ -4114,7 +4114,7 @@
           <p:cNvPr id="4" name="eyebrow">
             <a:extLst xmlns:a="http://schemas.openxmlformats.org/drawingml/2006/main">
               <a:ext uri="{FF2B5EF4-FFF2-40B4-BE49-F238E27FC236}">
-                <a16:creationId xmlns:a16="http://schemas.microsoft.com/office/drawing/2014/main" id="{B0F0EFCA-5BA7-4A40-AB10-3D9B19352692}"/>
+                <a16:creationId xmlns:a16="http://schemas.microsoft.com/office/drawing/2014/main" id="{E4C0BEDB-E756-4862-929E-A5CA8B5D22D5}"/>
               </a:ext>
             </a:extLst>
           </p:cNvPr>
@@ -4159,7 +4159,7 @@
           <p:cNvPr id="5" name="kv-key-0">
             <a:extLst xmlns:a="http://schemas.openxmlformats.org/drawingml/2006/main">
               <a:ext uri="{FF2B5EF4-FFF2-40B4-BE49-F238E27FC236}">
-                <a16:creationId xmlns:a16="http://schemas.microsoft.com/office/drawing/2014/main" id="{65224A6A-D5E2-4A0C-80A2-21CA65B0C6E3}"/>
+                <a16:creationId xmlns:a16="http://schemas.microsoft.com/office/drawing/2014/main" id="{6DCED746-D81E-41B6-94AD-9B1DFF33C82D}"/>
               </a:ext>
             </a:extLst>
           </p:cNvPr>
@@ -4204,7 +4204,7 @@
           <p:cNvPr id="6" name="kv-value-0">
             <a:extLst xmlns:a="http://schemas.openxmlformats.org/drawingml/2006/main">
               <a:ext uri="{FF2B5EF4-FFF2-40B4-BE49-F238E27FC236}">
-                <a16:creationId xmlns:a16="http://schemas.microsoft.com/office/drawing/2014/main" id="{318C91DE-677B-493A-ADA2-F1B4C3F3E8CB}"/>
+                <a16:creationId xmlns:a16="http://schemas.microsoft.com/office/drawing/2014/main" id="{A06D6FF1-134E-42AC-97B5-CE3144A6ED2D}"/>
               </a:ext>
             </a:extLst>
           </p:cNvPr>
@@ -4249,7 +4249,7 @@
           <p:cNvPr id="7" name="kv-key-1">
             <a:extLst xmlns:a="http://schemas.openxmlformats.org/drawingml/2006/main">
               <a:ext uri="{FF2B5EF4-FFF2-40B4-BE49-F238E27FC236}">
-                <a16:creationId xmlns:a16="http://schemas.microsoft.com/office/drawing/2014/main" id="{8416271E-F526-4CC2-B4F8-11A0D5C439B7}"/>
+                <a16:creationId xmlns:a16="http://schemas.microsoft.com/office/drawing/2014/main" id="{D8F7CA87-4E39-45F8-9DC4-49C42BABFEAA}"/>
               </a:ext>
             </a:extLst>
           </p:cNvPr>
@@ -4294,7 +4294,7 @@
           <p:cNvPr id="8" name="kv-value-1">
             <a:extLst xmlns:a="http://schemas.openxmlformats.org/drawingml/2006/main">
               <a:ext uri="{FF2B5EF4-FFF2-40B4-BE49-F238E27FC236}">
-                <a16:creationId xmlns:a16="http://schemas.microsoft.com/office/drawing/2014/main" id="{BA23D74B-18DF-4577-91F3-C6F3CA52F396}"/>
+                <a16:creationId xmlns:a16="http://schemas.microsoft.com/office/drawing/2014/main" id="{6B4A6583-3569-4675-9079-643C0282FF1C}"/>
               </a:ext>
             </a:extLst>
           </p:cNvPr>
@@ -4339,7 +4339,7 @@
           <p:cNvPr id="9" name="kv-key-2">
             <a:extLst xmlns:a="http://schemas.openxmlformats.org/drawingml/2006/main">
               <a:ext uri="{FF2B5EF4-FFF2-40B4-BE49-F238E27FC236}">
-                <a16:creationId xmlns:a16="http://schemas.microsoft.com/office/drawing/2014/main" id="{AC1530EB-64FC-47B6-AC92-05011A82123A}"/>
+                <a16:creationId xmlns:a16="http://schemas.microsoft.com/office/drawing/2014/main" id="{468DA64A-1A7A-4418-90F6-AF5639BC919B}"/>
               </a:ext>
             </a:extLst>
           </p:cNvPr>
@@ -4384,7 +4384,7 @@
           <p:cNvPr id="10" name="kv-value-2">
             <a:extLst xmlns:a="http://schemas.openxmlformats.org/drawingml/2006/main">
               <a:ext uri="{FF2B5EF4-FFF2-40B4-BE49-F238E27FC236}">
-                <a16:creationId xmlns:a16="http://schemas.microsoft.com/office/drawing/2014/main" id="{44D1CE68-FBB1-4C67-9945-5250B49B21E8}"/>
+                <a16:creationId xmlns:a16="http://schemas.microsoft.com/office/drawing/2014/main" id="{F6CBBC4E-3BE1-4FA0-BAAD-BBEFB30DB6B8}"/>
               </a:ext>
             </a:extLst>
           </p:cNvPr>
@@ -4429,7 +4429,7 @@
           <p:cNvPr id="11" name="eyebrow">
             <a:extLst xmlns:a="http://schemas.openxmlformats.org/drawingml/2006/main">
               <a:ext uri="{FF2B5EF4-FFF2-40B4-BE49-F238E27FC236}">
-                <a16:creationId xmlns:a16="http://schemas.microsoft.com/office/drawing/2014/main" id="{9B2E9D81-616A-49A5-9229-BF2408A14C4F}"/>
+                <a16:creationId xmlns:a16="http://schemas.microsoft.com/office/drawing/2014/main" id="{20C948CE-3D25-4A81-8F7D-698D54CF1BF7}"/>
               </a:ext>
             </a:extLst>
           </p:cNvPr>
@@ -4474,7 +4474,7 @@
           <p:cNvPr id="12" name="bullet-0">
             <a:extLst xmlns:a="http://schemas.openxmlformats.org/drawingml/2006/main">
               <a:ext uri="{FF2B5EF4-FFF2-40B4-BE49-F238E27FC236}">
-                <a16:creationId xmlns:a16="http://schemas.microsoft.com/office/drawing/2014/main" id="{412FF4C7-3696-4309-89F9-FA6C2B25E6C8}"/>
+                <a16:creationId xmlns:a16="http://schemas.microsoft.com/office/drawing/2014/main" id="{0151EA7B-4D4F-48CE-BD3B-FE791777C5E7}"/>
               </a:ext>
             </a:extLst>
           </p:cNvPr>
@@ -4519,7 +4519,7 @@
           <p:cNvPr id="13" name="bullet-1">
             <a:extLst xmlns:a="http://schemas.openxmlformats.org/drawingml/2006/main">
               <a:ext uri="{FF2B5EF4-FFF2-40B4-BE49-F238E27FC236}">
-                <a16:creationId xmlns:a16="http://schemas.microsoft.com/office/drawing/2014/main" id="{902AC3F6-168C-4C85-A22D-50E97342CA18}"/>
+                <a16:creationId xmlns:a16="http://schemas.microsoft.com/office/drawing/2014/main" id="{D53B8A3B-4B7A-41AE-80F4-AD243E484C8D}"/>
               </a:ext>
             </a:extLst>
           </p:cNvPr>
@@ -4564,7 +4564,7 @@
           <p:cNvPr id="14" name="bullet-2">
             <a:extLst xmlns:a="http://schemas.openxmlformats.org/drawingml/2006/main">
               <a:ext uri="{FF2B5EF4-FFF2-40B4-BE49-F238E27FC236}">
-                <a16:creationId xmlns:a16="http://schemas.microsoft.com/office/drawing/2014/main" id="{EDA8B86D-7C3A-4F60-BD46-1550F9CEE786}"/>
+                <a16:creationId xmlns:a16="http://schemas.microsoft.com/office/drawing/2014/main" id="{97B3A9BF-3801-4232-8924-A8E81008173F}"/>
               </a:ext>
             </a:extLst>
           </p:cNvPr>
@@ -4609,7 +4609,7 @@
           <p:cNvPr id="15" name="bullet-3">
             <a:extLst xmlns:a="http://schemas.openxmlformats.org/drawingml/2006/main">
               <a:ext uri="{FF2B5EF4-FFF2-40B4-BE49-F238E27FC236}">
-                <a16:creationId xmlns:a16="http://schemas.microsoft.com/office/drawing/2014/main" id="{189B19C6-0EED-4621-9522-D25629B38E11}"/>
+                <a16:creationId xmlns:a16="http://schemas.microsoft.com/office/drawing/2014/main" id="{C434800C-6F4D-434D-9A28-7E26CC28834B}"/>
               </a:ext>
             </a:extLst>
           </p:cNvPr>
@@ -4652,7 +4652,7 @@
     </p:spTree>
     <p:extLst>
       <p:ext uri="{BB962C8B-B14F-4D97-AF65-F5344CB8AC3E}">
-        <p14:creationId xmlns:p14="http://schemas.microsoft.com/office/powerpoint/2010/main" val="2091043037"/>
+        <p14:creationId xmlns:p14="http://schemas.microsoft.com/office/powerpoint/2010/main" val="1655884953"/>
       </p:ext>
     </p:extLst>
   </p:cSld>
@@ -4676,7 +4676,7 @@
           <p:cNvPr id="1" name="slide-title">
             <a:extLst xmlns:a="http://schemas.openxmlformats.org/drawingml/2006/main">
               <a:ext uri="{FF2B5EF4-FFF2-40B4-BE49-F238E27FC236}">
-                <a16:creationId xmlns:a16="http://schemas.microsoft.com/office/drawing/2014/main" id="{1E4F25E4-BE7D-4B0A-A568-F65A16F0178E}"/>
+                <a16:creationId xmlns:a16="http://schemas.microsoft.com/office/drawing/2014/main" id="{99D38034-7FD7-498E-91E6-A3A5EFB6F92A}"/>
               </a:ext>
             </a:extLst>
           </p:cNvPr>
@@ -4721,7 +4721,7 @@
           <p:cNvPr id="2" name="slide-subtitle">
             <a:extLst xmlns:a="http://schemas.openxmlformats.org/drawingml/2006/main">
               <a:ext uri="{FF2B5EF4-FFF2-40B4-BE49-F238E27FC236}">
-                <a16:creationId xmlns:a16="http://schemas.microsoft.com/office/drawing/2014/main" id="{D976115F-C08A-4648-8F94-63B25DB7C8FE}"/>
+                <a16:creationId xmlns:a16="http://schemas.microsoft.com/office/drawing/2014/main" id="{4B498B02-77A6-4B67-9078-16C0F668C90A}"/>
               </a:ext>
             </a:extLst>
           </p:cNvPr>
@@ -4766,7 +4766,7 @@
           <p:cNvPr id="3" name="blank-title-peer">
             <a:extLst xmlns:a="http://schemas.openxmlformats.org/drawingml/2006/main">
               <a:ext uri="{FF2B5EF4-FFF2-40B4-BE49-F238E27FC236}">
-                <a16:creationId xmlns:a16="http://schemas.microsoft.com/office/drawing/2014/main" id="{469BE59D-19D9-463A-9CBE-B7558D8DB644}"/>
+                <a16:creationId xmlns:a16="http://schemas.microsoft.com/office/drawing/2014/main" id="{1D5A17DE-BE41-4CB9-B772-0CE383F4A026}"/>
               </a:ext>
             </a:extLst>
           </p:cNvPr>
@@ -4799,7 +4799,7 @@
           <p:cNvPr id="4" name="eyebrow">
             <a:extLst xmlns:a="http://schemas.openxmlformats.org/drawingml/2006/main">
               <a:ext uri="{FF2B5EF4-FFF2-40B4-BE49-F238E27FC236}">
-                <a16:creationId xmlns:a16="http://schemas.microsoft.com/office/drawing/2014/main" id="{FFC7D1CE-6125-4DC3-B72F-05528988EACC}"/>
+                <a16:creationId xmlns:a16="http://schemas.microsoft.com/office/drawing/2014/main" id="{4C44A7D7-68F0-4D11-A3BD-0E1661E4EA4B}"/>
               </a:ext>
             </a:extLst>
           </p:cNvPr>
@@ -4844,7 +4844,7 @@
           <p:cNvPr id="5" name="kv-key-0">
             <a:extLst xmlns:a="http://schemas.openxmlformats.org/drawingml/2006/main">
               <a:ext uri="{FF2B5EF4-FFF2-40B4-BE49-F238E27FC236}">
-                <a16:creationId xmlns:a16="http://schemas.microsoft.com/office/drawing/2014/main" id="{02230E45-2406-424E-B212-D7D9904D2546}"/>
+                <a16:creationId xmlns:a16="http://schemas.microsoft.com/office/drawing/2014/main" id="{CA63B62E-E730-431C-AB5B-C803FD0CB4D8}"/>
               </a:ext>
             </a:extLst>
           </p:cNvPr>
@@ -4889,7 +4889,7 @@
           <p:cNvPr id="6" name="kv-value-0">
             <a:extLst xmlns:a="http://schemas.openxmlformats.org/drawingml/2006/main">
               <a:ext uri="{FF2B5EF4-FFF2-40B4-BE49-F238E27FC236}">
-                <a16:creationId xmlns:a16="http://schemas.microsoft.com/office/drawing/2014/main" id="{42E92C8C-155B-4BC3-8428-D109C60896B7}"/>
+                <a16:creationId xmlns:a16="http://schemas.microsoft.com/office/drawing/2014/main" id="{55134BC2-FB81-4549-BF76-5FA0C3CA5F42}"/>
               </a:ext>
             </a:extLst>
           </p:cNvPr>
@@ -4934,7 +4934,7 @@
           <p:cNvPr id="7" name="kv-key-1">
             <a:extLst xmlns:a="http://schemas.openxmlformats.org/drawingml/2006/main">
               <a:ext uri="{FF2B5EF4-FFF2-40B4-BE49-F238E27FC236}">
-                <a16:creationId xmlns:a16="http://schemas.microsoft.com/office/drawing/2014/main" id="{BBA2EBAF-F662-40CE-BDDB-8FF314EAB90C}"/>
+                <a16:creationId xmlns:a16="http://schemas.microsoft.com/office/drawing/2014/main" id="{9733DDF7-0972-4198-A4B5-DC44278477D8}"/>
               </a:ext>
             </a:extLst>
           </p:cNvPr>
@@ -4979,7 +4979,7 @@
           <p:cNvPr id="8" name="kv-value-1">
             <a:extLst xmlns:a="http://schemas.openxmlformats.org/drawingml/2006/main">
               <a:ext uri="{FF2B5EF4-FFF2-40B4-BE49-F238E27FC236}">
-                <a16:creationId xmlns:a16="http://schemas.microsoft.com/office/drawing/2014/main" id="{00BFD74A-D14F-4332-B92D-BBA1385A4186}"/>
+                <a16:creationId xmlns:a16="http://schemas.microsoft.com/office/drawing/2014/main" id="{BE557270-2610-45FC-B415-0A1A34F967C8}"/>
               </a:ext>
             </a:extLst>
           </p:cNvPr>
@@ -5024,7 +5024,7 @@
           <p:cNvPr id="9" name="kv-key-2">
             <a:extLst xmlns:a="http://schemas.openxmlformats.org/drawingml/2006/main">
               <a:ext uri="{FF2B5EF4-FFF2-40B4-BE49-F238E27FC236}">
-                <a16:creationId xmlns:a16="http://schemas.microsoft.com/office/drawing/2014/main" id="{62263F97-1B4A-49FA-B669-01AB8FBD9A92}"/>
+                <a16:creationId xmlns:a16="http://schemas.microsoft.com/office/drawing/2014/main" id="{138D7880-7CC8-4D63-B086-5991BAFBEE7B}"/>
               </a:ext>
             </a:extLst>
           </p:cNvPr>
@@ -5069,7 +5069,7 @@
           <p:cNvPr id="10" name="kv-value-2">
             <a:extLst xmlns:a="http://schemas.openxmlformats.org/drawingml/2006/main">
               <a:ext uri="{FF2B5EF4-FFF2-40B4-BE49-F238E27FC236}">
-                <a16:creationId xmlns:a16="http://schemas.microsoft.com/office/drawing/2014/main" id="{80198430-6BBC-4142-BE7A-6EAAA8095D8F}"/>
+                <a16:creationId xmlns:a16="http://schemas.microsoft.com/office/drawing/2014/main" id="{75B7D4A2-2717-4CE2-815A-6067B33E9519}"/>
               </a:ext>
             </a:extLst>
           </p:cNvPr>
@@ -5114,7 +5114,7 @@
           <p:cNvPr id="11" name="kv-key-3">
             <a:extLst xmlns:a="http://schemas.openxmlformats.org/drawingml/2006/main">
               <a:ext uri="{FF2B5EF4-FFF2-40B4-BE49-F238E27FC236}">
-                <a16:creationId xmlns:a16="http://schemas.microsoft.com/office/drawing/2014/main" id="{05375626-3A53-49E4-83F0-E82B87C7D3A6}"/>
+                <a16:creationId xmlns:a16="http://schemas.microsoft.com/office/drawing/2014/main" id="{91091651-88AE-457C-9015-E9F8B8BBB75B}"/>
               </a:ext>
             </a:extLst>
           </p:cNvPr>
@@ -5159,7 +5159,7 @@
           <p:cNvPr id="12" name="kv-value-3">
             <a:extLst xmlns:a="http://schemas.openxmlformats.org/drawingml/2006/main">
               <a:ext uri="{FF2B5EF4-FFF2-40B4-BE49-F238E27FC236}">
-                <a16:creationId xmlns:a16="http://schemas.microsoft.com/office/drawing/2014/main" id="{541A2C59-7DAF-4087-9A2D-0214F0D635D5}"/>
+                <a16:creationId xmlns:a16="http://schemas.microsoft.com/office/drawing/2014/main" id="{2A681D6F-13E9-4843-88A9-7CB01A5876BD}"/>
               </a:ext>
             </a:extLst>
           </p:cNvPr>
@@ -5204,7 +5204,7 @@
           <p:cNvPr id="13" name="kv-key-4">
             <a:extLst xmlns:a="http://schemas.openxmlformats.org/drawingml/2006/main">
               <a:ext uri="{FF2B5EF4-FFF2-40B4-BE49-F238E27FC236}">
-                <a16:creationId xmlns:a16="http://schemas.microsoft.com/office/drawing/2014/main" id="{6597531A-79C7-47D5-BE9C-91B0342265F3}"/>
+                <a16:creationId xmlns:a16="http://schemas.microsoft.com/office/drawing/2014/main" id="{D8ABEFD2-0D45-47DE-AAEF-A13E9AA0278E}"/>
               </a:ext>
             </a:extLst>
           </p:cNvPr>
@@ -5249,7 +5249,7 @@
           <p:cNvPr id="14" name="kv-value-4">
             <a:extLst xmlns:a="http://schemas.openxmlformats.org/drawingml/2006/main">
               <a:ext uri="{FF2B5EF4-FFF2-40B4-BE49-F238E27FC236}">
-                <a16:creationId xmlns:a16="http://schemas.microsoft.com/office/drawing/2014/main" id="{935C9F70-245F-4EB3-90B6-ADE2C4FE5908}"/>
+                <a16:creationId xmlns:a16="http://schemas.microsoft.com/office/drawing/2014/main" id="{84348430-36BD-4126-8E15-147B97DC45E8}"/>
               </a:ext>
             </a:extLst>
           </p:cNvPr>
@@ -5284,7 +5284,7 @@
                   <a:srgbClr val="333333"/>
                 </a:solidFill>
               </a:rPr>
-              <a:t>7 frozen traces, 5M warmup, 10M simulation</a:t>
+              <a:t>7 frozen traces, 20M warmup, 50M simulation</a:t>
             </a:r>
           </a:p>
         </p:txBody>
@@ -5294,7 +5294,7 @@
           <p:cNvPr id="15" name="kv-key-5">
             <a:extLst xmlns:a="http://schemas.openxmlformats.org/drawingml/2006/main">
               <a:ext uri="{FF2B5EF4-FFF2-40B4-BE49-F238E27FC236}">
-                <a16:creationId xmlns:a16="http://schemas.microsoft.com/office/drawing/2014/main" id="{AC1FD234-9931-4F6E-B41C-52D24CBAFC03}"/>
+                <a16:creationId xmlns:a16="http://schemas.microsoft.com/office/drawing/2014/main" id="{6BAB748D-F2BC-4CEC-9DAB-E99F89E6F2DB}"/>
               </a:ext>
             </a:extLst>
           </p:cNvPr>
@@ -5339,7 +5339,7 @@
           <p:cNvPr id="16" name="kv-value-5">
             <a:extLst xmlns:a="http://schemas.openxmlformats.org/drawingml/2006/main">
               <a:ext uri="{FF2B5EF4-FFF2-40B4-BE49-F238E27FC236}">
-                <a16:creationId xmlns:a16="http://schemas.microsoft.com/office/drawing/2014/main" id="{BD1C2DAE-624A-4C2C-961C-70A6DD06E168}"/>
+                <a16:creationId xmlns:a16="http://schemas.microsoft.com/office/drawing/2014/main" id="{AE6D3568-F4AC-49B4-930A-CE641F9E8C52}"/>
               </a:ext>
             </a:extLst>
           </p:cNvPr>
@@ -5384,7 +5384,7 @@
           <p:cNvPr id="17" name="eyebrow">
             <a:extLst xmlns:a="http://schemas.openxmlformats.org/drawingml/2006/main">
               <a:ext uri="{FF2B5EF4-FFF2-40B4-BE49-F238E27FC236}">
-                <a16:creationId xmlns:a16="http://schemas.microsoft.com/office/drawing/2014/main" id="{8B6D3605-E136-421B-81E8-093098DC94E6}"/>
+                <a16:creationId xmlns:a16="http://schemas.microsoft.com/office/drawing/2014/main" id="{5F40F179-B92B-48D6-8FE9-45B9B5C80093}"/>
               </a:ext>
             </a:extLst>
           </p:cNvPr>
@@ -5429,7 +5429,7 @@
           <p:cNvPr id="18" name="kv-key-0">
             <a:extLst xmlns:a="http://schemas.openxmlformats.org/drawingml/2006/main">
               <a:ext uri="{FF2B5EF4-FFF2-40B4-BE49-F238E27FC236}">
-                <a16:creationId xmlns:a16="http://schemas.microsoft.com/office/drawing/2014/main" id="{89DDBC26-EFE3-4633-BD3E-F333A1248A47}"/>
+                <a16:creationId xmlns:a16="http://schemas.microsoft.com/office/drawing/2014/main" id="{E2DB9935-67B4-4255-92A4-E9CE007B2375}"/>
               </a:ext>
             </a:extLst>
           </p:cNvPr>
@@ -5474,7 +5474,7 @@
           <p:cNvPr id="19" name="kv-value-0">
             <a:extLst xmlns:a="http://schemas.openxmlformats.org/drawingml/2006/main">
               <a:ext uri="{FF2B5EF4-FFF2-40B4-BE49-F238E27FC236}">
-                <a16:creationId xmlns:a16="http://schemas.microsoft.com/office/drawing/2014/main" id="{BAF24B4B-86D6-4FB0-A3FE-A6E9CAA2549E}"/>
+                <a16:creationId xmlns:a16="http://schemas.microsoft.com/office/drawing/2014/main" id="{9B0F37EC-0D37-4F75-8AC3-4CCEEFC7C3BE}"/>
               </a:ext>
             </a:extLst>
           </p:cNvPr>
@@ -5519,7 +5519,7 @@
           <p:cNvPr id="20" name="kv-key-1">
             <a:extLst xmlns:a="http://schemas.openxmlformats.org/drawingml/2006/main">
               <a:ext uri="{FF2B5EF4-FFF2-40B4-BE49-F238E27FC236}">
-                <a16:creationId xmlns:a16="http://schemas.microsoft.com/office/drawing/2014/main" id="{BCA53F19-9491-4842-B8CC-67E39F8F3C53}"/>
+                <a16:creationId xmlns:a16="http://schemas.microsoft.com/office/drawing/2014/main" id="{093968B8-D23A-445E-8133-84F04A8A673F}"/>
               </a:ext>
             </a:extLst>
           </p:cNvPr>
@@ -5564,7 +5564,7 @@
           <p:cNvPr id="21" name="kv-value-1">
             <a:extLst xmlns:a="http://schemas.openxmlformats.org/drawingml/2006/main">
               <a:ext uri="{FF2B5EF4-FFF2-40B4-BE49-F238E27FC236}">
-                <a16:creationId xmlns:a16="http://schemas.microsoft.com/office/drawing/2014/main" id="{025D7ABA-9CE7-4E4C-AF54-BC74CE917616}"/>
+                <a16:creationId xmlns:a16="http://schemas.microsoft.com/office/drawing/2014/main" id="{47DEF6A4-E9CE-4686-9669-DC1337B846A7}"/>
               </a:ext>
             </a:extLst>
           </p:cNvPr>
@@ -5609,7 +5609,7 @@
           <p:cNvPr id="22" name="kv-key-2">
             <a:extLst xmlns:a="http://schemas.openxmlformats.org/drawingml/2006/main">
               <a:ext uri="{FF2B5EF4-FFF2-40B4-BE49-F238E27FC236}">
-                <a16:creationId xmlns:a16="http://schemas.microsoft.com/office/drawing/2014/main" id="{DDC3A2E7-B947-402C-BDA7-A947D6688968}"/>
+                <a16:creationId xmlns:a16="http://schemas.microsoft.com/office/drawing/2014/main" id="{1DF7C7CE-9C38-4C7E-A87B-56025C812D1D}"/>
               </a:ext>
             </a:extLst>
           </p:cNvPr>
@@ -5654,7 +5654,7 @@
           <p:cNvPr id="23" name="kv-value-2">
             <a:extLst xmlns:a="http://schemas.openxmlformats.org/drawingml/2006/main">
               <a:ext uri="{FF2B5EF4-FFF2-40B4-BE49-F238E27FC236}">
-                <a16:creationId xmlns:a16="http://schemas.microsoft.com/office/drawing/2014/main" id="{25148564-F623-4EE4-AAA1-FF4F65F9817F}"/>
+                <a16:creationId xmlns:a16="http://schemas.microsoft.com/office/drawing/2014/main" id="{B69A4E08-8D25-4758-B6E6-7A10461A30D2}"/>
               </a:ext>
             </a:extLst>
           </p:cNvPr>
@@ -5699,7 +5699,7 @@
           <p:cNvPr id="24" name="kv-key-3">
             <a:extLst xmlns:a="http://schemas.openxmlformats.org/drawingml/2006/main">
               <a:ext uri="{FF2B5EF4-FFF2-40B4-BE49-F238E27FC236}">
-                <a16:creationId xmlns:a16="http://schemas.microsoft.com/office/drawing/2014/main" id="{4D35B150-0C4E-426B-9A6D-D88971AC735B}"/>
+                <a16:creationId xmlns:a16="http://schemas.microsoft.com/office/drawing/2014/main" id="{C6F28985-8F5E-480C-BF2A-F82F8CA9CF92}"/>
               </a:ext>
             </a:extLst>
           </p:cNvPr>
@@ -5744,7 +5744,7 @@
           <p:cNvPr id="25" name="kv-value-3">
             <a:extLst xmlns:a="http://schemas.openxmlformats.org/drawingml/2006/main">
               <a:ext uri="{FF2B5EF4-FFF2-40B4-BE49-F238E27FC236}">
-                <a16:creationId xmlns:a16="http://schemas.microsoft.com/office/drawing/2014/main" id="{5A28424C-E0B8-455E-A5AA-005AF752FE66}"/>
+                <a16:creationId xmlns:a16="http://schemas.microsoft.com/office/drawing/2014/main" id="{D36EC203-CCCA-4F61-AD1F-09E5E9D622AC}"/>
               </a:ext>
             </a:extLst>
           </p:cNvPr>
@@ -5787,7 +5787,7 @@
     </p:spTree>
     <p:extLst>
       <p:ext uri="{BB962C8B-B14F-4D97-AF65-F5344CB8AC3E}">
-        <p14:creationId xmlns:p14="http://schemas.microsoft.com/office/powerpoint/2010/main" val="1629506671"/>
+        <p14:creationId xmlns:p14="http://schemas.microsoft.com/office/powerpoint/2010/main" val="976175040"/>
       </p:ext>
     </p:extLst>
   </p:cSld>
@@ -5811,7 +5811,7 @@
           <p:cNvPr id="1" name="slide-title">
             <a:extLst xmlns:a="http://schemas.openxmlformats.org/drawingml/2006/main">
               <a:ext uri="{FF2B5EF4-FFF2-40B4-BE49-F238E27FC236}">
-                <a16:creationId xmlns:a16="http://schemas.microsoft.com/office/drawing/2014/main" id="{5A005F1A-ADF1-4885-98F3-38A0A8E38563}"/>
+                <a16:creationId xmlns:a16="http://schemas.microsoft.com/office/drawing/2014/main" id="{86CFC191-58D9-4EA4-A4C7-F16640FB5025}"/>
               </a:ext>
             </a:extLst>
           </p:cNvPr>
@@ -5856,7 +5856,7 @@
           <p:cNvPr id="2" name="slide-subtitle">
             <a:extLst xmlns:a="http://schemas.openxmlformats.org/drawingml/2006/main">
               <a:ext uri="{FF2B5EF4-FFF2-40B4-BE49-F238E27FC236}">
-                <a16:creationId xmlns:a16="http://schemas.microsoft.com/office/drawing/2014/main" id="{D660138E-AEB7-44D4-B250-667C08F67F60}"/>
+                <a16:creationId xmlns:a16="http://schemas.microsoft.com/office/drawing/2014/main" id="{5687E18B-30F2-49E1-B543-DA750F190563}"/>
               </a:ext>
             </a:extLst>
           </p:cNvPr>
@@ -5901,7 +5901,7 @@
           <p:cNvPr id="3" name="blank-title-peer">
             <a:extLst xmlns:a="http://schemas.openxmlformats.org/drawingml/2006/main">
               <a:ext uri="{FF2B5EF4-FFF2-40B4-BE49-F238E27FC236}">
-                <a16:creationId xmlns:a16="http://schemas.microsoft.com/office/drawing/2014/main" id="{2AD08C07-4517-4D70-8A67-8A27B4D1380E}"/>
+                <a16:creationId xmlns:a16="http://schemas.microsoft.com/office/drawing/2014/main" id="{64F8D736-9A73-4C15-9D81-693A4E69BAC8}"/>
               </a:ext>
             </a:extLst>
           </p:cNvPr>
@@ -5934,7 +5934,7 @@
           <p:cNvPr id="4" name="eyebrow">
             <a:extLst xmlns:a="http://schemas.openxmlformats.org/drawingml/2006/main">
               <a:ext uri="{FF2B5EF4-FFF2-40B4-BE49-F238E27FC236}">
-                <a16:creationId xmlns:a16="http://schemas.microsoft.com/office/drawing/2014/main" id="{A4EFFE9A-9472-42CD-BE4A-48A0B4FD5795}"/>
+                <a16:creationId xmlns:a16="http://schemas.microsoft.com/office/drawing/2014/main" id="{79CAF3EA-8747-46AF-9746-31CF9BEF6DC9}"/>
               </a:ext>
             </a:extLst>
           </p:cNvPr>
@@ -5979,7 +5979,7 @@
           <p:cNvPr id="5" name="kv-key-0">
             <a:extLst xmlns:a="http://schemas.openxmlformats.org/drawingml/2006/main">
               <a:ext uri="{FF2B5EF4-FFF2-40B4-BE49-F238E27FC236}">
-                <a16:creationId xmlns:a16="http://schemas.microsoft.com/office/drawing/2014/main" id="{7994DC74-97A8-4B25-9029-4B5B0E95740D}"/>
+                <a16:creationId xmlns:a16="http://schemas.microsoft.com/office/drawing/2014/main" id="{DF8CF6E2-2FF6-4B0F-8DB8-61DEA9F2760D}"/>
               </a:ext>
             </a:extLst>
           </p:cNvPr>
@@ -6024,7 +6024,7 @@
           <p:cNvPr id="6" name="kv-value-0">
             <a:extLst xmlns:a="http://schemas.openxmlformats.org/drawingml/2006/main">
               <a:ext uri="{FF2B5EF4-FFF2-40B4-BE49-F238E27FC236}">
-                <a16:creationId xmlns:a16="http://schemas.microsoft.com/office/drawing/2014/main" id="{B5E0F48A-B803-4699-9487-DAA2D917E5C8}"/>
+                <a16:creationId xmlns:a16="http://schemas.microsoft.com/office/drawing/2014/main" id="{B0B065DD-D56A-41F5-A5F9-CE8146EDBD66}"/>
               </a:ext>
             </a:extLst>
           </p:cNvPr>
@@ -6069,7 +6069,7 @@
           <p:cNvPr id="7" name="kv-key-1">
             <a:extLst xmlns:a="http://schemas.openxmlformats.org/drawingml/2006/main">
               <a:ext uri="{FF2B5EF4-FFF2-40B4-BE49-F238E27FC236}">
-                <a16:creationId xmlns:a16="http://schemas.microsoft.com/office/drawing/2014/main" id="{5B54FF3A-A06F-41E5-8ED0-1EC1F1DD8780}"/>
+                <a16:creationId xmlns:a16="http://schemas.microsoft.com/office/drawing/2014/main" id="{76CC022A-3268-4AA0-B8BD-F4EC24137417}"/>
               </a:ext>
             </a:extLst>
           </p:cNvPr>
@@ -6114,7 +6114,7 @@
           <p:cNvPr id="8" name="kv-value-1">
             <a:extLst xmlns:a="http://schemas.openxmlformats.org/drawingml/2006/main">
               <a:ext uri="{FF2B5EF4-FFF2-40B4-BE49-F238E27FC236}">
-                <a16:creationId xmlns:a16="http://schemas.microsoft.com/office/drawing/2014/main" id="{D0B33A59-8949-4951-BC0B-8931F439BD7A}"/>
+                <a16:creationId xmlns:a16="http://schemas.microsoft.com/office/drawing/2014/main" id="{ADA1218E-092B-4FF6-B9BA-7C615FCA3BB5}"/>
               </a:ext>
             </a:extLst>
           </p:cNvPr>
@@ -6159,7 +6159,7 @@
           <p:cNvPr id="9" name="kv-key-2">
             <a:extLst xmlns:a="http://schemas.openxmlformats.org/drawingml/2006/main">
               <a:ext uri="{FF2B5EF4-FFF2-40B4-BE49-F238E27FC236}">
-                <a16:creationId xmlns:a16="http://schemas.microsoft.com/office/drawing/2014/main" id="{7806F86E-4E85-45E2-BB1C-49D113B524E7}"/>
+                <a16:creationId xmlns:a16="http://schemas.microsoft.com/office/drawing/2014/main" id="{82626E9B-D602-46B0-80DC-A4DA072DBFAA}"/>
               </a:ext>
             </a:extLst>
           </p:cNvPr>
@@ -6204,7 +6204,7 @@
           <p:cNvPr id="10" name="kv-value-2">
             <a:extLst xmlns:a="http://schemas.openxmlformats.org/drawingml/2006/main">
               <a:ext uri="{FF2B5EF4-FFF2-40B4-BE49-F238E27FC236}">
-                <a16:creationId xmlns:a16="http://schemas.microsoft.com/office/drawing/2014/main" id="{33A504B3-52AE-44B9-9365-D3FCE7738F13}"/>
+                <a16:creationId xmlns:a16="http://schemas.microsoft.com/office/drawing/2014/main" id="{AF2CC740-8A13-4EA7-B977-CE7326C7845C}"/>
               </a:ext>
             </a:extLst>
           </p:cNvPr>
@@ -6249,7 +6249,7 @@
           <p:cNvPr id="11" name="kv-key-3">
             <a:extLst xmlns:a="http://schemas.openxmlformats.org/drawingml/2006/main">
               <a:ext uri="{FF2B5EF4-FFF2-40B4-BE49-F238E27FC236}">
-                <a16:creationId xmlns:a16="http://schemas.microsoft.com/office/drawing/2014/main" id="{8E7A434F-6CB6-4671-B820-BF4FD42A6C99}"/>
+                <a16:creationId xmlns:a16="http://schemas.microsoft.com/office/drawing/2014/main" id="{0D5C01E2-5DB2-4B36-843A-585C9C965E8A}"/>
               </a:ext>
             </a:extLst>
           </p:cNvPr>
@@ -6294,7 +6294,7 @@
           <p:cNvPr id="12" name="kv-value-3">
             <a:extLst xmlns:a="http://schemas.openxmlformats.org/drawingml/2006/main">
               <a:ext uri="{FF2B5EF4-FFF2-40B4-BE49-F238E27FC236}">
-                <a16:creationId xmlns:a16="http://schemas.microsoft.com/office/drawing/2014/main" id="{A12A95CF-EBAE-4E9A-B2AE-4BE2D79E5C2A}"/>
+                <a16:creationId xmlns:a16="http://schemas.microsoft.com/office/drawing/2014/main" id="{76E9A949-B4FF-465F-99B0-8435E7306A1C}"/>
               </a:ext>
             </a:extLst>
           </p:cNvPr>
@@ -6339,7 +6339,7 @@
           <p:cNvPr id="13" name="eyebrow">
             <a:extLst xmlns:a="http://schemas.openxmlformats.org/drawingml/2006/main">
               <a:ext uri="{FF2B5EF4-FFF2-40B4-BE49-F238E27FC236}">
-                <a16:creationId xmlns:a16="http://schemas.microsoft.com/office/drawing/2014/main" id="{CB5C914B-B0F7-4593-A68A-2DD723FD4545}"/>
+                <a16:creationId xmlns:a16="http://schemas.microsoft.com/office/drawing/2014/main" id="{73654540-B84B-4CED-A1B2-9C2919664450}"/>
               </a:ext>
             </a:extLst>
           </p:cNvPr>
@@ -6384,7 +6384,7 @@
           <p:cNvPr id="14" name="weighted-score-once">
             <a:extLst xmlns:a="http://schemas.openxmlformats.org/drawingml/2006/main">
               <a:ext uri="{FF2B5EF4-FFF2-40B4-BE49-F238E27FC236}">
-                <a16:creationId xmlns:a16="http://schemas.microsoft.com/office/drawing/2014/main" id="{CD5156AA-11B9-4506-903E-A10E756D8ABC}"/>
+                <a16:creationId xmlns:a16="http://schemas.microsoft.com/office/drawing/2014/main" id="{27054AF7-3C6C-4E51-9B61-6DB2084387DF}"/>
               </a:ext>
             </a:extLst>
           </p:cNvPr>
@@ -6429,7 +6429,7 @@
           <p:cNvPr id="15" name="failure-score">
             <a:extLst xmlns:a="http://schemas.openxmlformats.org/drawingml/2006/main">
               <a:ext uri="{FF2B5EF4-FFF2-40B4-BE49-F238E27FC236}">
-                <a16:creationId xmlns:a16="http://schemas.microsoft.com/office/drawing/2014/main" id="{DF68B3A7-DFC1-431E-B169-9097FDF35D84}"/>
+                <a16:creationId xmlns:a16="http://schemas.microsoft.com/office/drawing/2014/main" id="{48071911-700D-418D-9177-3D71CE1B3D2F}"/>
               </a:ext>
             </a:extLst>
           </p:cNvPr>
@@ -6474,7 +6474,7 @@
           <p:cNvPr id="16" name="table-cell-0-0">
             <a:extLst xmlns:a="http://schemas.openxmlformats.org/drawingml/2006/main">
               <a:ext uri="{FF2B5EF4-FFF2-40B4-BE49-F238E27FC236}">
-                <a16:creationId xmlns:a16="http://schemas.microsoft.com/office/drawing/2014/main" id="{6690AB9E-971F-4D71-A869-5E6CB316C81F}"/>
+                <a16:creationId xmlns:a16="http://schemas.microsoft.com/office/drawing/2014/main" id="{CACCA45C-ABC4-43B7-ABEF-2BB961191670}"/>
               </a:ext>
             </a:extLst>
           </p:cNvPr>
@@ -6519,7 +6519,7 @@
           <p:cNvPr id="17" name="table-cell-0-1">
             <a:extLst xmlns:a="http://schemas.openxmlformats.org/drawingml/2006/main">
               <a:ext uri="{FF2B5EF4-FFF2-40B4-BE49-F238E27FC236}">
-                <a16:creationId xmlns:a16="http://schemas.microsoft.com/office/drawing/2014/main" id="{41B7F7C0-9691-41CB-99CB-AFACF3A85923}"/>
+                <a16:creationId xmlns:a16="http://schemas.microsoft.com/office/drawing/2014/main" id="{6956F602-74B2-487C-B016-CA7A2AFC52D1}"/>
               </a:ext>
             </a:extLst>
           </p:cNvPr>
@@ -6564,7 +6564,7 @@
           <p:cNvPr id="18" name="table-cell-1-0">
             <a:extLst xmlns:a="http://schemas.openxmlformats.org/drawingml/2006/main">
               <a:ext uri="{FF2B5EF4-FFF2-40B4-BE49-F238E27FC236}">
-                <a16:creationId xmlns:a16="http://schemas.microsoft.com/office/drawing/2014/main" id="{3B207272-1225-4606-99D6-41A301B6BBE5}"/>
+                <a16:creationId xmlns:a16="http://schemas.microsoft.com/office/drawing/2014/main" id="{E4D352CC-6A7A-41E4-99FC-406AE784B355}"/>
               </a:ext>
             </a:extLst>
           </p:cNvPr>
@@ -6609,7 +6609,7 @@
           <p:cNvPr id="19" name="table-cell-1-1">
             <a:extLst xmlns:a="http://schemas.openxmlformats.org/drawingml/2006/main">
               <a:ext uri="{FF2B5EF4-FFF2-40B4-BE49-F238E27FC236}">
-                <a16:creationId xmlns:a16="http://schemas.microsoft.com/office/drawing/2014/main" id="{B48BADDC-85F5-4469-89F6-5DAFF099285B}"/>
+                <a16:creationId xmlns:a16="http://schemas.microsoft.com/office/drawing/2014/main" id="{44E0F255-DF26-4CCE-B5DB-3C866212A170}"/>
               </a:ext>
             </a:extLst>
           </p:cNvPr>
@@ -6654,7 +6654,7 @@
           <p:cNvPr id="20" name="table-cell-2-0">
             <a:extLst xmlns:a="http://schemas.openxmlformats.org/drawingml/2006/main">
               <a:ext uri="{FF2B5EF4-FFF2-40B4-BE49-F238E27FC236}">
-                <a16:creationId xmlns:a16="http://schemas.microsoft.com/office/drawing/2014/main" id="{BA93EFCB-E4D1-4FAA-BE54-C50D68F46D6F}"/>
+                <a16:creationId xmlns:a16="http://schemas.microsoft.com/office/drawing/2014/main" id="{508D4A43-CD18-4FAE-82EA-5F8E3BEBAADB}"/>
               </a:ext>
             </a:extLst>
           </p:cNvPr>
@@ -6699,7 +6699,7 @@
           <p:cNvPr id="21" name="table-cell-2-1">
             <a:extLst xmlns:a="http://schemas.openxmlformats.org/drawingml/2006/main">
               <a:ext uri="{FF2B5EF4-FFF2-40B4-BE49-F238E27FC236}">
-                <a16:creationId xmlns:a16="http://schemas.microsoft.com/office/drawing/2014/main" id="{6476A411-D3D4-44E1-8A1F-22D94D86A9FC}"/>
+                <a16:creationId xmlns:a16="http://schemas.microsoft.com/office/drawing/2014/main" id="{FA0D4409-9546-4ADD-BBCD-CEBE6B33D39B}"/>
               </a:ext>
             </a:extLst>
           </p:cNvPr>
@@ -6744,7 +6744,7 @@
           <p:cNvPr id="22" name="table-cell-3-0">
             <a:extLst xmlns:a="http://schemas.openxmlformats.org/drawingml/2006/main">
               <a:ext uri="{FF2B5EF4-FFF2-40B4-BE49-F238E27FC236}">
-                <a16:creationId xmlns:a16="http://schemas.microsoft.com/office/drawing/2014/main" id="{261A9238-137E-4DEC-8C48-CD6552808795}"/>
+                <a16:creationId xmlns:a16="http://schemas.microsoft.com/office/drawing/2014/main" id="{DEF9E4F9-B8E8-4AC1-A3C4-2C7413C73498}"/>
               </a:ext>
             </a:extLst>
           </p:cNvPr>
@@ -6789,7 +6789,7 @@
           <p:cNvPr id="23" name="table-cell-3-1">
             <a:extLst xmlns:a="http://schemas.openxmlformats.org/drawingml/2006/main">
               <a:ext uri="{FF2B5EF4-FFF2-40B4-BE49-F238E27FC236}">
-                <a16:creationId xmlns:a16="http://schemas.microsoft.com/office/drawing/2014/main" id="{C43905FE-2BA9-43B6-B660-2E26194EC121}"/>
+                <a16:creationId xmlns:a16="http://schemas.microsoft.com/office/drawing/2014/main" id="{8A86E380-0CDF-4D06-BBD5-0577F3F2B47C}"/>
               </a:ext>
             </a:extLst>
           </p:cNvPr>
@@ -6832,7 +6832,7 @@
     </p:spTree>
     <p:extLst>
       <p:ext uri="{BB962C8B-B14F-4D97-AF65-F5344CB8AC3E}">
-        <p14:creationId xmlns:p14="http://schemas.microsoft.com/office/powerpoint/2010/main" val="1480277898"/>
+        <p14:creationId xmlns:p14="http://schemas.microsoft.com/office/powerpoint/2010/main" val="1369690385"/>
       </p:ext>
     </p:extLst>
   </p:cSld>
@@ -6856,7 +6856,7 @@
           <p:cNvPr id="1" name="slide-title">
             <a:extLst xmlns:a="http://schemas.openxmlformats.org/drawingml/2006/main">
               <a:ext uri="{FF2B5EF4-FFF2-40B4-BE49-F238E27FC236}">
-                <a16:creationId xmlns:a16="http://schemas.microsoft.com/office/drawing/2014/main" id="{6ED328CC-E576-4B73-B7DF-E8BCFEC913FF}"/>
+                <a16:creationId xmlns:a16="http://schemas.microsoft.com/office/drawing/2014/main" id="{3F41FE88-FFE3-4AD0-9254-C0345DCE344E}"/>
               </a:ext>
             </a:extLst>
           </p:cNvPr>
@@ -6901,7 +6901,7 @@
           <p:cNvPr id="2" name="slide-subtitle">
             <a:extLst xmlns:a="http://schemas.openxmlformats.org/drawingml/2006/main">
               <a:ext uri="{FF2B5EF4-FFF2-40B4-BE49-F238E27FC236}">
-                <a16:creationId xmlns:a16="http://schemas.microsoft.com/office/drawing/2014/main" id="{BC22A08E-CAEA-4B82-952F-4EBC10E75248}"/>
+                <a16:creationId xmlns:a16="http://schemas.microsoft.com/office/drawing/2014/main" id="{033EF9E1-0991-4477-AA3B-A23FAC5F7FCE}"/>
               </a:ext>
             </a:extLst>
           </p:cNvPr>
@@ -6950,7 +6950,7 @@
           <p:nvPr/>
         </p:nvPicPr>
         <p:blipFill>
-          <a:blip xmlns:r="http://schemas.openxmlformats.org/officeDocument/2006/relationships" xmlns:a="http://schemas.openxmlformats.org/drawingml/2006/main" r:embed="Raaf501cc30324f11"/>
+          <a:blip xmlns:r="http://schemas.openxmlformats.org/officeDocument/2006/relationships" xmlns:a="http://schemas.openxmlformats.org/drawingml/2006/main" r:embed="Rb380cf374a9f4424"/>
           <a:stretch xmlns:a="http://schemas.openxmlformats.org/drawingml/2006/main"/>
         </p:blipFill>
         <p:spPr>
@@ -6968,7 +6968,7 @@
           <p:cNvPr id="4" name="figure-caption">
             <a:extLst xmlns:a="http://schemas.openxmlformats.org/drawingml/2006/main">
               <a:ext uri="{FF2B5EF4-FFF2-40B4-BE49-F238E27FC236}">
-                <a16:creationId xmlns:a16="http://schemas.microsoft.com/office/drawing/2014/main" id="{7C6EED1C-3422-47DA-9367-D504D04B91DB}"/>
+                <a16:creationId xmlns:a16="http://schemas.microsoft.com/office/drawing/2014/main" id="{0A53A81A-BA7B-438C-8D3B-29A13DFD516C}"/>
               </a:ext>
             </a:extLst>
           </p:cNvPr>
@@ -7011,7 +7011,7 @@
     </p:spTree>
     <p:extLst>
       <p:ext uri="{BB962C8B-B14F-4D97-AF65-F5344CB8AC3E}">
-        <p14:creationId xmlns:p14="http://schemas.microsoft.com/office/powerpoint/2010/main" val="1959500186"/>
+        <p14:creationId xmlns:p14="http://schemas.microsoft.com/office/powerpoint/2010/main" val="526221289"/>
       </p:ext>
     </p:extLst>
   </p:cSld>
@@ -7035,7 +7035,7 @@
           <p:cNvPr id="1" name="slide-title">
             <a:extLst xmlns:a="http://schemas.openxmlformats.org/drawingml/2006/main">
               <a:ext uri="{FF2B5EF4-FFF2-40B4-BE49-F238E27FC236}">
-                <a16:creationId xmlns:a16="http://schemas.microsoft.com/office/drawing/2014/main" id="{AF781B1E-C1E5-48F5-934F-865057EB528E}"/>
+                <a16:creationId xmlns:a16="http://schemas.microsoft.com/office/drawing/2014/main" id="{29D3492D-8C44-46DD-8C1B-0BD3C4E8BDC3}"/>
               </a:ext>
             </a:extLst>
           </p:cNvPr>
@@ -7080,7 +7080,7 @@
           <p:cNvPr id="2" name="slide-subtitle">
             <a:extLst xmlns:a="http://schemas.openxmlformats.org/drawingml/2006/main">
               <a:ext uri="{FF2B5EF4-FFF2-40B4-BE49-F238E27FC236}">
-                <a16:creationId xmlns:a16="http://schemas.microsoft.com/office/drawing/2014/main" id="{2FB6BBEC-5850-410B-A8F9-FABA11243B83}"/>
+                <a16:creationId xmlns:a16="http://schemas.microsoft.com/office/drawing/2014/main" id="{5A9F654F-ECF2-4569-B4C4-7BB5740DCE50}"/>
               </a:ext>
             </a:extLst>
           </p:cNvPr>
@@ -7125,7 +7125,7 @@
           <p:cNvPr id="3" name="blank-title-peer">
             <a:extLst xmlns:a="http://schemas.openxmlformats.org/drawingml/2006/main">
               <a:ext uri="{FF2B5EF4-FFF2-40B4-BE49-F238E27FC236}">
-                <a16:creationId xmlns:a16="http://schemas.microsoft.com/office/drawing/2014/main" id="{A2ADFCDB-2B26-447B-BEFE-3CAE2B059FCA}"/>
+                <a16:creationId xmlns:a16="http://schemas.microsoft.com/office/drawing/2014/main" id="{5F51615B-5B90-4878-8ED8-0A74699BB0AC}"/>
               </a:ext>
             </a:extLst>
           </p:cNvPr>
@@ -7158,7 +7158,7 @@
           <p:cNvPr id="4" name="table-cell-0-0">
             <a:extLst xmlns:a="http://schemas.openxmlformats.org/drawingml/2006/main">
               <a:ext uri="{FF2B5EF4-FFF2-40B4-BE49-F238E27FC236}">
-                <a16:creationId xmlns:a16="http://schemas.microsoft.com/office/drawing/2014/main" id="{8B4D2AAC-99FC-4A70-8FE0-AE978FBA1F4E}"/>
+                <a16:creationId xmlns:a16="http://schemas.microsoft.com/office/drawing/2014/main" id="{D871B340-4557-4BEA-BAD1-39E4EAFD87B5}"/>
               </a:ext>
             </a:extLst>
           </p:cNvPr>
@@ -7203,7 +7203,7 @@
           <p:cNvPr id="5" name="table-cell-0-1">
             <a:extLst xmlns:a="http://schemas.openxmlformats.org/drawingml/2006/main">
               <a:ext uri="{FF2B5EF4-FFF2-40B4-BE49-F238E27FC236}">
-                <a16:creationId xmlns:a16="http://schemas.microsoft.com/office/drawing/2014/main" id="{C48AA4B9-3C96-480B-92A8-500D1DD3E06C}"/>
+                <a16:creationId xmlns:a16="http://schemas.microsoft.com/office/drawing/2014/main" id="{5A0DCF1A-FE05-4BD4-BA0C-00FFD81682D1}"/>
               </a:ext>
             </a:extLst>
           </p:cNvPr>
@@ -7248,7 +7248,7 @@
           <p:cNvPr id="6" name="table-cell-0-2">
             <a:extLst xmlns:a="http://schemas.openxmlformats.org/drawingml/2006/main">
               <a:ext uri="{FF2B5EF4-FFF2-40B4-BE49-F238E27FC236}">
-                <a16:creationId xmlns:a16="http://schemas.microsoft.com/office/drawing/2014/main" id="{0BB9844C-C88A-409D-96B6-675E1DFA591D}"/>
+                <a16:creationId xmlns:a16="http://schemas.microsoft.com/office/drawing/2014/main" id="{092C0BF4-3746-47AF-B996-9BAA3BCA2642}"/>
               </a:ext>
             </a:extLst>
           </p:cNvPr>
@@ -7293,7 +7293,7 @@
           <p:cNvPr id="7" name="table-cell-0-3">
             <a:extLst xmlns:a="http://schemas.openxmlformats.org/drawingml/2006/main">
               <a:ext uri="{FF2B5EF4-FFF2-40B4-BE49-F238E27FC236}">
-                <a16:creationId xmlns:a16="http://schemas.microsoft.com/office/drawing/2014/main" id="{516A4FA6-922A-4B42-A956-FAF0E26B88E6}"/>
+                <a16:creationId xmlns:a16="http://schemas.microsoft.com/office/drawing/2014/main" id="{84033753-E2CB-43C0-A77F-0B6003776753}"/>
               </a:ext>
             </a:extLst>
           </p:cNvPr>
@@ -7338,7 +7338,7 @@
           <p:cNvPr id="8" name="table-cell-1-0">
             <a:extLst xmlns:a="http://schemas.openxmlformats.org/drawingml/2006/main">
               <a:ext uri="{FF2B5EF4-FFF2-40B4-BE49-F238E27FC236}">
-                <a16:creationId xmlns:a16="http://schemas.microsoft.com/office/drawing/2014/main" id="{445DEFDE-FB76-4357-98F1-C19F3A1DBDD6}"/>
+                <a16:creationId xmlns:a16="http://schemas.microsoft.com/office/drawing/2014/main" id="{5941F71B-F1C1-4120-81FE-11EA76C791C4}"/>
               </a:ext>
             </a:extLst>
           </p:cNvPr>
@@ -7383,7 +7383,7 @@
           <p:cNvPr id="9" name="table-cell-1-1">
             <a:extLst xmlns:a="http://schemas.openxmlformats.org/drawingml/2006/main">
               <a:ext uri="{FF2B5EF4-FFF2-40B4-BE49-F238E27FC236}">
-                <a16:creationId xmlns:a16="http://schemas.microsoft.com/office/drawing/2014/main" id="{ED21A7BE-F3DE-457F-ABD3-FB69327A6227}"/>
+                <a16:creationId xmlns:a16="http://schemas.microsoft.com/office/drawing/2014/main" id="{64552D58-4969-4578-91D0-5052D26C5E34}"/>
               </a:ext>
             </a:extLst>
           </p:cNvPr>
@@ -7428,7 +7428,7 @@
           <p:cNvPr id="10" name="table-cell-1-2">
             <a:extLst xmlns:a="http://schemas.openxmlformats.org/drawingml/2006/main">
               <a:ext uri="{FF2B5EF4-FFF2-40B4-BE49-F238E27FC236}">
-                <a16:creationId xmlns:a16="http://schemas.microsoft.com/office/drawing/2014/main" id="{2D882489-B346-4728-9969-EB75C506962B}"/>
+                <a16:creationId xmlns:a16="http://schemas.microsoft.com/office/drawing/2014/main" id="{B4FB61FA-1FC2-4040-B8E0-91557C6891D4}"/>
               </a:ext>
             </a:extLst>
           </p:cNvPr>
@@ -7473,7 +7473,7 @@
           <p:cNvPr id="11" name="table-cell-1-3">
             <a:extLst xmlns:a="http://schemas.openxmlformats.org/drawingml/2006/main">
               <a:ext uri="{FF2B5EF4-FFF2-40B4-BE49-F238E27FC236}">
-                <a16:creationId xmlns:a16="http://schemas.microsoft.com/office/drawing/2014/main" id="{1E0452D9-DA42-4E0E-9B3A-735EA9D6FD09}"/>
+                <a16:creationId xmlns:a16="http://schemas.microsoft.com/office/drawing/2014/main" id="{64FDB3BE-D363-48F7-95A1-F758D4359E19}"/>
               </a:ext>
             </a:extLst>
           </p:cNvPr>
@@ -7518,7 +7518,7 @@
           <p:cNvPr id="12" name="table-cell-2-0">
             <a:extLst xmlns:a="http://schemas.openxmlformats.org/drawingml/2006/main">
               <a:ext uri="{FF2B5EF4-FFF2-40B4-BE49-F238E27FC236}">
-                <a16:creationId xmlns:a16="http://schemas.microsoft.com/office/drawing/2014/main" id="{6C051DB9-4C9E-4CBD-A8B1-D6ED96BF525B}"/>
+                <a16:creationId xmlns:a16="http://schemas.microsoft.com/office/drawing/2014/main" id="{A72EE4AE-AC8B-4F7F-880F-C38B372130F4}"/>
               </a:ext>
             </a:extLst>
           </p:cNvPr>
@@ -7563,7 +7563,7 @@
           <p:cNvPr id="13" name="table-cell-2-1">
             <a:extLst xmlns:a="http://schemas.openxmlformats.org/drawingml/2006/main">
               <a:ext uri="{FF2B5EF4-FFF2-40B4-BE49-F238E27FC236}">
-                <a16:creationId xmlns:a16="http://schemas.microsoft.com/office/drawing/2014/main" id="{07B3D406-4677-4F45-811F-023C98714DB2}"/>
+                <a16:creationId xmlns:a16="http://schemas.microsoft.com/office/drawing/2014/main" id="{B43144A4-BE2F-4D11-A242-A584587327A3}"/>
               </a:ext>
             </a:extLst>
           </p:cNvPr>
@@ -7608,7 +7608,7 @@
           <p:cNvPr id="14" name="table-cell-2-2">
             <a:extLst xmlns:a="http://schemas.openxmlformats.org/drawingml/2006/main">
               <a:ext uri="{FF2B5EF4-FFF2-40B4-BE49-F238E27FC236}">
-                <a16:creationId xmlns:a16="http://schemas.microsoft.com/office/drawing/2014/main" id="{B16A879C-CFEA-4546-9A04-3351ED4B39E2}"/>
+                <a16:creationId xmlns:a16="http://schemas.microsoft.com/office/drawing/2014/main" id="{6EE6C936-9AF7-468D-BB8C-DADE0C972256}"/>
               </a:ext>
             </a:extLst>
           </p:cNvPr>
@@ -7653,7 +7653,7 @@
           <p:cNvPr id="15" name="table-cell-2-3">
             <a:extLst xmlns:a="http://schemas.openxmlformats.org/drawingml/2006/main">
               <a:ext uri="{FF2B5EF4-FFF2-40B4-BE49-F238E27FC236}">
-                <a16:creationId xmlns:a16="http://schemas.microsoft.com/office/drawing/2014/main" id="{5FD60A3D-984C-4444-9E30-B92DB3E92BF3}"/>
+                <a16:creationId xmlns:a16="http://schemas.microsoft.com/office/drawing/2014/main" id="{99F204DA-9DCC-4893-BA8B-EA81807A7A7B}"/>
               </a:ext>
             </a:extLst>
           </p:cNvPr>
@@ -7698,7 +7698,7 @@
           <p:cNvPr id="16" name="table-cell-3-0">
             <a:extLst xmlns:a="http://schemas.openxmlformats.org/drawingml/2006/main">
               <a:ext uri="{FF2B5EF4-FFF2-40B4-BE49-F238E27FC236}">
-                <a16:creationId xmlns:a16="http://schemas.microsoft.com/office/drawing/2014/main" id="{894D0867-ABF1-4759-86D3-F973B461CD20}"/>
+                <a16:creationId xmlns:a16="http://schemas.microsoft.com/office/drawing/2014/main" id="{AC2F94E5-D215-4F75-B1A7-BA88176AC151}"/>
               </a:ext>
             </a:extLst>
           </p:cNvPr>
@@ -7743,7 +7743,7 @@
           <p:cNvPr id="17" name="table-cell-3-1">
             <a:extLst xmlns:a="http://schemas.openxmlformats.org/drawingml/2006/main">
               <a:ext uri="{FF2B5EF4-FFF2-40B4-BE49-F238E27FC236}">
-                <a16:creationId xmlns:a16="http://schemas.microsoft.com/office/drawing/2014/main" id="{9C5E8A52-B994-43D4-BA78-0BFA750F2D67}"/>
+                <a16:creationId xmlns:a16="http://schemas.microsoft.com/office/drawing/2014/main" id="{7C234CBA-15C7-46FE-85EC-D97060F9E148}"/>
               </a:ext>
             </a:extLst>
           </p:cNvPr>
@@ -7788,7 +7788,7 @@
           <p:cNvPr id="18" name="table-cell-3-2">
             <a:extLst xmlns:a="http://schemas.openxmlformats.org/drawingml/2006/main">
               <a:ext uri="{FF2B5EF4-FFF2-40B4-BE49-F238E27FC236}">
-                <a16:creationId xmlns:a16="http://schemas.microsoft.com/office/drawing/2014/main" id="{F6446B24-5345-47C5-95E3-40E7169070A2}"/>
+                <a16:creationId xmlns:a16="http://schemas.microsoft.com/office/drawing/2014/main" id="{B6AE3985-71B2-4911-87ED-AF977FA03B5D}"/>
               </a:ext>
             </a:extLst>
           </p:cNvPr>
@@ -7833,7 +7833,7 @@
           <p:cNvPr id="19" name="table-cell-3-3">
             <a:extLst xmlns:a="http://schemas.openxmlformats.org/drawingml/2006/main">
               <a:ext uri="{FF2B5EF4-FFF2-40B4-BE49-F238E27FC236}">
-                <a16:creationId xmlns:a16="http://schemas.microsoft.com/office/drawing/2014/main" id="{B3D2F2ED-D77B-491F-B317-1505CB03F779}"/>
+                <a16:creationId xmlns:a16="http://schemas.microsoft.com/office/drawing/2014/main" id="{BDF2880A-942F-4A17-8EF3-00A0C773D17E}"/>
               </a:ext>
             </a:extLst>
           </p:cNvPr>
@@ -7866,7 +7866,7 @@
           <p:cNvPr id="20" name="table-cell-4-0">
             <a:extLst xmlns:a="http://schemas.openxmlformats.org/drawingml/2006/main">
               <a:ext uri="{FF2B5EF4-FFF2-40B4-BE49-F238E27FC236}">
-                <a16:creationId xmlns:a16="http://schemas.microsoft.com/office/drawing/2014/main" id="{9F65F736-ADDA-42F4-8E97-8967BC2BA441}"/>
+                <a16:creationId xmlns:a16="http://schemas.microsoft.com/office/drawing/2014/main" id="{01A74FC8-E538-46ED-8A56-AC9AB6B9CDDD}"/>
               </a:ext>
             </a:extLst>
           </p:cNvPr>
@@ -7911,7 +7911,7 @@
           <p:cNvPr id="21" name="table-cell-4-1">
             <a:extLst xmlns:a="http://schemas.openxmlformats.org/drawingml/2006/main">
               <a:ext uri="{FF2B5EF4-FFF2-40B4-BE49-F238E27FC236}">
-                <a16:creationId xmlns:a16="http://schemas.microsoft.com/office/drawing/2014/main" id="{2108766B-28FC-405A-B55A-3E7CB60A3194}"/>
+                <a16:creationId xmlns:a16="http://schemas.microsoft.com/office/drawing/2014/main" id="{DA5273F6-B2AE-46C4-8D9D-555D71253013}"/>
               </a:ext>
             </a:extLst>
           </p:cNvPr>
@@ -7956,7 +7956,7 @@
           <p:cNvPr id="22" name="table-cell-4-2">
             <a:extLst xmlns:a="http://schemas.openxmlformats.org/drawingml/2006/main">
               <a:ext uri="{FF2B5EF4-FFF2-40B4-BE49-F238E27FC236}">
-                <a16:creationId xmlns:a16="http://schemas.microsoft.com/office/drawing/2014/main" id="{322DB0A4-8DC7-40BD-9EF8-867CE5103102}"/>
+                <a16:creationId xmlns:a16="http://schemas.microsoft.com/office/drawing/2014/main" id="{CC742F1B-0C59-4AE9-A656-F60CBD90C8B3}"/>
               </a:ext>
             </a:extLst>
           </p:cNvPr>
@@ -8001,7 +8001,7 @@
           <p:cNvPr id="23" name="table-cell-4-3">
             <a:extLst xmlns:a="http://schemas.openxmlformats.org/drawingml/2006/main">
               <a:ext uri="{FF2B5EF4-FFF2-40B4-BE49-F238E27FC236}">
-                <a16:creationId xmlns:a16="http://schemas.microsoft.com/office/drawing/2014/main" id="{75345447-C730-4C32-84F1-A67EAE5FC567}"/>
+                <a16:creationId xmlns:a16="http://schemas.microsoft.com/office/drawing/2014/main" id="{A2CA0C56-B0F2-481E-80B0-6DD39971B660}"/>
               </a:ext>
             </a:extLst>
           </p:cNvPr>
@@ -8034,7 +8034,7 @@
           <p:cNvPr id="24" name="table-cell-5-0">
             <a:extLst xmlns:a="http://schemas.openxmlformats.org/drawingml/2006/main">
               <a:ext uri="{FF2B5EF4-FFF2-40B4-BE49-F238E27FC236}">
-                <a16:creationId xmlns:a16="http://schemas.microsoft.com/office/drawing/2014/main" id="{7466C51C-3E23-44EB-A10F-6E0E3B8CC85B}"/>
+                <a16:creationId xmlns:a16="http://schemas.microsoft.com/office/drawing/2014/main" id="{B950C290-44D5-4267-8008-22E2ED8D5CC7}"/>
               </a:ext>
             </a:extLst>
           </p:cNvPr>
@@ -8079,7 +8079,7 @@
           <p:cNvPr id="25" name="table-cell-5-1">
             <a:extLst xmlns:a="http://schemas.openxmlformats.org/drawingml/2006/main">
               <a:ext uri="{FF2B5EF4-FFF2-40B4-BE49-F238E27FC236}">
-                <a16:creationId xmlns:a16="http://schemas.microsoft.com/office/drawing/2014/main" id="{62C05943-8713-40A5-A45F-BFC63CCB3192}"/>
+                <a16:creationId xmlns:a16="http://schemas.microsoft.com/office/drawing/2014/main" id="{747AFA6F-BC0B-4DE5-99FE-D5F0D49EC5B8}"/>
               </a:ext>
             </a:extLst>
           </p:cNvPr>
@@ -8124,7 +8124,7 @@
           <p:cNvPr id="26" name="table-cell-5-2">
             <a:extLst xmlns:a="http://schemas.openxmlformats.org/drawingml/2006/main">
               <a:ext uri="{FF2B5EF4-FFF2-40B4-BE49-F238E27FC236}">
-                <a16:creationId xmlns:a16="http://schemas.microsoft.com/office/drawing/2014/main" id="{2BC7208B-D638-451B-95BE-25534808D169}"/>
+                <a16:creationId xmlns:a16="http://schemas.microsoft.com/office/drawing/2014/main" id="{57B37538-DA99-42DE-92C3-6FCB7E392BE5}"/>
               </a:ext>
             </a:extLst>
           </p:cNvPr>
@@ -8169,7 +8169,7 @@
           <p:cNvPr id="27" name="table-cell-5-3">
             <a:extLst xmlns:a="http://schemas.openxmlformats.org/drawingml/2006/main">
               <a:ext uri="{FF2B5EF4-FFF2-40B4-BE49-F238E27FC236}">
-                <a16:creationId xmlns:a16="http://schemas.microsoft.com/office/drawing/2014/main" id="{92F72B7C-4C24-4518-B4CF-EC11DDB799BB}"/>
+                <a16:creationId xmlns:a16="http://schemas.microsoft.com/office/drawing/2014/main" id="{A0C4EFB9-039E-4332-BAC8-19EEA074E621}"/>
               </a:ext>
             </a:extLst>
           </p:cNvPr>
@@ -8214,7 +8214,7 @@
           <p:cNvPr id="28" name="table-cell-6-0">
             <a:extLst xmlns:a="http://schemas.openxmlformats.org/drawingml/2006/main">
               <a:ext uri="{FF2B5EF4-FFF2-40B4-BE49-F238E27FC236}">
-                <a16:creationId xmlns:a16="http://schemas.microsoft.com/office/drawing/2014/main" id="{A903CA7A-F37C-4D1C-AD94-ADDBE57584C6}"/>
+                <a16:creationId xmlns:a16="http://schemas.microsoft.com/office/drawing/2014/main" id="{25A16DBA-479F-423A-BBBD-853DBE51E926}"/>
               </a:ext>
             </a:extLst>
           </p:cNvPr>
@@ -8259,7 +8259,7 @@
           <p:cNvPr id="29" name="table-cell-6-1">
             <a:extLst xmlns:a="http://schemas.openxmlformats.org/drawingml/2006/main">
               <a:ext uri="{FF2B5EF4-FFF2-40B4-BE49-F238E27FC236}">
-                <a16:creationId xmlns:a16="http://schemas.microsoft.com/office/drawing/2014/main" id="{EFF0E0FC-0EF9-407F-ADF2-2DA828D2384D}"/>
+                <a16:creationId xmlns:a16="http://schemas.microsoft.com/office/drawing/2014/main" id="{D9041AB9-4A6D-48B7-B403-481D739659C5}"/>
               </a:ext>
             </a:extLst>
           </p:cNvPr>
@@ -8304,7 +8304,7 @@
           <p:cNvPr id="30" name="table-cell-6-2">
             <a:extLst xmlns:a="http://schemas.openxmlformats.org/drawingml/2006/main">
               <a:ext uri="{FF2B5EF4-FFF2-40B4-BE49-F238E27FC236}">
-                <a16:creationId xmlns:a16="http://schemas.microsoft.com/office/drawing/2014/main" id="{251E8587-58AD-47F0-8504-0E461AF24D19}"/>
+                <a16:creationId xmlns:a16="http://schemas.microsoft.com/office/drawing/2014/main" id="{9C2ACD46-2573-43CE-9B00-BB6C865A4C21}"/>
               </a:ext>
             </a:extLst>
           </p:cNvPr>
@@ -8349,7 +8349,7 @@
           <p:cNvPr id="31" name="table-cell-6-3">
             <a:extLst xmlns:a="http://schemas.openxmlformats.org/drawingml/2006/main">
               <a:ext uri="{FF2B5EF4-FFF2-40B4-BE49-F238E27FC236}">
-                <a16:creationId xmlns:a16="http://schemas.microsoft.com/office/drawing/2014/main" id="{6A4D1EBA-430D-413A-AB52-DBA9A761A3CE}"/>
+                <a16:creationId xmlns:a16="http://schemas.microsoft.com/office/drawing/2014/main" id="{78162BB3-C19E-4CBB-B123-30BF737DC873}"/>
               </a:ext>
             </a:extLst>
           </p:cNvPr>
@@ -8394,7 +8394,7 @@
           <p:cNvPr id="32" name="cycle-interpretation">
             <a:extLst xmlns:a="http://schemas.openxmlformats.org/drawingml/2006/main">
               <a:ext uri="{FF2B5EF4-FFF2-40B4-BE49-F238E27FC236}">
-                <a16:creationId xmlns:a16="http://schemas.microsoft.com/office/drawing/2014/main" id="{F119884A-98DE-45E8-8C21-C5827C7A8438}"/>
+                <a16:creationId xmlns:a16="http://schemas.microsoft.com/office/drawing/2014/main" id="{A4C85464-2900-4C82-8EC4-E983D048CA70}"/>
               </a:ext>
             </a:extLst>
           </p:cNvPr>
@@ -8443,13 +8443,13 @@
           <p:nvPr/>
         </p:nvPicPr>
         <p:blipFill>
-          <a:blip xmlns:r="http://schemas.openxmlformats.org/officeDocument/2006/relationships" xmlns:a="http://schemas.openxmlformats.org/drawingml/2006/main" r:embed="R10a37459e78b4735"/>
+          <a:blip xmlns:r="http://schemas.openxmlformats.org/officeDocument/2006/relationships" xmlns:a="http://schemas.openxmlformats.org/drawingml/2006/main" r:embed="Rb5dc7e2ec6da4dfb"/>
           <a:stretch xmlns:a="http://schemas.openxmlformats.org/drawingml/2006/main"/>
         </p:blipFill>
         <p:spPr>
           <a:xfrm xmlns:a="http://schemas.openxmlformats.org/drawingml/2006/main">
-            <a:off x="9719141" y="2506980"/>
-            <a:ext cx="6548967" cy="6736080"/>
+            <a:off x="8385048" y="4199174"/>
+            <a:ext cx="9217152" cy="3351692"/>
           </a:xfrm>
           <a:prstGeom xmlns:a="http://schemas.openxmlformats.org/drawingml/2006/main" prst="rect">
             <a:avLst/>
@@ -8461,7 +8461,7 @@
           <p:cNvPr id="34" name="figure-caption">
             <a:extLst xmlns:a="http://schemas.openxmlformats.org/drawingml/2006/main">
               <a:ext uri="{FF2B5EF4-FFF2-40B4-BE49-F238E27FC236}">
-                <a16:creationId xmlns:a16="http://schemas.microsoft.com/office/drawing/2014/main" id="{40F56903-A958-4320-960D-0C85942C1420}"/>
+                <a16:creationId xmlns:a16="http://schemas.microsoft.com/office/drawing/2014/main" id="{EE38AC5C-1314-4A51-BE19-9723E5813D9C}"/>
               </a:ext>
             </a:extLst>
           </p:cNvPr>
@@ -8496,7 +8496,7 @@
                   <a:srgbClr val="333333"/>
                 </a:solidFill>
               </a:rPr>
-              <a:t>Caption: Blue rows are trace-level wins versus the best single prefetcher. Pink rows are losses. The mixed pattern motivates the measured heldout claim.</a:t>
+              <a:t>Caption: The routing-behavior plot uses final run summaries to show selected-epoch share, budget share, and useful-prefetch share for MoP-V1 and MoP-V2.</a:t>
             </a:r>
           </a:p>
         </p:txBody>
@@ -8504,7 +8504,7 @@
     </p:spTree>
     <p:extLst>
       <p:ext uri="{BB962C8B-B14F-4D97-AF65-F5344CB8AC3E}">
-        <p14:creationId xmlns:p14="http://schemas.microsoft.com/office/powerpoint/2010/main" val="992697647"/>
+        <p14:creationId xmlns:p14="http://schemas.microsoft.com/office/powerpoint/2010/main" val="1760234571"/>
       </p:ext>
     </p:extLst>
   </p:cSld>
@@ -8528,7 +8528,7 @@
           <p:cNvPr id="1" name="slide-title">
             <a:extLst xmlns:a="http://schemas.openxmlformats.org/drawingml/2006/main">
               <a:ext uri="{FF2B5EF4-FFF2-40B4-BE49-F238E27FC236}">
-                <a16:creationId xmlns:a16="http://schemas.microsoft.com/office/drawing/2014/main" id="{1EC3C76F-942D-4A3E-AD5A-7A4F8F462A95}"/>
+                <a16:creationId xmlns:a16="http://schemas.microsoft.com/office/drawing/2014/main" id="{84DCF3BD-6DC0-4966-A200-FBBF213A73CF}"/>
               </a:ext>
             </a:extLst>
           </p:cNvPr>
@@ -8573,7 +8573,7 @@
           <p:cNvPr id="2" name="slide-subtitle">
             <a:extLst xmlns:a="http://schemas.openxmlformats.org/drawingml/2006/main">
               <a:ext uri="{FF2B5EF4-FFF2-40B4-BE49-F238E27FC236}">
-                <a16:creationId xmlns:a16="http://schemas.microsoft.com/office/drawing/2014/main" id="{E2DFFD75-06A7-4AA8-9DE8-00F8933D5338}"/>
+                <a16:creationId xmlns:a16="http://schemas.microsoft.com/office/drawing/2014/main" id="{A5A92373-279C-47D4-98A3-43CC57B3B714}"/>
               </a:ext>
             </a:extLst>
           </p:cNvPr>
@@ -8622,7 +8622,7 @@
           <p:nvPr/>
         </p:nvPicPr>
         <p:blipFill>
-          <a:blip xmlns:r="http://schemas.openxmlformats.org/officeDocument/2006/relationships" xmlns:a="http://schemas.openxmlformats.org/drawingml/2006/main" r:embed="R6850a710d81f442f"/>
+          <a:blip xmlns:r="http://schemas.openxmlformats.org/officeDocument/2006/relationships" xmlns:a="http://schemas.openxmlformats.org/drawingml/2006/main" r:embed="R3d143dc0a7014f4c"/>
           <a:stretch xmlns:a="http://schemas.openxmlformats.org/drawingml/2006/main"/>
         </p:blipFill>
         <p:spPr>
@@ -8640,7 +8640,7 @@
           <p:cNvPr id="4" name="figure-caption">
             <a:extLst xmlns:a="http://schemas.openxmlformats.org/drawingml/2006/main">
               <a:ext uri="{FF2B5EF4-FFF2-40B4-BE49-F238E27FC236}">
-                <a16:creationId xmlns:a16="http://schemas.microsoft.com/office/drawing/2014/main" id="{98CBA306-07AC-49D2-B175-BAE9D8259FB9}"/>
+                <a16:creationId xmlns:a16="http://schemas.microsoft.com/office/drawing/2014/main" id="{9217AC30-5708-4ABE-8B56-B51AF71FF79E}"/>
               </a:ext>
             </a:extLst>
           </p:cNvPr>
@@ -8683,7 +8683,7 @@
     </p:spTree>
     <p:extLst>
       <p:ext uri="{BB962C8B-B14F-4D97-AF65-F5344CB8AC3E}">
-        <p14:creationId xmlns:p14="http://schemas.microsoft.com/office/powerpoint/2010/main" val="849945082"/>
+        <p14:creationId xmlns:p14="http://schemas.microsoft.com/office/powerpoint/2010/main" val="922095"/>
       </p:ext>
     </p:extLst>
   </p:cSld>
@@ -8707,7 +8707,7 @@
           <p:cNvPr id="1" name="slide-title">
             <a:extLst xmlns:a="http://schemas.openxmlformats.org/drawingml/2006/main">
               <a:ext uri="{FF2B5EF4-FFF2-40B4-BE49-F238E27FC236}">
-                <a16:creationId xmlns:a16="http://schemas.microsoft.com/office/drawing/2014/main" id="{458C5396-004E-4B11-99F1-2C114A1FA470}"/>
+                <a16:creationId xmlns:a16="http://schemas.microsoft.com/office/drawing/2014/main" id="{1659096C-D748-4C29-8470-11412B8FE806}"/>
               </a:ext>
             </a:extLst>
           </p:cNvPr>
@@ -8752,7 +8752,7 @@
           <p:cNvPr id="2" name="slide-subtitle">
             <a:extLst xmlns:a="http://schemas.openxmlformats.org/drawingml/2006/main">
               <a:ext uri="{FF2B5EF4-FFF2-40B4-BE49-F238E27FC236}">
-                <a16:creationId xmlns:a16="http://schemas.microsoft.com/office/drawing/2014/main" id="{A5717F81-E5D8-4752-AA6B-BACEE8BFC753}"/>
+                <a16:creationId xmlns:a16="http://schemas.microsoft.com/office/drawing/2014/main" id="{8885EFE9-0F2D-414B-BCE7-663A2EE2A91D}"/>
               </a:ext>
             </a:extLst>
           </p:cNvPr>
@@ -8797,7 +8797,7 @@
           <p:cNvPr id="3" name="blank-title-peer">
             <a:extLst xmlns:a="http://schemas.openxmlformats.org/drawingml/2006/main">
               <a:ext uri="{FF2B5EF4-FFF2-40B4-BE49-F238E27FC236}">
-                <a16:creationId xmlns:a16="http://schemas.microsoft.com/office/drawing/2014/main" id="{99DD63D3-5AC1-49FE-BC6A-0139D6E20CE8}"/>
+                <a16:creationId xmlns:a16="http://schemas.microsoft.com/office/drawing/2014/main" id="{E0332470-6F93-4E5F-9366-3BA898C3A1FC}"/>
               </a:ext>
             </a:extLst>
           </p:cNvPr>
@@ -8834,13 +8834,13 @@
           <p:nvPr/>
         </p:nvPicPr>
         <p:blipFill>
-          <a:blip xmlns:r="http://schemas.openxmlformats.org/officeDocument/2006/relationships" xmlns:a="http://schemas.openxmlformats.org/drawingml/2006/main" r:embed="R682a2120eb134db2"/>
+          <a:blip xmlns:r="http://schemas.openxmlformats.org/officeDocument/2006/relationships" xmlns:a="http://schemas.openxmlformats.org/drawingml/2006/main" r:embed="Re1e4a51457ad4b60"/>
           <a:stretch xmlns:a="http://schemas.openxmlformats.org/drawingml/2006/main"/>
         </p:blipFill>
         <p:spPr>
           <a:xfrm xmlns:a="http://schemas.openxmlformats.org/drawingml/2006/main">
-            <a:off x="1391690" y="2506980"/>
-            <a:ext cx="8025114" cy="6736080"/>
+            <a:off x="666750" y="3358225"/>
+            <a:ext cx="9474994" cy="5033590"/>
           </a:xfrm>
           <a:prstGeom xmlns:a="http://schemas.openxmlformats.org/drawingml/2006/main" prst="rect">
             <a:avLst/>
@@ -8852,7 +8852,7 @@
           <p:cNvPr id="5" name="figure-caption">
             <a:extLst xmlns:a="http://schemas.openxmlformats.org/drawingml/2006/main">
               <a:ext uri="{FF2B5EF4-FFF2-40B4-BE49-F238E27FC236}">
-                <a16:creationId xmlns:a16="http://schemas.microsoft.com/office/drawing/2014/main" id="{1F6E7F3C-ACFE-4617-8E01-0BC5AAD04D53}"/>
+                <a16:creationId xmlns:a16="http://schemas.microsoft.com/office/drawing/2014/main" id="{1007CCC1-F006-4942-B605-F98E96690C6D}"/>
               </a:ext>
             </a:extLst>
           </p:cNvPr>
@@ -8887,7 +8887,7 @@
                   <a:srgbClr val="333333"/>
                 </a:solidFill>
               </a:rPr>
-              <a:t>Caption: The scatter shows which single expert wins by trace. Different trace winners create room for a router to approach the dark-blue best-expert reference.</a:t>
+              <a:t>Caption: The heldout trace profile shows where MLOP, SPP+PPF, MoP-V1, and MoP-V2 land relative to disabled prefetching at 1.000x.</a:t>
             </a:r>
           </a:p>
         </p:txBody>
@@ -8897,7 +8897,7 @@
           <p:cNvPr id="6" name="metric-value">
             <a:extLst xmlns:a="http://schemas.openxmlformats.org/drawingml/2006/main">
               <a:ext uri="{FF2B5EF4-FFF2-40B4-BE49-F238E27FC236}">
-                <a16:creationId xmlns:a16="http://schemas.microsoft.com/office/drawing/2014/main" id="{49391206-9B3F-440A-BD3B-0AC0ADF62BDF}"/>
+                <a16:creationId xmlns:a16="http://schemas.microsoft.com/office/drawing/2014/main" id="{E2683F7B-D9D5-42BD-B10A-E0723DC29EDC}"/>
               </a:ext>
             </a:extLst>
           </p:cNvPr>
@@ -8942,7 +8942,7 @@
           <p:cNvPr id="7" name="metric-label">
             <a:extLst xmlns:a="http://schemas.openxmlformats.org/drawingml/2006/main">
               <a:ext uri="{FF2B5EF4-FFF2-40B4-BE49-F238E27FC236}">
-                <a16:creationId xmlns:a16="http://schemas.microsoft.com/office/drawing/2014/main" id="{E2099D70-B846-4B88-A2B8-DA77139F124C}"/>
+                <a16:creationId xmlns:a16="http://schemas.microsoft.com/office/drawing/2014/main" id="{B722D786-2B24-4105-8832-832AC844F2BD}"/>
               </a:ext>
             </a:extLst>
           </p:cNvPr>
@@ -8987,7 +8987,7 @@
           <p:cNvPr id="8" name="metric-value">
             <a:extLst xmlns:a="http://schemas.openxmlformats.org/drawingml/2006/main">
               <a:ext uri="{FF2B5EF4-FFF2-40B4-BE49-F238E27FC236}">
-                <a16:creationId xmlns:a16="http://schemas.microsoft.com/office/drawing/2014/main" id="{EFDB922B-ADCA-498B-B1A8-4AF961F78510}"/>
+                <a16:creationId xmlns:a16="http://schemas.microsoft.com/office/drawing/2014/main" id="{72D84D57-1309-4396-930E-71930071F643}"/>
               </a:ext>
             </a:extLst>
           </p:cNvPr>
@@ -9032,7 +9032,7 @@
           <p:cNvPr id="9" name="metric-label">
             <a:extLst xmlns:a="http://schemas.openxmlformats.org/drawingml/2006/main">
               <a:ext uri="{FF2B5EF4-FFF2-40B4-BE49-F238E27FC236}">
-                <a16:creationId xmlns:a16="http://schemas.microsoft.com/office/drawing/2014/main" id="{14F77780-26C8-40BB-8B15-380AC0E87678}"/>
+                <a16:creationId xmlns:a16="http://schemas.microsoft.com/office/drawing/2014/main" id="{01E31A4F-C663-4EA3-B71D-E4618F99132F}"/>
               </a:ext>
             </a:extLst>
           </p:cNvPr>
@@ -9077,7 +9077,7 @@
           <p:cNvPr id="10" name="best-expert-copy">
             <a:extLst xmlns:a="http://schemas.openxmlformats.org/drawingml/2006/main">
               <a:ext uri="{FF2B5EF4-FFF2-40B4-BE49-F238E27FC236}">
-                <a16:creationId xmlns:a16="http://schemas.microsoft.com/office/drawing/2014/main" id="{6322FD20-C240-4304-95E7-0141BE5809C8}"/>
+                <a16:creationId xmlns:a16="http://schemas.microsoft.com/office/drawing/2014/main" id="{B1A359EF-0DB6-4040-A886-F0B32ACC3745}"/>
               </a:ext>
             </a:extLst>
           </p:cNvPr>
@@ -9120,7 +9120,7 @@
     </p:spTree>
     <p:extLst>
       <p:ext uri="{BB962C8B-B14F-4D97-AF65-F5344CB8AC3E}">
-        <p14:creationId xmlns:p14="http://schemas.microsoft.com/office/powerpoint/2010/main" val="2032768480"/>
+        <p14:creationId xmlns:p14="http://schemas.microsoft.com/office/powerpoint/2010/main" val="86909915"/>
       </p:ext>
     </p:extLst>
   </p:cSld>
@@ -9144,7 +9144,7 @@
           <p:cNvPr id="1" name="slide-title">
             <a:extLst xmlns:a="http://schemas.openxmlformats.org/drawingml/2006/main">
               <a:ext uri="{FF2B5EF4-FFF2-40B4-BE49-F238E27FC236}">
-                <a16:creationId xmlns:a16="http://schemas.microsoft.com/office/drawing/2014/main" id="{7901397D-8105-4C9F-90EC-FC63F584510A}"/>
+                <a16:creationId xmlns:a16="http://schemas.microsoft.com/office/drawing/2014/main" id="{D44049F4-E554-44A0-8E82-7DEECC6895C1}"/>
               </a:ext>
             </a:extLst>
           </p:cNvPr>
@@ -9189,7 +9189,7 @@
           <p:cNvPr id="2" name="slide-subtitle">
             <a:extLst xmlns:a="http://schemas.openxmlformats.org/drawingml/2006/main">
               <a:ext uri="{FF2B5EF4-FFF2-40B4-BE49-F238E27FC236}">
-                <a16:creationId xmlns:a16="http://schemas.microsoft.com/office/drawing/2014/main" id="{8F3E3DF8-1E45-40D4-B944-863C782DB67E}"/>
+                <a16:creationId xmlns:a16="http://schemas.microsoft.com/office/drawing/2014/main" id="{4CDE3B31-2463-498C-85BF-394F84E9E5F5}"/>
               </a:ext>
             </a:extLst>
           </p:cNvPr>
@@ -9234,7 +9234,7 @@
           <p:cNvPr id="3" name="blank-title-peer">
             <a:extLst xmlns:a="http://schemas.openxmlformats.org/drawingml/2006/main">
               <a:ext uri="{FF2B5EF4-FFF2-40B4-BE49-F238E27FC236}">
-                <a16:creationId xmlns:a16="http://schemas.microsoft.com/office/drawing/2014/main" id="{944B1A2A-6691-4D9C-B0B8-117447F5D182}"/>
+                <a16:creationId xmlns:a16="http://schemas.microsoft.com/office/drawing/2014/main" id="{F7C7F0AE-1F67-4BEA-BC6D-DCAC4EB055DB}"/>
               </a:ext>
             </a:extLst>
           </p:cNvPr>
@@ -9267,7 +9267,7 @@
           <p:cNvPr id="4" name="kv-key-0">
             <a:extLst xmlns:a="http://schemas.openxmlformats.org/drawingml/2006/main">
               <a:ext uri="{FF2B5EF4-FFF2-40B4-BE49-F238E27FC236}">
-                <a16:creationId xmlns:a16="http://schemas.microsoft.com/office/drawing/2014/main" id="{5D6128BD-EC9B-4B52-AFFA-029D73E3F82D}"/>
+                <a16:creationId xmlns:a16="http://schemas.microsoft.com/office/drawing/2014/main" id="{6F391580-A752-4B7C-B932-F987FEE6DF71}"/>
               </a:ext>
             </a:extLst>
           </p:cNvPr>
@@ -9312,7 +9312,7 @@
           <p:cNvPr id="5" name="kv-value-0">
             <a:extLst xmlns:a="http://schemas.openxmlformats.org/drawingml/2006/main">
               <a:ext uri="{FF2B5EF4-FFF2-40B4-BE49-F238E27FC236}">
-                <a16:creationId xmlns:a16="http://schemas.microsoft.com/office/drawing/2014/main" id="{6C6832CB-6A7A-435B-9EFE-6A127CCEFF93}"/>
+                <a16:creationId xmlns:a16="http://schemas.microsoft.com/office/drawing/2014/main" id="{C5BD060F-612C-4778-9733-FDA809B4DD5A}"/>
               </a:ext>
             </a:extLst>
           </p:cNvPr>
@@ -9357,7 +9357,7 @@
           <p:cNvPr id="6" name="kv-key-1">
             <a:extLst xmlns:a="http://schemas.openxmlformats.org/drawingml/2006/main">
               <a:ext uri="{FF2B5EF4-FFF2-40B4-BE49-F238E27FC236}">
-                <a16:creationId xmlns:a16="http://schemas.microsoft.com/office/drawing/2014/main" id="{00640352-B769-43FD-B02A-92CB13DB42F4}"/>
+                <a16:creationId xmlns:a16="http://schemas.microsoft.com/office/drawing/2014/main" id="{D9B648E6-7C98-4DC3-931E-5FA6C101B85C}"/>
               </a:ext>
             </a:extLst>
           </p:cNvPr>
@@ -9402,7 +9402,7 @@
           <p:cNvPr id="7" name="kv-value-1">
             <a:extLst xmlns:a="http://schemas.openxmlformats.org/drawingml/2006/main">
               <a:ext uri="{FF2B5EF4-FFF2-40B4-BE49-F238E27FC236}">
-                <a16:creationId xmlns:a16="http://schemas.microsoft.com/office/drawing/2014/main" id="{E22EA374-072B-47ED-8920-3B0E68070C14}"/>
+                <a16:creationId xmlns:a16="http://schemas.microsoft.com/office/drawing/2014/main" id="{3803B17C-80F7-4868-8DEA-7E8344562B85}"/>
               </a:ext>
             </a:extLst>
           </p:cNvPr>
@@ -9447,7 +9447,7 @@
           <p:cNvPr id="8" name="kv-key-2">
             <a:extLst xmlns:a="http://schemas.openxmlformats.org/drawingml/2006/main">
               <a:ext uri="{FF2B5EF4-FFF2-40B4-BE49-F238E27FC236}">
-                <a16:creationId xmlns:a16="http://schemas.microsoft.com/office/drawing/2014/main" id="{03AA67A6-EBA3-4AE3-A67A-6756A970FD39}"/>
+                <a16:creationId xmlns:a16="http://schemas.microsoft.com/office/drawing/2014/main" id="{ACD6A5C6-66A8-44D5-A88A-258C449CEDCF}"/>
               </a:ext>
             </a:extLst>
           </p:cNvPr>
@@ -9492,7 +9492,7 @@
           <p:cNvPr id="9" name="kv-value-2">
             <a:extLst xmlns:a="http://schemas.openxmlformats.org/drawingml/2006/main">
               <a:ext uri="{FF2B5EF4-FFF2-40B4-BE49-F238E27FC236}">
-                <a16:creationId xmlns:a16="http://schemas.microsoft.com/office/drawing/2014/main" id="{02F09724-B333-4450-A4DD-548F09004381}"/>
+                <a16:creationId xmlns:a16="http://schemas.microsoft.com/office/drawing/2014/main" id="{4CC0D842-8F96-46F8-BF38-A83785AB499C}"/>
               </a:ext>
             </a:extLst>
           </p:cNvPr>
@@ -9537,7 +9537,7 @@
           <p:cNvPr id="10" name="table-cell-0-0">
             <a:extLst xmlns:a="http://schemas.openxmlformats.org/drawingml/2006/main">
               <a:ext uri="{FF2B5EF4-FFF2-40B4-BE49-F238E27FC236}">
-                <a16:creationId xmlns:a16="http://schemas.microsoft.com/office/drawing/2014/main" id="{CD143D12-139B-4A40-8F2C-6A1FFB58274E}"/>
+                <a16:creationId xmlns:a16="http://schemas.microsoft.com/office/drawing/2014/main" id="{3820495D-BE62-48AD-8898-B29A4FAEF056}"/>
               </a:ext>
             </a:extLst>
           </p:cNvPr>
@@ -9582,7 +9582,7 @@
           <p:cNvPr id="11" name="table-cell-0-1">
             <a:extLst xmlns:a="http://schemas.openxmlformats.org/drawingml/2006/main">
               <a:ext uri="{FF2B5EF4-FFF2-40B4-BE49-F238E27FC236}">
-                <a16:creationId xmlns:a16="http://schemas.microsoft.com/office/drawing/2014/main" id="{BB74E4F9-5588-42D9-8044-FC809931F144}"/>
+                <a16:creationId xmlns:a16="http://schemas.microsoft.com/office/drawing/2014/main" id="{AD9634D6-D838-4088-AC04-8A086893CCEB}"/>
               </a:ext>
             </a:extLst>
           </p:cNvPr>
@@ -9627,7 +9627,7 @@
           <p:cNvPr id="12" name="table-cell-0-2">
             <a:extLst xmlns:a="http://schemas.openxmlformats.org/drawingml/2006/main">
               <a:ext uri="{FF2B5EF4-FFF2-40B4-BE49-F238E27FC236}">
-                <a16:creationId xmlns:a16="http://schemas.microsoft.com/office/drawing/2014/main" id="{37992BDE-E65C-4B80-BB87-0F1FC7122041}"/>
+                <a16:creationId xmlns:a16="http://schemas.microsoft.com/office/drawing/2014/main" id="{2B63D534-4080-4696-94A6-6029DC962497}"/>
               </a:ext>
             </a:extLst>
           </p:cNvPr>
@@ -9672,7 +9672,7 @@
           <p:cNvPr id="13" name="table-cell-1-0">
             <a:extLst xmlns:a="http://schemas.openxmlformats.org/drawingml/2006/main">
               <a:ext uri="{FF2B5EF4-FFF2-40B4-BE49-F238E27FC236}">
-                <a16:creationId xmlns:a16="http://schemas.microsoft.com/office/drawing/2014/main" id="{E6EA48D7-6167-4334-BE17-793224B5BA5E}"/>
+                <a16:creationId xmlns:a16="http://schemas.microsoft.com/office/drawing/2014/main" id="{E00E1606-3318-4287-86C4-1ED54D9A0C20}"/>
               </a:ext>
             </a:extLst>
           </p:cNvPr>
@@ -9717,7 +9717,7 @@
           <p:cNvPr id="14" name="table-cell-1-1">
             <a:extLst xmlns:a="http://schemas.openxmlformats.org/drawingml/2006/main">
               <a:ext uri="{FF2B5EF4-FFF2-40B4-BE49-F238E27FC236}">
-                <a16:creationId xmlns:a16="http://schemas.microsoft.com/office/drawing/2014/main" id="{605D52F3-63E0-4791-BEBB-1222E08DAC60}"/>
+                <a16:creationId xmlns:a16="http://schemas.microsoft.com/office/drawing/2014/main" id="{851A6A13-EAD4-427F-B9B5-14BC9C21EA24}"/>
               </a:ext>
             </a:extLst>
           </p:cNvPr>
@@ -9762,7 +9762,7 @@
           <p:cNvPr id="15" name="table-cell-1-2">
             <a:extLst xmlns:a="http://schemas.openxmlformats.org/drawingml/2006/main">
               <a:ext uri="{FF2B5EF4-FFF2-40B4-BE49-F238E27FC236}">
-                <a16:creationId xmlns:a16="http://schemas.microsoft.com/office/drawing/2014/main" id="{014B0693-823F-4472-96A9-68811015147B}"/>
+                <a16:creationId xmlns:a16="http://schemas.microsoft.com/office/drawing/2014/main" id="{080E404E-CDAC-42FA-BE8B-508125B83A01}"/>
               </a:ext>
             </a:extLst>
           </p:cNvPr>
@@ -9807,7 +9807,7 @@
           <p:cNvPr id="16" name="table-cell-2-0">
             <a:extLst xmlns:a="http://schemas.openxmlformats.org/drawingml/2006/main">
               <a:ext uri="{FF2B5EF4-FFF2-40B4-BE49-F238E27FC236}">
-                <a16:creationId xmlns:a16="http://schemas.microsoft.com/office/drawing/2014/main" id="{6A25DA8E-0A7C-4FA0-97C0-BE422F99E826}"/>
+                <a16:creationId xmlns:a16="http://schemas.microsoft.com/office/drawing/2014/main" id="{F502889E-75EF-40C1-987D-66ACB9556C73}"/>
               </a:ext>
             </a:extLst>
           </p:cNvPr>
@@ -9852,7 +9852,7 @@
           <p:cNvPr id="17" name="table-cell-2-1">
             <a:extLst xmlns:a="http://schemas.openxmlformats.org/drawingml/2006/main">
               <a:ext uri="{FF2B5EF4-FFF2-40B4-BE49-F238E27FC236}">
-                <a16:creationId xmlns:a16="http://schemas.microsoft.com/office/drawing/2014/main" id="{75A8454F-1B0C-4EF0-B1BF-0A8C07A11EA4}"/>
+                <a16:creationId xmlns:a16="http://schemas.microsoft.com/office/drawing/2014/main" id="{1B93D664-A5EA-442E-AC80-8AC8672AA8C1}"/>
               </a:ext>
             </a:extLst>
           </p:cNvPr>
@@ -9897,7 +9897,7 @@
           <p:cNvPr id="18" name="table-cell-2-2">
             <a:extLst xmlns:a="http://schemas.openxmlformats.org/drawingml/2006/main">
               <a:ext uri="{FF2B5EF4-FFF2-40B4-BE49-F238E27FC236}">
-                <a16:creationId xmlns:a16="http://schemas.microsoft.com/office/drawing/2014/main" id="{1012144B-055C-49B5-8F0F-87A5C9734E82}"/>
+                <a16:creationId xmlns:a16="http://schemas.microsoft.com/office/drawing/2014/main" id="{6CE654C7-1008-4B06-B4C5-3CAEFECCCC1B}"/>
               </a:ext>
             </a:extLst>
           </p:cNvPr>
@@ -9942,7 +9942,7 @@
           <p:cNvPr id="19" name="table-cell-3-0">
             <a:extLst xmlns:a="http://schemas.openxmlformats.org/drawingml/2006/main">
               <a:ext uri="{FF2B5EF4-FFF2-40B4-BE49-F238E27FC236}">
-                <a16:creationId xmlns:a16="http://schemas.microsoft.com/office/drawing/2014/main" id="{51C623C9-8072-49EC-9447-FF4DED2472EA}"/>
+                <a16:creationId xmlns:a16="http://schemas.microsoft.com/office/drawing/2014/main" id="{3D83B420-2A3F-4E0E-BC72-0C2B6622BBFA}"/>
               </a:ext>
             </a:extLst>
           </p:cNvPr>
@@ -9987,7 +9987,7 @@
           <p:cNvPr id="20" name="table-cell-3-1">
             <a:extLst xmlns:a="http://schemas.openxmlformats.org/drawingml/2006/main">
               <a:ext uri="{FF2B5EF4-FFF2-40B4-BE49-F238E27FC236}">
-                <a16:creationId xmlns:a16="http://schemas.microsoft.com/office/drawing/2014/main" id="{FF6F4622-4D4D-486D-A04D-1D401D367557}"/>
+                <a16:creationId xmlns:a16="http://schemas.microsoft.com/office/drawing/2014/main" id="{A3758897-87C5-432D-8C1D-87BBBB3DBAFA}"/>
               </a:ext>
             </a:extLst>
           </p:cNvPr>
@@ -10032,7 +10032,7 @@
           <p:cNvPr id="21" name="table-cell-3-2">
             <a:extLst xmlns:a="http://schemas.openxmlformats.org/drawingml/2006/main">
               <a:ext uri="{FF2B5EF4-FFF2-40B4-BE49-F238E27FC236}">
-                <a16:creationId xmlns:a16="http://schemas.microsoft.com/office/drawing/2014/main" id="{099A71CD-1586-4CA1-B8DB-3B77A4CB1C1B}"/>
+                <a16:creationId xmlns:a16="http://schemas.microsoft.com/office/drawing/2014/main" id="{42EE3595-E432-48DF-8992-4DE81C2F7B36}"/>
               </a:ext>
             </a:extLst>
           </p:cNvPr>
@@ -10077,7 +10077,7 @@
           <p:cNvPr id="22" name="table-cell-4-0">
             <a:extLst xmlns:a="http://schemas.openxmlformats.org/drawingml/2006/main">
               <a:ext uri="{FF2B5EF4-FFF2-40B4-BE49-F238E27FC236}">
-                <a16:creationId xmlns:a16="http://schemas.microsoft.com/office/drawing/2014/main" id="{F80BB79E-594D-4672-99D3-6D83279B0470}"/>
+                <a16:creationId xmlns:a16="http://schemas.microsoft.com/office/drawing/2014/main" id="{A3B872DA-DA80-4846-8F10-C05B6925B03C}"/>
               </a:ext>
             </a:extLst>
           </p:cNvPr>
@@ -10122,7 +10122,7 @@
           <p:cNvPr id="23" name="table-cell-4-1">
             <a:extLst xmlns:a="http://schemas.openxmlformats.org/drawingml/2006/main">
               <a:ext uri="{FF2B5EF4-FFF2-40B4-BE49-F238E27FC236}">
-                <a16:creationId xmlns:a16="http://schemas.microsoft.com/office/drawing/2014/main" id="{1A9CB7AB-E4BA-4217-A38A-DC253D3E6FEC}"/>
+                <a16:creationId xmlns:a16="http://schemas.microsoft.com/office/drawing/2014/main" id="{8DFA518B-672A-40DE-881A-BDCEF80861E8}"/>
               </a:ext>
             </a:extLst>
           </p:cNvPr>
@@ -10167,7 +10167,7 @@
           <p:cNvPr id="24" name="table-cell-4-2">
             <a:extLst xmlns:a="http://schemas.openxmlformats.org/drawingml/2006/main">
               <a:ext uri="{FF2B5EF4-FFF2-40B4-BE49-F238E27FC236}">
-                <a16:creationId xmlns:a16="http://schemas.microsoft.com/office/drawing/2014/main" id="{A0E70FC0-1C42-44BC-B0E6-B21E24A443C5}"/>
+                <a16:creationId xmlns:a16="http://schemas.microsoft.com/office/drawing/2014/main" id="{322F8444-C8CA-48B3-B933-5C5B9C53E40A}"/>
               </a:ext>
             </a:extLst>
           </p:cNvPr>
@@ -10216,13 +10216,13 @@
           <p:nvPr/>
         </p:nvPicPr>
         <p:blipFill>
-          <a:blip xmlns:r="http://schemas.openxmlformats.org/officeDocument/2006/relationships" xmlns:a="http://schemas.openxmlformats.org/drawingml/2006/main" r:embed="R79d4de77429648e3"/>
+          <a:blip xmlns:r="http://schemas.openxmlformats.org/officeDocument/2006/relationships" xmlns:a="http://schemas.openxmlformats.org/drawingml/2006/main" r:embed="R08ccb49e8da7415f"/>
           <a:stretch xmlns:a="http://schemas.openxmlformats.org/drawingml/2006/main"/>
         </p:blipFill>
         <p:spPr>
           <a:xfrm xmlns:a="http://schemas.openxmlformats.org/drawingml/2006/main">
-            <a:off x="8391144" y="2506980"/>
-            <a:ext cx="8420100" cy="6736080"/>
+            <a:off x="7581138" y="3465393"/>
+            <a:ext cx="10040112" cy="4819254"/>
           </a:xfrm>
           <a:prstGeom xmlns:a="http://schemas.openxmlformats.org/drawingml/2006/main" prst="rect">
             <a:avLst/>
@@ -10234,7 +10234,7 @@
           <p:cNvPr id="26" name="figure-caption">
             <a:extLst xmlns:a="http://schemas.openxmlformats.org/drawingml/2006/main">
               <a:ext uri="{FF2B5EF4-FFF2-40B4-BE49-F238E27FC236}">
-                <a16:creationId xmlns:a16="http://schemas.microsoft.com/office/drawing/2014/main" id="{5CB75700-76A5-4BE1-82B4-13141D6265B1}"/>
+                <a16:creationId xmlns:a16="http://schemas.microsoft.com/office/drawing/2014/main" id="{BC7ABA40-37B5-4D1B-9D1A-5F1713104030}"/>
               </a:ext>
             </a:extLst>
           </p:cNvPr>
@@ -10269,7 +10269,7 @@
                   <a:srgbClr val="333333"/>
                 </a:solidFill>
               </a:rPr>
-              <a:t>Caption: The comparison keeps the baseline routers plain. MoP-V2 clears the simple router baselines on the 13-trace final validation surface.</a:t>
+              <a:t>Caption: MoP-V2 improves over MoP-V1 on the 13-trace validation surface, while the heldout effect is smaller and shown after policy selection.</a:t>
             </a:r>
           </a:p>
         </p:txBody>
@@ -10277,7 +10277,7 @@
     </p:spTree>
     <p:extLst>
       <p:ext uri="{BB962C8B-B14F-4D97-AF65-F5344CB8AC3E}">
-        <p14:creationId xmlns:p14="http://schemas.microsoft.com/office/powerpoint/2010/main" val="1799372096"/>
+        <p14:creationId xmlns:p14="http://schemas.microsoft.com/office/powerpoint/2010/main" val="473050673"/>
       </p:ext>
     </p:extLst>
   </p:cSld>

</xml_diff>